<commit_message>
Added results, outlook and conclusion section to my powerpoint. Now only the Introduction is missing. Test run shows that powerpoint is vastly too long.
</commit_message>
<xml_diff>
--- a/dev_documents/presentation/ba_thesis_presentation_kronig.pptx
+++ b/dev_documents/presentation/ba_thesis_presentation_kronig.pptx
@@ -7,10 +7,10 @@
     <p:sldMasterId id="2147483793" r:id="rId3"/>
   </p:sldMasterIdLst>
   <p:notesMasterIdLst>
-    <p:notesMasterId r:id="rId45"/>
+    <p:notesMasterId r:id="rId53"/>
   </p:notesMasterIdLst>
   <p:handoutMasterIdLst>
-    <p:handoutMasterId r:id="rId46"/>
+    <p:handoutMasterId r:id="rId54"/>
   </p:handoutMasterIdLst>
   <p:sldIdLst>
     <p:sldId id="256" r:id="rId4"/>
@@ -51,9 +51,17 @@
     <p:sldId id="300" r:id="rId39"/>
     <p:sldId id="295" r:id="rId40"/>
     <p:sldId id="282" r:id="rId41"/>
-    <p:sldId id="283" r:id="rId42"/>
-    <p:sldId id="284" r:id="rId43"/>
-    <p:sldId id="285" r:id="rId44"/>
+    <p:sldId id="301" r:id="rId42"/>
+    <p:sldId id="302" r:id="rId43"/>
+    <p:sldId id="303" r:id="rId44"/>
+    <p:sldId id="283" r:id="rId45"/>
+    <p:sldId id="304" r:id="rId46"/>
+    <p:sldId id="305" r:id="rId47"/>
+    <p:sldId id="284" r:id="rId48"/>
+    <p:sldId id="285" r:id="rId49"/>
+    <p:sldId id="308" r:id="rId50"/>
+    <p:sldId id="307" r:id="rId51"/>
+    <p:sldId id="306" r:id="rId52"/>
   </p:sldIdLst>
   <p:sldSz cx="9144000" cy="5143500" type="screen16x9"/>
   <p:notesSz cx="6858000" cy="9144000"/>
@@ -40669,7 +40677,10 @@
           <a:bodyPr/>
           <a:lstStyle/>
           <a:p>
-            <a:endParaRPr lang="en-US"/>
+            <a:r>
+              <a:rPr lang="en-US" dirty="0"/>
+              <a:t>Overview of Our Apps</a:t>
+            </a:r>
           </a:p>
         </p:txBody>
       </p:sp>
@@ -40694,7 +40705,10 @@
           <a:bodyPr/>
           <a:lstStyle/>
           <a:p>
-            <a:endParaRPr lang="en-US" dirty="0"/>
+            <a:r>
+              <a:rPr lang="en-US" dirty="0"/>
+              <a:t>Results</a:t>
+            </a:r>
           </a:p>
         </p:txBody>
       </p:sp>
@@ -40723,6 +40737,69 @@
         <p:txBody>
           <a:bodyPr anchor="t"/>
           <a:lstStyle/>
+          <a:p>
+            <a:pPr>
+              <a:lnSpc>
+                <a:spcPct val="150000"/>
+              </a:lnSpc>
+            </a:pPr>
+            <a:r>
+              <a:rPr lang="en-US" dirty="0"/>
+              <a:t>Three apps</a:t>
+            </a:r>
+          </a:p>
+          <a:p>
+            <a:pPr>
+              <a:lnSpc>
+                <a:spcPct val="150000"/>
+              </a:lnSpc>
+            </a:pPr>
+            <a:r>
+              <a:rPr lang="en-US" dirty="0"/>
+              <a:t>28 vulnerabilities</a:t>
+            </a:r>
+          </a:p>
+          <a:p>
+            <a:pPr>
+              <a:lnSpc>
+                <a:spcPct val="150000"/>
+              </a:lnSpc>
+            </a:pPr>
+            <a:r>
+              <a:rPr lang="en-US" dirty="0"/>
+              <a:t>Complete coverage of MASVS-STORAGE and CRYPTO</a:t>
+            </a:r>
+          </a:p>
+          <a:p>
+            <a:pPr>
+              <a:lnSpc>
+                <a:spcPct val="150000"/>
+              </a:lnSpc>
+            </a:pPr>
+            <a:r>
+              <a:rPr lang="en-US" dirty="0"/>
+              <a:t>25% MASWE coverage</a:t>
+            </a:r>
+          </a:p>
+          <a:p>
+            <a:pPr>
+              <a:lnSpc>
+                <a:spcPct val="150000"/>
+              </a:lnSpc>
+            </a:pPr>
+            <a:r>
+              <a:rPr lang="en-US" dirty="0"/>
+              <a:t>18 (65%) vulnerability types without previous coverage</a:t>
+            </a:r>
+          </a:p>
+          <a:p>
+            <a:pPr>
+              <a:lnSpc>
+                <a:spcPct val="150000"/>
+              </a:lnSpc>
+            </a:pPr>
+            <a:endParaRPr lang="en-US" dirty="0"/>
+          </a:p>
           <a:p>
             <a:pPr>
               <a:lnSpc>
@@ -40834,7 +40911,7 @@
         <p:cNvPr id="1" name="">
           <a:extLst>
             <a:ext uri="{FF2B5EF4-FFF2-40B4-BE49-F238E27FC236}">
-              <a16:creationId xmlns:a16="http://schemas.microsoft.com/office/drawing/2014/main" id="{8E436EE9-C990-5FE7-041E-4F5B09E7CD6C}"/>
+              <a16:creationId xmlns:a16="http://schemas.microsoft.com/office/drawing/2014/main" id="{51F29159-1E84-C261-434B-0CC9EBBFC7FA}"/>
             </a:ext>
           </a:extLst>
         </p:cNvPr>
@@ -40854,7 +40931,7 @@
           <p:cNvPr id="8" name="Textplatzhalter 7">
             <a:extLst>
               <a:ext uri="{FF2B5EF4-FFF2-40B4-BE49-F238E27FC236}">
-                <a16:creationId xmlns:a16="http://schemas.microsoft.com/office/drawing/2014/main" id="{78E8AD95-61A2-77CD-B870-A319B7260E8F}"/>
+                <a16:creationId xmlns:a16="http://schemas.microsoft.com/office/drawing/2014/main" id="{2F2760CC-1A5D-5656-7974-CF1C0D1DD4FB}"/>
               </a:ext>
             </a:extLst>
           </p:cNvPr>
@@ -40870,7 +40947,10 @@
           <a:bodyPr/>
           <a:lstStyle/>
           <a:p>
-            <a:endParaRPr lang="en-US"/>
+            <a:r>
+              <a:rPr lang="en-US" dirty="0"/>
+              <a:t>Overview of Our Apps</a:t>
+            </a:r>
           </a:p>
         </p:txBody>
       </p:sp>
@@ -40879,7 +40959,7 @@
           <p:cNvPr id="7" name="Titel 6">
             <a:extLst>
               <a:ext uri="{FF2B5EF4-FFF2-40B4-BE49-F238E27FC236}">
-                <a16:creationId xmlns:a16="http://schemas.microsoft.com/office/drawing/2014/main" id="{8AC539FA-EBDF-C1CB-E52F-738DBCDA4692}"/>
+                <a16:creationId xmlns:a16="http://schemas.microsoft.com/office/drawing/2014/main" id="{0F1AA677-696C-98F1-F2B8-1D61F5981E87}"/>
               </a:ext>
             </a:extLst>
           </p:cNvPr>
@@ -40895,7 +40975,10 @@
           <a:bodyPr/>
           <a:lstStyle/>
           <a:p>
-            <a:endParaRPr lang="en-US" dirty="0"/>
+            <a:r>
+              <a:rPr lang="en-US" dirty="0"/>
+              <a:t>Results</a:t>
+            </a:r>
           </a:p>
         </p:txBody>
       </p:sp>
@@ -40904,7 +40987,7 @@
           <p:cNvPr id="10" name="Inhaltsplatzhalter 9">
             <a:extLst>
               <a:ext uri="{FF2B5EF4-FFF2-40B4-BE49-F238E27FC236}">
-                <a16:creationId xmlns:a16="http://schemas.microsoft.com/office/drawing/2014/main" id="{3D4081EF-A6FC-3D8B-48D3-79CF305C88E4}"/>
+                <a16:creationId xmlns:a16="http://schemas.microsoft.com/office/drawing/2014/main" id="{481B5011-1F99-CCC8-1972-FD596CA867D7}"/>
               </a:ext>
             </a:extLst>
           </p:cNvPr>
@@ -40930,6 +41013,47 @@
                 <a:spcPct val="150000"/>
               </a:lnSpc>
             </a:pPr>
+            <a:r>
+              <a:rPr lang="en-US" dirty="0"/>
+              <a:t>25% MASWE coverage</a:t>
+            </a:r>
+          </a:p>
+          <a:p>
+            <a:pPr>
+              <a:lnSpc>
+                <a:spcPct val="150000"/>
+              </a:lnSpc>
+            </a:pPr>
+            <a:r>
+              <a:rPr lang="en-US" dirty="0"/>
+              <a:t>18/28 vulnerability types without previous coverage</a:t>
+            </a:r>
+          </a:p>
+          <a:p>
+            <a:pPr>
+              <a:lnSpc>
+                <a:spcPct val="150000"/>
+              </a:lnSpc>
+            </a:pPr>
+            <a:r>
+              <a:rPr lang="en-US" dirty="0"/>
+              <a:t>MASWE coverage from 35.9% to  51.3%</a:t>
+            </a:r>
+          </a:p>
+          <a:p>
+            <a:pPr>
+              <a:lnSpc>
+                <a:spcPct val="150000"/>
+              </a:lnSpc>
+            </a:pPr>
+            <a:endParaRPr lang="en-US" dirty="0"/>
+          </a:p>
+          <a:p>
+            <a:pPr>
+              <a:lnSpc>
+                <a:spcPct val="150000"/>
+              </a:lnSpc>
+            </a:pPr>
             <a:endParaRPr lang="en-US" dirty="0"/>
           </a:p>
         </p:txBody>
@@ -40939,7 +41063,7 @@
           <p:cNvPr id="9" name="Textplatzhalter 8">
             <a:extLst>
               <a:ext uri="{FF2B5EF4-FFF2-40B4-BE49-F238E27FC236}">
-                <a16:creationId xmlns:a16="http://schemas.microsoft.com/office/drawing/2014/main" id="{E6E9340D-6B84-073F-A6ED-82115C9DA4D4}"/>
+                <a16:creationId xmlns:a16="http://schemas.microsoft.com/office/drawing/2014/main" id="{675D1731-F918-A75F-2742-BEEC7E575539}"/>
               </a:ext>
             </a:extLst>
           </p:cNvPr>
@@ -40964,7 +41088,7 @@
           <p:cNvPr id="11" name="Fußzeilenplatzhalter 10">
             <a:extLst>
               <a:ext uri="{FF2B5EF4-FFF2-40B4-BE49-F238E27FC236}">
-                <a16:creationId xmlns:a16="http://schemas.microsoft.com/office/drawing/2014/main" id="{D06F3D58-BF04-8E6A-1D75-45010D651BDC}"/>
+                <a16:creationId xmlns:a16="http://schemas.microsoft.com/office/drawing/2014/main" id="{10A3BDE3-986F-DF87-D241-25242AD5B2F8}"/>
               </a:ext>
             </a:extLst>
           </p:cNvPr>
@@ -40989,7 +41113,7 @@
           <p:cNvPr id="12" name="Foliennummernplatzhalter 11">
             <a:extLst>
               <a:ext uri="{FF2B5EF4-FFF2-40B4-BE49-F238E27FC236}">
-                <a16:creationId xmlns:a16="http://schemas.microsoft.com/office/drawing/2014/main" id="{AA0553A4-0692-4646-8E66-2D3709ED2238}"/>
+                <a16:creationId xmlns:a16="http://schemas.microsoft.com/office/drawing/2014/main" id="{D5021142-9DF1-CBE6-D589-5DC8F1DD4D98}"/>
               </a:ext>
             </a:extLst>
           </p:cNvPr>
@@ -41017,7 +41141,7 @@
     </p:spTree>
     <p:extLst>
       <p:ext uri="{BB962C8B-B14F-4D97-AF65-F5344CB8AC3E}">
-        <p14:creationId xmlns:p14="http://schemas.microsoft.com/office/powerpoint/2010/main" val="3692513435"/>
+        <p14:creationId xmlns:p14="http://schemas.microsoft.com/office/powerpoint/2010/main" val="991241013"/>
       </p:ext>
     </p:extLst>
   </p:cSld>
@@ -41301,6 +41425,1241 @@
         <p:cNvPr id="1" name="">
           <a:extLst>
             <a:ext uri="{FF2B5EF4-FFF2-40B4-BE49-F238E27FC236}">
+              <a16:creationId xmlns:a16="http://schemas.microsoft.com/office/drawing/2014/main" id="{F214EE8D-A3F9-A17E-026A-E54B75D254FB}"/>
+            </a:ext>
+          </a:extLst>
+        </p:cNvPr>
+        <p:cNvGrpSpPr/>
+        <p:nvPr/>
+      </p:nvGrpSpPr>
+      <p:grpSpPr>
+        <a:xfrm>
+          <a:off x="0" y="0"/>
+          <a:ext cx="0" cy="0"/>
+          <a:chOff x="0" y="0"/>
+          <a:chExt cx="0" cy="0"/>
+        </a:xfrm>
+      </p:grpSpPr>
+      <p:sp>
+        <p:nvSpPr>
+          <p:cNvPr id="8" name="Textplatzhalter 7">
+            <a:extLst>
+              <a:ext uri="{FF2B5EF4-FFF2-40B4-BE49-F238E27FC236}">
+                <a16:creationId xmlns:a16="http://schemas.microsoft.com/office/drawing/2014/main" id="{E3CFD75C-28E3-802B-6BD6-DC1892352669}"/>
+              </a:ext>
+            </a:extLst>
+          </p:cNvPr>
+          <p:cNvSpPr>
+            <a:spLocks noGrp="1"/>
+          </p:cNvSpPr>
+          <p:nvPr>
+            <p:ph type="body" sz="quarter" idx="12"/>
+          </p:nvPr>
+        </p:nvSpPr>
+        <p:spPr/>
+        <p:txBody>
+          <a:bodyPr/>
+          <a:lstStyle/>
+          <a:p>
+            <a:r>
+              <a:rPr lang="en-US" dirty="0"/>
+              <a:t>Comparison with other MASTG Apps</a:t>
+            </a:r>
+          </a:p>
+        </p:txBody>
+      </p:sp>
+      <p:sp>
+        <p:nvSpPr>
+          <p:cNvPr id="7" name="Titel 6">
+            <a:extLst>
+              <a:ext uri="{FF2B5EF4-FFF2-40B4-BE49-F238E27FC236}">
+                <a16:creationId xmlns:a16="http://schemas.microsoft.com/office/drawing/2014/main" id="{F5233A53-64FE-CA26-14C6-FEE787318BC9}"/>
+              </a:ext>
+            </a:extLst>
+          </p:cNvPr>
+          <p:cNvSpPr>
+            <a:spLocks noGrp="1"/>
+          </p:cNvSpPr>
+          <p:nvPr>
+            <p:ph type="title"/>
+          </p:nvPr>
+        </p:nvSpPr>
+        <p:spPr/>
+        <p:txBody>
+          <a:bodyPr/>
+          <a:lstStyle/>
+          <a:p>
+            <a:r>
+              <a:rPr lang="en-US" dirty="0"/>
+              <a:t>Results</a:t>
+            </a:r>
+          </a:p>
+        </p:txBody>
+      </p:sp>
+      <p:sp>
+        <p:nvSpPr>
+          <p:cNvPr id="10" name="Inhaltsplatzhalter 9">
+            <a:extLst>
+              <a:ext uri="{FF2B5EF4-FFF2-40B4-BE49-F238E27FC236}">
+                <a16:creationId xmlns:a16="http://schemas.microsoft.com/office/drawing/2014/main" id="{B0CCCF5B-3D13-9BA2-D1CF-0A198C4D8018}"/>
+              </a:ext>
+            </a:extLst>
+          </p:cNvPr>
+          <p:cNvSpPr>
+            <a:spLocks noGrp="1"/>
+          </p:cNvSpPr>
+          <p:nvPr>
+            <p:ph sz="quarter" idx="20"/>
+          </p:nvPr>
+        </p:nvSpPr>
+        <p:spPr>
+          <a:xfrm>
+            <a:off x="359533" y="1203598"/>
+            <a:ext cx="8424467" cy="3332402"/>
+          </a:xfrm>
+        </p:spPr>
+        <p:txBody>
+          <a:bodyPr anchor="t"/>
+          <a:lstStyle/>
+          <a:p>
+            <a:pPr>
+              <a:lnSpc>
+                <a:spcPct val="150000"/>
+              </a:lnSpc>
+            </a:pPr>
+            <a:r>
+              <a:rPr lang="en-US" dirty="0"/>
+              <a:t>Largest contribution to crypto category</a:t>
+            </a:r>
+          </a:p>
+          <a:p>
+            <a:pPr>
+              <a:lnSpc>
+                <a:spcPct val="150000"/>
+              </a:lnSpc>
+            </a:pPr>
+            <a:endParaRPr lang="en-US" dirty="0"/>
+          </a:p>
+          <a:p>
+            <a:pPr>
+              <a:lnSpc>
+                <a:spcPct val="150000"/>
+              </a:lnSpc>
+            </a:pPr>
+            <a:endParaRPr lang="en-US" dirty="0"/>
+          </a:p>
+        </p:txBody>
+      </p:sp>
+      <p:sp>
+        <p:nvSpPr>
+          <p:cNvPr id="9" name="Textplatzhalter 8">
+            <a:extLst>
+              <a:ext uri="{FF2B5EF4-FFF2-40B4-BE49-F238E27FC236}">
+                <a16:creationId xmlns:a16="http://schemas.microsoft.com/office/drawing/2014/main" id="{8A29B60F-0C6A-26D2-D7BB-9FE0D1A767D8}"/>
+              </a:ext>
+            </a:extLst>
+          </p:cNvPr>
+          <p:cNvSpPr>
+            <a:spLocks noGrp="1"/>
+          </p:cNvSpPr>
+          <p:nvPr>
+            <p:ph type="body" sz="quarter" idx="19"/>
+          </p:nvPr>
+        </p:nvSpPr>
+        <p:spPr/>
+        <p:txBody>
+          <a:bodyPr/>
+          <a:lstStyle/>
+          <a:p>
+            <a:endParaRPr lang="en-US" dirty="0"/>
+          </a:p>
+        </p:txBody>
+      </p:sp>
+      <p:sp>
+        <p:nvSpPr>
+          <p:cNvPr id="11" name="Fußzeilenplatzhalter 10">
+            <a:extLst>
+              <a:ext uri="{FF2B5EF4-FFF2-40B4-BE49-F238E27FC236}">
+                <a16:creationId xmlns:a16="http://schemas.microsoft.com/office/drawing/2014/main" id="{89867BC0-A9AD-6CAE-A20C-B360213BE709}"/>
+              </a:ext>
+            </a:extLst>
+          </p:cNvPr>
+          <p:cNvSpPr>
+            <a:spLocks noGrp="1"/>
+          </p:cNvSpPr>
+          <p:nvPr>
+            <p:ph type="ftr" sz="quarter" idx="17"/>
+          </p:nvPr>
+        </p:nvSpPr>
+        <p:spPr/>
+        <p:txBody>
+          <a:bodyPr/>
+          <a:lstStyle/>
+          <a:p>
+            <a:endParaRPr lang="de-CH" dirty="0"/>
+          </a:p>
+        </p:txBody>
+      </p:sp>
+      <p:sp>
+        <p:nvSpPr>
+          <p:cNvPr id="12" name="Foliennummernplatzhalter 11">
+            <a:extLst>
+              <a:ext uri="{FF2B5EF4-FFF2-40B4-BE49-F238E27FC236}">
+                <a16:creationId xmlns:a16="http://schemas.microsoft.com/office/drawing/2014/main" id="{FCCCB0FA-F845-B5B9-FB50-83C6DDB4FB9D}"/>
+              </a:ext>
+            </a:extLst>
+          </p:cNvPr>
+          <p:cNvSpPr>
+            <a:spLocks noGrp="1"/>
+          </p:cNvSpPr>
+          <p:nvPr>
+            <p:ph type="sldNum" sz="quarter" idx="18"/>
+          </p:nvPr>
+        </p:nvSpPr>
+        <p:spPr/>
+        <p:txBody>
+          <a:bodyPr/>
+          <a:lstStyle/>
+          <a:p>
+            <a:fld id="{E6639024-6672-4F87-864B-EA4FA9190A1A}" type="slidenum">
+              <a:rPr lang="de-CH" smtClean="0"/>
+              <a:pPr/>
+              <a:t>40</a:t>
+            </a:fld>
+            <a:endParaRPr lang="de-CH" dirty="0"/>
+          </a:p>
+        </p:txBody>
+      </p:sp>
+      <p:pic>
+        <p:nvPicPr>
+          <p:cNvPr id="3" name="Grafik 2" descr="Ein Bild, das Text, Screenshot, Diagramm, Reihe enthält.&#10;&#10;KI-generierte Inhalte können fehlerhaft sein.">
+            <a:extLst>
+              <a:ext uri="{FF2B5EF4-FFF2-40B4-BE49-F238E27FC236}">
+                <a16:creationId xmlns:a16="http://schemas.microsoft.com/office/drawing/2014/main" id="{C248F9D5-5A82-83F9-3F7E-8FCF1E3CBF3E}"/>
+              </a:ext>
+            </a:extLst>
+          </p:cNvPr>
+          <p:cNvPicPr>
+            <a:picLocks noChangeAspect="1"/>
+          </p:cNvPicPr>
+          <p:nvPr/>
+        </p:nvPicPr>
+        <p:blipFill>
+          <a:blip r:embed="rId2">
+            <a:extLst>
+              <a:ext uri="{28A0092B-C50C-407E-A947-70E740481C1C}">
+                <a14:useLocalDpi xmlns:a14="http://schemas.microsoft.com/office/drawing/2010/main" val="0"/>
+              </a:ext>
+            </a:extLst>
+          </a:blip>
+          <a:stretch>
+            <a:fillRect/>
+          </a:stretch>
+        </p:blipFill>
+        <p:spPr>
+          <a:xfrm>
+            <a:off x="3484161" y="1914334"/>
+            <a:ext cx="5299839" cy="2621666"/>
+          </a:xfrm>
+          <a:prstGeom prst="rect">
+            <a:avLst/>
+          </a:prstGeom>
+        </p:spPr>
+      </p:pic>
+    </p:spTree>
+    <p:extLst>
+      <p:ext uri="{BB962C8B-B14F-4D97-AF65-F5344CB8AC3E}">
+        <p14:creationId xmlns:p14="http://schemas.microsoft.com/office/powerpoint/2010/main" val="3788952433"/>
+      </p:ext>
+    </p:extLst>
+  </p:cSld>
+  <p:clrMapOvr>
+    <a:masterClrMapping/>
+  </p:clrMapOvr>
+</p:sld>
+</file>
+
+<file path=ppt/slides/slide41.xml><?xml version="1.0" encoding="utf-8"?>
+<p:sld xmlns:a="http://schemas.openxmlformats.org/drawingml/2006/main" xmlns:r="http://schemas.openxmlformats.org/officeDocument/2006/relationships" xmlns:p="http://schemas.openxmlformats.org/presentationml/2006/main">
+  <p:cSld>
+    <p:spTree>
+      <p:nvGrpSpPr>
+        <p:cNvPr id="1" name="">
+          <a:extLst>
+            <a:ext uri="{FF2B5EF4-FFF2-40B4-BE49-F238E27FC236}">
+              <a16:creationId xmlns:a16="http://schemas.microsoft.com/office/drawing/2014/main" id="{C997DD8C-9CAF-69F1-7B45-F8956BE05E26}"/>
+            </a:ext>
+          </a:extLst>
+        </p:cNvPr>
+        <p:cNvGrpSpPr/>
+        <p:nvPr/>
+      </p:nvGrpSpPr>
+      <p:grpSpPr>
+        <a:xfrm>
+          <a:off x="0" y="0"/>
+          <a:ext cx="0" cy="0"/>
+          <a:chOff x="0" y="0"/>
+          <a:chExt cx="0" cy="0"/>
+        </a:xfrm>
+      </p:grpSpPr>
+      <p:sp>
+        <p:nvSpPr>
+          <p:cNvPr id="8" name="Textplatzhalter 7">
+            <a:extLst>
+              <a:ext uri="{FF2B5EF4-FFF2-40B4-BE49-F238E27FC236}">
+                <a16:creationId xmlns:a16="http://schemas.microsoft.com/office/drawing/2014/main" id="{7272B720-D64A-5D75-9232-ED24B2057CAF}"/>
+              </a:ext>
+            </a:extLst>
+          </p:cNvPr>
+          <p:cNvSpPr>
+            <a:spLocks noGrp="1"/>
+          </p:cNvSpPr>
+          <p:nvPr>
+            <p:ph type="body" sz="quarter" idx="12"/>
+          </p:nvPr>
+        </p:nvSpPr>
+        <p:spPr/>
+        <p:txBody>
+          <a:bodyPr/>
+          <a:lstStyle/>
+          <a:p>
+            <a:r>
+              <a:rPr lang="en-US" dirty="0"/>
+              <a:t>Comparison with other MASTG Apps</a:t>
+            </a:r>
+          </a:p>
+        </p:txBody>
+      </p:sp>
+      <p:sp>
+        <p:nvSpPr>
+          <p:cNvPr id="7" name="Titel 6">
+            <a:extLst>
+              <a:ext uri="{FF2B5EF4-FFF2-40B4-BE49-F238E27FC236}">
+                <a16:creationId xmlns:a16="http://schemas.microsoft.com/office/drawing/2014/main" id="{E7431756-EA25-1013-E49C-74AB56448023}"/>
+              </a:ext>
+            </a:extLst>
+          </p:cNvPr>
+          <p:cNvSpPr>
+            <a:spLocks noGrp="1"/>
+          </p:cNvSpPr>
+          <p:nvPr>
+            <p:ph type="title"/>
+          </p:nvPr>
+        </p:nvSpPr>
+        <p:spPr/>
+        <p:txBody>
+          <a:bodyPr/>
+          <a:lstStyle/>
+          <a:p>
+            <a:r>
+              <a:rPr lang="en-US" dirty="0"/>
+              <a:t>Results</a:t>
+            </a:r>
+          </a:p>
+        </p:txBody>
+      </p:sp>
+      <p:sp>
+        <p:nvSpPr>
+          <p:cNvPr id="10" name="Inhaltsplatzhalter 9">
+            <a:extLst>
+              <a:ext uri="{FF2B5EF4-FFF2-40B4-BE49-F238E27FC236}">
+                <a16:creationId xmlns:a16="http://schemas.microsoft.com/office/drawing/2014/main" id="{1BAB215B-66B3-1C59-E098-BDDFE1282847}"/>
+              </a:ext>
+            </a:extLst>
+          </p:cNvPr>
+          <p:cNvSpPr>
+            <a:spLocks noGrp="1"/>
+          </p:cNvSpPr>
+          <p:nvPr>
+            <p:ph sz="quarter" idx="20"/>
+          </p:nvPr>
+        </p:nvSpPr>
+        <p:spPr>
+          <a:xfrm>
+            <a:off x="359533" y="1203598"/>
+            <a:ext cx="8424467" cy="3332402"/>
+          </a:xfrm>
+        </p:spPr>
+        <p:txBody>
+          <a:bodyPr anchor="t"/>
+          <a:lstStyle/>
+          <a:p>
+            <a:pPr>
+              <a:lnSpc>
+                <a:spcPct val="150000"/>
+              </a:lnSpc>
+            </a:pPr>
+            <a:r>
+              <a:rPr lang="en-US" dirty="0"/>
+              <a:t>High number of “new” vulnerabilities</a:t>
+            </a:r>
+          </a:p>
+          <a:p>
+            <a:pPr>
+              <a:lnSpc>
+                <a:spcPct val="150000"/>
+              </a:lnSpc>
+            </a:pPr>
+            <a:endParaRPr lang="en-US" dirty="0"/>
+          </a:p>
+          <a:p>
+            <a:pPr>
+              <a:lnSpc>
+                <a:spcPct val="150000"/>
+              </a:lnSpc>
+            </a:pPr>
+            <a:endParaRPr lang="en-US" dirty="0"/>
+          </a:p>
+        </p:txBody>
+      </p:sp>
+      <p:sp>
+        <p:nvSpPr>
+          <p:cNvPr id="9" name="Textplatzhalter 8">
+            <a:extLst>
+              <a:ext uri="{FF2B5EF4-FFF2-40B4-BE49-F238E27FC236}">
+                <a16:creationId xmlns:a16="http://schemas.microsoft.com/office/drawing/2014/main" id="{E58B64BF-36FB-15C9-4654-0DEF4067F782}"/>
+              </a:ext>
+            </a:extLst>
+          </p:cNvPr>
+          <p:cNvSpPr>
+            <a:spLocks noGrp="1"/>
+          </p:cNvSpPr>
+          <p:nvPr>
+            <p:ph type="body" sz="quarter" idx="19"/>
+          </p:nvPr>
+        </p:nvSpPr>
+        <p:spPr/>
+        <p:txBody>
+          <a:bodyPr/>
+          <a:lstStyle/>
+          <a:p>
+            <a:endParaRPr lang="en-US" dirty="0"/>
+          </a:p>
+        </p:txBody>
+      </p:sp>
+      <p:sp>
+        <p:nvSpPr>
+          <p:cNvPr id="11" name="Fußzeilenplatzhalter 10">
+            <a:extLst>
+              <a:ext uri="{FF2B5EF4-FFF2-40B4-BE49-F238E27FC236}">
+                <a16:creationId xmlns:a16="http://schemas.microsoft.com/office/drawing/2014/main" id="{45E6AA50-490C-552A-BD0E-C9708CE00953}"/>
+              </a:ext>
+            </a:extLst>
+          </p:cNvPr>
+          <p:cNvSpPr>
+            <a:spLocks noGrp="1"/>
+          </p:cNvSpPr>
+          <p:nvPr>
+            <p:ph type="ftr" sz="quarter" idx="17"/>
+          </p:nvPr>
+        </p:nvSpPr>
+        <p:spPr/>
+        <p:txBody>
+          <a:bodyPr/>
+          <a:lstStyle/>
+          <a:p>
+            <a:endParaRPr lang="de-CH" dirty="0"/>
+          </a:p>
+        </p:txBody>
+      </p:sp>
+      <p:sp>
+        <p:nvSpPr>
+          <p:cNvPr id="12" name="Foliennummernplatzhalter 11">
+            <a:extLst>
+              <a:ext uri="{FF2B5EF4-FFF2-40B4-BE49-F238E27FC236}">
+                <a16:creationId xmlns:a16="http://schemas.microsoft.com/office/drawing/2014/main" id="{E4215688-A6A5-AE86-028E-36D00E8019F5}"/>
+              </a:ext>
+            </a:extLst>
+          </p:cNvPr>
+          <p:cNvSpPr>
+            <a:spLocks noGrp="1"/>
+          </p:cNvSpPr>
+          <p:nvPr>
+            <p:ph type="sldNum" sz="quarter" idx="18"/>
+          </p:nvPr>
+        </p:nvSpPr>
+        <p:spPr/>
+        <p:txBody>
+          <a:bodyPr/>
+          <a:lstStyle/>
+          <a:p>
+            <a:fld id="{E6639024-6672-4F87-864B-EA4FA9190A1A}" type="slidenum">
+              <a:rPr lang="de-CH" smtClean="0"/>
+              <a:pPr/>
+              <a:t>41</a:t>
+            </a:fld>
+            <a:endParaRPr lang="de-CH" dirty="0"/>
+          </a:p>
+        </p:txBody>
+      </p:sp>
+      <p:pic>
+        <p:nvPicPr>
+          <p:cNvPr id="5" name="Grafik 4" descr="Ein Bild, das Text, Screenshot, Diagramm, Reihe enthält.&#10;&#10;KI-generierte Inhalte können fehlerhaft sein.">
+            <a:extLst>
+              <a:ext uri="{FF2B5EF4-FFF2-40B4-BE49-F238E27FC236}">
+                <a16:creationId xmlns:a16="http://schemas.microsoft.com/office/drawing/2014/main" id="{89A740C7-F1EF-2DF0-33BD-7C533568F64D}"/>
+              </a:ext>
+            </a:extLst>
+          </p:cNvPr>
+          <p:cNvPicPr>
+            <a:picLocks noChangeAspect="1"/>
+          </p:cNvPicPr>
+          <p:nvPr/>
+        </p:nvPicPr>
+        <p:blipFill>
+          <a:blip r:embed="rId2">
+            <a:extLst>
+              <a:ext uri="{28A0092B-C50C-407E-A947-70E740481C1C}">
+                <a14:useLocalDpi xmlns:a14="http://schemas.microsoft.com/office/drawing/2010/main" val="0"/>
+              </a:ext>
+            </a:extLst>
+          </a:blip>
+          <a:stretch>
+            <a:fillRect/>
+          </a:stretch>
+        </p:blipFill>
+        <p:spPr>
+          <a:xfrm>
+            <a:off x="3059832" y="1752776"/>
+            <a:ext cx="5723633" cy="2759981"/>
+          </a:xfrm>
+          <a:prstGeom prst="rect">
+            <a:avLst/>
+          </a:prstGeom>
+        </p:spPr>
+      </p:pic>
+    </p:spTree>
+    <p:extLst>
+      <p:ext uri="{BB962C8B-B14F-4D97-AF65-F5344CB8AC3E}">
+        <p14:creationId xmlns:p14="http://schemas.microsoft.com/office/powerpoint/2010/main" val="1197027845"/>
+      </p:ext>
+    </p:extLst>
+  </p:cSld>
+  <p:clrMapOvr>
+    <a:masterClrMapping/>
+  </p:clrMapOvr>
+</p:sld>
+</file>
+
+<file path=ppt/slides/slide42.xml><?xml version="1.0" encoding="utf-8"?>
+<p:sld xmlns:a="http://schemas.openxmlformats.org/drawingml/2006/main" xmlns:r="http://schemas.openxmlformats.org/officeDocument/2006/relationships" xmlns:p="http://schemas.openxmlformats.org/presentationml/2006/main">
+  <p:cSld>
+    <p:spTree>
+      <p:nvGrpSpPr>
+        <p:cNvPr id="1" name="">
+          <a:extLst>
+            <a:ext uri="{FF2B5EF4-FFF2-40B4-BE49-F238E27FC236}">
+              <a16:creationId xmlns:a16="http://schemas.microsoft.com/office/drawing/2014/main" id="{8E436EE9-C990-5FE7-041E-4F5B09E7CD6C}"/>
+            </a:ext>
+          </a:extLst>
+        </p:cNvPr>
+        <p:cNvGrpSpPr/>
+        <p:nvPr/>
+      </p:nvGrpSpPr>
+      <p:grpSpPr>
+        <a:xfrm>
+          <a:off x="0" y="0"/>
+          <a:ext cx="0" cy="0"/>
+          <a:chOff x="0" y="0"/>
+          <a:chExt cx="0" cy="0"/>
+        </a:xfrm>
+      </p:grpSpPr>
+      <p:sp>
+        <p:nvSpPr>
+          <p:cNvPr id="8" name="Textplatzhalter 7">
+            <a:extLst>
+              <a:ext uri="{FF2B5EF4-FFF2-40B4-BE49-F238E27FC236}">
+                <a16:creationId xmlns:a16="http://schemas.microsoft.com/office/drawing/2014/main" id="{78E8AD95-61A2-77CD-B870-A319B7260E8F}"/>
+              </a:ext>
+            </a:extLst>
+          </p:cNvPr>
+          <p:cNvSpPr>
+            <a:spLocks noGrp="1"/>
+          </p:cNvSpPr>
+          <p:nvPr>
+            <p:ph type="body" sz="quarter" idx="12"/>
+          </p:nvPr>
+        </p:nvSpPr>
+        <p:spPr/>
+        <p:txBody>
+          <a:bodyPr/>
+          <a:lstStyle/>
+          <a:p>
+            <a:r>
+              <a:rPr lang="en-US" dirty="0"/>
+              <a:t>MobSF Static Scan</a:t>
+            </a:r>
+          </a:p>
+        </p:txBody>
+      </p:sp>
+      <p:sp>
+        <p:nvSpPr>
+          <p:cNvPr id="7" name="Titel 6">
+            <a:extLst>
+              <a:ext uri="{FF2B5EF4-FFF2-40B4-BE49-F238E27FC236}">
+                <a16:creationId xmlns:a16="http://schemas.microsoft.com/office/drawing/2014/main" id="{8AC539FA-EBDF-C1CB-E52F-738DBCDA4692}"/>
+              </a:ext>
+            </a:extLst>
+          </p:cNvPr>
+          <p:cNvSpPr>
+            <a:spLocks noGrp="1"/>
+          </p:cNvSpPr>
+          <p:nvPr>
+            <p:ph type="title"/>
+          </p:nvPr>
+        </p:nvSpPr>
+        <p:spPr/>
+        <p:txBody>
+          <a:bodyPr/>
+          <a:lstStyle/>
+          <a:p>
+            <a:r>
+              <a:rPr lang="en-US" dirty="0"/>
+              <a:t>Results</a:t>
+            </a:r>
+          </a:p>
+        </p:txBody>
+      </p:sp>
+      <p:sp>
+        <p:nvSpPr>
+          <p:cNvPr id="10" name="Inhaltsplatzhalter 9">
+            <a:extLst>
+              <a:ext uri="{FF2B5EF4-FFF2-40B4-BE49-F238E27FC236}">
+                <a16:creationId xmlns:a16="http://schemas.microsoft.com/office/drawing/2014/main" id="{3D4081EF-A6FC-3D8B-48D3-79CF305C88E4}"/>
+              </a:ext>
+            </a:extLst>
+          </p:cNvPr>
+          <p:cNvSpPr>
+            <a:spLocks noGrp="1"/>
+          </p:cNvSpPr>
+          <p:nvPr>
+            <p:ph sz="quarter" idx="20"/>
+          </p:nvPr>
+        </p:nvSpPr>
+        <p:spPr>
+          <a:xfrm>
+            <a:off x="359533" y="1203598"/>
+            <a:ext cx="8424467" cy="3332402"/>
+          </a:xfrm>
+        </p:spPr>
+        <p:txBody>
+          <a:bodyPr anchor="t"/>
+          <a:lstStyle/>
+          <a:p>
+            <a:pPr>
+              <a:lnSpc>
+                <a:spcPct val="150000"/>
+              </a:lnSpc>
+            </a:pPr>
+            <a:r>
+              <a:rPr lang="en-US" dirty="0"/>
+              <a:t>Surprisingly high security scores</a:t>
+            </a:r>
+          </a:p>
+          <a:p>
+            <a:pPr>
+              <a:lnSpc>
+                <a:spcPct val="150000"/>
+              </a:lnSpc>
+            </a:pPr>
+            <a:r>
+              <a:rPr lang="en-US" dirty="0"/>
+              <a:t>Storage and crypto apps deemed “low risk”</a:t>
+            </a:r>
+          </a:p>
+          <a:p>
+            <a:pPr>
+              <a:lnSpc>
+                <a:spcPct val="150000"/>
+              </a:lnSpc>
+            </a:pPr>
+            <a:r>
+              <a:rPr lang="en-US" dirty="0"/>
+              <a:t>Inconsistent vulnerability detection</a:t>
+            </a:r>
+          </a:p>
+          <a:p>
+            <a:pPr>
+              <a:lnSpc>
+                <a:spcPct val="150000"/>
+              </a:lnSpc>
+            </a:pPr>
+            <a:r>
+              <a:rPr lang="en-US" dirty="0"/>
+              <a:t>Many false positives</a:t>
+            </a:r>
+          </a:p>
+        </p:txBody>
+      </p:sp>
+      <p:sp>
+        <p:nvSpPr>
+          <p:cNvPr id="9" name="Textplatzhalter 8">
+            <a:extLst>
+              <a:ext uri="{FF2B5EF4-FFF2-40B4-BE49-F238E27FC236}">
+                <a16:creationId xmlns:a16="http://schemas.microsoft.com/office/drawing/2014/main" id="{E6E9340D-6B84-073F-A6ED-82115C9DA4D4}"/>
+              </a:ext>
+            </a:extLst>
+          </p:cNvPr>
+          <p:cNvSpPr>
+            <a:spLocks noGrp="1"/>
+          </p:cNvSpPr>
+          <p:nvPr>
+            <p:ph type="body" sz="quarter" idx="19"/>
+          </p:nvPr>
+        </p:nvSpPr>
+        <p:spPr/>
+        <p:txBody>
+          <a:bodyPr/>
+          <a:lstStyle/>
+          <a:p>
+            <a:endParaRPr lang="en-US" dirty="0"/>
+          </a:p>
+        </p:txBody>
+      </p:sp>
+      <p:sp>
+        <p:nvSpPr>
+          <p:cNvPr id="11" name="Fußzeilenplatzhalter 10">
+            <a:extLst>
+              <a:ext uri="{FF2B5EF4-FFF2-40B4-BE49-F238E27FC236}">
+                <a16:creationId xmlns:a16="http://schemas.microsoft.com/office/drawing/2014/main" id="{D06F3D58-BF04-8E6A-1D75-45010D651BDC}"/>
+              </a:ext>
+            </a:extLst>
+          </p:cNvPr>
+          <p:cNvSpPr>
+            <a:spLocks noGrp="1"/>
+          </p:cNvSpPr>
+          <p:nvPr>
+            <p:ph type="ftr" sz="quarter" idx="17"/>
+          </p:nvPr>
+        </p:nvSpPr>
+        <p:spPr/>
+        <p:txBody>
+          <a:bodyPr/>
+          <a:lstStyle/>
+          <a:p>
+            <a:endParaRPr lang="de-CH" dirty="0"/>
+          </a:p>
+        </p:txBody>
+      </p:sp>
+      <p:sp>
+        <p:nvSpPr>
+          <p:cNvPr id="12" name="Foliennummernplatzhalter 11">
+            <a:extLst>
+              <a:ext uri="{FF2B5EF4-FFF2-40B4-BE49-F238E27FC236}">
+                <a16:creationId xmlns:a16="http://schemas.microsoft.com/office/drawing/2014/main" id="{AA0553A4-0692-4646-8E66-2D3709ED2238}"/>
+              </a:ext>
+            </a:extLst>
+          </p:cNvPr>
+          <p:cNvSpPr>
+            <a:spLocks noGrp="1"/>
+          </p:cNvSpPr>
+          <p:nvPr>
+            <p:ph type="sldNum" sz="quarter" idx="18"/>
+          </p:nvPr>
+        </p:nvSpPr>
+        <p:spPr/>
+        <p:txBody>
+          <a:bodyPr/>
+          <a:lstStyle/>
+          <a:p>
+            <a:fld id="{E6639024-6672-4F87-864B-EA4FA9190A1A}" type="slidenum">
+              <a:rPr lang="de-CH" smtClean="0"/>
+              <a:pPr/>
+              <a:t>42</a:t>
+            </a:fld>
+            <a:endParaRPr lang="de-CH" dirty="0"/>
+          </a:p>
+        </p:txBody>
+      </p:sp>
+    </p:spTree>
+    <p:extLst>
+      <p:ext uri="{BB962C8B-B14F-4D97-AF65-F5344CB8AC3E}">
+        <p14:creationId xmlns:p14="http://schemas.microsoft.com/office/powerpoint/2010/main" val="3692513435"/>
+      </p:ext>
+    </p:extLst>
+  </p:cSld>
+  <p:clrMapOvr>
+    <a:masterClrMapping/>
+  </p:clrMapOvr>
+</p:sld>
+</file>
+
+<file path=ppt/slides/slide43.xml><?xml version="1.0" encoding="utf-8"?>
+<p:sld xmlns:a="http://schemas.openxmlformats.org/drawingml/2006/main" xmlns:r="http://schemas.openxmlformats.org/officeDocument/2006/relationships" xmlns:p="http://schemas.openxmlformats.org/presentationml/2006/main">
+  <p:cSld>
+    <p:spTree>
+      <p:nvGrpSpPr>
+        <p:cNvPr id="1" name="">
+          <a:extLst>
+            <a:ext uri="{FF2B5EF4-FFF2-40B4-BE49-F238E27FC236}">
+              <a16:creationId xmlns:a16="http://schemas.microsoft.com/office/drawing/2014/main" id="{B894C845-A802-16D2-D74D-E572E59835B6}"/>
+            </a:ext>
+          </a:extLst>
+        </p:cNvPr>
+        <p:cNvGrpSpPr/>
+        <p:nvPr/>
+      </p:nvGrpSpPr>
+      <p:grpSpPr>
+        <a:xfrm>
+          <a:off x="0" y="0"/>
+          <a:ext cx="0" cy="0"/>
+          <a:chOff x="0" y="0"/>
+          <a:chExt cx="0" cy="0"/>
+        </a:xfrm>
+      </p:grpSpPr>
+      <p:sp>
+        <p:nvSpPr>
+          <p:cNvPr id="8" name="Textplatzhalter 7">
+            <a:extLst>
+              <a:ext uri="{FF2B5EF4-FFF2-40B4-BE49-F238E27FC236}">
+                <a16:creationId xmlns:a16="http://schemas.microsoft.com/office/drawing/2014/main" id="{E958305D-F68E-F857-33C3-28778BE9809D}"/>
+              </a:ext>
+            </a:extLst>
+          </p:cNvPr>
+          <p:cNvSpPr>
+            <a:spLocks noGrp="1"/>
+          </p:cNvSpPr>
+          <p:nvPr>
+            <p:ph type="body" sz="quarter" idx="12"/>
+          </p:nvPr>
+        </p:nvSpPr>
+        <p:spPr/>
+        <p:txBody>
+          <a:bodyPr/>
+          <a:lstStyle/>
+          <a:p>
+            <a:r>
+              <a:rPr lang="en-US" dirty="0" err="1"/>
+              <a:t>Semgrep</a:t>
+            </a:r>
+            <a:r>
+              <a:rPr lang="en-US" dirty="0"/>
+              <a:t> Static Scan</a:t>
+            </a:r>
+          </a:p>
+        </p:txBody>
+      </p:sp>
+      <p:sp>
+        <p:nvSpPr>
+          <p:cNvPr id="7" name="Titel 6">
+            <a:extLst>
+              <a:ext uri="{FF2B5EF4-FFF2-40B4-BE49-F238E27FC236}">
+                <a16:creationId xmlns:a16="http://schemas.microsoft.com/office/drawing/2014/main" id="{97D00815-A5F6-BA3A-2DC4-2153B7942392}"/>
+              </a:ext>
+            </a:extLst>
+          </p:cNvPr>
+          <p:cNvSpPr>
+            <a:spLocks noGrp="1"/>
+          </p:cNvSpPr>
+          <p:nvPr>
+            <p:ph type="title"/>
+          </p:nvPr>
+        </p:nvSpPr>
+        <p:spPr/>
+        <p:txBody>
+          <a:bodyPr/>
+          <a:lstStyle/>
+          <a:p>
+            <a:r>
+              <a:rPr lang="en-US" dirty="0"/>
+              <a:t>Results</a:t>
+            </a:r>
+          </a:p>
+        </p:txBody>
+      </p:sp>
+      <p:sp>
+        <p:nvSpPr>
+          <p:cNvPr id="10" name="Inhaltsplatzhalter 9">
+            <a:extLst>
+              <a:ext uri="{FF2B5EF4-FFF2-40B4-BE49-F238E27FC236}">
+                <a16:creationId xmlns:a16="http://schemas.microsoft.com/office/drawing/2014/main" id="{DE6602BA-CB0E-8437-9505-F44B7F650C5E}"/>
+              </a:ext>
+            </a:extLst>
+          </p:cNvPr>
+          <p:cNvSpPr>
+            <a:spLocks noGrp="1"/>
+          </p:cNvSpPr>
+          <p:nvPr>
+            <p:ph sz="quarter" idx="20"/>
+          </p:nvPr>
+        </p:nvSpPr>
+        <p:spPr>
+          <a:xfrm>
+            <a:off x="359533" y="1203598"/>
+            <a:ext cx="8424467" cy="3332402"/>
+          </a:xfrm>
+        </p:spPr>
+        <p:txBody>
+          <a:bodyPr anchor="t"/>
+          <a:lstStyle/>
+          <a:p>
+            <a:pPr>
+              <a:lnSpc>
+                <a:spcPct val="150000"/>
+              </a:lnSpc>
+            </a:pPr>
+            <a:r>
+              <a:rPr lang="en-US" dirty="0"/>
+              <a:t>Slightly better than MobSF</a:t>
+            </a:r>
+          </a:p>
+          <a:p>
+            <a:pPr>
+              <a:lnSpc>
+                <a:spcPct val="150000"/>
+              </a:lnSpc>
+            </a:pPr>
+            <a:r>
+              <a:rPr lang="en-US" dirty="0"/>
+              <a:t>Found 8 of 28 vulnerabilities</a:t>
+            </a:r>
+          </a:p>
+          <a:p>
+            <a:pPr>
+              <a:lnSpc>
+                <a:spcPct val="150000"/>
+              </a:lnSpc>
+            </a:pPr>
+            <a:r>
+              <a:rPr lang="en-US" dirty="0"/>
+              <a:t>Failed to flag deprecated cryptographic algorithms</a:t>
+            </a:r>
+          </a:p>
+        </p:txBody>
+      </p:sp>
+      <p:sp>
+        <p:nvSpPr>
+          <p:cNvPr id="9" name="Textplatzhalter 8">
+            <a:extLst>
+              <a:ext uri="{FF2B5EF4-FFF2-40B4-BE49-F238E27FC236}">
+                <a16:creationId xmlns:a16="http://schemas.microsoft.com/office/drawing/2014/main" id="{2AE5507F-3E4F-A073-9302-391F8C17E42B}"/>
+              </a:ext>
+            </a:extLst>
+          </p:cNvPr>
+          <p:cNvSpPr>
+            <a:spLocks noGrp="1"/>
+          </p:cNvSpPr>
+          <p:nvPr>
+            <p:ph type="body" sz="quarter" idx="19"/>
+          </p:nvPr>
+        </p:nvSpPr>
+        <p:spPr/>
+        <p:txBody>
+          <a:bodyPr/>
+          <a:lstStyle/>
+          <a:p>
+            <a:endParaRPr lang="en-US" dirty="0"/>
+          </a:p>
+        </p:txBody>
+      </p:sp>
+      <p:sp>
+        <p:nvSpPr>
+          <p:cNvPr id="11" name="Fußzeilenplatzhalter 10">
+            <a:extLst>
+              <a:ext uri="{FF2B5EF4-FFF2-40B4-BE49-F238E27FC236}">
+                <a16:creationId xmlns:a16="http://schemas.microsoft.com/office/drawing/2014/main" id="{10EF794A-1D62-9F28-8543-EEA1BA5326AB}"/>
+              </a:ext>
+            </a:extLst>
+          </p:cNvPr>
+          <p:cNvSpPr>
+            <a:spLocks noGrp="1"/>
+          </p:cNvSpPr>
+          <p:nvPr>
+            <p:ph type="ftr" sz="quarter" idx="17"/>
+          </p:nvPr>
+        </p:nvSpPr>
+        <p:spPr/>
+        <p:txBody>
+          <a:bodyPr/>
+          <a:lstStyle/>
+          <a:p>
+            <a:endParaRPr lang="de-CH" dirty="0"/>
+          </a:p>
+        </p:txBody>
+      </p:sp>
+      <p:sp>
+        <p:nvSpPr>
+          <p:cNvPr id="12" name="Foliennummernplatzhalter 11">
+            <a:extLst>
+              <a:ext uri="{FF2B5EF4-FFF2-40B4-BE49-F238E27FC236}">
+                <a16:creationId xmlns:a16="http://schemas.microsoft.com/office/drawing/2014/main" id="{05AB2E62-B7C3-C2AB-23F5-0D2D3381EE06}"/>
+              </a:ext>
+            </a:extLst>
+          </p:cNvPr>
+          <p:cNvSpPr>
+            <a:spLocks noGrp="1"/>
+          </p:cNvSpPr>
+          <p:nvPr>
+            <p:ph type="sldNum" sz="quarter" idx="18"/>
+          </p:nvPr>
+        </p:nvSpPr>
+        <p:spPr/>
+        <p:txBody>
+          <a:bodyPr/>
+          <a:lstStyle/>
+          <a:p>
+            <a:fld id="{E6639024-6672-4F87-864B-EA4FA9190A1A}" type="slidenum">
+              <a:rPr lang="de-CH" smtClean="0"/>
+              <a:pPr/>
+              <a:t>43</a:t>
+            </a:fld>
+            <a:endParaRPr lang="de-CH" dirty="0"/>
+          </a:p>
+        </p:txBody>
+      </p:sp>
+    </p:spTree>
+    <p:extLst>
+      <p:ext uri="{BB962C8B-B14F-4D97-AF65-F5344CB8AC3E}">
+        <p14:creationId xmlns:p14="http://schemas.microsoft.com/office/powerpoint/2010/main" val="4009884843"/>
+      </p:ext>
+    </p:extLst>
+  </p:cSld>
+  <p:clrMapOvr>
+    <a:masterClrMapping/>
+  </p:clrMapOvr>
+</p:sld>
+</file>
+
+<file path=ppt/slides/slide44.xml><?xml version="1.0" encoding="utf-8"?>
+<p:sld xmlns:a="http://schemas.openxmlformats.org/drawingml/2006/main" xmlns:r="http://schemas.openxmlformats.org/officeDocument/2006/relationships" xmlns:p="http://schemas.openxmlformats.org/presentationml/2006/main">
+  <p:cSld>
+    <p:spTree>
+      <p:nvGrpSpPr>
+        <p:cNvPr id="1" name="">
+          <a:extLst>
+            <a:ext uri="{FF2B5EF4-FFF2-40B4-BE49-F238E27FC236}">
+              <a16:creationId xmlns:a16="http://schemas.microsoft.com/office/drawing/2014/main" id="{8D850EDE-EE95-0801-9755-C57819655EA2}"/>
+            </a:ext>
+          </a:extLst>
+        </p:cNvPr>
+        <p:cNvGrpSpPr/>
+        <p:nvPr/>
+      </p:nvGrpSpPr>
+      <p:grpSpPr>
+        <a:xfrm>
+          <a:off x="0" y="0"/>
+          <a:ext cx="0" cy="0"/>
+          <a:chOff x="0" y="0"/>
+          <a:chExt cx="0" cy="0"/>
+        </a:xfrm>
+      </p:grpSpPr>
+      <p:sp>
+        <p:nvSpPr>
+          <p:cNvPr id="8" name="Textplatzhalter 7">
+            <a:extLst>
+              <a:ext uri="{FF2B5EF4-FFF2-40B4-BE49-F238E27FC236}">
+                <a16:creationId xmlns:a16="http://schemas.microsoft.com/office/drawing/2014/main" id="{F67E9F36-AB03-5D9B-790C-7E639B94B1BE}"/>
+              </a:ext>
+            </a:extLst>
+          </p:cNvPr>
+          <p:cNvSpPr>
+            <a:spLocks noGrp="1"/>
+          </p:cNvSpPr>
+          <p:nvPr>
+            <p:ph type="body" sz="quarter" idx="12"/>
+          </p:nvPr>
+        </p:nvSpPr>
+        <p:spPr/>
+        <p:txBody>
+          <a:bodyPr/>
+          <a:lstStyle/>
+          <a:p>
+            <a:r>
+              <a:rPr lang="en-US" dirty="0"/>
+              <a:t>Benchmarking</a:t>
+            </a:r>
+          </a:p>
+        </p:txBody>
+      </p:sp>
+      <p:sp>
+        <p:nvSpPr>
+          <p:cNvPr id="7" name="Titel 6">
+            <a:extLst>
+              <a:ext uri="{FF2B5EF4-FFF2-40B4-BE49-F238E27FC236}">
+                <a16:creationId xmlns:a16="http://schemas.microsoft.com/office/drawing/2014/main" id="{162D9B01-8A0B-5E40-AE47-13BF3F7F22E2}"/>
+              </a:ext>
+            </a:extLst>
+          </p:cNvPr>
+          <p:cNvSpPr>
+            <a:spLocks noGrp="1"/>
+          </p:cNvSpPr>
+          <p:nvPr>
+            <p:ph type="title"/>
+          </p:nvPr>
+        </p:nvSpPr>
+        <p:spPr/>
+        <p:txBody>
+          <a:bodyPr/>
+          <a:lstStyle/>
+          <a:p>
+            <a:r>
+              <a:rPr lang="en-US" dirty="0"/>
+              <a:t>Outlook</a:t>
+            </a:r>
+          </a:p>
+        </p:txBody>
+      </p:sp>
+      <p:sp>
+        <p:nvSpPr>
+          <p:cNvPr id="10" name="Inhaltsplatzhalter 9">
+            <a:extLst>
+              <a:ext uri="{FF2B5EF4-FFF2-40B4-BE49-F238E27FC236}">
+                <a16:creationId xmlns:a16="http://schemas.microsoft.com/office/drawing/2014/main" id="{83692E1F-15B6-D264-0E11-C5078E79CAB7}"/>
+              </a:ext>
+            </a:extLst>
+          </p:cNvPr>
+          <p:cNvSpPr>
+            <a:spLocks noGrp="1"/>
+          </p:cNvSpPr>
+          <p:nvPr>
+            <p:ph sz="quarter" idx="20"/>
+          </p:nvPr>
+        </p:nvSpPr>
+        <p:spPr>
+          <a:xfrm>
+            <a:off x="359533" y="1203598"/>
+            <a:ext cx="8424467" cy="3332402"/>
+          </a:xfrm>
+        </p:spPr>
+        <p:txBody>
+          <a:bodyPr anchor="t"/>
+          <a:lstStyle/>
+          <a:p>
+            <a:pPr>
+              <a:lnSpc>
+                <a:spcPct val="150000"/>
+              </a:lnSpc>
+            </a:pPr>
+            <a:r>
+              <a:rPr lang="en-US" dirty="0"/>
+              <a:t>Natural next step</a:t>
+            </a:r>
+          </a:p>
+          <a:p>
+            <a:pPr>
+              <a:lnSpc>
+                <a:spcPct val="150000"/>
+              </a:lnSpc>
+            </a:pPr>
+            <a:r>
+              <a:rPr lang="en-US" dirty="0"/>
+              <a:t>Combine our apps with others</a:t>
+            </a:r>
+          </a:p>
+          <a:p>
+            <a:pPr>
+              <a:lnSpc>
+                <a:spcPct val="150000"/>
+              </a:lnSpc>
+            </a:pPr>
+            <a:r>
+              <a:rPr lang="en-US" dirty="0"/>
+              <a:t>Compare with existing benchmarks</a:t>
+            </a:r>
+          </a:p>
+        </p:txBody>
+      </p:sp>
+      <p:sp>
+        <p:nvSpPr>
+          <p:cNvPr id="9" name="Textplatzhalter 8">
+            <a:extLst>
+              <a:ext uri="{FF2B5EF4-FFF2-40B4-BE49-F238E27FC236}">
+                <a16:creationId xmlns:a16="http://schemas.microsoft.com/office/drawing/2014/main" id="{E0F4C412-038E-2975-D816-78E0184B99D1}"/>
+              </a:ext>
+            </a:extLst>
+          </p:cNvPr>
+          <p:cNvSpPr>
+            <a:spLocks noGrp="1"/>
+          </p:cNvSpPr>
+          <p:nvPr>
+            <p:ph type="body" sz="quarter" idx="19"/>
+          </p:nvPr>
+        </p:nvSpPr>
+        <p:spPr/>
+        <p:txBody>
+          <a:bodyPr/>
+          <a:lstStyle/>
+          <a:p>
+            <a:endParaRPr lang="en-US" dirty="0"/>
+          </a:p>
+        </p:txBody>
+      </p:sp>
+      <p:sp>
+        <p:nvSpPr>
+          <p:cNvPr id="11" name="Fußzeilenplatzhalter 10">
+            <a:extLst>
+              <a:ext uri="{FF2B5EF4-FFF2-40B4-BE49-F238E27FC236}">
+                <a16:creationId xmlns:a16="http://schemas.microsoft.com/office/drawing/2014/main" id="{676C700E-5399-7EEF-44D1-D7552BE4BCA9}"/>
+              </a:ext>
+            </a:extLst>
+          </p:cNvPr>
+          <p:cNvSpPr>
+            <a:spLocks noGrp="1"/>
+          </p:cNvSpPr>
+          <p:nvPr>
+            <p:ph type="ftr" sz="quarter" idx="17"/>
+          </p:nvPr>
+        </p:nvSpPr>
+        <p:spPr/>
+        <p:txBody>
+          <a:bodyPr/>
+          <a:lstStyle/>
+          <a:p>
+            <a:endParaRPr lang="de-CH" dirty="0"/>
+          </a:p>
+        </p:txBody>
+      </p:sp>
+      <p:sp>
+        <p:nvSpPr>
+          <p:cNvPr id="12" name="Foliennummernplatzhalter 11">
+            <a:extLst>
+              <a:ext uri="{FF2B5EF4-FFF2-40B4-BE49-F238E27FC236}">
+                <a16:creationId xmlns:a16="http://schemas.microsoft.com/office/drawing/2014/main" id="{DEE3525B-883D-594B-F2F3-F659A70B8BEF}"/>
+              </a:ext>
+            </a:extLst>
+          </p:cNvPr>
+          <p:cNvSpPr>
+            <a:spLocks noGrp="1"/>
+          </p:cNvSpPr>
+          <p:nvPr>
+            <p:ph type="sldNum" sz="quarter" idx="18"/>
+          </p:nvPr>
+        </p:nvSpPr>
+        <p:spPr/>
+        <p:txBody>
+          <a:bodyPr/>
+          <a:lstStyle/>
+          <a:p>
+            <a:fld id="{E6639024-6672-4F87-864B-EA4FA9190A1A}" type="slidenum">
+              <a:rPr lang="de-CH" smtClean="0"/>
+              <a:pPr/>
+              <a:t>44</a:t>
+            </a:fld>
+            <a:endParaRPr lang="de-CH" dirty="0"/>
+          </a:p>
+        </p:txBody>
+      </p:sp>
+    </p:spTree>
+    <p:extLst>
+      <p:ext uri="{BB962C8B-B14F-4D97-AF65-F5344CB8AC3E}">
+        <p14:creationId xmlns:p14="http://schemas.microsoft.com/office/powerpoint/2010/main" val="2970494048"/>
+      </p:ext>
+    </p:extLst>
+  </p:cSld>
+  <p:clrMapOvr>
+    <a:masterClrMapping/>
+  </p:clrMapOvr>
+</p:sld>
+</file>
+
+<file path=ppt/slides/slide45.xml><?xml version="1.0" encoding="utf-8"?>
+<p:sld xmlns:a="http://schemas.openxmlformats.org/drawingml/2006/main" xmlns:r="http://schemas.openxmlformats.org/officeDocument/2006/relationships" xmlns:p="http://schemas.openxmlformats.org/presentationml/2006/main">
+  <p:cSld>
+    <p:spTree>
+      <p:nvGrpSpPr>
+        <p:cNvPr id="1" name="">
+          <a:extLst>
+            <a:ext uri="{FF2B5EF4-FFF2-40B4-BE49-F238E27FC236}">
               <a16:creationId xmlns:a16="http://schemas.microsoft.com/office/drawing/2014/main" id="{85FC20D1-57AD-F86B-8489-2E358DBADFBB}"/>
             </a:ext>
           </a:extLst>
@@ -41337,7 +42696,10 @@
           <a:bodyPr/>
           <a:lstStyle/>
           <a:p>
-            <a:endParaRPr lang="en-US"/>
+            <a:r>
+              <a:rPr lang="en-US" dirty="0"/>
+              <a:t>Moving on to new Categories</a:t>
+            </a:r>
           </a:p>
         </p:txBody>
       </p:sp>
@@ -41362,7 +42724,10 @@
           <a:bodyPr/>
           <a:lstStyle/>
           <a:p>
-            <a:endParaRPr lang="en-US" dirty="0"/>
+            <a:r>
+              <a:rPr lang="en-US" dirty="0"/>
+              <a:t>Outlook</a:t>
+            </a:r>
           </a:p>
         </p:txBody>
       </p:sp>
@@ -41397,7 +42762,32 @@
                 <a:spcPct val="150000"/>
               </a:lnSpc>
             </a:pPr>
-            <a:endParaRPr lang="en-US" dirty="0"/>
+            <a:r>
+              <a:rPr lang="en-US" dirty="0"/>
+              <a:t>Only 60/117 (51.3%) of MASWE vulnerabilities implemented</a:t>
+            </a:r>
+          </a:p>
+          <a:p>
+            <a:pPr>
+              <a:lnSpc>
+                <a:spcPct val="150000"/>
+              </a:lnSpc>
+            </a:pPr>
+            <a:r>
+              <a:rPr lang="en-US" dirty="0"/>
+              <a:t>Privacy and auth still neglected</a:t>
+            </a:r>
+          </a:p>
+          <a:p>
+            <a:pPr>
+              <a:lnSpc>
+                <a:spcPct val="150000"/>
+              </a:lnSpc>
+            </a:pPr>
+            <a:r>
+              <a:rPr lang="en-US" dirty="0"/>
+              <a:t>Important for both educational and benchmarking reasons</a:t>
+            </a:r>
           </a:p>
         </p:txBody>
       </p:sp>
@@ -41475,7 +42865,7 @@
             <a:fld id="{E6639024-6672-4F87-864B-EA4FA9190A1A}" type="slidenum">
               <a:rPr lang="de-CH" smtClean="0"/>
               <a:pPr/>
-              <a:t>40</a:t>
+              <a:t>45</a:t>
             </a:fld>
             <a:endParaRPr lang="de-CH" dirty="0"/>
           </a:p>
@@ -41494,7 +42884,7 @@
 </p:sld>
 </file>
 
-<file path=ppt/slides/slide41.xml><?xml version="1.0" encoding="utf-8"?>
+<file path=ppt/slides/slide46.xml><?xml version="1.0" encoding="utf-8"?>
 <p:sld xmlns:a="http://schemas.openxmlformats.org/drawingml/2006/main" xmlns:r="http://schemas.openxmlformats.org/officeDocument/2006/relationships" xmlns:p="http://schemas.openxmlformats.org/presentationml/2006/main">
   <p:cSld>
     <p:spTree>
@@ -41538,7 +42928,10 @@
           <a:bodyPr/>
           <a:lstStyle/>
           <a:p>
-            <a:endParaRPr lang="en-US"/>
+            <a:r>
+              <a:rPr lang="en-US" dirty="0"/>
+              <a:t>Summary</a:t>
+            </a:r>
           </a:p>
         </p:txBody>
       </p:sp>
@@ -41563,7 +42956,10 @@
           <a:bodyPr/>
           <a:lstStyle/>
           <a:p>
-            <a:endParaRPr lang="en-US" dirty="0"/>
+            <a:r>
+              <a:rPr lang="en-US" dirty="0"/>
+              <a:t>Conclusion</a:t>
+            </a:r>
           </a:p>
         </p:txBody>
       </p:sp>
@@ -41598,6 +42994,39 @@
                 <a:spcPct val="150000"/>
               </a:lnSpc>
             </a:pPr>
+            <a:r>
+              <a:rPr lang="en-US" dirty="0"/>
+              <a:t>Identified weaknesses of MASTG apps</a:t>
+            </a:r>
+          </a:p>
+          <a:p>
+            <a:pPr>
+              <a:lnSpc>
+                <a:spcPct val="150000"/>
+              </a:lnSpc>
+            </a:pPr>
+            <a:r>
+              <a:rPr lang="en-US" dirty="0"/>
+              <a:t>Addressed them in a scalable and expandable way</a:t>
+            </a:r>
+          </a:p>
+          <a:p>
+            <a:pPr>
+              <a:lnSpc>
+                <a:spcPct val="150000"/>
+              </a:lnSpc>
+            </a:pPr>
+            <a:r>
+              <a:rPr lang="en-US" dirty="0"/>
+              <a:t>Built basis of MASTG tool testing benchmark</a:t>
+            </a:r>
+          </a:p>
+          <a:p>
+            <a:pPr>
+              <a:lnSpc>
+                <a:spcPct val="150000"/>
+              </a:lnSpc>
+            </a:pPr>
             <a:endParaRPr lang="en-US" dirty="0"/>
           </a:p>
         </p:txBody>
@@ -41676,7 +43105,7 @@
             <a:fld id="{E6639024-6672-4F87-864B-EA4FA9190A1A}" type="slidenum">
               <a:rPr lang="de-CH" smtClean="0"/>
               <a:pPr/>
-              <a:t>41</a:t>
+              <a:t>46</a:t>
             </a:fld>
             <a:endParaRPr lang="de-CH" dirty="0"/>
           </a:p>
@@ -41686,6 +43115,615 @@
     <p:extLst>
       <p:ext uri="{BB962C8B-B14F-4D97-AF65-F5344CB8AC3E}">
         <p14:creationId xmlns:p14="http://schemas.microsoft.com/office/powerpoint/2010/main" val="859088668"/>
+      </p:ext>
+    </p:extLst>
+  </p:cSld>
+  <p:clrMapOvr>
+    <a:masterClrMapping/>
+  </p:clrMapOvr>
+</p:sld>
+</file>
+
+<file path=ppt/slides/slide47.xml><?xml version="1.0" encoding="utf-8"?>
+<p:sld xmlns:a="http://schemas.openxmlformats.org/drawingml/2006/main" xmlns:r="http://schemas.openxmlformats.org/officeDocument/2006/relationships" xmlns:p="http://schemas.openxmlformats.org/presentationml/2006/main">
+  <p:cSld>
+    <p:spTree>
+      <p:nvGrpSpPr>
+        <p:cNvPr id="1" name="">
+          <a:extLst>
+            <a:ext uri="{FF2B5EF4-FFF2-40B4-BE49-F238E27FC236}">
+              <a16:creationId xmlns:a16="http://schemas.microsoft.com/office/drawing/2014/main" id="{19226741-3378-C652-CE5A-22458AF97E68}"/>
+            </a:ext>
+          </a:extLst>
+        </p:cNvPr>
+        <p:cNvGrpSpPr/>
+        <p:nvPr/>
+      </p:nvGrpSpPr>
+      <p:grpSpPr>
+        <a:xfrm>
+          <a:off x="0" y="0"/>
+          <a:ext cx="0" cy="0"/>
+          <a:chOff x="0" y="0"/>
+          <a:chExt cx="0" cy="0"/>
+        </a:xfrm>
+      </p:grpSpPr>
+      <p:sp>
+        <p:nvSpPr>
+          <p:cNvPr id="8" name="Textplatzhalter 7">
+            <a:extLst>
+              <a:ext uri="{FF2B5EF4-FFF2-40B4-BE49-F238E27FC236}">
+                <a16:creationId xmlns:a16="http://schemas.microsoft.com/office/drawing/2014/main" id="{6DAE21F1-DBDB-D981-0000-1A25FE77DA71}"/>
+              </a:ext>
+            </a:extLst>
+          </p:cNvPr>
+          <p:cNvSpPr>
+            <a:spLocks noGrp="1"/>
+          </p:cNvSpPr>
+          <p:nvPr>
+            <p:ph type="body" sz="quarter" idx="12"/>
+          </p:nvPr>
+        </p:nvSpPr>
+        <p:spPr/>
+        <p:txBody>
+          <a:bodyPr/>
+          <a:lstStyle/>
+          <a:p>
+            <a:endParaRPr lang="en-US"/>
+          </a:p>
+        </p:txBody>
+      </p:sp>
+      <p:sp>
+        <p:nvSpPr>
+          <p:cNvPr id="7" name="Titel 6">
+            <a:extLst>
+              <a:ext uri="{FF2B5EF4-FFF2-40B4-BE49-F238E27FC236}">
+                <a16:creationId xmlns:a16="http://schemas.microsoft.com/office/drawing/2014/main" id="{B499ECD8-21A2-F69E-66D9-542B96724E88}"/>
+              </a:ext>
+            </a:extLst>
+          </p:cNvPr>
+          <p:cNvSpPr>
+            <a:spLocks noGrp="1"/>
+          </p:cNvSpPr>
+          <p:nvPr>
+            <p:ph type="title"/>
+          </p:nvPr>
+        </p:nvSpPr>
+        <p:spPr/>
+        <p:txBody>
+          <a:bodyPr/>
+          <a:lstStyle/>
+          <a:p>
+            <a:r>
+              <a:rPr lang="en-US" dirty="0"/>
+              <a:t>Questions?</a:t>
+            </a:r>
+          </a:p>
+        </p:txBody>
+      </p:sp>
+      <p:sp>
+        <p:nvSpPr>
+          <p:cNvPr id="10" name="Inhaltsplatzhalter 9">
+            <a:extLst>
+              <a:ext uri="{FF2B5EF4-FFF2-40B4-BE49-F238E27FC236}">
+                <a16:creationId xmlns:a16="http://schemas.microsoft.com/office/drawing/2014/main" id="{F0209AC3-6152-2EC3-7B08-D60F78315CD9}"/>
+              </a:ext>
+            </a:extLst>
+          </p:cNvPr>
+          <p:cNvSpPr>
+            <a:spLocks noGrp="1"/>
+          </p:cNvSpPr>
+          <p:nvPr>
+            <p:ph sz="quarter" idx="20"/>
+          </p:nvPr>
+        </p:nvSpPr>
+        <p:spPr>
+          <a:xfrm>
+            <a:off x="359533" y="1203598"/>
+            <a:ext cx="8424467" cy="3332402"/>
+          </a:xfrm>
+        </p:spPr>
+        <p:txBody>
+          <a:bodyPr anchor="t"/>
+          <a:lstStyle/>
+          <a:p>
+            <a:pPr>
+              <a:lnSpc>
+                <a:spcPct val="150000"/>
+              </a:lnSpc>
+            </a:pPr>
+            <a:endParaRPr lang="en-US" dirty="0"/>
+          </a:p>
+        </p:txBody>
+      </p:sp>
+      <p:sp>
+        <p:nvSpPr>
+          <p:cNvPr id="9" name="Textplatzhalter 8">
+            <a:extLst>
+              <a:ext uri="{FF2B5EF4-FFF2-40B4-BE49-F238E27FC236}">
+                <a16:creationId xmlns:a16="http://schemas.microsoft.com/office/drawing/2014/main" id="{D0BE445A-0BE1-E0F9-67B0-0905722B74A2}"/>
+              </a:ext>
+            </a:extLst>
+          </p:cNvPr>
+          <p:cNvSpPr>
+            <a:spLocks noGrp="1"/>
+          </p:cNvSpPr>
+          <p:nvPr>
+            <p:ph type="body" sz="quarter" idx="19"/>
+          </p:nvPr>
+        </p:nvSpPr>
+        <p:spPr/>
+        <p:txBody>
+          <a:bodyPr/>
+          <a:lstStyle/>
+          <a:p>
+            <a:endParaRPr lang="en-US" dirty="0"/>
+          </a:p>
+        </p:txBody>
+      </p:sp>
+      <p:sp>
+        <p:nvSpPr>
+          <p:cNvPr id="11" name="Fußzeilenplatzhalter 10">
+            <a:extLst>
+              <a:ext uri="{FF2B5EF4-FFF2-40B4-BE49-F238E27FC236}">
+                <a16:creationId xmlns:a16="http://schemas.microsoft.com/office/drawing/2014/main" id="{6971C164-8476-F507-D597-E6464C90C2E0}"/>
+              </a:ext>
+            </a:extLst>
+          </p:cNvPr>
+          <p:cNvSpPr>
+            <a:spLocks noGrp="1"/>
+          </p:cNvSpPr>
+          <p:nvPr>
+            <p:ph type="ftr" sz="quarter" idx="17"/>
+          </p:nvPr>
+        </p:nvSpPr>
+        <p:spPr/>
+        <p:txBody>
+          <a:bodyPr/>
+          <a:lstStyle/>
+          <a:p>
+            <a:endParaRPr lang="de-CH" dirty="0"/>
+          </a:p>
+        </p:txBody>
+      </p:sp>
+      <p:sp>
+        <p:nvSpPr>
+          <p:cNvPr id="12" name="Foliennummernplatzhalter 11">
+            <a:extLst>
+              <a:ext uri="{FF2B5EF4-FFF2-40B4-BE49-F238E27FC236}">
+                <a16:creationId xmlns:a16="http://schemas.microsoft.com/office/drawing/2014/main" id="{50144C54-2894-0BD1-A93A-F2A240659B30}"/>
+              </a:ext>
+            </a:extLst>
+          </p:cNvPr>
+          <p:cNvSpPr>
+            <a:spLocks noGrp="1"/>
+          </p:cNvSpPr>
+          <p:nvPr>
+            <p:ph type="sldNum" sz="quarter" idx="18"/>
+          </p:nvPr>
+        </p:nvSpPr>
+        <p:spPr/>
+        <p:txBody>
+          <a:bodyPr/>
+          <a:lstStyle/>
+          <a:p>
+            <a:fld id="{E6639024-6672-4F87-864B-EA4FA9190A1A}" type="slidenum">
+              <a:rPr lang="de-CH" smtClean="0"/>
+              <a:pPr/>
+              <a:t>47</a:t>
+            </a:fld>
+            <a:endParaRPr lang="de-CH" dirty="0"/>
+          </a:p>
+        </p:txBody>
+      </p:sp>
+    </p:spTree>
+    <p:extLst>
+      <p:ext uri="{BB962C8B-B14F-4D97-AF65-F5344CB8AC3E}">
+        <p14:creationId xmlns:p14="http://schemas.microsoft.com/office/powerpoint/2010/main" val="1020592700"/>
+      </p:ext>
+    </p:extLst>
+  </p:cSld>
+  <p:clrMapOvr>
+    <a:masterClrMapping/>
+  </p:clrMapOvr>
+</p:sld>
+</file>
+
+<file path=ppt/slides/slide48.xml><?xml version="1.0" encoding="utf-8"?>
+<p:sld xmlns:a="http://schemas.openxmlformats.org/drawingml/2006/main" xmlns:r="http://schemas.openxmlformats.org/officeDocument/2006/relationships" xmlns:p="http://schemas.openxmlformats.org/presentationml/2006/main">
+  <p:cSld>
+    <p:spTree>
+      <p:nvGrpSpPr>
+        <p:cNvPr id="1" name="">
+          <a:extLst>
+            <a:ext uri="{FF2B5EF4-FFF2-40B4-BE49-F238E27FC236}">
+              <a16:creationId xmlns:a16="http://schemas.microsoft.com/office/drawing/2014/main" id="{7D6E30BC-8D2B-ABCB-ACED-04C90168D5E5}"/>
+            </a:ext>
+          </a:extLst>
+        </p:cNvPr>
+        <p:cNvGrpSpPr/>
+        <p:nvPr/>
+      </p:nvGrpSpPr>
+      <p:grpSpPr>
+        <a:xfrm>
+          <a:off x="0" y="0"/>
+          <a:ext cx="0" cy="0"/>
+          <a:chOff x="0" y="0"/>
+          <a:chExt cx="0" cy="0"/>
+        </a:xfrm>
+      </p:grpSpPr>
+      <p:sp>
+        <p:nvSpPr>
+          <p:cNvPr id="8" name="Textplatzhalter 7">
+            <a:extLst>
+              <a:ext uri="{FF2B5EF4-FFF2-40B4-BE49-F238E27FC236}">
+                <a16:creationId xmlns:a16="http://schemas.microsoft.com/office/drawing/2014/main" id="{26E4CD39-2B77-CB65-587D-23DC5FCD00B1}"/>
+              </a:ext>
+            </a:extLst>
+          </p:cNvPr>
+          <p:cNvSpPr>
+            <a:spLocks noGrp="1"/>
+          </p:cNvSpPr>
+          <p:nvPr>
+            <p:ph type="body" sz="quarter" idx="12"/>
+          </p:nvPr>
+        </p:nvSpPr>
+        <p:spPr/>
+        <p:txBody>
+          <a:bodyPr/>
+          <a:lstStyle/>
+          <a:p>
+            <a:endParaRPr lang="en-US" dirty="0"/>
+          </a:p>
+        </p:txBody>
+      </p:sp>
+      <p:sp>
+        <p:nvSpPr>
+          <p:cNvPr id="7" name="Titel 6">
+            <a:extLst>
+              <a:ext uri="{FF2B5EF4-FFF2-40B4-BE49-F238E27FC236}">
+                <a16:creationId xmlns:a16="http://schemas.microsoft.com/office/drawing/2014/main" id="{85F56EE2-9D2F-E529-5DB3-123FF39913EC}"/>
+              </a:ext>
+            </a:extLst>
+          </p:cNvPr>
+          <p:cNvSpPr>
+            <a:spLocks noGrp="1"/>
+          </p:cNvSpPr>
+          <p:nvPr>
+            <p:ph type="title"/>
+          </p:nvPr>
+        </p:nvSpPr>
+        <p:spPr/>
+        <p:txBody>
+          <a:bodyPr/>
+          <a:lstStyle/>
+          <a:p>
+            <a:r>
+              <a:rPr lang="en-US" dirty="0"/>
+              <a:t>References</a:t>
+            </a:r>
+          </a:p>
+        </p:txBody>
+      </p:sp>
+      <p:sp>
+        <p:nvSpPr>
+          <p:cNvPr id="10" name="Inhaltsplatzhalter 9">
+            <a:extLst>
+              <a:ext uri="{FF2B5EF4-FFF2-40B4-BE49-F238E27FC236}">
+                <a16:creationId xmlns:a16="http://schemas.microsoft.com/office/drawing/2014/main" id="{090446F2-8F46-FEEF-30D8-7C2D36877AF0}"/>
+              </a:ext>
+            </a:extLst>
+          </p:cNvPr>
+          <p:cNvSpPr>
+            <a:spLocks noGrp="1"/>
+          </p:cNvSpPr>
+          <p:nvPr>
+            <p:ph sz="quarter" idx="20"/>
+          </p:nvPr>
+        </p:nvSpPr>
+        <p:spPr>
+          <a:xfrm>
+            <a:off x="359533" y="1203598"/>
+            <a:ext cx="8424467" cy="3332402"/>
+          </a:xfrm>
+        </p:spPr>
+        <p:txBody>
+          <a:bodyPr anchor="t"/>
+          <a:lstStyle/>
+          <a:p>
+            <a:pPr>
+              <a:lnSpc>
+                <a:spcPct val="150000"/>
+              </a:lnSpc>
+            </a:pPr>
+            <a:endParaRPr lang="en-US" dirty="0"/>
+          </a:p>
+        </p:txBody>
+      </p:sp>
+      <p:sp>
+        <p:nvSpPr>
+          <p:cNvPr id="9" name="Textplatzhalter 8">
+            <a:extLst>
+              <a:ext uri="{FF2B5EF4-FFF2-40B4-BE49-F238E27FC236}">
+                <a16:creationId xmlns:a16="http://schemas.microsoft.com/office/drawing/2014/main" id="{99745CDA-60D0-F896-8FE0-83EF401AF55C}"/>
+              </a:ext>
+            </a:extLst>
+          </p:cNvPr>
+          <p:cNvSpPr>
+            <a:spLocks noGrp="1"/>
+          </p:cNvSpPr>
+          <p:nvPr>
+            <p:ph type="body" sz="quarter" idx="19"/>
+          </p:nvPr>
+        </p:nvSpPr>
+        <p:spPr/>
+        <p:txBody>
+          <a:bodyPr/>
+          <a:lstStyle/>
+          <a:p>
+            <a:endParaRPr lang="en-US" dirty="0"/>
+          </a:p>
+        </p:txBody>
+      </p:sp>
+      <p:sp>
+        <p:nvSpPr>
+          <p:cNvPr id="11" name="Fußzeilenplatzhalter 10">
+            <a:extLst>
+              <a:ext uri="{FF2B5EF4-FFF2-40B4-BE49-F238E27FC236}">
+                <a16:creationId xmlns:a16="http://schemas.microsoft.com/office/drawing/2014/main" id="{C5712523-7582-2BD8-986B-62381CBC2027}"/>
+              </a:ext>
+            </a:extLst>
+          </p:cNvPr>
+          <p:cNvSpPr>
+            <a:spLocks noGrp="1"/>
+          </p:cNvSpPr>
+          <p:nvPr>
+            <p:ph type="ftr" sz="quarter" idx="17"/>
+          </p:nvPr>
+        </p:nvSpPr>
+        <p:spPr/>
+        <p:txBody>
+          <a:bodyPr/>
+          <a:lstStyle/>
+          <a:p>
+            <a:endParaRPr lang="de-CH" dirty="0"/>
+          </a:p>
+        </p:txBody>
+      </p:sp>
+      <p:sp>
+        <p:nvSpPr>
+          <p:cNvPr id="12" name="Foliennummernplatzhalter 11">
+            <a:extLst>
+              <a:ext uri="{FF2B5EF4-FFF2-40B4-BE49-F238E27FC236}">
+                <a16:creationId xmlns:a16="http://schemas.microsoft.com/office/drawing/2014/main" id="{3B0CE1AF-0E44-EB91-7F41-52A6CB868F7F}"/>
+              </a:ext>
+            </a:extLst>
+          </p:cNvPr>
+          <p:cNvSpPr>
+            <a:spLocks noGrp="1"/>
+          </p:cNvSpPr>
+          <p:nvPr>
+            <p:ph type="sldNum" sz="quarter" idx="18"/>
+          </p:nvPr>
+        </p:nvSpPr>
+        <p:spPr/>
+        <p:txBody>
+          <a:bodyPr/>
+          <a:lstStyle/>
+          <a:p>
+            <a:fld id="{E6639024-6672-4F87-864B-EA4FA9190A1A}" type="slidenum">
+              <a:rPr lang="de-CH" smtClean="0"/>
+              <a:pPr/>
+              <a:t>48</a:t>
+            </a:fld>
+            <a:endParaRPr lang="de-CH" dirty="0"/>
+          </a:p>
+        </p:txBody>
+      </p:sp>
+    </p:spTree>
+    <p:extLst>
+      <p:ext uri="{BB962C8B-B14F-4D97-AF65-F5344CB8AC3E}">
+        <p14:creationId xmlns:p14="http://schemas.microsoft.com/office/powerpoint/2010/main" val="2128757960"/>
+      </p:ext>
+    </p:extLst>
+  </p:cSld>
+  <p:clrMapOvr>
+    <a:masterClrMapping/>
+  </p:clrMapOvr>
+</p:sld>
+</file>
+
+<file path=ppt/slides/slide49.xml><?xml version="1.0" encoding="utf-8"?>
+<p:sld xmlns:a="http://schemas.openxmlformats.org/drawingml/2006/main" xmlns:r="http://schemas.openxmlformats.org/officeDocument/2006/relationships" xmlns:p="http://schemas.openxmlformats.org/presentationml/2006/main">
+  <p:cSld>
+    <p:spTree>
+      <p:nvGrpSpPr>
+        <p:cNvPr id="1" name="">
+          <a:extLst>
+            <a:ext uri="{FF2B5EF4-FFF2-40B4-BE49-F238E27FC236}">
+              <a16:creationId xmlns:a16="http://schemas.microsoft.com/office/drawing/2014/main" id="{D4900803-E03E-4256-407B-FAE7CDFC165F}"/>
+            </a:ext>
+          </a:extLst>
+        </p:cNvPr>
+        <p:cNvGrpSpPr/>
+        <p:nvPr/>
+      </p:nvGrpSpPr>
+      <p:grpSpPr>
+        <a:xfrm>
+          <a:off x="0" y="0"/>
+          <a:ext cx="0" cy="0"/>
+          <a:chOff x="0" y="0"/>
+          <a:chExt cx="0" cy="0"/>
+        </a:xfrm>
+      </p:grpSpPr>
+      <p:sp>
+        <p:nvSpPr>
+          <p:cNvPr id="8" name="Textplatzhalter 7">
+            <a:extLst>
+              <a:ext uri="{FF2B5EF4-FFF2-40B4-BE49-F238E27FC236}">
+                <a16:creationId xmlns:a16="http://schemas.microsoft.com/office/drawing/2014/main" id="{181ABAB7-4944-26AF-8D85-744ECD9FD451}"/>
+              </a:ext>
+            </a:extLst>
+          </p:cNvPr>
+          <p:cNvSpPr>
+            <a:spLocks noGrp="1"/>
+          </p:cNvSpPr>
+          <p:nvPr>
+            <p:ph type="body" sz="quarter" idx="12"/>
+          </p:nvPr>
+        </p:nvSpPr>
+        <p:spPr/>
+        <p:txBody>
+          <a:bodyPr/>
+          <a:lstStyle/>
+          <a:p>
+            <a:endParaRPr lang="en-US"/>
+          </a:p>
+        </p:txBody>
+      </p:sp>
+      <p:sp>
+        <p:nvSpPr>
+          <p:cNvPr id="7" name="Titel 6">
+            <a:extLst>
+              <a:ext uri="{FF2B5EF4-FFF2-40B4-BE49-F238E27FC236}">
+                <a16:creationId xmlns:a16="http://schemas.microsoft.com/office/drawing/2014/main" id="{257B34DA-F6BC-04E0-7981-3F7D556C0B1F}"/>
+              </a:ext>
+            </a:extLst>
+          </p:cNvPr>
+          <p:cNvSpPr>
+            <a:spLocks noGrp="1"/>
+          </p:cNvSpPr>
+          <p:nvPr>
+            <p:ph type="title"/>
+          </p:nvPr>
+        </p:nvSpPr>
+        <p:spPr/>
+        <p:txBody>
+          <a:bodyPr/>
+          <a:lstStyle/>
+          <a:p>
+            <a:endParaRPr lang="en-US" dirty="0"/>
+          </a:p>
+        </p:txBody>
+      </p:sp>
+      <p:sp>
+        <p:nvSpPr>
+          <p:cNvPr id="10" name="Inhaltsplatzhalter 9">
+            <a:extLst>
+              <a:ext uri="{FF2B5EF4-FFF2-40B4-BE49-F238E27FC236}">
+                <a16:creationId xmlns:a16="http://schemas.microsoft.com/office/drawing/2014/main" id="{1DA1CC60-ABE8-FA5B-30CF-E47720B805DA}"/>
+              </a:ext>
+            </a:extLst>
+          </p:cNvPr>
+          <p:cNvSpPr>
+            <a:spLocks noGrp="1"/>
+          </p:cNvSpPr>
+          <p:nvPr>
+            <p:ph sz="quarter" idx="20"/>
+          </p:nvPr>
+        </p:nvSpPr>
+        <p:spPr>
+          <a:xfrm>
+            <a:off x="359533" y="1203598"/>
+            <a:ext cx="8424467" cy="3332402"/>
+          </a:xfrm>
+        </p:spPr>
+        <p:txBody>
+          <a:bodyPr anchor="t"/>
+          <a:lstStyle/>
+          <a:p>
+            <a:pPr>
+              <a:lnSpc>
+                <a:spcPct val="150000"/>
+              </a:lnSpc>
+            </a:pPr>
+            <a:endParaRPr lang="en-US" dirty="0"/>
+          </a:p>
+        </p:txBody>
+      </p:sp>
+      <p:sp>
+        <p:nvSpPr>
+          <p:cNvPr id="9" name="Textplatzhalter 8">
+            <a:extLst>
+              <a:ext uri="{FF2B5EF4-FFF2-40B4-BE49-F238E27FC236}">
+                <a16:creationId xmlns:a16="http://schemas.microsoft.com/office/drawing/2014/main" id="{3CF5D1FE-ADE6-CCE1-EE0E-EF9EF886F6F9}"/>
+              </a:ext>
+            </a:extLst>
+          </p:cNvPr>
+          <p:cNvSpPr>
+            <a:spLocks noGrp="1"/>
+          </p:cNvSpPr>
+          <p:nvPr>
+            <p:ph type="body" sz="quarter" idx="19"/>
+          </p:nvPr>
+        </p:nvSpPr>
+        <p:spPr/>
+        <p:txBody>
+          <a:bodyPr/>
+          <a:lstStyle/>
+          <a:p>
+            <a:endParaRPr lang="en-US" dirty="0"/>
+          </a:p>
+        </p:txBody>
+      </p:sp>
+      <p:sp>
+        <p:nvSpPr>
+          <p:cNvPr id="11" name="Fußzeilenplatzhalter 10">
+            <a:extLst>
+              <a:ext uri="{FF2B5EF4-FFF2-40B4-BE49-F238E27FC236}">
+                <a16:creationId xmlns:a16="http://schemas.microsoft.com/office/drawing/2014/main" id="{BD3BC772-1808-72C0-840C-4671D66F866E}"/>
+              </a:ext>
+            </a:extLst>
+          </p:cNvPr>
+          <p:cNvSpPr>
+            <a:spLocks noGrp="1"/>
+          </p:cNvSpPr>
+          <p:nvPr>
+            <p:ph type="ftr" sz="quarter" idx="17"/>
+          </p:nvPr>
+        </p:nvSpPr>
+        <p:spPr/>
+        <p:txBody>
+          <a:bodyPr/>
+          <a:lstStyle/>
+          <a:p>
+            <a:endParaRPr lang="de-CH" dirty="0"/>
+          </a:p>
+        </p:txBody>
+      </p:sp>
+      <p:sp>
+        <p:nvSpPr>
+          <p:cNvPr id="12" name="Foliennummernplatzhalter 11">
+            <a:extLst>
+              <a:ext uri="{FF2B5EF4-FFF2-40B4-BE49-F238E27FC236}">
+                <a16:creationId xmlns:a16="http://schemas.microsoft.com/office/drawing/2014/main" id="{EAB3C26B-0B46-9A09-B6C8-9B7226ECB059}"/>
+              </a:ext>
+            </a:extLst>
+          </p:cNvPr>
+          <p:cNvSpPr>
+            <a:spLocks noGrp="1"/>
+          </p:cNvSpPr>
+          <p:nvPr>
+            <p:ph type="sldNum" sz="quarter" idx="18"/>
+          </p:nvPr>
+        </p:nvSpPr>
+        <p:spPr/>
+        <p:txBody>
+          <a:bodyPr/>
+          <a:lstStyle/>
+          <a:p>
+            <a:fld id="{E6639024-6672-4F87-864B-EA4FA9190A1A}" type="slidenum">
+              <a:rPr lang="de-CH" smtClean="0"/>
+              <a:pPr/>
+              <a:t>49</a:t>
+            </a:fld>
+            <a:endParaRPr lang="de-CH" dirty="0"/>
+          </a:p>
+        </p:txBody>
+      </p:sp>
+    </p:spTree>
+    <p:extLst>
+      <p:ext uri="{BB962C8B-B14F-4D97-AF65-F5344CB8AC3E}">
+        <p14:creationId xmlns:p14="http://schemas.microsoft.com/office/powerpoint/2010/main" val="2327944303"/>
       </p:ext>
     </p:extLst>
   </p:cSld>

</xml_diff>

<commit_message>
Fixed typos in the BA thesis presentation, did slight adjustments to the bullet points in introduction and design section
</commit_message>
<xml_diff>
--- a/dev_documents/presentation/ba_thesis_presentation_kronig.pptx
+++ b/dev_documents/presentation/ba_thesis_presentation_kronig.pptx
@@ -249,7 +249,7 @@
           <a:p>
             <a:fld id="{442B13D9-EE20-4263-A517-453A6CC03581}" type="datetimeFigureOut">
               <a:rPr lang="en-US" smtClean="0"/>
-              <a:t>2/2/2026</a:t>
+              <a:t>2/3/2026</a:t>
             </a:fld>
             <a:endParaRPr lang="en-US"/>
           </a:p>
@@ -414,7 +414,7 @@
           <a:p>
             <a:fld id="{C4B9E2E8-0589-406D-8FD1-7B0DBC84FBDE}" type="datetimeFigureOut">
               <a:rPr lang="de-CH" smtClean="0"/>
-              <a:t>02.02.2026</a:t>
+              <a:t>03.02.2026</a:t>
             </a:fld>
             <a:endParaRPr lang="de-CH"/>
           </a:p>
@@ -36868,6 +36868,18 @@
               </a:lnSpc>
             </a:pPr>
             <a:r>
+              <a:rPr lang="en-US" dirty="0"/>
+              <a:t>Isolated app development &amp; testing</a:t>
+            </a:r>
+            <a:endParaRPr lang="en-US" noProof="0" dirty="0"/>
+          </a:p>
+          <a:p>
+            <a:pPr>
+              <a:lnSpc>
+                <a:spcPct val="150000"/>
+              </a:lnSpc>
+            </a:pPr>
+            <a:r>
               <a:rPr lang="en-US" noProof="0" dirty="0"/>
               <a:t>Limit boilerplate code</a:t>
             </a:r>
@@ -37734,7 +37746,7 @@
             </a:pPr>
             <a:r>
               <a:rPr lang="en-US" noProof="0" dirty="0"/>
-              <a:t>Isolated app development &amp; testing</a:t>
+              <a:t>Isolated vulnerability development</a:t>
             </a:r>
           </a:p>
           <a:p>
@@ -40745,36 +40757,6 @@
                 <a:spcPct val="150000"/>
               </a:lnSpc>
             </a:pPr>
-            <a:r>
-              <a:rPr lang="en-US" noProof="0" dirty="0"/>
-              <a:t>25% MASWE coverage</a:t>
-            </a:r>
-          </a:p>
-          <a:p>
-            <a:pPr>
-              <a:lnSpc>
-                <a:spcPct val="150000"/>
-              </a:lnSpc>
-            </a:pPr>
-            <a:r>
-              <a:rPr lang="en-US" noProof="0" dirty="0"/>
-              <a:t>18 (65%) vulnerability types without previous coverage</a:t>
-            </a:r>
-          </a:p>
-          <a:p>
-            <a:pPr>
-              <a:lnSpc>
-                <a:spcPct val="150000"/>
-              </a:lnSpc>
-            </a:pPr>
-            <a:endParaRPr lang="en-US" noProof="0" dirty="0"/>
-          </a:p>
-          <a:p>
-            <a:pPr>
-              <a:lnSpc>
-                <a:spcPct val="150000"/>
-              </a:lnSpc>
-            </a:pPr>
             <a:endParaRPr lang="en-US" noProof="0" dirty="0"/>
           </a:p>
         </p:txBody>
@@ -44115,6 +44097,18 @@
           <a:bodyPr anchor="t"/>
           <a:lstStyle/>
           <a:p>
+            <a:pPr marL="0" indent="0">
+              <a:lnSpc>
+                <a:spcPct val="150000"/>
+              </a:lnSpc>
+              <a:buNone/>
+            </a:pPr>
+            <a:r>
+              <a:rPr lang="en-US" noProof="0" dirty="0"/>
+              <a:t>What to do?</a:t>
+            </a:r>
+          </a:p>
+          <a:p>
             <a:pPr>
               <a:lnSpc>
                 <a:spcPct val="150000"/>
@@ -44122,7 +44116,19 @@
             </a:pPr>
             <a:r>
               <a:rPr lang="en-US" noProof="0" dirty="0"/>
-              <a:t>Make mobile security knowledge more accessible</a:t>
+              <a:t>Avoid implementing vulnerabilities</a:t>
+            </a:r>
+          </a:p>
+          <a:p>
+            <a:pPr marL="0" indent="0">
+              <a:lnSpc>
+                <a:spcPct val="150000"/>
+              </a:lnSpc>
+              <a:buNone/>
+            </a:pPr>
+            <a:r>
+              <a:rPr lang="en-US" noProof="0" dirty="0"/>
+              <a:t>-&gt; Make mobile security knowledge more accessible</a:t>
             </a:r>
           </a:p>
           <a:p>
@@ -44133,8 +44139,36 @@
             </a:pPr>
             <a:r>
               <a:rPr lang="en-US" noProof="0" dirty="0"/>
-              <a:t>Improve and promote the best security testing tools</a:t>
-            </a:r>
+              <a:t>Find existing vulnerabilities</a:t>
+            </a:r>
+          </a:p>
+          <a:p>
+            <a:pPr marL="0" indent="0">
+              <a:lnSpc>
+                <a:spcPct val="150000"/>
+              </a:lnSpc>
+              <a:buNone/>
+            </a:pPr>
+            <a:r>
+              <a:rPr lang="en-US" dirty="0"/>
+              <a:t>-&gt; Improve and promote the best security testing tools</a:t>
+            </a:r>
+          </a:p>
+          <a:p>
+            <a:pPr>
+              <a:lnSpc>
+                <a:spcPct val="150000"/>
+              </a:lnSpc>
+            </a:pPr>
+            <a:endParaRPr lang="en-US" noProof="0" dirty="0"/>
+          </a:p>
+          <a:p>
+            <a:pPr>
+              <a:lnSpc>
+                <a:spcPct val="150000"/>
+              </a:lnSpc>
+            </a:pPr>
+            <a:endParaRPr lang="en-US" noProof="0" dirty="0"/>
           </a:p>
           <a:p>
             <a:pPr>

</xml_diff>

<commit_message>
Reworked the beginning of my presentation, made improved the flow of narrative by re-ordering my slides, fixed typos.
</commit_message>
<xml_diff>
--- a/dev_documents/presentation/ba_thesis_presentation_kronig.pptx
+++ b/dev_documents/presentation/ba_thesis_presentation_kronig.pptx
@@ -7,10 +7,10 @@
     <p:sldMasterId id="2147483793" r:id="rId3"/>
   </p:sldMasterIdLst>
   <p:notesMasterIdLst>
-    <p:notesMasterId r:id="rId53"/>
+    <p:notesMasterId r:id="rId52"/>
   </p:notesMasterIdLst>
   <p:handoutMasterIdLst>
-    <p:handoutMasterId r:id="rId54"/>
+    <p:handoutMasterId r:id="rId53"/>
   </p:handoutMasterIdLst>
   <p:sldIdLst>
     <p:sldId id="256" r:id="rId4"/>
@@ -19,9 +19,9 @@
     <p:sldId id="319" r:id="rId7"/>
     <p:sldId id="320" r:id="rId8"/>
     <p:sldId id="312" r:id="rId9"/>
-    <p:sldId id="313" r:id="rId10"/>
-    <p:sldId id="324" r:id="rId11"/>
-    <p:sldId id="314" r:id="rId12"/>
+    <p:sldId id="325" r:id="rId10"/>
+    <p:sldId id="313" r:id="rId11"/>
+    <p:sldId id="324" r:id="rId12"/>
     <p:sldId id="315" r:id="rId13"/>
     <p:sldId id="316" r:id="rId14"/>
     <p:sldId id="317" r:id="rId15"/>
@@ -53,15 +53,14 @@
     <p:sldId id="282" r:id="rId41"/>
     <p:sldId id="301" r:id="rId42"/>
     <p:sldId id="302" r:id="rId43"/>
-    <p:sldId id="303" r:id="rId44"/>
-    <p:sldId id="283" r:id="rId45"/>
-    <p:sldId id="304" r:id="rId46"/>
-    <p:sldId id="305" r:id="rId47"/>
-    <p:sldId id="284" r:id="rId48"/>
-    <p:sldId id="285" r:id="rId49"/>
-    <p:sldId id="308" r:id="rId50"/>
-    <p:sldId id="307" r:id="rId51"/>
-    <p:sldId id="306" r:id="rId52"/>
+    <p:sldId id="283" r:id="rId44"/>
+    <p:sldId id="304" r:id="rId45"/>
+    <p:sldId id="305" r:id="rId46"/>
+    <p:sldId id="284" r:id="rId47"/>
+    <p:sldId id="285" r:id="rId48"/>
+    <p:sldId id="308" r:id="rId49"/>
+    <p:sldId id="307" r:id="rId50"/>
+    <p:sldId id="306" r:id="rId51"/>
   </p:sldIdLst>
   <p:sldSz cx="9144000" cy="5143500" type="screen16x9"/>
   <p:notesSz cx="6858000" cy="9144000"/>
@@ -31576,7 +31575,7 @@
             </a:pPr>
             <a:r>
               <a:rPr lang="en-US" i="1" noProof="0" dirty="0"/>
-              <a:t>Problem: Lack of coverage</a:t>
+              <a:t>Challenge: Lack of coverage</a:t>
             </a:r>
           </a:p>
           <a:p>
@@ -31773,6 +31772,18 @@
               </a:lnSpc>
             </a:pPr>
             <a:r>
+              <a:rPr lang="en-US" dirty="0"/>
+              <a:t>Promote best security testing tools</a:t>
+            </a:r>
+            <a:endParaRPr lang="en-US" noProof="0" dirty="0"/>
+          </a:p>
+          <a:p>
+            <a:pPr>
+              <a:lnSpc>
+                <a:spcPct val="150000"/>
+              </a:lnSpc>
+            </a:pPr>
+            <a:r>
               <a:rPr lang="en-US" noProof="0" dirty="0"/>
               <a:t>Tools for vulnerability detection</a:t>
             </a:r>
@@ -31856,18 +31867,6 @@
               </a:lnSpc>
             </a:pPr>
             <a:r>
-              <a:rPr lang="en-US" dirty="0"/>
-              <a:t>Improve and promote the best security testing tools</a:t>
-            </a:r>
-            <a:endParaRPr lang="en-US" noProof="0" dirty="0"/>
-          </a:p>
-          <a:p>
-            <a:pPr>
-              <a:lnSpc>
-                <a:spcPct val="150000"/>
-              </a:lnSpc>
-            </a:pPr>
-            <a:r>
               <a:rPr lang="en-US" noProof="0" dirty="0"/>
               <a:t>Abundance of such tools</a:t>
             </a:r>
@@ -31880,7 +31879,7 @@
             </a:pPr>
             <a:r>
               <a:rPr lang="en-US" i="1" noProof="0" dirty="0"/>
-              <a:t>Problem: How to know which ones are good?</a:t>
+              <a:t>Challenge: How to know which ones are good?</a:t>
             </a:r>
           </a:p>
           <a:p>
@@ -32133,7 +32132,7 @@
             </a:pPr>
             <a:r>
               <a:rPr lang="en-US" noProof="0" dirty="0"/>
-              <a:t>…solve both problems!</a:t>
+              <a:t>…solve both challenges!</a:t>
             </a:r>
           </a:p>
           <a:p>
@@ -34158,19 +34157,8 @@
               </a:lnSpc>
             </a:pPr>
             <a:r>
-              <a:rPr lang="en-US" noProof="0" dirty="0"/>
+              <a:rPr lang="en-US" i="1" noProof="0" dirty="0"/>
               <a:t>What makes a good reference app?</a:t>
-            </a:r>
-          </a:p>
-          <a:p>
-            <a:pPr>
-              <a:lnSpc>
-                <a:spcPct val="150000"/>
-              </a:lnSpc>
-            </a:pPr>
-            <a:r>
-              <a:rPr lang="en-US" noProof="0" dirty="0"/>
-              <a:t>Analyze existing MASTG apps</a:t>
             </a:r>
           </a:p>
         </p:txBody>
@@ -34478,6 +34466,12 @@
         <p:txBody>
           <a:bodyPr/>
           <a:lstStyle/>
+          <a:p>
+            <a:r>
+              <a:rPr lang="en-US" dirty="0"/>
+              <a:t>“Today I will be discussing Android vulnerabilities with you”</a:t>
+            </a:r>
+          </a:p>
           <a:p>
             <a:endParaRPr lang="en-US" noProof="0" dirty="0"/>
           </a:p>
@@ -36761,6 +36755,18 @@
               </a:lnSpc>
             </a:pPr>
             <a:r>
+              <a:rPr lang="en-US" dirty="0"/>
+              <a:t>Vulnerabilities with no coverage</a:t>
+            </a:r>
+            <a:endParaRPr lang="en-US" noProof="0" dirty="0"/>
+          </a:p>
+          <a:p>
+            <a:pPr>
+              <a:lnSpc>
+                <a:spcPct val="150000"/>
+              </a:lnSpc>
+            </a:pPr>
+            <a:r>
               <a:rPr lang="en-US" noProof="0" dirty="0"/>
               <a:t>Focus on MASVS-CRYPTO</a:t>
             </a:r>
@@ -37444,39 +37450,42 @@
             <a:endParaRPr lang="en-US" i="1" noProof="0" dirty="0"/>
           </a:p>
           <a:p>
-            <a:pPr marL="0" indent="0">
+            <a:pPr>
               <a:lnSpc>
                 <a:spcPct val="150000"/>
               </a:lnSpc>
-              <a:buNone/>
+              <a:buFont typeface="Wingdings" panose="05000000000000000000" pitchFamily="2" charset="2"/>
+              <a:buChar char="§"/>
             </a:pPr>
             <a:r>
               <a:rPr lang="en-US" sz="2400" dirty="0"/>
-              <a:t>&lt; 5?</a:t>
-            </a:r>
-          </a:p>
-          <a:p>
-            <a:pPr marL="0" indent="0">
+              <a:t> Around 5?</a:t>
+            </a:r>
+          </a:p>
+          <a:p>
+            <a:pPr>
               <a:lnSpc>
                 <a:spcPct val="150000"/>
               </a:lnSpc>
-              <a:buNone/>
+              <a:buFont typeface="Wingdings" panose="05000000000000000000" pitchFamily="2" charset="2"/>
+              <a:buChar char="§"/>
             </a:pPr>
             <a:r>
               <a:rPr lang="en-US" sz="2400" dirty="0"/>
-              <a:t>&lt; 10?</a:t>
-            </a:r>
-          </a:p>
-          <a:p>
-            <a:pPr marL="0" indent="0">
+              <a:t>Around 15?</a:t>
+            </a:r>
+          </a:p>
+          <a:p>
+            <a:pPr>
               <a:lnSpc>
                 <a:spcPct val="150000"/>
               </a:lnSpc>
-              <a:buNone/>
+              <a:buFont typeface="Wingdings" panose="05000000000000000000" pitchFamily="2" charset="2"/>
+              <a:buChar char="§"/>
             </a:pPr>
             <a:r>
               <a:rPr lang="en-US" sz="2400" dirty="0"/>
-              <a:t>&lt; 40?</a:t>
+              <a:t>More than 30?</a:t>
             </a:r>
           </a:p>
           <a:p>
@@ -41597,7 +41606,7 @@
             </a:pPr>
             <a:r>
               <a:rPr lang="en-US" noProof="0" dirty="0"/>
-              <a:t>MASWE coverage from 35.9% to  51.3%</a:t>
+              <a:t>MASWE coverage from 35.9% to 51.3%</a:t>
             </a:r>
           </a:p>
           <a:p>
@@ -42495,269 +42504,6 @@
         <p:cNvPr id="1" name="">
           <a:extLst>
             <a:ext uri="{FF2B5EF4-FFF2-40B4-BE49-F238E27FC236}">
-              <a16:creationId xmlns:a16="http://schemas.microsoft.com/office/drawing/2014/main" id="{C997DD8C-9CAF-69F1-7B45-F8956BE05E26}"/>
-            </a:ext>
-          </a:extLst>
-        </p:cNvPr>
-        <p:cNvGrpSpPr/>
-        <p:nvPr/>
-      </p:nvGrpSpPr>
-      <p:grpSpPr>
-        <a:xfrm>
-          <a:off x="0" y="0"/>
-          <a:ext cx="0" cy="0"/>
-          <a:chOff x="0" y="0"/>
-          <a:chExt cx="0" cy="0"/>
-        </a:xfrm>
-      </p:grpSpPr>
-      <p:sp>
-        <p:nvSpPr>
-          <p:cNvPr id="8" name="Textplatzhalter 7">
-            <a:extLst>
-              <a:ext uri="{FF2B5EF4-FFF2-40B4-BE49-F238E27FC236}">
-                <a16:creationId xmlns:a16="http://schemas.microsoft.com/office/drawing/2014/main" id="{7272B720-D64A-5D75-9232-ED24B2057CAF}"/>
-              </a:ext>
-            </a:extLst>
-          </p:cNvPr>
-          <p:cNvSpPr>
-            <a:spLocks noGrp="1"/>
-          </p:cNvSpPr>
-          <p:nvPr>
-            <p:ph type="body" sz="quarter" idx="12"/>
-          </p:nvPr>
-        </p:nvSpPr>
-        <p:spPr/>
-        <p:txBody>
-          <a:bodyPr/>
-          <a:lstStyle/>
-          <a:p>
-            <a:r>
-              <a:rPr lang="en-US" dirty="0"/>
-              <a:t>Comparison with other MASTG Apps</a:t>
-            </a:r>
-            <a:endParaRPr lang="en-US" noProof="0" dirty="0"/>
-          </a:p>
-        </p:txBody>
-      </p:sp>
-      <p:sp>
-        <p:nvSpPr>
-          <p:cNvPr id="7" name="Titel 6">
-            <a:extLst>
-              <a:ext uri="{FF2B5EF4-FFF2-40B4-BE49-F238E27FC236}">
-                <a16:creationId xmlns:a16="http://schemas.microsoft.com/office/drawing/2014/main" id="{E7431756-EA25-1013-E49C-74AB56448023}"/>
-              </a:ext>
-            </a:extLst>
-          </p:cNvPr>
-          <p:cNvSpPr>
-            <a:spLocks noGrp="1"/>
-          </p:cNvSpPr>
-          <p:nvPr>
-            <p:ph type="title"/>
-          </p:nvPr>
-        </p:nvSpPr>
-        <p:spPr/>
-        <p:txBody>
-          <a:bodyPr/>
-          <a:lstStyle/>
-          <a:p>
-            <a:r>
-              <a:rPr lang="en-US" dirty="0"/>
-              <a:t>Results</a:t>
-            </a:r>
-          </a:p>
-        </p:txBody>
-      </p:sp>
-      <p:sp>
-        <p:nvSpPr>
-          <p:cNvPr id="10" name="Inhaltsplatzhalter 9">
-            <a:extLst>
-              <a:ext uri="{FF2B5EF4-FFF2-40B4-BE49-F238E27FC236}">
-                <a16:creationId xmlns:a16="http://schemas.microsoft.com/office/drawing/2014/main" id="{1BAB215B-66B3-1C59-E098-BDDFE1282847}"/>
-              </a:ext>
-            </a:extLst>
-          </p:cNvPr>
-          <p:cNvSpPr>
-            <a:spLocks noGrp="1"/>
-          </p:cNvSpPr>
-          <p:nvPr>
-            <p:ph sz="quarter" idx="20"/>
-          </p:nvPr>
-        </p:nvSpPr>
-        <p:spPr>
-          <a:xfrm>
-            <a:off x="359533" y="1203598"/>
-            <a:ext cx="8424467" cy="3332402"/>
-          </a:xfrm>
-        </p:spPr>
-        <p:txBody>
-          <a:bodyPr anchor="t"/>
-          <a:lstStyle/>
-          <a:p>
-            <a:pPr>
-              <a:lnSpc>
-                <a:spcPct val="150000"/>
-              </a:lnSpc>
-            </a:pPr>
-            <a:r>
-              <a:rPr lang="en-US" noProof="0" dirty="0"/>
-              <a:t>High number of “new” vulnerabilities</a:t>
-            </a:r>
-          </a:p>
-          <a:p>
-            <a:pPr>
-              <a:lnSpc>
-                <a:spcPct val="150000"/>
-              </a:lnSpc>
-            </a:pPr>
-            <a:endParaRPr lang="en-US" noProof="0" dirty="0"/>
-          </a:p>
-          <a:p>
-            <a:pPr>
-              <a:lnSpc>
-                <a:spcPct val="150000"/>
-              </a:lnSpc>
-            </a:pPr>
-            <a:endParaRPr lang="en-US" noProof="0" dirty="0"/>
-          </a:p>
-        </p:txBody>
-      </p:sp>
-      <p:sp>
-        <p:nvSpPr>
-          <p:cNvPr id="9" name="Textplatzhalter 8">
-            <a:extLst>
-              <a:ext uri="{FF2B5EF4-FFF2-40B4-BE49-F238E27FC236}">
-                <a16:creationId xmlns:a16="http://schemas.microsoft.com/office/drawing/2014/main" id="{E58B64BF-36FB-15C9-4654-0DEF4067F782}"/>
-              </a:ext>
-            </a:extLst>
-          </p:cNvPr>
-          <p:cNvSpPr>
-            <a:spLocks noGrp="1"/>
-          </p:cNvSpPr>
-          <p:nvPr>
-            <p:ph type="body" sz="quarter" idx="19"/>
-          </p:nvPr>
-        </p:nvSpPr>
-        <p:spPr/>
-        <p:txBody>
-          <a:bodyPr/>
-          <a:lstStyle/>
-          <a:p>
-            <a:endParaRPr lang="en-US" noProof="0" dirty="0"/>
-          </a:p>
-        </p:txBody>
-      </p:sp>
-      <p:sp>
-        <p:nvSpPr>
-          <p:cNvPr id="11" name="Fußzeilenplatzhalter 10">
-            <a:extLst>
-              <a:ext uri="{FF2B5EF4-FFF2-40B4-BE49-F238E27FC236}">
-                <a16:creationId xmlns:a16="http://schemas.microsoft.com/office/drawing/2014/main" id="{45E6AA50-490C-552A-BD0E-C9708CE00953}"/>
-              </a:ext>
-            </a:extLst>
-          </p:cNvPr>
-          <p:cNvSpPr>
-            <a:spLocks noGrp="1"/>
-          </p:cNvSpPr>
-          <p:nvPr>
-            <p:ph type="ftr" sz="quarter" idx="17"/>
-          </p:nvPr>
-        </p:nvSpPr>
-        <p:spPr/>
-        <p:txBody>
-          <a:bodyPr/>
-          <a:lstStyle/>
-          <a:p>
-            <a:endParaRPr lang="en-US" noProof="0" dirty="0"/>
-          </a:p>
-        </p:txBody>
-      </p:sp>
-      <p:sp>
-        <p:nvSpPr>
-          <p:cNvPr id="12" name="Foliennummernplatzhalter 11">
-            <a:extLst>
-              <a:ext uri="{FF2B5EF4-FFF2-40B4-BE49-F238E27FC236}">
-                <a16:creationId xmlns:a16="http://schemas.microsoft.com/office/drawing/2014/main" id="{E4215688-A6A5-AE86-028E-36D00E8019F5}"/>
-              </a:ext>
-            </a:extLst>
-          </p:cNvPr>
-          <p:cNvSpPr>
-            <a:spLocks noGrp="1"/>
-          </p:cNvSpPr>
-          <p:nvPr>
-            <p:ph type="sldNum" sz="quarter" idx="18"/>
-          </p:nvPr>
-        </p:nvSpPr>
-        <p:spPr/>
-        <p:txBody>
-          <a:bodyPr/>
-          <a:lstStyle/>
-          <a:p>
-            <a:fld id="{E6639024-6672-4F87-864B-EA4FA9190A1A}" type="slidenum">
-              <a:rPr lang="en-US" noProof="0" smtClean="0"/>
-              <a:pPr/>
-              <a:t>41</a:t>
-            </a:fld>
-            <a:endParaRPr lang="en-US" noProof="0" dirty="0"/>
-          </a:p>
-        </p:txBody>
-      </p:sp>
-      <p:pic>
-        <p:nvPicPr>
-          <p:cNvPr id="5" name="Grafik 4" descr="Ein Bild, das Text, Screenshot, Diagramm, Reihe enthält.&#10;&#10;KI-generierte Inhalte können fehlerhaft sein.">
-            <a:extLst>
-              <a:ext uri="{FF2B5EF4-FFF2-40B4-BE49-F238E27FC236}">
-                <a16:creationId xmlns:a16="http://schemas.microsoft.com/office/drawing/2014/main" id="{89A740C7-F1EF-2DF0-33BD-7C533568F64D}"/>
-              </a:ext>
-            </a:extLst>
-          </p:cNvPr>
-          <p:cNvPicPr>
-            <a:picLocks noChangeAspect="1"/>
-          </p:cNvPicPr>
-          <p:nvPr/>
-        </p:nvPicPr>
-        <p:blipFill>
-          <a:blip r:embed="rId2">
-            <a:extLst>
-              <a:ext uri="{28A0092B-C50C-407E-A947-70E740481C1C}">
-                <a14:useLocalDpi xmlns:a14="http://schemas.microsoft.com/office/drawing/2010/main" val="0"/>
-              </a:ext>
-            </a:extLst>
-          </a:blip>
-          <a:stretch>
-            <a:fillRect/>
-          </a:stretch>
-        </p:blipFill>
-        <p:spPr>
-          <a:xfrm>
-            <a:off x="3059832" y="1752776"/>
-            <a:ext cx="5723633" cy="2759981"/>
-          </a:xfrm>
-          <a:prstGeom prst="rect">
-            <a:avLst/>
-          </a:prstGeom>
-        </p:spPr>
-      </p:pic>
-    </p:spTree>
-    <p:extLst>
-      <p:ext uri="{BB962C8B-B14F-4D97-AF65-F5344CB8AC3E}">
-        <p14:creationId xmlns:p14="http://schemas.microsoft.com/office/powerpoint/2010/main" val="1197027845"/>
-      </p:ext>
-    </p:extLst>
-  </p:cSld>
-  <p:clrMapOvr>
-    <a:masterClrMapping/>
-  </p:clrMapOvr>
-</p:sld>
-</file>
-
-<file path=ppt/slides/slide42.xml><?xml version="1.0" encoding="utf-8"?>
-<p:sld xmlns:a="http://schemas.openxmlformats.org/drawingml/2006/main" xmlns:r="http://schemas.openxmlformats.org/officeDocument/2006/relationships" xmlns:p="http://schemas.openxmlformats.org/presentationml/2006/main">
-  <p:cSld>
-    <p:spTree>
-      <p:nvGrpSpPr>
-        <p:cNvPr id="1" name="">
-          <a:extLst>
-            <a:ext uri="{FF2B5EF4-FFF2-40B4-BE49-F238E27FC236}">
               <a16:creationId xmlns:a16="http://schemas.microsoft.com/office/drawing/2014/main" id="{8E436EE9-C990-5FE7-041E-4F5B09E7CD6C}"/>
             </a:ext>
           </a:extLst>
@@ -42975,7 +42721,7 @@
             <a:fld id="{E6639024-6672-4F87-864B-EA4FA9190A1A}" type="slidenum">
               <a:rPr lang="en-US" noProof="0" smtClean="0"/>
               <a:pPr/>
-              <a:t>42</a:t>
+              <a:t>41</a:t>
             </a:fld>
             <a:endParaRPr lang="en-US" noProof="0" dirty="0"/>
           </a:p>
@@ -42994,7 +42740,7 @@
 </p:sld>
 </file>
 
-<file path=ppt/slides/slide43.xml><?xml version="1.0" encoding="utf-8"?>
+<file path=ppt/slides/slide42.xml><?xml version="1.0" encoding="utf-8"?>
 <p:sld xmlns:a="http://schemas.openxmlformats.org/drawingml/2006/main" xmlns:r="http://schemas.openxmlformats.org/officeDocument/2006/relationships" xmlns:p="http://schemas.openxmlformats.org/presentationml/2006/main">
   <p:cSld>
     <p:spTree>
@@ -43207,7 +42953,7 @@
             <a:fld id="{E6639024-6672-4F87-864B-EA4FA9190A1A}" type="slidenum">
               <a:rPr lang="en-US" noProof="0" smtClean="0"/>
               <a:pPr/>
-              <a:t>43</a:t>
+              <a:t>42</a:t>
             </a:fld>
             <a:endParaRPr lang="en-US" noProof="0" dirty="0"/>
           </a:p>
@@ -43226,7 +42972,7 @@
 </p:sld>
 </file>
 
-<file path=ppt/slides/slide44.xml><?xml version="1.0" encoding="utf-8"?>
+<file path=ppt/slides/slide43.xml><?xml version="1.0" encoding="utf-8"?>
 <p:sld xmlns:a="http://schemas.openxmlformats.org/drawingml/2006/main" xmlns:r="http://schemas.openxmlformats.org/officeDocument/2006/relationships" xmlns:p="http://schemas.openxmlformats.org/presentationml/2006/main">
   <p:cSld>
     <p:spTree>
@@ -43439,7 +43185,7 @@
             <a:fld id="{E6639024-6672-4F87-864B-EA4FA9190A1A}" type="slidenum">
               <a:rPr lang="en-US" noProof="0" smtClean="0"/>
               <a:pPr/>
-              <a:t>44</a:t>
+              <a:t>43</a:t>
             </a:fld>
             <a:endParaRPr lang="en-US" noProof="0" dirty="0"/>
           </a:p>
@@ -43458,7 +43204,7 @@
 </p:sld>
 </file>
 
-<file path=ppt/slides/slide45.xml><?xml version="1.0" encoding="utf-8"?>
+<file path=ppt/slides/slide44.xml><?xml version="1.0" encoding="utf-8"?>
 <p:sld xmlns:a="http://schemas.openxmlformats.org/drawingml/2006/main" xmlns:r="http://schemas.openxmlformats.org/officeDocument/2006/relationships" xmlns:p="http://schemas.openxmlformats.org/presentationml/2006/main">
   <p:cSld>
     <p:spTree>
@@ -43671,7 +43417,7 @@
             <a:fld id="{E6639024-6672-4F87-864B-EA4FA9190A1A}" type="slidenum">
               <a:rPr lang="en-US" noProof="0" smtClean="0"/>
               <a:pPr/>
-              <a:t>45</a:t>
+              <a:t>44</a:t>
             </a:fld>
             <a:endParaRPr lang="en-US" noProof="0" dirty="0"/>
           </a:p>
@@ -43690,7 +43436,7 @@
 </p:sld>
 </file>
 
-<file path=ppt/slides/slide46.xml><?xml version="1.0" encoding="utf-8"?>
+<file path=ppt/slides/slide45.xml><?xml version="1.0" encoding="utf-8"?>
 <p:sld xmlns:a="http://schemas.openxmlformats.org/drawingml/2006/main" xmlns:r="http://schemas.openxmlformats.org/officeDocument/2006/relationships" xmlns:p="http://schemas.openxmlformats.org/presentationml/2006/main">
   <p:cSld>
     <p:spTree>
@@ -43823,6 +43569,18 @@
               </a:lnSpc>
             </a:pPr>
             <a:r>
+              <a:rPr lang="en-US" dirty="0"/>
+              <a:t>Increased coverage of MASVS categories</a:t>
+            </a:r>
+            <a:endParaRPr lang="en-US" noProof="0" dirty="0"/>
+          </a:p>
+          <a:p>
+            <a:pPr>
+              <a:lnSpc>
+                <a:spcPct val="150000"/>
+              </a:lnSpc>
+            </a:pPr>
+            <a:r>
               <a:rPr lang="en-US" noProof="0" dirty="0"/>
               <a:t>Built basis of MASTG tool testing benchmark</a:t>
             </a:r>
@@ -43911,7 +43669,7 @@
             <a:fld id="{E6639024-6672-4F87-864B-EA4FA9190A1A}" type="slidenum">
               <a:rPr lang="en-US" noProof="0" smtClean="0"/>
               <a:pPr/>
-              <a:t>46</a:t>
+              <a:t>45</a:t>
             </a:fld>
             <a:endParaRPr lang="en-US" noProof="0" dirty="0"/>
           </a:p>
@@ -43930,7 +43688,7 @@
 </p:sld>
 </file>
 
-<file path=ppt/slides/slide47.xml><?xml version="1.0" encoding="utf-8"?>
+<file path=ppt/slides/slide46.xml><?xml version="1.0" encoding="utf-8"?>
 <p:sld xmlns:a="http://schemas.openxmlformats.org/drawingml/2006/main" xmlns:r="http://schemas.openxmlformats.org/officeDocument/2006/relationships" xmlns:p="http://schemas.openxmlformats.org/presentationml/2006/main">
   <p:cSld>
     <p:spTree>
@@ -44115,7 +43873,7 @@
             <a:fld id="{E6639024-6672-4F87-864B-EA4FA9190A1A}" type="slidenum">
               <a:rPr lang="en-US" noProof="0" smtClean="0"/>
               <a:pPr/>
-              <a:t>47</a:t>
+              <a:t>46</a:t>
             </a:fld>
             <a:endParaRPr lang="en-US" noProof="0" dirty="0"/>
           </a:p>
@@ -44134,7 +43892,7 @@
 </p:sld>
 </file>
 
-<file path=ppt/slides/slide48.xml><?xml version="1.0" encoding="utf-8"?>
+<file path=ppt/slides/slide47.xml><?xml version="1.0" encoding="utf-8"?>
 <p:sld xmlns:a="http://schemas.openxmlformats.org/drawingml/2006/main" xmlns:r="http://schemas.openxmlformats.org/officeDocument/2006/relationships" xmlns:p="http://schemas.openxmlformats.org/presentationml/2006/main">
   <p:cSld>
     <p:spTree>
@@ -44365,7 +44123,7 @@
             <a:fld id="{E6639024-6672-4F87-864B-EA4FA9190A1A}" type="slidenum">
               <a:rPr lang="en-US" noProof="0" smtClean="0"/>
               <a:pPr/>
-              <a:t>48</a:t>
+              <a:t>47</a:t>
             </a:fld>
             <a:endParaRPr lang="en-US" noProof="0" dirty="0"/>
           </a:p>
@@ -44384,7 +44142,7 @@
 </p:sld>
 </file>
 
-<file path=ppt/slides/slide49.xml><?xml version="1.0" encoding="utf-8"?>
+<file path=ppt/slides/slide48.xml><?xml version="1.0" encoding="utf-8"?>
 <p:sld xmlns:a="http://schemas.openxmlformats.org/drawingml/2006/main" xmlns:r="http://schemas.openxmlformats.org/officeDocument/2006/relationships" xmlns:p="http://schemas.openxmlformats.org/presentationml/2006/main">
   <p:cSld>
     <p:spTree>
@@ -44566,7 +44324,7 @@
             <a:fld id="{E6639024-6672-4F87-864B-EA4FA9190A1A}" type="slidenum">
               <a:rPr lang="en-US" noProof="0" smtClean="0"/>
               <a:pPr/>
-              <a:t>49</a:t>
+              <a:t>48</a:t>
             </a:fld>
             <a:endParaRPr lang="en-US" noProof="0" dirty="0"/>
           </a:p>
@@ -45722,6 +45480,409 @@
         <p:cNvPr id="1" name="">
           <a:extLst>
             <a:ext uri="{FF2B5EF4-FFF2-40B4-BE49-F238E27FC236}">
+              <a16:creationId xmlns:a16="http://schemas.microsoft.com/office/drawing/2014/main" id="{C5C196FE-28C1-0EB1-1B63-38103B8B791F}"/>
+            </a:ext>
+          </a:extLst>
+        </p:cNvPr>
+        <p:cNvGrpSpPr/>
+        <p:nvPr/>
+      </p:nvGrpSpPr>
+      <p:grpSpPr>
+        <a:xfrm>
+          <a:off x="0" y="0"/>
+          <a:ext cx="0" cy="0"/>
+          <a:chOff x="0" y="0"/>
+          <a:chExt cx="0" cy="0"/>
+        </a:xfrm>
+      </p:grpSpPr>
+      <p:sp>
+        <p:nvSpPr>
+          <p:cNvPr id="8" name="Textplatzhalter 7">
+            <a:extLst>
+              <a:ext uri="{FF2B5EF4-FFF2-40B4-BE49-F238E27FC236}">
+                <a16:creationId xmlns:a16="http://schemas.microsoft.com/office/drawing/2014/main" id="{161BEA3D-BF86-9C8E-ACF8-54A5E5C77AC7}"/>
+              </a:ext>
+            </a:extLst>
+          </p:cNvPr>
+          <p:cNvSpPr>
+            <a:spLocks noGrp="1"/>
+          </p:cNvSpPr>
+          <p:nvPr>
+            <p:ph type="body" sz="quarter" idx="12"/>
+          </p:nvPr>
+        </p:nvSpPr>
+        <p:spPr/>
+        <p:txBody>
+          <a:bodyPr/>
+          <a:lstStyle/>
+          <a:p>
+            <a:r>
+              <a:rPr lang="en-US" noProof="0" dirty="0"/>
+              <a:t>The Causes</a:t>
+            </a:r>
+          </a:p>
+        </p:txBody>
+      </p:sp>
+      <p:sp>
+        <p:nvSpPr>
+          <p:cNvPr id="7" name="Titel 6">
+            <a:extLst>
+              <a:ext uri="{FF2B5EF4-FFF2-40B4-BE49-F238E27FC236}">
+                <a16:creationId xmlns:a16="http://schemas.microsoft.com/office/drawing/2014/main" id="{C1DB040A-2EBC-0C1B-6661-5695E9DAB72F}"/>
+              </a:ext>
+            </a:extLst>
+          </p:cNvPr>
+          <p:cNvSpPr>
+            <a:spLocks noGrp="1"/>
+          </p:cNvSpPr>
+          <p:nvPr>
+            <p:ph type="title"/>
+          </p:nvPr>
+        </p:nvSpPr>
+        <p:spPr/>
+        <p:txBody>
+          <a:bodyPr/>
+          <a:lstStyle/>
+          <a:p>
+            <a:r>
+              <a:rPr lang="en-US" dirty="0"/>
+              <a:t>State of Android App Security</a:t>
+            </a:r>
+            <a:endParaRPr lang="en-US" noProof="0" dirty="0"/>
+          </a:p>
+        </p:txBody>
+      </p:sp>
+      <p:sp>
+        <p:nvSpPr>
+          <p:cNvPr id="9" name="Textplatzhalter 8">
+            <a:extLst>
+              <a:ext uri="{FF2B5EF4-FFF2-40B4-BE49-F238E27FC236}">
+                <a16:creationId xmlns:a16="http://schemas.microsoft.com/office/drawing/2014/main" id="{7AEF5994-AB60-B71F-38F7-11DBF1BF4714}"/>
+              </a:ext>
+            </a:extLst>
+          </p:cNvPr>
+          <p:cNvSpPr>
+            <a:spLocks noGrp="1"/>
+          </p:cNvSpPr>
+          <p:nvPr>
+            <p:ph type="body" sz="quarter" idx="19"/>
+          </p:nvPr>
+        </p:nvSpPr>
+        <p:spPr/>
+        <p:txBody>
+          <a:bodyPr/>
+          <a:lstStyle/>
+          <a:p>
+            <a:endParaRPr lang="en-US" noProof="0" dirty="0"/>
+          </a:p>
+        </p:txBody>
+      </p:sp>
+      <p:sp>
+        <p:nvSpPr>
+          <p:cNvPr id="11" name="Fußzeilenplatzhalter 10">
+            <a:extLst>
+              <a:ext uri="{FF2B5EF4-FFF2-40B4-BE49-F238E27FC236}">
+                <a16:creationId xmlns:a16="http://schemas.microsoft.com/office/drawing/2014/main" id="{ACF08163-F9EB-4A62-6E1A-03D1B6FA4326}"/>
+              </a:ext>
+            </a:extLst>
+          </p:cNvPr>
+          <p:cNvSpPr>
+            <a:spLocks noGrp="1"/>
+          </p:cNvSpPr>
+          <p:nvPr>
+            <p:ph type="ftr" sz="quarter" idx="17"/>
+          </p:nvPr>
+        </p:nvSpPr>
+        <p:spPr/>
+        <p:txBody>
+          <a:bodyPr/>
+          <a:lstStyle/>
+          <a:p>
+            <a:endParaRPr lang="en-US" noProof="0" dirty="0"/>
+          </a:p>
+        </p:txBody>
+      </p:sp>
+      <p:sp>
+        <p:nvSpPr>
+          <p:cNvPr id="12" name="Foliennummernplatzhalter 11">
+            <a:extLst>
+              <a:ext uri="{FF2B5EF4-FFF2-40B4-BE49-F238E27FC236}">
+                <a16:creationId xmlns:a16="http://schemas.microsoft.com/office/drawing/2014/main" id="{EEF4182B-0650-3ABB-177A-BAE527E8EF23}"/>
+              </a:ext>
+            </a:extLst>
+          </p:cNvPr>
+          <p:cNvSpPr>
+            <a:spLocks noGrp="1"/>
+          </p:cNvSpPr>
+          <p:nvPr>
+            <p:ph type="sldNum" sz="quarter" idx="18"/>
+          </p:nvPr>
+        </p:nvSpPr>
+        <p:spPr/>
+        <p:txBody>
+          <a:bodyPr/>
+          <a:lstStyle/>
+          <a:p>
+            <a:fld id="{E6639024-6672-4F87-864B-EA4FA9190A1A}" type="slidenum">
+              <a:rPr lang="en-US" noProof="0" smtClean="0"/>
+              <a:pPr/>
+              <a:t>7</a:t>
+            </a:fld>
+            <a:endParaRPr lang="en-US" noProof="0" dirty="0"/>
+          </a:p>
+        </p:txBody>
+      </p:sp>
+      <p:sp>
+        <p:nvSpPr>
+          <p:cNvPr id="2" name="Inhaltsplatzhalter 9">
+            <a:extLst>
+              <a:ext uri="{FF2B5EF4-FFF2-40B4-BE49-F238E27FC236}">
+                <a16:creationId xmlns:a16="http://schemas.microsoft.com/office/drawing/2014/main" id="{DF15101C-F91B-BCF4-F6CE-ED0794DA7FCA}"/>
+              </a:ext>
+            </a:extLst>
+          </p:cNvPr>
+          <p:cNvSpPr txBox="1">
+            <a:spLocks/>
+          </p:cNvSpPr>
+          <p:nvPr/>
+        </p:nvSpPr>
+        <p:spPr>
+          <a:xfrm>
+            <a:off x="359532" y="1207321"/>
+            <a:ext cx="8424467" cy="3332402"/>
+          </a:xfrm>
+          <a:prstGeom prst="rect">
+            <a:avLst/>
+          </a:prstGeom>
+        </p:spPr>
+        <p:txBody>
+          <a:bodyPr vert="horz" lIns="36000" tIns="36000" rIns="36000" bIns="36000" rtlCol="0" anchor="t">
+            <a:normAutofit/>
+          </a:bodyPr>
+          <a:lstStyle>
+            <a:lvl1pPr marL="216000" indent="-216000" algn="l" defTabSz="685800" rtl="0" eaLnBrk="1" latinLnBrk="0" hangingPunct="1">
+              <a:lnSpc>
+                <a:spcPct val="100000"/>
+              </a:lnSpc>
+              <a:spcBef>
+                <a:spcPts val="200"/>
+              </a:spcBef>
+              <a:buClr>
+                <a:schemeClr val="tx1"/>
+              </a:buClr>
+              <a:buFont typeface="Symbol" panose="05050102010706020507" pitchFamily="18" charset="2"/>
+              <a:buChar char="-"/>
+              <a:defRPr sz="1800" kern="1200">
+                <a:solidFill>
+                  <a:schemeClr val="tx1"/>
+                </a:solidFill>
+                <a:latin typeface="+mn-lt"/>
+                <a:ea typeface="+mn-ea"/>
+                <a:cs typeface="+mn-cs"/>
+              </a:defRPr>
+            </a:lvl1pPr>
+            <a:lvl2pPr marL="432000" indent="-216000" algn="l" defTabSz="685800" rtl="0" eaLnBrk="1" latinLnBrk="0" hangingPunct="1">
+              <a:lnSpc>
+                <a:spcPct val="100000"/>
+              </a:lnSpc>
+              <a:spcBef>
+                <a:spcPts val="200"/>
+              </a:spcBef>
+              <a:buFont typeface="Symbol" panose="05050102010706020507" pitchFamily="18" charset="2"/>
+              <a:buChar char="-"/>
+              <a:defRPr sz="1600" kern="1200">
+                <a:solidFill>
+                  <a:schemeClr val="tx1"/>
+                </a:solidFill>
+                <a:latin typeface="+mn-lt"/>
+                <a:ea typeface="+mn-ea"/>
+                <a:cs typeface="+mn-cs"/>
+              </a:defRPr>
+            </a:lvl2pPr>
+            <a:lvl3pPr marL="648000" indent="-216000" algn="l" defTabSz="685800" rtl="0" eaLnBrk="1" latinLnBrk="0" hangingPunct="1">
+              <a:lnSpc>
+                <a:spcPct val="100000"/>
+              </a:lnSpc>
+              <a:spcBef>
+                <a:spcPts val="200"/>
+              </a:spcBef>
+              <a:buFont typeface="Symbol" panose="05050102010706020507" pitchFamily="18" charset="2"/>
+              <a:buChar char="-"/>
+              <a:defRPr sz="1400" kern="1200">
+                <a:solidFill>
+                  <a:schemeClr val="tx1"/>
+                </a:solidFill>
+                <a:latin typeface="+mn-lt"/>
+                <a:ea typeface="+mn-ea"/>
+                <a:cs typeface="+mn-cs"/>
+              </a:defRPr>
+            </a:lvl3pPr>
+            <a:lvl4pPr marL="864000" indent="-216000" algn="l" defTabSz="685800" rtl="0" eaLnBrk="1" latinLnBrk="0" hangingPunct="1">
+              <a:lnSpc>
+                <a:spcPct val="100000"/>
+              </a:lnSpc>
+              <a:spcBef>
+                <a:spcPts val="200"/>
+              </a:spcBef>
+              <a:buFont typeface="Symbol" panose="05050102010706020507" pitchFamily="18" charset="2"/>
+              <a:buChar char="-"/>
+              <a:defRPr sz="1200" kern="1200">
+                <a:solidFill>
+                  <a:schemeClr val="tx1"/>
+                </a:solidFill>
+                <a:latin typeface="+mn-lt"/>
+                <a:ea typeface="+mn-ea"/>
+                <a:cs typeface="+mn-cs"/>
+              </a:defRPr>
+            </a:lvl4pPr>
+            <a:lvl5pPr marL="1080000" indent="-216000" algn="l" defTabSz="685800" rtl="0" eaLnBrk="1" latinLnBrk="0" hangingPunct="1">
+              <a:lnSpc>
+                <a:spcPct val="100000"/>
+              </a:lnSpc>
+              <a:spcBef>
+                <a:spcPts val="200"/>
+              </a:spcBef>
+              <a:buFont typeface="Symbol" panose="05050102010706020507" pitchFamily="18" charset="2"/>
+              <a:buChar char="-"/>
+              <a:defRPr sz="1100" kern="1200">
+                <a:solidFill>
+                  <a:schemeClr val="tx1"/>
+                </a:solidFill>
+                <a:latin typeface="+mn-lt"/>
+                <a:ea typeface="+mn-ea"/>
+                <a:cs typeface="+mn-cs"/>
+              </a:defRPr>
+            </a:lvl5pPr>
+            <a:lvl6pPr marL="1885950" indent="-171450" algn="l" defTabSz="685800" rtl="0" eaLnBrk="1" latinLnBrk="0" hangingPunct="1">
+              <a:lnSpc>
+                <a:spcPct val="90000"/>
+              </a:lnSpc>
+              <a:spcBef>
+                <a:spcPts val="375"/>
+              </a:spcBef>
+              <a:buFont typeface="Arial" panose="020B0604020202020204" pitchFamily="34" charset="0"/>
+              <a:buChar char="•"/>
+              <a:defRPr sz="1350" kern="1200">
+                <a:solidFill>
+                  <a:schemeClr val="tx1"/>
+                </a:solidFill>
+                <a:latin typeface="+mn-lt"/>
+                <a:ea typeface="+mn-ea"/>
+                <a:cs typeface="+mn-cs"/>
+              </a:defRPr>
+            </a:lvl6pPr>
+            <a:lvl7pPr marL="2228850" indent="-171450" algn="l" defTabSz="685800" rtl="0" eaLnBrk="1" latinLnBrk="0" hangingPunct="1">
+              <a:lnSpc>
+                <a:spcPct val="90000"/>
+              </a:lnSpc>
+              <a:spcBef>
+                <a:spcPts val="375"/>
+              </a:spcBef>
+              <a:buFont typeface="Arial" panose="020B0604020202020204" pitchFamily="34" charset="0"/>
+              <a:buChar char="•"/>
+              <a:defRPr sz="1350" kern="1200">
+                <a:solidFill>
+                  <a:schemeClr val="tx1"/>
+                </a:solidFill>
+                <a:latin typeface="+mn-lt"/>
+                <a:ea typeface="+mn-ea"/>
+                <a:cs typeface="+mn-cs"/>
+              </a:defRPr>
+            </a:lvl7pPr>
+            <a:lvl8pPr marL="2571750" indent="-171450" algn="l" defTabSz="685800" rtl="0" eaLnBrk="1" latinLnBrk="0" hangingPunct="1">
+              <a:lnSpc>
+                <a:spcPct val="90000"/>
+              </a:lnSpc>
+              <a:spcBef>
+                <a:spcPts val="375"/>
+              </a:spcBef>
+              <a:buFont typeface="Arial" panose="020B0604020202020204" pitchFamily="34" charset="0"/>
+              <a:buChar char="•"/>
+              <a:defRPr sz="1350" kern="1200">
+                <a:solidFill>
+                  <a:schemeClr val="tx1"/>
+                </a:solidFill>
+                <a:latin typeface="+mn-lt"/>
+                <a:ea typeface="+mn-ea"/>
+                <a:cs typeface="+mn-cs"/>
+              </a:defRPr>
+            </a:lvl8pPr>
+            <a:lvl9pPr marL="2914650" indent="-171450" algn="l" defTabSz="685800" rtl="0" eaLnBrk="1" latinLnBrk="0" hangingPunct="1">
+              <a:lnSpc>
+                <a:spcPct val="90000"/>
+              </a:lnSpc>
+              <a:spcBef>
+                <a:spcPts val="375"/>
+              </a:spcBef>
+              <a:buFont typeface="Arial" panose="020B0604020202020204" pitchFamily="34" charset="0"/>
+              <a:buChar char="•"/>
+              <a:defRPr sz="1350" kern="1200">
+                <a:solidFill>
+                  <a:schemeClr val="tx1"/>
+                </a:solidFill>
+                <a:latin typeface="+mn-lt"/>
+                <a:ea typeface="+mn-ea"/>
+                <a:cs typeface="+mn-cs"/>
+              </a:defRPr>
+            </a:lvl9pPr>
+          </a:lstStyle>
+          <a:p>
+            <a:pPr marL="0" indent="0">
+              <a:lnSpc>
+                <a:spcPct val="150000"/>
+              </a:lnSpc>
+              <a:buNone/>
+            </a:pPr>
+            <a:r>
+              <a:rPr lang="en-US" dirty="0"/>
+              <a:t>What to do?</a:t>
+            </a:r>
+          </a:p>
+          <a:p>
+            <a:pPr>
+              <a:lnSpc>
+                <a:spcPct val="150000"/>
+              </a:lnSpc>
+            </a:pPr>
+            <a:r>
+              <a:rPr lang="en-US" dirty="0"/>
+              <a:t>Find existing vulnerabilities</a:t>
+            </a:r>
+          </a:p>
+          <a:p>
+            <a:pPr>
+              <a:lnSpc>
+                <a:spcPct val="150000"/>
+              </a:lnSpc>
+            </a:pPr>
+            <a:r>
+              <a:rPr lang="en-US" dirty="0"/>
+              <a:t>Prevent new vulnerabilities</a:t>
+            </a:r>
+          </a:p>
+        </p:txBody>
+      </p:sp>
+    </p:spTree>
+    <p:extLst>
+      <p:ext uri="{BB962C8B-B14F-4D97-AF65-F5344CB8AC3E}">
+        <p14:creationId xmlns:p14="http://schemas.microsoft.com/office/powerpoint/2010/main" val="3037396894"/>
+      </p:ext>
+    </p:extLst>
+  </p:cSld>
+  <p:clrMapOvr>
+    <a:masterClrMapping/>
+  </p:clrMapOvr>
+</p:sld>
+</file>
+
+<file path=ppt/slides/slide8.xml><?xml version="1.0" encoding="utf-8"?>
+<p:sld xmlns:a="http://schemas.openxmlformats.org/drawingml/2006/main" xmlns:r="http://schemas.openxmlformats.org/officeDocument/2006/relationships" xmlns:p="http://schemas.openxmlformats.org/presentationml/2006/main">
+  <p:cSld>
+    <p:spTree>
+      <p:nvGrpSpPr>
+        <p:cNvPr id="1" name="">
+          <a:extLst>
+            <a:ext uri="{FF2B5EF4-FFF2-40B4-BE49-F238E27FC236}">
               <a16:creationId xmlns:a16="http://schemas.microsoft.com/office/drawing/2014/main" id="{3CFE7E38-6FC8-9A74-E751-F1897FBC5CB6}"/>
             </a:ext>
           </a:extLst>
@@ -45871,7 +46032,7 @@
             <a:fld id="{E6639024-6672-4F87-864B-EA4FA9190A1A}" type="slidenum">
               <a:rPr lang="en-US" noProof="0" smtClean="0"/>
               <a:pPr/>
-              <a:t>7</a:t>
+              <a:t>8</a:t>
             </a:fld>
             <a:endParaRPr lang="en-US" noProof="0" dirty="0"/>
           </a:p>
@@ -46231,7 +46392,7 @@
 </p:sld>
 </file>
 
-<file path=ppt/slides/slide8.xml><?xml version="1.0" encoding="utf-8"?>
+<file path=ppt/slides/slide9.xml><?xml version="1.0" encoding="utf-8"?>
 <p:sld xmlns:a="http://schemas.openxmlformats.org/drawingml/2006/main" xmlns:r="http://schemas.openxmlformats.org/officeDocument/2006/relationships" xmlns:p="http://schemas.openxmlformats.org/presentationml/2006/main">
   <p:cSld>
     <p:spTree>
@@ -46333,7 +46494,9 @@
           </a:xfrm>
         </p:spPr>
         <p:txBody>
-          <a:bodyPr anchor="t"/>
+          <a:bodyPr anchor="t">
+            <a:normAutofit/>
+          </a:bodyPr>
           <a:lstStyle/>
           <a:p>
             <a:pPr marL="0" indent="0">
@@ -46344,18 +46507,7 @@
             </a:pPr>
             <a:r>
               <a:rPr lang="en-US" noProof="0" dirty="0"/>
-              <a:t>What to do?</a:t>
-            </a:r>
-          </a:p>
-          <a:p>
-            <a:pPr>
-              <a:lnSpc>
-                <a:spcPct val="150000"/>
-              </a:lnSpc>
-            </a:pPr>
-            <a:r>
-              <a:rPr lang="en-US" noProof="0" dirty="0"/>
-              <a:t>Avoid implementing vulnerabilities</a:t>
+              <a:t>Lack of knowledge…</a:t>
             </a:r>
           </a:p>
           <a:p>
@@ -46366,19 +46518,16 @@
               <a:buNone/>
             </a:pPr>
             <a:r>
-              <a:rPr lang="en-US" noProof="0" dirty="0"/>
-              <a:t>-&gt; Make mobile security knowledge more accessible</a:t>
-            </a:r>
-          </a:p>
-          <a:p>
-            <a:pPr>
-              <a:lnSpc>
-                <a:spcPct val="150000"/>
-              </a:lnSpc>
-            </a:pPr>
-            <a:r>
-              <a:rPr lang="en-US" noProof="0" dirty="0"/>
-              <a:t>Find existing vulnerabilities</a:t>
+              <a:rPr lang="en-US" dirty="0"/>
+              <a:t>	…make </a:t>
+            </a:r>
+            <a:r>
+              <a:rPr lang="en-US" b="1" dirty="0"/>
+              <a:t>mobile security knowledge</a:t>
+            </a:r>
+            <a:r>
+              <a:rPr lang="en-US" dirty="0"/>
+              <a:t> more accessible</a:t>
             </a:r>
           </a:p>
           <a:p>
@@ -46388,9 +46537,34 @@
               </a:lnSpc>
               <a:buNone/>
             </a:pPr>
+            <a:endParaRPr lang="en-US" noProof="0" dirty="0"/>
+          </a:p>
+          <a:p>
+            <a:pPr marL="0" indent="0">
+              <a:lnSpc>
+                <a:spcPct val="150000"/>
+              </a:lnSpc>
+              <a:buNone/>
+            </a:pPr>
+            <a:r>
+              <a:rPr lang="en-US" noProof="0" dirty="0"/>
+              <a:t>Too complex and expensive…</a:t>
+            </a:r>
+          </a:p>
+          <a:p>
+            <a:pPr marL="0" indent="0">
+              <a:lnSpc>
+                <a:spcPct val="150000"/>
+              </a:lnSpc>
+              <a:buNone/>
+            </a:pPr>
             <a:r>
               <a:rPr lang="en-US" dirty="0"/>
-              <a:t>-&gt; Improve and promote the best security testing tools</a:t>
+              <a:t>	…benchmark and promote the best </a:t>
+            </a:r>
+            <a:r>
+              <a:rPr lang="en-US" b="1" dirty="0"/>
+              <a:t>security testing tools</a:t>
             </a:r>
           </a:p>
           <a:p>
@@ -46501,7 +46675,7 @@
             <a:fld id="{E6639024-6672-4F87-864B-EA4FA9190A1A}" type="slidenum">
               <a:rPr lang="en-US" noProof="0" smtClean="0"/>
               <a:pPr/>
-              <a:t>8</a:t>
+              <a:t>9</a:t>
             </a:fld>
             <a:endParaRPr lang="en-US" noProof="0" dirty="0"/>
           </a:p>
@@ -46511,279 +46685,6 @@
     <p:extLst>
       <p:ext uri="{BB962C8B-B14F-4D97-AF65-F5344CB8AC3E}">
         <p14:creationId xmlns:p14="http://schemas.microsoft.com/office/powerpoint/2010/main" val="3943694554"/>
-      </p:ext>
-    </p:extLst>
-  </p:cSld>
-  <p:clrMapOvr>
-    <a:masterClrMapping/>
-  </p:clrMapOvr>
-</p:sld>
-</file>
-
-<file path=ppt/slides/slide9.xml><?xml version="1.0" encoding="utf-8"?>
-<p:sld xmlns:a="http://schemas.openxmlformats.org/drawingml/2006/main" xmlns:r="http://schemas.openxmlformats.org/officeDocument/2006/relationships" xmlns:p="http://schemas.openxmlformats.org/presentationml/2006/main">
-  <p:cSld>
-    <p:spTree>
-      <p:nvGrpSpPr>
-        <p:cNvPr id="1" name="">
-          <a:extLst>
-            <a:ext uri="{FF2B5EF4-FFF2-40B4-BE49-F238E27FC236}">
-              <a16:creationId xmlns:a16="http://schemas.microsoft.com/office/drawing/2014/main" id="{04E2A447-830E-35E8-2A4E-F4CB5F279E4F}"/>
-            </a:ext>
-          </a:extLst>
-        </p:cNvPr>
-        <p:cNvGrpSpPr/>
-        <p:nvPr/>
-      </p:nvGrpSpPr>
-      <p:grpSpPr>
-        <a:xfrm>
-          <a:off x="0" y="0"/>
-          <a:ext cx="0" cy="0"/>
-          <a:chOff x="0" y="0"/>
-          <a:chExt cx="0" cy="0"/>
-        </a:xfrm>
-      </p:grpSpPr>
-      <p:sp>
-        <p:nvSpPr>
-          <p:cNvPr id="8" name="Textplatzhalter 7">
-            <a:extLst>
-              <a:ext uri="{FF2B5EF4-FFF2-40B4-BE49-F238E27FC236}">
-                <a16:creationId xmlns:a16="http://schemas.microsoft.com/office/drawing/2014/main" id="{7D0C7159-3A9C-9E0A-67C8-E90393B95739}"/>
-              </a:ext>
-            </a:extLst>
-          </p:cNvPr>
-          <p:cNvSpPr>
-            <a:spLocks noGrp="1"/>
-          </p:cNvSpPr>
-          <p:nvPr>
-            <p:ph type="body" sz="quarter" idx="12"/>
-          </p:nvPr>
-        </p:nvSpPr>
-        <p:spPr/>
-        <p:txBody>
-          <a:bodyPr/>
-          <a:lstStyle/>
-          <a:p>
-            <a:r>
-              <a:rPr lang="en-US" noProof="0" dirty="0"/>
-              <a:t>The Goals</a:t>
-            </a:r>
-          </a:p>
-        </p:txBody>
-      </p:sp>
-      <p:sp>
-        <p:nvSpPr>
-          <p:cNvPr id="7" name="Titel 6">
-            <a:extLst>
-              <a:ext uri="{FF2B5EF4-FFF2-40B4-BE49-F238E27FC236}">
-                <a16:creationId xmlns:a16="http://schemas.microsoft.com/office/drawing/2014/main" id="{3D3E65E5-755F-7414-B8FF-412C1BFE0A06}"/>
-              </a:ext>
-            </a:extLst>
-          </p:cNvPr>
-          <p:cNvSpPr>
-            <a:spLocks noGrp="1"/>
-          </p:cNvSpPr>
-          <p:nvPr>
-            <p:ph type="title"/>
-          </p:nvPr>
-        </p:nvSpPr>
-        <p:spPr/>
-        <p:txBody>
-          <a:bodyPr/>
-          <a:lstStyle/>
-          <a:p>
-            <a:r>
-              <a:rPr lang="en-US" dirty="0"/>
-              <a:t>Understanding the Challenge</a:t>
-            </a:r>
-          </a:p>
-        </p:txBody>
-      </p:sp>
-      <p:sp>
-        <p:nvSpPr>
-          <p:cNvPr id="10" name="Inhaltsplatzhalter 9">
-            <a:extLst>
-              <a:ext uri="{FF2B5EF4-FFF2-40B4-BE49-F238E27FC236}">
-                <a16:creationId xmlns:a16="http://schemas.microsoft.com/office/drawing/2014/main" id="{2B0271F4-9D9C-9885-13F9-C5696DA8BCD5}"/>
-              </a:ext>
-            </a:extLst>
-          </p:cNvPr>
-          <p:cNvSpPr>
-            <a:spLocks noGrp="1"/>
-          </p:cNvSpPr>
-          <p:nvPr>
-            <p:ph sz="quarter" idx="20"/>
-          </p:nvPr>
-        </p:nvSpPr>
-        <p:spPr>
-          <a:xfrm>
-            <a:off x="359533" y="1203598"/>
-            <a:ext cx="8424467" cy="3332402"/>
-          </a:xfrm>
-        </p:spPr>
-        <p:txBody>
-          <a:bodyPr anchor="t"/>
-          <a:lstStyle/>
-          <a:p>
-            <a:pPr marL="0" indent="0">
-              <a:lnSpc>
-                <a:spcPct val="150000"/>
-              </a:lnSpc>
-              <a:buNone/>
-            </a:pPr>
-            <a:r>
-              <a:rPr lang="en-US" noProof="0" dirty="0"/>
-              <a:t>What to do?</a:t>
-            </a:r>
-          </a:p>
-          <a:p>
-            <a:pPr>
-              <a:lnSpc>
-                <a:spcPct val="150000"/>
-              </a:lnSpc>
-            </a:pPr>
-            <a:r>
-              <a:rPr lang="en-US" noProof="0" dirty="0"/>
-              <a:t>Avoid new vulnerabilities </a:t>
-            </a:r>
-            <a:r>
-              <a:rPr lang="en-US" b="1" noProof="0" dirty="0"/>
-              <a:t>(Mobile Security Knowledge)</a:t>
-            </a:r>
-          </a:p>
-          <a:p>
-            <a:pPr>
-              <a:lnSpc>
-                <a:spcPct val="150000"/>
-              </a:lnSpc>
-            </a:pPr>
-            <a:r>
-              <a:rPr lang="en-US" noProof="0" dirty="0"/>
-              <a:t>Find existing vulnerabilities </a:t>
-            </a:r>
-            <a:r>
-              <a:rPr lang="en-US" b="1" noProof="0" dirty="0"/>
-              <a:t>(Security Testing Tools)</a:t>
-            </a:r>
-          </a:p>
-          <a:p>
-            <a:pPr>
-              <a:lnSpc>
-                <a:spcPct val="150000"/>
-              </a:lnSpc>
-            </a:pPr>
-            <a:endParaRPr lang="en-US" noProof="0" dirty="0"/>
-          </a:p>
-          <a:p>
-            <a:pPr>
-              <a:lnSpc>
-                <a:spcPct val="150000"/>
-              </a:lnSpc>
-            </a:pPr>
-            <a:endParaRPr lang="en-US" noProof="0" dirty="0"/>
-          </a:p>
-          <a:p>
-            <a:pPr>
-              <a:lnSpc>
-                <a:spcPct val="150000"/>
-              </a:lnSpc>
-            </a:pPr>
-            <a:endParaRPr lang="en-US" noProof="0" dirty="0"/>
-          </a:p>
-          <a:p>
-            <a:pPr>
-              <a:lnSpc>
-                <a:spcPct val="150000"/>
-              </a:lnSpc>
-            </a:pPr>
-            <a:endParaRPr lang="en-US" noProof="0" dirty="0"/>
-          </a:p>
-        </p:txBody>
-      </p:sp>
-      <p:sp>
-        <p:nvSpPr>
-          <p:cNvPr id="9" name="Textplatzhalter 8">
-            <a:extLst>
-              <a:ext uri="{FF2B5EF4-FFF2-40B4-BE49-F238E27FC236}">
-                <a16:creationId xmlns:a16="http://schemas.microsoft.com/office/drawing/2014/main" id="{5DEE1DFE-829C-EF60-D6FE-232D0C660AD4}"/>
-              </a:ext>
-            </a:extLst>
-          </p:cNvPr>
-          <p:cNvSpPr>
-            <a:spLocks noGrp="1"/>
-          </p:cNvSpPr>
-          <p:nvPr>
-            <p:ph type="body" sz="quarter" idx="19"/>
-          </p:nvPr>
-        </p:nvSpPr>
-        <p:spPr/>
-        <p:txBody>
-          <a:bodyPr/>
-          <a:lstStyle/>
-          <a:p>
-            <a:endParaRPr lang="en-US" noProof="0" dirty="0"/>
-          </a:p>
-        </p:txBody>
-      </p:sp>
-      <p:sp>
-        <p:nvSpPr>
-          <p:cNvPr id="11" name="Fußzeilenplatzhalter 10">
-            <a:extLst>
-              <a:ext uri="{FF2B5EF4-FFF2-40B4-BE49-F238E27FC236}">
-                <a16:creationId xmlns:a16="http://schemas.microsoft.com/office/drawing/2014/main" id="{F68EF483-9C7D-F49C-6D75-07B6BAF60A7A}"/>
-              </a:ext>
-            </a:extLst>
-          </p:cNvPr>
-          <p:cNvSpPr>
-            <a:spLocks noGrp="1"/>
-          </p:cNvSpPr>
-          <p:nvPr>
-            <p:ph type="ftr" sz="quarter" idx="17"/>
-          </p:nvPr>
-        </p:nvSpPr>
-        <p:spPr/>
-        <p:txBody>
-          <a:bodyPr/>
-          <a:lstStyle/>
-          <a:p>
-            <a:endParaRPr lang="en-US" noProof="0" dirty="0"/>
-          </a:p>
-        </p:txBody>
-      </p:sp>
-      <p:sp>
-        <p:nvSpPr>
-          <p:cNvPr id="12" name="Foliennummernplatzhalter 11">
-            <a:extLst>
-              <a:ext uri="{FF2B5EF4-FFF2-40B4-BE49-F238E27FC236}">
-                <a16:creationId xmlns:a16="http://schemas.microsoft.com/office/drawing/2014/main" id="{D347BDF0-3E38-78D7-E5CC-14DA06A0999A}"/>
-              </a:ext>
-            </a:extLst>
-          </p:cNvPr>
-          <p:cNvSpPr>
-            <a:spLocks noGrp="1"/>
-          </p:cNvSpPr>
-          <p:nvPr>
-            <p:ph type="sldNum" sz="quarter" idx="18"/>
-          </p:nvPr>
-        </p:nvSpPr>
-        <p:spPr/>
-        <p:txBody>
-          <a:bodyPr/>
-          <a:lstStyle/>
-          <a:p>
-            <a:fld id="{E6639024-6672-4F87-864B-EA4FA9190A1A}" type="slidenum">
-              <a:rPr lang="en-US" noProof="0" smtClean="0"/>
-              <a:pPr/>
-              <a:t>9</a:t>
-            </a:fld>
-            <a:endParaRPr lang="en-US" noProof="0" dirty="0"/>
-          </a:p>
-        </p:txBody>
-      </p:sp>
-    </p:spTree>
-    <p:extLst>
-      <p:ext uri="{BB962C8B-B14F-4D97-AF65-F5344CB8AC3E}">
-        <p14:creationId xmlns:p14="http://schemas.microsoft.com/office/powerpoint/2010/main" val="253532363"/>
       </p:ext>
     </p:extLst>
   </p:cSld>

</xml_diff>

<commit_message>
Started adding proper references and citations to the presentation. Removed the slides discussing the flow diagrams, as I am still 5 minutes over the required talking time
</commit_message>
<xml_diff>
--- a/dev_documents/presentation/ba_thesis_presentation_kronig.pptx
+++ b/dev_documents/presentation/ba_thesis_presentation_kronig.pptx
@@ -31,35 +31,35 @@
     <p:sldId id="262" r:id="rId19"/>
     <p:sldId id="273" r:id="rId20"/>
     <p:sldId id="275" r:id="rId21"/>
-    <p:sldId id="263" r:id="rId22"/>
-    <p:sldId id="277" r:id="rId23"/>
-    <p:sldId id="276" r:id="rId24"/>
-    <p:sldId id="278" r:id="rId25"/>
-    <p:sldId id="292" r:id="rId26"/>
-    <p:sldId id="281" r:id="rId27"/>
-    <p:sldId id="286" r:id="rId28"/>
-    <p:sldId id="287" r:id="rId29"/>
-    <p:sldId id="288" r:id="rId30"/>
-    <p:sldId id="289" r:id="rId31"/>
-    <p:sldId id="264" r:id="rId32"/>
-    <p:sldId id="293" r:id="rId33"/>
-    <p:sldId id="294" r:id="rId34"/>
-    <p:sldId id="296" r:id="rId35"/>
-    <p:sldId id="297" r:id="rId36"/>
-    <p:sldId id="298" r:id="rId37"/>
-    <p:sldId id="299" r:id="rId38"/>
-    <p:sldId id="300" r:id="rId39"/>
-    <p:sldId id="295" r:id="rId40"/>
-    <p:sldId id="282" r:id="rId41"/>
-    <p:sldId id="301" r:id="rId42"/>
-    <p:sldId id="302" r:id="rId43"/>
-    <p:sldId id="283" r:id="rId44"/>
-    <p:sldId id="304" r:id="rId45"/>
-    <p:sldId id="305" r:id="rId46"/>
-    <p:sldId id="284" r:id="rId47"/>
-    <p:sldId id="285" r:id="rId48"/>
-    <p:sldId id="308" r:id="rId49"/>
-    <p:sldId id="307" r:id="rId50"/>
+    <p:sldId id="326" r:id="rId22"/>
+    <p:sldId id="263" r:id="rId23"/>
+    <p:sldId id="277" r:id="rId24"/>
+    <p:sldId id="276" r:id="rId25"/>
+    <p:sldId id="278" r:id="rId26"/>
+    <p:sldId id="292" r:id="rId27"/>
+    <p:sldId id="281" r:id="rId28"/>
+    <p:sldId id="286" r:id="rId29"/>
+    <p:sldId id="287" r:id="rId30"/>
+    <p:sldId id="288" r:id="rId31"/>
+    <p:sldId id="289" r:id="rId32"/>
+    <p:sldId id="264" r:id="rId33"/>
+    <p:sldId id="293" r:id="rId34"/>
+    <p:sldId id="294" r:id="rId35"/>
+    <p:sldId id="296" r:id="rId36"/>
+    <p:sldId id="297" r:id="rId37"/>
+    <p:sldId id="298" r:id="rId38"/>
+    <p:sldId id="295" r:id="rId39"/>
+    <p:sldId id="282" r:id="rId40"/>
+    <p:sldId id="301" r:id="rId41"/>
+    <p:sldId id="302" r:id="rId42"/>
+    <p:sldId id="283" r:id="rId43"/>
+    <p:sldId id="304" r:id="rId44"/>
+    <p:sldId id="305" r:id="rId45"/>
+    <p:sldId id="284" r:id="rId46"/>
+    <p:sldId id="285" r:id="rId47"/>
+    <p:sldId id="308" r:id="rId48"/>
+    <p:sldId id="307" r:id="rId49"/>
+    <p:sldId id="327" r:id="rId50"/>
     <p:sldId id="306" r:id="rId51"/>
   </p:sldIdLst>
   <p:sldSz cx="9144000" cy="5143500" type="screen16x9"/>
@@ -31552,8 +31552,12 @@
               </a:lnSpc>
             </a:pPr>
             <a:r>
+              <a:rPr lang="en-US" dirty="0"/>
+              <a:t>OWASP</a:t>
+            </a:r>
+            <a:r>
               <a:rPr lang="en-US" noProof="0" dirty="0"/>
-              <a:t>OWASP (MASTG)</a:t>
+              <a:t> MASTG</a:t>
             </a:r>
           </a:p>
           <a:p>
@@ -31772,29 +31776,6 @@
               </a:lnSpc>
             </a:pPr>
             <a:r>
-              <a:rPr lang="en-US" dirty="0"/>
-              <a:t>Promote best security testing tools</a:t>
-            </a:r>
-            <a:endParaRPr lang="en-US" noProof="0" dirty="0"/>
-          </a:p>
-          <a:p>
-            <a:pPr>
-              <a:lnSpc>
-                <a:spcPct val="150000"/>
-              </a:lnSpc>
-            </a:pPr>
-            <a:r>
-              <a:rPr lang="en-US" noProof="0" dirty="0"/>
-              <a:t>Tools for vulnerability detection</a:t>
-            </a:r>
-          </a:p>
-          <a:p>
-            <a:pPr>
-              <a:lnSpc>
-                <a:spcPct val="150000"/>
-              </a:lnSpc>
-            </a:pPr>
-            <a:r>
               <a:rPr lang="en-US" b="1" dirty="0"/>
               <a:t>S</a:t>
             </a:r>
@@ -31857,6 +31838,21 @@
             <a:r>
               <a:rPr lang="en-US" dirty="0"/>
               <a:t>)</a:t>
+            </a:r>
+          </a:p>
+          <a:p>
+            <a:pPr>
+              <a:lnSpc>
+                <a:spcPct val="150000"/>
+              </a:lnSpc>
+            </a:pPr>
+            <a:r>
+              <a:rPr lang="en-US" noProof="0" dirty="0"/>
+              <a:t>Tools fo</a:t>
+            </a:r>
+            <a:r>
+              <a:rPr lang="en-US" dirty="0"/>
+              <a:t>r vulnerability detection</a:t>
             </a:r>
             <a:endParaRPr lang="en-US" noProof="0" dirty="0"/>
           </a:p>
@@ -32701,6 +32697,10 @@
           <a:bodyPr/>
           <a:lstStyle/>
           <a:p>
+            <a:r>
+              <a:rPr lang="de-CH" dirty="0"/>
+              <a:t>(OWASP MAS, 2026)</a:t>
+            </a:r>
             <a:endParaRPr lang="en-US" noProof="0" dirty="0"/>
           </a:p>
         </p:txBody>
@@ -34042,7 +34042,7 @@
         <p:cNvPr id="1" name="">
           <a:extLst>
             <a:ext uri="{FF2B5EF4-FFF2-40B4-BE49-F238E27FC236}">
-              <a16:creationId xmlns:a16="http://schemas.microsoft.com/office/drawing/2014/main" id="{86FB1F7E-92A6-4C6C-183A-68C0BC6EEB49}"/>
+              <a16:creationId xmlns:a16="http://schemas.microsoft.com/office/drawing/2014/main" id="{8604C0DE-1380-91C2-0F3C-7B21E37677AE}"/>
             </a:ext>
           </a:extLst>
         </p:cNvPr>
@@ -34062,7 +34062,7 @@
           <p:cNvPr id="8" name="Textplatzhalter 7">
             <a:extLst>
               <a:ext uri="{FF2B5EF4-FFF2-40B4-BE49-F238E27FC236}">
-                <a16:creationId xmlns:a16="http://schemas.microsoft.com/office/drawing/2014/main" id="{7509BCEB-73EC-F2FF-D7D1-DC7CFAEB0E77}"/>
+                <a16:creationId xmlns:a16="http://schemas.microsoft.com/office/drawing/2014/main" id="{377CF773-BFCA-D3B5-2AF7-7D7335614CB9}"/>
               </a:ext>
             </a:extLst>
           </p:cNvPr>
@@ -34080,7 +34080,7 @@
           <a:p>
             <a:r>
               <a:rPr lang="en-US" dirty="0"/>
-              <a:t>Understanding the Challenge</a:t>
+              <a:t>Findings</a:t>
             </a:r>
             <a:endParaRPr lang="en-US" noProof="0" dirty="0"/>
           </a:p>
@@ -34091,7 +34091,7 @@
           <p:cNvPr id="7" name="Titel 6">
             <a:extLst>
               <a:ext uri="{FF2B5EF4-FFF2-40B4-BE49-F238E27FC236}">
-                <a16:creationId xmlns:a16="http://schemas.microsoft.com/office/drawing/2014/main" id="{C682571B-C559-5183-3951-9894A7698B08}"/>
+                <a16:creationId xmlns:a16="http://schemas.microsoft.com/office/drawing/2014/main" id="{9E666D68-0D73-30A0-1CD7-DDA6D8144DF4}"/>
               </a:ext>
             </a:extLst>
           </p:cNvPr>
@@ -34109,7 +34109,7 @@
           <a:p>
             <a:r>
               <a:rPr lang="en-US" dirty="0"/>
-              <a:t>State of the Art in MASTG Reference Apps</a:t>
+              <a:t>Connection to Academia</a:t>
             </a:r>
           </a:p>
         </p:txBody>
@@ -34119,7 +34119,7 @@
           <p:cNvPr id="10" name="Inhaltsplatzhalter 9">
             <a:extLst>
               <a:ext uri="{FF2B5EF4-FFF2-40B4-BE49-F238E27FC236}">
-                <a16:creationId xmlns:a16="http://schemas.microsoft.com/office/drawing/2014/main" id="{E1AB05A6-B10A-4874-6B0F-21E5160E7B46}"/>
+                <a16:creationId xmlns:a16="http://schemas.microsoft.com/office/drawing/2014/main" id="{624B0D4A-7708-B6EC-F002-7DF590D7D200}"/>
               </a:ext>
             </a:extLst>
           </p:cNvPr>
@@ -34140,6 +34140,18 @@
           <a:bodyPr anchor="t"/>
           <a:lstStyle/>
           <a:p>
+            <a:pPr marL="0" indent="0">
+              <a:lnSpc>
+                <a:spcPct val="150000"/>
+              </a:lnSpc>
+              <a:buNone/>
+            </a:pPr>
+            <a:r>
+              <a:rPr lang="en-US" noProof="0" dirty="0"/>
+              <a:t>Take-away points:</a:t>
+            </a:r>
+          </a:p>
+          <a:p>
             <a:pPr>
               <a:lnSpc>
                 <a:spcPct val="150000"/>
@@ -34147,7 +34159,7 @@
             </a:pPr>
             <a:r>
               <a:rPr lang="en-US" noProof="0" dirty="0"/>
-              <a:t>Our goal is clear: develop MASTG reference apps</a:t>
+              <a:t>Significant use-case for academia</a:t>
             </a:r>
           </a:p>
           <a:p>
@@ -34157,9 +34169,21 @@
               </a:lnSpc>
             </a:pPr>
             <a:r>
-              <a:rPr lang="en-US" i="1" noProof="0" dirty="0"/>
-              <a:t>What makes a good reference app?</a:t>
-            </a:r>
+              <a:rPr lang="en-US" noProof="0" dirty="0"/>
+              <a:t>Evaluating real-world apps</a:t>
+            </a:r>
+          </a:p>
+          <a:p>
+            <a:pPr>
+              <a:lnSpc>
+                <a:spcPct val="150000"/>
+              </a:lnSpc>
+            </a:pPr>
+            <a:r>
+              <a:rPr lang="en-US" dirty="0"/>
+              <a:t>Developing &amp; testing tools</a:t>
+            </a:r>
+            <a:endParaRPr lang="en-US" noProof="0" dirty="0"/>
           </a:p>
         </p:txBody>
       </p:sp>
@@ -34168,7 +34192,7 @@
           <p:cNvPr id="9" name="Textplatzhalter 8">
             <a:extLst>
               <a:ext uri="{FF2B5EF4-FFF2-40B4-BE49-F238E27FC236}">
-                <a16:creationId xmlns:a16="http://schemas.microsoft.com/office/drawing/2014/main" id="{32E852CA-1974-5955-9DD6-316FF4D74B22}"/>
+                <a16:creationId xmlns:a16="http://schemas.microsoft.com/office/drawing/2014/main" id="{C59DB9BD-6149-4BF0-EE69-27F9C2461397}"/>
               </a:ext>
             </a:extLst>
           </p:cNvPr>
@@ -34193,7 +34217,7 @@
           <p:cNvPr id="11" name="Fußzeilenplatzhalter 10">
             <a:extLst>
               <a:ext uri="{FF2B5EF4-FFF2-40B4-BE49-F238E27FC236}">
-                <a16:creationId xmlns:a16="http://schemas.microsoft.com/office/drawing/2014/main" id="{B4A35F96-9ACA-F8A2-CEC7-8E162B9165A3}"/>
+                <a16:creationId xmlns:a16="http://schemas.microsoft.com/office/drawing/2014/main" id="{18497FD9-1CA0-DE30-143F-294594CC2E05}"/>
               </a:ext>
             </a:extLst>
           </p:cNvPr>
@@ -34218,7 +34242,7 @@
           <p:cNvPr id="12" name="Foliennummernplatzhalter 11">
             <a:extLst>
               <a:ext uri="{FF2B5EF4-FFF2-40B4-BE49-F238E27FC236}">
-                <a16:creationId xmlns:a16="http://schemas.microsoft.com/office/drawing/2014/main" id="{32AE0C18-55B9-0E93-0E77-63AD3F17D322}"/>
+                <a16:creationId xmlns:a16="http://schemas.microsoft.com/office/drawing/2014/main" id="{0B2259FF-ED81-7380-55AF-A876F69C16FF}"/>
               </a:ext>
             </a:extLst>
           </p:cNvPr>
@@ -34246,7 +34270,7 @@
     </p:spTree>
     <p:extLst>
       <p:ext uri="{BB962C8B-B14F-4D97-AF65-F5344CB8AC3E}">
-        <p14:creationId xmlns:p14="http://schemas.microsoft.com/office/powerpoint/2010/main" val="3553623308"/>
+        <p14:creationId xmlns:p14="http://schemas.microsoft.com/office/powerpoint/2010/main" val="1260704541"/>
       </p:ext>
     </p:extLst>
   </p:cSld>
@@ -34371,21 +34395,6 @@
             <a:r>
               <a:rPr lang="en-US" dirty="0"/>
               <a:t>Android most dominant mobile market</a:t>
-            </a:r>
-          </a:p>
-          <a:p>
-            <a:pPr>
-              <a:lnSpc>
-                <a:spcPct val="150000"/>
-              </a:lnSpc>
-            </a:pPr>
-            <a:r>
-              <a:rPr lang="en-US" noProof="0" dirty="0"/>
-              <a:t>Light revie</a:t>
-            </a:r>
-            <a:r>
-              <a:rPr lang="en-US" dirty="0"/>
-              <a:t>w process</a:t>
             </a:r>
           </a:p>
           <a:p>
@@ -34564,6 +34573,228 @@
         <p:cNvPr id="1" name="">
           <a:extLst>
             <a:ext uri="{FF2B5EF4-FFF2-40B4-BE49-F238E27FC236}">
+              <a16:creationId xmlns:a16="http://schemas.microsoft.com/office/drawing/2014/main" id="{86FB1F7E-92A6-4C6C-183A-68C0BC6EEB49}"/>
+            </a:ext>
+          </a:extLst>
+        </p:cNvPr>
+        <p:cNvGrpSpPr/>
+        <p:nvPr/>
+      </p:nvGrpSpPr>
+      <p:grpSpPr>
+        <a:xfrm>
+          <a:off x="0" y="0"/>
+          <a:ext cx="0" cy="0"/>
+          <a:chOff x="0" y="0"/>
+          <a:chExt cx="0" cy="0"/>
+        </a:xfrm>
+      </p:grpSpPr>
+      <p:sp>
+        <p:nvSpPr>
+          <p:cNvPr id="8" name="Textplatzhalter 7">
+            <a:extLst>
+              <a:ext uri="{FF2B5EF4-FFF2-40B4-BE49-F238E27FC236}">
+                <a16:creationId xmlns:a16="http://schemas.microsoft.com/office/drawing/2014/main" id="{7509BCEB-73EC-F2FF-D7D1-DC7CFAEB0E77}"/>
+              </a:ext>
+            </a:extLst>
+          </p:cNvPr>
+          <p:cNvSpPr>
+            <a:spLocks noGrp="1"/>
+          </p:cNvSpPr>
+          <p:nvPr>
+            <p:ph type="body" sz="quarter" idx="12"/>
+          </p:nvPr>
+        </p:nvSpPr>
+        <p:spPr/>
+        <p:txBody>
+          <a:bodyPr/>
+          <a:lstStyle/>
+          <a:p>
+            <a:r>
+              <a:rPr lang="en-US" dirty="0"/>
+              <a:t>Understanding the Challenge</a:t>
+            </a:r>
+            <a:endParaRPr lang="en-US" noProof="0" dirty="0"/>
+          </a:p>
+        </p:txBody>
+      </p:sp>
+      <p:sp>
+        <p:nvSpPr>
+          <p:cNvPr id="7" name="Titel 6">
+            <a:extLst>
+              <a:ext uri="{FF2B5EF4-FFF2-40B4-BE49-F238E27FC236}">
+                <a16:creationId xmlns:a16="http://schemas.microsoft.com/office/drawing/2014/main" id="{C682571B-C559-5183-3951-9894A7698B08}"/>
+              </a:ext>
+            </a:extLst>
+          </p:cNvPr>
+          <p:cNvSpPr>
+            <a:spLocks noGrp="1"/>
+          </p:cNvSpPr>
+          <p:nvPr>
+            <p:ph type="title"/>
+          </p:nvPr>
+        </p:nvSpPr>
+        <p:spPr/>
+        <p:txBody>
+          <a:bodyPr/>
+          <a:lstStyle/>
+          <a:p>
+            <a:r>
+              <a:rPr lang="en-US" dirty="0"/>
+              <a:t>State of the Art in MASTG Reference Apps</a:t>
+            </a:r>
+          </a:p>
+        </p:txBody>
+      </p:sp>
+      <p:sp>
+        <p:nvSpPr>
+          <p:cNvPr id="10" name="Inhaltsplatzhalter 9">
+            <a:extLst>
+              <a:ext uri="{FF2B5EF4-FFF2-40B4-BE49-F238E27FC236}">
+                <a16:creationId xmlns:a16="http://schemas.microsoft.com/office/drawing/2014/main" id="{E1AB05A6-B10A-4874-6B0F-21E5160E7B46}"/>
+              </a:ext>
+            </a:extLst>
+          </p:cNvPr>
+          <p:cNvSpPr>
+            <a:spLocks noGrp="1"/>
+          </p:cNvSpPr>
+          <p:nvPr>
+            <p:ph sz="quarter" idx="20"/>
+          </p:nvPr>
+        </p:nvSpPr>
+        <p:spPr>
+          <a:xfrm>
+            <a:off x="359533" y="1203598"/>
+            <a:ext cx="8424467" cy="3332402"/>
+          </a:xfrm>
+        </p:spPr>
+        <p:txBody>
+          <a:bodyPr anchor="t"/>
+          <a:lstStyle/>
+          <a:p>
+            <a:pPr>
+              <a:lnSpc>
+                <a:spcPct val="150000"/>
+              </a:lnSpc>
+            </a:pPr>
+            <a:r>
+              <a:rPr lang="en-US" noProof="0" dirty="0"/>
+              <a:t>Our goal is clear: develop MASTG reference apps</a:t>
+            </a:r>
+          </a:p>
+          <a:p>
+            <a:pPr>
+              <a:lnSpc>
+                <a:spcPct val="150000"/>
+              </a:lnSpc>
+            </a:pPr>
+            <a:r>
+              <a:rPr lang="en-US" i="1" noProof="0" dirty="0"/>
+              <a:t>What makes a good reference app?</a:t>
+            </a:r>
+          </a:p>
+        </p:txBody>
+      </p:sp>
+      <p:sp>
+        <p:nvSpPr>
+          <p:cNvPr id="9" name="Textplatzhalter 8">
+            <a:extLst>
+              <a:ext uri="{FF2B5EF4-FFF2-40B4-BE49-F238E27FC236}">
+                <a16:creationId xmlns:a16="http://schemas.microsoft.com/office/drawing/2014/main" id="{32E852CA-1974-5955-9DD6-316FF4D74B22}"/>
+              </a:ext>
+            </a:extLst>
+          </p:cNvPr>
+          <p:cNvSpPr>
+            <a:spLocks noGrp="1"/>
+          </p:cNvSpPr>
+          <p:nvPr>
+            <p:ph type="body" sz="quarter" idx="19"/>
+          </p:nvPr>
+        </p:nvSpPr>
+        <p:spPr/>
+        <p:txBody>
+          <a:bodyPr/>
+          <a:lstStyle/>
+          <a:p>
+            <a:endParaRPr lang="en-US" noProof="0" dirty="0"/>
+          </a:p>
+        </p:txBody>
+      </p:sp>
+      <p:sp>
+        <p:nvSpPr>
+          <p:cNvPr id="11" name="Fußzeilenplatzhalter 10">
+            <a:extLst>
+              <a:ext uri="{FF2B5EF4-FFF2-40B4-BE49-F238E27FC236}">
+                <a16:creationId xmlns:a16="http://schemas.microsoft.com/office/drawing/2014/main" id="{B4A35F96-9ACA-F8A2-CEC7-8E162B9165A3}"/>
+              </a:ext>
+            </a:extLst>
+          </p:cNvPr>
+          <p:cNvSpPr>
+            <a:spLocks noGrp="1"/>
+          </p:cNvSpPr>
+          <p:nvPr>
+            <p:ph type="ftr" sz="quarter" idx="17"/>
+          </p:nvPr>
+        </p:nvSpPr>
+        <p:spPr/>
+        <p:txBody>
+          <a:bodyPr/>
+          <a:lstStyle/>
+          <a:p>
+            <a:endParaRPr lang="en-US" noProof="0" dirty="0"/>
+          </a:p>
+        </p:txBody>
+      </p:sp>
+      <p:sp>
+        <p:nvSpPr>
+          <p:cNvPr id="12" name="Foliennummernplatzhalter 11">
+            <a:extLst>
+              <a:ext uri="{FF2B5EF4-FFF2-40B4-BE49-F238E27FC236}">
+                <a16:creationId xmlns:a16="http://schemas.microsoft.com/office/drawing/2014/main" id="{32AE0C18-55B9-0E93-0E77-63AD3F17D322}"/>
+              </a:ext>
+            </a:extLst>
+          </p:cNvPr>
+          <p:cNvSpPr>
+            <a:spLocks noGrp="1"/>
+          </p:cNvSpPr>
+          <p:nvPr>
+            <p:ph type="sldNum" sz="quarter" idx="18"/>
+          </p:nvPr>
+        </p:nvSpPr>
+        <p:spPr/>
+        <p:txBody>
+          <a:bodyPr/>
+          <a:lstStyle/>
+          <a:p>
+            <a:fld id="{E6639024-6672-4F87-864B-EA4FA9190A1A}" type="slidenum">
+              <a:rPr lang="en-US" noProof="0" smtClean="0"/>
+              <a:pPr/>
+              <a:t>20</a:t>
+            </a:fld>
+            <a:endParaRPr lang="en-US" noProof="0" dirty="0"/>
+          </a:p>
+        </p:txBody>
+      </p:sp>
+    </p:spTree>
+    <p:extLst>
+      <p:ext uri="{BB962C8B-B14F-4D97-AF65-F5344CB8AC3E}">
+        <p14:creationId xmlns:p14="http://schemas.microsoft.com/office/powerpoint/2010/main" val="3553623308"/>
+      </p:ext>
+    </p:extLst>
+  </p:cSld>
+  <p:clrMapOvr>
+    <a:masterClrMapping/>
+  </p:clrMapOvr>
+</p:sld>
+</file>
+
+<file path=ppt/slides/slide21.xml><?xml version="1.0" encoding="utf-8"?>
+<p:sld xmlns:a="http://schemas.openxmlformats.org/drawingml/2006/main" xmlns:r="http://schemas.openxmlformats.org/officeDocument/2006/relationships" xmlns:p="http://schemas.openxmlformats.org/presentationml/2006/main">
+  <p:cSld>
+    <p:spTree>
+      <p:nvGrpSpPr>
+        <p:cNvPr id="1" name="">
+          <a:extLst>
+            <a:ext uri="{FF2B5EF4-FFF2-40B4-BE49-F238E27FC236}">
               <a16:creationId xmlns:a16="http://schemas.microsoft.com/office/drawing/2014/main" id="{1128FFB0-9015-D5A5-681C-008FEF57C782}"/>
             </a:ext>
           </a:extLst>
@@ -34781,7 +35012,7 @@
             <a:fld id="{E6639024-6672-4F87-864B-EA4FA9190A1A}" type="slidenum">
               <a:rPr lang="en-US" noProof="0" smtClean="0"/>
               <a:pPr/>
-              <a:t>20</a:t>
+              <a:t>21</a:t>
             </a:fld>
             <a:endParaRPr lang="en-US" noProof="0" dirty="0"/>
           </a:p>
@@ -34800,7 +35031,7 @@
 </p:sld>
 </file>
 
-<file path=ppt/slides/slide21.xml><?xml version="1.0" encoding="utf-8"?>
+<file path=ppt/slides/slide22.xml><?xml version="1.0" encoding="utf-8"?>
 <p:sld xmlns:a="http://schemas.openxmlformats.org/drawingml/2006/main" xmlns:r="http://schemas.openxmlformats.org/officeDocument/2006/relationships" xmlns:p="http://schemas.openxmlformats.org/presentationml/2006/main">
   <p:cSld>
     <p:spTree>
@@ -35038,6 +35269,10 @@
           <a:bodyPr/>
           <a:lstStyle/>
           <a:p>
+            <a:r>
+              <a:rPr lang="de-CH" dirty="0"/>
+              <a:t>(OWASP MASTG, 2025)</a:t>
+            </a:r>
             <a:endParaRPr lang="en-US" noProof="0" dirty="0"/>
           </a:p>
         </p:txBody>
@@ -35091,7 +35326,7 @@
             <a:fld id="{E6639024-6672-4F87-864B-EA4FA9190A1A}" type="slidenum">
               <a:rPr lang="en-US" noProof="0" smtClean="0"/>
               <a:pPr/>
-              <a:t>21</a:t>
+              <a:t>22</a:t>
             </a:fld>
             <a:endParaRPr lang="en-US" noProof="0" dirty="0"/>
           </a:p>
@@ -35110,7 +35345,7 @@
 </p:sld>
 </file>
 
-<file path=ppt/slides/slide22.xml><?xml version="1.0" encoding="utf-8"?>
+<file path=ppt/slides/slide23.xml><?xml version="1.0" encoding="utf-8"?>
 <p:sld xmlns:a="http://schemas.openxmlformats.org/drawingml/2006/main" xmlns:r="http://schemas.openxmlformats.org/officeDocument/2006/relationships" xmlns:p="http://schemas.openxmlformats.org/presentationml/2006/main">
   <p:cSld>
     <p:spTree>
@@ -35324,7 +35559,7 @@
             <a:fld id="{E6639024-6672-4F87-864B-EA4FA9190A1A}" type="slidenum">
               <a:rPr lang="en-US" noProof="0" smtClean="0"/>
               <a:pPr/>
-              <a:t>22</a:t>
+              <a:t>23</a:t>
             </a:fld>
             <a:endParaRPr lang="en-US" noProof="0" dirty="0"/>
           </a:p>
@@ -35343,7 +35578,7 @@
 </p:sld>
 </file>
 
-<file path=ppt/slides/slide23.xml><?xml version="1.0" encoding="utf-8"?>
+<file path=ppt/slides/slide24.xml><?xml version="1.0" encoding="utf-8"?>
 <p:sld xmlns:a="http://schemas.openxmlformats.org/drawingml/2006/main" xmlns:r="http://schemas.openxmlformats.org/officeDocument/2006/relationships" xmlns:p="http://schemas.openxmlformats.org/presentationml/2006/main">
   <p:cSld>
     <p:spTree>
@@ -35557,7 +35792,7 @@
             <a:fld id="{E6639024-6672-4F87-864B-EA4FA9190A1A}" type="slidenum">
               <a:rPr lang="en-US" noProof="0" smtClean="0"/>
               <a:pPr/>
-              <a:t>23</a:t>
+              <a:t>24</a:t>
             </a:fld>
             <a:endParaRPr lang="en-US" noProof="0" dirty="0"/>
           </a:p>
@@ -35576,7 +35811,7 @@
 </p:sld>
 </file>
 
-<file path=ppt/slides/slide24.xml><?xml version="1.0" encoding="utf-8"?>
+<file path=ppt/slides/slide25.xml><?xml version="1.0" encoding="utf-8"?>
 <p:sld xmlns:a="http://schemas.openxmlformats.org/drawingml/2006/main" xmlns:r="http://schemas.openxmlformats.org/officeDocument/2006/relationships" xmlns:p="http://schemas.openxmlformats.org/presentationml/2006/main">
   <p:cSld>
     <p:spTree>
@@ -35701,7 +35936,7 @@
             </a:pPr>
             <a:r>
               <a:rPr lang="en-US" noProof="0" dirty="0"/>
-              <a:t>5 of category platform</a:t>
+              <a:t>5 of category Platform</a:t>
             </a:r>
           </a:p>
           <a:p>
@@ -35712,7 +35947,7 @@
             </a:pPr>
             <a:r>
               <a:rPr lang="en-US" noProof="0" dirty="0"/>
-              <a:t>3 of category storage</a:t>
+              <a:t>3 of category Storage</a:t>
             </a:r>
           </a:p>
           <a:p>
@@ -35803,7 +36038,7 @@
             <a:fld id="{E6639024-6672-4F87-864B-EA4FA9190A1A}" type="slidenum">
               <a:rPr lang="en-US" noProof="0" smtClean="0"/>
               <a:pPr/>
-              <a:t>24</a:t>
+              <a:t>25</a:t>
             </a:fld>
             <a:endParaRPr lang="en-US" noProof="0" dirty="0"/>
           </a:p>
@@ -35858,7 +36093,7 @@
 </p:sld>
 </file>
 
-<file path=ppt/slides/slide25.xml><?xml version="1.0" encoding="utf-8"?>
+<file path=ppt/slides/slide26.xml><?xml version="1.0" encoding="utf-8"?>
 <p:sld xmlns:a="http://schemas.openxmlformats.org/drawingml/2006/main" xmlns:r="http://schemas.openxmlformats.org/officeDocument/2006/relationships" xmlns:p="http://schemas.openxmlformats.org/presentationml/2006/main">
   <p:cSld>
     <p:spTree>
@@ -35972,7 +36207,7 @@
             </a:pPr>
             <a:r>
               <a:rPr lang="en-US" noProof="0" dirty="0"/>
-              <a:t>Favoring of storage and platform vulnerability types</a:t>
+              <a:t>Favoring of Storage and Platform vulnerability types</a:t>
             </a:r>
           </a:p>
           <a:p>
@@ -35983,7 +36218,7 @@
             </a:pPr>
             <a:r>
               <a:rPr lang="en-US" noProof="0" dirty="0"/>
-              <a:t>Lack of privacy</a:t>
+              <a:t>Lack of Privacy</a:t>
             </a:r>
           </a:p>
         </p:txBody>
@@ -36062,7 +36297,7 @@
             <a:fld id="{E6639024-6672-4F87-864B-EA4FA9190A1A}" type="slidenum">
               <a:rPr lang="en-US" noProof="0" smtClean="0"/>
               <a:pPr/>
-              <a:t>25</a:t>
+              <a:t>26</a:t>
             </a:fld>
             <a:endParaRPr lang="en-US" noProof="0" dirty="0"/>
           </a:p>
@@ -36117,7 +36352,7 @@
 </p:sld>
 </file>
 
-<file path=ppt/slides/slide26.xml><?xml version="1.0" encoding="utf-8"?>
+<file path=ppt/slides/slide27.xml><?xml version="1.0" encoding="utf-8"?>
 <p:sld xmlns:a="http://schemas.openxmlformats.org/drawingml/2006/main" xmlns:r="http://schemas.openxmlformats.org/officeDocument/2006/relationships" xmlns:p="http://schemas.openxmlformats.org/presentationml/2006/main">
   <p:cSld>
     <p:spTree>
@@ -36320,7 +36555,7 @@
             <a:fld id="{E6639024-6672-4F87-864B-EA4FA9190A1A}" type="slidenum">
               <a:rPr lang="en-US" noProof="0" smtClean="0"/>
               <a:pPr/>
-              <a:t>26</a:t>
+              <a:t>27</a:t>
             </a:fld>
             <a:endParaRPr lang="en-US" noProof="0" dirty="0"/>
           </a:p>
@@ -36375,7 +36610,7 @@
 </p:sld>
 </file>
 
-<file path=ppt/slides/slide27.xml><?xml version="1.0" encoding="utf-8"?>
+<file path=ppt/slides/slide28.xml><?xml version="1.0" encoding="utf-8"?>
 <p:sld xmlns:a="http://schemas.openxmlformats.org/drawingml/2006/main" xmlns:r="http://schemas.openxmlformats.org/officeDocument/2006/relationships" xmlns:p="http://schemas.openxmlformats.org/presentationml/2006/main">
   <p:cSld>
     <p:spTree>
@@ -36601,7 +36836,7 @@
             <a:fld id="{E6639024-6672-4F87-864B-EA4FA9190A1A}" type="slidenum">
               <a:rPr lang="en-US" noProof="0" smtClean="0"/>
               <a:pPr/>
-              <a:t>27</a:t>
+              <a:t>28</a:t>
             </a:fld>
             <a:endParaRPr lang="en-US" noProof="0" dirty="0"/>
           </a:p>
@@ -36620,7 +36855,7 @@
 </p:sld>
 </file>
 
-<file path=ppt/slides/slide28.xml><?xml version="1.0" encoding="utf-8"?>
+<file path=ppt/slides/slide29.xml><?xml version="1.0" encoding="utf-8"?>
 <p:sld xmlns:a="http://schemas.openxmlformats.org/drawingml/2006/main" xmlns:r="http://schemas.openxmlformats.org/officeDocument/2006/relationships" xmlns:p="http://schemas.openxmlformats.org/presentationml/2006/main">
   <p:cSld>
     <p:spTree>
@@ -36858,7 +37093,7 @@
             <a:fld id="{E6639024-6672-4F87-864B-EA4FA9190A1A}" type="slidenum">
               <a:rPr lang="en-US" noProof="0" smtClean="0"/>
               <a:pPr/>
-              <a:t>28</a:t>
+              <a:t>29</a:t>
             </a:fld>
             <a:endParaRPr lang="en-US" noProof="0" dirty="0"/>
           </a:p>
@@ -36868,451 +37103,6 @@
     <p:extLst>
       <p:ext uri="{BB962C8B-B14F-4D97-AF65-F5344CB8AC3E}">
         <p14:creationId xmlns:p14="http://schemas.microsoft.com/office/powerpoint/2010/main" val="1238817749"/>
-      </p:ext>
-    </p:extLst>
-  </p:cSld>
-  <p:clrMapOvr>
-    <a:masterClrMapping/>
-  </p:clrMapOvr>
-</p:sld>
-</file>
-
-<file path=ppt/slides/slide29.xml><?xml version="1.0" encoding="utf-8"?>
-<p:sld xmlns:a="http://schemas.openxmlformats.org/drawingml/2006/main" xmlns:r="http://schemas.openxmlformats.org/officeDocument/2006/relationships" xmlns:p="http://schemas.openxmlformats.org/presentationml/2006/main">
-  <p:cSld>
-    <p:spTree>
-      <p:nvGrpSpPr>
-        <p:cNvPr id="1" name="">
-          <a:extLst>
-            <a:ext uri="{FF2B5EF4-FFF2-40B4-BE49-F238E27FC236}">
-              <a16:creationId xmlns:a16="http://schemas.microsoft.com/office/drawing/2014/main" id="{FA142CDC-AE40-2043-91B5-FA9B459C8B11}"/>
-            </a:ext>
-          </a:extLst>
-        </p:cNvPr>
-        <p:cNvGrpSpPr/>
-        <p:nvPr/>
-      </p:nvGrpSpPr>
-      <p:grpSpPr>
-        <a:xfrm>
-          <a:off x="0" y="0"/>
-          <a:ext cx="0" cy="0"/>
-          <a:chOff x="0" y="0"/>
-          <a:chExt cx="0" cy="0"/>
-        </a:xfrm>
-      </p:grpSpPr>
-      <p:sp>
-        <p:nvSpPr>
-          <p:cNvPr id="8" name="Textplatzhalter 7">
-            <a:extLst>
-              <a:ext uri="{FF2B5EF4-FFF2-40B4-BE49-F238E27FC236}">
-                <a16:creationId xmlns:a16="http://schemas.microsoft.com/office/drawing/2014/main" id="{1F11FF47-86F5-05D9-C898-0FD3FB1997D0}"/>
-              </a:ext>
-            </a:extLst>
-          </p:cNvPr>
-          <p:cNvSpPr>
-            <a:spLocks noGrp="1"/>
-          </p:cNvSpPr>
-          <p:nvPr>
-            <p:ph type="body" sz="quarter" idx="12"/>
-          </p:nvPr>
-        </p:nvSpPr>
-        <p:spPr/>
-        <p:txBody>
-          <a:bodyPr/>
-          <a:lstStyle/>
-          <a:p>
-            <a:r>
-              <a:rPr lang="en-US" dirty="0"/>
-              <a:t>Modular Architecture</a:t>
-            </a:r>
-            <a:endParaRPr lang="en-US" noProof="0" dirty="0"/>
-          </a:p>
-        </p:txBody>
-      </p:sp>
-      <p:sp>
-        <p:nvSpPr>
-          <p:cNvPr id="7" name="Titel 6">
-            <a:extLst>
-              <a:ext uri="{FF2B5EF4-FFF2-40B4-BE49-F238E27FC236}">
-                <a16:creationId xmlns:a16="http://schemas.microsoft.com/office/drawing/2014/main" id="{8A743DB6-A94E-34CA-ECF4-4573D06073B7}"/>
-              </a:ext>
-            </a:extLst>
-          </p:cNvPr>
-          <p:cNvSpPr>
-            <a:spLocks noGrp="1"/>
-          </p:cNvSpPr>
-          <p:nvPr>
-            <p:ph type="title"/>
-          </p:nvPr>
-        </p:nvSpPr>
-        <p:spPr/>
-        <p:txBody>
-          <a:bodyPr/>
-          <a:lstStyle/>
-          <a:p>
-            <a:r>
-              <a:rPr lang="en-US" dirty="0"/>
-              <a:t>Designing Our Apps</a:t>
-            </a:r>
-          </a:p>
-        </p:txBody>
-      </p:sp>
-      <p:pic>
-        <p:nvPicPr>
-          <p:cNvPr id="3" name="Inhaltsplatzhalter 2" descr="Ein Bild, das Text, Screenshot, Diagramm, Rechteck enthält.&#10;&#10;KI-generierte Inhalte können fehlerhaft sein.">
-            <a:extLst>
-              <a:ext uri="{FF2B5EF4-FFF2-40B4-BE49-F238E27FC236}">
-                <a16:creationId xmlns:a16="http://schemas.microsoft.com/office/drawing/2014/main" id="{E2EE6E93-9B74-0C77-0E18-1F5A13D3A9E1}"/>
-              </a:ext>
-            </a:extLst>
-          </p:cNvPr>
-          <p:cNvPicPr>
-            <a:picLocks noGrp="1" noChangeAspect="1"/>
-          </p:cNvPicPr>
-          <p:nvPr>
-            <p:ph sz="quarter" idx="20"/>
-          </p:nvPr>
-        </p:nvPicPr>
-        <p:blipFill>
-          <a:blip r:embed="rId2">
-            <a:extLst>
-              <a:ext uri="{28A0092B-C50C-407E-A947-70E740481C1C}">
-                <a14:useLocalDpi xmlns:a14="http://schemas.microsoft.com/office/drawing/2010/main" val="0"/>
-              </a:ext>
-            </a:extLst>
-          </a:blip>
-          <a:stretch>
-            <a:fillRect/>
-          </a:stretch>
-        </p:blipFill>
-        <p:spPr>
-          <a:xfrm>
-            <a:off x="4266048" y="2159724"/>
-            <a:ext cx="4517952" cy="2335776"/>
-          </a:xfrm>
-        </p:spPr>
-      </p:pic>
-      <p:sp>
-        <p:nvSpPr>
-          <p:cNvPr id="9" name="Textplatzhalter 8">
-            <a:extLst>
-              <a:ext uri="{FF2B5EF4-FFF2-40B4-BE49-F238E27FC236}">
-                <a16:creationId xmlns:a16="http://schemas.microsoft.com/office/drawing/2014/main" id="{E8B0D81D-B41B-8882-1E7F-4DF1DAFA2BCB}"/>
-              </a:ext>
-            </a:extLst>
-          </p:cNvPr>
-          <p:cNvSpPr>
-            <a:spLocks noGrp="1"/>
-          </p:cNvSpPr>
-          <p:nvPr>
-            <p:ph type="body" sz="quarter" idx="19"/>
-          </p:nvPr>
-        </p:nvSpPr>
-        <p:spPr/>
-        <p:txBody>
-          <a:bodyPr/>
-          <a:lstStyle/>
-          <a:p>
-            <a:endParaRPr lang="en-US" noProof="0" dirty="0"/>
-          </a:p>
-        </p:txBody>
-      </p:sp>
-      <p:sp>
-        <p:nvSpPr>
-          <p:cNvPr id="11" name="Fußzeilenplatzhalter 10">
-            <a:extLst>
-              <a:ext uri="{FF2B5EF4-FFF2-40B4-BE49-F238E27FC236}">
-                <a16:creationId xmlns:a16="http://schemas.microsoft.com/office/drawing/2014/main" id="{0A18D5A3-4CB6-5CBC-5E17-9A197AE8E987}"/>
-              </a:ext>
-            </a:extLst>
-          </p:cNvPr>
-          <p:cNvSpPr>
-            <a:spLocks noGrp="1"/>
-          </p:cNvSpPr>
-          <p:nvPr>
-            <p:ph type="ftr" sz="quarter" idx="17"/>
-          </p:nvPr>
-        </p:nvSpPr>
-        <p:spPr/>
-        <p:txBody>
-          <a:bodyPr/>
-          <a:lstStyle/>
-          <a:p>
-            <a:endParaRPr lang="en-US" noProof="0" dirty="0"/>
-          </a:p>
-        </p:txBody>
-      </p:sp>
-      <p:sp>
-        <p:nvSpPr>
-          <p:cNvPr id="12" name="Foliennummernplatzhalter 11">
-            <a:extLst>
-              <a:ext uri="{FF2B5EF4-FFF2-40B4-BE49-F238E27FC236}">
-                <a16:creationId xmlns:a16="http://schemas.microsoft.com/office/drawing/2014/main" id="{AA45B65B-3FDB-635B-543E-18F97EF86399}"/>
-              </a:ext>
-            </a:extLst>
-          </p:cNvPr>
-          <p:cNvSpPr>
-            <a:spLocks noGrp="1"/>
-          </p:cNvSpPr>
-          <p:nvPr>
-            <p:ph type="sldNum" sz="quarter" idx="18"/>
-          </p:nvPr>
-        </p:nvSpPr>
-        <p:spPr/>
-        <p:txBody>
-          <a:bodyPr/>
-          <a:lstStyle/>
-          <a:p>
-            <a:fld id="{E6639024-6672-4F87-864B-EA4FA9190A1A}" type="slidenum">
-              <a:rPr lang="en-US" noProof="0" smtClean="0"/>
-              <a:pPr/>
-              <a:t>29</a:t>
-            </a:fld>
-            <a:endParaRPr lang="en-US" noProof="0" dirty="0"/>
-          </a:p>
-        </p:txBody>
-      </p:sp>
-      <p:sp>
-        <p:nvSpPr>
-          <p:cNvPr id="4" name="Inhaltsplatzhalter 9">
-            <a:extLst>
-              <a:ext uri="{FF2B5EF4-FFF2-40B4-BE49-F238E27FC236}">
-                <a16:creationId xmlns:a16="http://schemas.microsoft.com/office/drawing/2014/main" id="{19386211-C073-B58E-3A7A-CB3A32FCDB1C}"/>
-              </a:ext>
-            </a:extLst>
-          </p:cNvPr>
-          <p:cNvSpPr txBox="1">
-            <a:spLocks/>
-          </p:cNvSpPr>
-          <p:nvPr/>
-        </p:nvSpPr>
-        <p:spPr>
-          <a:xfrm>
-            <a:off x="359533" y="1203598"/>
-            <a:ext cx="8424467" cy="3332402"/>
-          </a:xfrm>
-          <a:prstGeom prst="rect">
-            <a:avLst/>
-          </a:prstGeom>
-        </p:spPr>
-        <p:txBody>
-          <a:bodyPr vert="horz" lIns="36000" tIns="36000" rIns="36000" bIns="36000" rtlCol="0" anchor="t">
-            <a:normAutofit/>
-          </a:bodyPr>
-          <a:lstStyle>
-            <a:lvl1pPr marL="216000" indent="-216000" algn="l" defTabSz="685800" rtl="0" eaLnBrk="1" latinLnBrk="0" hangingPunct="1">
-              <a:lnSpc>
-                <a:spcPct val="100000"/>
-              </a:lnSpc>
-              <a:spcBef>
-                <a:spcPts val="200"/>
-              </a:spcBef>
-              <a:buClr>
-                <a:schemeClr val="tx1"/>
-              </a:buClr>
-              <a:buFont typeface="Symbol" panose="05050102010706020507" pitchFamily="18" charset="2"/>
-              <a:buChar char="-"/>
-              <a:defRPr sz="1800" kern="1200">
-                <a:solidFill>
-                  <a:schemeClr val="tx1"/>
-                </a:solidFill>
-                <a:latin typeface="+mn-lt"/>
-                <a:ea typeface="+mn-ea"/>
-                <a:cs typeface="+mn-cs"/>
-              </a:defRPr>
-            </a:lvl1pPr>
-            <a:lvl2pPr marL="432000" indent="-216000" algn="l" defTabSz="685800" rtl="0" eaLnBrk="1" latinLnBrk="0" hangingPunct="1">
-              <a:lnSpc>
-                <a:spcPct val="100000"/>
-              </a:lnSpc>
-              <a:spcBef>
-                <a:spcPts val="200"/>
-              </a:spcBef>
-              <a:buFont typeface="Symbol" panose="05050102010706020507" pitchFamily="18" charset="2"/>
-              <a:buChar char="-"/>
-              <a:defRPr sz="1600" kern="1200">
-                <a:solidFill>
-                  <a:schemeClr val="tx1"/>
-                </a:solidFill>
-                <a:latin typeface="+mn-lt"/>
-                <a:ea typeface="+mn-ea"/>
-                <a:cs typeface="+mn-cs"/>
-              </a:defRPr>
-            </a:lvl2pPr>
-            <a:lvl3pPr marL="648000" indent="-216000" algn="l" defTabSz="685800" rtl="0" eaLnBrk="1" latinLnBrk="0" hangingPunct="1">
-              <a:lnSpc>
-                <a:spcPct val="100000"/>
-              </a:lnSpc>
-              <a:spcBef>
-                <a:spcPts val="200"/>
-              </a:spcBef>
-              <a:buFont typeface="Symbol" panose="05050102010706020507" pitchFamily="18" charset="2"/>
-              <a:buChar char="-"/>
-              <a:defRPr sz="1400" kern="1200">
-                <a:solidFill>
-                  <a:schemeClr val="tx1"/>
-                </a:solidFill>
-                <a:latin typeface="+mn-lt"/>
-                <a:ea typeface="+mn-ea"/>
-                <a:cs typeface="+mn-cs"/>
-              </a:defRPr>
-            </a:lvl3pPr>
-            <a:lvl4pPr marL="864000" indent="-216000" algn="l" defTabSz="685800" rtl="0" eaLnBrk="1" latinLnBrk="0" hangingPunct="1">
-              <a:lnSpc>
-                <a:spcPct val="100000"/>
-              </a:lnSpc>
-              <a:spcBef>
-                <a:spcPts val="200"/>
-              </a:spcBef>
-              <a:buFont typeface="Symbol" panose="05050102010706020507" pitchFamily="18" charset="2"/>
-              <a:buChar char="-"/>
-              <a:defRPr sz="1200" kern="1200">
-                <a:solidFill>
-                  <a:schemeClr val="tx1"/>
-                </a:solidFill>
-                <a:latin typeface="+mn-lt"/>
-                <a:ea typeface="+mn-ea"/>
-                <a:cs typeface="+mn-cs"/>
-              </a:defRPr>
-            </a:lvl4pPr>
-            <a:lvl5pPr marL="1080000" indent="-216000" algn="l" defTabSz="685800" rtl="0" eaLnBrk="1" latinLnBrk="0" hangingPunct="1">
-              <a:lnSpc>
-                <a:spcPct val="100000"/>
-              </a:lnSpc>
-              <a:spcBef>
-                <a:spcPts val="200"/>
-              </a:spcBef>
-              <a:buFont typeface="Symbol" panose="05050102010706020507" pitchFamily="18" charset="2"/>
-              <a:buChar char="-"/>
-              <a:defRPr sz="1100" kern="1200">
-                <a:solidFill>
-                  <a:schemeClr val="tx1"/>
-                </a:solidFill>
-                <a:latin typeface="+mn-lt"/>
-                <a:ea typeface="+mn-ea"/>
-                <a:cs typeface="+mn-cs"/>
-              </a:defRPr>
-            </a:lvl5pPr>
-            <a:lvl6pPr marL="1885950" indent="-171450" algn="l" defTabSz="685800" rtl="0" eaLnBrk="1" latinLnBrk="0" hangingPunct="1">
-              <a:lnSpc>
-                <a:spcPct val="90000"/>
-              </a:lnSpc>
-              <a:spcBef>
-                <a:spcPts val="375"/>
-              </a:spcBef>
-              <a:buFont typeface="Arial" panose="020B0604020202020204" pitchFamily="34" charset="0"/>
-              <a:buChar char="•"/>
-              <a:defRPr sz="1350" kern="1200">
-                <a:solidFill>
-                  <a:schemeClr val="tx1"/>
-                </a:solidFill>
-                <a:latin typeface="+mn-lt"/>
-                <a:ea typeface="+mn-ea"/>
-                <a:cs typeface="+mn-cs"/>
-              </a:defRPr>
-            </a:lvl6pPr>
-            <a:lvl7pPr marL="2228850" indent="-171450" algn="l" defTabSz="685800" rtl="0" eaLnBrk="1" latinLnBrk="0" hangingPunct="1">
-              <a:lnSpc>
-                <a:spcPct val="90000"/>
-              </a:lnSpc>
-              <a:spcBef>
-                <a:spcPts val="375"/>
-              </a:spcBef>
-              <a:buFont typeface="Arial" panose="020B0604020202020204" pitchFamily="34" charset="0"/>
-              <a:buChar char="•"/>
-              <a:defRPr sz="1350" kern="1200">
-                <a:solidFill>
-                  <a:schemeClr val="tx1"/>
-                </a:solidFill>
-                <a:latin typeface="+mn-lt"/>
-                <a:ea typeface="+mn-ea"/>
-                <a:cs typeface="+mn-cs"/>
-              </a:defRPr>
-            </a:lvl7pPr>
-            <a:lvl8pPr marL="2571750" indent="-171450" algn="l" defTabSz="685800" rtl="0" eaLnBrk="1" latinLnBrk="0" hangingPunct="1">
-              <a:lnSpc>
-                <a:spcPct val="90000"/>
-              </a:lnSpc>
-              <a:spcBef>
-                <a:spcPts val="375"/>
-              </a:spcBef>
-              <a:buFont typeface="Arial" panose="020B0604020202020204" pitchFamily="34" charset="0"/>
-              <a:buChar char="•"/>
-              <a:defRPr sz="1350" kern="1200">
-                <a:solidFill>
-                  <a:schemeClr val="tx1"/>
-                </a:solidFill>
-                <a:latin typeface="+mn-lt"/>
-                <a:ea typeface="+mn-ea"/>
-                <a:cs typeface="+mn-cs"/>
-              </a:defRPr>
-            </a:lvl8pPr>
-            <a:lvl9pPr marL="2914650" indent="-171450" algn="l" defTabSz="685800" rtl="0" eaLnBrk="1" latinLnBrk="0" hangingPunct="1">
-              <a:lnSpc>
-                <a:spcPct val="90000"/>
-              </a:lnSpc>
-              <a:spcBef>
-                <a:spcPts val="375"/>
-              </a:spcBef>
-              <a:buFont typeface="Arial" panose="020B0604020202020204" pitchFamily="34" charset="0"/>
-              <a:buChar char="•"/>
-              <a:defRPr sz="1350" kern="1200">
-                <a:solidFill>
-                  <a:schemeClr val="tx1"/>
-                </a:solidFill>
-                <a:latin typeface="+mn-lt"/>
-                <a:ea typeface="+mn-ea"/>
-                <a:cs typeface="+mn-cs"/>
-              </a:defRPr>
-            </a:lvl9pPr>
-          </a:lstStyle>
-          <a:p>
-            <a:pPr>
-              <a:lnSpc>
-                <a:spcPct val="150000"/>
-              </a:lnSpc>
-            </a:pPr>
-            <a:r>
-              <a:rPr lang="en-US" noProof="0" dirty="0"/>
-              <a:t>Multiple, modular apps design</a:t>
-            </a:r>
-          </a:p>
-          <a:p>
-            <a:pPr>
-              <a:lnSpc>
-                <a:spcPct val="150000"/>
-              </a:lnSpc>
-            </a:pPr>
-            <a:r>
-              <a:rPr lang="en-US" noProof="0" dirty="0"/>
-              <a:t>One app per MASVS category</a:t>
-            </a:r>
-          </a:p>
-          <a:p>
-            <a:pPr>
-              <a:lnSpc>
-                <a:spcPct val="150000"/>
-              </a:lnSpc>
-            </a:pPr>
-            <a:r>
-              <a:rPr lang="en-US" noProof="0" dirty="0"/>
-              <a:t>Shared resources in “</a:t>
-            </a:r>
-            <a:r>
-              <a:rPr lang="en-US" b="1" noProof="0" dirty="0"/>
-              <a:t>common</a:t>
-            </a:r>
-            <a:r>
-              <a:rPr lang="en-US" noProof="0" dirty="0"/>
-              <a:t>”</a:t>
-            </a:r>
-          </a:p>
-        </p:txBody>
-      </p:sp>
-    </p:spTree>
-    <p:extLst>
-      <p:ext uri="{BB962C8B-B14F-4D97-AF65-F5344CB8AC3E}">
-        <p14:creationId xmlns:p14="http://schemas.microsoft.com/office/powerpoint/2010/main" val="3008849192"/>
       </p:ext>
     </p:extLst>
   </p:cSld>
@@ -37616,7 +37406,7 @@
         <p:cNvPr id="1" name="">
           <a:extLst>
             <a:ext uri="{FF2B5EF4-FFF2-40B4-BE49-F238E27FC236}">
-              <a16:creationId xmlns:a16="http://schemas.microsoft.com/office/drawing/2014/main" id="{3343B27A-E95C-74E1-E657-A35EA9235026}"/>
+              <a16:creationId xmlns:a16="http://schemas.microsoft.com/office/drawing/2014/main" id="{FA142CDC-AE40-2043-91B5-FA9B459C8B11}"/>
             </a:ext>
           </a:extLst>
         </p:cNvPr>
@@ -37636,7 +37426,7 @@
           <p:cNvPr id="8" name="Textplatzhalter 7">
             <a:extLst>
               <a:ext uri="{FF2B5EF4-FFF2-40B4-BE49-F238E27FC236}">
-                <a16:creationId xmlns:a16="http://schemas.microsoft.com/office/drawing/2014/main" id="{99251183-A64E-C3E4-A617-E0F19B343861}"/>
+                <a16:creationId xmlns:a16="http://schemas.microsoft.com/office/drawing/2014/main" id="{1F11FF47-86F5-05D9-C898-0FD3FB1997D0}"/>
               </a:ext>
             </a:extLst>
           </p:cNvPr>
@@ -37665,7 +37455,7 @@
           <p:cNvPr id="7" name="Titel 6">
             <a:extLst>
               <a:ext uri="{FF2B5EF4-FFF2-40B4-BE49-F238E27FC236}">
-                <a16:creationId xmlns:a16="http://schemas.microsoft.com/office/drawing/2014/main" id="{206D26FC-D5D3-DCFE-69BB-EB994D68A8F6}"/>
+                <a16:creationId xmlns:a16="http://schemas.microsoft.com/office/drawing/2014/main" id="{8A743DB6-A94E-34CA-ECF4-4573D06073B7}"/>
               </a:ext>
             </a:extLst>
           </p:cNvPr>
@@ -37685,7 +37475,6 @@
               <a:rPr lang="en-US" dirty="0"/>
               <a:t>Designing Our Apps</a:t>
             </a:r>
-            <a:endParaRPr lang="en-US" noProof="0" dirty="0"/>
           </a:p>
         </p:txBody>
       </p:sp>
@@ -37694,7 +37483,7 @@
           <p:cNvPr id="3" name="Inhaltsplatzhalter 2" descr="Ein Bild, das Text, Screenshot, Diagramm, Rechteck enthält.&#10;&#10;KI-generierte Inhalte können fehlerhaft sein.">
             <a:extLst>
               <a:ext uri="{FF2B5EF4-FFF2-40B4-BE49-F238E27FC236}">
-                <a16:creationId xmlns:a16="http://schemas.microsoft.com/office/drawing/2014/main" id="{39FB0F4B-0604-48D6-5FA8-589883FE9B71}"/>
+                <a16:creationId xmlns:a16="http://schemas.microsoft.com/office/drawing/2014/main" id="{E2EE6E93-9B74-0C77-0E18-1F5A13D3A9E1}"/>
               </a:ext>
             </a:extLst>
           </p:cNvPr>
@@ -37729,6 +37518,452 @@
           <p:cNvPr id="9" name="Textplatzhalter 8">
             <a:extLst>
               <a:ext uri="{FF2B5EF4-FFF2-40B4-BE49-F238E27FC236}">
+                <a16:creationId xmlns:a16="http://schemas.microsoft.com/office/drawing/2014/main" id="{E8B0D81D-B41B-8882-1E7F-4DF1DAFA2BCB}"/>
+              </a:ext>
+            </a:extLst>
+          </p:cNvPr>
+          <p:cNvSpPr>
+            <a:spLocks noGrp="1"/>
+          </p:cNvSpPr>
+          <p:nvPr>
+            <p:ph type="body" sz="quarter" idx="19"/>
+          </p:nvPr>
+        </p:nvSpPr>
+        <p:spPr/>
+        <p:txBody>
+          <a:bodyPr/>
+          <a:lstStyle/>
+          <a:p>
+            <a:endParaRPr lang="en-US" noProof="0" dirty="0"/>
+          </a:p>
+        </p:txBody>
+      </p:sp>
+      <p:sp>
+        <p:nvSpPr>
+          <p:cNvPr id="11" name="Fußzeilenplatzhalter 10">
+            <a:extLst>
+              <a:ext uri="{FF2B5EF4-FFF2-40B4-BE49-F238E27FC236}">
+                <a16:creationId xmlns:a16="http://schemas.microsoft.com/office/drawing/2014/main" id="{0A18D5A3-4CB6-5CBC-5E17-9A197AE8E987}"/>
+              </a:ext>
+            </a:extLst>
+          </p:cNvPr>
+          <p:cNvSpPr>
+            <a:spLocks noGrp="1"/>
+          </p:cNvSpPr>
+          <p:nvPr>
+            <p:ph type="ftr" sz="quarter" idx="17"/>
+          </p:nvPr>
+        </p:nvSpPr>
+        <p:spPr/>
+        <p:txBody>
+          <a:bodyPr/>
+          <a:lstStyle/>
+          <a:p>
+            <a:endParaRPr lang="en-US" noProof="0" dirty="0"/>
+          </a:p>
+        </p:txBody>
+      </p:sp>
+      <p:sp>
+        <p:nvSpPr>
+          <p:cNvPr id="12" name="Foliennummernplatzhalter 11">
+            <a:extLst>
+              <a:ext uri="{FF2B5EF4-FFF2-40B4-BE49-F238E27FC236}">
+                <a16:creationId xmlns:a16="http://schemas.microsoft.com/office/drawing/2014/main" id="{AA45B65B-3FDB-635B-543E-18F97EF86399}"/>
+              </a:ext>
+            </a:extLst>
+          </p:cNvPr>
+          <p:cNvSpPr>
+            <a:spLocks noGrp="1"/>
+          </p:cNvSpPr>
+          <p:nvPr>
+            <p:ph type="sldNum" sz="quarter" idx="18"/>
+          </p:nvPr>
+        </p:nvSpPr>
+        <p:spPr/>
+        <p:txBody>
+          <a:bodyPr/>
+          <a:lstStyle/>
+          <a:p>
+            <a:fld id="{E6639024-6672-4F87-864B-EA4FA9190A1A}" type="slidenum">
+              <a:rPr lang="en-US" noProof="0" smtClean="0"/>
+              <a:pPr/>
+              <a:t>30</a:t>
+            </a:fld>
+            <a:endParaRPr lang="en-US" noProof="0" dirty="0"/>
+          </a:p>
+        </p:txBody>
+      </p:sp>
+      <p:sp>
+        <p:nvSpPr>
+          <p:cNvPr id="4" name="Inhaltsplatzhalter 9">
+            <a:extLst>
+              <a:ext uri="{FF2B5EF4-FFF2-40B4-BE49-F238E27FC236}">
+                <a16:creationId xmlns:a16="http://schemas.microsoft.com/office/drawing/2014/main" id="{19386211-C073-B58E-3A7A-CB3A32FCDB1C}"/>
+              </a:ext>
+            </a:extLst>
+          </p:cNvPr>
+          <p:cNvSpPr txBox="1">
+            <a:spLocks/>
+          </p:cNvSpPr>
+          <p:nvPr/>
+        </p:nvSpPr>
+        <p:spPr>
+          <a:xfrm>
+            <a:off x="359533" y="1203598"/>
+            <a:ext cx="8424467" cy="3332402"/>
+          </a:xfrm>
+          <a:prstGeom prst="rect">
+            <a:avLst/>
+          </a:prstGeom>
+        </p:spPr>
+        <p:txBody>
+          <a:bodyPr vert="horz" lIns="36000" tIns="36000" rIns="36000" bIns="36000" rtlCol="0" anchor="t">
+            <a:normAutofit/>
+          </a:bodyPr>
+          <a:lstStyle>
+            <a:lvl1pPr marL="216000" indent="-216000" algn="l" defTabSz="685800" rtl="0" eaLnBrk="1" latinLnBrk="0" hangingPunct="1">
+              <a:lnSpc>
+                <a:spcPct val="100000"/>
+              </a:lnSpc>
+              <a:spcBef>
+                <a:spcPts val="200"/>
+              </a:spcBef>
+              <a:buClr>
+                <a:schemeClr val="tx1"/>
+              </a:buClr>
+              <a:buFont typeface="Symbol" panose="05050102010706020507" pitchFamily="18" charset="2"/>
+              <a:buChar char="-"/>
+              <a:defRPr sz="1800" kern="1200">
+                <a:solidFill>
+                  <a:schemeClr val="tx1"/>
+                </a:solidFill>
+                <a:latin typeface="+mn-lt"/>
+                <a:ea typeface="+mn-ea"/>
+                <a:cs typeface="+mn-cs"/>
+              </a:defRPr>
+            </a:lvl1pPr>
+            <a:lvl2pPr marL="432000" indent="-216000" algn="l" defTabSz="685800" rtl="0" eaLnBrk="1" latinLnBrk="0" hangingPunct="1">
+              <a:lnSpc>
+                <a:spcPct val="100000"/>
+              </a:lnSpc>
+              <a:spcBef>
+                <a:spcPts val="200"/>
+              </a:spcBef>
+              <a:buFont typeface="Symbol" panose="05050102010706020507" pitchFamily="18" charset="2"/>
+              <a:buChar char="-"/>
+              <a:defRPr sz="1600" kern="1200">
+                <a:solidFill>
+                  <a:schemeClr val="tx1"/>
+                </a:solidFill>
+                <a:latin typeface="+mn-lt"/>
+                <a:ea typeface="+mn-ea"/>
+                <a:cs typeface="+mn-cs"/>
+              </a:defRPr>
+            </a:lvl2pPr>
+            <a:lvl3pPr marL="648000" indent="-216000" algn="l" defTabSz="685800" rtl="0" eaLnBrk="1" latinLnBrk="0" hangingPunct="1">
+              <a:lnSpc>
+                <a:spcPct val="100000"/>
+              </a:lnSpc>
+              <a:spcBef>
+                <a:spcPts val="200"/>
+              </a:spcBef>
+              <a:buFont typeface="Symbol" panose="05050102010706020507" pitchFamily="18" charset="2"/>
+              <a:buChar char="-"/>
+              <a:defRPr sz="1400" kern="1200">
+                <a:solidFill>
+                  <a:schemeClr val="tx1"/>
+                </a:solidFill>
+                <a:latin typeface="+mn-lt"/>
+                <a:ea typeface="+mn-ea"/>
+                <a:cs typeface="+mn-cs"/>
+              </a:defRPr>
+            </a:lvl3pPr>
+            <a:lvl4pPr marL="864000" indent="-216000" algn="l" defTabSz="685800" rtl="0" eaLnBrk="1" latinLnBrk="0" hangingPunct="1">
+              <a:lnSpc>
+                <a:spcPct val="100000"/>
+              </a:lnSpc>
+              <a:spcBef>
+                <a:spcPts val="200"/>
+              </a:spcBef>
+              <a:buFont typeface="Symbol" panose="05050102010706020507" pitchFamily="18" charset="2"/>
+              <a:buChar char="-"/>
+              <a:defRPr sz="1200" kern="1200">
+                <a:solidFill>
+                  <a:schemeClr val="tx1"/>
+                </a:solidFill>
+                <a:latin typeface="+mn-lt"/>
+                <a:ea typeface="+mn-ea"/>
+                <a:cs typeface="+mn-cs"/>
+              </a:defRPr>
+            </a:lvl4pPr>
+            <a:lvl5pPr marL="1080000" indent="-216000" algn="l" defTabSz="685800" rtl="0" eaLnBrk="1" latinLnBrk="0" hangingPunct="1">
+              <a:lnSpc>
+                <a:spcPct val="100000"/>
+              </a:lnSpc>
+              <a:spcBef>
+                <a:spcPts val="200"/>
+              </a:spcBef>
+              <a:buFont typeface="Symbol" panose="05050102010706020507" pitchFamily="18" charset="2"/>
+              <a:buChar char="-"/>
+              <a:defRPr sz="1100" kern="1200">
+                <a:solidFill>
+                  <a:schemeClr val="tx1"/>
+                </a:solidFill>
+                <a:latin typeface="+mn-lt"/>
+                <a:ea typeface="+mn-ea"/>
+                <a:cs typeface="+mn-cs"/>
+              </a:defRPr>
+            </a:lvl5pPr>
+            <a:lvl6pPr marL="1885950" indent="-171450" algn="l" defTabSz="685800" rtl="0" eaLnBrk="1" latinLnBrk="0" hangingPunct="1">
+              <a:lnSpc>
+                <a:spcPct val="90000"/>
+              </a:lnSpc>
+              <a:spcBef>
+                <a:spcPts val="375"/>
+              </a:spcBef>
+              <a:buFont typeface="Arial" panose="020B0604020202020204" pitchFamily="34" charset="0"/>
+              <a:buChar char="•"/>
+              <a:defRPr sz="1350" kern="1200">
+                <a:solidFill>
+                  <a:schemeClr val="tx1"/>
+                </a:solidFill>
+                <a:latin typeface="+mn-lt"/>
+                <a:ea typeface="+mn-ea"/>
+                <a:cs typeface="+mn-cs"/>
+              </a:defRPr>
+            </a:lvl6pPr>
+            <a:lvl7pPr marL="2228850" indent="-171450" algn="l" defTabSz="685800" rtl="0" eaLnBrk="1" latinLnBrk="0" hangingPunct="1">
+              <a:lnSpc>
+                <a:spcPct val="90000"/>
+              </a:lnSpc>
+              <a:spcBef>
+                <a:spcPts val="375"/>
+              </a:spcBef>
+              <a:buFont typeface="Arial" panose="020B0604020202020204" pitchFamily="34" charset="0"/>
+              <a:buChar char="•"/>
+              <a:defRPr sz="1350" kern="1200">
+                <a:solidFill>
+                  <a:schemeClr val="tx1"/>
+                </a:solidFill>
+                <a:latin typeface="+mn-lt"/>
+                <a:ea typeface="+mn-ea"/>
+                <a:cs typeface="+mn-cs"/>
+              </a:defRPr>
+            </a:lvl7pPr>
+            <a:lvl8pPr marL="2571750" indent="-171450" algn="l" defTabSz="685800" rtl="0" eaLnBrk="1" latinLnBrk="0" hangingPunct="1">
+              <a:lnSpc>
+                <a:spcPct val="90000"/>
+              </a:lnSpc>
+              <a:spcBef>
+                <a:spcPts val="375"/>
+              </a:spcBef>
+              <a:buFont typeface="Arial" panose="020B0604020202020204" pitchFamily="34" charset="0"/>
+              <a:buChar char="•"/>
+              <a:defRPr sz="1350" kern="1200">
+                <a:solidFill>
+                  <a:schemeClr val="tx1"/>
+                </a:solidFill>
+                <a:latin typeface="+mn-lt"/>
+                <a:ea typeface="+mn-ea"/>
+                <a:cs typeface="+mn-cs"/>
+              </a:defRPr>
+            </a:lvl8pPr>
+            <a:lvl9pPr marL="2914650" indent="-171450" algn="l" defTabSz="685800" rtl="0" eaLnBrk="1" latinLnBrk="0" hangingPunct="1">
+              <a:lnSpc>
+                <a:spcPct val="90000"/>
+              </a:lnSpc>
+              <a:spcBef>
+                <a:spcPts val="375"/>
+              </a:spcBef>
+              <a:buFont typeface="Arial" panose="020B0604020202020204" pitchFamily="34" charset="0"/>
+              <a:buChar char="•"/>
+              <a:defRPr sz="1350" kern="1200">
+                <a:solidFill>
+                  <a:schemeClr val="tx1"/>
+                </a:solidFill>
+                <a:latin typeface="+mn-lt"/>
+                <a:ea typeface="+mn-ea"/>
+                <a:cs typeface="+mn-cs"/>
+              </a:defRPr>
+            </a:lvl9pPr>
+          </a:lstStyle>
+          <a:p>
+            <a:pPr>
+              <a:lnSpc>
+                <a:spcPct val="150000"/>
+              </a:lnSpc>
+            </a:pPr>
+            <a:r>
+              <a:rPr lang="en-US" noProof="0" dirty="0"/>
+              <a:t>Multiple, modular apps design</a:t>
+            </a:r>
+          </a:p>
+          <a:p>
+            <a:pPr>
+              <a:lnSpc>
+                <a:spcPct val="150000"/>
+              </a:lnSpc>
+            </a:pPr>
+            <a:r>
+              <a:rPr lang="en-US" noProof="0" dirty="0"/>
+              <a:t>One app per MASVS category</a:t>
+            </a:r>
+          </a:p>
+          <a:p>
+            <a:pPr>
+              <a:lnSpc>
+                <a:spcPct val="150000"/>
+              </a:lnSpc>
+            </a:pPr>
+            <a:r>
+              <a:rPr lang="en-US" noProof="0" dirty="0"/>
+              <a:t>Shared resources in “</a:t>
+            </a:r>
+            <a:r>
+              <a:rPr lang="en-US" b="1" noProof="0" dirty="0"/>
+              <a:t>common</a:t>
+            </a:r>
+            <a:r>
+              <a:rPr lang="en-US" noProof="0" dirty="0"/>
+              <a:t>”</a:t>
+            </a:r>
+          </a:p>
+        </p:txBody>
+      </p:sp>
+    </p:spTree>
+    <p:extLst>
+      <p:ext uri="{BB962C8B-B14F-4D97-AF65-F5344CB8AC3E}">
+        <p14:creationId xmlns:p14="http://schemas.microsoft.com/office/powerpoint/2010/main" val="3008849192"/>
+      </p:ext>
+    </p:extLst>
+  </p:cSld>
+  <p:clrMapOvr>
+    <a:masterClrMapping/>
+  </p:clrMapOvr>
+</p:sld>
+</file>
+
+<file path=ppt/slides/slide31.xml><?xml version="1.0" encoding="utf-8"?>
+<p:sld xmlns:a="http://schemas.openxmlformats.org/drawingml/2006/main" xmlns:r="http://schemas.openxmlformats.org/officeDocument/2006/relationships" xmlns:p="http://schemas.openxmlformats.org/presentationml/2006/main">
+  <p:cSld>
+    <p:spTree>
+      <p:nvGrpSpPr>
+        <p:cNvPr id="1" name="">
+          <a:extLst>
+            <a:ext uri="{FF2B5EF4-FFF2-40B4-BE49-F238E27FC236}">
+              <a16:creationId xmlns:a16="http://schemas.microsoft.com/office/drawing/2014/main" id="{3343B27A-E95C-74E1-E657-A35EA9235026}"/>
+            </a:ext>
+          </a:extLst>
+        </p:cNvPr>
+        <p:cNvGrpSpPr/>
+        <p:nvPr/>
+      </p:nvGrpSpPr>
+      <p:grpSpPr>
+        <a:xfrm>
+          <a:off x="0" y="0"/>
+          <a:ext cx="0" cy="0"/>
+          <a:chOff x="0" y="0"/>
+          <a:chExt cx="0" cy="0"/>
+        </a:xfrm>
+      </p:grpSpPr>
+      <p:sp>
+        <p:nvSpPr>
+          <p:cNvPr id="8" name="Textplatzhalter 7">
+            <a:extLst>
+              <a:ext uri="{FF2B5EF4-FFF2-40B4-BE49-F238E27FC236}">
+                <a16:creationId xmlns:a16="http://schemas.microsoft.com/office/drawing/2014/main" id="{99251183-A64E-C3E4-A617-E0F19B343861}"/>
+              </a:ext>
+            </a:extLst>
+          </p:cNvPr>
+          <p:cNvSpPr>
+            <a:spLocks noGrp="1"/>
+          </p:cNvSpPr>
+          <p:nvPr>
+            <p:ph type="body" sz="quarter" idx="12"/>
+          </p:nvPr>
+        </p:nvSpPr>
+        <p:spPr/>
+        <p:txBody>
+          <a:bodyPr/>
+          <a:lstStyle/>
+          <a:p>
+            <a:r>
+              <a:rPr lang="en-US" dirty="0"/>
+              <a:t>Modular Architecture</a:t>
+            </a:r>
+            <a:endParaRPr lang="en-US" noProof="0" dirty="0"/>
+          </a:p>
+        </p:txBody>
+      </p:sp>
+      <p:sp>
+        <p:nvSpPr>
+          <p:cNvPr id="7" name="Titel 6">
+            <a:extLst>
+              <a:ext uri="{FF2B5EF4-FFF2-40B4-BE49-F238E27FC236}">
+                <a16:creationId xmlns:a16="http://schemas.microsoft.com/office/drawing/2014/main" id="{206D26FC-D5D3-DCFE-69BB-EB994D68A8F6}"/>
+              </a:ext>
+            </a:extLst>
+          </p:cNvPr>
+          <p:cNvSpPr>
+            <a:spLocks noGrp="1"/>
+          </p:cNvSpPr>
+          <p:nvPr>
+            <p:ph type="title"/>
+          </p:nvPr>
+        </p:nvSpPr>
+        <p:spPr/>
+        <p:txBody>
+          <a:bodyPr/>
+          <a:lstStyle/>
+          <a:p>
+            <a:r>
+              <a:rPr lang="en-US" dirty="0"/>
+              <a:t>Designing Our Apps</a:t>
+            </a:r>
+            <a:endParaRPr lang="en-US" noProof="0" dirty="0"/>
+          </a:p>
+        </p:txBody>
+      </p:sp>
+      <p:pic>
+        <p:nvPicPr>
+          <p:cNvPr id="3" name="Inhaltsplatzhalter 2" descr="Ein Bild, das Text, Screenshot, Diagramm, Rechteck enthält.&#10;&#10;KI-generierte Inhalte können fehlerhaft sein.">
+            <a:extLst>
+              <a:ext uri="{FF2B5EF4-FFF2-40B4-BE49-F238E27FC236}">
+                <a16:creationId xmlns:a16="http://schemas.microsoft.com/office/drawing/2014/main" id="{39FB0F4B-0604-48D6-5FA8-589883FE9B71}"/>
+              </a:ext>
+            </a:extLst>
+          </p:cNvPr>
+          <p:cNvPicPr>
+            <a:picLocks noGrp="1" noChangeAspect="1"/>
+          </p:cNvPicPr>
+          <p:nvPr>
+            <p:ph sz="quarter" idx="20"/>
+          </p:nvPr>
+        </p:nvPicPr>
+        <p:blipFill>
+          <a:blip r:embed="rId2">
+            <a:extLst>
+              <a:ext uri="{28A0092B-C50C-407E-A947-70E740481C1C}">
+                <a14:useLocalDpi xmlns:a14="http://schemas.microsoft.com/office/drawing/2010/main" val="0"/>
+              </a:ext>
+            </a:extLst>
+          </a:blip>
+          <a:stretch>
+            <a:fillRect/>
+          </a:stretch>
+        </p:blipFill>
+        <p:spPr>
+          <a:xfrm>
+            <a:off x="4266048" y="2159724"/>
+            <a:ext cx="4517952" cy="2335776"/>
+          </a:xfrm>
+        </p:spPr>
+      </p:pic>
+      <p:sp>
+        <p:nvSpPr>
+          <p:cNvPr id="9" name="Textplatzhalter 8">
+            <a:extLst>
+              <a:ext uri="{FF2B5EF4-FFF2-40B4-BE49-F238E27FC236}">
                 <a16:creationId xmlns:a16="http://schemas.microsoft.com/office/drawing/2014/main" id="{51DAD757-48CD-E760-F582-E81A85AB06CD}"/>
               </a:ext>
             </a:extLst>
@@ -37798,7 +38033,7 @@
             <a:fld id="{E6639024-6672-4F87-864B-EA4FA9190A1A}" type="slidenum">
               <a:rPr lang="en-US" noProof="0" smtClean="0"/>
               <a:pPr/>
-              <a:t>30</a:t>
+              <a:t>31</a:t>
             </a:fld>
             <a:endParaRPr lang="en-US" noProof="0" dirty="0"/>
           </a:p>
@@ -38081,7 +38316,7 @@
 </p:sld>
 </file>
 
-<file path=ppt/slides/slide31.xml><?xml version="1.0" encoding="utf-8"?>
+<file path=ppt/slides/slide32.xml><?xml version="1.0" encoding="utf-8"?>
 <p:sld xmlns:a="http://schemas.openxmlformats.org/drawingml/2006/main" xmlns:r="http://schemas.openxmlformats.org/officeDocument/2006/relationships" xmlns:p="http://schemas.openxmlformats.org/presentationml/2006/main">
   <p:cSld>
     <p:spTree>
@@ -38236,7 +38471,7 @@
             <a:fld id="{E6639024-6672-4F87-864B-EA4FA9190A1A}" type="slidenum">
               <a:rPr lang="en-US" noProof="0" smtClean="0"/>
               <a:pPr/>
-              <a:t>31</a:t>
+              <a:t>32</a:t>
             </a:fld>
             <a:endParaRPr lang="en-US" noProof="0" dirty="0"/>
           </a:p>
@@ -38520,7 +38755,7 @@
 </p:sld>
 </file>
 
-<file path=ppt/slides/slide32.xml><?xml version="1.0" encoding="utf-8"?>
+<file path=ppt/slides/slide33.xml><?xml version="1.0" encoding="utf-8"?>
 <p:sld xmlns:a="http://schemas.openxmlformats.org/drawingml/2006/main" xmlns:r="http://schemas.openxmlformats.org/officeDocument/2006/relationships" xmlns:p="http://schemas.openxmlformats.org/presentationml/2006/main">
   <p:cSld>
     <p:spTree>
@@ -38675,7 +38910,7 @@
             <a:fld id="{E6639024-6672-4F87-864B-EA4FA9190A1A}" type="slidenum">
               <a:rPr lang="en-US" noProof="0" smtClean="0"/>
               <a:pPr/>
-              <a:t>32</a:t>
+              <a:t>33</a:t>
             </a:fld>
             <a:endParaRPr lang="en-US" noProof="0" dirty="0"/>
           </a:p>
@@ -38982,7 +39217,7 @@
 </p:sld>
 </file>
 
-<file path=ppt/slides/slide33.xml><?xml version="1.0" encoding="utf-8"?>
+<file path=ppt/slides/slide34.xml><?xml version="1.0" encoding="utf-8"?>
 <p:sld xmlns:a="http://schemas.openxmlformats.org/drawingml/2006/main" xmlns:r="http://schemas.openxmlformats.org/officeDocument/2006/relationships" xmlns:p="http://schemas.openxmlformats.org/presentationml/2006/main">
   <p:cSld>
     <p:spTree>
@@ -39137,7 +39372,7 @@
             <a:fld id="{E6639024-6672-4F87-864B-EA4FA9190A1A}" type="slidenum">
               <a:rPr lang="en-US" noProof="0" smtClean="0"/>
               <a:pPr/>
-              <a:t>33</a:t>
+              <a:t>34</a:t>
             </a:fld>
             <a:endParaRPr lang="en-US" noProof="0" dirty="0"/>
           </a:p>
@@ -39434,7 +39669,7 @@
 </p:sld>
 </file>
 
-<file path=ppt/slides/slide34.xml><?xml version="1.0" encoding="utf-8"?>
+<file path=ppt/slides/slide35.xml><?xml version="1.0" encoding="utf-8"?>
 <p:sld xmlns:a="http://schemas.openxmlformats.org/drawingml/2006/main" xmlns:r="http://schemas.openxmlformats.org/officeDocument/2006/relationships" xmlns:p="http://schemas.openxmlformats.org/presentationml/2006/main">
   <p:cSld>
     <p:spTree>
@@ -39589,7 +39824,7 @@
             <a:fld id="{E6639024-6672-4F87-864B-EA4FA9190A1A}" type="slidenum">
               <a:rPr lang="en-US" noProof="0" smtClean="0"/>
               <a:pPr/>
-              <a:t>34</a:t>
+              <a:t>35</a:t>
             </a:fld>
             <a:endParaRPr lang="en-US" noProof="0" dirty="0"/>
           </a:p>
@@ -39885,919 +40120,7 @@
 </p:sld>
 </file>
 
-<file path=ppt/slides/slide35.xml><?xml version="1.0" encoding="utf-8"?>
-<p:sld xmlns:a="http://schemas.openxmlformats.org/drawingml/2006/main" xmlns:r="http://schemas.openxmlformats.org/officeDocument/2006/relationships" xmlns:p="http://schemas.openxmlformats.org/presentationml/2006/main">
-  <p:cSld>
-    <p:spTree>
-      <p:nvGrpSpPr>
-        <p:cNvPr id="1" name="">
-          <a:extLst>
-            <a:ext uri="{FF2B5EF4-FFF2-40B4-BE49-F238E27FC236}">
-              <a16:creationId xmlns:a16="http://schemas.microsoft.com/office/drawing/2014/main" id="{33EE2DA2-E7DA-E0CB-91A3-BBCC1142F5C8}"/>
-            </a:ext>
-          </a:extLst>
-        </p:cNvPr>
-        <p:cNvGrpSpPr/>
-        <p:nvPr/>
-      </p:nvGrpSpPr>
-      <p:grpSpPr>
-        <a:xfrm>
-          <a:off x="0" y="0"/>
-          <a:ext cx="0" cy="0"/>
-          <a:chOff x="0" y="0"/>
-          <a:chExt cx="0" cy="0"/>
-        </a:xfrm>
-      </p:grpSpPr>
-      <p:sp>
-        <p:nvSpPr>
-          <p:cNvPr id="8" name="Textplatzhalter 7">
-            <a:extLst>
-              <a:ext uri="{FF2B5EF4-FFF2-40B4-BE49-F238E27FC236}">
-                <a16:creationId xmlns:a16="http://schemas.microsoft.com/office/drawing/2014/main" id="{6B69A41C-5269-C908-DF01-8D43FD41E56B}"/>
-              </a:ext>
-            </a:extLst>
-          </p:cNvPr>
-          <p:cNvSpPr>
-            <a:spLocks noGrp="1"/>
-          </p:cNvSpPr>
-          <p:nvPr>
-            <p:ph type="body" sz="quarter" idx="12"/>
-          </p:nvPr>
-        </p:nvSpPr>
-        <p:spPr/>
-        <p:txBody>
-          <a:bodyPr/>
-          <a:lstStyle/>
-          <a:p>
-            <a:r>
-              <a:rPr lang="en-US" dirty="0"/>
-              <a:t>Abstract Templates</a:t>
-            </a:r>
-            <a:endParaRPr lang="en-US" noProof="0" dirty="0"/>
-          </a:p>
-        </p:txBody>
-      </p:sp>
-      <p:sp>
-        <p:nvSpPr>
-          <p:cNvPr id="7" name="Titel 6">
-            <a:extLst>
-              <a:ext uri="{FF2B5EF4-FFF2-40B4-BE49-F238E27FC236}">
-                <a16:creationId xmlns:a16="http://schemas.microsoft.com/office/drawing/2014/main" id="{E717848F-6DA8-AF9E-8A4E-B69EDC9693B7}"/>
-              </a:ext>
-            </a:extLst>
-          </p:cNvPr>
-          <p:cNvSpPr>
-            <a:spLocks noGrp="1"/>
-          </p:cNvSpPr>
-          <p:nvPr>
-            <p:ph type="title"/>
-          </p:nvPr>
-        </p:nvSpPr>
-        <p:spPr/>
-        <p:txBody>
-          <a:bodyPr/>
-          <a:lstStyle/>
-          <a:p>
-            <a:r>
-              <a:rPr lang="en-US" dirty="0"/>
-              <a:t>Designing Our Apps</a:t>
-            </a:r>
-            <a:endParaRPr lang="en-US" noProof="0" dirty="0"/>
-          </a:p>
-        </p:txBody>
-      </p:sp>
-      <p:sp>
-        <p:nvSpPr>
-          <p:cNvPr id="9" name="Textplatzhalter 8">
-            <a:extLst>
-              <a:ext uri="{FF2B5EF4-FFF2-40B4-BE49-F238E27FC236}">
-                <a16:creationId xmlns:a16="http://schemas.microsoft.com/office/drawing/2014/main" id="{312011C8-D2DB-1D12-EEAA-FA05806642CE}"/>
-              </a:ext>
-            </a:extLst>
-          </p:cNvPr>
-          <p:cNvSpPr>
-            <a:spLocks noGrp="1"/>
-          </p:cNvSpPr>
-          <p:nvPr>
-            <p:ph type="body" sz="quarter" idx="19"/>
-          </p:nvPr>
-        </p:nvSpPr>
-        <p:spPr/>
-        <p:txBody>
-          <a:bodyPr/>
-          <a:lstStyle/>
-          <a:p>
-            <a:endParaRPr lang="en-US" noProof="0" dirty="0"/>
-          </a:p>
-        </p:txBody>
-      </p:sp>
-      <p:sp>
-        <p:nvSpPr>
-          <p:cNvPr id="11" name="Fußzeilenplatzhalter 10">
-            <a:extLst>
-              <a:ext uri="{FF2B5EF4-FFF2-40B4-BE49-F238E27FC236}">
-                <a16:creationId xmlns:a16="http://schemas.microsoft.com/office/drawing/2014/main" id="{9E3B69F2-6A45-E2DD-4729-4DAD9BE32D49}"/>
-              </a:ext>
-            </a:extLst>
-          </p:cNvPr>
-          <p:cNvSpPr>
-            <a:spLocks noGrp="1"/>
-          </p:cNvSpPr>
-          <p:nvPr>
-            <p:ph type="ftr" sz="quarter" idx="17"/>
-          </p:nvPr>
-        </p:nvSpPr>
-        <p:spPr/>
-        <p:txBody>
-          <a:bodyPr/>
-          <a:lstStyle/>
-          <a:p>
-            <a:endParaRPr lang="en-US" noProof="0" dirty="0"/>
-          </a:p>
-        </p:txBody>
-      </p:sp>
-      <p:sp>
-        <p:nvSpPr>
-          <p:cNvPr id="12" name="Foliennummernplatzhalter 11">
-            <a:extLst>
-              <a:ext uri="{FF2B5EF4-FFF2-40B4-BE49-F238E27FC236}">
-                <a16:creationId xmlns:a16="http://schemas.microsoft.com/office/drawing/2014/main" id="{193A4457-A35A-24A9-56B9-A12B8A0AAC52}"/>
-              </a:ext>
-            </a:extLst>
-          </p:cNvPr>
-          <p:cNvSpPr>
-            <a:spLocks noGrp="1"/>
-          </p:cNvSpPr>
-          <p:nvPr>
-            <p:ph type="sldNum" sz="quarter" idx="18"/>
-          </p:nvPr>
-        </p:nvSpPr>
-        <p:spPr/>
-        <p:txBody>
-          <a:bodyPr/>
-          <a:lstStyle/>
-          <a:p>
-            <a:fld id="{E6639024-6672-4F87-864B-EA4FA9190A1A}" type="slidenum">
-              <a:rPr lang="en-US" noProof="0" smtClean="0"/>
-              <a:pPr/>
-              <a:t>35</a:t>
-            </a:fld>
-            <a:endParaRPr lang="en-US" noProof="0" dirty="0"/>
-          </a:p>
-        </p:txBody>
-      </p:sp>
-      <p:sp>
-        <p:nvSpPr>
-          <p:cNvPr id="4" name="Inhaltsplatzhalter 9">
-            <a:extLst>
-              <a:ext uri="{FF2B5EF4-FFF2-40B4-BE49-F238E27FC236}">
-                <a16:creationId xmlns:a16="http://schemas.microsoft.com/office/drawing/2014/main" id="{E08FBE29-0A9B-2136-FE95-547CD4A4F357}"/>
-              </a:ext>
-            </a:extLst>
-          </p:cNvPr>
-          <p:cNvSpPr txBox="1">
-            <a:spLocks/>
-          </p:cNvSpPr>
-          <p:nvPr/>
-        </p:nvSpPr>
-        <p:spPr>
-          <a:xfrm>
-            <a:off x="359533" y="1203598"/>
-            <a:ext cx="8424467" cy="3332402"/>
-          </a:xfrm>
-          <a:prstGeom prst="rect">
-            <a:avLst/>
-          </a:prstGeom>
-        </p:spPr>
-        <p:txBody>
-          <a:bodyPr vert="horz" lIns="36000" tIns="36000" rIns="36000" bIns="36000" rtlCol="0" anchor="t">
-            <a:normAutofit/>
-          </a:bodyPr>
-          <a:lstStyle>
-            <a:lvl1pPr marL="216000" indent="-216000" algn="l" defTabSz="685800" rtl="0" eaLnBrk="1" latinLnBrk="0" hangingPunct="1">
-              <a:lnSpc>
-                <a:spcPct val="100000"/>
-              </a:lnSpc>
-              <a:spcBef>
-                <a:spcPts val="200"/>
-              </a:spcBef>
-              <a:buClr>
-                <a:schemeClr val="tx1"/>
-              </a:buClr>
-              <a:buFont typeface="Symbol" panose="05050102010706020507" pitchFamily="18" charset="2"/>
-              <a:buChar char="-"/>
-              <a:defRPr sz="1800" kern="1200">
-                <a:solidFill>
-                  <a:schemeClr val="tx1"/>
-                </a:solidFill>
-                <a:latin typeface="+mn-lt"/>
-                <a:ea typeface="+mn-ea"/>
-                <a:cs typeface="+mn-cs"/>
-              </a:defRPr>
-            </a:lvl1pPr>
-            <a:lvl2pPr marL="432000" indent="-216000" algn="l" defTabSz="685800" rtl="0" eaLnBrk="1" latinLnBrk="0" hangingPunct="1">
-              <a:lnSpc>
-                <a:spcPct val="100000"/>
-              </a:lnSpc>
-              <a:spcBef>
-                <a:spcPts val="200"/>
-              </a:spcBef>
-              <a:buFont typeface="Symbol" panose="05050102010706020507" pitchFamily="18" charset="2"/>
-              <a:buChar char="-"/>
-              <a:defRPr sz="1600" kern="1200">
-                <a:solidFill>
-                  <a:schemeClr val="tx1"/>
-                </a:solidFill>
-                <a:latin typeface="+mn-lt"/>
-                <a:ea typeface="+mn-ea"/>
-                <a:cs typeface="+mn-cs"/>
-              </a:defRPr>
-            </a:lvl2pPr>
-            <a:lvl3pPr marL="648000" indent="-216000" algn="l" defTabSz="685800" rtl="0" eaLnBrk="1" latinLnBrk="0" hangingPunct="1">
-              <a:lnSpc>
-                <a:spcPct val="100000"/>
-              </a:lnSpc>
-              <a:spcBef>
-                <a:spcPts val="200"/>
-              </a:spcBef>
-              <a:buFont typeface="Symbol" panose="05050102010706020507" pitchFamily="18" charset="2"/>
-              <a:buChar char="-"/>
-              <a:defRPr sz="1400" kern="1200">
-                <a:solidFill>
-                  <a:schemeClr val="tx1"/>
-                </a:solidFill>
-                <a:latin typeface="+mn-lt"/>
-                <a:ea typeface="+mn-ea"/>
-                <a:cs typeface="+mn-cs"/>
-              </a:defRPr>
-            </a:lvl3pPr>
-            <a:lvl4pPr marL="864000" indent="-216000" algn="l" defTabSz="685800" rtl="0" eaLnBrk="1" latinLnBrk="0" hangingPunct="1">
-              <a:lnSpc>
-                <a:spcPct val="100000"/>
-              </a:lnSpc>
-              <a:spcBef>
-                <a:spcPts val="200"/>
-              </a:spcBef>
-              <a:buFont typeface="Symbol" panose="05050102010706020507" pitchFamily="18" charset="2"/>
-              <a:buChar char="-"/>
-              <a:defRPr sz="1200" kern="1200">
-                <a:solidFill>
-                  <a:schemeClr val="tx1"/>
-                </a:solidFill>
-                <a:latin typeface="+mn-lt"/>
-                <a:ea typeface="+mn-ea"/>
-                <a:cs typeface="+mn-cs"/>
-              </a:defRPr>
-            </a:lvl4pPr>
-            <a:lvl5pPr marL="1080000" indent="-216000" algn="l" defTabSz="685800" rtl="0" eaLnBrk="1" latinLnBrk="0" hangingPunct="1">
-              <a:lnSpc>
-                <a:spcPct val="100000"/>
-              </a:lnSpc>
-              <a:spcBef>
-                <a:spcPts val="200"/>
-              </a:spcBef>
-              <a:buFont typeface="Symbol" panose="05050102010706020507" pitchFamily="18" charset="2"/>
-              <a:buChar char="-"/>
-              <a:defRPr sz="1100" kern="1200">
-                <a:solidFill>
-                  <a:schemeClr val="tx1"/>
-                </a:solidFill>
-                <a:latin typeface="+mn-lt"/>
-                <a:ea typeface="+mn-ea"/>
-                <a:cs typeface="+mn-cs"/>
-              </a:defRPr>
-            </a:lvl5pPr>
-            <a:lvl6pPr marL="1885950" indent="-171450" algn="l" defTabSz="685800" rtl="0" eaLnBrk="1" latinLnBrk="0" hangingPunct="1">
-              <a:lnSpc>
-                <a:spcPct val="90000"/>
-              </a:lnSpc>
-              <a:spcBef>
-                <a:spcPts val="375"/>
-              </a:spcBef>
-              <a:buFont typeface="Arial" panose="020B0604020202020204" pitchFamily="34" charset="0"/>
-              <a:buChar char="•"/>
-              <a:defRPr sz="1350" kern="1200">
-                <a:solidFill>
-                  <a:schemeClr val="tx1"/>
-                </a:solidFill>
-                <a:latin typeface="+mn-lt"/>
-                <a:ea typeface="+mn-ea"/>
-                <a:cs typeface="+mn-cs"/>
-              </a:defRPr>
-            </a:lvl6pPr>
-            <a:lvl7pPr marL="2228850" indent="-171450" algn="l" defTabSz="685800" rtl="0" eaLnBrk="1" latinLnBrk="0" hangingPunct="1">
-              <a:lnSpc>
-                <a:spcPct val="90000"/>
-              </a:lnSpc>
-              <a:spcBef>
-                <a:spcPts val="375"/>
-              </a:spcBef>
-              <a:buFont typeface="Arial" panose="020B0604020202020204" pitchFamily="34" charset="0"/>
-              <a:buChar char="•"/>
-              <a:defRPr sz="1350" kern="1200">
-                <a:solidFill>
-                  <a:schemeClr val="tx1"/>
-                </a:solidFill>
-                <a:latin typeface="+mn-lt"/>
-                <a:ea typeface="+mn-ea"/>
-                <a:cs typeface="+mn-cs"/>
-              </a:defRPr>
-            </a:lvl7pPr>
-            <a:lvl8pPr marL="2571750" indent="-171450" algn="l" defTabSz="685800" rtl="0" eaLnBrk="1" latinLnBrk="0" hangingPunct="1">
-              <a:lnSpc>
-                <a:spcPct val="90000"/>
-              </a:lnSpc>
-              <a:spcBef>
-                <a:spcPts val="375"/>
-              </a:spcBef>
-              <a:buFont typeface="Arial" panose="020B0604020202020204" pitchFamily="34" charset="0"/>
-              <a:buChar char="•"/>
-              <a:defRPr sz="1350" kern="1200">
-                <a:solidFill>
-                  <a:schemeClr val="tx1"/>
-                </a:solidFill>
-                <a:latin typeface="+mn-lt"/>
-                <a:ea typeface="+mn-ea"/>
-                <a:cs typeface="+mn-cs"/>
-              </a:defRPr>
-            </a:lvl8pPr>
-            <a:lvl9pPr marL="2914650" indent="-171450" algn="l" defTabSz="685800" rtl="0" eaLnBrk="1" latinLnBrk="0" hangingPunct="1">
-              <a:lnSpc>
-                <a:spcPct val="90000"/>
-              </a:lnSpc>
-              <a:spcBef>
-                <a:spcPts val="375"/>
-              </a:spcBef>
-              <a:buFont typeface="Arial" panose="020B0604020202020204" pitchFamily="34" charset="0"/>
-              <a:buChar char="•"/>
-              <a:defRPr sz="1350" kern="1200">
-                <a:solidFill>
-                  <a:schemeClr val="tx1"/>
-                </a:solidFill>
-                <a:latin typeface="+mn-lt"/>
-                <a:ea typeface="+mn-ea"/>
-                <a:cs typeface="+mn-cs"/>
-              </a:defRPr>
-            </a:lvl9pPr>
-          </a:lstStyle>
-          <a:p>
-            <a:pPr marL="0" indent="0">
-              <a:lnSpc>
-                <a:spcPct val="150000"/>
-              </a:lnSpc>
-              <a:buNone/>
-            </a:pPr>
-            <a:r>
-              <a:rPr lang="en-US" noProof="0" dirty="0"/>
-              <a:t>Hooks for:</a:t>
-            </a:r>
-          </a:p>
-          <a:p>
-            <a:pPr>
-              <a:lnSpc>
-                <a:spcPct val="150000"/>
-              </a:lnSpc>
-            </a:pPr>
-            <a:r>
-              <a:rPr lang="en-US" noProof="0" dirty="0"/>
-              <a:t>Specifying credentials file</a:t>
-            </a:r>
-          </a:p>
-          <a:p>
-            <a:pPr>
-              <a:lnSpc>
-                <a:spcPct val="150000"/>
-              </a:lnSpc>
-            </a:pPr>
-            <a:r>
-              <a:rPr lang="en-US" noProof="0" dirty="0"/>
-              <a:t>Custom encryption</a:t>
-            </a:r>
-          </a:p>
-          <a:p>
-            <a:pPr>
-              <a:lnSpc>
-                <a:spcPct val="150000"/>
-              </a:lnSpc>
-            </a:pPr>
-            <a:r>
-              <a:rPr lang="en-US" noProof="0" dirty="0"/>
-              <a:t>Post registration logic</a:t>
-            </a:r>
-          </a:p>
-        </p:txBody>
-      </p:sp>
-      <p:pic>
-        <p:nvPicPr>
-          <p:cNvPr id="10" name="Grafik 9" descr="Ein Bild, das Text, Screenshot, Schrift, Diagramm enthält.&#10;&#10;KI-generierte Inhalte können fehlerhaft sein.">
-            <a:extLst>
-              <a:ext uri="{FF2B5EF4-FFF2-40B4-BE49-F238E27FC236}">
-                <a16:creationId xmlns:a16="http://schemas.microsoft.com/office/drawing/2014/main" id="{7623B661-7ABF-B101-0E01-F825DBAD8F8B}"/>
-              </a:ext>
-            </a:extLst>
-          </p:cNvPr>
-          <p:cNvPicPr>
-            <a:picLocks noChangeAspect="1"/>
-          </p:cNvPicPr>
-          <p:nvPr/>
-        </p:nvPicPr>
-        <p:blipFill>
-          <a:blip r:embed="rId2">
-            <a:extLst>
-              <a:ext uri="{28A0092B-C50C-407E-A947-70E740481C1C}">
-                <a14:useLocalDpi xmlns:a14="http://schemas.microsoft.com/office/drawing/2010/main" val="0"/>
-              </a:ext>
-            </a:extLst>
-          </a:blip>
-          <a:stretch>
-            <a:fillRect/>
-          </a:stretch>
-        </p:blipFill>
-        <p:spPr>
-          <a:xfrm>
-            <a:off x="5142906" y="1091590"/>
-            <a:ext cx="3641094" cy="3556418"/>
-          </a:xfrm>
-          <a:prstGeom prst="rect">
-            <a:avLst/>
-          </a:prstGeom>
-        </p:spPr>
-      </p:pic>
-    </p:spTree>
-    <p:extLst>
-      <p:ext uri="{BB962C8B-B14F-4D97-AF65-F5344CB8AC3E}">
-        <p14:creationId xmlns:p14="http://schemas.microsoft.com/office/powerpoint/2010/main" val="3869592993"/>
-      </p:ext>
-    </p:extLst>
-  </p:cSld>
-  <p:clrMapOvr>
-    <a:masterClrMapping/>
-  </p:clrMapOvr>
-</p:sld>
-</file>
-
 <file path=ppt/slides/slide36.xml><?xml version="1.0" encoding="utf-8"?>
-<p:sld xmlns:a="http://schemas.openxmlformats.org/drawingml/2006/main" xmlns:r="http://schemas.openxmlformats.org/officeDocument/2006/relationships" xmlns:p="http://schemas.openxmlformats.org/presentationml/2006/main">
-  <p:cSld>
-    <p:spTree>
-      <p:nvGrpSpPr>
-        <p:cNvPr id="1" name="">
-          <a:extLst>
-            <a:ext uri="{FF2B5EF4-FFF2-40B4-BE49-F238E27FC236}">
-              <a16:creationId xmlns:a16="http://schemas.microsoft.com/office/drawing/2014/main" id="{1F0A5CA4-64C5-7650-1AD1-BB5C5634320D}"/>
-            </a:ext>
-          </a:extLst>
-        </p:cNvPr>
-        <p:cNvGrpSpPr/>
-        <p:nvPr/>
-      </p:nvGrpSpPr>
-      <p:grpSpPr>
-        <a:xfrm>
-          <a:off x="0" y="0"/>
-          <a:ext cx="0" cy="0"/>
-          <a:chOff x="0" y="0"/>
-          <a:chExt cx="0" cy="0"/>
-        </a:xfrm>
-      </p:grpSpPr>
-      <p:sp>
-        <p:nvSpPr>
-          <p:cNvPr id="8" name="Textplatzhalter 7">
-            <a:extLst>
-              <a:ext uri="{FF2B5EF4-FFF2-40B4-BE49-F238E27FC236}">
-                <a16:creationId xmlns:a16="http://schemas.microsoft.com/office/drawing/2014/main" id="{23BDF50A-3A9D-54A1-1FF3-007B51AFB98F}"/>
-              </a:ext>
-            </a:extLst>
-          </p:cNvPr>
-          <p:cNvSpPr>
-            <a:spLocks noGrp="1"/>
-          </p:cNvSpPr>
-          <p:nvPr>
-            <p:ph type="body" sz="quarter" idx="12"/>
-          </p:nvPr>
-        </p:nvSpPr>
-        <p:spPr/>
-        <p:txBody>
-          <a:bodyPr/>
-          <a:lstStyle/>
-          <a:p>
-            <a:r>
-              <a:rPr lang="en-US" dirty="0"/>
-              <a:t>Abstract Templates</a:t>
-            </a:r>
-          </a:p>
-        </p:txBody>
-      </p:sp>
-      <p:sp>
-        <p:nvSpPr>
-          <p:cNvPr id="7" name="Titel 6">
-            <a:extLst>
-              <a:ext uri="{FF2B5EF4-FFF2-40B4-BE49-F238E27FC236}">
-                <a16:creationId xmlns:a16="http://schemas.microsoft.com/office/drawing/2014/main" id="{276CF0BA-EEB7-1496-78DC-AD84BAC5AA98}"/>
-              </a:ext>
-            </a:extLst>
-          </p:cNvPr>
-          <p:cNvSpPr>
-            <a:spLocks noGrp="1"/>
-          </p:cNvSpPr>
-          <p:nvPr>
-            <p:ph type="title"/>
-          </p:nvPr>
-        </p:nvSpPr>
-        <p:spPr/>
-        <p:txBody>
-          <a:bodyPr/>
-          <a:lstStyle/>
-          <a:p>
-            <a:r>
-              <a:rPr lang="en-US" dirty="0"/>
-              <a:t>Designing Our Apps</a:t>
-            </a:r>
-            <a:endParaRPr lang="en-US" noProof="0" dirty="0"/>
-          </a:p>
-        </p:txBody>
-      </p:sp>
-      <p:sp>
-        <p:nvSpPr>
-          <p:cNvPr id="9" name="Textplatzhalter 8">
-            <a:extLst>
-              <a:ext uri="{FF2B5EF4-FFF2-40B4-BE49-F238E27FC236}">
-                <a16:creationId xmlns:a16="http://schemas.microsoft.com/office/drawing/2014/main" id="{A66041B5-2F5A-84E7-FE51-779E7D59EC6A}"/>
-              </a:ext>
-            </a:extLst>
-          </p:cNvPr>
-          <p:cNvSpPr>
-            <a:spLocks noGrp="1"/>
-          </p:cNvSpPr>
-          <p:nvPr>
-            <p:ph type="body" sz="quarter" idx="19"/>
-          </p:nvPr>
-        </p:nvSpPr>
-        <p:spPr/>
-        <p:txBody>
-          <a:bodyPr/>
-          <a:lstStyle/>
-          <a:p>
-            <a:endParaRPr lang="en-US" noProof="0" dirty="0"/>
-          </a:p>
-        </p:txBody>
-      </p:sp>
-      <p:sp>
-        <p:nvSpPr>
-          <p:cNvPr id="11" name="Fußzeilenplatzhalter 10">
-            <a:extLst>
-              <a:ext uri="{FF2B5EF4-FFF2-40B4-BE49-F238E27FC236}">
-                <a16:creationId xmlns:a16="http://schemas.microsoft.com/office/drawing/2014/main" id="{F634A877-7806-0F14-7C8C-13C17F46DFE9}"/>
-              </a:ext>
-            </a:extLst>
-          </p:cNvPr>
-          <p:cNvSpPr>
-            <a:spLocks noGrp="1"/>
-          </p:cNvSpPr>
-          <p:nvPr>
-            <p:ph type="ftr" sz="quarter" idx="17"/>
-          </p:nvPr>
-        </p:nvSpPr>
-        <p:spPr/>
-        <p:txBody>
-          <a:bodyPr/>
-          <a:lstStyle/>
-          <a:p>
-            <a:endParaRPr lang="en-US" noProof="0" dirty="0"/>
-          </a:p>
-        </p:txBody>
-      </p:sp>
-      <p:sp>
-        <p:nvSpPr>
-          <p:cNvPr id="12" name="Foliennummernplatzhalter 11">
-            <a:extLst>
-              <a:ext uri="{FF2B5EF4-FFF2-40B4-BE49-F238E27FC236}">
-                <a16:creationId xmlns:a16="http://schemas.microsoft.com/office/drawing/2014/main" id="{6FFF35CB-62A4-48C5-FA8C-E3E872DF4E7C}"/>
-              </a:ext>
-            </a:extLst>
-          </p:cNvPr>
-          <p:cNvSpPr>
-            <a:spLocks noGrp="1"/>
-          </p:cNvSpPr>
-          <p:nvPr>
-            <p:ph type="sldNum" sz="quarter" idx="18"/>
-          </p:nvPr>
-        </p:nvSpPr>
-        <p:spPr/>
-        <p:txBody>
-          <a:bodyPr/>
-          <a:lstStyle/>
-          <a:p>
-            <a:fld id="{E6639024-6672-4F87-864B-EA4FA9190A1A}" type="slidenum">
-              <a:rPr lang="en-US" noProof="0" smtClean="0"/>
-              <a:pPr/>
-              <a:t>36</a:t>
-            </a:fld>
-            <a:endParaRPr lang="en-US" noProof="0" dirty="0"/>
-          </a:p>
-        </p:txBody>
-      </p:sp>
-      <p:sp>
-        <p:nvSpPr>
-          <p:cNvPr id="4" name="Inhaltsplatzhalter 9">
-            <a:extLst>
-              <a:ext uri="{FF2B5EF4-FFF2-40B4-BE49-F238E27FC236}">
-                <a16:creationId xmlns:a16="http://schemas.microsoft.com/office/drawing/2014/main" id="{34223479-BFE4-D526-569D-0D213A21FD2D}"/>
-              </a:ext>
-            </a:extLst>
-          </p:cNvPr>
-          <p:cNvSpPr txBox="1">
-            <a:spLocks/>
-          </p:cNvSpPr>
-          <p:nvPr/>
-        </p:nvSpPr>
-        <p:spPr>
-          <a:xfrm>
-            <a:off x="359533" y="1203598"/>
-            <a:ext cx="8424467" cy="3332402"/>
-          </a:xfrm>
-          <a:prstGeom prst="rect">
-            <a:avLst/>
-          </a:prstGeom>
-        </p:spPr>
-        <p:txBody>
-          <a:bodyPr vert="horz" lIns="36000" tIns="36000" rIns="36000" bIns="36000" rtlCol="0" anchor="t">
-            <a:normAutofit/>
-          </a:bodyPr>
-          <a:lstStyle>
-            <a:lvl1pPr marL="216000" indent="-216000" algn="l" defTabSz="685800" rtl="0" eaLnBrk="1" latinLnBrk="0" hangingPunct="1">
-              <a:lnSpc>
-                <a:spcPct val="100000"/>
-              </a:lnSpc>
-              <a:spcBef>
-                <a:spcPts val="200"/>
-              </a:spcBef>
-              <a:buClr>
-                <a:schemeClr val="tx1"/>
-              </a:buClr>
-              <a:buFont typeface="Symbol" panose="05050102010706020507" pitchFamily="18" charset="2"/>
-              <a:buChar char="-"/>
-              <a:defRPr sz="1800" kern="1200">
-                <a:solidFill>
-                  <a:schemeClr val="tx1"/>
-                </a:solidFill>
-                <a:latin typeface="+mn-lt"/>
-                <a:ea typeface="+mn-ea"/>
-                <a:cs typeface="+mn-cs"/>
-              </a:defRPr>
-            </a:lvl1pPr>
-            <a:lvl2pPr marL="432000" indent="-216000" algn="l" defTabSz="685800" rtl="0" eaLnBrk="1" latinLnBrk="0" hangingPunct="1">
-              <a:lnSpc>
-                <a:spcPct val="100000"/>
-              </a:lnSpc>
-              <a:spcBef>
-                <a:spcPts val="200"/>
-              </a:spcBef>
-              <a:buFont typeface="Symbol" panose="05050102010706020507" pitchFamily="18" charset="2"/>
-              <a:buChar char="-"/>
-              <a:defRPr sz="1600" kern="1200">
-                <a:solidFill>
-                  <a:schemeClr val="tx1"/>
-                </a:solidFill>
-                <a:latin typeface="+mn-lt"/>
-                <a:ea typeface="+mn-ea"/>
-                <a:cs typeface="+mn-cs"/>
-              </a:defRPr>
-            </a:lvl2pPr>
-            <a:lvl3pPr marL="648000" indent="-216000" algn="l" defTabSz="685800" rtl="0" eaLnBrk="1" latinLnBrk="0" hangingPunct="1">
-              <a:lnSpc>
-                <a:spcPct val="100000"/>
-              </a:lnSpc>
-              <a:spcBef>
-                <a:spcPts val="200"/>
-              </a:spcBef>
-              <a:buFont typeface="Symbol" panose="05050102010706020507" pitchFamily="18" charset="2"/>
-              <a:buChar char="-"/>
-              <a:defRPr sz="1400" kern="1200">
-                <a:solidFill>
-                  <a:schemeClr val="tx1"/>
-                </a:solidFill>
-                <a:latin typeface="+mn-lt"/>
-                <a:ea typeface="+mn-ea"/>
-                <a:cs typeface="+mn-cs"/>
-              </a:defRPr>
-            </a:lvl3pPr>
-            <a:lvl4pPr marL="864000" indent="-216000" algn="l" defTabSz="685800" rtl="0" eaLnBrk="1" latinLnBrk="0" hangingPunct="1">
-              <a:lnSpc>
-                <a:spcPct val="100000"/>
-              </a:lnSpc>
-              <a:spcBef>
-                <a:spcPts val="200"/>
-              </a:spcBef>
-              <a:buFont typeface="Symbol" panose="05050102010706020507" pitchFamily="18" charset="2"/>
-              <a:buChar char="-"/>
-              <a:defRPr sz="1200" kern="1200">
-                <a:solidFill>
-                  <a:schemeClr val="tx1"/>
-                </a:solidFill>
-                <a:latin typeface="+mn-lt"/>
-                <a:ea typeface="+mn-ea"/>
-                <a:cs typeface="+mn-cs"/>
-              </a:defRPr>
-            </a:lvl4pPr>
-            <a:lvl5pPr marL="1080000" indent="-216000" algn="l" defTabSz="685800" rtl="0" eaLnBrk="1" latinLnBrk="0" hangingPunct="1">
-              <a:lnSpc>
-                <a:spcPct val="100000"/>
-              </a:lnSpc>
-              <a:spcBef>
-                <a:spcPts val="200"/>
-              </a:spcBef>
-              <a:buFont typeface="Symbol" panose="05050102010706020507" pitchFamily="18" charset="2"/>
-              <a:buChar char="-"/>
-              <a:defRPr sz="1100" kern="1200">
-                <a:solidFill>
-                  <a:schemeClr val="tx1"/>
-                </a:solidFill>
-                <a:latin typeface="+mn-lt"/>
-                <a:ea typeface="+mn-ea"/>
-                <a:cs typeface="+mn-cs"/>
-              </a:defRPr>
-            </a:lvl5pPr>
-            <a:lvl6pPr marL="1885950" indent="-171450" algn="l" defTabSz="685800" rtl="0" eaLnBrk="1" latinLnBrk="0" hangingPunct="1">
-              <a:lnSpc>
-                <a:spcPct val="90000"/>
-              </a:lnSpc>
-              <a:spcBef>
-                <a:spcPts val="375"/>
-              </a:spcBef>
-              <a:buFont typeface="Arial" panose="020B0604020202020204" pitchFamily="34" charset="0"/>
-              <a:buChar char="•"/>
-              <a:defRPr sz="1350" kern="1200">
-                <a:solidFill>
-                  <a:schemeClr val="tx1"/>
-                </a:solidFill>
-                <a:latin typeface="+mn-lt"/>
-                <a:ea typeface="+mn-ea"/>
-                <a:cs typeface="+mn-cs"/>
-              </a:defRPr>
-            </a:lvl6pPr>
-            <a:lvl7pPr marL="2228850" indent="-171450" algn="l" defTabSz="685800" rtl="0" eaLnBrk="1" latinLnBrk="0" hangingPunct="1">
-              <a:lnSpc>
-                <a:spcPct val="90000"/>
-              </a:lnSpc>
-              <a:spcBef>
-                <a:spcPts val="375"/>
-              </a:spcBef>
-              <a:buFont typeface="Arial" panose="020B0604020202020204" pitchFamily="34" charset="0"/>
-              <a:buChar char="•"/>
-              <a:defRPr sz="1350" kern="1200">
-                <a:solidFill>
-                  <a:schemeClr val="tx1"/>
-                </a:solidFill>
-                <a:latin typeface="+mn-lt"/>
-                <a:ea typeface="+mn-ea"/>
-                <a:cs typeface="+mn-cs"/>
-              </a:defRPr>
-            </a:lvl7pPr>
-            <a:lvl8pPr marL="2571750" indent="-171450" algn="l" defTabSz="685800" rtl="0" eaLnBrk="1" latinLnBrk="0" hangingPunct="1">
-              <a:lnSpc>
-                <a:spcPct val="90000"/>
-              </a:lnSpc>
-              <a:spcBef>
-                <a:spcPts val="375"/>
-              </a:spcBef>
-              <a:buFont typeface="Arial" panose="020B0604020202020204" pitchFamily="34" charset="0"/>
-              <a:buChar char="•"/>
-              <a:defRPr sz="1350" kern="1200">
-                <a:solidFill>
-                  <a:schemeClr val="tx1"/>
-                </a:solidFill>
-                <a:latin typeface="+mn-lt"/>
-                <a:ea typeface="+mn-ea"/>
-                <a:cs typeface="+mn-cs"/>
-              </a:defRPr>
-            </a:lvl8pPr>
-            <a:lvl9pPr marL="2914650" indent="-171450" algn="l" defTabSz="685800" rtl="0" eaLnBrk="1" latinLnBrk="0" hangingPunct="1">
-              <a:lnSpc>
-                <a:spcPct val="90000"/>
-              </a:lnSpc>
-              <a:spcBef>
-                <a:spcPts val="375"/>
-              </a:spcBef>
-              <a:buFont typeface="Arial" panose="020B0604020202020204" pitchFamily="34" charset="0"/>
-              <a:buChar char="•"/>
-              <a:defRPr sz="1350" kern="1200">
-                <a:solidFill>
-                  <a:schemeClr val="tx1"/>
-                </a:solidFill>
-                <a:latin typeface="+mn-lt"/>
-                <a:ea typeface="+mn-ea"/>
-                <a:cs typeface="+mn-cs"/>
-              </a:defRPr>
-            </a:lvl9pPr>
-          </a:lstStyle>
-          <a:p>
-            <a:pPr marL="0" indent="0">
-              <a:lnSpc>
-                <a:spcPct val="150000"/>
-              </a:lnSpc>
-              <a:buNone/>
-            </a:pPr>
-            <a:r>
-              <a:rPr lang="en-US" noProof="0" dirty="0"/>
-              <a:t>Hooks for:</a:t>
-            </a:r>
-          </a:p>
-          <a:p>
-            <a:pPr>
-              <a:lnSpc>
-                <a:spcPct val="150000"/>
-              </a:lnSpc>
-            </a:pPr>
-            <a:r>
-              <a:rPr lang="en-US" noProof="0" dirty="0"/>
-              <a:t>Specifying credentials file</a:t>
-            </a:r>
-          </a:p>
-          <a:p>
-            <a:pPr>
-              <a:lnSpc>
-                <a:spcPct val="150000"/>
-              </a:lnSpc>
-            </a:pPr>
-            <a:r>
-              <a:rPr lang="en-US" noProof="0" dirty="0"/>
-              <a:t>Custom decryption</a:t>
-            </a:r>
-          </a:p>
-          <a:p>
-            <a:pPr>
-              <a:lnSpc>
-                <a:spcPct val="150000"/>
-              </a:lnSpc>
-            </a:pPr>
-            <a:r>
-              <a:rPr lang="en-US" noProof="0" dirty="0"/>
-              <a:t>Custom verification process</a:t>
-            </a:r>
-          </a:p>
-          <a:p>
-            <a:pPr>
-              <a:lnSpc>
-                <a:spcPct val="150000"/>
-              </a:lnSpc>
-            </a:pPr>
-            <a:r>
-              <a:rPr lang="en-US" noProof="0" dirty="0"/>
-              <a:t>Custom failed login logic</a:t>
-            </a:r>
-          </a:p>
-        </p:txBody>
-      </p:sp>
-      <p:pic>
-        <p:nvPicPr>
-          <p:cNvPr id="5" name="Grafik 4" descr="Ein Bild, das Text, Screenshot, Schrift, Diagramm enthält.&#10;&#10;KI-generierte Inhalte können fehlerhaft sein.">
-            <a:extLst>
-              <a:ext uri="{FF2B5EF4-FFF2-40B4-BE49-F238E27FC236}">
-                <a16:creationId xmlns:a16="http://schemas.microsoft.com/office/drawing/2014/main" id="{9798647E-AEF4-6663-479E-CF1472EF7BC3}"/>
-              </a:ext>
-            </a:extLst>
-          </p:cNvPr>
-          <p:cNvPicPr>
-            <a:picLocks noChangeAspect="1"/>
-          </p:cNvPicPr>
-          <p:nvPr/>
-        </p:nvPicPr>
-        <p:blipFill>
-          <a:blip r:embed="rId2">
-            <a:extLst>
-              <a:ext uri="{28A0092B-C50C-407E-A947-70E740481C1C}">
-                <a14:useLocalDpi xmlns:a14="http://schemas.microsoft.com/office/drawing/2010/main" val="0"/>
-              </a:ext>
-            </a:extLst>
-          </a:blip>
-          <a:stretch>
-            <a:fillRect/>
-          </a:stretch>
-        </p:blipFill>
-        <p:spPr>
-          <a:xfrm>
-            <a:off x="4644008" y="1096416"/>
-            <a:ext cx="4139629" cy="3542926"/>
-          </a:xfrm>
-          <a:prstGeom prst="rect">
-            <a:avLst/>
-          </a:prstGeom>
-        </p:spPr>
-      </p:pic>
-    </p:spTree>
-    <p:extLst>
-      <p:ext uri="{BB962C8B-B14F-4D97-AF65-F5344CB8AC3E}">
-        <p14:creationId xmlns:p14="http://schemas.microsoft.com/office/powerpoint/2010/main" val="1734310983"/>
-      </p:ext>
-    </p:extLst>
-  </p:cSld>
-  <p:clrMapOvr>
-    <a:masterClrMapping/>
-  </p:clrMapOvr>
-</p:sld>
-</file>
-
-<file path=ppt/slides/slide37.xml><?xml version="1.0" encoding="utf-8"?>
 <p:sld xmlns:a="http://schemas.openxmlformats.org/drawingml/2006/main" xmlns:r="http://schemas.openxmlformats.org/officeDocument/2006/relationships" xmlns:p="http://schemas.openxmlformats.org/presentationml/2006/main">
   <p:cSld>
     <p:spTree>
@@ -40952,7 +40275,7 @@
             <a:fld id="{E6639024-6672-4F87-864B-EA4FA9190A1A}" type="slidenum">
               <a:rPr lang="en-US" noProof="0" smtClean="0"/>
               <a:pPr/>
-              <a:t>37</a:t>
+              <a:t>36</a:t>
             </a:fld>
             <a:endParaRPr lang="en-US" noProof="0" dirty="0"/>
           </a:p>
@@ -41230,7 +40553,7 @@
 </p:sld>
 </file>
 
-<file path=ppt/slides/slide38.xml><?xml version="1.0" encoding="utf-8"?>
+<file path=ppt/slides/slide37.xml><?xml version="1.0" encoding="utf-8"?>
 <p:sld xmlns:a="http://schemas.openxmlformats.org/drawingml/2006/main" xmlns:r="http://schemas.openxmlformats.org/officeDocument/2006/relationships" xmlns:p="http://schemas.openxmlformats.org/presentationml/2006/main">
   <p:cSld>
     <p:spTree>
@@ -41452,7 +40775,7 @@
             <a:fld id="{E6639024-6672-4F87-864B-EA4FA9190A1A}" type="slidenum">
               <a:rPr lang="en-US" noProof="0" smtClean="0"/>
               <a:pPr/>
-              <a:t>38</a:t>
+              <a:t>37</a:t>
             </a:fld>
             <a:endParaRPr lang="en-US" noProof="0" dirty="0"/>
           </a:p>
@@ -41471,7 +40794,7 @@
 </p:sld>
 </file>
 
-<file path=ppt/slides/slide39.xml><?xml version="1.0" encoding="utf-8"?>
+<file path=ppt/slides/slide38.xml><?xml version="1.0" encoding="utf-8"?>
 <p:sld xmlns:a="http://schemas.openxmlformats.org/drawingml/2006/main" xmlns:r="http://schemas.openxmlformats.org/officeDocument/2006/relationships" xmlns:p="http://schemas.openxmlformats.org/presentationml/2006/main">
   <p:cSld>
     <p:spTree>
@@ -41701,7 +41024,7 @@
             <a:fld id="{E6639024-6672-4F87-864B-EA4FA9190A1A}" type="slidenum">
               <a:rPr lang="en-US" noProof="0" smtClean="0"/>
               <a:pPr/>
-              <a:t>39</a:t>
+              <a:t>38</a:t>
             </a:fld>
             <a:endParaRPr lang="en-US" noProof="0" dirty="0"/>
           </a:p>
@@ -41720,521 +41043,7 @@
 </p:sld>
 </file>
 
-<file path=ppt/slides/slide4.xml><?xml version="1.0" encoding="utf-8"?>
-<p:sld xmlns:a="http://schemas.openxmlformats.org/drawingml/2006/main" xmlns:r="http://schemas.openxmlformats.org/officeDocument/2006/relationships" xmlns:p="http://schemas.openxmlformats.org/presentationml/2006/main">
-  <p:cSld>
-    <p:spTree>
-      <p:nvGrpSpPr>
-        <p:cNvPr id="1" name="">
-          <a:extLst>
-            <a:ext uri="{FF2B5EF4-FFF2-40B4-BE49-F238E27FC236}">
-              <a16:creationId xmlns:a16="http://schemas.microsoft.com/office/drawing/2014/main" id="{BCFE60A0-D67C-A722-3DAB-AA33D708D4F6}"/>
-            </a:ext>
-          </a:extLst>
-        </p:cNvPr>
-        <p:cNvGrpSpPr/>
-        <p:nvPr/>
-      </p:nvGrpSpPr>
-      <p:grpSpPr>
-        <a:xfrm>
-          <a:off x="0" y="0"/>
-          <a:ext cx="0" cy="0"/>
-          <a:chOff x="0" y="0"/>
-          <a:chExt cx="0" cy="0"/>
-        </a:xfrm>
-      </p:grpSpPr>
-      <p:sp>
-        <p:nvSpPr>
-          <p:cNvPr id="8" name="Textplatzhalter 7">
-            <a:extLst>
-              <a:ext uri="{FF2B5EF4-FFF2-40B4-BE49-F238E27FC236}">
-                <a16:creationId xmlns:a16="http://schemas.microsoft.com/office/drawing/2014/main" id="{D45C3CB5-A282-30D8-22A2-FD1E1FF7F3CD}"/>
-              </a:ext>
-            </a:extLst>
-          </p:cNvPr>
-          <p:cNvSpPr>
-            <a:spLocks noGrp="1"/>
-          </p:cNvSpPr>
-          <p:nvPr>
-            <p:ph type="body" sz="quarter" idx="12"/>
-          </p:nvPr>
-        </p:nvSpPr>
-        <p:spPr/>
-        <p:txBody>
-          <a:bodyPr/>
-          <a:lstStyle/>
-          <a:p>
-            <a:r>
-              <a:rPr lang="en-US" noProof="0" dirty="0"/>
-              <a:t>The Problem in Numbers</a:t>
-            </a:r>
-          </a:p>
-        </p:txBody>
-      </p:sp>
-      <p:sp>
-        <p:nvSpPr>
-          <p:cNvPr id="7" name="Titel 6">
-            <a:extLst>
-              <a:ext uri="{FF2B5EF4-FFF2-40B4-BE49-F238E27FC236}">
-                <a16:creationId xmlns:a16="http://schemas.microsoft.com/office/drawing/2014/main" id="{5043144B-0AA1-C080-E282-449EFCCFAF22}"/>
-              </a:ext>
-            </a:extLst>
-          </p:cNvPr>
-          <p:cNvSpPr>
-            <a:spLocks noGrp="1"/>
-          </p:cNvSpPr>
-          <p:nvPr>
-            <p:ph type="title"/>
-          </p:nvPr>
-        </p:nvSpPr>
-        <p:spPr/>
-        <p:txBody>
-          <a:bodyPr/>
-          <a:lstStyle/>
-          <a:p>
-            <a:r>
-              <a:rPr lang="en-US" dirty="0"/>
-              <a:t>State of Android App Security</a:t>
-            </a:r>
-            <a:endParaRPr lang="en-US" noProof="0" dirty="0"/>
-          </a:p>
-        </p:txBody>
-      </p:sp>
-      <p:sp>
-        <p:nvSpPr>
-          <p:cNvPr id="9" name="Textplatzhalter 8">
-            <a:extLst>
-              <a:ext uri="{FF2B5EF4-FFF2-40B4-BE49-F238E27FC236}">
-                <a16:creationId xmlns:a16="http://schemas.microsoft.com/office/drawing/2014/main" id="{ECA742AD-C2CF-78CE-281C-ABD846F3CB3C}"/>
-              </a:ext>
-            </a:extLst>
-          </p:cNvPr>
-          <p:cNvSpPr>
-            <a:spLocks noGrp="1"/>
-          </p:cNvSpPr>
-          <p:nvPr>
-            <p:ph type="body" sz="quarter" idx="19"/>
-          </p:nvPr>
-        </p:nvSpPr>
-        <p:spPr/>
-        <p:txBody>
-          <a:bodyPr/>
-          <a:lstStyle/>
-          <a:p>
-            <a:r>
-              <a:rPr lang="en-US" noProof="0" dirty="0"/>
-              <a:t>(Ferrari et al., 2025; Tech Inside Out 20</a:t>
-            </a:r>
-            <a:r>
-              <a:rPr lang="en-US" dirty="0"/>
-              <a:t>21</a:t>
-            </a:r>
-            <a:r>
-              <a:rPr lang="en-US" noProof="0" dirty="0"/>
-              <a:t>)</a:t>
-            </a:r>
-          </a:p>
-        </p:txBody>
-      </p:sp>
-      <p:sp>
-        <p:nvSpPr>
-          <p:cNvPr id="11" name="Fußzeilenplatzhalter 10">
-            <a:extLst>
-              <a:ext uri="{FF2B5EF4-FFF2-40B4-BE49-F238E27FC236}">
-                <a16:creationId xmlns:a16="http://schemas.microsoft.com/office/drawing/2014/main" id="{9E040E96-317A-C10D-4B2B-31D6C089B9D6}"/>
-              </a:ext>
-            </a:extLst>
-          </p:cNvPr>
-          <p:cNvSpPr>
-            <a:spLocks noGrp="1"/>
-          </p:cNvSpPr>
-          <p:nvPr>
-            <p:ph type="ftr" sz="quarter" idx="17"/>
-          </p:nvPr>
-        </p:nvSpPr>
-        <p:spPr/>
-        <p:txBody>
-          <a:bodyPr/>
-          <a:lstStyle/>
-          <a:p>
-            <a:endParaRPr lang="en-US" noProof="0" dirty="0"/>
-          </a:p>
-        </p:txBody>
-      </p:sp>
-      <p:sp>
-        <p:nvSpPr>
-          <p:cNvPr id="12" name="Foliennummernplatzhalter 11">
-            <a:extLst>
-              <a:ext uri="{FF2B5EF4-FFF2-40B4-BE49-F238E27FC236}">
-                <a16:creationId xmlns:a16="http://schemas.microsoft.com/office/drawing/2014/main" id="{11FC7BB2-8FB3-9A88-4C83-5936E9011CD0}"/>
-              </a:ext>
-            </a:extLst>
-          </p:cNvPr>
-          <p:cNvSpPr>
-            <a:spLocks noGrp="1"/>
-          </p:cNvSpPr>
-          <p:nvPr>
-            <p:ph type="sldNum" sz="quarter" idx="18"/>
-          </p:nvPr>
-        </p:nvSpPr>
-        <p:spPr/>
-        <p:txBody>
-          <a:bodyPr/>
-          <a:lstStyle/>
-          <a:p>
-            <a:fld id="{E6639024-6672-4F87-864B-EA4FA9190A1A}" type="slidenum">
-              <a:rPr lang="en-US" noProof="0" smtClean="0"/>
-              <a:pPr/>
-              <a:t>4</a:t>
-            </a:fld>
-            <a:endParaRPr lang="en-US" noProof="0" dirty="0"/>
-          </a:p>
-        </p:txBody>
-      </p:sp>
-      <p:sp>
-        <p:nvSpPr>
-          <p:cNvPr id="5" name="Textfeld 4">
-            <a:extLst>
-              <a:ext uri="{FF2B5EF4-FFF2-40B4-BE49-F238E27FC236}">
-                <a16:creationId xmlns:a16="http://schemas.microsoft.com/office/drawing/2014/main" id="{7ADA47EF-7EB6-938E-6E09-56430F4CA70D}"/>
-              </a:ext>
-            </a:extLst>
-          </p:cNvPr>
-          <p:cNvSpPr txBox="1"/>
-          <p:nvPr/>
-        </p:nvSpPr>
-        <p:spPr>
-          <a:xfrm>
-            <a:off x="1331640" y="2088634"/>
-            <a:ext cx="1952275" cy="1538883"/>
-          </a:xfrm>
-          <a:prstGeom prst="rect">
-            <a:avLst/>
-          </a:prstGeom>
-          <a:noFill/>
-        </p:spPr>
-        <p:txBody>
-          <a:bodyPr wrap="square" rtlCol="0">
-            <a:spAutoFit/>
-          </a:bodyPr>
-          <a:lstStyle/>
-          <a:p>
-            <a:pPr algn="ctr"/>
-            <a:r>
-              <a:rPr lang="en-US" sz="6000" noProof="0" dirty="0">
-                <a:solidFill>
-                  <a:schemeClr val="bg2"/>
-                </a:solidFill>
-              </a:rPr>
-              <a:t>39</a:t>
-            </a:r>
-            <a:r>
-              <a:rPr lang="en-US" sz="8000" noProof="0" dirty="0"/>
-              <a:t> </a:t>
-            </a:r>
-          </a:p>
-          <a:p>
-            <a:pPr algn="ctr"/>
-            <a:r>
-              <a:rPr lang="en-US" sz="1400" noProof="0" dirty="0"/>
-              <a:t>vulnerabilities per app</a:t>
-            </a:r>
-          </a:p>
-        </p:txBody>
-      </p:sp>
-      <p:sp>
-        <p:nvSpPr>
-          <p:cNvPr id="6" name="Textfeld 5">
-            <a:extLst>
-              <a:ext uri="{FF2B5EF4-FFF2-40B4-BE49-F238E27FC236}">
-                <a16:creationId xmlns:a16="http://schemas.microsoft.com/office/drawing/2014/main" id="{AF023A3C-46D8-3046-6EBE-17844C562EB6}"/>
-              </a:ext>
-            </a:extLst>
-          </p:cNvPr>
-          <p:cNvSpPr txBox="1"/>
-          <p:nvPr/>
-        </p:nvSpPr>
-        <p:spPr>
-          <a:xfrm>
-            <a:off x="5076056" y="2073246"/>
-            <a:ext cx="2196244" cy="1569660"/>
-          </a:xfrm>
-          <a:prstGeom prst="rect">
-            <a:avLst/>
-          </a:prstGeom>
-          <a:noFill/>
-        </p:spPr>
-        <p:txBody>
-          <a:bodyPr wrap="square" rtlCol="0">
-            <a:spAutoFit/>
-          </a:bodyPr>
-          <a:lstStyle/>
-          <a:p>
-            <a:pPr algn="ctr"/>
-            <a:r>
-              <a:rPr lang="en-US" sz="6000" noProof="0" dirty="0">
-                <a:solidFill>
-                  <a:schemeClr val="bg2"/>
-                </a:solidFill>
-              </a:rPr>
-              <a:t>63%</a:t>
-            </a:r>
-            <a:r>
-              <a:rPr lang="en-US" sz="8000" noProof="0" dirty="0">
-                <a:solidFill>
-                  <a:schemeClr val="bg2"/>
-                </a:solidFill>
-              </a:rPr>
-              <a:t> </a:t>
-            </a:r>
-          </a:p>
-          <a:p>
-            <a:pPr algn="ctr"/>
-            <a:r>
-              <a:rPr lang="en-US" sz="1400" noProof="0" dirty="0"/>
-              <a:t>apps show vulnerabilities</a:t>
-            </a:r>
-          </a:p>
-        </p:txBody>
-      </p:sp>
-      <p:sp>
-        <p:nvSpPr>
-          <p:cNvPr id="2" name="Inhaltsplatzhalter 9">
-            <a:extLst>
-              <a:ext uri="{FF2B5EF4-FFF2-40B4-BE49-F238E27FC236}">
-                <a16:creationId xmlns:a16="http://schemas.microsoft.com/office/drawing/2014/main" id="{7B402A66-69FE-A1BE-113F-727ECEA35F08}"/>
-              </a:ext>
-            </a:extLst>
-          </p:cNvPr>
-          <p:cNvSpPr txBox="1">
-            <a:spLocks/>
-          </p:cNvSpPr>
-          <p:nvPr/>
-        </p:nvSpPr>
-        <p:spPr>
-          <a:xfrm>
-            <a:off x="359532" y="1207321"/>
-            <a:ext cx="8424467" cy="3332402"/>
-          </a:xfrm>
-          <a:prstGeom prst="rect">
-            <a:avLst/>
-          </a:prstGeom>
-        </p:spPr>
-        <p:txBody>
-          <a:bodyPr vert="horz" lIns="36000" tIns="36000" rIns="36000" bIns="36000" rtlCol="0" anchor="t">
-            <a:normAutofit/>
-          </a:bodyPr>
-          <a:lstStyle>
-            <a:lvl1pPr marL="216000" indent="-216000" algn="l" defTabSz="685800" rtl="0" eaLnBrk="1" latinLnBrk="0" hangingPunct="1">
-              <a:lnSpc>
-                <a:spcPct val="100000"/>
-              </a:lnSpc>
-              <a:spcBef>
-                <a:spcPts val="200"/>
-              </a:spcBef>
-              <a:buClr>
-                <a:schemeClr val="tx1"/>
-              </a:buClr>
-              <a:buFont typeface="Symbol" panose="05050102010706020507" pitchFamily="18" charset="2"/>
-              <a:buChar char="-"/>
-              <a:defRPr sz="1800" kern="1200">
-                <a:solidFill>
-                  <a:schemeClr val="tx1"/>
-                </a:solidFill>
-                <a:latin typeface="+mn-lt"/>
-                <a:ea typeface="+mn-ea"/>
-                <a:cs typeface="+mn-cs"/>
-              </a:defRPr>
-            </a:lvl1pPr>
-            <a:lvl2pPr marL="432000" indent="-216000" algn="l" defTabSz="685800" rtl="0" eaLnBrk="1" latinLnBrk="0" hangingPunct="1">
-              <a:lnSpc>
-                <a:spcPct val="100000"/>
-              </a:lnSpc>
-              <a:spcBef>
-                <a:spcPts val="200"/>
-              </a:spcBef>
-              <a:buFont typeface="Symbol" panose="05050102010706020507" pitchFamily="18" charset="2"/>
-              <a:buChar char="-"/>
-              <a:defRPr sz="1600" kern="1200">
-                <a:solidFill>
-                  <a:schemeClr val="tx1"/>
-                </a:solidFill>
-                <a:latin typeface="+mn-lt"/>
-                <a:ea typeface="+mn-ea"/>
-                <a:cs typeface="+mn-cs"/>
-              </a:defRPr>
-            </a:lvl2pPr>
-            <a:lvl3pPr marL="648000" indent="-216000" algn="l" defTabSz="685800" rtl="0" eaLnBrk="1" latinLnBrk="0" hangingPunct="1">
-              <a:lnSpc>
-                <a:spcPct val="100000"/>
-              </a:lnSpc>
-              <a:spcBef>
-                <a:spcPts val="200"/>
-              </a:spcBef>
-              <a:buFont typeface="Symbol" panose="05050102010706020507" pitchFamily="18" charset="2"/>
-              <a:buChar char="-"/>
-              <a:defRPr sz="1400" kern="1200">
-                <a:solidFill>
-                  <a:schemeClr val="tx1"/>
-                </a:solidFill>
-                <a:latin typeface="+mn-lt"/>
-                <a:ea typeface="+mn-ea"/>
-                <a:cs typeface="+mn-cs"/>
-              </a:defRPr>
-            </a:lvl3pPr>
-            <a:lvl4pPr marL="864000" indent="-216000" algn="l" defTabSz="685800" rtl="0" eaLnBrk="1" latinLnBrk="0" hangingPunct="1">
-              <a:lnSpc>
-                <a:spcPct val="100000"/>
-              </a:lnSpc>
-              <a:spcBef>
-                <a:spcPts val="200"/>
-              </a:spcBef>
-              <a:buFont typeface="Symbol" panose="05050102010706020507" pitchFamily="18" charset="2"/>
-              <a:buChar char="-"/>
-              <a:defRPr sz="1200" kern="1200">
-                <a:solidFill>
-                  <a:schemeClr val="tx1"/>
-                </a:solidFill>
-                <a:latin typeface="+mn-lt"/>
-                <a:ea typeface="+mn-ea"/>
-                <a:cs typeface="+mn-cs"/>
-              </a:defRPr>
-            </a:lvl4pPr>
-            <a:lvl5pPr marL="1080000" indent="-216000" algn="l" defTabSz="685800" rtl="0" eaLnBrk="1" latinLnBrk="0" hangingPunct="1">
-              <a:lnSpc>
-                <a:spcPct val="100000"/>
-              </a:lnSpc>
-              <a:spcBef>
-                <a:spcPts val="200"/>
-              </a:spcBef>
-              <a:buFont typeface="Symbol" panose="05050102010706020507" pitchFamily="18" charset="2"/>
-              <a:buChar char="-"/>
-              <a:defRPr sz="1100" kern="1200">
-                <a:solidFill>
-                  <a:schemeClr val="tx1"/>
-                </a:solidFill>
-                <a:latin typeface="+mn-lt"/>
-                <a:ea typeface="+mn-ea"/>
-                <a:cs typeface="+mn-cs"/>
-              </a:defRPr>
-            </a:lvl5pPr>
-            <a:lvl6pPr marL="1885950" indent="-171450" algn="l" defTabSz="685800" rtl="0" eaLnBrk="1" latinLnBrk="0" hangingPunct="1">
-              <a:lnSpc>
-                <a:spcPct val="90000"/>
-              </a:lnSpc>
-              <a:spcBef>
-                <a:spcPts val="375"/>
-              </a:spcBef>
-              <a:buFont typeface="Arial" panose="020B0604020202020204" pitchFamily="34" charset="0"/>
-              <a:buChar char="•"/>
-              <a:defRPr sz="1350" kern="1200">
-                <a:solidFill>
-                  <a:schemeClr val="tx1"/>
-                </a:solidFill>
-                <a:latin typeface="+mn-lt"/>
-                <a:ea typeface="+mn-ea"/>
-                <a:cs typeface="+mn-cs"/>
-              </a:defRPr>
-            </a:lvl6pPr>
-            <a:lvl7pPr marL="2228850" indent="-171450" algn="l" defTabSz="685800" rtl="0" eaLnBrk="1" latinLnBrk="0" hangingPunct="1">
-              <a:lnSpc>
-                <a:spcPct val="90000"/>
-              </a:lnSpc>
-              <a:spcBef>
-                <a:spcPts val="375"/>
-              </a:spcBef>
-              <a:buFont typeface="Arial" panose="020B0604020202020204" pitchFamily="34" charset="0"/>
-              <a:buChar char="•"/>
-              <a:defRPr sz="1350" kern="1200">
-                <a:solidFill>
-                  <a:schemeClr val="tx1"/>
-                </a:solidFill>
-                <a:latin typeface="+mn-lt"/>
-                <a:ea typeface="+mn-ea"/>
-                <a:cs typeface="+mn-cs"/>
-              </a:defRPr>
-            </a:lvl7pPr>
-            <a:lvl8pPr marL="2571750" indent="-171450" algn="l" defTabSz="685800" rtl="0" eaLnBrk="1" latinLnBrk="0" hangingPunct="1">
-              <a:lnSpc>
-                <a:spcPct val="90000"/>
-              </a:lnSpc>
-              <a:spcBef>
-                <a:spcPts val="375"/>
-              </a:spcBef>
-              <a:buFont typeface="Arial" panose="020B0604020202020204" pitchFamily="34" charset="0"/>
-              <a:buChar char="•"/>
-              <a:defRPr sz="1350" kern="1200">
-                <a:solidFill>
-                  <a:schemeClr val="tx1"/>
-                </a:solidFill>
-                <a:latin typeface="+mn-lt"/>
-                <a:ea typeface="+mn-ea"/>
-                <a:cs typeface="+mn-cs"/>
-              </a:defRPr>
-            </a:lvl8pPr>
-            <a:lvl9pPr marL="2914650" indent="-171450" algn="l" defTabSz="685800" rtl="0" eaLnBrk="1" latinLnBrk="0" hangingPunct="1">
-              <a:lnSpc>
-                <a:spcPct val="90000"/>
-              </a:lnSpc>
-              <a:spcBef>
-                <a:spcPts val="375"/>
-              </a:spcBef>
-              <a:buFont typeface="Arial" panose="020B0604020202020204" pitchFamily="34" charset="0"/>
-              <a:buChar char="•"/>
-              <a:defRPr sz="1350" kern="1200">
-                <a:solidFill>
-                  <a:schemeClr val="tx1"/>
-                </a:solidFill>
-                <a:latin typeface="+mn-lt"/>
-                <a:ea typeface="+mn-ea"/>
-                <a:cs typeface="+mn-cs"/>
-              </a:defRPr>
-            </a:lvl9pPr>
-          </a:lstStyle>
-          <a:p>
-            <a:pPr marL="0" indent="0">
-              <a:lnSpc>
-                <a:spcPct val="150000"/>
-              </a:lnSpc>
-              <a:buNone/>
-            </a:pPr>
-            <a:r>
-              <a:rPr lang="en-US" noProof="0" dirty="0"/>
-              <a:t>Across the 18 most popular Android categories:</a:t>
-            </a:r>
-          </a:p>
-          <a:p>
-            <a:pPr>
-              <a:lnSpc>
-                <a:spcPct val="150000"/>
-              </a:lnSpc>
-            </a:pPr>
-            <a:endParaRPr lang="en-US" noProof="0" dirty="0"/>
-          </a:p>
-          <a:p>
-            <a:pPr>
-              <a:lnSpc>
-                <a:spcPct val="150000"/>
-              </a:lnSpc>
-            </a:pPr>
-            <a:endParaRPr lang="en-US" noProof="0" dirty="0"/>
-          </a:p>
-        </p:txBody>
-      </p:sp>
-    </p:spTree>
-    <p:extLst>
-      <p:ext uri="{BB962C8B-B14F-4D97-AF65-F5344CB8AC3E}">
-        <p14:creationId xmlns:p14="http://schemas.microsoft.com/office/powerpoint/2010/main" val="3225203029"/>
-      </p:ext>
-    </p:extLst>
-  </p:cSld>
-  <p:clrMapOvr>
-    <a:masterClrMapping/>
-  </p:clrMapOvr>
-</p:sld>
-</file>
-
-<file path=ppt/slides/slide40.xml><?xml version="1.0" encoding="utf-8"?>
+<file path=ppt/slides/slide39.xml><?xml version="1.0" encoding="utf-8"?>
 <p:sld xmlns:a="http://schemas.openxmlformats.org/drawingml/2006/main" xmlns:r="http://schemas.openxmlformats.org/officeDocument/2006/relationships" xmlns:p="http://schemas.openxmlformats.org/presentationml/2006/main">
   <p:cSld>
     <p:spTree>
@@ -42346,7 +41155,7 @@
             </a:pPr>
             <a:r>
               <a:rPr lang="en-US" noProof="0" dirty="0"/>
-              <a:t>Largest contribution to crypto category</a:t>
+              <a:t>Largest contribution to Crypto category</a:t>
             </a:r>
           </a:p>
           <a:p>
@@ -42441,7 +41250,7 @@
             <a:fld id="{E6639024-6672-4F87-864B-EA4FA9190A1A}" type="slidenum">
               <a:rPr lang="en-US" noProof="0" smtClean="0"/>
               <a:pPr/>
-              <a:t>40</a:t>
+              <a:t>39</a:t>
             </a:fld>
             <a:endParaRPr lang="en-US" noProof="0" dirty="0"/>
           </a:p>
@@ -42496,7 +41305,521 @@
 </p:sld>
 </file>
 
-<file path=ppt/slides/slide41.xml><?xml version="1.0" encoding="utf-8"?>
+<file path=ppt/slides/slide4.xml><?xml version="1.0" encoding="utf-8"?>
+<p:sld xmlns:a="http://schemas.openxmlformats.org/drawingml/2006/main" xmlns:r="http://schemas.openxmlformats.org/officeDocument/2006/relationships" xmlns:p="http://schemas.openxmlformats.org/presentationml/2006/main">
+  <p:cSld>
+    <p:spTree>
+      <p:nvGrpSpPr>
+        <p:cNvPr id="1" name="">
+          <a:extLst>
+            <a:ext uri="{FF2B5EF4-FFF2-40B4-BE49-F238E27FC236}">
+              <a16:creationId xmlns:a16="http://schemas.microsoft.com/office/drawing/2014/main" id="{BCFE60A0-D67C-A722-3DAB-AA33D708D4F6}"/>
+            </a:ext>
+          </a:extLst>
+        </p:cNvPr>
+        <p:cNvGrpSpPr/>
+        <p:nvPr/>
+      </p:nvGrpSpPr>
+      <p:grpSpPr>
+        <a:xfrm>
+          <a:off x="0" y="0"/>
+          <a:ext cx="0" cy="0"/>
+          <a:chOff x="0" y="0"/>
+          <a:chExt cx="0" cy="0"/>
+        </a:xfrm>
+      </p:grpSpPr>
+      <p:sp>
+        <p:nvSpPr>
+          <p:cNvPr id="8" name="Textplatzhalter 7">
+            <a:extLst>
+              <a:ext uri="{FF2B5EF4-FFF2-40B4-BE49-F238E27FC236}">
+                <a16:creationId xmlns:a16="http://schemas.microsoft.com/office/drawing/2014/main" id="{D45C3CB5-A282-30D8-22A2-FD1E1FF7F3CD}"/>
+              </a:ext>
+            </a:extLst>
+          </p:cNvPr>
+          <p:cNvSpPr>
+            <a:spLocks noGrp="1"/>
+          </p:cNvSpPr>
+          <p:nvPr>
+            <p:ph type="body" sz="quarter" idx="12"/>
+          </p:nvPr>
+        </p:nvSpPr>
+        <p:spPr/>
+        <p:txBody>
+          <a:bodyPr/>
+          <a:lstStyle/>
+          <a:p>
+            <a:r>
+              <a:rPr lang="en-US" noProof="0" dirty="0"/>
+              <a:t>The Problem in Numbers</a:t>
+            </a:r>
+          </a:p>
+        </p:txBody>
+      </p:sp>
+      <p:sp>
+        <p:nvSpPr>
+          <p:cNvPr id="7" name="Titel 6">
+            <a:extLst>
+              <a:ext uri="{FF2B5EF4-FFF2-40B4-BE49-F238E27FC236}">
+                <a16:creationId xmlns:a16="http://schemas.microsoft.com/office/drawing/2014/main" id="{5043144B-0AA1-C080-E282-449EFCCFAF22}"/>
+              </a:ext>
+            </a:extLst>
+          </p:cNvPr>
+          <p:cNvSpPr>
+            <a:spLocks noGrp="1"/>
+          </p:cNvSpPr>
+          <p:nvPr>
+            <p:ph type="title"/>
+          </p:nvPr>
+        </p:nvSpPr>
+        <p:spPr/>
+        <p:txBody>
+          <a:bodyPr/>
+          <a:lstStyle/>
+          <a:p>
+            <a:r>
+              <a:rPr lang="en-US" dirty="0"/>
+              <a:t>State of Android App Security</a:t>
+            </a:r>
+            <a:endParaRPr lang="en-US" noProof="0" dirty="0"/>
+          </a:p>
+        </p:txBody>
+      </p:sp>
+      <p:sp>
+        <p:nvSpPr>
+          <p:cNvPr id="9" name="Textplatzhalter 8">
+            <a:extLst>
+              <a:ext uri="{FF2B5EF4-FFF2-40B4-BE49-F238E27FC236}">
+                <a16:creationId xmlns:a16="http://schemas.microsoft.com/office/drawing/2014/main" id="{ECA742AD-C2CF-78CE-281C-ABD846F3CB3C}"/>
+              </a:ext>
+            </a:extLst>
+          </p:cNvPr>
+          <p:cNvSpPr>
+            <a:spLocks noGrp="1"/>
+          </p:cNvSpPr>
+          <p:nvPr>
+            <p:ph type="body" sz="quarter" idx="19"/>
+          </p:nvPr>
+        </p:nvSpPr>
+        <p:spPr/>
+        <p:txBody>
+          <a:bodyPr/>
+          <a:lstStyle/>
+          <a:p>
+            <a:r>
+              <a:rPr lang="en-US" noProof="0" dirty="0"/>
+              <a:t>(Ferrari et al., 2025; Tech Inside Out 20</a:t>
+            </a:r>
+            <a:r>
+              <a:rPr lang="en-US" dirty="0"/>
+              <a:t>21</a:t>
+            </a:r>
+            <a:r>
+              <a:rPr lang="en-US" noProof="0" dirty="0"/>
+              <a:t>)</a:t>
+            </a:r>
+          </a:p>
+        </p:txBody>
+      </p:sp>
+      <p:sp>
+        <p:nvSpPr>
+          <p:cNvPr id="11" name="Fußzeilenplatzhalter 10">
+            <a:extLst>
+              <a:ext uri="{FF2B5EF4-FFF2-40B4-BE49-F238E27FC236}">
+                <a16:creationId xmlns:a16="http://schemas.microsoft.com/office/drawing/2014/main" id="{9E040E96-317A-C10D-4B2B-31D6C089B9D6}"/>
+              </a:ext>
+            </a:extLst>
+          </p:cNvPr>
+          <p:cNvSpPr>
+            <a:spLocks noGrp="1"/>
+          </p:cNvSpPr>
+          <p:nvPr>
+            <p:ph type="ftr" sz="quarter" idx="17"/>
+          </p:nvPr>
+        </p:nvSpPr>
+        <p:spPr/>
+        <p:txBody>
+          <a:bodyPr/>
+          <a:lstStyle/>
+          <a:p>
+            <a:endParaRPr lang="en-US" noProof="0" dirty="0"/>
+          </a:p>
+        </p:txBody>
+      </p:sp>
+      <p:sp>
+        <p:nvSpPr>
+          <p:cNvPr id="12" name="Foliennummernplatzhalter 11">
+            <a:extLst>
+              <a:ext uri="{FF2B5EF4-FFF2-40B4-BE49-F238E27FC236}">
+                <a16:creationId xmlns:a16="http://schemas.microsoft.com/office/drawing/2014/main" id="{11FC7BB2-8FB3-9A88-4C83-5936E9011CD0}"/>
+              </a:ext>
+            </a:extLst>
+          </p:cNvPr>
+          <p:cNvSpPr>
+            <a:spLocks noGrp="1"/>
+          </p:cNvSpPr>
+          <p:nvPr>
+            <p:ph type="sldNum" sz="quarter" idx="18"/>
+          </p:nvPr>
+        </p:nvSpPr>
+        <p:spPr/>
+        <p:txBody>
+          <a:bodyPr/>
+          <a:lstStyle/>
+          <a:p>
+            <a:fld id="{E6639024-6672-4F87-864B-EA4FA9190A1A}" type="slidenum">
+              <a:rPr lang="en-US" noProof="0" smtClean="0"/>
+              <a:pPr/>
+              <a:t>4</a:t>
+            </a:fld>
+            <a:endParaRPr lang="en-US" noProof="0" dirty="0"/>
+          </a:p>
+        </p:txBody>
+      </p:sp>
+      <p:sp>
+        <p:nvSpPr>
+          <p:cNvPr id="5" name="Textfeld 4">
+            <a:extLst>
+              <a:ext uri="{FF2B5EF4-FFF2-40B4-BE49-F238E27FC236}">
+                <a16:creationId xmlns:a16="http://schemas.microsoft.com/office/drawing/2014/main" id="{7ADA47EF-7EB6-938E-6E09-56430F4CA70D}"/>
+              </a:ext>
+            </a:extLst>
+          </p:cNvPr>
+          <p:cNvSpPr txBox="1"/>
+          <p:nvPr/>
+        </p:nvSpPr>
+        <p:spPr>
+          <a:xfrm>
+            <a:off x="1331640" y="2088634"/>
+            <a:ext cx="1952275" cy="1538883"/>
+          </a:xfrm>
+          <a:prstGeom prst="rect">
+            <a:avLst/>
+          </a:prstGeom>
+          <a:noFill/>
+        </p:spPr>
+        <p:txBody>
+          <a:bodyPr wrap="square" rtlCol="0">
+            <a:spAutoFit/>
+          </a:bodyPr>
+          <a:lstStyle/>
+          <a:p>
+            <a:pPr algn="ctr"/>
+            <a:r>
+              <a:rPr lang="en-US" sz="6000" noProof="0" dirty="0">
+                <a:solidFill>
+                  <a:schemeClr val="bg2"/>
+                </a:solidFill>
+              </a:rPr>
+              <a:t>39</a:t>
+            </a:r>
+            <a:r>
+              <a:rPr lang="en-US" sz="8000" noProof="0" dirty="0"/>
+              <a:t> </a:t>
+            </a:r>
+          </a:p>
+          <a:p>
+            <a:pPr algn="ctr"/>
+            <a:r>
+              <a:rPr lang="en-US" sz="1400" noProof="0" dirty="0"/>
+              <a:t>vulnerabilities per app</a:t>
+            </a:r>
+          </a:p>
+        </p:txBody>
+      </p:sp>
+      <p:sp>
+        <p:nvSpPr>
+          <p:cNvPr id="6" name="Textfeld 5">
+            <a:extLst>
+              <a:ext uri="{FF2B5EF4-FFF2-40B4-BE49-F238E27FC236}">
+                <a16:creationId xmlns:a16="http://schemas.microsoft.com/office/drawing/2014/main" id="{AF023A3C-46D8-3046-6EBE-17844C562EB6}"/>
+              </a:ext>
+            </a:extLst>
+          </p:cNvPr>
+          <p:cNvSpPr txBox="1"/>
+          <p:nvPr/>
+        </p:nvSpPr>
+        <p:spPr>
+          <a:xfrm>
+            <a:off x="5076056" y="2073246"/>
+            <a:ext cx="2196244" cy="1569660"/>
+          </a:xfrm>
+          <a:prstGeom prst="rect">
+            <a:avLst/>
+          </a:prstGeom>
+          <a:noFill/>
+        </p:spPr>
+        <p:txBody>
+          <a:bodyPr wrap="square" rtlCol="0">
+            <a:spAutoFit/>
+          </a:bodyPr>
+          <a:lstStyle/>
+          <a:p>
+            <a:pPr algn="ctr"/>
+            <a:r>
+              <a:rPr lang="en-US" sz="6000" noProof="0" dirty="0">
+                <a:solidFill>
+                  <a:schemeClr val="bg2"/>
+                </a:solidFill>
+              </a:rPr>
+              <a:t>63%</a:t>
+            </a:r>
+            <a:r>
+              <a:rPr lang="en-US" sz="8000" noProof="0" dirty="0">
+                <a:solidFill>
+                  <a:schemeClr val="bg2"/>
+                </a:solidFill>
+              </a:rPr>
+              <a:t> </a:t>
+            </a:r>
+          </a:p>
+          <a:p>
+            <a:pPr algn="ctr"/>
+            <a:r>
+              <a:rPr lang="en-US" sz="1400" noProof="0" dirty="0"/>
+              <a:t>apps show vulnerabilities</a:t>
+            </a:r>
+          </a:p>
+        </p:txBody>
+      </p:sp>
+      <p:sp>
+        <p:nvSpPr>
+          <p:cNvPr id="2" name="Inhaltsplatzhalter 9">
+            <a:extLst>
+              <a:ext uri="{FF2B5EF4-FFF2-40B4-BE49-F238E27FC236}">
+                <a16:creationId xmlns:a16="http://schemas.microsoft.com/office/drawing/2014/main" id="{7B402A66-69FE-A1BE-113F-727ECEA35F08}"/>
+              </a:ext>
+            </a:extLst>
+          </p:cNvPr>
+          <p:cNvSpPr txBox="1">
+            <a:spLocks/>
+          </p:cNvSpPr>
+          <p:nvPr/>
+        </p:nvSpPr>
+        <p:spPr>
+          <a:xfrm>
+            <a:off x="359532" y="1207321"/>
+            <a:ext cx="8424467" cy="3332402"/>
+          </a:xfrm>
+          <a:prstGeom prst="rect">
+            <a:avLst/>
+          </a:prstGeom>
+        </p:spPr>
+        <p:txBody>
+          <a:bodyPr vert="horz" lIns="36000" tIns="36000" rIns="36000" bIns="36000" rtlCol="0" anchor="t">
+            <a:normAutofit/>
+          </a:bodyPr>
+          <a:lstStyle>
+            <a:lvl1pPr marL="216000" indent="-216000" algn="l" defTabSz="685800" rtl="0" eaLnBrk="1" latinLnBrk="0" hangingPunct="1">
+              <a:lnSpc>
+                <a:spcPct val="100000"/>
+              </a:lnSpc>
+              <a:spcBef>
+                <a:spcPts val="200"/>
+              </a:spcBef>
+              <a:buClr>
+                <a:schemeClr val="tx1"/>
+              </a:buClr>
+              <a:buFont typeface="Symbol" panose="05050102010706020507" pitchFamily="18" charset="2"/>
+              <a:buChar char="-"/>
+              <a:defRPr sz="1800" kern="1200">
+                <a:solidFill>
+                  <a:schemeClr val="tx1"/>
+                </a:solidFill>
+                <a:latin typeface="+mn-lt"/>
+                <a:ea typeface="+mn-ea"/>
+                <a:cs typeface="+mn-cs"/>
+              </a:defRPr>
+            </a:lvl1pPr>
+            <a:lvl2pPr marL="432000" indent="-216000" algn="l" defTabSz="685800" rtl="0" eaLnBrk="1" latinLnBrk="0" hangingPunct="1">
+              <a:lnSpc>
+                <a:spcPct val="100000"/>
+              </a:lnSpc>
+              <a:spcBef>
+                <a:spcPts val="200"/>
+              </a:spcBef>
+              <a:buFont typeface="Symbol" panose="05050102010706020507" pitchFamily="18" charset="2"/>
+              <a:buChar char="-"/>
+              <a:defRPr sz="1600" kern="1200">
+                <a:solidFill>
+                  <a:schemeClr val="tx1"/>
+                </a:solidFill>
+                <a:latin typeface="+mn-lt"/>
+                <a:ea typeface="+mn-ea"/>
+                <a:cs typeface="+mn-cs"/>
+              </a:defRPr>
+            </a:lvl2pPr>
+            <a:lvl3pPr marL="648000" indent="-216000" algn="l" defTabSz="685800" rtl="0" eaLnBrk="1" latinLnBrk="0" hangingPunct="1">
+              <a:lnSpc>
+                <a:spcPct val="100000"/>
+              </a:lnSpc>
+              <a:spcBef>
+                <a:spcPts val="200"/>
+              </a:spcBef>
+              <a:buFont typeface="Symbol" panose="05050102010706020507" pitchFamily="18" charset="2"/>
+              <a:buChar char="-"/>
+              <a:defRPr sz="1400" kern="1200">
+                <a:solidFill>
+                  <a:schemeClr val="tx1"/>
+                </a:solidFill>
+                <a:latin typeface="+mn-lt"/>
+                <a:ea typeface="+mn-ea"/>
+                <a:cs typeface="+mn-cs"/>
+              </a:defRPr>
+            </a:lvl3pPr>
+            <a:lvl4pPr marL="864000" indent="-216000" algn="l" defTabSz="685800" rtl="0" eaLnBrk="1" latinLnBrk="0" hangingPunct="1">
+              <a:lnSpc>
+                <a:spcPct val="100000"/>
+              </a:lnSpc>
+              <a:spcBef>
+                <a:spcPts val="200"/>
+              </a:spcBef>
+              <a:buFont typeface="Symbol" panose="05050102010706020507" pitchFamily="18" charset="2"/>
+              <a:buChar char="-"/>
+              <a:defRPr sz="1200" kern="1200">
+                <a:solidFill>
+                  <a:schemeClr val="tx1"/>
+                </a:solidFill>
+                <a:latin typeface="+mn-lt"/>
+                <a:ea typeface="+mn-ea"/>
+                <a:cs typeface="+mn-cs"/>
+              </a:defRPr>
+            </a:lvl4pPr>
+            <a:lvl5pPr marL="1080000" indent="-216000" algn="l" defTabSz="685800" rtl="0" eaLnBrk="1" latinLnBrk="0" hangingPunct="1">
+              <a:lnSpc>
+                <a:spcPct val="100000"/>
+              </a:lnSpc>
+              <a:spcBef>
+                <a:spcPts val="200"/>
+              </a:spcBef>
+              <a:buFont typeface="Symbol" panose="05050102010706020507" pitchFamily="18" charset="2"/>
+              <a:buChar char="-"/>
+              <a:defRPr sz="1100" kern="1200">
+                <a:solidFill>
+                  <a:schemeClr val="tx1"/>
+                </a:solidFill>
+                <a:latin typeface="+mn-lt"/>
+                <a:ea typeface="+mn-ea"/>
+                <a:cs typeface="+mn-cs"/>
+              </a:defRPr>
+            </a:lvl5pPr>
+            <a:lvl6pPr marL="1885950" indent="-171450" algn="l" defTabSz="685800" rtl="0" eaLnBrk="1" latinLnBrk="0" hangingPunct="1">
+              <a:lnSpc>
+                <a:spcPct val="90000"/>
+              </a:lnSpc>
+              <a:spcBef>
+                <a:spcPts val="375"/>
+              </a:spcBef>
+              <a:buFont typeface="Arial" panose="020B0604020202020204" pitchFamily="34" charset="0"/>
+              <a:buChar char="•"/>
+              <a:defRPr sz="1350" kern="1200">
+                <a:solidFill>
+                  <a:schemeClr val="tx1"/>
+                </a:solidFill>
+                <a:latin typeface="+mn-lt"/>
+                <a:ea typeface="+mn-ea"/>
+                <a:cs typeface="+mn-cs"/>
+              </a:defRPr>
+            </a:lvl6pPr>
+            <a:lvl7pPr marL="2228850" indent="-171450" algn="l" defTabSz="685800" rtl="0" eaLnBrk="1" latinLnBrk="0" hangingPunct="1">
+              <a:lnSpc>
+                <a:spcPct val="90000"/>
+              </a:lnSpc>
+              <a:spcBef>
+                <a:spcPts val="375"/>
+              </a:spcBef>
+              <a:buFont typeface="Arial" panose="020B0604020202020204" pitchFamily="34" charset="0"/>
+              <a:buChar char="•"/>
+              <a:defRPr sz="1350" kern="1200">
+                <a:solidFill>
+                  <a:schemeClr val="tx1"/>
+                </a:solidFill>
+                <a:latin typeface="+mn-lt"/>
+                <a:ea typeface="+mn-ea"/>
+                <a:cs typeface="+mn-cs"/>
+              </a:defRPr>
+            </a:lvl7pPr>
+            <a:lvl8pPr marL="2571750" indent="-171450" algn="l" defTabSz="685800" rtl="0" eaLnBrk="1" latinLnBrk="0" hangingPunct="1">
+              <a:lnSpc>
+                <a:spcPct val="90000"/>
+              </a:lnSpc>
+              <a:spcBef>
+                <a:spcPts val="375"/>
+              </a:spcBef>
+              <a:buFont typeface="Arial" panose="020B0604020202020204" pitchFamily="34" charset="0"/>
+              <a:buChar char="•"/>
+              <a:defRPr sz="1350" kern="1200">
+                <a:solidFill>
+                  <a:schemeClr val="tx1"/>
+                </a:solidFill>
+                <a:latin typeface="+mn-lt"/>
+                <a:ea typeface="+mn-ea"/>
+                <a:cs typeface="+mn-cs"/>
+              </a:defRPr>
+            </a:lvl8pPr>
+            <a:lvl9pPr marL="2914650" indent="-171450" algn="l" defTabSz="685800" rtl="0" eaLnBrk="1" latinLnBrk="0" hangingPunct="1">
+              <a:lnSpc>
+                <a:spcPct val="90000"/>
+              </a:lnSpc>
+              <a:spcBef>
+                <a:spcPts val="375"/>
+              </a:spcBef>
+              <a:buFont typeface="Arial" panose="020B0604020202020204" pitchFamily="34" charset="0"/>
+              <a:buChar char="•"/>
+              <a:defRPr sz="1350" kern="1200">
+                <a:solidFill>
+                  <a:schemeClr val="tx1"/>
+                </a:solidFill>
+                <a:latin typeface="+mn-lt"/>
+                <a:ea typeface="+mn-ea"/>
+                <a:cs typeface="+mn-cs"/>
+              </a:defRPr>
+            </a:lvl9pPr>
+          </a:lstStyle>
+          <a:p>
+            <a:pPr marL="0" indent="0">
+              <a:lnSpc>
+                <a:spcPct val="150000"/>
+              </a:lnSpc>
+              <a:buNone/>
+            </a:pPr>
+            <a:r>
+              <a:rPr lang="en-US" noProof="0" dirty="0"/>
+              <a:t>Across the 18 most popular Android categories:</a:t>
+            </a:r>
+          </a:p>
+          <a:p>
+            <a:pPr>
+              <a:lnSpc>
+                <a:spcPct val="150000"/>
+              </a:lnSpc>
+            </a:pPr>
+            <a:endParaRPr lang="en-US" noProof="0" dirty="0"/>
+          </a:p>
+          <a:p>
+            <a:pPr>
+              <a:lnSpc>
+                <a:spcPct val="150000"/>
+              </a:lnSpc>
+            </a:pPr>
+            <a:endParaRPr lang="en-US" noProof="0" dirty="0"/>
+          </a:p>
+        </p:txBody>
+      </p:sp>
+    </p:spTree>
+    <p:extLst>
+      <p:ext uri="{BB962C8B-B14F-4D97-AF65-F5344CB8AC3E}">
+        <p14:creationId xmlns:p14="http://schemas.microsoft.com/office/powerpoint/2010/main" val="3225203029"/>
+      </p:ext>
+    </p:extLst>
+  </p:cSld>
+  <p:clrMapOvr>
+    <a:masterClrMapping/>
+  </p:clrMapOvr>
+</p:sld>
+</file>
+
+<file path=ppt/slides/slide40.xml><?xml version="1.0" encoding="utf-8"?>
 <p:sld xmlns:a="http://schemas.openxmlformats.org/drawingml/2006/main" xmlns:r="http://schemas.openxmlformats.org/officeDocument/2006/relationships" xmlns:p="http://schemas.openxmlformats.org/presentationml/2006/main">
   <p:cSld>
     <p:spTree>
@@ -42721,7 +42044,7 @@
             <a:fld id="{E6639024-6672-4F87-864B-EA4FA9190A1A}" type="slidenum">
               <a:rPr lang="en-US" noProof="0" smtClean="0"/>
               <a:pPr/>
-              <a:t>41</a:t>
+              <a:t>40</a:t>
             </a:fld>
             <a:endParaRPr lang="en-US" noProof="0" dirty="0"/>
           </a:p>
@@ -42740,7 +42063,7 @@
 </p:sld>
 </file>
 
-<file path=ppt/slides/slide42.xml><?xml version="1.0" encoding="utf-8"?>
+<file path=ppt/slides/slide41.xml><?xml version="1.0" encoding="utf-8"?>
 <p:sld xmlns:a="http://schemas.openxmlformats.org/drawingml/2006/main" xmlns:r="http://schemas.openxmlformats.org/officeDocument/2006/relationships" xmlns:p="http://schemas.openxmlformats.org/presentationml/2006/main">
   <p:cSld>
     <p:spTree>
@@ -42953,7 +42276,7 @@
             <a:fld id="{E6639024-6672-4F87-864B-EA4FA9190A1A}" type="slidenum">
               <a:rPr lang="en-US" noProof="0" smtClean="0"/>
               <a:pPr/>
-              <a:t>42</a:t>
+              <a:t>41</a:t>
             </a:fld>
             <a:endParaRPr lang="en-US" noProof="0" dirty="0"/>
           </a:p>
@@ -42972,7 +42295,7 @@
 </p:sld>
 </file>
 
-<file path=ppt/slides/slide43.xml><?xml version="1.0" encoding="utf-8"?>
+<file path=ppt/slides/slide42.xml><?xml version="1.0" encoding="utf-8"?>
 <p:sld xmlns:a="http://schemas.openxmlformats.org/drawingml/2006/main" xmlns:r="http://schemas.openxmlformats.org/officeDocument/2006/relationships" xmlns:p="http://schemas.openxmlformats.org/presentationml/2006/main">
   <p:cSld>
     <p:spTree>
@@ -43185,7 +42508,7 @@
             <a:fld id="{E6639024-6672-4F87-864B-EA4FA9190A1A}" type="slidenum">
               <a:rPr lang="en-US" noProof="0" smtClean="0"/>
               <a:pPr/>
-              <a:t>43</a:t>
+              <a:t>42</a:t>
             </a:fld>
             <a:endParaRPr lang="en-US" noProof="0" dirty="0"/>
           </a:p>
@@ -43204,7 +42527,7 @@
 </p:sld>
 </file>
 
-<file path=ppt/slides/slide44.xml><?xml version="1.0" encoding="utf-8"?>
+<file path=ppt/slides/slide43.xml><?xml version="1.0" encoding="utf-8"?>
 <p:sld xmlns:a="http://schemas.openxmlformats.org/drawingml/2006/main" xmlns:r="http://schemas.openxmlformats.org/officeDocument/2006/relationships" xmlns:p="http://schemas.openxmlformats.org/presentationml/2006/main">
   <p:cSld>
     <p:spTree>
@@ -43327,7 +42650,7 @@
             </a:pPr>
             <a:r>
               <a:rPr lang="en-US" noProof="0" dirty="0"/>
-              <a:t>Privacy and auth still neglected</a:t>
+              <a:t>Privacy and Auth still neglected</a:t>
             </a:r>
           </a:p>
           <a:p>
@@ -43417,7 +42740,7 @@
             <a:fld id="{E6639024-6672-4F87-864B-EA4FA9190A1A}" type="slidenum">
               <a:rPr lang="en-US" noProof="0" smtClean="0"/>
               <a:pPr/>
-              <a:t>44</a:t>
+              <a:t>43</a:t>
             </a:fld>
             <a:endParaRPr lang="en-US" noProof="0" dirty="0"/>
           </a:p>
@@ -43436,7 +42759,7 @@
 </p:sld>
 </file>
 
-<file path=ppt/slides/slide45.xml><?xml version="1.0" encoding="utf-8"?>
+<file path=ppt/slides/slide44.xml><?xml version="1.0" encoding="utf-8"?>
 <p:sld xmlns:a="http://schemas.openxmlformats.org/drawingml/2006/main" xmlns:r="http://schemas.openxmlformats.org/officeDocument/2006/relationships" xmlns:p="http://schemas.openxmlformats.org/presentationml/2006/main">
   <p:cSld>
     <p:spTree>
@@ -43548,7 +42871,7 @@
             </a:pPr>
             <a:r>
               <a:rPr lang="en-US" noProof="0" dirty="0"/>
-              <a:t>Identified weaknesses of MASTG apps</a:t>
+              <a:t>Identified weaknesses of MASTG reference apps</a:t>
             </a:r>
           </a:p>
           <a:p>
@@ -43669,7 +42992,7 @@
             <a:fld id="{E6639024-6672-4F87-864B-EA4FA9190A1A}" type="slidenum">
               <a:rPr lang="en-US" noProof="0" smtClean="0"/>
               <a:pPr/>
-              <a:t>45</a:t>
+              <a:t>44</a:t>
             </a:fld>
             <a:endParaRPr lang="en-US" noProof="0" dirty="0"/>
           </a:p>
@@ -43688,7 +43011,7 @@
 </p:sld>
 </file>
 
-<file path=ppt/slides/slide46.xml><?xml version="1.0" encoding="utf-8"?>
+<file path=ppt/slides/slide45.xml><?xml version="1.0" encoding="utf-8"?>
 <p:sld xmlns:a="http://schemas.openxmlformats.org/drawingml/2006/main" xmlns:r="http://schemas.openxmlformats.org/officeDocument/2006/relationships" xmlns:p="http://schemas.openxmlformats.org/presentationml/2006/main">
   <p:cSld>
     <p:spTree>
@@ -43873,7 +43196,7 @@
             <a:fld id="{E6639024-6672-4F87-864B-EA4FA9190A1A}" type="slidenum">
               <a:rPr lang="en-US" noProof="0" smtClean="0"/>
               <a:pPr/>
-              <a:t>46</a:t>
+              <a:t>45</a:t>
             </a:fld>
             <a:endParaRPr lang="en-US" noProof="0" dirty="0"/>
           </a:p>
@@ -43892,7 +43215,7 @@
 </p:sld>
 </file>
 
-<file path=ppt/slides/slide47.xml><?xml version="1.0" encoding="utf-8"?>
+<file path=ppt/slides/slide46.xml><?xml version="1.0" encoding="utf-8"?>
 <p:sld xmlns:a="http://schemas.openxmlformats.org/drawingml/2006/main" xmlns:r="http://schemas.openxmlformats.org/officeDocument/2006/relationships" xmlns:p="http://schemas.openxmlformats.org/presentationml/2006/main">
   <p:cSld>
     <p:spTree>
@@ -44002,22 +43325,26 @@
               </a:lnSpc>
             </a:pPr>
             <a:r>
+              <a:rPr lang="en-US" sz="1400" dirty="0" err="1"/>
+              <a:t>StatCounter</a:t>
+            </a:r>
+            <a:r>
               <a:rPr lang="en-US" sz="1400" dirty="0"/>
-              <a:t>Tech Inside Out. (2021, August 2). </a:t>
+              <a:t> Global Stats. (2026). </a:t>
             </a:r>
             <a:r>
               <a:rPr lang="en-US" sz="1400" i="1" dirty="0"/>
-              <a:t>Security vulnerabilities found in over 60% of Android apps</a:t>
+              <a:t>Mobile operating system market share worldwide</a:t>
             </a:r>
             <a:r>
               <a:rPr lang="en-US" sz="1400" dirty="0"/>
-              <a:t>. </a:t>
+              <a:t>. Retrieved February 3, 2026, from </a:t>
             </a:r>
             <a:r>
               <a:rPr lang="en-US" sz="1400" dirty="0">
                 <a:hlinkClick r:id="rId2"/>
               </a:rPr>
-              <a:t>https://www.techinsideout.co/inside/security-vulnerabilities-found-in-over-60-of-android-apps</a:t>
+              <a:t>https://gs.statcounter.com/os-market-share/mobile/worldwide</a:t>
             </a:r>
             <a:endParaRPr lang="en-US" sz="1400" dirty="0"/>
           </a:p>
@@ -44029,23 +43356,57 @@
             </a:pPr>
             <a:r>
               <a:rPr lang="en-US" sz="1400" dirty="0"/>
-              <a:t>StatCounter Global Stats. (2026). </a:t>
+              <a:t>Tech Inside Out. (2021, August 2). </a:t>
             </a:r>
             <a:r>
               <a:rPr lang="en-US" sz="1400" i="1" dirty="0"/>
-              <a:t>Mobile operating system market share worldwide</a:t>
+              <a:t>Security vulnerabilities found in over 60% of Android apps</a:t>
             </a:r>
             <a:r>
               <a:rPr lang="en-US" sz="1400" dirty="0"/>
-              <a:t>. Retrieved February 3, 2026, from </a:t>
+              <a:t>. </a:t>
             </a:r>
             <a:r>
               <a:rPr lang="en-US" sz="1400" dirty="0">
                 <a:hlinkClick r:id="rId3"/>
               </a:rPr>
-              <a:t>https://gs.statcounter.com/os-market-share/mobile/worldwide</a:t>
-            </a:r>
-            <a:endParaRPr lang="en-US" sz="1400" noProof="0" dirty="0"/>
+              <a:t>https://www.techinsideout.co/inside/security-vulnerabilities-found-in-over-60-of-android-apps</a:t>
+            </a:r>
+            <a:endParaRPr lang="en-US" sz="1400" dirty="0"/>
+          </a:p>
+          <a:p>
+            <a:pPr>
+              <a:lnSpc>
+                <a:spcPct val="150000"/>
+              </a:lnSpc>
+            </a:pPr>
+            <a:r>
+              <a:rPr lang="en-US" sz="1400" dirty="0"/>
+              <a:t>Stevenson, L., &amp; Das, S. (2025). </a:t>
+            </a:r>
+            <a:r>
+              <a:rPr lang="en-US" sz="1400" i="1" dirty="0"/>
+              <a:t>“Your doctor is spying on you”: An analysis of data practices in mobile healthcare applications</a:t>
+            </a:r>
+            <a:r>
+              <a:rPr lang="en-US" sz="1400" dirty="0"/>
+              <a:t> (arXiv:2510.06015). </a:t>
+            </a:r>
+            <a:r>
+              <a:rPr lang="en-US" sz="1400" dirty="0" err="1"/>
+              <a:t>arXiv</a:t>
+            </a:r>
+            <a:r>
+              <a:rPr lang="en-US" sz="1400" dirty="0"/>
+              <a:t>. </a:t>
+            </a:r>
+            <a:r>
+              <a:rPr lang="en-US" sz="1400" dirty="0">
+                <a:hlinkClick r:id="rId4"/>
+              </a:rPr>
+              <a:t>https://doi.org/10.48550/arXiv.2510.06015</a:t>
+            </a:r>
+            <a:endParaRPr lang="en-US" sz="1400" dirty="0"/>
           </a:p>
         </p:txBody>
       </p:sp>
@@ -44123,7 +43484,7 @@
             <a:fld id="{E6639024-6672-4F87-864B-EA4FA9190A1A}" type="slidenum">
               <a:rPr lang="en-US" noProof="0" smtClean="0"/>
               <a:pPr/>
-              <a:t>47</a:t>
+              <a:t>46</a:t>
             </a:fld>
             <a:endParaRPr lang="en-US" noProof="0" dirty="0"/>
           </a:p>
@@ -44133,6 +43494,402 @@
     <p:extLst>
       <p:ext uri="{BB962C8B-B14F-4D97-AF65-F5344CB8AC3E}">
         <p14:creationId xmlns:p14="http://schemas.microsoft.com/office/powerpoint/2010/main" val="2128757960"/>
+      </p:ext>
+    </p:extLst>
+  </p:cSld>
+  <p:clrMapOvr>
+    <a:masterClrMapping/>
+  </p:clrMapOvr>
+</p:sld>
+</file>
+
+<file path=ppt/slides/slide47.xml><?xml version="1.0" encoding="utf-8"?>
+<p:sld xmlns:a="http://schemas.openxmlformats.org/drawingml/2006/main" xmlns:r="http://schemas.openxmlformats.org/officeDocument/2006/relationships" xmlns:p="http://schemas.openxmlformats.org/presentationml/2006/main">
+  <p:cSld>
+    <p:spTree>
+      <p:nvGrpSpPr>
+        <p:cNvPr id="1" name="">
+          <a:extLst>
+            <a:ext uri="{FF2B5EF4-FFF2-40B4-BE49-F238E27FC236}">
+              <a16:creationId xmlns:a16="http://schemas.microsoft.com/office/drawing/2014/main" id="{BB40AE52-FC4D-C8EB-2D9D-4D6B89AF5260}"/>
+            </a:ext>
+          </a:extLst>
+        </p:cNvPr>
+        <p:cNvGrpSpPr/>
+        <p:nvPr/>
+      </p:nvGrpSpPr>
+      <p:grpSpPr>
+        <a:xfrm>
+          <a:off x="0" y="0"/>
+          <a:ext cx="0" cy="0"/>
+          <a:chOff x="0" y="0"/>
+          <a:chExt cx="0" cy="0"/>
+        </a:xfrm>
+      </p:grpSpPr>
+      <p:sp>
+        <p:nvSpPr>
+          <p:cNvPr id="8" name="Textplatzhalter 7">
+            <a:extLst>
+              <a:ext uri="{FF2B5EF4-FFF2-40B4-BE49-F238E27FC236}">
+                <a16:creationId xmlns:a16="http://schemas.microsoft.com/office/drawing/2014/main" id="{CDED4ACE-6196-C8D7-8A33-7F52874BCD9F}"/>
+              </a:ext>
+            </a:extLst>
+          </p:cNvPr>
+          <p:cNvSpPr>
+            <a:spLocks noGrp="1"/>
+          </p:cNvSpPr>
+          <p:nvPr>
+            <p:ph type="body" sz="quarter" idx="12"/>
+          </p:nvPr>
+        </p:nvSpPr>
+        <p:spPr/>
+        <p:txBody>
+          <a:bodyPr/>
+          <a:lstStyle/>
+          <a:p>
+            <a:endParaRPr lang="en-US" noProof="0" dirty="0"/>
+          </a:p>
+        </p:txBody>
+      </p:sp>
+      <p:sp>
+        <p:nvSpPr>
+          <p:cNvPr id="7" name="Titel 6">
+            <a:extLst>
+              <a:ext uri="{FF2B5EF4-FFF2-40B4-BE49-F238E27FC236}">
+                <a16:creationId xmlns:a16="http://schemas.microsoft.com/office/drawing/2014/main" id="{CFA00ED5-48B8-9DCD-233D-6BEB2B0C8011}"/>
+              </a:ext>
+            </a:extLst>
+          </p:cNvPr>
+          <p:cNvSpPr>
+            <a:spLocks noGrp="1"/>
+          </p:cNvSpPr>
+          <p:nvPr>
+            <p:ph type="title"/>
+          </p:nvPr>
+        </p:nvSpPr>
+        <p:spPr/>
+        <p:txBody>
+          <a:bodyPr/>
+          <a:lstStyle/>
+          <a:p>
+            <a:r>
+              <a:rPr lang="en-US" noProof="0" dirty="0"/>
+              <a:t>References</a:t>
+            </a:r>
+          </a:p>
+        </p:txBody>
+      </p:sp>
+      <p:sp>
+        <p:nvSpPr>
+          <p:cNvPr id="10" name="Inhaltsplatzhalter 9">
+            <a:extLst>
+              <a:ext uri="{FF2B5EF4-FFF2-40B4-BE49-F238E27FC236}">
+                <a16:creationId xmlns:a16="http://schemas.microsoft.com/office/drawing/2014/main" id="{09A9A1BE-072D-3160-0CDF-6BEE52C1A57A}"/>
+              </a:ext>
+            </a:extLst>
+          </p:cNvPr>
+          <p:cNvSpPr>
+            <a:spLocks noGrp="1"/>
+          </p:cNvSpPr>
+          <p:nvPr>
+            <p:ph sz="quarter" idx="20"/>
+          </p:nvPr>
+        </p:nvSpPr>
+        <p:spPr>
+          <a:xfrm>
+            <a:off x="359533" y="1203598"/>
+            <a:ext cx="8424467" cy="3332402"/>
+          </a:xfrm>
+        </p:spPr>
+        <p:txBody>
+          <a:bodyPr anchor="t">
+            <a:normAutofit/>
+          </a:bodyPr>
+          <a:lstStyle/>
+          <a:p>
+            <a:pPr>
+              <a:lnSpc>
+                <a:spcPct val="150000"/>
+              </a:lnSpc>
+            </a:pPr>
+            <a:r>
+              <a:rPr lang="de-CH" sz="1400" dirty="0"/>
+              <a:t>Chiboora, T. H., </a:t>
+            </a:r>
+            <a:r>
+              <a:rPr lang="de-CH" sz="1400" dirty="0" err="1"/>
+              <a:t>Chacha</a:t>
+            </a:r>
+            <a:r>
+              <a:rPr lang="de-CH" sz="1400" dirty="0"/>
+              <a:t>, L., </a:t>
+            </a:r>
+            <a:r>
+              <a:rPr lang="de-CH" sz="1400" dirty="0" err="1"/>
+              <a:t>Byagutangaza</a:t>
+            </a:r>
+            <a:r>
+              <a:rPr lang="de-CH" sz="1400" dirty="0"/>
+              <a:t>, T., &amp; </a:t>
+            </a:r>
+            <a:r>
+              <a:rPr lang="de-CH" sz="1400" dirty="0" err="1"/>
+              <a:t>Gueye</a:t>
+            </a:r>
+            <a:r>
+              <a:rPr lang="de-CH" sz="1400" dirty="0"/>
+              <a:t>, A. (2023). </a:t>
+            </a:r>
+            <a:r>
+              <a:rPr lang="de-CH" sz="1400" i="1" dirty="0" err="1"/>
+              <a:t>Evaluating</a:t>
+            </a:r>
+            <a:r>
+              <a:rPr lang="de-CH" sz="1400" i="1" dirty="0"/>
+              <a:t> mobile </a:t>
+            </a:r>
+            <a:r>
+              <a:rPr lang="de-CH" sz="1400" i="1" dirty="0" err="1"/>
+              <a:t>banking</a:t>
+            </a:r>
+            <a:r>
+              <a:rPr lang="de-CH" sz="1400" i="1" dirty="0"/>
+              <a:t> </a:t>
+            </a:r>
+            <a:r>
+              <a:rPr lang="de-CH" sz="1400" i="1" dirty="0" err="1"/>
+              <a:t>application</a:t>
+            </a:r>
+            <a:r>
+              <a:rPr lang="de-CH" sz="1400" i="1" dirty="0"/>
+              <a:t> </a:t>
+            </a:r>
+            <a:r>
+              <a:rPr lang="de-CH" sz="1400" i="1" dirty="0" err="1"/>
+              <a:t>security</a:t>
+            </a:r>
+            <a:r>
+              <a:rPr lang="de-CH" sz="1400" i="1" dirty="0"/>
+              <a:t> </a:t>
+            </a:r>
+            <a:r>
+              <a:rPr lang="de-CH" sz="1400" i="1" dirty="0" err="1"/>
+              <a:t>posture</a:t>
+            </a:r>
+            <a:r>
+              <a:rPr lang="de-CH" sz="1400" i="1" dirty="0"/>
+              <a:t> </a:t>
+            </a:r>
+            <a:r>
+              <a:rPr lang="de-CH" sz="1400" i="1" dirty="0" err="1"/>
+              <a:t>using</a:t>
+            </a:r>
+            <a:r>
+              <a:rPr lang="de-CH" sz="1400" i="1" dirty="0"/>
+              <a:t> </a:t>
+            </a:r>
+            <a:r>
+              <a:rPr lang="de-CH" sz="1400" i="1" dirty="0" err="1"/>
+              <a:t>the</a:t>
+            </a:r>
+            <a:r>
+              <a:rPr lang="de-CH" sz="1400" i="1" dirty="0"/>
+              <a:t> </a:t>
+            </a:r>
+            <a:r>
+              <a:rPr lang="de-CH" sz="1400" i="1" dirty="0" err="1"/>
+              <a:t>OWASP’s</a:t>
+            </a:r>
+            <a:r>
+              <a:rPr lang="de-CH" sz="1400" i="1" dirty="0"/>
+              <a:t> MASVS </a:t>
+            </a:r>
+            <a:r>
+              <a:rPr lang="de-CH" sz="1400" i="1" dirty="0" err="1"/>
+              <a:t>framework</a:t>
+            </a:r>
+            <a:r>
+              <a:rPr lang="de-CH" sz="1400" dirty="0"/>
+              <a:t>. In </a:t>
+            </a:r>
+            <a:r>
+              <a:rPr lang="de-CH" sz="1400" i="1" dirty="0"/>
+              <a:t>Proceedings </a:t>
+            </a:r>
+            <a:r>
+              <a:rPr lang="de-CH" sz="1400" i="1" dirty="0" err="1"/>
+              <a:t>of</a:t>
+            </a:r>
+            <a:r>
+              <a:rPr lang="de-CH" sz="1400" i="1" dirty="0"/>
+              <a:t> </a:t>
+            </a:r>
+            <a:r>
+              <a:rPr lang="de-CH" sz="1400" i="1" dirty="0" err="1"/>
+              <a:t>the</a:t>
+            </a:r>
+            <a:r>
+              <a:rPr lang="de-CH" sz="1400" i="1" dirty="0"/>
+              <a:t> 6th ACM SIGCAS/SIGCHI Conference on Computing and </a:t>
+            </a:r>
+            <a:r>
+              <a:rPr lang="de-CH" sz="1400" i="1" dirty="0" err="1"/>
+              <a:t>Sustainable</a:t>
+            </a:r>
+            <a:r>
+              <a:rPr lang="de-CH" sz="1400" i="1" dirty="0"/>
+              <a:t> Societies (COMPASS 2023)</a:t>
+            </a:r>
+            <a:r>
+              <a:rPr lang="de-CH" sz="1400" dirty="0"/>
+              <a:t> (pp. 99–106). ACM. </a:t>
+            </a:r>
+            <a:r>
+              <a:rPr lang="de-CH" sz="1400" dirty="0">
+                <a:hlinkClick r:id="rId2"/>
+              </a:rPr>
+              <a:t>https://doi.org/10.1145/3588001.3609367</a:t>
+            </a:r>
+            <a:endParaRPr lang="de-CH" sz="1400" dirty="0"/>
+          </a:p>
+          <a:p>
+            <a:pPr>
+              <a:lnSpc>
+                <a:spcPct val="150000"/>
+              </a:lnSpc>
+            </a:pPr>
+            <a:r>
+              <a:rPr lang="en-US" sz="1400" dirty="0"/>
+              <a:t>OWASP Mobile Application Security. (2025). </a:t>
+            </a:r>
+            <a:r>
+              <a:rPr lang="en-US" sz="1400" i="1" dirty="0"/>
+              <a:t>Home page</a:t>
+            </a:r>
+            <a:r>
+              <a:rPr lang="en-US" sz="1400" dirty="0"/>
+              <a:t>. The OWASP Foundation. </a:t>
+            </a:r>
+            <a:r>
+              <a:rPr lang="en-US" sz="1400" dirty="0">
+                <a:hlinkClick r:id="rId3"/>
+              </a:rPr>
+              <a:t>https://mas.owasp.org/</a:t>
+            </a:r>
+            <a:endParaRPr lang="en-US" sz="1400" dirty="0"/>
+          </a:p>
+          <a:p>
+            <a:pPr>
+              <a:lnSpc>
+                <a:spcPct val="150000"/>
+              </a:lnSpc>
+            </a:pPr>
+            <a:r>
+              <a:rPr lang="en-US" sz="1400" dirty="0"/>
+              <a:t>OWASP Mobile Application Security Testing Guide (MASTG). (2025). </a:t>
+            </a:r>
+            <a:r>
+              <a:rPr lang="en-US" sz="1400" i="1" dirty="0"/>
+              <a:t>Android reference apps section</a:t>
+            </a:r>
+            <a:r>
+              <a:rPr lang="en-US" sz="1400" dirty="0"/>
+              <a:t>. The OWASP Foundation. </a:t>
+            </a:r>
+            <a:r>
+              <a:rPr lang="en-US" sz="1400" dirty="0">
+                <a:hlinkClick r:id="rId4"/>
+              </a:rPr>
+              <a:t>https://github.com/OWASP/mastg/tree/ffde0bdd9bdfd375d93ddb433bd3134e3977c64d/apps/android</a:t>
+            </a:r>
+            <a:endParaRPr lang="en-US" sz="1400" noProof="0" dirty="0"/>
+          </a:p>
+        </p:txBody>
+      </p:sp>
+      <p:sp>
+        <p:nvSpPr>
+          <p:cNvPr id="9" name="Textplatzhalter 8">
+            <a:extLst>
+              <a:ext uri="{FF2B5EF4-FFF2-40B4-BE49-F238E27FC236}">
+                <a16:creationId xmlns:a16="http://schemas.microsoft.com/office/drawing/2014/main" id="{0FD75FB1-E467-F2FE-BC4D-F49775063E4C}"/>
+              </a:ext>
+            </a:extLst>
+          </p:cNvPr>
+          <p:cNvSpPr>
+            <a:spLocks noGrp="1"/>
+          </p:cNvSpPr>
+          <p:nvPr>
+            <p:ph type="body" sz="quarter" idx="19"/>
+          </p:nvPr>
+        </p:nvSpPr>
+        <p:spPr/>
+        <p:txBody>
+          <a:bodyPr/>
+          <a:lstStyle/>
+          <a:p>
+            <a:endParaRPr lang="en-US" noProof="0" dirty="0"/>
+          </a:p>
+        </p:txBody>
+      </p:sp>
+      <p:sp>
+        <p:nvSpPr>
+          <p:cNvPr id="11" name="Fußzeilenplatzhalter 10">
+            <a:extLst>
+              <a:ext uri="{FF2B5EF4-FFF2-40B4-BE49-F238E27FC236}">
+                <a16:creationId xmlns:a16="http://schemas.microsoft.com/office/drawing/2014/main" id="{A907E6BB-8850-8DA0-6092-87B50923B4F2}"/>
+              </a:ext>
+            </a:extLst>
+          </p:cNvPr>
+          <p:cNvSpPr>
+            <a:spLocks noGrp="1"/>
+          </p:cNvSpPr>
+          <p:nvPr>
+            <p:ph type="ftr" sz="quarter" idx="17"/>
+          </p:nvPr>
+        </p:nvSpPr>
+        <p:spPr/>
+        <p:txBody>
+          <a:bodyPr/>
+          <a:lstStyle/>
+          <a:p>
+            <a:endParaRPr lang="en-US" noProof="0" dirty="0"/>
+          </a:p>
+        </p:txBody>
+      </p:sp>
+      <p:sp>
+        <p:nvSpPr>
+          <p:cNvPr id="12" name="Foliennummernplatzhalter 11">
+            <a:extLst>
+              <a:ext uri="{FF2B5EF4-FFF2-40B4-BE49-F238E27FC236}">
+                <a16:creationId xmlns:a16="http://schemas.microsoft.com/office/drawing/2014/main" id="{32296EAA-DCB2-B193-D4AA-9D3B42002ACE}"/>
+              </a:ext>
+            </a:extLst>
+          </p:cNvPr>
+          <p:cNvSpPr>
+            <a:spLocks noGrp="1"/>
+          </p:cNvSpPr>
+          <p:nvPr>
+            <p:ph type="sldNum" sz="quarter" idx="18"/>
+          </p:nvPr>
+        </p:nvSpPr>
+        <p:spPr/>
+        <p:txBody>
+          <a:bodyPr/>
+          <a:lstStyle/>
+          <a:p>
+            <a:fld id="{E6639024-6672-4F87-864B-EA4FA9190A1A}" type="slidenum">
+              <a:rPr lang="en-US" noProof="0" smtClean="0"/>
+              <a:pPr/>
+              <a:t>47</a:t>
+            </a:fld>
+            <a:endParaRPr lang="en-US" noProof="0" dirty="0"/>
+          </a:p>
+        </p:txBody>
+      </p:sp>
+    </p:spTree>
+    <p:extLst>
+      <p:ext uri="{BB962C8B-B14F-4D97-AF65-F5344CB8AC3E}">
+        <p14:creationId xmlns:p14="http://schemas.microsoft.com/office/powerpoint/2010/main" val="1316929055"/>
       </p:ext>
     </p:extLst>
   </p:cSld>
@@ -45021,7 +44778,19 @@
           <a:p>
             <a:r>
               <a:rPr lang="en-US" noProof="0" dirty="0"/>
-              <a:t>(Ferrari et al., 2025; Stevenson &amp; Das, 2025 )</a:t>
+              <a:t>(</a:t>
+            </a:r>
+            <a:r>
+              <a:rPr lang="en-US" dirty="0"/>
+              <a:t>S</a:t>
+            </a:r>
+            <a:r>
+              <a:rPr lang="en-US" noProof="0" dirty="0" err="1"/>
+              <a:t>tevenson</a:t>
+            </a:r>
+            <a:r>
+              <a:rPr lang="en-US" noProof="0" dirty="0"/>
+              <a:t> &amp; Das, 2025 )</a:t>
             </a:r>
           </a:p>
         </p:txBody>
@@ -45977,8 +45746,12 @@
           <a:lstStyle/>
           <a:p>
             <a:r>
+              <a:rPr lang="de-CH" dirty="0"/>
+              <a:t>(Chiboora et al., 2023</a:t>
+            </a:r>
+            <a:r>
               <a:rPr lang="en-US" noProof="0" dirty="0"/>
-              <a:t>(Ferrari et al., 2025; Stevenson &amp; Das, 2025 )</a:t>
+              <a:t>)</a:t>
             </a:r>
           </a:p>
         </p:txBody>

</xml_diff>

<commit_message>
Changed the coloring scheme of titles and subtitles of my presentation, swapping them.
</commit_message>
<xml_diff>
--- a/dev_documents/presentation/ba_thesis_presentation_kronig.pptx
+++ b/dev_documents/presentation/ba_thesis_presentation_kronig.pptx
@@ -252,7 +252,7 @@
           <a:p>
             <a:fld id="{442B13D9-EE20-4263-A517-453A6CC03581}" type="datetimeFigureOut">
               <a:rPr lang="en-US" smtClean="0"/>
-              <a:t>2/3/2026</a:t>
+              <a:t>2/4/2026</a:t>
             </a:fld>
             <a:endParaRPr lang="en-US"/>
           </a:p>
@@ -417,7 +417,7 @@
           <a:p>
             <a:fld id="{C4B9E2E8-0589-406D-8FD1-7B0DBC84FBDE}" type="datetimeFigureOut">
               <a:rPr lang="de-CH" smtClean="0"/>
-              <a:t>03.02.2026</a:t>
+              <a:t>04.02.2026</a:t>
             </a:fld>
             <a:endParaRPr lang="de-CH"/>
           </a:p>
@@ -31324,7 +31324,11 @@
           <a:lstStyle/>
           <a:p>
             <a:r>
-              <a:rPr lang="en-US" sz="1400" noProof="0" dirty="0"/>
+              <a:rPr lang="en-US" sz="1400" noProof="0" dirty="0">
+                <a:solidFill>
+                  <a:schemeClr val="bg2"/>
+                </a:solidFill>
+              </a:rPr>
               <a:t>BA Thesis Presentation</a:t>
             </a:r>
           </a:p>
@@ -31346,7 +31350,11 @@
           <a:lstStyle/>
           <a:p>
             <a:r>
-              <a:rPr lang="en-US" sz="1800" noProof="0" dirty="0"/>
+              <a:rPr lang="en-US" sz="1800" noProof="0" dirty="0">
+                <a:solidFill>
+                  <a:schemeClr val="tx1"/>
+                </a:solidFill>
+              </a:rPr>
               <a:t>Development of a Reference Application for the OWASP Mobile Application Security Testing Guide (MASTG)</a:t>
             </a:r>
           </a:p>
@@ -31473,10 +31481,18 @@
           <a:lstStyle/>
           <a:p>
             <a:r>
-              <a:rPr lang="en-US" dirty="0"/>
+              <a:rPr lang="en-US" dirty="0">
+                <a:solidFill>
+                  <a:schemeClr val="bg2"/>
+                </a:solidFill>
+              </a:rPr>
               <a:t>Mobile Security Knowledge</a:t>
             </a:r>
-            <a:endParaRPr lang="en-US" noProof="0" dirty="0"/>
+            <a:endParaRPr lang="en-US" noProof="0" dirty="0">
+              <a:solidFill>
+                <a:schemeClr val="bg2"/>
+              </a:solidFill>
+            </a:endParaRPr>
           </a:p>
         </p:txBody>
       </p:sp>
@@ -31502,7 +31518,11 @@
           <a:lstStyle/>
           <a:p>
             <a:r>
-              <a:rPr lang="en-US" noProof="0" dirty="0"/>
+              <a:rPr lang="en-US" noProof="0" dirty="0">
+                <a:solidFill>
+                  <a:schemeClr val="tx1"/>
+                </a:solidFill>
+              </a:rPr>
               <a:t>Understanding the Challenge</a:t>
             </a:r>
           </a:p>
@@ -31738,7 +31758,11 @@
           <a:lstStyle/>
           <a:p>
             <a:r>
-              <a:rPr lang="en-US" noProof="0" dirty="0"/>
+              <a:rPr lang="en-US" noProof="0" dirty="0">
+                <a:solidFill>
+                  <a:schemeClr val="tx1"/>
+                </a:solidFill>
+              </a:rPr>
               <a:t>Understanding the Challenge</a:t>
             </a:r>
           </a:p>
@@ -31990,10 +32014,18 @@
           <a:lstStyle/>
           <a:p>
             <a:r>
-              <a:rPr lang="en-US" dirty="0"/>
+              <a:rPr lang="en-US" dirty="0">
+                <a:solidFill>
+                  <a:schemeClr val="bg2"/>
+                </a:solidFill>
+              </a:rPr>
               <a:t>Security Testing Tools</a:t>
             </a:r>
-            <a:endParaRPr lang="en-US" noProof="0" dirty="0"/>
+            <a:endParaRPr lang="en-US" noProof="0" dirty="0">
+              <a:solidFill>
+                <a:schemeClr val="bg2"/>
+              </a:solidFill>
+            </a:endParaRPr>
           </a:p>
         </p:txBody>
       </p:sp>
@@ -32055,7 +32087,11 @@
           <a:lstStyle/>
           <a:p>
             <a:r>
-              <a:rPr lang="en-US" noProof="0" dirty="0"/>
+              <a:rPr lang="en-US" noProof="0" dirty="0">
+                <a:solidFill>
+                  <a:schemeClr val="tx1"/>
+                </a:solidFill>
+              </a:rPr>
               <a:t>Understanding the Challenge</a:t>
             </a:r>
           </a:p>
@@ -32243,10 +32279,18 @@
           <a:lstStyle/>
           <a:p>
             <a:r>
-              <a:rPr lang="en-US" dirty="0"/>
+              <a:rPr lang="en-US" dirty="0">
+                <a:solidFill>
+                  <a:schemeClr val="bg2"/>
+                </a:solidFill>
+              </a:rPr>
               <a:t>Our Purpose</a:t>
             </a:r>
-            <a:endParaRPr lang="en-US" noProof="0" dirty="0"/>
+            <a:endParaRPr lang="en-US" noProof="0" dirty="0">
+              <a:solidFill>
+                <a:schemeClr val="bg2"/>
+              </a:solidFill>
+            </a:endParaRPr>
           </a:p>
         </p:txBody>
       </p:sp>
@@ -32333,7 +32377,11 @@
           <a:lstStyle/>
           <a:p>
             <a:r>
-              <a:rPr lang="en-US" noProof="0" dirty="0"/>
+              <a:rPr lang="en-US" noProof="0" dirty="0">
+                <a:solidFill>
+                  <a:schemeClr val="tx1"/>
+                </a:solidFill>
+              </a:rPr>
               <a:t>Presentation Outline</a:t>
             </a:r>
           </a:p>
@@ -32599,7 +32647,11 @@
           <a:lstStyle/>
           <a:p>
             <a:r>
-              <a:rPr lang="en-US" noProof="0" dirty="0"/>
+              <a:rPr lang="en-US" noProof="0" dirty="0">
+                <a:solidFill>
+                  <a:schemeClr val="bg2"/>
+                </a:solidFill>
+              </a:rPr>
               <a:t>OWASP Ecosystem</a:t>
             </a:r>
           </a:p>
@@ -32627,7 +32679,11 @@
           <a:lstStyle/>
           <a:p>
             <a:r>
-              <a:rPr lang="en-US" noProof="0" dirty="0"/>
+              <a:rPr lang="en-US" noProof="0" dirty="0">
+                <a:solidFill>
+                  <a:schemeClr val="tx1"/>
+                </a:solidFill>
+              </a:rPr>
               <a:t>Background Knowledge</a:t>
             </a:r>
           </a:p>
@@ -33174,7 +33230,11 @@
           <a:lstStyle/>
           <a:p>
             <a:r>
-              <a:rPr lang="en-US" noProof="0" dirty="0"/>
+              <a:rPr lang="en-US" noProof="0" dirty="0">
+                <a:solidFill>
+                  <a:schemeClr val="tx1"/>
+                </a:solidFill>
+              </a:rPr>
               <a:t>Connection to Academia</a:t>
             </a:r>
           </a:p>
@@ -33357,10 +33417,18 @@
           <a:lstStyle/>
           <a:p>
             <a:r>
-              <a:rPr lang="en-US" dirty="0"/>
+              <a:rPr lang="en-US" dirty="0">
+                <a:solidFill>
+                  <a:schemeClr val="bg2"/>
+                </a:solidFill>
+              </a:rPr>
               <a:t>Methodology</a:t>
             </a:r>
-            <a:endParaRPr lang="en-US" noProof="0" dirty="0"/>
+            <a:endParaRPr lang="en-US" noProof="0" dirty="0">
+              <a:solidFill>
+                <a:schemeClr val="bg2"/>
+              </a:solidFill>
+            </a:endParaRPr>
           </a:p>
         </p:txBody>
       </p:sp>
@@ -33386,7 +33454,11 @@
           <a:lstStyle/>
           <a:p>
             <a:r>
-              <a:rPr lang="en-US" dirty="0"/>
+              <a:rPr lang="en-US" dirty="0">
+                <a:solidFill>
+                  <a:schemeClr val="tx1"/>
+                </a:solidFill>
+              </a:rPr>
               <a:t>Connection to Academia</a:t>
             </a:r>
           </a:p>
@@ -33612,10 +33684,18 @@
           <a:lstStyle/>
           <a:p>
             <a:r>
-              <a:rPr lang="en-US" dirty="0"/>
+              <a:rPr lang="en-US" dirty="0">
+                <a:solidFill>
+                  <a:schemeClr val="bg2"/>
+                </a:solidFill>
+              </a:rPr>
               <a:t>Findings</a:t>
             </a:r>
-            <a:endParaRPr lang="en-US" noProof="0" dirty="0"/>
+            <a:endParaRPr lang="en-US" noProof="0" dirty="0">
+              <a:solidFill>
+                <a:schemeClr val="bg2"/>
+              </a:solidFill>
+            </a:endParaRPr>
           </a:p>
         </p:txBody>
       </p:sp>
@@ -33641,7 +33721,11 @@
           <a:lstStyle/>
           <a:p>
             <a:r>
-              <a:rPr lang="en-US" dirty="0"/>
+              <a:rPr lang="en-US" dirty="0">
+                <a:solidFill>
+                  <a:schemeClr val="tx1"/>
+                </a:solidFill>
+              </a:rPr>
               <a:t>Connection to Academia</a:t>
             </a:r>
           </a:p>
@@ -33845,10 +33929,18 @@
           <a:lstStyle/>
           <a:p>
             <a:r>
-              <a:rPr lang="en-US" dirty="0"/>
+              <a:rPr lang="en-US" dirty="0">
+                <a:solidFill>
+                  <a:schemeClr val="bg2"/>
+                </a:solidFill>
+              </a:rPr>
               <a:t>Findings</a:t>
             </a:r>
-            <a:endParaRPr lang="en-US" noProof="0" dirty="0"/>
+            <a:endParaRPr lang="en-US" noProof="0" dirty="0">
+              <a:solidFill>
+                <a:schemeClr val="bg2"/>
+              </a:solidFill>
+            </a:endParaRPr>
           </a:p>
         </p:txBody>
       </p:sp>
@@ -33874,7 +33966,11 @@
           <a:lstStyle/>
           <a:p>
             <a:r>
-              <a:rPr lang="en-US" dirty="0"/>
+              <a:rPr lang="en-US" dirty="0">
+                <a:solidFill>
+                  <a:schemeClr val="tx1"/>
+                </a:solidFill>
+              </a:rPr>
               <a:t>Connection to Academia</a:t>
             </a:r>
           </a:p>
@@ -34079,10 +34175,18 @@
           <a:lstStyle/>
           <a:p>
             <a:r>
-              <a:rPr lang="en-US" dirty="0"/>
+              <a:rPr lang="en-US" dirty="0">
+                <a:solidFill>
+                  <a:schemeClr val="bg2"/>
+                </a:solidFill>
+              </a:rPr>
               <a:t>Findings</a:t>
             </a:r>
-            <a:endParaRPr lang="en-US" noProof="0" dirty="0"/>
+            <a:endParaRPr lang="en-US" noProof="0" dirty="0">
+              <a:solidFill>
+                <a:schemeClr val="bg2"/>
+              </a:solidFill>
+            </a:endParaRPr>
           </a:p>
         </p:txBody>
       </p:sp>
@@ -34108,7 +34212,11 @@
           <a:lstStyle/>
           <a:p>
             <a:r>
-              <a:rPr lang="en-US" dirty="0"/>
+              <a:rPr lang="en-US" dirty="0">
+                <a:solidFill>
+                  <a:schemeClr val="tx1"/>
+                </a:solidFill>
+              </a:rPr>
               <a:t>Connection to Academia</a:t>
             </a:r>
           </a:p>
@@ -34325,10 +34433,18 @@
           <a:lstStyle/>
           <a:p>
             <a:r>
-              <a:rPr lang="en-US" dirty="0"/>
+              <a:rPr lang="en-US" dirty="0">
+                <a:solidFill>
+                  <a:schemeClr val="bg2"/>
+                </a:solidFill>
+              </a:rPr>
               <a:t>Android Dominance</a:t>
             </a:r>
-            <a:endParaRPr lang="en-US" noProof="0" dirty="0"/>
+            <a:endParaRPr lang="en-US" noProof="0" dirty="0">
+              <a:solidFill>
+                <a:schemeClr val="bg2"/>
+              </a:solidFill>
+            </a:endParaRPr>
           </a:p>
         </p:txBody>
       </p:sp>
@@ -34354,10 +34470,18 @@
           <a:lstStyle/>
           <a:p>
             <a:r>
-              <a:rPr lang="en-US" dirty="0"/>
+              <a:rPr lang="en-US" dirty="0">
+                <a:solidFill>
+                  <a:schemeClr val="tx1"/>
+                </a:solidFill>
+              </a:rPr>
               <a:t>State of Android App Security</a:t>
             </a:r>
-            <a:endParaRPr lang="en-US" noProof="0" dirty="0"/>
+            <a:endParaRPr lang="en-US" noProof="0" dirty="0">
+              <a:solidFill>
+                <a:schemeClr val="tx1"/>
+              </a:solidFill>
+            </a:endParaRPr>
           </a:p>
         </p:txBody>
       </p:sp>
@@ -34610,10 +34734,18 @@
           <a:lstStyle/>
           <a:p>
             <a:r>
-              <a:rPr lang="en-US" dirty="0"/>
+              <a:rPr lang="en-US" dirty="0">
+                <a:solidFill>
+                  <a:schemeClr val="bg2"/>
+                </a:solidFill>
+              </a:rPr>
               <a:t>Understanding the Challenge</a:t>
             </a:r>
-            <a:endParaRPr lang="en-US" noProof="0" dirty="0"/>
+            <a:endParaRPr lang="en-US" noProof="0" dirty="0">
+              <a:solidFill>
+                <a:schemeClr val="bg2"/>
+              </a:solidFill>
+            </a:endParaRPr>
           </a:p>
         </p:txBody>
       </p:sp>
@@ -34639,7 +34771,11 @@
           <a:lstStyle/>
           <a:p>
             <a:r>
-              <a:rPr lang="en-US" dirty="0"/>
+              <a:rPr lang="en-US" dirty="0">
+                <a:solidFill>
+                  <a:schemeClr val="tx1"/>
+                </a:solidFill>
+              </a:rPr>
               <a:t>State of the Art in MASTG Reference Apps</a:t>
             </a:r>
           </a:p>
@@ -34832,10 +34968,18 @@
           <a:lstStyle/>
           <a:p>
             <a:r>
-              <a:rPr lang="en-US" dirty="0"/>
+              <a:rPr lang="en-US" dirty="0">
+                <a:solidFill>
+                  <a:schemeClr val="bg2"/>
+                </a:solidFill>
+              </a:rPr>
               <a:t>Methodology</a:t>
             </a:r>
-            <a:endParaRPr lang="en-US" noProof="0" dirty="0"/>
+            <a:endParaRPr lang="en-US" noProof="0" dirty="0">
+              <a:solidFill>
+                <a:schemeClr val="bg2"/>
+              </a:solidFill>
+            </a:endParaRPr>
           </a:p>
         </p:txBody>
       </p:sp>
@@ -34861,7 +35005,11 @@
           <a:lstStyle/>
           <a:p>
             <a:r>
-              <a:rPr lang="en-US" dirty="0"/>
+              <a:rPr lang="en-US" dirty="0">
+                <a:solidFill>
+                  <a:schemeClr val="tx1"/>
+                </a:solidFill>
+              </a:rPr>
               <a:t>State of the Art in MASTG Reference Apps</a:t>
             </a:r>
           </a:p>
@@ -35076,10 +35224,18 @@
           <a:lstStyle/>
           <a:p>
             <a:r>
-              <a:rPr lang="en-US" dirty="0"/>
+              <a:rPr lang="en-US" dirty="0">
+                <a:solidFill>
+                  <a:schemeClr val="bg2"/>
+                </a:solidFill>
+              </a:rPr>
               <a:t>Methodology</a:t>
             </a:r>
-            <a:endParaRPr lang="en-US" noProof="0" dirty="0"/>
+            <a:endParaRPr lang="en-US" noProof="0" dirty="0">
+              <a:solidFill>
+                <a:schemeClr val="bg2"/>
+              </a:solidFill>
+            </a:endParaRPr>
           </a:p>
         </p:txBody>
       </p:sp>
@@ -35105,10 +35261,18 @@
           <a:lstStyle/>
           <a:p>
             <a:r>
-              <a:rPr lang="en-US" dirty="0"/>
+              <a:rPr lang="en-US" dirty="0">
+                <a:solidFill>
+                  <a:schemeClr val="tx1"/>
+                </a:solidFill>
+              </a:rPr>
               <a:t>State of the Art in MASTG Reference Apps</a:t>
             </a:r>
-            <a:endParaRPr lang="en-US" noProof="0" dirty="0"/>
+            <a:endParaRPr lang="en-US" noProof="0" dirty="0">
+              <a:solidFill>
+                <a:schemeClr val="tx1"/>
+              </a:solidFill>
+            </a:endParaRPr>
           </a:p>
         </p:txBody>
       </p:sp>
@@ -35390,10 +35554,18 @@
           <a:lstStyle/>
           <a:p>
             <a:r>
-              <a:rPr lang="en-US" dirty="0"/>
+              <a:rPr lang="en-US" dirty="0">
+                <a:solidFill>
+                  <a:schemeClr val="bg2"/>
+                </a:solidFill>
+              </a:rPr>
               <a:t>Results Overview</a:t>
             </a:r>
-            <a:endParaRPr lang="en-US" noProof="0" dirty="0"/>
+            <a:endParaRPr lang="en-US" noProof="0" dirty="0">
+              <a:solidFill>
+                <a:schemeClr val="bg2"/>
+              </a:solidFill>
+            </a:endParaRPr>
           </a:p>
         </p:txBody>
       </p:sp>
@@ -35419,7 +35591,11 @@
           <a:lstStyle/>
           <a:p>
             <a:r>
-              <a:rPr lang="en-US" dirty="0"/>
+              <a:rPr lang="en-US" dirty="0">
+                <a:solidFill>
+                  <a:schemeClr val="tx1"/>
+                </a:solidFill>
+              </a:rPr>
               <a:t>State of the Art in MASTG Reference Apps</a:t>
             </a:r>
           </a:p>
@@ -35623,10 +35799,18 @@
           <a:lstStyle/>
           <a:p>
             <a:r>
-              <a:rPr lang="en-US" dirty="0"/>
+              <a:rPr lang="en-US" dirty="0">
+                <a:solidFill>
+                  <a:schemeClr val="bg2"/>
+                </a:solidFill>
+              </a:rPr>
               <a:t>Results Overview</a:t>
             </a:r>
-            <a:endParaRPr lang="en-US" noProof="0" dirty="0"/>
+            <a:endParaRPr lang="en-US" noProof="0" dirty="0">
+              <a:solidFill>
+                <a:schemeClr val="bg2"/>
+              </a:solidFill>
+            </a:endParaRPr>
           </a:p>
         </p:txBody>
       </p:sp>
@@ -35652,7 +35836,11 @@
           <a:lstStyle/>
           <a:p>
             <a:r>
-              <a:rPr lang="en-US" dirty="0"/>
+              <a:rPr lang="en-US" dirty="0">
+                <a:solidFill>
+                  <a:schemeClr val="tx1"/>
+                </a:solidFill>
+              </a:rPr>
               <a:t>State of the Art in MASTG Reference Apps</a:t>
             </a:r>
           </a:p>
@@ -35856,10 +36044,18 @@
           <a:lstStyle/>
           <a:p>
             <a:r>
-              <a:rPr lang="en-US" dirty="0"/>
+              <a:rPr lang="en-US" dirty="0">
+                <a:solidFill>
+                  <a:schemeClr val="bg2"/>
+                </a:solidFill>
+              </a:rPr>
               <a:t>Skewered Coverage of Vulnerability Types</a:t>
             </a:r>
-            <a:endParaRPr lang="en-US" noProof="0" dirty="0"/>
+            <a:endParaRPr lang="en-US" noProof="0" dirty="0">
+              <a:solidFill>
+                <a:schemeClr val="bg2"/>
+              </a:solidFill>
+            </a:endParaRPr>
           </a:p>
         </p:txBody>
       </p:sp>
@@ -35885,10 +36081,18 @@
           <a:lstStyle/>
           <a:p>
             <a:r>
-              <a:rPr lang="en-US" dirty="0"/>
+              <a:rPr lang="en-US" dirty="0">
+                <a:solidFill>
+                  <a:schemeClr val="tx1"/>
+                </a:solidFill>
+              </a:rPr>
               <a:t>State of the Art in MASTG Reference Apps</a:t>
             </a:r>
-            <a:endParaRPr lang="en-US" noProof="0" dirty="0"/>
+            <a:endParaRPr lang="en-US" noProof="0" dirty="0">
+              <a:solidFill>
+                <a:schemeClr val="tx1"/>
+              </a:solidFill>
+            </a:endParaRPr>
           </a:p>
         </p:txBody>
       </p:sp>
@@ -36138,10 +36342,18 @@
           <a:lstStyle/>
           <a:p>
             <a:r>
-              <a:rPr lang="en-US" dirty="0"/>
+              <a:rPr lang="en-US" dirty="0">
+                <a:solidFill>
+                  <a:schemeClr val="bg2"/>
+                </a:solidFill>
+              </a:rPr>
               <a:t>Skewered Coverage of Vulnerability Categories</a:t>
             </a:r>
-            <a:endParaRPr lang="en-US" noProof="0" dirty="0"/>
+            <a:endParaRPr lang="en-US" noProof="0" dirty="0">
+              <a:solidFill>
+                <a:schemeClr val="bg2"/>
+              </a:solidFill>
+            </a:endParaRPr>
           </a:p>
         </p:txBody>
       </p:sp>
@@ -36167,10 +36379,18 @@
           <a:lstStyle/>
           <a:p>
             <a:r>
-              <a:rPr lang="en-US" dirty="0"/>
+              <a:rPr lang="en-US" dirty="0">
+                <a:solidFill>
+                  <a:schemeClr val="tx1"/>
+                </a:solidFill>
+              </a:rPr>
               <a:t>State of the Art in MASTG Reference Apps</a:t>
             </a:r>
-            <a:endParaRPr lang="en-US" noProof="0" dirty="0"/>
+            <a:endParaRPr lang="en-US" noProof="0" dirty="0">
+              <a:solidFill>
+                <a:schemeClr val="tx1"/>
+              </a:solidFill>
+            </a:endParaRPr>
           </a:p>
         </p:txBody>
       </p:sp>
@@ -36397,7 +36617,11 @@
           <a:lstStyle/>
           <a:p>
             <a:r>
-              <a:rPr lang="en-US" dirty="0"/>
+              <a:rPr lang="en-US" dirty="0">
+                <a:solidFill>
+                  <a:schemeClr val="bg2"/>
+                </a:solidFill>
+              </a:rPr>
               <a:t>Skewered Coverage of Vulnerability Categories</a:t>
             </a:r>
           </a:p>
@@ -36425,10 +36649,18 @@
           <a:lstStyle/>
           <a:p>
             <a:r>
-              <a:rPr lang="en-US" dirty="0"/>
+              <a:rPr lang="en-US" dirty="0">
+                <a:solidFill>
+                  <a:schemeClr val="tx1"/>
+                </a:solidFill>
+              </a:rPr>
               <a:t>State of the Art in MASTG Reference Apps</a:t>
             </a:r>
-            <a:endParaRPr lang="en-US" noProof="0" dirty="0"/>
+            <a:endParaRPr lang="en-US" noProof="0" dirty="0">
+              <a:solidFill>
+                <a:schemeClr val="tx1"/>
+              </a:solidFill>
+            </a:endParaRPr>
           </a:p>
         </p:txBody>
       </p:sp>
@@ -36655,10 +36887,18 @@
           <a:lstStyle/>
           <a:p>
             <a:r>
-              <a:rPr lang="en-US" dirty="0"/>
+              <a:rPr lang="en-US" dirty="0">
+                <a:solidFill>
+                  <a:schemeClr val="bg2"/>
+                </a:solidFill>
+              </a:rPr>
               <a:t>Take-Away Points</a:t>
             </a:r>
-            <a:endParaRPr lang="en-US" noProof="0" dirty="0"/>
+            <a:endParaRPr lang="en-US" noProof="0" dirty="0">
+              <a:solidFill>
+                <a:schemeClr val="bg2"/>
+              </a:solidFill>
+            </a:endParaRPr>
           </a:p>
         </p:txBody>
       </p:sp>
@@ -36684,10 +36924,18 @@
           <a:lstStyle/>
           <a:p>
             <a:r>
-              <a:rPr lang="en-US" dirty="0"/>
+              <a:rPr lang="en-US" dirty="0">
+                <a:solidFill>
+                  <a:schemeClr val="tx1"/>
+                </a:solidFill>
+              </a:rPr>
               <a:t>State of the Art in MASTG Reference Apps</a:t>
             </a:r>
-            <a:endParaRPr lang="en-US" noProof="0" dirty="0"/>
+            <a:endParaRPr lang="en-US" noProof="0" dirty="0">
+              <a:solidFill>
+                <a:schemeClr val="tx1"/>
+              </a:solidFill>
+            </a:endParaRPr>
           </a:p>
         </p:txBody>
       </p:sp>
@@ -36900,10 +37148,18 @@
           <a:lstStyle/>
           <a:p>
             <a:r>
-              <a:rPr lang="en-US" dirty="0"/>
+              <a:rPr lang="en-US" dirty="0">
+                <a:solidFill>
+                  <a:schemeClr val="bg2"/>
+                </a:solidFill>
+              </a:rPr>
               <a:t>Significance for Our Apps</a:t>
             </a:r>
-            <a:endParaRPr lang="en-US" noProof="0" dirty="0"/>
+            <a:endParaRPr lang="en-US" noProof="0" dirty="0">
+              <a:solidFill>
+                <a:schemeClr val="bg2"/>
+              </a:solidFill>
+            </a:endParaRPr>
           </a:p>
         </p:txBody>
       </p:sp>
@@ -36929,10 +37185,18 @@
           <a:lstStyle/>
           <a:p>
             <a:r>
-              <a:rPr lang="en-US" dirty="0"/>
+              <a:rPr lang="en-US" dirty="0">
+                <a:solidFill>
+                  <a:schemeClr val="tx1"/>
+                </a:solidFill>
+              </a:rPr>
               <a:t>State of the Art in MASTG Reference Apps</a:t>
             </a:r>
-            <a:endParaRPr lang="en-US" noProof="0" dirty="0"/>
+            <a:endParaRPr lang="en-US" noProof="0" dirty="0">
+              <a:solidFill>
+                <a:schemeClr val="tx1"/>
+              </a:solidFill>
+            </a:endParaRPr>
           </a:p>
         </p:txBody>
       </p:sp>
@@ -37157,10 +37421,18 @@
           <a:lstStyle/>
           <a:p>
             <a:r>
-              <a:rPr lang="en-US" dirty="0"/>
+              <a:rPr lang="en-US" dirty="0">
+                <a:solidFill>
+                  <a:schemeClr val="bg2"/>
+                </a:solidFill>
+              </a:rPr>
               <a:t>The Problem in Numbers</a:t>
             </a:r>
-            <a:endParaRPr lang="en-US" noProof="0" dirty="0"/>
+            <a:endParaRPr lang="en-US" noProof="0" dirty="0">
+              <a:solidFill>
+                <a:schemeClr val="bg2"/>
+              </a:solidFill>
+            </a:endParaRPr>
           </a:p>
         </p:txBody>
       </p:sp>
@@ -37186,10 +37458,18 @@
           <a:lstStyle/>
           <a:p>
             <a:r>
-              <a:rPr lang="en-US" dirty="0"/>
+              <a:rPr lang="en-US" dirty="0">
+                <a:solidFill>
+                  <a:schemeClr val="tx1"/>
+                </a:solidFill>
+              </a:rPr>
               <a:t>State of Android App Security</a:t>
             </a:r>
-            <a:endParaRPr lang="en-US" noProof="0" dirty="0"/>
+            <a:endParaRPr lang="en-US" noProof="0" dirty="0">
+              <a:solidFill>
+                <a:schemeClr val="tx1"/>
+              </a:solidFill>
+            </a:endParaRPr>
           </a:p>
         </p:txBody>
       </p:sp>
@@ -37443,10 +37723,18 @@
           <a:lstStyle/>
           <a:p>
             <a:r>
-              <a:rPr lang="en-US" dirty="0"/>
+              <a:rPr lang="en-US" dirty="0">
+                <a:solidFill>
+                  <a:schemeClr val="bg2"/>
+                </a:solidFill>
+              </a:rPr>
               <a:t>Modular Architecture</a:t>
             </a:r>
-            <a:endParaRPr lang="en-US" noProof="0" dirty="0"/>
+            <a:endParaRPr lang="en-US" noProof="0" dirty="0">
+              <a:solidFill>
+                <a:schemeClr val="bg2"/>
+              </a:solidFill>
+            </a:endParaRPr>
           </a:p>
         </p:txBody>
       </p:sp>
@@ -37472,7 +37760,11 @@
           <a:lstStyle/>
           <a:p>
             <a:r>
-              <a:rPr lang="en-US" dirty="0"/>
+              <a:rPr lang="en-US" dirty="0">
+                <a:solidFill>
+                  <a:schemeClr val="tx1"/>
+                </a:solidFill>
+              </a:rPr>
               <a:t>Designing Our Apps</a:t>
             </a:r>
           </a:p>
@@ -37888,10 +38180,18 @@
           <a:lstStyle/>
           <a:p>
             <a:r>
-              <a:rPr lang="en-US" dirty="0"/>
+              <a:rPr lang="en-US" dirty="0">
+                <a:solidFill>
+                  <a:schemeClr val="bg2"/>
+                </a:solidFill>
+              </a:rPr>
               <a:t>Modular Architecture</a:t>
             </a:r>
-            <a:endParaRPr lang="en-US" noProof="0" dirty="0"/>
+            <a:endParaRPr lang="en-US" noProof="0" dirty="0">
+              <a:solidFill>
+                <a:schemeClr val="bg2"/>
+              </a:solidFill>
+            </a:endParaRPr>
           </a:p>
         </p:txBody>
       </p:sp>
@@ -37917,10 +38217,18 @@
           <a:lstStyle/>
           <a:p>
             <a:r>
-              <a:rPr lang="en-US" dirty="0"/>
+              <a:rPr lang="en-US" dirty="0">
+                <a:solidFill>
+                  <a:schemeClr val="tx1"/>
+                </a:solidFill>
+              </a:rPr>
               <a:t>Designing Our Apps</a:t>
             </a:r>
-            <a:endParaRPr lang="en-US" noProof="0" dirty="0"/>
+            <a:endParaRPr lang="en-US" noProof="0" dirty="0">
+              <a:solidFill>
+                <a:schemeClr val="tx1"/>
+              </a:solidFill>
+            </a:endParaRPr>
           </a:p>
         </p:txBody>
       </p:sp>
@@ -38361,10 +38669,18 @@
           <a:lstStyle/>
           <a:p>
             <a:r>
-              <a:rPr lang="en-US" dirty="0"/>
+              <a:rPr lang="en-US" dirty="0">
+                <a:solidFill>
+                  <a:schemeClr val="bg2"/>
+                </a:solidFill>
+              </a:rPr>
               <a:t>Feature-Oriented Design</a:t>
             </a:r>
-            <a:endParaRPr lang="en-US" noProof="0" dirty="0"/>
+            <a:endParaRPr lang="en-US" noProof="0" dirty="0">
+              <a:solidFill>
+                <a:schemeClr val="bg2"/>
+              </a:solidFill>
+            </a:endParaRPr>
           </a:p>
         </p:txBody>
       </p:sp>
@@ -38390,10 +38706,18 @@
           <a:lstStyle/>
           <a:p>
             <a:r>
-              <a:rPr lang="en-US" dirty="0"/>
+              <a:rPr lang="en-US" dirty="0">
+                <a:solidFill>
+                  <a:schemeClr val="tx1"/>
+                </a:solidFill>
+              </a:rPr>
               <a:t>Designing Our Apps</a:t>
             </a:r>
-            <a:endParaRPr lang="en-US" noProof="0" dirty="0"/>
+            <a:endParaRPr lang="en-US" noProof="0" dirty="0">
+              <a:solidFill>
+                <a:schemeClr val="tx1"/>
+              </a:solidFill>
+            </a:endParaRPr>
           </a:p>
         </p:txBody>
       </p:sp>
@@ -38800,10 +39124,18 @@
           <a:lstStyle/>
           <a:p>
             <a:r>
-              <a:rPr lang="en-US" dirty="0"/>
+              <a:rPr lang="en-US" dirty="0">
+                <a:solidFill>
+                  <a:schemeClr val="bg2"/>
+                </a:solidFill>
+              </a:rPr>
               <a:t>Feature-Oriented Design</a:t>
             </a:r>
-            <a:endParaRPr lang="en-US" noProof="0" dirty="0"/>
+            <a:endParaRPr lang="en-US" noProof="0" dirty="0">
+              <a:solidFill>
+                <a:schemeClr val="bg2"/>
+              </a:solidFill>
+            </a:endParaRPr>
           </a:p>
         </p:txBody>
       </p:sp>
@@ -38829,10 +39161,18 @@
           <a:lstStyle/>
           <a:p>
             <a:r>
-              <a:rPr lang="en-US" dirty="0"/>
+              <a:rPr lang="en-US" dirty="0">
+                <a:solidFill>
+                  <a:schemeClr val="tx1"/>
+                </a:solidFill>
+              </a:rPr>
               <a:t>Designing Our Apps</a:t>
             </a:r>
-            <a:endParaRPr lang="en-US" noProof="0" dirty="0"/>
+            <a:endParaRPr lang="en-US" noProof="0" dirty="0">
+              <a:solidFill>
+                <a:schemeClr val="tx1"/>
+              </a:solidFill>
+            </a:endParaRPr>
           </a:p>
         </p:txBody>
       </p:sp>
@@ -39262,10 +39602,18 @@
           <a:lstStyle/>
           <a:p>
             <a:r>
-              <a:rPr lang="en-US" dirty="0"/>
+              <a:rPr lang="en-US" dirty="0">
+                <a:solidFill>
+                  <a:schemeClr val="bg2"/>
+                </a:solidFill>
+              </a:rPr>
               <a:t>Inheritance</a:t>
             </a:r>
-            <a:endParaRPr lang="en-US" noProof="0" dirty="0"/>
+            <a:endParaRPr lang="en-US" noProof="0" dirty="0">
+              <a:solidFill>
+                <a:schemeClr val="bg2"/>
+              </a:solidFill>
+            </a:endParaRPr>
           </a:p>
         </p:txBody>
       </p:sp>
@@ -39291,10 +39639,18 @@
           <a:lstStyle/>
           <a:p>
             <a:r>
-              <a:rPr lang="en-US" dirty="0"/>
+              <a:rPr lang="en-US" dirty="0">
+                <a:solidFill>
+                  <a:schemeClr val="tx1"/>
+                </a:solidFill>
+              </a:rPr>
               <a:t>Designing Our Apps</a:t>
             </a:r>
-            <a:endParaRPr lang="en-US" noProof="0" dirty="0"/>
+            <a:endParaRPr lang="en-US" noProof="0" dirty="0">
+              <a:solidFill>
+                <a:schemeClr val="tx1"/>
+              </a:solidFill>
+            </a:endParaRPr>
           </a:p>
         </p:txBody>
       </p:sp>
@@ -39714,10 +40070,18 @@
           <a:lstStyle/>
           <a:p>
             <a:r>
-              <a:rPr lang="en-US" dirty="0"/>
+              <a:rPr lang="en-US" dirty="0">
+                <a:solidFill>
+                  <a:schemeClr val="bg2"/>
+                </a:solidFill>
+              </a:rPr>
               <a:t>Inheritance</a:t>
             </a:r>
-            <a:endParaRPr lang="en-US" noProof="0" dirty="0"/>
+            <a:endParaRPr lang="en-US" noProof="0" dirty="0">
+              <a:solidFill>
+                <a:schemeClr val="bg2"/>
+              </a:solidFill>
+            </a:endParaRPr>
           </a:p>
         </p:txBody>
       </p:sp>
@@ -39743,10 +40107,18 @@
           <a:lstStyle/>
           <a:p>
             <a:r>
-              <a:rPr lang="en-US" dirty="0"/>
+              <a:rPr lang="en-US" dirty="0">
+                <a:solidFill>
+                  <a:schemeClr val="tx1"/>
+                </a:solidFill>
+              </a:rPr>
               <a:t>Designing Our Apps</a:t>
             </a:r>
-            <a:endParaRPr lang="en-US" noProof="0" dirty="0"/>
+            <a:endParaRPr lang="en-US" noProof="0" dirty="0">
+              <a:solidFill>
+                <a:schemeClr val="tx1"/>
+              </a:solidFill>
+            </a:endParaRPr>
           </a:p>
         </p:txBody>
       </p:sp>
@@ -40165,10 +40537,18 @@
           <a:lstStyle/>
           <a:p>
             <a:r>
-              <a:rPr lang="en-US" dirty="0"/>
+              <a:rPr lang="en-US" dirty="0">
+                <a:solidFill>
+                  <a:schemeClr val="bg2"/>
+                </a:solidFill>
+              </a:rPr>
               <a:t>Architecture Summary</a:t>
             </a:r>
-            <a:endParaRPr lang="en-US" noProof="0" dirty="0"/>
+            <a:endParaRPr lang="en-US" noProof="0" dirty="0">
+              <a:solidFill>
+                <a:schemeClr val="bg2"/>
+              </a:solidFill>
+            </a:endParaRPr>
           </a:p>
         </p:txBody>
       </p:sp>
@@ -40194,10 +40574,18 @@
           <a:lstStyle/>
           <a:p>
             <a:r>
-              <a:rPr lang="en-US" dirty="0"/>
+              <a:rPr lang="en-US" dirty="0">
+                <a:solidFill>
+                  <a:schemeClr val="tx1"/>
+                </a:solidFill>
+              </a:rPr>
               <a:t>Designing Our Apps</a:t>
             </a:r>
-            <a:endParaRPr lang="en-US" noProof="0" dirty="0"/>
+            <a:endParaRPr lang="en-US" noProof="0" dirty="0">
+              <a:solidFill>
+                <a:schemeClr val="tx1"/>
+              </a:solidFill>
+            </a:endParaRPr>
           </a:p>
         </p:txBody>
       </p:sp>
@@ -40598,10 +40986,18 @@
           <a:lstStyle/>
           <a:p>
             <a:r>
-              <a:rPr lang="en-US" dirty="0"/>
+              <a:rPr lang="en-US" dirty="0">
+                <a:solidFill>
+                  <a:schemeClr val="bg2"/>
+                </a:solidFill>
+              </a:rPr>
               <a:t>Overview of Our Apps</a:t>
             </a:r>
-            <a:endParaRPr lang="en-US" noProof="0" dirty="0"/>
+            <a:endParaRPr lang="en-US" noProof="0" dirty="0">
+              <a:solidFill>
+                <a:schemeClr val="bg2"/>
+              </a:solidFill>
+            </a:endParaRPr>
           </a:p>
         </p:txBody>
       </p:sp>
@@ -40627,7 +41023,11 @@
           <a:lstStyle/>
           <a:p>
             <a:r>
-              <a:rPr lang="en-US" dirty="0"/>
+              <a:rPr lang="en-US" dirty="0">
+                <a:solidFill>
+                  <a:schemeClr val="tx1"/>
+                </a:solidFill>
+              </a:rPr>
               <a:t>Results</a:t>
             </a:r>
           </a:p>
@@ -40839,10 +41239,18 @@
           <a:lstStyle/>
           <a:p>
             <a:r>
-              <a:rPr lang="en-US" dirty="0"/>
+              <a:rPr lang="en-US" dirty="0">
+                <a:solidFill>
+                  <a:schemeClr val="bg2"/>
+                </a:solidFill>
+              </a:rPr>
               <a:t>Overview of Our Apps</a:t>
             </a:r>
-            <a:endParaRPr lang="en-US" noProof="0" dirty="0"/>
+            <a:endParaRPr lang="en-US" noProof="0" dirty="0">
+              <a:solidFill>
+                <a:schemeClr val="bg2"/>
+              </a:solidFill>
+            </a:endParaRPr>
           </a:p>
         </p:txBody>
       </p:sp>
@@ -40868,7 +41276,11 @@
           <a:lstStyle/>
           <a:p>
             <a:r>
-              <a:rPr lang="en-US" dirty="0"/>
+              <a:rPr lang="en-US" dirty="0">
+                <a:solidFill>
+                  <a:schemeClr val="tx1"/>
+                </a:solidFill>
+              </a:rPr>
               <a:t>Results</a:t>
             </a:r>
           </a:p>
@@ -41088,7 +41500,11 @@
           <a:lstStyle/>
           <a:p>
             <a:r>
-              <a:rPr lang="en-US" noProof="0" dirty="0"/>
+              <a:rPr lang="en-US" noProof="0" dirty="0">
+                <a:solidFill>
+                  <a:schemeClr val="bg2"/>
+                </a:solidFill>
+              </a:rPr>
               <a:t>Comparison with other MASTG Apps</a:t>
             </a:r>
           </a:p>
@@ -41116,7 +41532,11 @@
           <a:lstStyle/>
           <a:p>
             <a:r>
-              <a:rPr lang="en-US" noProof="0" dirty="0"/>
+              <a:rPr lang="en-US" noProof="0" dirty="0">
+                <a:solidFill>
+                  <a:schemeClr val="tx1"/>
+                </a:solidFill>
+              </a:rPr>
               <a:t>Results</a:t>
             </a:r>
           </a:p>
@@ -41350,7 +41770,11 @@
           <a:lstStyle/>
           <a:p>
             <a:r>
-              <a:rPr lang="en-US" noProof="0" dirty="0"/>
+              <a:rPr lang="en-US" noProof="0" dirty="0">
+                <a:solidFill>
+                  <a:schemeClr val="bg2"/>
+                </a:solidFill>
+              </a:rPr>
               <a:t>The Problem in Numbers</a:t>
             </a:r>
           </a:p>
@@ -41378,10 +41802,18 @@
           <a:lstStyle/>
           <a:p>
             <a:r>
-              <a:rPr lang="en-US" dirty="0"/>
+              <a:rPr lang="en-US" dirty="0">
+                <a:solidFill>
+                  <a:schemeClr val="tx1"/>
+                </a:solidFill>
+              </a:rPr>
               <a:t>State of Android App Security</a:t>
             </a:r>
-            <a:endParaRPr lang="en-US" noProof="0" dirty="0"/>
+            <a:endParaRPr lang="en-US" noProof="0" dirty="0">
+              <a:solidFill>
+                <a:schemeClr val="tx1"/>
+              </a:solidFill>
+            </a:endParaRPr>
           </a:p>
         </p:txBody>
       </p:sp>
@@ -41864,10 +42296,18 @@
           <a:lstStyle/>
           <a:p>
             <a:r>
-              <a:rPr lang="en-US" dirty="0"/>
+              <a:rPr lang="en-US" dirty="0">
+                <a:solidFill>
+                  <a:schemeClr val="bg2"/>
+                </a:solidFill>
+              </a:rPr>
               <a:t>MobSF Static Scan</a:t>
             </a:r>
-            <a:endParaRPr lang="en-US" noProof="0" dirty="0"/>
+            <a:endParaRPr lang="en-US" noProof="0" dirty="0">
+              <a:solidFill>
+                <a:schemeClr val="bg2"/>
+              </a:solidFill>
+            </a:endParaRPr>
           </a:p>
         </p:txBody>
       </p:sp>
@@ -41893,7 +42333,11 @@
           <a:lstStyle/>
           <a:p>
             <a:r>
-              <a:rPr lang="en-US" dirty="0"/>
+              <a:rPr lang="en-US" dirty="0">
+                <a:solidFill>
+                  <a:schemeClr val="tx1"/>
+                </a:solidFill>
+              </a:rPr>
               <a:t>Results</a:t>
             </a:r>
           </a:p>
@@ -42108,7 +42552,11 @@
           <a:lstStyle/>
           <a:p>
             <a:r>
-              <a:rPr lang="en-US" noProof="0" dirty="0"/>
+              <a:rPr lang="en-US" noProof="0" dirty="0">
+                <a:solidFill>
+                  <a:schemeClr val="bg2"/>
+                </a:solidFill>
+              </a:rPr>
               <a:t>Semgrep Static Scan</a:t>
             </a:r>
           </a:p>
@@ -42136,7 +42584,11 @@
           <a:lstStyle/>
           <a:p>
             <a:r>
-              <a:rPr lang="en-US" noProof="0" dirty="0"/>
+              <a:rPr lang="en-US" noProof="0" dirty="0">
+                <a:solidFill>
+                  <a:schemeClr val="tx1"/>
+                </a:solidFill>
+              </a:rPr>
               <a:t>Results</a:t>
             </a:r>
           </a:p>
@@ -42340,7 +42792,11 @@
           <a:lstStyle/>
           <a:p>
             <a:r>
-              <a:rPr lang="en-US" noProof="0" dirty="0"/>
+              <a:rPr lang="en-US" noProof="0" dirty="0">
+                <a:solidFill>
+                  <a:schemeClr val="bg2"/>
+                </a:solidFill>
+              </a:rPr>
               <a:t>Benchmarking Security Testing Tools</a:t>
             </a:r>
           </a:p>
@@ -42368,7 +42824,11 @@
           <a:lstStyle/>
           <a:p>
             <a:r>
-              <a:rPr lang="en-US" noProof="0" dirty="0"/>
+              <a:rPr lang="en-US" noProof="0" dirty="0">
+                <a:solidFill>
+                  <a:schemeClr val="tx1"/>
+                </a:solidFill>
+              </a:rPr>
               <a:t>Outlook</a:t>
             </a:r>
           </a:p>
@@ -42572,7 +43032,11 @@
           <a:lstStyle/>
           <a:p>
             <a:r>
-              <a:rPr lang="en-US" noProof="0" dirty="0"/>
+              <a:rPr lang="en-US" noProof="0" dirty="0">
+                <a:solidFill>
+                  <a:schemeClr val="bg2"/>
+                </a:solidFill>
+              </a:rPr>
               <a:t>Moving on to new Categories</a:t>
             </a:r>
           </a:p>
@@ -42600,7 +43064,11 @@
           <a:lstStyle/>
           <a:p>
             <a:r>
-              <a:rPr lang="en-US" noProof="0" dirty="0"/>
+              <a:rPr lang="en-US" noProof="0" dirty="0">
+                <a:solidFill>
+                  <a:schemeClr val="tx1"/>
+                </a:solidFill>
+              </a:rPr>
               <a:t>Outlook</a:t>
             </a:r>
           </a:p>
@@ -42804,7 +43272,11 @@
           <a:lstStyle/>
           <a:p>
             <a:r>
-              <a:rPr lang="en-US" noProof="0" dirty="0"/>
+              <a:rPr lang="en-US" noProof="0" dirty="0">
+                <a:solidFill>
+                  <a:schemeClr val="bg2"/>
+                </a:solidFill>
+              </a:rPr>
               <a:t>Summary</a:t>
             </a:r>
           </a:p>
@@ -42832,7 +43304,11 @@
           <a:lstStyle/>
           <a:p>
             <a:r>
-              <a:rPr lang="en-US" noProof="0" dirty="0"/>
+              <a:rPr lang="en-US" noProof="0" dirty="0">
+                <a:solidFill>
+                  <a:schemeClr val="tx1"/>
+                </a:solidFill>
+              </a:rPr>
               <a:t>Conclusion</a:t>
             </a:r>
           </a:p>
@@ -43081,7 +43557,11 @@
           <a:lstStyle/>
           <a:p>
             <a:r>
-              <a:rPr lang="en-US" noProof="0" dirty="0"/>
+              <a:rPr lang="en-US" noProof="0" dirty="0">
+                <a:solidFill>
+                  <a:schemeClr val="tx1"/>
+                </a:solidFill>
+              </a:rPr>
               <a:t>Questions?</a:t>
             </a:r>
           </a:p>
@@ -43285,7 +43765,11 @@
           <a:lstStyle/>
           <a:p>
             <a:r>
-              <a:rPr lang="en-US" noProof="0" dirty="0"/>
+              <a:rPr lang="en-US" noProof="0" dirty="0">
+                <a:solidFill>
+                  <a:schemeClr val="tx1"/>
+                </a:solidFill>
+              </a:rPr>
               <a:t>References</a:t>
             </a:r>
           </a:p>
@@ -43325,12 +43809,8 @@
               </a:lnSpc>
             </a:pPr>
             <a:r>
-              <a:rPr lang="en-US" sz="1400" dirty="0" err="1"/>
-              <a:t>StatCounter</a:t>
-            </a:r>
-            <a:r>
               <a:rPr lang="en-US" sz="1400" dirty="0"/>
-              <a:t> Global Stats. (2026). </a:t>
+              <a:t>StatCounter Global Stats. (2026). </a:t>
             </a:r>
             <a:r>
               <a:rPr lang="en-US" sz="1400" i="1" dirty="0"/>
@@ -43573,7 +44053,11 @@
           <a:lstStyle/>
           <a:p>
             <a:r>
-              <a:rPr lang="en-US" noProof="0" dirty="0"/>
+              <a:rPr lang="en-US" noProof="0" dirty="0">
+                <a:solidFill>
+                  <a:schemeClr val="tx1"/>
+                </a:solidFill>
+              </a:rPr>
               <a:t>References</a:t>
             </a:r>
           </a:p>
@@ -44145,7 +44629,11 @@
           <a:lstStyle/>
           <a:p>
             <a:r>
-              <a:rPr lang="en-US" noProof="0" dirty="0"/>
+              <a:rPr lang="en-US" noProof="0" dirty="0">
+                <a:solidFill>
+                  <a:schemeClr val="bg2"/>
+                </a:solidFill>
+              </a:rPr>
               <a:t>The Problem in Numbers</a:t>
             </a:r>
           </a:p>
@@ -44173,10 +44661,18 @@
           <a:lstStyle/>
           <a:p>
             <a:r>
-              <a:rPr lang="en-US" dirty="0"/>
+              <a:rPr lang="en-US" dirty="0">
+                <a:solidFill>
+                  <a:schemeClr val="tx1"/>
+                </a:solidFill>
+              </a:rPr>
               <a:t>State of Android App Security</a:t>
             </a:r>
-            <a:endParaRPr lang="en-US" noProof="0" dirty="0"/>
+            <a:endParaRPr lang="en-US" noProof="0" dirty="0">
+              <a:solidFill>
+                <a:schemeClr val="tx1"/>
+              </a:solidFill>
+            </a:endParaRPr>
           </a:p>
         </p:txBody>
       </p:sp>
@@ -44720,7 +45216,11 @@
           <a:lstStyle/>
           <a:p>
             <a:r>
-              <a:rPr lang="en-US" noProof="0" dirty="0"/>
+              <a:rPr lang="en-US" noProof="0" dirty="0">
+                <a:solidFill>
+                  <a:schemeClr val="bg2"/>
+                </a:solidFill>
+              </a:rPr>
               <a:t>The Problem in Numbers</a:t>
             </a:r>
           </a:p>
@@ -44748,10 +45248,18 @@
           <a:lstStyle/>
           <a:p>
             <a:r>
-              <a:rPr lang="en-US" dirty="0"/>
+              <a:rPr lang="en-US" dirty="0">
+                <a:solidFill>
+                  <a:schemeClr val="tx1"/>
+                </a:solidFill>
+              </a:rPr>
               <a:t>State of Android App Security</a:t>
             </a:r>
-            <a:endParaRPr lang="en-US" noProof="0" dirty="0"/>
+            <a:endParaRPr lang="en-US" noProof="0" dirty="0">
+              <a:solidFill>
+                <a:schemeClr val="tx1"/>
+              </a:solidFill>
+            </a:endParaRPr>
           </a:p>
         </p:txBody>
       </p:sp>
@@ -45286,7 +45794,11 @@
           <a:lstStyle/>
           <a:p>
             <a:r>
-              <a:rPr lang="en-US" noProof="0" dirty="0"/>
+              <a:rPr lang="en-US" noProof="0" dirty="0">
+                <a:solidFill>
+                  <a:schemeClr val="bg2"/>
+                </a:solidFill>
+              </a:rPr>
               <a:t>The Causes</a:t>
             </a:r>
           </a:p>
@@ -45314,10 +45826,18 @@
           <a:lstStyle/>
           <a:p>
             <a:r>
-              <a:rPr lang="en-US" dirty="0"/>
+              <a:rPr lang="en-US" dirty="0">
+                <a:solidFill>
+                  <a:schemeClr val="tx1"/>
+                </a:solidFill>
+              </a:rPr>
               <a:t>State of Android App Security</a:t>
             </a:r>
-            <a:endParaRPr lang="en-US" noProof="0" dirty="0"/>
+            <a:endParaRPr lang="en-US" noProof="0" dirty="0">
+              <a:solidFill>
+                <a:schemeClr val="tx1"/>
+              </a:solidFill>
+            </a:endParaRPr>
           </a:p>
         </p:txBody>
       </p:sp>
@@ -45689,7 +46209,11 @@
           <a:lstStyle/>
           <a:p>
             <a:r>
-              <a:rPr lang="en-US" noProof="0" dirty="0"/>
+              <a:rPr lang="en-US" noProof="0" dirty="0">
+                <a:solidFill>
+                  <a:schemeClr val="bg2"/>
+                </a:solidFill>
+              </a:rPr>
               <a:t>The Causes</a:t>
             </a:r>
           </a:p>
@@ -45717,10 +46241,18 @@
           <a:lstStyle/>
           <a:p>
             <a:r>
-              <a:rPr lang="en-US" dirty="0"/>
+              <a:rPr lang="en-US" dirty="0">
+                <a:solidFill>
+                  <a:schemeClr val="tx1"/>
+                </a:solidFill>
+              </a:rPr>
               <a:t>State of Android App Security</a:t>
             </a:r>
-            <a:endParaRPr lang="en-US" noProof="0" dirty="0"/>
+            <a:endParaRPr lang="en-US" noProof="0" dirty="0">
+              <a:solidFill>
+                <a:schemeClr val="tx1"/>
+              </a:solidFill>
+            </a:endParaRPr>
           </a:p>
         </p:txBody>
       </p:sp>
@@ -46210,7 +46742,11 @@
           <a:lstStyle/>
           <a:p>
             <a:r>
-              <a:rPr lang="en-US" noProof="0" dirty="0"/>
+              <a:rPr lang="en-US" noProof="0" dirty="0">
+                <a:solidFill>
+                  <a:schemeClr val="bg2"/>
+                </a:solidFill>
+              </a:rPr>
               <a:t>The Goals</a:t>
             </a:r>
           </a:p>
@@ -46238,7 +46774,11 @@
           <a:lstStyle/>
           <a:p>
             <a:r>
-              <a:rPr lang="en-US" dirty="0"/>
+              <a:rPr lang="en-US" dirty="0">
+                <a:solidFill>
+                  <a:schemeClr val="tx1"/>
+                </a:solidFill>
+              </a:rPr>
               <a:t>Understanding the Challenge</a:t>
             </a:r>
           </a:p>

</xml_diff>

<commit_message>
Replaced the bar chart in the introduction of my ba thesis presentation with a pie plot for better visibility
</commit_message>
<xml_diff>
--- a/dev_documents/presentation/ba_thesis_presentation_kronig.pptx
+++ b/dev_documents/presentation/ba_thesis_presentation_kronig.pptx
@@ -14,7 +14,7 @@
   </p:handoutMasterIdLst>
   <p:sldIdLst>
     <p:sldId id="256" r:id="rId4"/>
-    <p:sldId id="322" r:id="rId5"/>
+    <p:sldId id="328" r:id="rId5"/>
     <p:sldId id="321" r:id="rId6"/>
     <p:sldId id="319" r:id="rId7"/>
     <p:sldId id="320" r:id="rId8"/>
@@ -31800,6 +31800,18 @@
               </a:lnSpc>
             </a:pPr>
             <a:r>
+              <a:rPr lang="en-US" dirty="0"/>
+              <a:t>Tools for vulnerability detection</a:t>
+            </a:r>
+            <a:endParaRPr lang="en-US" b="1" dirty="0"/>
+          </a:p>
+          <a:p>
+            <a:pPr>
+              <a:lnSpc>
+                <a:spcPct val="150000"/>
+              </a:lnSpc>
+            </a:pPr>
+            <a:r>
               <a:rPr lang="en-US" b="1" dirty="0"/>
               <a:t>S</a:t>
             </a:r>
@@ -31863,22 +31875,6 @@
               <a:rPr lang="en-US" dirty="0"/>
               <a:t>)</a:t>
             </a:r>
-          </a:p>
-          <a:p>
-            <a:pPr>
-              <a:lnSpc>
-                <a:spcPct val="150000"/>
-              </a:lnSpc>
-            </a:pPr>
-            <a:r>
-              <a:rPr lang="en-US" noProof="0" dirty="0"/>
-              <a:t>Tools fo</a:t>
-            </a:r>
-            <a:r>
-              <a:rPr lang="en-US" dirty="0"/>
-              <a:t>r vulnerability detection</a:t>
-            </a:r>
-            <a:endParaRPr lang="en-US" noProof="0" dirty="0"/>
           </a:p>
           <a:p>
             <a:pPr>
@@ -32164,7 +32160,11 @@
             </a:pPr>
             <a:r>
               <a:rPr lang="en-US" noProof="0" dirty="0"/>
-              <a:t>…solve both challenges!</a:t>
+              <a:t>…</a:t>
+            </a:r>
+            <a:r>
+              <a:rPr lang="en-US" i="1" noProof="0" dirty="0"/>
+              <a:t>solve both challenges!</a:t>
             </a:r>
           </a:p>
           <a:p>
@@ -34396,7 +34396,7 @@
         <p:cNvPr id="1" name="">
           <a:extLst>
             <a:ext uri="{FF2B5EF4-FFF2-40B4-BE49-F238E27FC236}">
-              <a16:creationId xmlns:a16="http://schemas.microsoft.com/office/drawing/2014/main" id="{E5EC0B43-F179-B9EA-5BC2-AC64C53C4C9B}"/>
+              <a16:creationId xmlns:a16="http://schemas.microsoft.com/office/drawing/2014/main" id="{912F838B-9793-1E2D-5B63-E6C84A16B00D}"/>
             </a:ext>
           </a:extLst>
         </p:cNvPr>
@@ -34416,7 +34416,7 @@
           <p:cNvPr id="8" name="Textplatzhalter 7">
             <a:extLst>
               <a:ext uri="{FF2B5EF4-FFF2-40B4-BE49-F238E27FC236}">
-                <a16:creationId xmlns:a16="http://schemas.microsoft.com/office/drawing/2014/main" id="{C28AAE82-5705-88C1-DFD7-2111C4466EB2}"/>
+                <a16:creationId xmlns:a16="http://schemas.microsoft.com/office/drawing/2014/main" id="{D8DEED39-1B51-F25A-29A9-94C1D53561BA}"/>
               </a:ext>
             </a:extLst>
           </p:cNvPr>
@@ -34453,7 +34453,7 @@
           <p:cNvPr id="7" name="Titel 6">
             <a:extLst>
               <a:ext uri="{FF2B5EF4-FFF2-40B4-BE49-F238E27FC236}">
-                <a16:creationId xmlns:a16="http://schemas.microsoft.com/office/drawing/2014/main" id="{F60CD8EF-51C5-1A60-57E4-1A1487E622A7}"/>
+                <a16:creationId xmlns:a16="http://schemas.microsoft.com/office/drawing/2014/main" id="{C5467C5E-75FF-4EAE-645B-68E6FC59E533}"/>
               </a:ext>
             </a:extLst>
           </p:cNvPr>
@@ -34490,7 +34490,7 @@
           <p:cNvPr id="10" name="Inhaltsplatzhalter 9">
             <a:extLst>
               <a:ext uri="{FF2B5EF4-FFF2-40B4-BE49-F238E27FC236}">
-                <a16:creationId xmlns:a16="http://schemas.microsoft.com/office/drawing/2014/main" id="{4138B486-AD16-7820-CE66-39306F42B7B8}"/>
+                <a16:creationId xmlns:a16="http://schemas.microsoft.com/office/drawing/2014/main" id="{0946E172-560B-8BDE-237B-CC21EE2AA1BA}"/>
               </a:ext>
             </a:extLst>
           </p:cNvPr>
@@ -34529,6 +34529,29 @@
             </a:pPr>
             <a:r>
               <a:rPr lang="en-US" noProof="0" dirty="0"/>
+              <a:t>Sideloading of apps</a:t>
+            </a:r>
+          </a:p>
+          <a:p>
+            <a:pPr>
+              <a:lnSpc>
+                <a:spcPct val="150000"/>
+              </a:lnSpc>
+            </a:pPr>
+            <a:r>
+              <a:rPr lang="en-US" dirty="0"/>
+              <a:t>Automated security review</a:t>
+            </a:r>
+            <a:endParaRPr lang="en-US" noProof="0" dirty="0"/>
+          </a:p>
+          <a:p>
+            <a:pPr>
+              <a:lnSpc>
+                <a:spcPct val="150000"/>
+              </a:lnSpc>
+            </a:pPr>
+            <a:r>
+              <a:rPr lang="en-US" i="1" noProof="0" dirty="0"/>
               <a:t>Vulnerabilities</a:t>
             </a:r>
           </a:p>
@@ -34555,7 +34578,7 @@
           <p:cNvPr id="9" name="Textplatzhalter 8">
             <a:extLst>
               <a:ext uri="{FF2B5EF4-FFF2-40B4-BE49-F238E27FC236}">
-                <a16:creationId xmlns:a16="http://schemas.microsoft.com/office/drawing/2014/main" id="{A5122B93-6A45-5D57-F0FF-D45161742E9F}"/>
+                <a16:creationId xmlns:a16="http://schemas.microsoft.com/office/drawing/2014/main" id="{5B6E05ED-11BE-82C9-0606-42D797B9E6C1}"/>
               </a:ext>
             </a:extLst>
           </p:cNvPr>
@@ -34584,7 +34607,7 @@
           <p:cNvPr id="11" name="Fußzeilenplatzhalter 10">
             <a:extLst>
               <a:ext uri="{FF2B5EF4-FFF2-40B4-BE49-F238E27FC236}">
-                <a16:creationId xmlns:a16="http://schemas.microsoft.com/office/drawing/2014/main" id="{14FF6A07-D61D-B2E2-FF8B-24C8FDEA4F38}"/>
+                <a16:creationId xmlns:a16="http://schemas.microsoft.com/office/drawing/2014/main" id="{A4D6812B-4695-A409-3FDE-07165F82C90D}"/>
               </a:ext>
             </a:extLst>
           </p:cNvPr>
@@ -34615,7 +34638,7 @@
           <p:cNvPr id="12" name="Foliennummernplatzhalter 11">
             <a:extLst>
               <a:ext uri="{FF2B5EF4-FFF2-40B4-BE49-F238E27FC236}">
-                <a16:creationId xmlns:a16="http://schemas.microsoft.com/office/drawing/2014/main" id="{41953284-D2EF-DC4C-6B36-1B5EC4DCC6D9}"/>
+                <a16:creationId xmlns:a16="http://schemas.microsoft.com/office/drawing/2014/main" id="{FC453924-915C-0DFE-D4BB-1EBE0F86AB98}"/>
               </a:ext>
             </a:extLst>
           </p:cNvPr>
@@ -34642,10 +34665,10 @@
       </p:sp>
       <p:pic>
         <p:nvPicPr>
-          <p:cNvPr id="15" name="Grafik 14" descr="Ein Bild, das Text, Screenshot, Diagramm, Rechteck enthält.&#10;&#10;KI-generierte Inhalte können fehlerhaft sein.">
+          <p:cNvPr id="5" name="Grafik 4" descr="Ein Bild, das Text, Screenshot, Schrift, Kreis enthält.&#10;&#10;KI-generierte Inhalte können fehlerhaft sein.">
             <a:extLst>
               <a:ext uri="{FF2B5EF4-FFF2-40B4-BE49-F238E27FC236}">
-                <a16:creationId xmlns:a16="http://schemas.microsoft.com/office/drawing/2014/main" id="{70273F15-B74A-4897-5C7A-5CC08C62314D}"/>
+                <a16:creationId xmlns:a16="http://schemas.microsoft.com/office/drawing/2014/main" id="{E8FD955B-52D4-18F5-BE9E-12B060EE754F}"/>
               </a:ext>
             </a:extLst>
           </p:cNvPr>
@@ -34668,8 +34691,8 @@
         </p:blipFill>
         <p:spPr>
           <a:xfrm>
-            <a:off x="3486429" y="1866764"/>
-            <a:ext cx="5297571" cy="2628736"/>
+            <a:off x="5076056" y="1386977"/>
+            <a:ext cx="2987079" cy="3186217"/>
           </a:xfrm>
           <a:prstGeom prst="rect">
             <a:avLst/>
@@ -34679,7 +34702,7 @@
     </p:spTree>
     <p:extLst>
       <p:ext uri="{BB962C8B-B14F-4D97-AF65-F5344CB8AC3E}">
-        <p14:creationId xmlns:p14="http://schemas.microsoft.com/office/powerpoint/2010/main" val="3874573317"/>
+        <p14:creationId xmlns:p14="http://schemas.microsoft.com/office/powerpoint/2010/main" val="205559390"/>
       </p:ext>
     </p:extLst>
   </p:cSld>
@@ -35636,6 +35659,7 @@
               <a:rPr lang="en-US" noProof="0" dirty="0"/>
               <a:t>163 implemented vulnerabilities</a:t>
             </a:r>
+            <a:endParaRPr lang="en-US" dirty="0"/>
           </a:p>
           <a:p>
             <a:pPr>
@@ -35644,20 +35668,42 @@
               </a:lnSpc>
             </a:pPr>
             <a:r>
+              <a:rPr lang="en-US" dirty="0"/>
+              <a:t>Of 117 MASWE vulnerability types…</a:t>
+            </a:r>
+          </a:p>
+          <a:p>
+            <a:pPr marL="0" indent="0">
+              <a:lnSpc>
+                <a:spcPct val="150000"/>
+              </a:lnSpc>
+              <a:buNone/>
+            </a:pPr>
+            <a:r>
               <a:rPr lang="en-US" noProof="0" dirty="0"/>
-              <a:t>42/117 MASWE vulnerability types covered</a:t>
-            </a:r>
-          </a:p>
-          <a:p>
-            <a:pPr>
+              <a:t>	</a:t>
+            </a:r>
+            <a:r>
+              <a:rPr lang="en-US" dirty="0"/>
+              <a:t>…42 (35.9%) covered</a:t>
+            </a:r>
+          </a:p>
+          <a:p>
+            <a:pPr marL="0" indent="0">
               <a:lnSpc>
                 <a:spcPct val="150000"/>
               </a:lnSpc>
+              <a:buNone/>
             </a:pPr>
             <a:r>
               <a:rPr lang="en-US" noProof="0" dirty="0"/>
-              <a:t>75 vulnerability types with no reference implementation</a:t>
-            </a:r>
+              <a:t>	…</a:t>
+            </a:r>
+            <a:r>
+              <a:rPr lang="en-US" dirty="0"/>
+              <a:t>75 (64.1%) with no reference implementations</a:t>
+            </a:r>
+            <a:endParaRPr lang="en-US" noProof="0" dirty="0"/>
           </a:p>
         </p:txBody>
       </p:sp>
@@ -35879,7 +35925,7 @@
             </a:pPr>
             <a:r>
               <a:rPr lang="en-US" noProof="0" dirty="0"/>
-              <a:t>Most vulnerabilities without reference implementation</a:t>
+              <a:t>Most vulnerability types without reference implementation</a:t>
             </a:r>
           </a:p>
           <a:p>
@@ -37528,7 +37574,7 @@
               <a:buChar char="§"/>
             </a:pPr>
             <a:r>
-              <a:rPr lang="en-US" sz="2400" dirty="0"/>
+              <a:rPr lang="en-US" dirty="0"/>
               <a:t> Around 5?</a:t>
             </a:r>
           </a:p>
@@ -37541,7 +37587,7 @@
               <a:buChar char="§"/>
             </a:pPr>
             <a:r>
-              <a:rPr lang="en-US" sz="2400" dirty="0"/>
+              <a:rPr lang="en-US" dirty="0"/>
               <a:t>Around 15?</a:t>
             </a:r>
           </a:p>
@@ -37554,7 +37600,7 @@
               <a:buChar char="§"/>
             </a:pPr>
             <a:r>
-              <a:rPr lang="en-US" sz="2400" dirty="0"/>
+              <a:rPr lang="en-US" dirty="0"/>
               <a:t>More than 30?</a:t>
             </a:r>
           </a:p>
@@ -39003,8 +39049,20 @@
             </a:pPr>
             <a:r>
               <a:rPr lang="en-US" noProof="0" dirty="0"/>
-              <a:t>Feature-oriented structure</a:t>
-            </a:r>
+              <a:t>Feature-oriented app structure</a:t>
+            </a:r>
+          </a:p>
+          <a:p>
+            <a:pPr>
+              <a:lnSpc>
+                <a:spcPct val="150000"/>
+              </a:lnSpc>
+            </a:pPr>
+            <a:r>
+              <a:rPr lang="en-US" dirty="0"/>
+              <a:t>Menu as launcher</a:t>
+            </a:r>
+            <a:endParaRPr lang="en-US" noProof="0" dirty="0"/>
           </a:p>
           <a:p>
             <a:pPr>
@@ -39937,7 +39995,15 @@
             </a:pPr>
             <a:r>
               <a:rPr lang="en-US" noProof="0" dirty="0"/>
-              <a:t>All vulnerabilities share:</a:t>
+              <a:t>All vulnerabilities</a:t>
+            </a:r>
+            <a:r>
+              <a:rPr lang="en-US" dirty="0"/>
+              <a:t> (</a:t>
+            </a:r>
+            <a:r>
+              <a:rPr lang="en-US" noProof="0" dirty="0"/>
+              <a:t>packages) share:</a:t>
             </a:r>
           </a:p>
           <a:p>
@@ -39959,7 +40025,7 @@
             </a:pPr>
             <a:r>
               <a:rPr lang="en-US" noProof="0" dirty="0"/>
-              <a:t>Activity layouts</a:t>
+              <a:t>Layouts</a:t>
             </a:r>
           </a:p>
           <a:p>
@@ -39970,7 +40036,7 @@
               <a:buNone/>
             </a:pPr>
             <a:r>
-              <a:rPr lang="en-US" noProof="0" dirty="0"/>
+              <a:rPr lang="en-US" i="1" noProof="0" dirty="0"/>
               <a:t>Mostly differ in encryption and storage</a:t>
             </a:r>
           </a:p>
@@ -40870,6 +40936,18 @@
               </a:lnSpc>
             </a:pPr>
             <a:r>
+              <a:rPr lang="en-US" dirty="0"/>
+              <a:t>One app per vulnerability category</a:t>
+            </a:r>
+            <a:endParaRPr lang="en-US" noProof="0" dirty="0"/>
+          </a:p>
+          <a:p>
+            <a:pPr>
+              <a:lnSpc>
+                <a:spcPct val="150000"/>
+              </a:lnSpc>
+            </a:pPr>
+            <a:r>
               <a:rPr lang="en-US" noProof="0" dirty="0"/>
               <a:t>One app package per vulnerability type</a:t>
             </a:r>
@@ -40882,18 +40960,11 @@
             </a:pPr>
             <a:r>
               <a:rPr lang="en-US" noProof="0" dirty="0"/>
-              <a:t>One app per vulnerability category</a:t>
-            </a:r>
-          </a:p>
-          <a:p>
-            <a:pPr>
-              <a:lnSpc>
-                <a:spcPct val="150000"/>
-              </a:lnSpc>
-            </a:pPr>
-            <a:r>
-              <a:rPr lang="en-US" noProof="0" dirty="0"/>
-              <a:t>Resources shared by apps stored in “common” library module</a:t>
+              <a:t>Shared resources in </a:t>
+            </a:r>
+            <a:r>
+              <a:rPr lang="en-US" i="1" noProof="0" dirty="0"/>
+              <a:t>“common”</a:t>
             </a:r>
           </a:p>
           <a:p>
@@ -43346,6 +43417,17 @@
               </a:lnSpc>
             </a:pPr>
             <a:r>
+              <a:rPr lang="en-US" b="1" noProof="0" dirty="0"/>
+              <a:t>Developed MASTG reference apps</a:t>
+            </a:r>
+          </a:p>
+          <a:p>
+            <a:pPr>
+              <a:lnSpc>
+                <a:spcPct val="150000"/>
+              </a:lnSpc>
+            </a:pPr>
+            <a:r>
               <a:rPr lang="en-US" noProof="0" dirty="0"/>
               <a:t>Identified weaknesses of MASTG reference apps</a:t>
             </a:r>
@@ -46389,7 +46471,7 @@
             <a:pPr algn="ctr"/>
             <a:r>
               <a:rPr lang="en-US" sz="1400" noProof="0" dirty="0"/>
-              <a:t>of developers lacked </a:t>
+              <a:t>lacked </a:t>
             </a:r>
           </a:p>
           <a:p>
@@ -46604,7 +46686,7 @@
             </a:pPr>
             <a:r>
               <a:rPr lang="en-US" noProof="0" dirty="0"/>
-              <a:t>Study’s show:</a:t>
+              <a:t>Of interviewed developers:</a:t>
             </a:r>
           </a:p>
           <a:p>
@@ -46672,7 +46754,7 @@
             <a:pPr algn="ctr"/>
             <a:r>
               <a:rPr lang="en-US" sz="1400" noProof="0" dirty="0"/>
-              <a:t>of developers cite security</a:t>
+              <a:t>cited security</a:t>
             </a:r>
           </a:p>
           <a:p>

</xml_diff>

<commit_message>
Minor asthetic changes and styling overhauls to the presentation slides of BA thesis
</commit_message>
<xml_diff>
--- a/dev_documents/presentation/ba_thesis_presentation_kronig.pptx
+++ b/dev_documents/presentation/ba_thesis_presentation_kronig.pptx
@@ -7,10 +7,10 @@
     <p:sldMasterId id="2147483793" r:id="rId3"/>
   </p:sldMasterIdLst>
   <p:notesMasterIdLst>
-    <p:notesMasterId r:id="rId52"/>
+    <p:notesMasterId r:id="rId54"/>
   </p:notesMasterIdLst>
   <p:handoutMasterIdLst>
-    <p:handoutMasterId r:id="rId53"/>
+    <p:handoutMasterId r:id="rId55"/>
   </p:handoutMasterIdLst>
   <p:sldIdLst>
     <p:sldId id="256" r:id="rId4"/>
@@ -22,45 +22,47 @@
     <p:sldId id="325" r:id="rId10"/>
     <p:sldId id="313" r:id="rId11"/>
     <p:sldId id="324" r:id="rId12"/>
-    <p:sldId id="315" r:id="rId13"/>
-    <p:sldId id="316" r:id="rId14"/>
-    <p:sldId id="317" r:id="rId15"/>
-    <p:sldId id="290" r:id="rId16"/>
-    <p:sldId id="291" r:id="rId17"/>
-    <p:sldId id="274" r:id="rId18"/>
-    <p:sldId id="262" r:id="rId19"/>
-    <p:sldId id="273" r:id="rId20"/>
-    <p:sldId id="275" r:id="rId21"/>
-    <p:sldId id="326" r:id="rId22"/>
-    <p:sldId id="263" r:id="rId23"/>
-    <p:sldId id="277" r:id="rId24"/>
-    <p:sldId id="276" r:id="rId25"/>
-    <p:sldId id="278" r:id="rId26"/>
-    <p:sldId id="292" r:id="rId27"/>
-    <p:sldId id="281" r:id="rId28"/>
-    <p:sldId id="286" r:id="rId29"/>
-    <p:sldId id="287" r:id="rId30"/>
-    <p:sldId id="288" r:id="rId31"/>
-    <p:sldId id="289" r:id="rId32"/>
-    <p:sldId id="264" r:id="rId33"/>
-    <p:sldId id="293" r:id="rId34"/>
-    <p:sldId id="294" r:id="rId35"/>
-    <p:sldId id="296" r:id="rId36"/>
-    <p:sldId id="297" r:id="rId37"/>
-    <p:sldId id="298" r:id="rId38"/>
-    <p:sldId id="295" r:id="rId39"/>
-    <p:sldId id="282" r:id="rId40"/>
-    <p:sldId id="301" r:id="rId41"/>
-    <p:sldId id="302" r:id="rId42"/>
-    <p:sldId id="283" r:id="rId43"/>
-    <p:sldId id="304" r:id="rId44"/>
-    <p:sldId id="305" r:id="rId45"/>
-    <p:sldId id="284" r:id="rId46"/>
-    <p:sldId id="285" r:id="rId47"/>
-    <p:sldId id="308" r:id="rId48"/>
-    <p:sldId id="307" r:id="rId49"/>
-    <p:sldId id="327" r:id="rId50"/>
-    <p:sldId id="306" r:id="rId51"/>
+    <p:sldId id="330" r:id="rId13"/>
+    <p:sldId id="315" r:id="rId14"/>
+    <p:sldId id="316" r:id="rId15"/>
+    <p:sldId id="317" r:id="rId16"/>
+    <p:sldId id="290" r:id="rId17"/>
+    <p:sldId id="291" r:id="rId18"/>
+    <p:sldId id="274" r:id="rId19"/>
+    <p:sldId id="262" r:id="rId20"/>
+    <p:sldId id="273" r:id="rId21"/>
+    <p:sldId id="275" r:id="rId22"/>
+    <p:sldId id="326" r:id="rId23"/>
+    <p:sldId id="263" r:id="rId24"/>
+    <p:sldId id="277" r:id="rId25"/>
+    <p:sldId id="276" r:id="rId26"/>
+    <p:sldId id="278" r:id="rId27"/>
+    <p:sldId id="292" r:id="rId28"/>
+    <p:sldId id="281" r:id="rId29"/>
+    <p:sldId id="286" r:id="rId30"/>
+    <p:sldId id="287" r:id="rId31"/>
+    <p:sldId id="288" r:id="rId32"/>
+    <p:sldId id="289" r:id="rId33"/>
+    <p:sldId id="264" r:id="rId34"/>
+    <p:sldId id="293" r:id="rId35"/>
+    <p:sldId id="331" r:id="rId36"/>
+    <p:sldId id="294" r:id="rId37"/>
+    <p:sldId id="296" r:id="rId38"/>
+    <p:sldId id="297" r:id="rId39"/>
+    <p:sldId id="298" r:id="rId40"/>
+    <p:sldId id="295" r:id="rId41"/>
+    <p:sldId id="282" r:id="rId42"/>
+    <p:sldId id="301" r:id="rId43"/>
+    <p:sldId id="302" r:id="rId44"/>
+    <p:sldId id="283" r:id="rId45"/>
+    <p:sldId id="304" r:id="rId46"/>
+    <p:sldId id="305" r:id="rId47"/>
+    <p:sldId id="284" r:id="rId48"/>
+    <p:sldId id="285" r:id="rId49"/>
+    <p:sldId id="308" r:id="rId50"/>
+    <p:sldId id="307" r:id="rId51"/>
+    <p:sldId id="327" r:id="rId52"/>
+    <p:sldId id="306" r:id="rId53"/>
   </p:sldIdLst>
   <p:sldSz cx="9144000" cy="5143500" type="screen16x9"/>
   <p:notesSz cx="6858000" cy="9144000"/>
@@ -252,7 +254,7 @@
           <a:p>
             <a:fld id="{442B13D9-EE20-4263-A517-453A6CC03581}" type="datetimeFigureOut">
               <a:rPr lang="en-US" smtClean="0"/>
-              <a:t>2/4/2026</a:t>
+              <a:t>2/5/2026</a:t>
             </a:fld>
             <a:endParaRPr lang="en-US"/>
           </a:p>
@@ -417,7 +419,7 @@
           <a:p>
             <a:fld id="{C4B9E2E8-0589-406D-8FD1-7B0DBC84FBDE}" type="datetimeFigureOut">
               <a:rPr lang="de-CH" smtClean="0"/>
-              <a:t>04.02.2026</a:t>
+              <a:t>05.02.2026</a:t>
             </a:fld>
             <a:endParaRPr lang="de-CH"/>
           </a:p>
@@ -31444,6 +31446,423 @@
         <p:cNvPr id="1" name="">
           <a:extLst>
             <a:ext uri="{FF2B5EF4-FFF2-40B4-BE49-F238E27FC236}">
+              <a16:creationId xmlns:a16="http://schemas.microsoft.com/office/drawing/2014/main" id="{FCF8C2E8-6FBF-0F6F-0B3B-93E3FEAD7254}"/>
+            </a:ext>
+          </a:extLst>
+        </p:cNvPr>
+        <p:cNvGrpSpPr/>
+        <p:nvPr/>
+      </p:nvGrpSpPr>
+      <p:grpSpPr>
+        <a:xfrm>
+          <a:off x="0" y="0"/>
+          <a:ext cx="0" cy="0"/>
+          <a:chOff x="0" y="0"/>
+          <a:chExt cx="0" cy="0"/>
+        </a:xfrm>
+      </p:grpSpPr>
+      <p:sp>
+        <p:nvSpPr>
+          <p:cNvPr id="8" name="Textplatzhalter 7">
+            <a:extLst>
+              <a:ext uri="{FF2B5EF4-FFF2-40B4-BE49-F238E27FC236}">
+                <a16:creationId xmlns:a16="http://schemas.microsoft.com/office/drawing/2014/main" id="{38805191-FFAD-9A03-AD05-E469105BCD90}"/>
+              </a:ext>
+            </a:extLst>
+          </p:cNvPr>
+          <p:cNvSpPr>
+            <a:spLocks noGrp="1"/>
+          </p:cNvSpPr>
+          <p:nvPr>
+            <p:ph type="body" sz="quarter" idx="12"/>
+          </p:nvPr>
+        </p:nvSpPr>
+        <p:spPr/>
+        <p:txBody>
+          <a:bodyPr/>
+          <a:lstStyle/>
+          <a:p>
+            <a:r>
+              <a:rPr lang="en-US" noProof="0" dirty="0">
+                <a:solidFill>
+                  <a:schemeClr val="bg2"/>
+                </a:solidFill>
+              </a:rPr>
+              <a:t>The Causes</a:t>
+            </a:r>
+          </a:p>
+        </p:txBody>
+      </p:sp>
+      <p:sp>
+        <p:nvSpPr>
+          <p:cNvPr id="7" name="Titel 6">
+            <a:extLst>
+              <a:ext uri="{FF2B5EF4-FFF2-40B4-BE49-F238E27FC236}">
+                <a16:creationId xmlns:a16="http://schemas.microsoft.com/office/drawing/2014/main" id="{1C2F7245-0BA0-6ABC-ADF1-AFE6FD94E273}"/>
+              </a:ext>
+            </a:extLst>
+          </p:cNvPr>
+          <p:cNvSpPr>
+            <a:spLocks noGrp="1"/>
+          </p:cNvSpPr>
+          <p:nvPr>
+            <p:ph type="title"/>
+          </p:nvPr>
+        </p:nvSpPr>
+        <p:spPr/>
+        <p:txBody>
+          <a:bodyPr/>
+          <a:lstStyle/>
+          <a:p>
+            <a:r>
+              <a:rPr lang="en-US" dirty="0">
+                <a:solidFill>
+                  <a:schemeClr val="tx1"/>
+                </a:solidFill>
+              </a:rPr>
+              <a:t>State of Android App Security</a:t>
+            </a:r>
+            <a:endParaRPr lang="en-US" noProof="0" dirty="0">
+              <a:solidFill>
+                <a:schemeClr val="tx1"/>
+              </a:solidFill>
+            </a:endParaRPr>
+          </a:p>
+        </p:txBody>
+      </p:sp>
+      <p:sp>
+        <p:nvSpPr>
+          <p:cNvPr id="9" name="Textplatzhalter 8">
+            <a:extLst>
+              <a:ext uri="{FF2B5EF4-FFF2-40B4-BE49-F238E27FC236}">
+                <a16:creationId xmlns:a16="http://schemas.microsoft.com/office/drawing/2014/main" id="{E4D48D23-C47F-CFBD-F903-5EF04F947F49}"/>
+              </a:ext>
+            </a:extLst>
+          </p:cNvPr>
+          <p:cNvSpPr>
+            <a:spLocks noGrp="1"/>
+          </p:cNvSpPr>
+          <p:nvPr>
+            <p:ph type="body" sz="quarter" idx="19"/>
+          </p:nvPr>
+        </p:nvSpPr>
+        <p:spPr/>
+        <p:txBody>
+          <a:bodyPr/>
+          <a:lstStyle/>
+          <a:p>
+            <a:endParaRPr lang="en-US" noProof="0" dirty="0"/>
+          </a:p>
+        </p:txBody>
+      </p:sp>
+      <p:sp>
+        <p:nvSpPr>
+          <p:cNvPr id="11" name="Fußzeilenplatzhalter 10">
+            <a:extLst>
+              <a:ext uri="{FF2B5EF4-FFF2-40B4-BE49-F238E27FC236}">
+                <a16:creationId xmlns:a16="http://schemas.microsoft.com/office/drawing/2014/main" id="{3FB1FBBF-5993-A467-B36D-4E124D3D3D18}"/>
+              </a:ext>
+            </a:extLst>
+          </p:cNvPr>
+          <p:cNvSpPr>
+            <a:spLocks noGrp="1"/>
+          </p:cNvSpPr>
+          <p:nvPr>
+            <p:ph type="ftr" sz="quarter" idx="17"/>
+          </p:nvPr>
+        </p:nvSpPr>
+        <p:spPr/>
+        <p:txBody>
+          <a:bodyPr/>
+          <a:lstStyle/>
+          <a:p>
+            <a:endParaRPr lang="en-US" noProof="0" dirty="0"/>
+          </a:p>
+        </p:txBody>
+      </p:sp>
+      <p:sp>
+        <p:nvSpPr>
+          <p:cNvPr id="12" name="Foliennummernplatzhalter 11">
+            <a:extLst>
+              <a:ext uri="{FF2B5EF4-FFF2-40B4-BE49-F238E27FC236}">
+                <a16:creationId xmlns:a16="http://schemas.microsoft.com/office/drawing/2014/main" id="{C076E40C-2F25-7A6B-6BA2-54F0DDCAE6F8}"/>
+              </a:ext>
+            </a:extLst>
+          </p:cNvPr>
+          <p:cNvSpPr>
+            <a:spLocks noGrp="1"/>
+          </p:cNvSpPr>
+          <p:nvPr>
+            <p:ph type="sldNum" sz="quarter" idx="18"/>
+          </p:nvPr>
+        </p:nvSpPr>
+        <p:spPr/>
+        <p:txBody>
+          <a:bodyPr/>
+          <a:lstStyle/>
+          <a:p>
+            <a:fld id="{E6639024-6672-4F87-864B-EA4FA9190A1A}" type="slidenum">
+              <a:rPr lang="en-US" noProof="0" smtClean="0"/>
+              <a:pPr/>
+              <a:t>10</a:t>
+            </a:fld>
+            <a:endParaRPr lang="en-US" noProof="0" dirty="0"/>
+          </a:p>
+        </p:txBody>
+      </p:sp>
+      <p:sp>
+        <p:nvSpPr>
+          <p:cNvPr id="2" name="Inhaltsplatzhalter 9">
+            <a:extLst>
+              <a:ext uri="{FF2B5EF4-FFF2-40B4-BE49-F238E27FC236}">
+                <a16:creationId xmlns:a16="http://schemas.microsoft.com/office/drawing/2014/main" id="{E18E8960-5BFF-9B51-423F-4745EFE49F0C}"/>
+              </a:ext>
+            </a:extLst>
+          </p:cNvPr>
+          <p:cNvSpPr txBox="1">
+            <a:spLocks/>
+          </p:cNvSpPr>
+          <p:nvPr/>
+        </p:nvSpPr>
+        <p:spPr>
+          <a:xfrm>
+            <a:off x="359532" y="1207321"/>
+            <a:ext cx="8424467" cy="3332402"/>
+          </a:xfrm>
+          <a:prstGeom prst="rect">
+            <a:avLst/>
+          </a:prstGeom>
+        </p:spPr>
+        <p:txBody>
+          <a:bodyPr vert="horz" lIns="36000" tIns="36000" rIns="36000" bIns="36000" rtlCol="0" anchor="t">
+            <a:normAutofit/>
+          </a:bodyPr>
+          <a:lstStyle>
+            <a:lvl1pPr marL="216000" indent="-216000" algn="l" defTabSz="685800" rtl="0" eaLnBrk="1" latinLnBrk="0" hangingPunct="1">
+              <a:lnSpc>
+                <a:spcPct val="100000"/>
+              </a:lnSpc>
+              <a:spcBef>
+                <a:spcPts val="200"/>
+              </a:spcBef>
+              <a:buClr>
+                <a:schemeClr val="tx1"/>
+              </a:buClr>
+              <a:buFont typeface="Symbol" panose="05050102010706020507" pitchFamily="18" charset="2"/>
+              <a:buChar char="-"/>
+              <a:defRPr sz="1800" kern="1200">
+                <a:solidFill>
+                  <a:schemeClr val="tx1"/>
+                </a:solidFill>
+                <a:latin typeface="+mn-lt"/>
+                <a:ea typeface="+mn-ea"/>
+                <a:cs typeface="+mn-cs"/>
+              </a:defRPr>
+            </a:lvl1pPr>
+            <a:lvl2pPr marL="432000" indent="-216000" algn="l" defTabSz="685800" rtl="0" eaLnBrk="1" latinLnBrk="0" hangingPunct="1">
+              <a:lnSpc>
+                <a:spcPct val="100000"/>
+              </a:lnSpc>
+              <a:spcBef>
+                <a:spcPts val="200"/>
+              </a:spcBef>
+              <a:buFont typeface="Symbol" panose="05050102010706020507" pitchFamily="18" charset="2"/>
+              <a:buChar char="-"/>
+              <a:defRPr sz="1600" kern="1200">
+                <a:solidFill>
+                  <a:schemeClr val="tx1"/>
+                </a:solidFill>
+                <a:latin typeface="+mn-lt"/>
+                <a:ea typeface="+mn-ea"/>
+                <a:cs typeface="+mn-cs"/>
+              </a:defRPr>
+            </a:lvl2pPr>
+            <a:lvl3pPr marL="648000" indent="-216000" algn="l" defTabSz="685800" rtl="0" eaLnBrk="1" latinLnBrk="0" hangingPunct="1">
+              <a:lnSpc>
+                <a:spcPct val="100000"/>
+              </a:lnSpc>
+              <a:spcBef>
+                <a:spcPts val="200"/>
+              </a:spcBef>
+              <a:buFont typeface="Symbol" panose="05050102010706020507" pitchFamily="18" charset="2"/>
+              <a:buChar char="-"/>
+              <a:defRPr sz="1400" kern="1200">
+                <a:solidFill>
+                  <a:schemeClr val="tx1"/>
+                </a:solidFill>
+                <a:latin typeface="+mn-lt"/>
+                <a:ea typeface="+mn-ea"/>
+                <a:cs typeface="+mn-cs"/>
+              </a:defRPr>
+            </a:lvl3pPr>
+            <a:lvl4pPr marL="864000" indent="-216000" algn="l" defTabSz="685800" rtl="0" eaLnBrk="1" latinLnBrk="0" hangingPunct="1">
+              <a:lnSpc>
+                <a:spcPct val="100000"/>
+              </a:lnSpc>
+              <a:spcBef>
+                <a:spcPts val="200"/>
+              </a:spcBef>
+              <a:buFont typeface="Symbol" panose="05050102010706020507" pitchFamily="18" charset="2"/>
+              <a:buChar char="-"/>
+              <a:defRPr sz="1200" kern="1200">
+                <a:solidFill>
+                  <a:schemeClr val="tx1"/>
+                </a:solidFill>
+                <a:latin typeface="+mn-lt"/>
+                <a:ea typeface="+mn-ea"/>
+                <a:cs typeface="+mn-cs"/>
+              </a:defRPr>
+            </a:lvl4pPr>
+            <a:lvl5pPr marL="1080000" indent="-216000" algn="l" defTabSz="685800" rtl="0" eaLnBrk="1" latinLnBrk="0" hangingPunct="1">
+              <a:lnSpc>
+                <a:spcPct val="100000"/>
+              </a:lnSpc>
+              <a:spcBef>
+                <a:spcPts val="200"/>
+              </a:spcBef>
+              <a:buFont typeface="Symbol" panose="05050102010706020507" pitchFamily="18" charset="2"/>
+              <a:buChar char="-"/>
+              <a:defRPr sz="1100" kern="1200">
+                <a:solidFill>
+                  <a:schemeClr val="tx1"/>
+                </a:solidFill>
+                <a:latin typeface="+mn-lt"/>
+                <a:ea typeface="+mn-ea"/>
+                <a:cs typeface="+mn-cs"/>
+              </a:defRPr>
+            </a:lvl5pPr>
+            <a:lvl6pPr marL="1885950" indent="-171450" algn="l" defTabSz="685800" rtl="0" eaLnBrk="1" latinLnBrk="0" hangingPunct="1">
+              <a:lnSpc>
+                <a:spcPct val="90000"/>
+              </a:lnSpc>
+              <a:spcBef>
+                <a:spcPts val="375"/>
+              </a:spcBef>
+              <a:buFont typeface="Arial" panose="020B0604020202020204" pitchFamily="34" charset="0"/>
+              <a:buChar char="•"/>
+              <a:defRPr sz="1350" kern="1200">
+                <a:solidFill>
+                  <a:schemeClr val="tx1"/>
+                </a:solidFill>
+                <a:latin typeface="+mn-lt"/>
+                <a:ea typeface="+mn-ea"/>
+                <a:cs typeface="+mn-cs"/>
+              </a:defRPr>
+            </a:lvl6pPr>
+            <a:lvl7pPr marL="2228850" indent="-171450" algn="l" defTabSz="685800" rtl="0" eaLnBrk="1" latinLnBrk="0" hangingPunct="1">
+              <a:lnSpc>
+                <a:spcPct val="90000"/>
+              </a:lnSpc>
+              <a:spcBef>
+                <a:spcPts val="375"/>
+              </a:spcBef>
+              <a:buFont typeface="Arial" panose="020B0604020202020204" pitchFamily="34" charset="0"/>
+              <a:buChar char="•"/>
+              <a:defRPr sz="1350" kern="1200">
+                <a:solidFill>
+                  <a:schemeClr val="tx1"/>
+                </a:solidFill>
+                <a:latin typeface="+mn-lt"/>
+                <a:ea typeface="+mn-ea"/>
+                <a:cs typeface="+mn-cs"/>
+              </a:defRPr>
+            </a:lvl7pPr>
+            <a:lvl8pPr marL="2571750" indent="-171450" algn="l" defTabSz="685800" rtl="0" eaLnBrk="1" latinLnBrk="0" hangingPunct="1">
+              <a:lnSpc>
+                <a:spcPct val="90000"/>
+              </a:lnSpc>
+              <a:spcBef>
+                <a:spcPts val="375"/>
+              </a:spcBef>
+              <a:buFont typeface="Arial" panose="020B0604020202020204" pitchFamily="34" charset="0"/>
+              <a:buChar char="•"/>
+              <a:defRPr sz="1350" kern="1200">
+                <a:solidFill>
+                  <a:schemeClr val="tx1"/>
+                </a:solidFill>
+                <a:latin typeface="+mn-lt"/>
+                <a:ea typeface="+mn-ea"/>
+                <a:cs typeface="+mn-cs"/>
+              </a:defRPr>
+            </a:lvl8pPr>
+            <a:lvl9pPr marL="2914650" indent="-171450" algn="l" defTabSz="685800" rtl="0" eaLnBrk="1" latinLnBrk="0" hangingPunct="1">
+              <a:lnSpc>
+                <a:spcPct val="90000"/>
+              </a:lnSpc>
+              <a:spcBef>
+                <a:spcPts val="375"/>
+              </a:spcBef>
+              <a:buFont typeface="Arial" panose="020B0604020202020204" pitchFamily="34" charset="0"/>
+              <a:buChar char="•"/>
+              <a:defRPr sz="1350" kern="1200">
+                <a:solidFill>
+                  <a:schemeClr val="tx1"/>
+                </a:solidFill>
+                <a:latin typeface="+mn-lt"/>
+                <a:ea typeface="+mn-ea"/>
+                <a:cs typeface="+mn-cs"/>
+              </a:defRPr>
+            </a:lvl9pPr>
+          </a:lstStyle>
+          <a:p>
+            <a:pPr marL="0" indent="0">
+              <a:lnSpc>
+                <a:spcPct val="150000"/>
+              </a:lnSpc>
+              <a:buNone/>
+            </a:pPr>
+            <a:r>
+              <a:rPr lang="en-US" dirty="0"/>
+              <a:t>What can be done about this?</a:t>
+            </a:r>
+          </a:p>
+          <a:p>
+            <a:pPr marL="0" indent="0">
+              <a:lnSpc>
+                <a:spcPct val="150000"/>
+              </a:lnSpc>
+              <a:buNone/>
+            </a:pPr>
+            <a:r>
+              <a:rPr lang="en-US" dirty="0"/>
+              <a:t>🗹 Find existing vulnerabilities</a:t>
+            </a:r>
+          </a:p>
+          <a:p>
+            <a:pPr marL="0" indent="0">
+              <a:lnSpc>
+                <a:spcPct val="150000"/>
+              </a:lnSpc>
+              <a:buNone/>
+            </a:pPr>
+            <a:r>
+              <a:rPr lang="en-US" dirty="0"/>
+              <a:t>🗹 Prevent new vulnerabilities</a:t>
+            </a:r>
+          </a:p>
+        </p:txBody>
+      </p:sp>
+    </p:spTree>
+    <p:extLst>
+      <p:ext uri="{BB962C8B-B14F-4D97-AF65-F5344CB8AC3E}">
+        <p14:creationId xmlns:p14="http://schemas.microsoft.com/office/powerpoint/2010/main" val="2965204057"/>
+      </p:ext>
+    </p:extLst>
+  </p:cSld>
+  <p:clrMapOvr>
+    <a:masterClrMapping/>
+  </p:clrMapOvr>
+</p:sld>
+</file>
+
+<file path=ppt/slides/slide11.xml><?xml version="1.0" encoding="utf-8"?>
+<p:sld xmlns:a="http://schemas.openxmlformats.org/drawingml/2006/main" xmlns:r="http://schemas.openxmlformats.org/officeDocument/2006/relationships" xmlns:p="http://schemas.openxmlformats.org/presentationml/2006/main">
+  <p:cSld>
+    <p:spTree>
+      <p:nvGrpSpPr>
+        <p:cNvPr id="1" name="">
+          <a:extLst>
+            <a:ext uri="{FF2B5EF4-FFF2-40B4-BE49-F238E27FC236}">
               <a16:creationId xmlns:a16="http://schemas.microsoft.com/office/drawing/2014/main" id="{62B38361-CB1A-356C-FB9D-8009EE0B1ADC}"/>
             </a:ext>
           </a:extLst>
@@ -31561,7 +31980,7 @@
             </a:pPr>
             <a:r>
               <a:rPr lang="en-US" dirty="0"/>
-              <a:t>Make mobile security knowledge more accessible</a:t>
+              <a:t>“Make mobile security knowledge more accessible”</a:t>
             </a:r>
             <a:endParaRPr lang="en-US" noProof="0" dirty="0"/>
           </a:p>
@@ -31694,7 +32113,7 @@
             <a:fld id="{E6639024-6672-4F87-864B-EA4FA9190A1A}" type="slidenum">
               <a:rPr lang="en-US" noProof="0" smtClean="0"/>
               <a:pPr/>
-              <a:t>10</a:t>
+              <a:t>11</a:t>
             </a:fld>
             <a:endParaRPr lang="en-US" noProof="0" dirty="0"/>
           </a:p>
@@ -31713,7 +32132,7 @@
 </p:sld>
 </file>
 
-<file path=ppt/slides/slide11.xml><?xml version="1.0" encoding="utf-8"?>
+<file path=ppt/slides/slide12.xml><?xml version="1.0" encoding="utf-8"?>
 <p:sld xmlns:a="http://schemas.openxmlformats.org/drawingml/2006/main" xmlns:r="http://schemas.openxmlformats.org/officeDocument/2006/relationships" xmlns:p="http://schemas.openxmlformats.org/presentationml/2006/main">
   <p:cSld>
     <p:spTree>
@@ -31801,6 +32220,17 @@
             </a:pPr>
             <a:r>
               <a:rPr lang="en-US" dirty="0"/>
+              <a:t>“Promote the best security testing tools”</a:t>
+            </a:r>
+          </a:p>
+          <a:p>
+            <a:pPr>
+              <a:lnSpc>
+                <a:spcPct val="150000"/>
+              </a:lnSpc>
+            </a:pPr>
+            <a:r>
+              <a:rPr lang="en-US" dirty="0"/>
               <a:t>Tools for vulnerability detection</a:t>
             </a:r>
             <a:endParaRPr lang="en-US" b="1" dirty="0"/>
@@ -31982,7 +32412,7 @@
             <a:fld id="{E6639024-6672-4F87-864B-EA4FA9190A1A}" type="slidenum">
               <a:rPr lang="en-US" noProof="0" smtClean="0"/>
               <a:pPr/>
-              <a:t>11</a:t>
+              <a:t>12</a:t>
             </a:fld>
             <a:endParaRPr lang="en-US" noProof="0" dirty="0"/>
           </a:p>
@@ -32038,7 +32468,7 @@
 </p:sld>
 </file>
 
-<file path=ppt/slides/slide12.xml><?xml version="1.0" encoding="utf-8"?>
+<file path=ppt/slides/slide13.xml><?xml version="1.0" encoding="utf-8"?>
 <p:sld xmlns:a="http://schemas.openxmlformats.org/drawingml/2006/main" xmlns:r="http://schemas.openxmlformats.org/officeDocument/2006/relationships" xmlns:p="http://schemas.openxmlformats.org/presentationml/2006/main">
   <p:cSld>
     <p:spTree>
@@ -32131,36 +32561,39 @@
             </a:r>
           </a:p>
           <a:p>
-            <a:pPr>
+            <a:pPr marL="0" indent="0">
               <a:lnSpc>
                 <a:spcPct val="150000"/>
               </a:lnSpc>
+              <a:buNone/>
             </a:pPr>
             <a:r>
               <a:rPr lang="en-US" noProof="0" dirty="0"/>
-              <a:t>…improve educational value of OWASP MASTG</a:t>
-            </a:r>
-          </a:p>
-          <a:p>
-            <a:pPr>
+              <a:t>	…improve educational value of OWASP MASTG</a:t>
+            </a:r>
+          </a:p>
+          <a:p>
+            <a:pPr marL="0" indent="0">
               <a:lnSpc>
                 <a:spcPct val="150000"/>
               </a:lnSpc>
+              <a:buNone/>
             </a:pPr>
             <a:r>
               <a:rPr lang="en-US" noProof="0" dirty="0"/>
-              <a:t>...create a benchmark for evaluating SAST &amp; DAST tools</a:t>
-            </a:r>
-          </a:p>
-          <a:p>
-            <a:pPr>
+              <a:t>	...create a benchmark for evaluating SAST &amp; DAST tools</a:t>
+            </a:r>
+          </a:p>
+          <a:p>
+            <a:pPr marL="0" indent="0">
               <a:lnSpc>
                 <a:spcPct val="150000"/>
               </a:lnSpc>
+              <a:buNone/>
             </a:pPr>
             <a:r>
               <a:rPr lang="en-US" noProof="0" dirty="0"/>
-              <a:t>…</a:t>
+              <a:t>	…</a:t>
             </a:r>
             <a:r>
               <a:rPr lang="en-US" i="1" noProof="0" dirty="0"/>
@@ -32251,7 +32684,7 @@
             <a:fld id="{E6639024-6672-4F87-864B-EA4FA9190A1A}" type="slidenum">
               <a:rPr lang="en-US" noProof="0" smtClean="0"/>
               <a:pPr/>
-              <a:t>12</a:t>
+              <a:t>13</a:t>
             </a:fld>
             <a:endParaRPr lang="en-US" noProof="0" dirty="0"/>
           </a:p>
@@ -32307,7 +32740,7 @@
 </p:sld>
 </file>
 
-<file path=ppt/slides/slide13.xml><?xml version="1.0" encoding="utf-8"?>
+<file path=ppt/slides/slide14.xml><?xml version="1.0" encoding="utf-8"?>
 <p:sld xmlns:a="http://schemas.openxmlformats.org/drawingml/2006/main" xmlns:r="http://schemas.openxmlformats.org/officeDocument/2006/relationships" xmlns:p="http://schemas.openxmlformats.org/presentationml/2006/main">
   <p:cSld>
     <p:spTree>
@@ -32583,7 +33016,7 @@
             <a:fld id="{E6639024-6672-4F87-864B-EA4FA9190A1A}" type="slidenum">
               <a:rPr lang="en-US" noProof="0" smtClean="0"/>
               <a:pPr/>
-              <a:t>13</a:t>
+              <a:t>14</a:t>
             </a:fld>
             <a:endParaRPr lang="en-US" noProof="0" dirty="0"/>
           </a:p>
@@ -32602,7 +33035,7 @@
 </p:sld>
 </file>
 
-<file path=ppt/slides/slide14.xml><?xml version="1.0" encoding="utf-8"?>
+<file path=ppt/slides/slide15.xml><?xml version="1.0" encoding="utf-8"?>
 <p:sld xmlns:a="http://schemas.openxmlformats.org/drawingml/2006/main" xmlns:r="http://schemas.openxmlformats.org/officeDocument/2006/relationships" xmlns:p="http://schemas.openxmlformats.org/presentationml/2006/main">
   <p:cSld>
     <p:spTree>
@@ -32810,7 +33243,7 @@
             <a:fld id="{E6639024-6672-4F87-864B-EA4FA9190A1A}" type="slidenum">
               <a:rPr lang="en-US" noProof="0" smtClean="0"/>
               <a:pPr/>
-              <a:t>14</a:t>
+              <a:t>15</a:t>
             </a:fld>
             <a:endParaRPr lang="en-US" noProof="0" dirty="0"/>
           </a:p>
@@ -33160,7 +33593,7 @@
 </p:sld>
 </file>
 
-<file path=ppt/slides/slide15.xml><?xml version="1.0" encoding="utf-8"?>
+<file path=ppt/slides/slide16.xml><?xml version="1.0" encoding="utf-8"?>
 <p:sld xmlns:a="http://schemas.openxmlformats.org/drawingml/2006/main" xmlns:r="http://schemas.openxmlformats.org/officeDocument/2006/relationships" xmlns:p="http://schemas.openxmlformats.org/presentationml/2006/main">
   <p:cSld>
     <p:spTree>
@@ -33353,7 +33786,7 @@
             <a:fld id="{E6639024-6672-4F87-864B-EA4FA9190A1A}" type="slidenum">
               <a:rPr lang="en-US" noProof="0" smtClean="0"/>
               <a:pPr/>
-              <a:t>15</a:t>
+              <a:t>16</a:t>
             </a:fld>
             <a:endParaRPr lang="en-US" noProof="0" dirty="0"/>
           </a:p>
@@ -33372,7 +33805,7 @@
 </p:sld>
 </file>
 
-<file path=ppt/slides/slide16.xml><?xml version="1.0" encoding="utf-8"?>
+<file path=ppt/slides/slide17.xml><?xml version="1.0" encoding="utf-8"?>
 <p:sld xmlns:a="http://schemas.openxmlformats.org/drawingml/2006/main" xmlns:r="http://schemas.openxmlformats.org/officeDocument/2006/relationships" xmlns:p="http://schemas.openxmlformats.org/presentationml/2006/main">
   <p:cSld>
     <p:spTree>
@@ -33620,7 +34053,7 @@
             <a:fld id="{E6639024-6672-4F87-864B-EA4FA9190A1A}" type="slidenum">
               <a:rPr lang="en-US" noProof="0" smtClean="0"/>
               <a:pPr/>
-              <a:t>16</a:t>
+              <a:t>17</a:t>
             </a:fld>
             <a:endParaRPr lang="en-US" noProof="0" dirty="0"/>
           </a:p>
@@ -33639,7 +34072,7 @@
 </p:sld>
 </file>
 
-<file path=ppt/slides/slide17.xml><?xml version="1.0" encoding="utf-8"?>
+<file path=ppt/slides/slide18.xml><?xml version="1.0" encoding="utf-8"?>
 <p:sld xmlns:a="http://schemas.openxmlformats.org/drawingml/2006/main" xmlns:r="http://schemas.openxmlformats.org/officeDocument/2006/relationships" xmlns:p="http://schemas.openxmlformats.org/presentationml/2006/main">
   <p:cSld>
     <p:spTree>
@@ -33865,7 +34298,7 @@
             <a:fld id="{E6639024-6672-4F87-864B-EA4FA9190A1A}" type="slidenum">
               <a:rPr lang="en-US" noProof="0" smtClean="0"/>
               <a:pPr/>
-              <a:t>17</a:t>
+              <a:t>18</a:t>
             </a:fld>
             <a:endParaRPr lang="en-US" noProof="0" dirty="0"/>
           </a:p>
@@ -33884,7 +34317,7 @@
 </p:sld>
 </file>
 
-<file path=ppt/slides/slide18.xml><?xml version="1.0" encoding="utf-8"?>
+<file path=ppt/slides/slide19.xml><?xml version="1.0" encoding="utf-8"?>
 <p:sld xmlns:a="http://schemas.openxmlformats.org/drawingml/2006/main" xmlns:r="http://schemas.openxmlformats.org/officeDocument/2006/relationships" xmlns:p="http://schemas.openxmlformats.org/presentationml/2006/main">
   <p:cSld>
     <p:spTree>
@@ -34020,19 +34453,16 @@
               </a:lnSpc>
             </a:pPr>
             <a:r>
+              <a:rPr lang="en-US" dirty="0"/>
+              <a:t>Developing &amp; t</a:t>
+            </a:r>
+            <a:r>
+              <a:rPr lang="en-US" noProof="0" dirty="0" err="1"/>
+              <a:t>esting</a:t>
+            </a:r>
+            <a:r>
               <a:rPr lang="en-US" noProof="0" dirty="0"/>
-              <a:t>Testing tools</a:t>
-            </a:r>
-          </a:p>
-          <a:p>
-            <a:pPr>
-              <a:lnSpc>
-                <a:spcPct val="150000"/>
-              </a:lnSpc>
-            </a:pPr>
-            <a:r>
-              <a:rPr lang="en-US" noProof="0" dirty="0"/>
-              <a:t>Comparing to real-world apps</a:t>
+              <a:t> tools</a:t>
             </a:r>
           </a:p>
         </p:txBody>
@@ -34111,7 +34541,7 @@
             <a:fld id="{E6639024-6672-4F87-864B-EA4FA9190A1A}" type="slidenum">
               <a:rPr lang="en-US" noProof="0" smtClean="0"/>
               <a:pPr/>
-              <a:t>18</a:t>
+              <a:t>19</a:t>
             </a:fld>
             <a:endParaRPr lang="en-US" noProof="0" dirty="0"/>
           </a:p>
@@ -34121,264 +34551,6 @@
     <p:extLst>
       <p:ext uri="{BB962C8B-B14F-4D97-AF65-F5344CB8AC3E}">
         <p14:creationId xmlns:p14="http://schemas.microsoft.com/office/powerpoint/2010/main" val="1307421813"/>
-      </p:ext>
-    </p:extLst>
-  </p:cSld>
-  <p:clrMapOvr>
-    <a:masterClrMapping/>
-  </p:clrMapOvr>
-</p:sld>
-</file>
-
-<file path=ppt/slides/slide19.xml><?xml version="1.0" encoding="utf-8"?>
-<p:sld xmlns:a="http://schemas.openxmlformats.org/drawingml/2006/main" xmlns:r="http://schemas.openxmlformats.org/officeDocument/2006/relationships" xmlns:p="http://schemas.openxmlformats.org/presentationml/2006/main">
-  <p:cSld>
-    <p:spTree>
-      <p:nvGrpSpPr>
-        <p:cNvPr id="1" name="">
-          <a:extLst>
-            <a:ext uri="{FF2B5EF4-FFF2-40B4-BE49-F238E27FC236}">
-              <a16:creationId xmlns:a16="http://schemas.microsoft.com/office/drawing/2014/main" id="{8604C0DE-1380-91C2-0F3C-7B21E37677AE}"/>
-            </a:ext>
-          </a:extLst>
-        </p:cNvPr>
-        <p:cNvGrpSpPr/>
-        <p:nvPr/>
-      </p:nvGrpSpPr>
-      <p:grpSpPr>
-        <a:xfrm>
-          <a:off x="0" y="0"/>
-          <a:ext cx="0" cy="0"/>
-          <a:chOff x="0" y="0"/>
-          <a:chExt cx="0" cy="0"/>
-        </a:xfrm>
-      </p:grpSpPr>
-      <p:sp>
-        <p:nvSpPr>
-          <p:cNvPr id="8" name="Textplatzhalter 7">
-            <a:extLst>
-              <a:ext uri="{FF2B5EF4-FFF2-40B4-BE49-F238E27FC236}">
-                <a16:creationId xmlns:a16="http://schemas.microsoft.com/office/drawing/2014/main" id="{377CF773-BFCA-D3B5-2AF7-7D7335614CB9}"/>
-              </a:ext>
-            </a:extLst>
-          </p:cNvPr>
-          <p:cNvSpPr>
-            <a:spLocks noGrp="1"/>
-          </p:cNvSpPr>
-          <p:nvPr>
-            <p:ph type="body" sz="quarter" idx="12"/>
-          </p:nvPr>
-        </p:nvSpPr>
-        <p:spPr/>
-        <p:txBody>
-          <a:bodyPr/>
-          <a:lstStyle/>
-          <a:p>
-            <a:r>
-              <a:rPr lang="en-US" dirty="0">
-                <a:solidFill>
-                  <a:schemeClr val="bg2"/>
-                </a:solidFill>
-              </a:rPr>
-              <a:t>Findings</a:t>
-            </a:r>
-            <a:endParaRPr lang="en-US" noProof="0" dirty="0">
-              <a:solidFill>
-                <a:schemeClr val="bg2"/>
-              </a:solidFill>
-            </a:endParaRPr>
-          </a:p>
-        </p:txBody>
-      </p:sp>
-      <p:sp>
-        <p:nvSpPr>
-          <p:cNvPr id="7" name="Titel 6">
-            <a:extLst>
-              <a:ext uri="{FF2B5EF4-FFF2-40B4-BE49-F238E27FC236}">
-                <a16:creationId xmlns:a16="http://schemas.microsoft.com/office/drawing/2014/main" id="{9E666D68-0D73-30A0-1CD7-DDA6D8144DF4}"/>
-              </a:ext>
-            </a:extLst>
-          </p:cNvPr>
-          <p:cNvSpPr>
-            <a:spLocks noGrp="1"/>
-          </p:cNvSpPr>
-          <p:nvPr>
-            <p:ph type="title"/>
-          </p:nvPr>
-        </p:nvSpPr>
-        <p:spPr/>
-        <p:txBody>
-          <a:bodyPr/>
-          <a:lstStyle/>
-          <a:p>
-            <a:r>
-              <a:rPr lang="en-US" dirty="0">
-                <a:solidFill>
-                  <a:schemeClr val="tx1"/>
-                </a:solidFill>
-              </a:rPr>
-              <a:t>Connection to Academia</a:t>
-            </a:r>
-          </a:p>
-        </p:txBody>
-      </p:sp>
-      <p:sp>
-        <p:nvSpPr>
-          <p:cNvPr id="10" name="Inhaltsplatzhalter 9">
-            <a:extLst>
-              <a:ext uri="{FF2B5EF4-FFF2-40B4-BE49-F238E27FC236}">
-                <a16:creationId xmlns:a16="http://schemas.microsoft.com/office/drawing/2014/main" id="{624B0D4A-7708-B6EC-F002-7DF590D7D200}"/>
-              </a:ext>
-            </a:extLst>
-          </p:cNvPr>
-          <p:cNvSpPr>
-            <a:spLocks noGrp="1"/>
-          </p:cNvSpPr>
-          <p:nvPr>
-            <p:ph sz="quarter" idx="20"/>
-          </p:nvPr>
-        </p:nvSpPr>
-        <p:spPr>
-          <a:xfrm>
-            <a:off x="359533" y="1203598"/>
-            <a:ext cx="8424467" cy="3332402"/>
-          </a:xfrm>
-        </p:spPr>
-        <p:txBody>
-          <a:bodyPr anchor="t"/>
-          <a:lstStyle/>
-          <a:p>
-            <a:pPr marL="0" indent="0">
-              <a:lnSpc>
-                <a:spcPct val="150000"/>
-              </a:lnSpc>
-              <a:buNone/>
-            </a:pPr>
-            <a:r>
-              <a:rPr lang="en-US" noProof="0" dirty="0"/>
-              <a:t>Take-away points:</a:t>
-            </a:r>
-          </a:p>
-          <a:p>
-            <a:pPr>
-              <a:lnSpc>
-                <a:spcPct val="150000"/>
-              </a:lnSpc>
-            </a:pPr>
-            <a:r>
-              <a:rPr lang="en-US" noProof="0" dirty="0"/>
-              <a:t>Significant use-case for academia</a:t>
-            </a:r>
-          </a:p>
-          <a:p>
-            <a:pPr>
-              <a:lnSpc>
-                <a:spcPct val="150000"/>
-              </a:lnSpc>
-            </a:pPr>
-            <a:r>
-              <a:rPr lang="en-US" noProof="0" dirty="0"/>
-              <a:t>Evaluating real-world apps</a:t>
-            </a:r>
-          </a:p>
-          <a:p>
-            <a:pPr>
-              <a:lnSpc>
-                <a:spcPct val="150000"/>
-              </a:lnSpc>
-            </a:pPr>
-            <a:r>
-              <a:rPr lang="en-US" dirty="0"/>
-              <a:t>Developing &amp; testing tools</a:t>
-            </a:r>
-            <a:endParaRPr lang="en-US" noProof="0" dirty="0"/>
-          </a:p>
-        </p:txBody>
-      </p:sp>
-      <p:sp>
-        <p:nvSpPr>
-          <p:cNvPr id="9" name="Textplatzhalter 8">
-            <a:extLst>
-              <a:ext uri="{FF2B5EF4-FFF2-40B4-BE49-F238E27FC236}">
-                <a16:creationId xmlns:a16="http://schemas.microsoft.com/office/drawing/2014/main" id="{C59DB9BD-6149-4BF0-EE69-27F9C2461397}"/>
-              </a:ext>
-            </a:extLst>
-          </p:cNvPr>
-          <p:cNvSpPr>
-            <a:spLocks noGrp="1"/>
-          </p:cNvSpPr>
-          <p:nvPr>
-            <p:ph type="body" sz="quarter" idx="19"/>
-          </p:nvPr>
-        </p:nvSpPr>
-        <p:spPr/>
-        <p:txBody>
-          <a:bodyPr/>
-          <a:lstStyle/>
-          <a:p>
-            <a:endParaRPr lang="en-US" noProof="0" dirty="0"/>
-          </a:p>
-        </p:txBody>
-      </p:sp>
-      <p:sp>
-        <p:nvSpPr>
-          <p:cNvPr id="11" name="Fußzeilenplatzhalter 10">
-            <a:extLst>
-              <a:ext uri="{FF2B5EF4-FFF2-40B4-BE49-F238E27FC236}">
-                <a16:creationId xmlns:a16="http://schemas.microsoft.com/office/drawing/2014/main" id="{18497FD9-1CA0-DE30-143F-294594CC2E05}"/>
-              </a:ext>
-            </a:extLst>
-          </p:cNvPr>
-          <p:cNvSpPr>
-            <a:spLocks noGrp="1"/>
-          </p:cNvSpPr>
-          <p:nvPr>
-            <p:ph type="ftr" sz="quarter" idx="17"/>
-          </p:nvPr>
-        </p:nvSpPr>
-        <p:spPr/>
-        <p:txBody>
-          <a:bodyPr/>
-          <a:lstStyle/>
-          <a:p>
-            <a:endParaRPr lang="en-US" noProof="0" dirty="0"/>
-          </a:p>
-        </p:txBody>
-      </p:sp>
-      <p:sp>
-        <p:nvSpPr>
-          <p:cNvPr id="12" name="Foliennummernplatzhalter 11">
-            <a:extLst>
-              <a:ext uri="{FF2B5EF4-FFF2-40B4-BE49-F238E27FC236}">
-                <a16:creationId xmlns:a16="http://schemas.microsoft.com/office/drawing/2014/main" id="{0B2259FF-ED81-7380-55AF-A876F69C16FF}"/>
-              </a:ext>
-            </a:extLst>
-          </p:cNvPr>
-          <p:cNvSpPr>
-            <a:spLocks noGrp="1"/>
-          </p:cNvSpPr>
-          <p:nvPr>
-            <p:ph type="sldNum" sz="quarter" idx="18"/>
-          </p:nvPr>
-        </p:nvSpPr>
-        <p:spPr/>
-        <p:txBody>
-          <a:bodyPr/>
-          <a:lstStyle/>
-          <a:p>
-            <a:fld id="{E6639024-6672-4F87-864B-EA4FA9190A1A}" type="slidenum">
-              <a:rPr lang="en-US" noProof="0" smtClean="0"/>
-              <a:pPr/>
-              <a:t>19</a:t>
-            </a:fld>
-            <a:endParaRPr lang="en-US" noProof="0" dirty="0"/>
-          </a:p>
-        </p:txBody>
-      </p:sp>
-    </p:spTree>
-    <p:extLst>
-      <p:ext uri="{BB962C8B-B14F-4D97-AF65-F5344CB8AC3E}">
-        <p14:creationId xmlns:p14="http://schemas.microsoft.com/office/powerpoint/2010/main" val="1260704541"/>
       </p:ext>
     </p:extLst>
   </p:cSld>
@@ -34622,12 +34794,6 @@
         <p:txBody>
           <a:bodyPr/>
           <a:lstStyle/>
-          <a:p>
-            <a:r>
-              <a:rPr lang="en-US" dirty="0"/>
-              <a:t>“Today I will be discussing Android vulnerabilities with you”</a:t>
-            </a:r>
-          </a:p>
           <a:p>
             <a:endParaRPr lang="en-US" noProof="0" dirty="0"/>
           </a:p>
@@ -34720,6 +34886,264 @@
         <p:cNvPr id="1" name="">
           <a:extLst>
             <a:ext uri="{FF2B5EF4-FFF2-40B4-BE49-F238E27FC236}">
+              <a16:creationId xmlns:a16="http://schemas.microsoft.com/office/drawing/2014/main" id="{8604C0DE-1380-91C2-0F3C-7B21E37677AE}"/>
+            </a:ext>
+          </a:extLst>
+        </p:cNvPr>
+        <p:cNvGrpSpPr/>
+        <p:nvPr/>
+      </p:nvGrpSpPr>
+      <p:grpSpPr>
+        <a:xfrm>
+          <a:off x="0" y="0"/>
+          <a:ext cx="0" cy="0"/>
+          <a:chOff x="0" y="0"/>
+          <a:chExt cx="0" cy="0"/>
+        </a:xfrm>
+      </p:grpSpPr>
+      <p:sp>
+        <p:nvSpPr>
+          <p:cNvPr id="8" name="Textplatzhalter 7">
+            <a:extLst>
+              <a:ext uri="{FF2B5EF4-FFF2-40B4-BE49-F238E27FC236}">
+                <a16:creationId xmlns:a16="http://schemas.microsoft.com/office/drawing/2014/main" id="{377CF773-BFCA-D3B5-2AF7-7D7335614CB9}"/>
+              </a:ext>
+            </a:extLst>
+          </p:cNvPr>
+          <p:cNvSpPr>
+            <a:spLocks noGrp="1"/>
+          </p:cNvSpPr>
+          <p:nvPr>
+            <p:ph type="body" sz="quarter" idx="12"/>
+          </p:nvPr>
+        </p:nvSpPr>
+        <p:spPr/>
+        <p:txBody>
+          <a:bodyPr/>
+          <a:lstStyle/>
+          <a:p>
+            <a:r>
+              <a:rPr lang="en-US" dirty="0">
+                <a:solidFill>
+                  <a:schemeClr val="bg2"/>
+                </a:solidFill>
+              </a:rPr>
+              <a:t>Findings</a:t>
+            </a:r>
+            <a:endParaRPr lang="en-US" noProof="0" dirty="0">
+              <a:solidFill>
+                <a:schemeClr val="bg2"/>
+              </a:solidFill>
+            </a:endParaRPr>
+          </a:p>
+        </p:txBody>
+      </p:sp>
+      <p:sp>
+        <p:nvSpPr>
+          <p:cNvPr id="7" name="Titel 6">
+            <a:extLst>
+              <a:ext uri="{FF2B5EF4-FFF2-40B4-BE49-F238E27FC236}">
+                <a16:creationId xmlns:a16="http://schemas.microsoft.com/office/drawing/2014/main" id="{9E666D68-0D73-30A0-1CD7-DDA6D8144DF4}"/>
+              </a:ext>
+            </a:extLst>
+          </p:cNvPr>
+          <p:cNvSpPr>
+            <a:spLocks noGrp="1"/>
+          </p:cNvSpPr>
+          <p:nvPr>
+            <p:ph type="title"/>
+          </p:nvPr>
+        </p:nvSpPr>
+        <p:spPr/>
+        <p:txBody>
+          <a:bodyPr/>
+          <a:lstStyle/>
+          <a:p>
+            <a:r>
+              <a:rPr lang="en-US" dirty="0">
+                <a:solidFill>
+                  <a:schemeClr val="tx1"/>
+                </a:solidFill>
+              </a:rPr>
+              <a:t>Connection to Academia</a:t>
+            </a:r>
+          </a:p>
+        </p:txBody>
+      </p:sp>
+      <p:sp>
+        <p:nvSpPr>
+          <p:cNvPr id="10" name="Inhaltsplatzhalter 9">
+            <a:extLst>
+              <a:ext uri="{FF2B5EF4-FFF2-40B4-BE49-F238E27FC236}">
+                <a16:creationId xmlns:a16="http://schemas.microsoft.com/office/drawing/2014/main" id="{624B0D4A-7708-B6EC-F002-7DF590D7D200}"/>
+              </a:ext>
+            </a:extLst>
+          </p:cNvPr>
+          <p:cNvSpPr>
+            <a:spLocks noGrp="1"/>
+          </p:cNvSpPr>
+          <p:nvPr>
+            <p:ph sz="quarter" idx="20"/>
+          </p:nvPr>
+        </p:nvSpPr>
+        <p:spPr>
+          <a:xfrm>
+            <a:off x="359533" y="1203598"/>
+            <a:ext cx="8424467" cy="3332402"/>
+          </a:xfrm>
+        </p:spPr>
+        <p:txBody>
+          <a:bodyPr anchor="t"/>
+          <a:lstStyle/>
+          <a:p>
+            <a:pPr marL="0" indent="0">
+              <a:lnSpc>
+                <a:spcPct val="150000"/>
+              </a:lnSpc>
+              <a:buNone/>
+            </a:pPr>
+            <a:r>
+              <a:rPr lang="en-US" noProof="0" dirty="0"/>
+              <a:t>Take-away points:</a:t>
+            </a:r>
+          </a:p>
+          <a:p>
+            <a:pPr>
+              <a:lnSpc>
+                <a:spcPct val="150000"/>
+              </a:lnSpc>
+            </a:pPr>
+            <a:r>
+              <a:rPr lang="en-US" noProof="0" dirty="0"/>
+              <a:t>Significant use-case for academia</a:t>
+            </a:r>
+          </a:p>
+          <a:p>
+            <a:pPr>
+              <a:lnSpc>
+                <a:spcPct val="150000"/>
+              </a:lnSpc>
+            </a:pPr>
+            <a:r>
+              <a:rPr lang="en-US" noProof="0" dirty="0"/>
+              <a:t>Evaluating real-world apps</a:t>
+            </a:r>
+          </a:p>
+          <a:p>
+            <a:pPr>
+              <a:lnSpc>
+                <a:spcPct val="150000"/>
+              </a:lnSpc>
+            </a:pPr>
+            <a:r>
+              <a:rPr lang="en-US" dirty="0"/>
+              <a:t>Developing &amp; testing tools</a:t>
+            </a:r>
+            <a:endParaRPr lang="en-US" noProof="0" dirty="0"/>
+          </a:p>
+        </p:txBody>
+      </p:sp>
+      <p:sp>
+        <p:nvSpPr>
+          <p:cNvPr id="9" name="Textplatzhalter 8">
+            <a:extLst>
+              <a:ext uri="{FF2B5EF4-FFF2-40B4-BE49-F238E27FC236}">
+                <a16:creationId xmlns:a16="http://schemas.microsoft.com/office/drawing/2014/main" id="{C59DB9BD-6149-4BF0-EE69-27F9C2461397}"/>
+              </a:ext>
+            </a:extLst>
+          </p:cNvPr>
+          <p:cNvSpPr>
+            <a:spLocks noGrp="1"/>
+          </p:cNvSpPr>
+          <p:nvPr>
+            <p:ph type="body" sz="quarter" idx="19"/>
+          </p:nvPr>
+        </p:nvSpPr>
+        <p:spPr/>
+        <p:txBody>
+          <a:bodyPr/>
+          <a:lstStyle/>
+          <a:p>
+            <a:endParaRPr lang="en-US" noProof="0" dirty="0"/>
+          </a:p>
+        </p:txBody>
+      </p:sp>
+      <p:sp>
+        <p:nvSpPr>
+          <p:cNvPr id="11" name="Fußzeilenplatzhalter 10">
+            <a:extLst>
+              <a:ext uri="{FF2B5EF4-FFF2-40B4-BE49-F238E27FC236}">
+                <a16:creationId xmlns:a16="http://schemas.microsoft.com/office/drawing/2014/main" id="{18497FD9-1CA0-DE30-143F-294594CC2E05}"/>
+              </a:ext>
+            </a:extLst>
+          </p:cNvPr>
+          <p:cNvSpPr>
+            <a:spLocks noGrp="1"/>
+          </p:cNvSpPr>
+          <p:nvPr>
+            <p:ph type="ftr" sz="quarter" idx="17"/>
+          </p:nvPr>
+        </p:nvSpPr>
+        <p:spPr/>
+        <p:txBody>
+          <a:bodyPr/>
+          <a:lstStyle/>
+          <a:p>
+            <a:endParaRPr lang="en-US" noProof="0" dirty="0"/>
+          </a:p>
+        </p:txBody>
+      </p:sp>
+      <p:sp>
+        <p:nvSpPr>
+          <p:cNvPr id="12" name="Foliennummernplatzhalter 11">
+            <a:extLst>
+              <a:ext uri="{FF2B5EF4-FFF2-40B4-BE49-F238E27FC236}">
+                <a16:creationId xmlns:a16="http://schemas.microsoft.com/office/drawing/2014/main" id="{0B2259FF-ED81-7380-55AF-A876F69C16FF}"/>
+              </a:ext>
+            </a:extLst>
+          </p:cNvPr>
+          <p:cNvSpPr>
+            <a:spLocks noGrp="1"/>
+          </p:cNvSpPr>
+          <p:nvPr>
+            <p:ph type="sldNum" sz="quarter" idx="18"/>
+          </p:nvPr>
+        </p:nvSpPr>
+        <p:spPr/>
+        <p:txBody>
+          <a:bodyPr/>
+          <a:lstStyle/>
+          <a:p>
+            <a:fld id="{E6639024-6672-4F87-864B-EA4FA9190A1A}" type="slidenum">
+              <a:rPr lang="en-US" noProof="0" smtClean="0"/>
+              <a:pPr/>
+              <a:t>20</a:t>
+            </a:fld>
+            <a:endParaRPr lang="en-US" noProof="0" dirty="0"/>
+          </a:p>
+        </p:txBody>
+      </p:sp>
+    </p:spTree>
+    <p:extLst>
+      <p:ext uri="{BB962C8B-B14F-4D97-AF65-F5344CB8AC3E}">
+        <p14:creationId xmlns:p14="http://schemas.microsoft.com/office/powerpoint/2010/main" val="1260704541"/>
+      </p:ext>
+    </p:extLst>
+  </p:cSld>
+  <p:clrMapOvr>
+    <a:masterClrMapping/>
+  </p:clrMapOvr>
+</p:sld>
+</file>
+
+<file path=ppt/slides/slide21.xml><?xml version="1.0" encoding="utf-8"?>
+<p:sld xmlns:a="http://schemas.openxmlformats.org/drawingml/2006/main" xmlns:r="http://schemas.openxmlformats.org/officeDocument/2006/relationships" xmlns:p="http://schemas.openxmlformats.org/presentationml/2006/main">
+  <p:cSld>
+    <p:spTree>
+      <p:nvGrpSpPr>
+        <p:cNvPr id="1" name="">
+          <a:extLst>
+            <a:ext uri="{FF2B5EF4-FFF2-40B4-BE49-F238E27FC236}">
               <a16:creationId xmlns:a16="http://schemas.microsoft.com/office/drawing/2014/main" id="{86FB1F7E-92A6-4C6C-183A-68C0BC6EEB49}"/>
             </a:ext>
           </a:extLst>
@@ -34927,7 +35351,7 @@
             <a:fld id="{E6639024-6672-4F87-864B-EA4FA9190A1A}" type="slidenum">
               <a:rPr lang="en-US" noProof="0" smtClean="0"/>
               <a:pPr/>
-              <a:t>20</a:t>
+              <a:t>21</a:t>
             </a:fld>
             <a:endParaRPr lang="en-US" noProof="0" dirty="0"/>
           </a:p>
@@ -34946,7 +35370,7 @@
 </p:sld>
 </file>
 
-<file path=ppt/slides/slide21.xml><?xml version="1.0" encoding="utf-8"?>
+<file path=ppt/slides/slide22.xml><?xml version="1.0" encoding="utf-8"?>
 <p:sld xmlns:a="http://schemas.openxmlformats.org/drawingml/2006/main" xmlns:r="http://schemas.openxmlformats.org/officeDocument/2006/relationships" xmlns:p="http://schemas.openxmlformats.org/presentationml/2006/main">
   <p:cSld>
     <p:spTree>
@@ -35183,7 +35607,7 @@
             <a:fld id="{E6639024-6672-4F87-864B-EA4FA9190A1A}" type="slidenum">
               <a:rPr lang="en-US" noProof="0" smtClean="0"/>
               <a:pPr/>
-              <a:t>21</a:t>
+              <a:t>22</a:t>
             </a:fld>
             <a:endParaRPr lang="en-US" noProof="0" dirty="0"/>
           </a:p>
@@ -35202,7 +35626,7 @@
 </p:sld>
 </file>
 
-<file path=ppt/slides/slide22.xml><?xml version="1.0" encoding="utf-8"?>
+<file path=ppt/slides/slide23.xml><?xml version="1.0" encoding="utf-8"?>
 <p:sld xmlns:a="http://schemas.openxmlformats.org/drawingml/2006/main" xmlns:r="http://schemas.openxmlformats.org/officeDocument/2006/relationships" xmlns:p="http://schemas.openxmlformats.org/presentationml/2006/main">
   <p:cSld>
     <p:spTree>
@@ -35333,7 +35757,7 @@
             </a:pPr>
             <a:r>
               <a:rPr lang="en-US" noProof="0" dirty="0"/>
-              <a:t>Under </a:t>
+              <a:t>Of </a:t>
             </a:r>
             <a:r>
               <a:rPr lang="en-US" b="1" dirty="0"/>
@@ -35357,11 +35781,19 @@
             </a:pPr>
             <a:r>
               <a:rPr lang="en-US" dirty="0"/>
-              <a:t>	…there are </a:t>
+              <a:t>	…</a:t>
             </a:r>
             <a:r>
               <a:rPr lang="en-US" b="1" dirty="0"/>
-              <a:t>18 Android </a:t>
+              <a:t>18</a:t>
+            </a:r>
+            <a:r>
+              <a:rPr lang="en-US" dirty="0"/>
+              <a:t> are</a:t>
+            </a:r>
+            <a:r>
+              <a:rPr lang="en-US" b="1" dirty="0"/>
+              <a:t> Android </a:t>
             </a:r>
             <a:r>
               <a:rPr lang="en-US" dirty="0"/>
@@ -35513,7 +35945,7 @@
             <a:fld id="{E6639024-6672-4F87-864B-EA4FA9190A1A}" type="slidenum">
               <a:rPr lang="en-US" noProof="0" smtClean="0"/>
               <a:pPr/>
-              <a:t>22</a:t>
+              <a:t>23</a:t>
             </a:fld>
             <a:endParaRPr lang="en-US" noProof="0" dirty="0"/>
           </a:p>
@@ -35532,7 +35964,7 @@
 </p:sld>
 </file>
 
-<file path=ppt/slides/slide23.xml><?xml version="1.0" encoding="utf-8"?>
+<file path=ppt/slides/slide24.xml><?xml version="1.0" encoding="utf-8"?>
 <p:sld xmlns:a="http://schemas.openxmlformats.org/drawingml/2006/main" xmlns:r="http://schemas.openxmlformats.org/officeDocument/2006/relationships" xmlns:p="http://schemas.openxmlformats.org/presentationml/2006/main">
   <p:cSld>
     <p:spTree>
@@ -35781,7 +36213,7 @@
             <a:fld id="{E6639024-6672-4F87-864B-EA4FA9190A1A}" type="slidenum">
               <a:rPr lang="en-US" noProof="0" smtClean="0"/>
               <a:pPr/>
-              <a:t>23</a:t>
+              <a:t>24</a:t>
             </a:fld>
             <a:endParaRPr lang="en-US" noProof="0" dirty="0"/>
           </a:p>
@@ -35800,7 +36232,7 @@
 </p:sld>
 </file>
 
-<file path=ppt/slides/slide24.xml><?xml version="1.0" encoding="utf-8"?>
+<file path=ppt/slides/slide25.xml><?xml version="1.0" encoding="utf-8"?>
 <p:sld xmlns:a="http://schemas.openxmlformats.org/drawingml/2006/main" xmlns:r="http://schemas.openxmlformats.org/officeDocument/2006/relationships" xmlns:p="http://schemas.openxmlformats.org/presentationml/2006/main">
   <p:cSld>
     <p:spTree>
@@ -36026,7 +36458,7 @@
             <a:fld id="{E6639024-6672-4F87-864B-EA4FA9190A1A}" type="slidenum">
               <a:rPr lang="en-US" noProof="0" smtClean="0"/>
               <a:pPr/>
-              <a:t>24</a:t>
+              <a:t>25</a:t>
             </a:fld>
             <a:endParaRPr lang="en-US" noProof="0" dirty="0"/>
           </a:p>
@@ -36045,7 +36477,7 @@
 </p:sld>
 </file>
 
-<file path=ppt/slides/slide25.xml><?xml version="1.0" encoding="utf-8"?>
+<file path=ppt/slides/slide26.xml><?xml version="1.0" encoding="utf-8"?>
 <p:sld xmlns:a="http://schemas.openxmlformats.org/drawingml/2006/main" xmlns:r="http://schemas.openxmlformats.org/officeDocument/2006/relationships" xmlns:p="http://schemas.openxmlformats.org/presentationml/2006/main">
   <p:cSld>
     <p:spTree>
@@ -36288,7 +36720,7 @@
             <a:fld id="{E6639024-6672-4F87-864B-EA4FA9190A1A}" type="slidenum">
               <a:rPr lang="en-US" noProof="0" smtClean="0"/>
               <a:pPr/>
-              <a:t>25</a:t>
+              <a:t>26</a:t>
             </a:fld>
             <a:endParaRPr lang="en-US" noProof="0" dirty="0"/>
           </a:p>
@@ -36343,7 +36775,7 @@
 </p:sld>
 </file>
 
-<file path=ppt/slides/slide26.xml><?xml version="1.0" encoding="utf-8"?>
+<file path=ppt/slides/slide27.xml><?xml version="1.0" encoding="utf-8"?>
 <p:sld xmlns:a="http://schemas.openxmlformats.org/drawingml/2006/main" xmlns:r="http://schemas.openxmlformats.org/officeDocument/2006/relationships" xmlns:p="http://schemas.openxmlformats.org/presentationml/2006/main">
   <p:cSld>
     <p:spTree>
@@ -36563,7 +36995,7 @@
             <a:fld id="{E6639024-6672-4F87-864B-EA4FA9190A1A}" type="slidenum">
               <a:rPr lang="en-US" noProof="0" smtClean="0"/>
               <a:pPr/>
-              <a:t>26</a:t>
+              <a:t>27</a:t>
             </a:fld>
             <a:endParaRPr lang="en-US" noProof="0" dirty="0"/>
           </a:p>
@@ -36618,7 +37050,7 @@
 </p:sld>
 </file>
 
-<file path=ppt/slides/slide27.xml><?xml version="1.0" encoding="utf-8"?>
+<file path=ppt/slides/slide28.xml><?xml version="1.0" encoding="utf-8"?>
 <p:sld xmlns:a="http://schemas.openxmlformats.org/drawingml/2006/main" xmlns:r="http://schemas.openxmlformats.org/officeDocument/2006/relationships" xmlns:p="http://schemas.openxmlformats.org/presentationml/2006/main">
   <p:cSld>
     <p:spTree>
@@ -36833,7 +37265,7 @@
             <a:fld id="{E6639024-6672-4F87-864B-EA4FA9190A1A}" type="slidenum">
               <a:rPr lang="en-US" noProof="0" smtClean="0"/>
               <a:pPr/>
-              <a:t>27</a:t>
+              <a:t>28</a:t>
             </a:fld>
             <a:endParaRPr lang="en-US" noProof="0" dirty="0"/>
           </a:p>
@@ -36888,7 +37320,7 @@
 </p:sld>
 </file>
 
-<file path=ppt/slides/slide28.xml><?xml version="1.0" encoding="utf-8"?>
+<file path=ppt/slides/slide29.xml><?xml version="1.0" encoding="utf-8"?>
 <p:sld xmlns:a="http://schemas.openxmlformats.org/drawingml/2006/main" xmlns:r="http://schemas.openxmlformats.org/officeDocument/2006/relationships" xmlns:p="http://schemas.openxmlformats.org/presentationml/2006/main">
   <p:cSld>
     <p:spTree>
@@ -37130,7 +37562,7 @@
             <a:fld id="{E6639024-6672-4F87-864B-EA4FA9190A1A}" type="slidenum">
               <a:rPr lang="en-US" noProof="0" smtClean="0"/>
               <a:pPr/>
-              <a:t>28</a:t>
+              <a:t>29</a:t>
             </a:fld>
             <a:endParaRPr lang="en-US" noProof="0" dirty="0"/>
           </a:p>
@@ -37140,279 +37572,6 @@
     <p:extLst>
       <p:ext uri="{BB962C8B-B14F-4D97-AF65-F5344CB8AC3E}">
         <p14:creationId xmlns:p14="http://schemas.microsoft.com/office/powerpoint/2010/main" val="121004567"/>
-      </p:ext>
-    </p:extLst>
-  </p:cSld>
-  <p:clrMapOvr>
-    <a:masterClrMapping/>
-  </p:clrMapOvr>
-</p:sld>
-</file>
-
-<file path=ppt/slides/slide29.xml><?xml version="1.0" encoding="utf-8"?>
-<p:sld xmlns:a="http://schemas.openxmlformats.org/drawingml/2006/main" xmlns:r="http://schemas.openxmlformats.org/officeDocument/2006/relationships" xmlns:p="http://schemas.openxmlformats.org/presentationml/2006/main">
-  <p:cSld>
-    <p:spTree>
-      <p:nvGrpSpPr>
-        <p:cNvPr id="1" name="">
-          <a:extLst>
-            <a:ext uri="{FF2B5EF4-FFF2-40B4-BE49-F238E27FC236}">
-              <a16:creationId xmlns:a16="http://schemas.microsoft.com/office/drawing/2014/main" id="{DA8C4075-1FC6-D5EE-574B-05F6521F064B}"/>
-            </a:ext>
-          </a:extLst>
-        </p:cNvPr>
-        <p:cNvGrpSpPr/>
-        <p:nvPr/>
-      </p:nvGrpSpPr>
-      <p:grpSpPr>
-        <a:xfrm>
-          <a:off x="0" y="0"/>
-          <a:ext cx="0" cy="0"/>
-          <a:chOff x="0" y="0"/>
-          <a:chExt cx="0" cy="0"/>
-        </a:xfrm>
-      </p:grpSpPr>
-      <p:sp>
-        <p:nvSpPr>
-          <p:cNvPr id="8" name="Textplatzhalter 7">
-            <a:extLst>
-              <a:ext uri="{FF2B5EF4-FFF2-40B4-BE49-F238E27FC236}">
-                <a16:creationId xmlns:a16="http://schemas.microsoft.com/office/drawing/2014/main" id="{442471FA-6B96-2A48-B81B-4A7D45A0B6EE}"/>
-              </a:ext>
-            </a:extLst>
-          </p:cNvPr>
-          <p:cNvSpPr>
-            <a:spLocks noGrp="1"/>
-          </p:cNvSpPr>
-          <p:nvPr>
-            <p:ph type="body" sz="quarter" idx="12"/>
-          </p:nvPr>
-        </p:nvSpPr>
-        <p:spPr/>
-        <p:txBody>
-          <a:bodyPr/>
-          <a:lstStyle/>
-          <a:p>
-            <a:r>
-              <a:rPr lang="en-US" dirty="0">
-                <a:solidFill>
-                  <a:schemeClr val="bg2"/>
-                </a:solidFill>
-              </a:rPr>
-              <a:t>Significance for Our Apps</a:t>
-            </a:r>
-            <a:endParaRPr lang="en-US" noProof="0" dirty="0">
-              <a:solidFill>
-                <a:schemeClr val="bg2"/>
-              </a:solidFill>
-            </a:endParaRPr>
-          </a:p>
-        </p:txBody>
-      </p:sp>
-      <p:sp>
-        <p:nvSpPr>
-          <p:cNvPr id="7" name="Titel 6">
-            <a:extLst>
-              <a:ext uri="{FF2B5EF4-FFF2-40B4-BE49-F238E27FC236}">
-                <a16:creationId xmlns:a16="http://schemas.microsoft.com/office/drawing/2014/main" id="{47DEFD3A-84E7-AA54-1523-4EE85251E9C5}"/>
-              </a:ext>
-            </a:extLst>
-          </p:cNvPr>
-          <p:cNvSpPr>
-            <a:spLocks noGrp="1"/>
-          </p:cNvSpPr>
-          <p:nvPr>
-            <p:ph type="title"/>
-          </p:nvPr>
-        </p:nvSpPr>
-        <p:spPr/>
-        <p:txBody>
-          <a:bodyPr/>
-          <a:lstStyle/>
-          <a:p>
-            <a:r>
-              <a:rPr lang="en-US" dirty="0">
-                <a:solidFill>
-                  <a:schemeClr val="tx1"/>
-                </a:solidFill>
-              </a:rPr>
-              <a:t>State of the Art in MASTG Reference Apps</a:t>
-            </a:r>
-            <a:endParaRPr lang="en-US" noProof="0" dirty="0">
-              <a:solidFill>
-                <a:schemeClr val="tx1"/>
-              </a:solidFill>
-            </a:endParaRPr>
-          </a:p>
-        </p:txBody>
-      </p:sp>
-      <p:sp>
-        <p:nvSpPr>
-          <p:cNvPr id="10" name="Inhaltsplatzhalter 9">
-            <a:extLst>
-              <a:ext uri="{FF2B5EF4-FFF2-40B4-BE49-F238E27FC236}">
-                <a16:creationId xmlns:a16="http://schemas.microsoft.com/office/drawing/2014/main" id="{8F4E58F5-2341-2B40-98FD-A10FF5E37FBA}"/>
-              </a:ext>
-            </a:extLst>
-          </p:cNvPr>
-          <p:cNvSpPr>
-            <a:spLocks noGrp="1"/>
-          </p:cNvSpPr>
-          <p:nvPr>
-            <p:ph sz="quarter" idx="20"/>
-          </p:nvPr>
-        </p:nvSpPr>
-        <p:spPr>
-          <a:xfrm>
-            <a:off x="359533" y="1203598"/>
-            <a:ext cx="8424467" cy="3332402"/>
-          </a:xfrm>
-        </p:spPr>
-        <p:txBody>
-          <a:bodyPr anchor="t"/>
-          <a:lstStyle/>
-          <a:p>
-            <a:pPr>
-              <a:lnSpc>
-                <a:spcPct val="150000"/>
-              </a:lnSpc>
-            </a:pPr>
-            <a:r>
-              <a:rPr lang="en-US" noProof="0" dirty="0"/>
-              <a:t>Completely open-source</a:t>
-            </a:r>
-          </a:p>
-          <a:p>
-            <a:pPr>
-              <a:lnSpc>
-                <a:spcPct val="150000"/>
-              </a:lnSpc>
-            </a:pPr>
-            <a:r>
-              <a:rPr lang="en-US" noProof="0" dirty="0"/>
-              <a:t>Extensive documentation</a:t>
-            </a:r>
-          </a:p>
-          <a:p>
-            <a:pPr>
-              <a:lnSpc>
-                <a:spcPct val="150000"/>
-              </a:lnSpc>
-            </a:pPr>
-            <a:r>
-              <a:rPr lang="en-US" dirty="0"/>
-              <a:t>Vulnerabilities with no coverage</a:t>
-            </a:r>
-            <a:endParaRPr lang="en-US" noProof="0" dirty="0"/>
-          </a:p>
-          <a:p>
-            <a:pPr>
-              <a:lnSpc>
-                <a:spcPct val="150000"/>
-              </a:lnSpc>
-            </a:pPr>
-            <a:r>
-              <a:rPr lang="en-US" noProof="0" dirty="0"/>
-              <a:t>Focus on MASVS-CRYPTO</a:t>
-            </a:r>
-          </a:p>
-          <a:p>
-            <a:pPr>
-              <a:lnSpc>
-                <a:spcPct val="150000"/>
-              </a:lnSpc>
-            </a:pPr>
-            <a:r>
-              <a:rPr lang="en-US" noProof="0" dirty="0"/>
-              <a:t>Start with MASVS-STORAGE</a:t>
-            </a:r>
-          </a:p>
-        </p:txBody>
-      </p:sp>
-      <p:sp>
-        <p:nvSpPr>
-          <p:cNvPr id="9" name="Textplatzhalter 8">
-            <a:extLst>
-              <a:ext uri="{FF2B5EF4-FFF2-40B4-BE49-F238E27FC236}">
-                <a16:creationId xmlns:a16="http://schemas.microsoft.com/office/drawing/2014/main" id="{314A3998-2A48-183B-C336-6441A00DCCF4}"/>
-              </a:ext>
-            </a:extLst>
-          </p:cNvPr>
-          <p:cNvSpPr>
-            <a:spLocks noGrp="1"/>
-          </p:cNvSpPr>
-          <p:nvPr>
-            <p:ph type="body" sz="quarter" idx="19"/>
-          </p:nvPr>
-        </p:nvSpPr>
-        <p:spPr/>
-        <p:txBody>
-          <a:bodyPr/>
-          <a:lstStyle/>
-          <a:p>
-            <a:endParaRPr lang="en-US" noProof="0" dirty="0"/>
-          </a:p>
-        </p:txBody>
-      </p:sp>
-      <p:sp>
-        <p:nvSpPr>
-          <p:cNvPr id="11" name="Fußzeilenplatzhalter 10">
-            <a:extLst>
-              <a:ext uri="{FF2B5EF4-FFF2-40B4-BE49-F238E27FC236}">
-                <a16:creationId xmlns:a16="http://schemas.microsoft.com/office/drawing/2014/main" id="{5D2F4C98-D62D-01FF-2D8E-71E2DE1EAD76}"/>
-              </a:ext>
-            </a:extLst>
-          </p:cNvPr>
-          <p:cNvSpPr>
-            <a:spLocks noGrp="1"/>
-          </p:cNvSpPr>
-          <p:nvPr>
-            <p:ph type="ftr" sz="quarter" idx="17"/>
-          </p:nvPr>
-        </p:nvSpPr>
-        <p:spPr/>
-        <p:txBody>
-          <a:bodyPr/>
-          <a:lstStyle/>
-          <a:p>
-            <a:endParaRPr lang="en-US" noProof="0" dirty="0"/>
-          </a:p>
-        </p:txBody>
-      </p:sp>
-      <p:sp>
-        <p:nvSpPr>
-          <p:cNvPr id="12" name="Foliennummernplatzhalter 11">
-            <a:extLst>
-              <a:ext uri="{FF2B5EF4-FFF2-40B4-BE49-F238E27FC236}">
-                <a16:creationId xmlns:a16="http://schemas.microsoft.com/office/drawing/2014/main" id="{FB0042D3-BCD3-7C80-60EC-0EDF161535CF}"/>
-              </a:ext>
-            </a:extLst>
-          </p:cNvPr>
-          <p:cNvSpPr>
-            <a:spLocks noGrp="1"/>
-          </p:cNvSpPr>
-          <p:nvPr>
-            <p:ph type="sldNum" sz="quarter" idx="18"/>
-          </p:nvPr>
-        </p:nvSpPr>
-        <p:spPr/>
-        <p:txBody>
-          <a:bodyPr/>
-          <a:lstStyle/>
-          <a:p>
-            <a:fld id="{E6639024-6672-4F87-864B-EA4FA9190A1A}" type="slidenum">
-              <a:rPr lang="en-US" noProof="0" smtClean="0"/>
-              <a:pPr/>
-              <a:t>29</a:t>
-            </a:fld>
-            <a:endParaRPr lang="en-US" noProof="0" dirty="0"/>
-          </a:p>
-        </p:txBody>
-      </p:sp>
-    </p:spTree>
-    <p:extLst>
-      <p:ext uri="{BB962C8B-B14F-4D97-AF65-F5344CB8AC3E}">
-        <p14:creationId xmlns:p14="http://schemas.microsoft.com/office/powerpoint/2010/main" val="1238817749"/>
       </p:ext>
     </p:extLst>
   </p:cSld>
@@ -37542,7 +37701,9 @@
           </a:xfrm>
         </p:spPr>
         <p:txBody>
-          <a:bodyPr anchor="t"/>
+          <a:bodyPr anchor="t">
+            <a:normAutofit/>
+          </a:bodyPr>
           <a:lstStyle/>
           <a:p>
             <a:pPr marL="0" indent="0">
@@ -37570,12 +37731,10 @@
               <a:lnSpc>
                 <a:spcPct val="150000"/>
               </a:lnSpc>
-              <a:buFont typeface="Wingdings" panose="05000000000000000000" pitchFamily="2" charset="2"/>
-              <a:buChar char="§"/>
             </a:pPr>
             <a:r>
               <a:rPr lang="en-US" dirty="0"/>
-              <a:t> Around 5?</a:t>
+              <a:t>Around 5?</a:t>
             </a:r>
           </a:p>
           <a:p>
@@ -37583,8 +37742,6 @@
               <a:lnSpc>
                 <a:spcPct val="150000"/>
               </a:lnSpc>
-              <a:buFont typeface="Wingdings" panose="05000000000000000000" pitchFamily="2" charset="2"/>
-              <a:buChar char="§"/>
             </a:pPr>
             <a:r>
               <a:rPr lang="en-US" dirty="0"/>
@@ -37596,21 +37753,11 @@
               <a:lnSpc>
                 <a:spcPct val="150000"/>
               </a:lnSpc>
-              <a:buFont typeface="Wingdings" panose="05000000000000000000" pitchFamily="2" charset="2"/>
-              <a:buChar char="§"/>
             </a:pPr>
             <a:r>
               <a:rPr lang="en-US" dirty="0"/>
               <a:t>More than 30?</a:t>
             </a:r>
-          </a:p>
-          <a:p>
-            <a:pPr marL="0" indent="0">
-              <a:lnSpc>
-                <a:spcPct val="150000"/>
-              </a:lnSpc>
-              <a:buNone/>
-            </a:pPr>
             <a:endParaRPr lang="en-US" i="1" noProof="0" dirty="0"/>
           </a:p>
           <a:p>
@@ -37725,6 +37872,279 @@
 </file>
 
 <file path=ppt/slides/slide30.xml><?xml version="1.0" encoding="utf-8"?>
+<p:sld xmlns:a="http://schemas.openxmlformats.org/drawingml/2006/main" xmlns:r="http://schemas.openxmlformats.org/officeDocument/2006/relationships" xmlns:p="http://schemas.openxmlformats.org/presentationml/2006/main">
+  <p:cSld>
+    <p:spTree>
+      <p:nvGrpSpPr>
+        <p:cNvPr id="1" name="">
+          <a:extLst>
+            <a:ext uri="{FF2B5EF4-FFF2-40B4-BE49-F238E27FC236}">
+              <a16:creationId xmlns:a16="http://schemas.microsoft.com/office/drawing/2014/main" id="{DA8C4075-1FC6-D5EE-574B-05F6521F064B}"/>
+            </a:ext>
+          </a:extLst>
+        </p:cNvPr>
+        <p:cNvGrpSpPr/>
+        <p:nvPr/>
+      </p:nvGrpSpPr>
+      <p:grpSpPr>
+        <a:xfrm>
+          <a:off x="0" y="0"/>
+          <a:ext cx="0" cy="0"/>
+          <a:chOff x="0" y="0"/>
+          <a:chExt cx="0" cy="0"/>
+        </a:xfrm>
+      </p:grpSpPr>
+      <p:sp>
+        <p:nvSpPr>
+          <p:cNvPr id="8" name="Textplatzhalter 7">
+            <a:extLst>
+              <a:ext uri="{FF2B5EF4-FFF2-40B4-BE49-F238E27FC236}">
+                <a16:creationId xmlns:a16="http://schemas.microsoft.com/office/drawing/2014/main" id="{442471FA-6B96-2A48-B81B-4A7D45A0B6EE}"/>
+              </a:ext>
+            </a:extLst>
+          </p:cNvPr>
+          <p:cNvSpPr>
+            <a:spLocks noGrp="1"/>
+          </p:cNvSpPr>
+          <p:nvPr>
+            <p:ph type="body" sz="quarter" idx="12"/>
+          </p:nvPr>
+        </p:nvSpPr>
+        <p:spPr/>
+        <p:txBody>
+          <a:bodyPr/>
+          <a:lstStyle/>
+          <a:p>
+            <a:r>
+              <a:rPr lang="en-US" dirty="0">
+                <a:solidFill>
+                  <a:schemeClr val="bg2"/>
+                </a:solidFill>
+              </a:rPr>
+              <a:t>Significance for Our Apps</a:t>
+            </a:r>
+            <a:endParaRPr lang="en-US" noProof="0" dirty="0">
+              <a:solidFill>
+                <a:schemeClr val="bg2"/>
+              </a:solidFill>
+            </a:endParaRPr>
+          </a:p>
+        </p:txBody>
+      </p:sp>
+      <p:sp>
+        <p:nvSpPr>
+          <p:cNvPr id="7" name="Titel 6">
+            <a:extLst>
+              <a:ext uri="{FF2B5EF4-FFF2-40B4-BE49-F238E27FC236}">
+                <a16:creationId xmlns:a16="http://schemas.microsoft.com/office/drawing/2014/main" id="{47DEFD3A-84E7-AA54-1523-4EE85251E9C5}"/>
+              </a:ext>
+            </a:extLst>
+          </p:cNvPr>
+          <p:cNvSpPr>
+            <a:spLocks noGrp="1"/>
+          </p:cNvSpPr>
+          <p:nvPr>
+            <p:ph type="title"/>
+          </p:nvPr>
+        </p:nvSpPr>
+        <p:spPr/>
+        <p:txBody>
+          <a:bodyPr/>
+          <a:lstStyle/>
+          <a:p>
+            <a:r>
+              <a:rPr lang="en-US" dirty="0">
+                <a:solidFill>
+                  <a:schemeClr val="tx1"/>
+                </a:solidFill>
+              </a:rPr>
+              <a:t>State of the Art in MASTG Reference Apps</a:t>
+            </a:r>
+            <a:endParaRPr lang="en-US" noProof="0" dirty="0">
+              <a:solidFill>
+                <a:schemeClr val="tx1"/>
+              </a:solidFill>
+            </a:endParaRPr>
+          </a:p>
+        </p:txBody>
+      </p:sp>
+      <p:sp>
+        <p:nvSpPr>
+          <p:cNvPr id="10" name="Inhaltsplatzhalter 9">
+            <a:extLst>
+              <a:ext uri="{FF2B5EF4-FFF2-40B4-BE49-F238E27FC236}">
+                <a16:creationId xmlns:a16="http://schemas.microsoft.com/office/drawing/2014/main" id="{8F4E58F5-2341-2B40-98FD-A10FF5E37FBA}"/>
+              </a:ext>
+            </a:extLst>
+          </p:cNvPr>
+          <p:cNvSpPr>
+            <a:spLocks noGrp="1"/>
+          </p:cNvSpPr>
+          <p:nvPr>
+            <p:ph sz="quarter" idx="20"/>
+          </p:nvPr>
+        </p:nvSpPr>
+        <p:spPr>
+          <a:xfrm>
+            <a:off x="359533" y="1203598"/>
+            <a:ext cx="8424467" cy="3332402"/>
+          </a:xfrm>
+        </p:spPr>
+        <p:txBody>
+          <a:bodyPr anchor="t"/>
+          <a:lstStyle/>
+          <a:p>
+            <a:pPr>
+              <a:lnSpc>
+                <a:spcPct val="150000"/>
+              </a:lnSpc>
+            </a:pPr>
+            <a:r>
+              <a:rPr lang="en-US" noProof="0" dirty="0"/>
+              <a:t>Completely open-source</a:t>
+            </a:r>
+          </a:p>
+          <a:p>
+            <a:pPr>
+              <a:lnSpc>
+                <a:spcPct val="150000"/>
+              </a:lnSpc>
+            </a:pPr>
+            <a:r>
+              <a:rPr lang="en-US" noProof="0" dirty="0"/>
+              <a:t>Extensive documentation</a:t>
+            </a:r>
+          </a:p>
+          <a:p>
+            <a:pPr>
+              <a:lnSpc>
+                <a:spcPct val="150000"/>
+              </a:lnSpc>
+            </a:pPr>
+            <a:r>
+              <a:rPr lang="en-US" dirty="0"/>
+              <a:t>Vulnerabilities with no coverage</a:t>
+            </a:r>
+            <a:endParaRPr lang="en-US" noProof="0" dirty="0"/>
+          </a:p>
+          <a:p>
+            <a:pPr>
+              <a:lnSpc>
+                <a:spcPct val="150000"/>
+              </a:lnSpc>
+            </a:pPr>
+            <a:r>
+              <a:rPr lang="en-US" noProof="0" dirty="0"/>
+              <a:t>Focus on MASVS-CRYPTO</a:t>
+            </a:r>
+          </a:p>
+          <a:p>
+            <a:pPr>
+              <a:lnSpc>
+                <a:spcPct val="150000"/>
+              </a:lnSpc>
+            </a:pPr>
+            <a:r>
+              <a:rPr lang="en-US" noProof="0" dirty="0"/>
+              <a:t>Start with MASVS-STORAGE</a:t>
+            </a:r>
+          </a:p>
+        </p:txBody>
+      </p:sp>
+      <p:sp>
+        <p:nvSpPr>
+          <p:cNvPr id="9" name="Textplatzhalter 8">
+            <a:extLst>
+              <a:ext uri="{FF2B5EF4-FFF2-40B4-BE49-F238E27FC236}">
+                <a16:creationId xmlns:a16="http://schemas.microsoft.com/office/drawing/2014/main" id="{314A3998-2A48-183B-C336-6441A00DCCF4}"/>
+              </a:ext>
+            </a:extLst>
+          </p:cNvPr>
+          <p:cNvSpPr>
+            <a:spLocks noGrp="1"/>
+          </p:cNvSpPr>
+          <p:nvPr>
+            <p:ph type="body" sz="quarter" idx="19"/>
+          </p:nvPr>
+        </p:nvSpPr>
+        <p:spPr/>
+        <p:txBody>
+          <a:bodyPr/>
+          <a:lstStyle/>
+          <a:p>
+            <a:endParaRPr lang="en-US" noProof="0" dirty="0"/>
+          </a:p>
+        </p:txBody>
+      </p:sp>
+      <p:sp>
+        <p:nvSpPr>
+          <p:cNvPr id="11" name="Fußzeilenplatzhalter 10">
+            <a:extLst>
+              <a:ext uri="{FF2B5EF4-FFF2-40B4-BE49-F238E27FC236}">
+                <a16:creationId xmlns:a16="http://schemas.microsoft.com/office/drawing/2014/main" id="{5D2F4C98-D62D-01FF-2D8E-71E2DE1EAD76}"/>
+              </a:ext>
+            </a:extLst>
+          </p:cNvPr>
+          <p:cNvSpPr>
+            <a:spLocks noGrp="1"/>
+          </p:cNvSpPr>
+          <p:nvPr>
+            <p:ph type="ftr" sz="quarter" idx="17"/>
+          </p:nvPr>
+        </p:nvSpPr>
+        <p:spPr/>
+        <p:txBody>
+          <a:bodyPr/>
+          <a:lstStyle/>
+          <a:p>
+            <a:endParaRPr lang="en-US" noProof="0" dirty="0"/>
+          </a:p>
+        </p:txBody>
+      </p:sp>
+      <p:sp>
+        <p:nvSpPr>
+          <p:cNvPr id="12" name="Foliennummernplatzhalter 11">
+            <a:extLst>
+              <a:ext uri="{FF2B5EF4-FFF2-40B4-BE49-F238E27FC236}">
+                <a16:creationId xmlns:a16="http://schemas.microsoft.com/office/drawing/2014/main" id="{FB0042D3-BCD3-7C80-60EC-0EDF161535CF}"/>
+              </a:ext>
+            </a:extLst>
+          </p:cNvPr>
+          <p:cNvSpPr>
+            <a:spLocks noGrp="1"/>
+          </p:cNvSpPr>
+          <p:nvPr>
+            <p:ph type="sldNum" sz="quarter" idx="18"/>
+          </p:nvPr>
+        </p:nvSpPr>
+        <p:spPr/>
+        <p:txBody>
+          <a:bodyPr/>
+          <a:lstStyle/>
+          <a:p>
+            <a:fld id="{E6639024-6672-4F87-864B-EA4FA9190A1A}" type="slidenum">
+              <a:rPr lang="en-US" noProof="0" smtClean="0"/>
+              <a:pPr/>
+              <a:t>30</a:t>
+            </a:fld>
+            <a:endParaRPr lang="en-US" noProof="0" dirty="0"/>
+          </a:p>
+        </p:txBody>
+      </p:sp>
+    </p:spTree>
+    <p:extLst>
+      <p:ext uri="{BB962C8B-B14F-4D97-AF65-F5344CB8AC3E}">
+        <p14:creationId xmlns:p14="http://schemas.microsoft.com/office/powerpoint/2010/main" val="1238817749"/>
+      </p:ext>
+    </p:extLst>
+  </p:cSld>
+  <p:clrMapOvr>
+    <a:masterClrMapping/>
+  </p:clrMapOvr>
+</p:sld>
+</file>
+
+<file path=ppt/slides/slide31.xml><?xml version="1.0" encoding="utf-8"?>
 <p:sld xmlns:a="http://schemas.openxmlformats.org/drawingml/2006/main" xmlns:r="http://schemas.openxmlformats.org/officeDocument/2006/relationships" xmlns:p="http://schemas.openxmlformats.org/presentationml/2006/main">
   <p:cSld>
     <p:spTree>
@@ -37925,7 +38345,7 @@
             <a:fld id="{E6639024-6672-4F87-864B-EA4FA9190A1A}" type="slidenum">
               <a:rPr lang="en-US" noProof="0" smtClean="0"/>
               <a:pPr/>
-              <a:t>30</a:t>
+              <a:t>31</a:t>
             </a:fld>
             <a:endParaRPr lang="en-US" noProof="0" dirty="0"/>
           </a:p>
@@ -38155,15 +38575,11 @@
             </a:pPr>
             <a:r>
               <a:rPr lang="en-US" noProof="0" dirty="0"/>
-              <a:t>Shared resources in “</a:t>
-            </a:r>
-            <a:r>
-              <a:rPr lang="en-US" b="1" noProof="0" dirty="0"/>
-              <a:t>common</a:t>
-            </a:r>
-            <a:r>
-              <a:rPr lang="en-US" noProof="0" dirty="0"/>
-              <a:t>”</a:t>
+              <a:t>Shared resources in </a:t>
+            </a:r>
+            <a:r>
+              <a:rPr lang="en-US" i="1" noProof="0" dirty="0"/>
+              <a:t>“common”</a:t>
             </a:r>
           </a:p>
         </p:txBody>
@@ -38181,7 +38597,7 @@
 </p:sld>
 </file>
 
-<file path=ppt/slides/slide31.xml><?xml version="1.0" encoding="utf-8"?>
+<file path=ppt/slides/slide32.xml><?xml version="1.0" encoding="utf-8"?>
 <p:sld xmlns:a="http://schemas.openxmlformats.org/drawingml/2006/main" xmlns:r="http://schemas.openxmlformats.org/officeDocument/2006/relationships" xmlns:p="http://schemas.openxmlformats.org/presentationml/2006/main">
   <p:cSld>
     <p:spTree>
@@ -38387,7 +38803,7 @@
             <a:fld id="{E6639024-6672-4F87-864B-EA4FA9190A1A}" type="slidenum">
               <a:rPr lang="en-US" noProof="0" smtClean="0"/>
               <a:pPr/>
-              <a:t>31</a:t>
+              <a:t>32</a:t>
             </a:fld>
             <a:endParaRPr lang="en-US" noProof="0" dirty="0"/>
           </a:p>
@@ -38632,28 +39048,6 @@
               <a:t>Isolated app development &amp; testing</a:t>
             </a:r>
             <a:endParaRPr lang="en-US" noProof="0" dirty="0"/>
-          </a:p>
-          <a:p>
-            <a:pPr>
-              <a:lnSpc>
-                <a:spcPct val="150000"/>
-              </a:lnSpc>
-            </a:pPr>
-            <a:r>
-              <a:rPr lang="en-US" noProof="0" dirty="0"/>
-              <a:t>Limit boilerplate code</a:t>
-            </a:r>
-          </a:p>
-          <a:p>
-            <a:pPr>
-              <a:lnSpc>
-                <a:spcPct val="150000"/>
-              </a:lnSpc>
-            </a:pPr>
-            <a:r>
-              <a:rPr lang="en-US" noProof="0" dirty="0"/>
-              <a:t>Limit scaling costs</a:t>
-            </a:r>
           </a:p>
         </p:txBody>
       </p:sp>
@@ -38670,7 +39064,474 @@
 </p:sld>
 </file>
 
-<file path=ppt/slides/slide32.xml><?xml version="1.0" encoding="utf-8"?>
+<file path=ppt/slides/slide33.xml><?xml version="1.0" encoding="utf-8"?>
+<p:sld xmlns:a="http://schemas.openxmlformats.org/drawingml/2006/main" xmlns:r="http://schemas.openxmlformats.org/officeDocument/2006/relationships" xmlns:p="http://schemas.openxmlformats.org/presentationml/2006/main">
+  <p:cSld>
+    <p:spTree>
+      <p:nvGrpSpPr>
+        <p:cNvPr id="1" name="">
+          <a:extLst>
+            <a:ext uri="{FF2B5EF4-FFF2-40B4-BE49-F238E27FC236}">
+              <a16:creationId xmlns:a16="http://schemas.microsoft.com/office/drawing/2014/main" id="{FF989D5D-7C50-7DD7-0E58-AA269A14891B}"/>
+            </a:ext>
+          </a:extLst>
+        </p:cNvPr>
+        <p:cNvGrpSpPr/>
+        <p:nvPr/>
+      </p:nvGrpSpPr>
+      <p:grpSpPr>
+        <a:xfrm>
+          <a:off x="0" y="0"/>
+          <a:ext cx="0" cy="0"/>
+          <a:chOff x="0" y="0"/>
+          <a:chExt cx="0" cy="0"/>
+        </a:xfrm>
+      </p:grpSpPr>
+      <p:sp>
+        <p:nvSpPr>
+          <p:cNvPr id="8" name="Textplatzhalter 7">
+            <a:extLst>
+              <a:ext uri="{FF2B5EF4-FFF2-40B4-BE49-F238E27FC236}">
+                <a16:creationId xmlns:a16="http://schemas.microsoft.com/office/drawing/2014/main" id="{99D46B93-44EB-F98A-8F8B-CEA5670D2A9B}"/>
+              </a:ext>
+            </a:extLst>
+          </p:cNvPr>
+          <p:cNvSpPr>
+            <a:spLocks noGrp="1"/>
+          </p:cNvSpPr>
+          <p:nvPr>
+            <p:ph type="body" sz="quarter" idx="12"/>
+          </p:nvPr>
+        </p:nvSpPr>
+        <p:spPr/>
+        <p:txBody>
+          <a:bodyPr/>
+          <a:lstStyle/>
+          <a:p>
+            <a:r>
+              <a:rPr lang="en-US" dirty="0">
+                <a:solidFill>
+                  <a:schemeClr val="bg2"/>
+                </a:solidFill>
+              </a:rPr>
+              <a:t>Modular Architecture</a:t>
+            </a:r>
+            <a:endParaRPr lang="en-US" noProof="0" dirty="0">
+              <a:solidFill>
+                <a:schemeClr val="bg2"/>
+              </a:solidFill>
+            </a:endParaRPr>
+          </a:p>
+        </p:txBody>
+      </p:sp>
+      <p:sp>
+        <p:nvSpPr>
+          <p:cNvPr id="7" name="Titel 6">
+            <a:extLst>
+              <a:ext uri="{FF2B5EF4-FFF2-40B4-BE49-F238E27FC236}">
+                <a16:creationId xmlns:a16="http://schemas.microsoft.com/office/drawing/2014/main" id="{7DBE7BA0-D45D-FBBA-21A4-49E91B1F331D}"/>
+              </a:ext>
+            </a:extLst>
+          </p:cNvPr>
+          <p:cNvSpPr>
+            <a:spLocks noGrp="1"/>
+          </p:cNvSpPr>
+          <p:nvPr>
+            <p:ph type="title"/>
+          </p:nvPr>
+        </p:nvSpPr>
+        <p:spPr/>
+        <p:txBody>
+          <a:bodyPr/>
+          <a:lstStyle/>
+          <a:p>
+            <a:r>
+              <a:rPr lang="en-US" dirty="0">
+                <a:solidFill>
+                  <a:schemeClr val="tx1"/>
+                </a:solidFill>
+              </a:rPr>
+              <a:t>Designing Our Apps</a:t>
+            </a:r>
+            <a:endParaRPr lang="en-US" noProof="0" dirty="0">
+              <a:solidFill>
+                <a:schemeClr val="tx1"/>
+              </a:solidFill>
+            </a:endParaRPr>
+          </a:p>
+        </p:txBody>
+      </p:sp>
+      <p:pic>
+        <p:nvPicPr>
+          <p:cNvPr id="3" name="Inhaltsplatzhalter 2" descr="Ein Bild, das Text, Screenshot, Diagramm, Rechteck enthält.&#10;&#10;KI-generierte Inhalte können fehlerhaft sein.">
+            <a:extLst>
+              <a:ext uri="{FF2B5EF4-FFF2-40B4-BE49-F238E27FC236}">
+                <a16:creationId xmlns:a16="http://schemas.microsoft.com/office/drawing/2014/main" id="{CABCB5CD-383C-0E3B-8F40-BCF7A38E6C9C}"/>
+              </a:ext>
+            </a:extLst>
+          </p:cNvPr>
+          <p:cNvPicPr>
+            <a:picLocks noGrp="1" noChangeAspect="1"/>
+          </p:cNvPicPr>
+          <p:nvPr>
+            <p:ph sz="quarter" idx="20"/>
+          </p:nvPr>
+        </p:nvPicPr>
+        <p:blipFill>
+          <a:blip r:embed="rId2">
+            <a:extLst>
+              <a:ext uri="{28A0092B-C50C-407E-A947-70E740481C1C}">
+                <a14:useLocalDpi xmlns:a14="http://schemas.microsoft.com/office/drawing/2010/main" val="0"/>
+              </a:ext>
+            </a:extLst>
+          </a:blip>
+          <a:stretch>
+            <a:fillRect/>
+          </a:stretch>
+        </p:blipFill>
+        <p:spPr>
+          <a:xfrm>
+            <a:off x="4266048" y="2159724"/>
+            <a:ext cx="4517952" cy="2335776"/>
+          </a:xfrm>
+        </p:spPr>
+      </p:pic>
+      <p:sp>
+        <p:nvSpPr>
+          <p:cNvPr id="9" name="Textplatzhalter 8">
+            <a:extLst>
+              <a:ext uri="{FF2B5EF4-FFF2-40B4-BE49-F238E27FC236}">
+                <a16:creationId xmlns:a16="http://schemas.microsoft.com/office/drawing/2014/main" id="{6B355760-0C9C-DBC5-A4BE-6B8E3A839EFB}"/>
+              </a:ext>
+            </a:extLst>
+          </p:cNvPr>
+          <p:cNvSpPr>
+            <a:spLocks noGrp="1"/>
+          </p:cNvSpPr>
+          <p:nvPr>
+            <p:ph type="body" sz="quarter" idx="19"/>
+          </p:nvPr>
+        </p:nvSpPr>
+        <p:spPr/>
+        <p:txBody>
+          <a:bodyPr/>
+          <a:lstStyle/>
+          <a:p>
+            <a:endParaRPr lang="en-US" noProof="0" dirty="0"/>
+          </a:p>
+        </p:txBody>
+      </p:sp>
+      <p:sp>
+        <p:nvSpPr>
+          <p:cNvPr id="11" name="Fußzeilenplatzhalter 10">
+            <a:extLst>
+              <a:ext uri="{FF2B5EF4-FFF2-40B4-BE49-F238E27FC236}">
+                <a16:creationId xmlns:a16="http://schemas.microsoft.com/office/drawing/2014/main" id="{B498A413-8350-5BED-6445-BE3352539FB1}"/>
+              </a:ext>
+            </a:extLst>
+          </p:cNvPr>
+          <p:cNvSpPr>
+            <a:spLocks noGrp="1"/>
+          </p:cNvSpPr>
+          <p:nvPr>
+            <p:ph type="ftr" sz="quarter" idx="17"/>
+          </p:nvPr>
+        </p:nvSpPr>
+        <p:spPr/>
+        <p:txBody>
+          <a:bodyPr/>
+          <a:lstStyle/>
+          <a:p>
+            <a:endParaRPr lang="en-US" noProof="0" dirty="0"/>
+          </a:p>
+        </p:txBody>
+      </p:sp>
+      <p:sp>
+        <p:nvSpPr>
+          <p:cNvPr id="12" name="Foliennummernplatzhalter 11">
+            <a:extLst>
+              <a:ext uri="{FF2B5EF4-FFF2-40B4-BE49-F238E27FC236}">
+                <a16:creationId xmlns:a16="http://schemas.microsoft.com/office/drawing/2014/main" id="{3D374115-A8F2-BC49-6137-972351B0A6C5}"/>
+              </a:ext>
+            </a:extLst>
+          </p:cNvPr>
+          <p:cNvSpPr>
+            <a:spLocks noGrp="1"/>
+          </p:cNvSpPr>
+          <p:nvPr>
+            <p:ph type="sldNum" sz="quarter" idx="18"/>
+          </p:nvPr>
+        </p:nvSpPr>
+        <p:spPr/>
+        <p:txBody>
+          <a:bodyPr/>
+          <a:lstStyle/>
+          <a:p>
+            <a:fld id="{E6639024-6672-4F87-864B-EA4FA9190A1A}" type="slidenum">
+              <a:rPr lang="en-US" noProof="0" smtClean="0"/>
+              <a:pPr/>
+              <a:t>33</a:t>
+            </a:fld>
+            <a:endParaRPr lang="en-US" noProof="0" dirty="0"/>
+          </a:p>
+        </p:txBody>
+      </p:sp>
+      <p:sp>
+        <p:nvSpPr>
+          <p:cNvPr id="4" name="Inhaltsplatzhalter 9">
+            <a:extLst>
+              <a:ext uri="{FF2B5EF4-FFF2-40B4-BE49-F238E27FC236}">
+                <a16:creationId xmlns:a16="http://schemas.microsoft.com/office/drawing/2014/main" id="{2EF8BEFF-3F05-B0FB-5FC0-B040C601E419}"/>
+              </a:ext>
+            </a:extLst>
+          </p:cNvPr>
+          <p:cNvSpPr txBox="1">
+            <a:spLocks/>
+          </p:cNvSpPr>
+          <p:nvPr/>
+        </p:nvSpPr>
+        <p:spPr>
+          <a:xfrm>
+            <a:off x="359533" y="1203598"/>
+            <a:ext cx="8424467" cy="3332402"/>
+          </a:xfrm>
+          <a:prstGeom prst="rect">
+            <a:avLst/>
+          </a:prstGeom>
+        </p:spPr>
+        <p:txBody>
+          <a:bodyPr vert="horz" lIns="36000" tIns="36000" rIns="36000" bIns="36000" rtlCol="0" anchor="t">
+            <a:normAutofit/>
+          </a:bodyPr>
+          <a:lstStyle>
+            <a:lvl1pPr marL="216000" indent="-216000" algn="l" defTabSz="685800" rtl="0" eaLnBrk="1" latinLnBrk="0" hangingPunct="1">
+              <a:lnSpc>
+                <a:spcPct val="100000"/>
+              </a:lnSpc>
+              <a:spcBef>
+                <a:spcPts val="200"/>
+              </a:spcBef>
+              <a:buClr>
+                <a:schemeClr val="tx1"/>
+              </a:buClr>
+              <a:buFont typeface="Symbol" panose="05050102010706020507" pitchFamily="18" charset="2"/>
+              <a:buChar char="-"/>
+              <a:defRPr sz="1800" kern="1200">
+                <a:solidFill>
+                  <a:schemeClr val="tx1"/>
+                </a:solidFill>
+                <a:latin typeface="+mn-lt"/>
+                <a:ea typeface="+mn-ea"/>
+                <a:cs typeface="+mn-cs"/>
+              </a:defRPr>
+            </a:lvl1pPr>
+            <a:lvl2pPr marL="432000" indent="-216000" algn="l" defTabSz="685800" rtl="0" eaLnBrk="1" latinLnBrk="0" hangingPunct="1">
+              <a:lnSpc>
+                <a:spcPct val="100000"/>
+              </a:lnSpc>
+              <a:spcBef>
+                <a:spcPts val="200"/>
+              </a:spcBef>
+              <a:buFont typeface="Symbol" panose="05050102010706020507" pitchFamily="18" charset="2"/>
+              <a:buChar char="-"/>
+              <a:defRPr sz="1600" kern="1200">
+                <a:solidFill>
+                  <a:schemeClr val="tx1"/>
+                </a:solidFill>
+                <a:latin typeface="+mn-lt"/>
+                <a:ea typeface="+mn-ea"/>
+                <a:cs typeface="+mn-cs"/>
+              </a:defRPr>
+            </a:lvl2pPr>
+            <a:lvl3pPr marL="648000" indent="-216000" algn="l" defTabSz="685800" rtl="0" eaLnBrk="1" latinLnBrk="0" hangingPunct="1">
+              <a:lnSpc>
+                <a:spcPct val="100000"/>
+              </a:lnSpc>
+              <a:spcBef>
+                <a:spcPts val="200"/>
+              </a:spcBef>
+              <a:buFont typeface="Symbol" panose="05050102010706020507" pitchFamily="18" charset="2"/>
+              <a:buChar char="-"/>
+              <a:defRPr sz="1400" kern="1200">
+                <a:solidFill>
+                  <a:schemeClr val="tx1"/>
+                </a:solidFill>
+                <a:latin typeface="+mn-lt"/>
+                <a:ea typeface="+mn-ea"/>
+                <a:cs typeface="+mn-cs"/>
+              </a:defRPr>
+            </a:lvl3pPr>
+            <a:lvl4pPr marL="864000" indent="-216000" algn="l" defTabSz="685800" rtl="0" eaLnBrk="1" latinLnBrk="0" hangingPunct="1">
+              <a:lnSpc>
+                <a:spcPct val="100000"/>
+              </a:lnSpc>
+              <a:spcBef>
+                <a:spcPts val="200"/>
+              </a:spcBef>
+              <a:buFont typeface="Symbol" panose="05050102010706020507" pitchFamily="18" charset="2"/>
+              <a:buChar char="-"/>
+              <a:defRPr sz="1200" kern="1200">
+                <a:solidFill>
+                  <a:schemeClr val="tx1"/>
+                </a:solidFill>
+                <a:latin typeface="+mn-lt"/>
+                <a:ea typeface="+mn-ea"/>
+                <a:cs typeface="+mn-cs"/>
+              </a:defRPr>
+            </a:lvl4pPr>
+            <a:lvl5pPr marL="1080000" indent="-216000" algn="l" defTabSz="685800" rtl="0" eaLnBrk="1" latinLnBrk="0" hangingPunct="1">
+              <a:lnSpc>
+                <a:spcPct val="100000"/>
+              </a:lnSpc>
+              <a:spcBef>
+                <a:spcPts val="200"/>
+              </a:spcBef>
+              <a:buFont typeface="Symbol" panose="05050102010706020507" pitchFamily="18" charset="2"/>
+              <a:buChar char="-"/>
+              <a:defRPr sz="1100" kern="1200">
+                <a:solidFill>
+                  <a:schemeClr val="tx1"/>
+                </a:solidFill>
+                <a:latin typeface="+mn-lt"/>
+                <a:ea typeface="+mn-ea"/>
+                <a:cs typeface="+mn-cs"/>
+              </a:defRPr>
+            </a:lvl5pPr>
+            <a:lvl6pPr marL="1885950" indent="-171450" algn="l" defTabSz="685800" rtl="0" eaLnBrk="1" latinLnBrk="0" hangingPunct="1">
+              <a:lnSpc>
+                <a:spcPct val="90000"/>
+              </a:lnSpc>
+              <a:spcBef>
+                <a:spcPts val="375"/>
+              </a:spcBef>
+              <a:buFont typeface="Arial" panose="020B0604020202020204" pitchFamily="34" charset="0"/>
+              <a:buChar char="•"/>
+              <a:defRPr sz="1350" kern="1200">
+                <a:solidFill>
+                  <a:schemeClr val="tx1"/>
+                </a:solidFill>
+                <a:latin typeface="+mn-lt"/>
+                <a:ea typeface="+mn-ea"/>
+                <a:cs typeface="+mn-cs"/>
+              </a:defRPr>
+            </a:lvl6pPr>
+            <a:lvl7pPr marL="2228850" indent="-171450" algn="l" defTabSz="685800" rtl="0" eaLnBrk="1" latinLnBrk="0" hangingPunct="1">
+              <a:lnSpc>
+                <a:spcPct val="90000"/>
+              </a:lnSpc>
+              <a:spcBef>
+                <a:spcPts val="375"/>
+              </a:spcBef>
+              <a:buFont typeface="Arial" panose="020B0604020202020204" pitchFamily="34" charset="0"/>
+              <a:buChar char="•"/>
+              <a:defRPr sz="1350" kern="1200">
+                <a:solidFill>
+                  <a:schemeClr val="tx1"/>
+                </a:solidFill>
+                <a:latin typeface="+mn-lt"/>
+                <a:ea typeface="+mn-ea"/>
+                <a:cs typeface="+mn-cs"/>
+              </a:defRPr>
+            </a:lvl7pPr>
+            <a:lvl8pPr marL="2571750" indent="-171450" algn="l" defTabSz="685800" rtl="0" eaLnBrk="1" latinLnBrk="0" hangingPunct="1">
+              <a:lnSpc>
+                <a:spcPct val="90000"/>
+              </a:lnSpc>
+              <a:spcBef>
+                <a:spcPts val="375"/>
+              </a:spcBef>
+              <a:buFont typeface="Arial" panose="020B0604020202020204" pitchFamily="34" charset="0"/>
+              <a:buChar char="•"/>
+              <a:defRPr sz="1350" kern="1200">
+                <a:solidFill>
+                  <a:schemeClr val="tx1"/>
+                </a:solidFill>
+                <a:latin typeface="+mn-lt"/>
+                <a:ea typeface="+mn-ea"/>
+                <a:cs typeface="+mn-cs"/>
+              </a:defRPr>
+            </a:lvl8pPr>
+            <a:lvl9pPr marL="2914650" indent="-171450" algn="l" defTabSz="685800" rtl="0" eaLnBrk="1" latinLnBrk="0" hangingPunct="1">
+              <a:lnSpc>
+                <a:spcPct val="90000"/>
+              </a:lnSpc>
+              <a:spcBef>
+                <a:spcPts val="375"/>
+              </a:spcBef>
+              <a:buFont typeface="Arial" panose="020B0604020202020204" pitchFamily="34" charset="0"/>
+              <a:buChar char="•"/>
+              <a:defRPr sz="1350" kern="1200">
+                <a:solidFill>
+                  <a:schemeClr val="tx1"/>
+                </a:solidFill>
+                <a:latin typeface="+mn-lt"/>
+                <a:ea typeface="+mn-ea"/>
+                <a:cs typeface="+mn-cs"/>
+              </a:defRPr>
+            </a:lvl9pPr>
+          </a:lstStyle>
+          <a:p>
+            <a:pPr marL="0" indent="0">
+              <a:lnSpc>
+                <a:spcPct val="150000"/>
+              </a:lnSpc>
+              <a:buNone/>
+            </a:pPr>
+            <a:r>
+              <a:rPr lang="en-US" noProof="0" dirty="0"/>
+              <a:t>Advantages:</a:t>
+            </a:r>
+          </a:p>
+          <a:p>
+            <a:pPr>
+              <a:lnSpc>
+                <a:spcPct val="150000"/>
+              </a:lnSpc>
+            </a:pPr>
+            <a:r>
+              <a:rPr lang="en-US" dirty="0"/>
+              <a:t>Uniform formatting</a:t>
+            </a:r>
+            <a:endParaRPr lang="en-US" noProof="0" dirty="0"/>
+          </a:p>
+          <a:p>
+            <a:pPr>
+              <a:lnSpc>
+                <a:spcPct val="150000"/>
+              </a:lnSpc>
+            </a:pPr>
+            <a:r>
+              <a:rPr lang="en-US" noProof="0" dirty="0"/>
+              <a:t>Limit boilerplate code</a:t>
+            </a:r>
+          </a:p>
+          <a:p>
+            <a:pPr>
+              <a:lnSpc>
+                <a:spcPct val="150000"/>
+              </a:lnSpc>
+            </a:pPr>
+            <a:r>
+              <a:rPr lang="en-US" noProof="0" dirty="0"/>
+              <a:t>Limit scaling costs</a:t>
+            </a:r>
+          </a:p>
+        </p:txBody>
+      </p:sp>
+    </p:spTree>
+    <p:extLst>
+      <p:ext uri="{BB962C8B-B14F-4D97-AF65-F5344CB8AC3E}">
+        <p14:creationId xmlns:p14="http://schemas.microsoft.com/office/powerpoint/2010/main" val="964078047"/>
+      </p:ext>
+    </p:extLst>
+  </p:cSld>
+  <p:clrMapOvr>
+    <a:masterClrMapping/>
+  </p:clrMapOvr>
+</p:sld>
+</file>
+
+<file path=ppt/slides/slide34.xml><?xml version="1.0" encoding="utf-8"?>
 <p:sld xmlns:a="http://schemas.openxmlformats.org/drawingml/2006/main" xmlns:r="http://schemas.openxmlformats.org/officeDocument/2006/relationships" xmlns:p="http://schemas.openxmlformats.org/presentationml/2006/main">
   <p:cSld>
     <p:spTree>
@@ -38841,7 +39702,7 @@
             <a:fld id="{E6639024-6672-4F87-864B-EA4FA9190A1A}" type="slidenum">
               <a:rPr lang="en-US" noProof="0" smtClean="0"/>
               <a:pPr/>
-              <a:t>32</a:t>
+              <a:t>34</a:t>
             </a:fld>
             <a:endParaRPr lang="en-US" noProof="0" dirty="0"/>
           </a:p>
@@ -39137,7 +39998,7 @@
 </p:sld>
 </file>
 
-<file path=ppt/slides/slide33.xml><?xml version="1.0" encoding="utf-8"?>
+<file path=ppt/slides/slide35.xml><?xml version="1.0" encoding="utf-8"?>
 <p:sld xmlns:a="http://schemas.openxmlformats.org/drawingml/2006/main" xmlns:r="http://schemas.openxmlformats.org/officeDocument/2006/relationships" xmlns:p="http://schemas.openxmlformats.org/presentationml/2006/main">
   <p:cSld>
     <p:spTree>
@@ -39308,7 +40169,7 @@
             <a:fld id="{E6639024-6672-4F87-864B-EA4FA9190A1A}" type="slidenum">
               <a:rPr lang="en-US" noProof="0" smtClean="0"/>
               <a:pPr/>
-              <a:t>33</a:t>
+              <a:t>35</a:t>
             </a:fld>
             <a:endParaRPr lang="en-US" noProof="0" dirty="0"/>
           </a:p>
@@ -39615,7 +40476,7 @@
 </p:sld>
 </file>
 
-<file path=ppt/slides/slide34.xml><?xml version="1.0" encoding="utf-8"?>
+<file path=ppt/slides/slide36.xml><?xml version="1.0" encoding="utf-8"?>
 <p:sld xmlns:a="http://schemas.openxmlformats.org/drawingml/2006/main" xmlns:r="http://schemas.openxmlformats.org/officeDocument/2006/relationships" xmlns:p="http://schemas.openxmlformats.org/presentationml/2006/main">
   <p:cSld>
     <p:spTree>
@@ -39786,7 +40647,7 @@
             <a:fld id="{E6639024-6672-4F87-864B-EA4FA9190A1A}" type="slidenum">
               <a:rPr lang="en-US" noProof="0" smtClean="0"/>
               <a:pPr/>
-              <a:t>34</a:t>
+              <a:t>36</a:t>
             </a:fld>
             <a:endParaRPr lang="en-US" noProof="0" dirty="0"/>
           </a:p>
@@ -39994,8 +40855,12 @@
               <a:buNone/>
             </a:pPr>
             <a:r>
+              <a:rPr lang="en-US" b="1" noProof="0" dirty="0"/>
+              <a:t>All</a:t>
+            </a:r>
+            <a:r>
               <a:rPr lang="en-US" noProof="0" dirty="0"/>
-              <a:t>All vulnerabilities</a:t>
+              <a:t> vulnerabilities</a:t>
             </a:r>
             <a:r>
               <a:rPr lang="en-US" dirty="0"/>
@@ -40091,7 +40956,7 @@
 </p:sld>
 </file>
 
-<file path=ppt/slides/slide35.xml><?xml version="1.0" encoding="utf-8"?>
+<file path=ppt/slides/slide37.xml><?xml version="1.0" encoding="utf-8"?>
 <p:sld xmlns:a="http://schemas.openxmlformats.org/drawingml/2006/main" xmlns:r="http://schemas.openxmlformats.org/officeDocument/2006/relationships" xmlns:p="http://schemas.openxmlformats.org/presentationml/2006/main">
   <p:cSld>
     <p:spTree>
@@ -40262,7 +41127,7 @@
             <a:fld id="{E6639024-6672-4F87-864B-EA4FA9190A1A}" type="slidenum">
               <a:rPr lang="en-US" noProof="0" smtClean="0"/>
               <a:pPr/>
-              <a:t>35</a:t>
+              <a:t>37</a:t>
             </a:fld>
             <a:endParaRPr lang="en-US" noProof="0" dirty="0"/>
           </a:p>
@@ -40483,17 +41348,6 @@
             <a:r>
               <a:rPr lang="en-US" noProof="0" dirty="0"/>
               <a:t>Reduce boilerplate code</a:t>
-            </a:r>
-          </a:p>
-          <a:p>
-            <a:pPr>
-              <a:lnSpc>
-                <a:spcPct val="150000"/>
-              </a:lnSpc>
-            </a:pPr>
-            <a:r>
-              <a:rPr lang="en-US" noProof="0" dirty="0"/>
-              <a:t>Uniform formatting</a:t>
             </a:r>
           </a:p>
           <a:p>
@@ -40558,7 +41412,7 @@
 </p:sld>
 </file>
 
-<file path=ppt/slides/slide36.xml><?xml version="1.0" encoding="utf-8"?>
+<file path=ppt/slides/slide38.xml><?xml version="1.0" encoding="utf-8"?>
 <p:sld xmlns:a="http://schemas.openxmlformats.org/drawingml/2006/main" xmlns:r="http://schemas.openxmlformats.org/officeDocument/2006/relationships" xmlns:p="http://schemas.openxmlformats.org/presentationml/2006/main">
   <p:cSld>
     <p:spTree>
@@ -40729,7 +41583,7 @@
             <a:fld id="{E6639024-6672-4F87-864B-EA4FA9190A1A}" type="slidenum">
               <a:rPr lang="en-US" noProof="0" smtClean="0"/>
               <a:pPr/>
-              <a:t>36</a:t>
+              <a:t>38</a:t>
             </a:fld>
             <a:endParaRPr lang="en-US" noProof="0" dirty="0"/>
           </a:p>
@@ -41012,7 +41866,7 @@
 </p:sld>
 </file>
 
-<file path=ppt/slides/slide37.xml><?xml version="1.0" encoding="utf-8"?>
+<file path=ppt/slides/slide39.xml><?xml version="1.0" encoding="utf-8"?>
 <p:sld xmlns:a="http://schemas.openxmlformats.org/drawingml/2006/main" xmlns:r="http://schemas.openxmlformats.org/officeDocument/2006/relationships" xmlns:p="http://schemas.openxmlformats.org/presentationml/2006/main">
   <p:cSld>
     <p:spTree>
@@ -41246,7 +42100,7 @@
             <a:fld id="{E6639024-6672-4F87-864B-EA4FA9190A1A}" type="slidenum">
               <a:rPr lang="en-US" noProof="0" smtClean="0"/>
               <a:pPr/>
-              <a:t>37</a:t>
+              <a:t>39</a:t>
             </a:fld>
             <a:endParaRPr lang="en-US" noProof="0" dirty="0"/>
           </a:p>
@@ -41265,7 +42119,533 @@
 </p:sld>
 </file>
 
-<file path=ppt/slides/slide38.xml><?xml version="1.0" encoding="utf-8"?>
+<file path=ppt/slides/slide4.xml><?xml version="1.0" encoding="utf-8"?>
+<p:sld xmlns:a="http://schemas.openxmlformats.org/drawingml/2006/main" xmlns:r="http://schemas.openxmlformats.org/officeDocument/2006/relationships" xmlns:p="http://schemas.openxmlformats.org/presentationml/2006/main">
+  <p:cSld>
+    <p:spTree>
+      <p:nvGrpSpPr>
+        <p:cNvPr id="1" name="">
+          <a:extLst>
+            <a:ext uri="{FF2B5EF4-FFF2-40B4-BE49-F238E27FC236}">
+              <a16:creationId xmlns:a16="http://schemas.microsoft.com/office/drawing/2014/main" id="{BCFE60A0-D67C-A722-3DAB-AA33D708D4F6}"/>
+            </a:ext>
+          </a:extLst>
+        </p:cNvPr>
+        <p:cNvGrpSpPr/>
+        <p:nvPr/>
+      </p:nvGrpSpPr>
+      <p:grpSpPr>
+        <a:xfrm>
+          <a:off x="0" y="0"/>
+          <a:ext cx="0" cy="0"/>
+          <a:chOff x="0" y="0"/>
+          <a:chExt cx="0" cy="0"/>
+        </a:xfrm>
+      </p:grpSpPr>
+      <p:sp>
+        <p:nvSpPr>
+          <p:cNvPr id="8" name="Textplatzhalter 7">
+            <a:extLst>
+              <a:ext uri="{FF2B5EF4-FFF2-40B4-BE49-F238E27FC236}">
+                <a16:creationId xmlns:a16="http://schemas.microsoft.com/office/drawing/2014/main" id="{D45C3CB5-A282-30D8-22A2-FD1E1FF7F3CD}"/>
+              </a:ext>
+            </a:extLst>
+          </p:cNvPr>
+          <p:cNvSpPr>
+            <a:spLocks noGrp="1"/>
+          </p:cNvSpPr>
+          <p:nvPr>
+            <p:ph type="body" sz="quarter" idx="12"/>
+          </p:nvPr>
+        </p:nvSpPr>
+        <p:spPr/>
+        <p:txBody>
+          <a:bodyPr/>
+          <a:lstStyle/>
+          <a:p>
+            <a:r>
+              <a:rPr lang="en-US" noProof="0" dirty="0">
+                <a:solidFill>
+                  <a:schemeClr val="bg2"/>
+                </a:solidFill>
+              </a:rPr>
+              <a:t>The Problem in Numbers</a:t>
+            </a:r>
+          </a:p>
+        </p:txBody>
+      </p:sp>
+      <p:sp>
+        <p:nvSpPr>
+          <p:cNvPr id="7" name="Titel 6">
+            <a:extLst>
+              <a:ext uri="{FF2B5EF4-FFF2-40B4-BE49-F238E27FC236}">
+                <a16:creationId xmlns:a16="http://schemas.microsoft.com/office/drawing/2014/main" id="{5043144B-0AA1-C080-E282-449EFCCFAF22}"/>
+              </a:ext>
+            </a:extLst>
+          </p:cNvPr>
+          <p:cNvSpPr>
+            <a:spLocks noGrp="1"/>
+          </p:cNvSpPr>
+          <p:nvPr>
+            <p:ph type="title"/>
+          </p:nvPr>
+        </p:nvSpPr>
+        <p:spPr/>
+        <p:txBody>
+          <a:bodyPr/>
+          <a:lstStyle/>
+          <a:p>
+            <a:r>
+              <a:rPr lang="en-US" dirty="0">
+                <a:solidFill>
+                  <a:schemeClr val="tx1"/>
+                </a:solidFill>
+              </a:rPr>
+              <a:t>State of Android App Security</a:t>
+            </a:r>
+            <a:endParaRPr lang="en-US" noProof="0" dirty="0">
+              <a:solidFill>
+                <a:schemeClr val="tx1"/>
+              </a:solidFill>
+            </a:endParaRPr>
+          </a:p>
+        </p:txBody>
+      </p:sp>
+      <p:sp>
+        <p:nvSpPr>
+          <p:cNvPr id="9" name="Textplatzhalter 8">
+            <a:extLst>
+              <a:ext uri="{FF2B5EF4-FFF2-40B4-BE49-F238E27FC236}">
+                <a16:creationId xmlns:a16="http://schemas.microsoft.com/office/drawing/2014/main" id="{ECA742AD-C2CF-78CE-281C-ABD846F3CB3C}"/>
+              </a:ext>
+            </a:extLst>
+          </p:cNvPr>
+          <p:cNvSpPr>
+            <a:spLocks noGrp="1"/>
+          </p:cNvSpPr>
+          <p:nvPr>
+            <p:ph type="body" sz="quarter" idx="19"/>
+          </p:nvPr>
+        </p:nvSpPr>
+        <p:spPr/>
+        <p:txBody>
+          <a:bodyPr/>
+          <a:lstStyle/>
+          <a:p>
+            <a:r>
+              <a:rPr lang="en-US" noProof="0" dirty="0"/>
+              <a:t>(Ferrari et al., 2025; Tech Inside Out 20</a:t>
+            </a:r>
+            <a:r>
+              <a:rPr lang="en-US" dirty="0"/>
+              <a:t>21</a:t>
+            </a:r>
+            <a:r>
+              <a:rPr lang="en-US" noProof="0" dirty="0"/>
+              <a:t>)</a:t>
+            </a:r>
+          </a:p>
+        </p:txBody>
+      </p:sp>
+      <p:sp>
+        <p:nvSpPr>
+          <p:cNvPr id="11" name="Fußzeilenplatzhalter 10">
+            <a:extLst>
+              <a:ext uri="{FF2B5EF4-FFF2-40B4-BE49-F238E27FC236}">
+                <a16:creationId xmlns:a16="http://schemas.microsoft.com/office/drawing/2014/main" id="{9E040E96-317A-C10D-4B2B-31D6C089B9D6}"/>
+              </a:ext>
+            </a:extLst>
+          </p:cNvPr>
+          <p:cNvSpPr>
+            <a:spLocks noGrp="1"/>
+          </p:cNvSpPr>
+          <p:nvPr>
+            <p:ph type="ftr" sz="quarter" idx="17"/>
+          </p:nvPr>
+        </p:nvSpPr>
+        <p:spPr/>
+        <p:txBody>
+          <a:bodyPr/>
+          <a:lstStyle/>
+          <a:p>
+            <a:endParaRPr lang="en-US" noProof="0" dirty="0"/>
+          </a:p>
+        </p:txBody>
+      </p:sp>
+      <p:sp>
+        <p:nvSpPr>
+          <p:cNvPr id="12" name="Foliennummernplatzhalter 11">
+            <a:extLst>
+              <a:ext uri="{FF2B5EF4-FFF2-40B4-BE49-F238E27FC236}">
+                <a16:creationId xmlns:a16="http://schemas.microsoft.com/office/drawing/2014/main" id="{11FC7BB2-8FB3-9A88-4C83-5936E9011CD0}"/>
+              </a:ext>
+            </a:extLst>
+          </p:cNvPr>
+          <p:cNvSpPr>
+            <a:spLocks noGrp="1"/>
+          </p:cNvSpPr>
+          <p:nvPr>
+            <p:ph type="sldNum" sz="quarter" idx="18"/>
+          </p:nvPr>
+        </p:nvSpPr>
+        <p:spPr/>
+        <p:txBody>
+          <a:bodyPr/>
+          <a:lstStyle/>
+          <a:p>
+            <a:fld id="{E6639024-6672-4F87-864B-EA4FA9190A1A}" type="slidenum">
+              <a:rPr lang="en-US" noProof="0" smtClean="0"/>
+              <a:pPr/>
+              <a:t>4</a:t>
+            </a:fld>
+            <a:endParaRPr lang="en-US" noProof="0" dirty="0"/>
+          </a:p>
+        </p:txBody>
+      </p:sp>
+      <p:sp>
+        <p:nvSpPr>
+          <p:cNvPr id="5" name="Textfeld 4">
+            <a:extLst>
+              <a:ext uri="{FF2B5EF4-FFF2-40B4-BE49-F238E27FC236}">
+                <a16:creationId xmlns:a16="http://schemas.microsoft.com/office/drawing/2014/main" id="{7ADA47EF-7EB6-938E-6E09-56430F4CA70D}"/>
+              </a:ext>
+            </a:extLst>
+          </p:cNvPr>
+          <p:cNvSpPr txBox="1"/>
+          <p:nvPr/>
+        </p:nvSpPr>
+        <p:spPr>
+          <a:xfrm>
+            <a:off x="1331640" y="2088634"/>
+            <a:ext cx="1952275" cy="1538883"/>
+          </a:xfrm>
+          <a:prstGeom prst="rect">
+            <a:avLst/>
+          </a:prstGeom>
+          <a:noFill/>
+        </p:spPr>
+        <p:txBody>
+          <a:bodyPr wrap="square" rtlCol="0">
+            <a:spAutoFit/>
+          </a:bodyPr>
+          <a:lstStyle/>
+          <a:p>
+            <a:pPr algn="ctr"/>
+            <a:r>
+              <a:rPr lang="en-US" sz="6000" noProof="0" dirty="0">
+                <a:solidFill>
+                  <a:schemeClr val="bg2"/>
+                </a:solidFill>
+              </a:rPr>
+              <a:t>39</a:t>
+            </a:r>
+            <a:r>
+              <a:rPr lang="en-US" sz="8000" noProof="0" dirty="0"/>
+              <a:t> </a:t>
+            </a:r>
+          </a:p>
+          <a:p>
+            <a:pPr algn="ctr"/>
+            <a:r>
+              <a:rPr lang="en-US" sz="1400" noProof="0" dirty="0"/>
+              <a:t>vulnerabilities per app</a:t>
+            </a:r>
+          </a:p>
+        </p:txBody>
+      </p:sp>
+      <p:sp>
+        <p:nvSpPr>
+          <p:cNvPr id="6" name="Textfeld 5">
+            <a:extLst>
+              <a:ext uri="{FF2B5EF4-FFF2-40B4-BE49-F238E27FC236}">
+                <a16:creationId xmlns:a16="http://schemas.microsoft.com/office/drawing/2014/main" id="{AF023A3C-46D8-3046-6EBE-17844C562EB6}"/>
+              </a:ext>
+            </a:extLst>
+          </p:cNvPr>
+          <p:cNvSpPr txBox="1"/>
+          <p:nvPr/>
+        </p:nvSpPr>
+        <p:spPr>
+          <a:xfrm>
+            <a:off x="5076056" y="2073246"/>
+            <a:ext cx="2196244" cy="1569660"/>
+          </a:xfrm>
+          <a:prstGeom prst="rect">
+            <a:avLst/>
+          </a:prstGeom>
+          <a:noFill/>
+        </p:spPr>
+        <p:txBody>
+          <a:bodyPr wrap="square" rtlCol="0">
+            <a:spAutoFit/>
+          </a:bodyPr>
+          <a:lstStyle/>
+          <a:p>
+            <a:pPr algn="ctr"/>
+            <a:r>
+              <a:rPr lang="en-US" sz="6000" noProof="0" dirty="0">
+                <a:solidFill>
+                  <a:schemeClr val="bg2"/>
+                </a:solidFill>
+              </a:rPr>
+              <a:t>63%</a:t>
+            </a:r>
+            <a:r>
+              <a:rPr lang="en-US" sz="8000" noProof="0" dirty="0">
+                <a:solidFill>
+                  <a:schemeClr val="bg2"/>
+                </a:solidFill>
+              </a:rPr>
+              <a:t> </a:t>
+            </a:r>
+          </a:p>
+          <a:p>
+            <a:pPr algn="ctr"/>
+            <a:r>
+              <a:rPr lang="en-US" sz="1400" noProof="0" dirty="0"/>
+              <a:t>apps show vulnerabilities</a:t>
+            </a:r>
+          </a:p>
+        </p:txBody>
+      </p:sp>
+      <p:sp>
+        <p:nvSpPr>
+          <p:cNvPr id="2" name="Inhaltsplatzhalter 9">
+            <a:extLst>
+              <a:ext uri="{FF2B5EF4-FFF2-40B4-BE49-F238E27FC236}">
+                <a16:creationId xmlns:a16="http://schemas.microsoft.com/office/drawing/2014/main" id="{7B402A66-69FE-A1BE-113F-727ECEA35F08}"/>
+              </a:ext>
+            </a:extLst>
+          </p:cNvPr>
+          <p:cNvSpPr txBox="1">
+            <a:spLocks/>
+          </p:cNvSpPr>
+          <p:nvPr/>
+        </p:nvSpPr>
+        <p:spPr>
+          <a:xfrm>
+            <a:off x="359532" y="1207321"/>
+            <a:ext cx="8424467" cy="3332402"/>
+          </a:xfrm>
+          <a:prstGeom prst="rect">
+            <a:avLst/>
+          </a:prstGeom>
+        </p:spPr>
+        <p:txBody>
+          <a:bodyPr vert="horz" lIns="36000" tIns="36000" rIns="36000" bIns="36000" rtlCol="0" anchor="t">
+            <a:normAutofit/>
+          </a:bodyPr>
+          <a:lstStyle>
+            <a:lvl1pPr marL="216000" indent="-216000" algn="l" defTabSz="685800" rtl="0" eaLnBrk="1" latinLnBrk="0" hangingPunct="1">
+              <a:lnSpc>
+                <a:spcPct val="100000"/>
+              </a:lnSpc>
+              <a:spcBef>
+                <a:spcPts val="200"/>
+              </a:spcBef>
+              <a:buClr>
+                <a:schemeClr val="tx1"/>
+              </a:buClr>
+              <a:buFont typeface="Symbol" panose="05050102010706020507" pitchFamily="18" charset="2"/>
+              <a:buChar char="-"/>
+              <a:defRPr sz="1800" kern="1200">
+                <a:solidFill>
+                  <a:schemeClr val="tx1"/>
+                </a:solidFill>
+                <a:latin typeface="+mn-lt"/>
+                <a:ea typeface="+mn-ea"/>
+                <a:cs typeface="+mn-cs"/>
+              </a:defRPr>
+            </a:lvl1pPr>
+            <a:lvl2pPr marL="432000" indent="-216000" algn="l" defTabSz="685800" rtl="0" eaLnBrk="1" latinLnBrk="0" hangingPunct="1">
+              <a:lnSpc>
+                <a:spcPct val="100000"/>
+              </a:lnSpc>
+              <a:spcBef>
+                <a:spcPts val="200"/>
+              </a:spcBef>
+              <a:buFont typeface="Symbol" panose="05050102010706020507" pitchFamily="18" charset="2"/>
+              <a:buChar char="-"/>
+              <a:defRPr sz="1600" kern="1200">
+                <a:solidFill>
+                  <a:schemeClr val="tx1"/>
+                </a:solidFill>
+                <a:latin typeface="+mn-lt"/>
+                <a:ea typeface="+mn-ea"/>
+                <a:cs typeface="+mn-cs"/>
+              </a:defRPr>
+            </a:lvl2pPr>
+            <a:lvl3pPr marL="648000" indent="-216000" algn="l" defTabSz="685800" rtl="0" eaLnBrk="1" latinLnBrk="0" hangingPunct="1">
+              <a:lnSpc>
+                <a:spcPct val="100000"/>
+              </a:lnSpc>
+              <a:spcBef>
+                <a:spcPts val="200"/>
+              </a:spcBef>
+              <a:buFont typeface="Symbol" panose="05050102010706020507" pitchFamily="18" charset="2"/>
+              <a:buChar char="-"/>
+              <a:defRPr sz="1400" kern="1200">
+                <a:solidFill>
+                  <a:schemeClr val="tx1"/>
+                </a:solidFill>
+                <a:latin typeface="+mn-lt"/>
+                <a:ea typeface="+mn-ea"/>
+                <a:cs typeface="+mn-cs"/>
+              </a:defRPr>
+            </a:lvl3pPr>
+            <a:lvl4pPr marL="864000" indent="-216000" algn="l" defTabSz="685800" rtl="0" eaLnBrk="1" latinLnBrk="0" hangingPunct="1">
+              <a:lnSpc>
+                <a:spcPct val="100000"/>
+              </a:lnSpc>
+              <a:spcBef>
+                <a:spcPts val="200"/>
+              </a:spcBef>
+              <a:buFont typeface="Symbol" panose="05050102010706020507" pitchFamily="18" charset="2"/>
+              <a:buChar char="-"/>
+              <a:defRPr sz="1200" kern="1200">
+                <a:solidFill>
+                  <a:schemeClr val="tx1"/>
+                </a:solidFill>
+                <a:latin typeface="+mn-lt"/>
+                <a:ea typeface="+mn-ea"/>
+                <a:cs typeface="+mn-cs"/>
+              </a:defRPr>
+            </a:lvl4pPr>
+            <a:lvl5pPr marL="1080000" indent="-216000" algn="l" defTabSz="685800" rtl="0" eaLnBrk="1" latinLnBrk="0" hangingPunct="1">
+              <a:lnSpc>
+                <a:spcPct val="100000"/>
+              </a:lnSpc>
+              <a:spcBef>
+                <a:spcPts val="200"/>
+              </a:spcBef>
+              <a:buFont typeface="Symbol" panose="05050102010706020507" pitchFamily="18" charset="2"/>
+              <a:buChar char="-"/>
+              <a:defRPr sz="1100" kern="1200">
+                <a:solidFill>
+                  <a:schemeClr val="tx1"/>
+                </a:solidFill>
+                <a:latin typeface="+mn-lt"/>
+                <a:ea typeface="+mn-ea"/>
+                <a:cs typeface="+mn-cs"/>
+              </a:defRPr>
+            </a:lvl5pPr>
+            <a:lvl6pPr marL="1885950" indent="-171450" algn="l" defTabSz="685800" rtl="0" eaLnBrk="1" latinLnBrk="0" hangingPunct="1">
+              <a:lnSpc>
+                <a:spcPct val="90000"/>
+              </a:lnSpc>
+              <a:spcBef>
+                <a:spcPts val="375"/>
+              </a:spcBef>
+              <a:buFont typeface="Arial" panose="020B0604020202020204" pitchFamily="34" charset="0"/>
+              <a:buChar char="•"/>
+              <a:defRPr sz="1350" kern="1200">
+                <a:solidFill>
+                  <a:schemeClr val="tx1"/>
+                </a:solidFill>
+                <a:latin typeface="+mn-lt"/>
+                <a:ea typeface="+mn-ea"/>
+                <a:cs typeface="+mn-cs"/>
+              </a:defRPr>
+            </a:lvl6pPr>
+            <a:lvl7pPr marL="2228850" indent="-171450" algn="l" defTabSz="685800" rtl="0" eaLnBrk="1" latinLnBrk="0" hangingPunct="1">
+              <a:lnSpc>
+                <a:spcPct val="90000"/>
+              </a:lnSpc>
+              <a:spcBef>
+                <a:spcPts val="375"/>
+              </a:spcBef>
+              <a:buFont typeface="Arial" panose="020B0604020202020204" pitchFamily="34" charset="0"/>
+              <a:buChar char="•"/>
+              <a:defRPr sz="1350" kern="1200">
+                <a:solidFill>
+                  <a:schemeClr val="tx1"/>
+                </a:solidFill>
+                <a:latin typeface="+mn-lt"/>
+                <a:ea typeface="+mn-ea"/>
+                <a:cs typeface="+mn-cs"/>
+              </a:defRPr>
+            </a:lvl7pPr>
+            <a:lvl8pPr marL="2571750" indent="-171450" algn="l" defTabSz="685800" rtl="0" eaLnBrk="1" latinLnBrk="0" hangingPunct="1">
+              <a:lnSpc>
+                <a:spcPct val="90000"/>
+              </a:lnSpc>
+              <a:spcBef>
+                <a:spcPts val="375"/>
+              </a:spcBef>
+              <a:buFont typeface="Arial" panose="020B0604020202020204" pitchFamily="34" charset="0"/>
+              <a:buChar char="•"/>
+              <a:defRPr sz="1350" kern="1200">
+                <a:solidFill>
+                  <a:schemeClr val="tx1"/>
+                </a:solidFill>
+                <a:latin typeface="+mn-lt"/>
+                <a:ea typeface="+mn-ea"/>
+                <a:cs typeface="+mn-cs"/>
+              </a:defRPr>
+            </a:lvl8pPr>
+            <a:lvl9pPr marL="2914650" indent="-171450" algn="l" defTabSz="685800" rtl="0" eaLnBrk="1" latinLnBrk="0" hangingPunct="1">
+              <a:lnSpc>
+                <a:spcPct val="90000"/>
+              </a:lnSpc>
+              <a:spcBef>
+                <a:spcPts val="375"/>
+              </a:spcBef>
+              <a:buFont typeface="Arial" panose="020B0604020202020204" pitchFamily="34" charset="0"/>
+              <a:buChar char="•"/>
+              <a:defRPr sz="1350" kern="1200">
+                <a:solidFill>
+                  <a:schemeClr val="tx1"/>
+                </a:solidFill>
+                <a:latin typeface="+mn-lt"/>
+                <a:ea typeface="+mn-ea"/>
+                <a:cs typeface="+mn-cs"/>
+              </a:defRPr>
+            </a:lvl9pPr>
+          </a:lstStyle>
+          <a:p>
+            <a:pPr marL="0" indent="0">
+              <a:lnSpc>
+                <a:spcPct val="150000"/>
+              </a:lnSpc>
+              <a:buNone/>
+            </a:pPr>
+            <a:r>
+              <a:rPr lang="en-US" noProof="0" dirty="0"/>
+              <a:t>Across the 18 most popular Android categories:</a:t>
+            </a:r>
+          </a:p>
+          <a:p>
+            <a:pPr>
+              <a:lnSpc>
+                <a:spcPct val="150000"/>
+              </a:lnSpc>
+            </a:pPr>
+            <a:endParaRPr lang="en-US" noProof="0" dirty="0"/>
+          </a:p>
+          <a:p>
+            <a:pPr>
+              <a:lnSpc>
+                <a:spcPct val="150000"/>
+              </a:lnSpc>
+            </a:pPr>
+            <a:endParaRPr lang="en-US" noProof="0" dirty="0"/>
+          </a:p>
+        </p:txBody>
+      </p:sp>
+    </p:spTree>
+    <p:extLst>
+      <p:ext uri="{BB962C8B-B14F-4D97-AF65-F5344CB8AC3E}">
+        <p14:creationId xmlns:p14="http://schemas.microsoft.com/office/powerpoint/2010/main" val="3225203029"/>
+      </p:ext>
+    </p:extLst>
+  </p:cSld>
+  <p:clrMapOvr>
+    <a:masterClrMapping/>
+  </p:clrMapOvr>
+</p:sld>
+</file>
+
+<file path=ppt/slides/slide40.xml><?xml version="1.0" encoding="utf-8"?>
 <p:sld xmlns:a="http://schemas.openxmlformats.org/drawingml/2006/main" xmlns:r="http://schemas.openxmlformats.org/officeDocument/2006/relationships" xmlns:p="http://schemas.openxmlformats.org/presentationml/2006/main">
   <p:cSld>
     <p:spTree>
@@ -41507,7 +42887,7 @@
             <a:fld id="{E6639024-6672-4F87-864B-EA4FA9190A1A}" type="slidenum">
               <a:rPr lang="en-US" noProof="0" smtClean="0"/>
               <a:pPr/>
-              <a:t>38</a:t>
+              <a:t>40</a:t>
             </a:fld>
             <a:endParaRPr lang="en-US" noProof="0" dirty="0"/>
           </a:p>
@@ -41526,7 +42906,7 @@
 </p:sld>
 </file>
 
-<file path=ppt/slides/slide39.xml><?xml version="1.0" encoding="utf-8"?>
+<file path=ppt/slides/slide41.xml><?xml version="1.0" encoding="utf-8"?>
 <p:sld xmlns:a="http://schemas.openxmlformats.org/drawingml/2006/main" xmlns:r="http://schemas.openxmlformats.org/officeDocument/2006/relationships" xmlns:p="http://schemas.openxmlformats.org/presentationml/2006/main">
   <p:cSld>
     <p:spTree>
@@ -41741,7 +43121,7 @@
             <a:fld id="{E6639024-6672-4F87-864B-EA4FA9190A1A}" type="slidenum">
               <a:rPr lang="en-US" noProof="0" smtClean="0"/>
               <a:pPr/>
-              <a:t>39</a:t>
+              <a:t>41</a:t>
             </a:fld>
             <a:endParaRPr lang="en-US" noProof="0" dirty="0"/>
           </a:p>
@@ -41796,533 +43176,7 @@
 </p:sld>
 </file>
 
-<file path=ppt/slides/slide4.xml><?xml version="1.0" encoding="utf-8"?>
-<p:sld xmlns:a="http://schemas.openxmlformats.org/drawingml/2006/main" xmlns:r="http://schemas.openxmlformats.org/officeDocument/2006/relationships" xmlns:p="http://schemas.openxmlformats.org/presentationml/2006/main">
-  <p:cSld>
-    <p:spTree>
-      <p:nvGrpSpPr>
-        <p:cNvPr id="1" name="">
-          <a:extLst>
-            <a:ext uri="{FF2B5EF4-FFF2-40B4-BE49-F238E27FC236}">
-              <a16:creationId xmlns:a16="http://schemas.microsoft.com/office/drawing/2014/main" id="{BCFE60A0-D67C-A722-3DAB-AA33D708D4F6}"/>
-            </a:ext>
-          </a:extLst>
-        </p:cNvPr>
-        <p:cNvGrpSpPr/>
-        <p:nvPr/>
-      </p:nvGrpSpPr>
-      <p:grpSpPr>
-        <a:xfrm>
-          <a:off x="0" y="0"/>
-          <a:ext cx="0" cy="0"/>
-          <a:chOff x="0" y="0"/>
-          <a:chExt cx="0" cy="0"/>
-        </a:xfrm>
-      </p:grpSpPr>
-      <p:sp>
-        <p:nvSpPr>
-          <p:cNvPr id="8" name="Textplatzhalter 7">
-            <a:extLst>
-              <a:ext uri="{FF2B5EF4-FFF2-40B4-BE49-F238E27FC236}">
-                <a16:creationId xmlns:a16="http://schemas.microsoft.com/office/drawing/2014/main" id="{D45C3CB5-A282-30D8-22A2-FD1E1FF7F3CD}"/>
-              </a:ext>
-            </a:extLst>
-          </p:cNvPr>
-          <p:cNvSpPr>
-            <a:spLocks noGrp="1"/>
-          </p:cNvSpPr>
-          <p:nvPr>
-            <p:ph type="body" sz="quarter" idx="12"/>
-          </p:nvPr>
-        </p:nvSpPr>
-        <p:spPr/>
-        <p:txBody>
-          <a:bodyPr/>
-          <a:lstStyle/>
-          <a:p>
-            <a:r>
-              <a:rPr lang="en-US" noProof="0" dirty="0">
-                <a:solidFill>
-                  <a:schemeClr val="bg2"/>
-                </a:solidFill>
-              </a:rPr>
-              <a:t>The Problem in Numbers</a:t>
-            </a:r>
-          </a:p>
-        </p:txBody>
-      </p:sp>
-      <p:sp>
-        <p:nvSpPr>
-          <p:cNvPr id="7" name="Titel 6">
-            <a:extLst>
-              <a:ext uri="{FF2B5EF4-FFF2-40B4-BE49-F238E27FC236}">
-                <a16:creationId xmlns:a16="http://schemas.microsoft.com/office/drawing/2014/main" id="{5043144B-0AA1-C080-E282-449EFCCFAF22}"/>
-              </a:ext>
-            </a:extLst>
-          </p:cNvPr>
-          <p:cNvSpPr>
-            <a:spLocks noGrp="1"/>
-          </p:cNvSpPr>
-          <p:nvPr>
-            <p:ph type="title"/>
-          </p:nvPr>
-        </p:nvSpPr>
-        <p:spPr/>
-        <p:txBody>
-          <a:bodyPr/>
-          <a:lstStyle/>
-          <a:p>
-            <a:r>
-              <a:rPr lang="en-US" dirty="0">
-                <a:solidFill>
-                  <a:schemeClr val="tx1"/>
-                </a:solidFill>
-              </a:rPr>
-              <a:t>State of Android App Security</a:t>
-            </a:r>
-            <a:endParaRPr lang="en-US" noProof="0" dirty="0">
-              <a:solidFill>
-                <a:schemeClr val="tx1"/>
-              </a:solidFill>
-            </a:endParaRPr>
-          </a:p>
-        </p:txBody>
-      </p:sp>
-      <p:sp>
-        <p:nvSpPr>
-          <p:cNvPr id="9" name="Textplatzhalter 8">
-            <a:extLst>
-              <a:ext uri="{FF2B5EF4-FFF2-40B4-BE49-F238E27FC236}">
-                <a16:creationId xmlns:a16="http://schemas.microsoft.com/office/drawing/2014/main" id="{ECA742AD-C2CF-78CE-281C-ABD846F3CB3C}"/>
-              </a:ext>
-            </a:extLst>
-          </p:cNvPr>
-          <p:cNvSpPr>
-            <a:spLocks noGrp="1"/>
-          </p:cNvSpPr>
-          <p:nvPr>
-            <p:ph type="body" sz="quarter" idx="19"/>
-          </p:nvPr>
-        </p:nvSpPr>
-        <p:spPr/>
-        <p:txBody>
-          <a:bodyPr/>
-          <a:lstStyle/>
-          <a:p>
-            <a:r>
-              <a:rPr lang="en-US" noProof="0" dirty="0"/>
-              <a:t>(Ferrari et al., 2025; Tech Inside Out 20</a:t>
-            </a:r>
-            <a:r>
-              <a:rPr lang="en-US" dirty="0"/>
-              <a:t>21</a:t>
-            </a:r>
-            <a:r>
-              <a:rPr lang="en-US" noProof="0" dirty="0"/>
-              <a:t>)</a:t>
-            </a:r>
-          </a:p>
-        </p:txBody>
-      </p:sp>
-      <p:sp>
-        <p:nvSpPr>
-          <p:cNvPr id="11" name="Fußzeilenplatzhalter 10">
-            <a:extLst>
-              <a:ext uri="{FF2B5EF4-FFF2-40B4-BE49-F238E27FC236}">
-                <a16:creationId xmlns:a16="http://schemas.microsoft.com/office/drawing/2014/main" id="{9E040E96-317A-C10D-4B2B-31D6C089B9D6}"/>
-              </a:ext>
-            </a:extLst>
-          </p:cNvPr>
-          <p:cNvSpPr>
-            <a:spLocks noGrp="1"/>
-          </p:cNvSpPr>
-          <p:nvPr>
-            <p:ph type="ftr" sz="quarter" idx="17"/>
-          </p:nvPr>
-        </p:nvSpPr>
-        <p:spPr/>
-        <p:txBody>
-          <a:bodyPr/>
-          <a:lstStyle/>
-          <a:p>
-            <a:endParaRPr lang="en-US" noProof="0" dirty="0"/>
-          </a:p>
-        </p:txBody>
-      </p:sp>
-      <p:sp>
-        <p:nvSpPr>
-          <p:cNvPr id="12" name="Foliennummernplatzhalter 11">
-            <a:extLst>
-              <a:ext uri="{FF2B5EF4-FFF2-40B4-BE49-F238E27FC236}">
-                <a16:creationId xmlns:a16="http://schemas.microsoft.com/office/drawing/2014/main" id="{11FC7BB2-8FB3-9A88-4C83-5936E9011CD0}"/>
-              </a:ext>
-            </a:extLst>
-          </p:cNvPr>
-          <p:cNvSpPr>
-            <a:spLocks noGrp="1"/>
-          </p:cNvSpPr>
-          <p:nvPr>
-            <p:ph type="sldNum" sz="quarter" idx="18"/>
-          </p:nvPr>
-        </p:nvSpPr>
-        <p:spPr/>
-        <p:txBody>
-          <a:bodyPr/>
-          <a:lstStyle/>
-          <a:p>
-            <a:fld id="{E6639024-6672-4F87-864B-EA4FA9190A1A}" type="slidenum">
-              <a:rPr lang="en-US" noProof="0" smtClean="0"/>
-              <a:pPr/>
-              <a:t>4</a:t>
-            </a:fld>
-            <a:endParaRPr lang="en-US" noProof="0" dirty="0"/>
-          </a:p>
-        </p:txBody>
-      </p:sp>
-      <p:sp>
-        <p:nvSpPr>
-          <p:cNvPr id="5" name="Textfeld 4">
-            <a:extLst>
-              <a:ext uri="{FF2B5EF4-FFF2-40B4-BE49-F238E27FC236}">
-                <a16:creationId xmlns:a16="http://schemas.microsoft.com/office/drawing/2014/main" id="{7ADA47EF-7EB6-938E-6E09-56430F4CA70D}"/>
-              </a:ext>
-            </a:extLst>
-          </p:cNvPr>
-          <p:cNvSpPr txBox="1"/>
-          <p:nvPr/>
-        </p:nvSpPr>
-        <p:spPr>
-          <a:xfrm>
-            <a:off x="1331640" y="2088634"/>
-            <a:ext cx="1952275" cy="1538883"/>
-          </a:xfrm>
-          <a:prstGeom prst="rect">
-            <a:avLst/>
-          </a:prstGeom>
-          <a:noFill/>
-        </p:spPr>
-        <p:txBody>
-          <a:bodyPr wrap="square" rtlCol="0">
-            <a:spAutoFit/>
-          </a:bodyPr>
-          <a:lstStyle/>
-          <a:p>
-            <a:pPr algn="ctr"/>
-            <a:r>
-              <a:rPr lang="en-US" sz="6000" noProof="0" dirty="0">
-                <a:solidFill>
-                  <a:schemeClr val="bg2"/>
-                </a:solidFill>
-              </a:rPr>
-              <a:t>39</a:t>
-            </a:r>
-            <a:r>
-              <a:rPr lang="en-US" sz="8000" noProof="0" dirty="0"/>
-              <a:t> </a:t>
-            </a:r>
-          </a:p>
-          <a:p>
-            <a:pPr algn="ctr"/>
-            <a:r>
-              <a:rPr lang="en-US" sz="1400" noProof="0" dirty="0"/>
-              <a:t>vulnerabilities per app</a:t>
-            </a:r>
-          </a:p>
-        </p:txBody>
-      </p:sp>
-      <p:sp>
-        <p:nvSpPr>
-          <p:cNvPr id="6" name="Textfeld 5">
-            <a:extLst>
-              <a:ext uri="{FF2B5EF4-FFF2-40B4-BE49-F238E27FC236}">
-                <a16:creationId xmlns:a16="http://schemas.microsoft.com/office/drawing/2014/main" id="{AF023A3C-46D8-3046-6EBE-17844C562EB6}"/>
-              </a:ext>
-            </a:extLst>
-          </p:cNvPr>
-          <p:cNvSpPr txBox="1"/>
-          <p:nvPr/>
-        </p:nvSpPr>
-        <p:spPr>
-          <a:xfrm>
-            <a:off x="5076056" y="2073246"/>
-            <a:ext cx="2196244" cy="1569660"/>
-          </a:xfrm>
-          <a:prstGeom prst="rect">
-            <a:avLst/>
-          </a:prstGeom>
-          <a:noFill/>
-        </p:spPr>
-        <p:txBody>
-          <a:bodyPr wrap="square" rtlCol="0">
-            <a:spAutoFit/>
-          </a:bodyPr>
-          <a:lstStyle/>
-          <a:p>
-            <a:pPr algn="ctr"/>
-            <a:r>
-              <a:rPr lang="en-US" sz="6000" noProof="0" dirty="0">
-                <a:solidFill>
-                  <a:schemeClr val="bg2"/>
-                </a:solidFill>
-              </a:rPr>
-              <a:t>63%</a:t>
-            </a:r>
-            <a:r>
-              <a:rPr lang="en-US" sz="8000" noProof="0" dirty="0">
-                <a:solidFill>
-                  <a:schemeClr val="bg2"/>
-                </a:solidFill>
-              </a:rPr>
-              <a:t> </a:t>
-            </a:r>
-          </a:p>
-          <a:p>
-            <a:pPr algn="ctr"/>
-            <a:r>
-              <a:rPr lang="en-US" sz="1400" noProof="0" dirty="0"/>
-              <a:t>apps show vulnerabilities</a:t>
-            </a:r>
-          </a:p>
-        </p:txBody>
-      </p:sp>
-      <p:sp>
-        <p:nvSpPr>
-          <p:cNvPr id="2" name="Inhaltsplatzhalter 9">
-            <a:extLst>
-              <a:ext uri="{FF2B5EF4-FFF2-40B4-BE49-F238E27FC236}">
-                <a16:creationId xmlns:a16="http://schemas.microsoft.com/office/drawing/2014/main" id="{7B402A66-69FE-A1BE-113F-727ECEA35F08}"/>
-              </a:ext>
-            </a:extLst>
-          </p:cNvPr>
-          <p:cNvSpPr txBox="1">
-            <a:spLocks/>
-          </p:cNvSpPr>
-          <p:nvPr/>
-        </p:nvSpPr>
-        <p:spPr>
-          <a:xfrm>
-            <a:off x="359532" y="1207321"/>
-            <a:ext cx="8424467" cy="3332402"/>
-          </a:xfrm>
-          <a:prstGeom prst="rect">
-            <a:avLst/>
-          </a:prstGeom>
-        </p:spPr>
-        <p:txBody>
-          <a:bodyPr vert="horz" lIns="36000" tIns="36000" rIns="36000" bIns="36000" rtlCol="0" anchor="t">
-            <a:normAutofit/>
-          </a:bodyPr>
-          <a:lstStyle>
-            <a:lvl1pPr marL="216000" indent="-216000" algn="l" defTabSz="685800" rtl="0" eaLnBrk="1" latinLnBrk="0" hangingPunct="1">
-              <a:lnSpc>
-                <a:spcPct val="100000"/>
-              </a:lnSpc>
-              <a:spcBef>
-                <a:spcPts val="200"/>
-              </a:spcBef>
-              <a:buClr>
-                <a:schemeClr val="tx1"/>
-              </a:buClr>
-              <a:buFont typeface="Symbol" panose="05050102010706020507" pitchFamily="18" charset="2"/>
-              <a:buChar char="-"/>
-              <a:defRPr sz="1800" kern="1200">
-                <a:solidFill>
-                  <a:schemeClr val="tx1"/>
-                </a:solidFill>
-                <a:latin typeface="+mn-lt"/>
-                <a:ea typeface="+mn-ea"/>
-                <a:cs typeface="+mn-cs"/>
-              </a:defRPr>
-            </a:lvl1pPr>
-            <a:lvl2pPr marL="432000" indent="-216000" algn="l" defTabSz="685800" rtl="0" eaLnBrk="1" latinLnBrk="0" hangingPunct="1">
-              <a:lnSpc>
-                <a:spcPct val="100000"/>
-              </a:lnSpc>
-              <a:spcBef>
-                <a:spcPts val="200"/>
-              </a:spcBef>
-              <a:buFont typeface="Symbol" panose="05050102010706020507" pitchFamily="18" charset="2"/>
-              <a:buChar char="-"/>
-              <a:defRPr sz="1600" kern="1200">
-                <a:solidFill>
-                  <a:schemeClr val="tx1"/>
-                </a:solidFill>
-                <a:latin typeface="+mn-lt"/>
-                <a:ea typeface="+mn-ea"/>
-                <a:cs typeface="+mn-cs"/>
-              </a:defRPr>
-            </a:lvl2pPr>
-            <a:lvl3pPr marL="648000" indent="-216000" algn="l" defTabSz="685800" rtl="0" eaLnBrk="1" latinLnBrk="0" hangingPunct="1">
-              <a:lnSpc>
-                <a:spcPct val="100000"/>
-              </a:lnSpc>
-              <a:spcBef>
-                <a:spcPts val="200"/>
-              </a:spcBef>
-              <a:buFont typeface="Symbol" panose="05050102010706020507" pitchFamily="18" charset="2"/>
-              <a:buChar char="-"/>
-              <a:defRPr sz="1400" kern="1200">
-                <a:solidFill>
-                  <a:schemeClr val="tx1"/>
-                </a:solidFill>
-                <a:latin typeface="+mn-lt"/>
-                <a:ea typeface="+mn-ea"/>
-                <a:cs typeface="+mn-cs"/>
-              </a:defRPr>
-            </a:lvl3pPr>
-            <a:lvl4pPr marL="864000" indent="-216000" algn="l" defTabSz="685800" rtl="0" eaLnBrk="1" latinLnBrk="0" hangingPunct="1">
-              <a:lnSpc>
-                <a:spcPct val="100000"/>
-              </a:lnSpc>
-              <a:spcBef>
-                <a:spcPts val="200"/>
-              </a:spcBef>
-              <a:buFont typeface="Symbol" panose="05050102010706020507" pitchFamily="18" charset="2"/>
-              <a:buChar char="-"/>
-              <a:defRPr sz="1200" kern="1200">
-                <a:solidFill>
-                  <a:schemeClr val="tx1"/>
-                </a:solidFill>
-                <a:latin typeface="+mn-lt"/>
-                <a:ea typeface="+mn-ea"/>
-                <a:cs typeface="+mn-cs"/>
-              </a:defRPr>
-            </a:lvl4pPr>
-            <a:lvl5pPr marL="1080000" indent="-216000" algn="l" defTabSz="685800" rtl="0" eaLnBrk="1" latinLnBrk="0" hangingPunct="1">
-              <a:lnSpc>
-                <a:spcPct val="100000"/>
-              </a:lnSpc>
-              <a:spcBef>
-                <a:spcPts val="200"/>
-              </a:spcBef>
-              <a:buFont typeface="Symbol" panose="05050102010706020507" pitchFamily="18" charset="2"/>
-              <a:buChar char="-"/>
-              <a:defRPr sz="1100" kern="1200">
-                <a:solidFill>
-                  <a:schemeClr val="tx1"/>
-                </a:solidFill>
-                <a:latin typeface="+mn-lt"/>
-                <a:ea typeface="+mn-ea"/>
-                <a:cs typeface="+mn-cs"/>
-              </a:defRPr>
-            </a:lvl5pPr>
-            <a:lvl6pPr marL="1885950" indent="-171450" algn="l" defTabSz="685800" rtl="0" eaLnBrk="1" latinLnBrk="0" hangingPunct="1">
-              <a:lnSpc>
-                <a:spcPct val="90000"/>
-              </a:lnSpc>
-              <a:spcBef>
-                <a:spcPts val="375"/>
-              </a:spcBef>
-              <a:buFont typeface="Arial" panose="020B0604020202020204" pitchFamily="34" charset="0"/>
-              <a:buChar char="•"/>
-              <a:defRPr sz="1350" kern="1200">
-                <a:solidFill>
-                  <a:schemeClr val="tx1"/>
-                </a:solidFill>
-                <a:latin typeface="+mn-lt"/>
-                <a:ea typeface="+mn-ea"/>
-                <a:cs typeface="+mn-cs"/>
-              </a:defRPr>
-            </a:lvl6pPr>
-            <a:lvl7pPr marL="2228850" indent="-171450" algn="l" defTabSz="685800" rtl="0" eaLnBrk="1" latinLnBrk="0" hangingPunct="1">
-              <a:lnSpc>
-                <a:spcPct val="90000"/>
-              </a:lnSpc>
-              <a:spcBef>
-                <a:spcPts val="375"/>
-              </a:spcBef>
-              <a:buFont typeface="Arial" panose="020B0604020202020204" pitchFamily="34" charset="0"/>
-              <a:buChar char="•"/>
-              <a:defRPr sz="1350" kern="1200">
-                <a:solidFill>
-                  <a:schemeClr val="tx1"/>
-                </a:solidFill>
-                <a:latin typeface="+mn-lt"/>
-                <a:ea typeface="+mn-ea"/>
-                <a:cs typeface="+mn-cs"/>
-              </a:defRPr>
-            </a:lvl7pPr>
-            <a:lvl8pPr marL="2571750" indent="-171450" algn="l" defTabSz="685800" rtl="0" eaLnBrk="1" latinLnBrk="0" hangingPunct="1">
-              <a:lnSpc>
-                <a:spcPct val="90000"/>
-              </a:lnSpc>
-              <a:spcBef>
-                <a:spcPts val="375"/>
-              </a:spcBef>
-              <a:buFont typeface="Arial" panose="020B0604020202020204" pitchFamily="34" charset="0"/>
-              <a:buChar char="•"/>
-              <a:defRPr sz="1350" kern="1200">
-                <a:solidFill>
-                  <a:schemeClr val="tx1"/>
-                </a:solidFill>
-                <a:latin typeface="+mn-lt"/>
-                <a:ea typeface="+mn-ea"/>
-                <a:cs typeface="+mn-cs"/>
-              </a:defRPr>
-            </a:lvl8pPr>
-            <a:lvl9pPr marL="2914650" indent="-171450" algn="l" defTabSz="685800" rtl="0" eaLnBrk="1" latinLnBrk="0" hangingPunct="1">
-              <a:lnSpc>
-                <a:spcPct val="90000"/>
-              </a:lnSpc>
-              <a:spcBef>
-                <a:spcPts val="375"/>
-              </a:spcBef>
-              <a:buFont typeface="Arial" panose="020B0604020202020204" pitchFamily="34" charset="0"/>
-              <a:buChar char="•"/>
-              <a:defRPr sz="1350" kern="1200">
-                <a:solidFill>
-                  <a:schemeClr val="tx1"/>
-                </a:solidFill>
-                <a:latin typeface="+mn-lt"/>
-                <a:ea typeface="+mn-ea"/>
-                <a:cs typeface="+mn-cs"/>
-              </a:defRPr>
-            </a:lvl9pPr>
-          </a:lstStyle>
-          <a:p>
-            <a:pPr marL="0" indent="0">
-              <a:lnSpc>
-                <a:spcPct val="150000"/>
-              </a:lnSpc>
-              <a:buNone/>
-            </a:pPr>
-            <a:r>
-              <a:rPr lang="en-US" noProof="0" dirty="0"/>
-              <a:t>Across the 18 most popular Android categories:</a:t>
-            </a:r>
-          </a:p>
-          <a:p>
-            <a:pPr>
-              <a:lnSpc>
-                <a:spcPct val="150000"/>
-              </a:lnSpc>
-            </a:pPr>
-            <a:endParaRPr lang="en-US" noProof="0" dirty="0"/>
-          </a:p>
-          <a:p>
-            <a:pPr>
-              <a:lnSpc>
-                <a:spcPct val="150000"/>
-              </a:lnSpc>
-            </a:pPr>
-            <a:endParaRPr lang="en-US" noProof="0" dirty="0"/>
-          </a:p>
-        </p:txBody>
-      </p:sp>
-    </p:spTree>
-    <p:extLst>
-      <p:ext uri="{BB962C8B-B14F-4D97-AF65-F5344CB8AC3E}">
-        <p14:creationId xmlns:p14="http://schemas.microsoft.com/office/powerpoint/2010/main" val="3225203029"/>
-      </p:ext>
-    </p:extLst>
-  </p:cSld>
-  <p:clrMapOvr>
-    <a:masterClrMapping/>
-  </p:clrMapOvr>
-</p:sld>
-</file>
-
-<file path=ppt/slides/slide40.xml><?xml version="1.0" encoding="utf-8"?>
+<file path=ppt/slides/slide42.xml><?xml version="1.0" encoding="utf-8"?>
 <p:sld xmlns:a="http://schemas.openxmlformats.org/drawingml/2006/main" xmlns:r="http://schemas.openxmlformats.org/officeDocument/2006/relationships" xmlns:p="http://schemas.openxmlformats.org/presentationml/2006/main">
   <p:cSld>
     <p:spTree>
@@ -42559,7 +43413,7 @@
             <a:fld id="{E6639024-6672-4F87-864B-EA4FA9190A1A}" type="slidenum">
               <a:rPr lang="en-US" noProof="0" smtClean="0"/>
               <a:pPr/>
-              <a:t>40</a:t>
+              <a:t>42</a:t>
             </a:fld>
             <a:endParaRPr lang="en-US" noProof="0" dirty="0"/>
           </a:p>
@@ -42578,7 +43432,7 @@
 </p:sld>
 </file>
 
-<file path=ppt/slides/slide41.xml><?xml version="1.0" encoding="utf-8"?>
+<file path=ppt/slides/slide43.xml><?xml version="1.0" encoding="utf-8"?>
 <p:sld xmlns:a="http://schemas.openxmlformats.org/drawingml/2006/main" xmlns:r="http://schemas.openxmlformats.org/officeDocument/2006/relationships" xmlns:p="http://schemas.openxmlformats.org/presentationml/2006/main">
   <p:cSld>
     <p:spTree>
@@ -42799,7 +43653,7 @@
             <a:fld id="{E6639024-6672-4F87-864B-EA4FA9190A1A}" type="slidenum">
               <a:rPr lang="en-US" noProof="0" smtClean="0"/>
               <a:pPr/>
-              <a:t>41</a:t>
+              <a:t>43</a:t>
             </a:fld>
             <a:endParaRPr lang="en-US" noProof="0" dirty="0"/>
           </a:p>
@@ -42818,7 +43672,7 @@
 </p:sld>
 </file>
 
-<file path=ppt/slides/slide42.xml><?xml version="1.0" encoding="utf-8"?>
+<file path=ppt/slides/slide44.xml><?xml version="1.0" encoding="utf-8"?>
 <p:sld xmlns:a="http://schemas.openxmlformats.org/drawingml/2006/main" xmlns:r="http://schemas.openxmlformats.org/officeDocument/2006/relationships" xmlns:p="http://schemas.openxmlformats.org/presentationml/2006/main">
   <p:cSld>
     <p:spTree>
@@ -43039,7 +43893,7 @@
             <a:fld id="{E6639024-6672-4F87-864B-EA4FA9190A1A}" type="slidenum">
               <a:rPr lang="en-US" noProof="0" smtClean="0"/>
               <a:pPr/>
-              <a:t>42</a:t>
+              <a:t>44</a:t>
             </a:fld>
             <a:endParaRPr lang="en-US" noProof="0" dirty="0"/>
           </a:p>
@@ -43058,7 +43912,7 @@
 </p:sld>
 </file>
 
-<file path=ppt/slides/slide43.xml><?xml version="1.0" encoding="utf-8"?>
+<file path=ppt/slides/slide45.xml><?xml version="1.0" encoding="utf-8"?>
 <p:sld xmlns:a="http://schemas.openxmlformats.org/drawingml/2006/main" xmlns:r="http://schemas.openxmlformats.org/officeDocument/2006/relationships" xmlns:p="http://schemas.openxmlformats.org/presentationml/2006/main">
   <p:cSld>
     <p:spTree>
@@ -43279,7 +44133,7 @@
             <a:fld id="{E6639024-6672-4F87-864B-EA4FA9190A1A}" type="slidenum">
               <a:rPr lang="en-US" noProof="0" smtClean="0"/>
               <a:pPr/>
-              <a:t>43</a:t>
+              <a:t>45</a:t>
             </a:fld>
             <a:endParaRPr lang="en-US" noProof="0" dirty="0"/>
           </a:p>
@@ -43298,7 +44152,7 @@
 </p:sld>
 </file>
 
-<file path=ppt/slides/slide44.xml><?xml version="1.0" encoding="utf-8"?>
+<file path=ppt/slides/slide46.xml><?xml version="1.0" encoding="utf-8"?>
 <p:sld xmlns:a="http://schemas.openxmlformats.org/drawingml/2006/main" xmlns:r="http://schemas.openxmlformats.org/officeDocument/2006/relationships" xmlns:p="http://schemas.openxmlformats.org/presentationml/2006/main">
   <p:cSld>
     <p:spTree>
@@ -43411,10 +44265,11 @@
           <a:bodyPr anchor="t"/>
           <a:lstStyle/>
           <a:p>
-            <a:pPr>
+            <a:pPr marL="0" indent="0">
               <a:lnSpc>
                 <a:spcPct val="150000"/>
               </a:lnSpc>
+              <a:buNone/>
             </a:pPr>
             <a:r>
               <a:rPr lang="en-US" b="1" noProof="0" dirty="0"/>
@@ -43440,7 +44295,11 @@
             </a:pPr>
             <a:r>
               <a:rPr lang="en-US" noProof="0" dirty="0"/>
-              <a:t>Addressed them in a scalable and expandable way</a:t>
+              <a:t>Designed a </a:t>
+            </a:r>
+            <a:r>
+              <a:rPr lang="en-US" dirty="0"/>
+              <a:t>clean and scalable apps architecture</a:t>
             </a:r>
           </a:p>
           <a:p>
@@ -43550,7 +44409,7 @@
             <a:fld id="{E6639024-6672-4F87-864B-EA4FA9190A1A}" type="slidenum">
               <a:rPr lang="en-US" noProof="0" smtClean="0"/>
               <a:pPr/>
-              <a:t>44</a:t>
+              <a:t>46</a:t>
             </a:fld>
             <a:endParaRPr lang="en-US" noProof="0" dirty="0"/>
           </a:p>
@@ -43569,7 +44428,7 @@
 </p:sld>
 </file>
 
-<file path=ppt/slides/slide45.xml><?xml version="1.0" encoding="utf-8"?>
+<file path=ppt/slides/slide47.xml><?xml version="1.0" encoding="utf-8"?>
 <p:sld xmlns:a="http://schemas.openxmlformats.org/drawingml/2006/main" xmlns:r="http://schemas.openxmlformats.org/officeDocument/2006/relationships" xmlns:p="http://schemas.openxmlformats.org/presentationml/2006/main">
   <p:cSld>
     <p:spTree>
@@ -43758,7 +44617,7 @@
             <a:fld id="{E6639024-6672-4F87-864B-EA4FA9190A1A}" type="slidenum">
               <a:rPr lang="en-US" noProof="0" smtClean="0"/>
               <a:pPr/>
-              <a:t>45</a:t>
+              <a:t>47</a:t>
             </a:fld>
             <a:endParaRPr lang="en-US" noProof="0" dirty="0"/>
           </a:p>
@@ -43777,7 +44636,7 @@
 </p:sld>
 </file>
 
-<file path=ppt/slides/slide46.xml><?xml version="1.0" encoding="utf-8"?>
+<file path=ppt/slides/slide48.xml><?xml version="1.0" encoding="utf-8"?>
 <p:sld xmlns:a="http://schemas.openxmlformats.org/drawingml/2006/main" xmlns:r="http://schemas.openxmlformats.org/officeDocument/2006/relationships" xmlns:p="http://schemas.openxmlformats.org/presentationml/2006/main">
   <p:cSld>
     <p:spTree>
@@ -44046,7 +44905,7 @@
             <a:fld id="{E6639024-6672-4F87-864B-EA4FA9190A1A}" type="slidenum">
               <a:rPr lang="en-US" noProof="0" smtClean="0"/>
               <a:pPr/>
-              <a:t>46</a:t>
+              <a:t>48</a:t>
             </a:fld>
             <a:endParaRPr lang="en-US" noProof="0" dirty="0"/>
           </a:p>
@@ -44065,7 +44924,7 @@
 </p:sld>
 </file>
 
-<file path=ppt/slides/slide47.xml><?xml version="1.0" encoding="utf-8"?>
+<file path=ppt/slides/slide49.xml><?xml version="1.0" encoding="utf-8"?>
 <p:sld xmlns:a="http://schemas.openxmlformats.org/drawingml/2006/main" xmlns:r="http://schemas.openxmlformats.org/officeDocument/2006/relationships" xmlns:p="http://schemas.openxmlformats.org/presentationml/2006/main">
   <p:cSld>
     <p:spTree>
@@ -44446,7 +45305,7 @@
             <a:fld id="{E6639024-6672-4F87-864B-EA4FA9190A1A}" type="slidenum">
               <a:rPr lang="en-US" noProof="0" smtClean="0"/>
               <a:pPr/>
-              <a:t>47</a:t>
+              <a:t>49</a:t>
             </a:fld>
             <a:endParaRPr lang="en-US" noProof="0" dirty="0"/>
           </a:p>
@@ -44456,207 +45315,6 @@
     <p:extLst>
       <p:ext uri="{BB962C8B-B14F-4D97-AF65-F5344CB8AC3E}">
         <p14:creationId xmlns:p14="http://schemas.microsoft.com/office/powerpoint/2010/main" val="1316929055"/>
-      </p:ext>
-    </p:extLst>
-  </p:cSld>
-  <p:clrMapOvr>
-    <a:masterClrMapping/>
-  </p:clrMapOvr>
-</p:sld>
-</file>
-
-<file path=ppt/slides/slide48.xml><?xml version="1.0" encoding="utf-8"?>
-<p:sld xmlns:a="http://schemas.openxmlformats.org/drawingml/2006/main" xmlns:r="http://schemas.openxmlformats.org/officeDocument/2006/relationships" xmlns:p="http://schemas.openxmlformats.org/presentationml/2006/main">
-  <p:cSld>
-    <p:spTree>
-      <p:nvGrpSpPr>
-        <p:cNvPr id="1" name="">
-          <a:extLst>
-            <a:ext uri="{FF2B5EF4-FFF2-40B4-BE49-F238E27FC236}">
-              <a16:creationId xmlns:a16="http://schemas.microsoft.com/office/drawing/2014/main" id="{D4900803-E03E-4256-407B-FAE7CDFC165F}"/>
-            </a:ext>
-          </a:extLst>
-        </p:cNvPr>
-        <p:cNvGrpSpPr/>
-        <p:nvPr/>
-      </p:nvGrpSpPr>
-      <p:grpSpPr>
-        <a:xfrm>
-          <a:off x="0" y="0"/>
-          <a:ext cx="0" cy="0"/>
-          <a:chOff x="0" y="0"/>
-          <a:chExt cx="0" cy="0"/>
-        </a:xfrm>
-      </p:grpSpPr>
-      <p:sp>
-        <p:nvSpPr>
-          <p:cNvPr id="8" name="Textplatzhalter 7">
-            <a:extLst>
-              <a:ext uri="{FF2B5EF4-FFF2-40B4-BE49-F238E27FC236}">
-                <a16:creationId xmlns:a16="http://schemas.microsoft.com/office/drawing/2014/main" id="{181ABAB7-4944-26AF-8D85-744ECD9FD451}"/>
-              </a:ext>
-            </a:extLst>
-          </p:cNvPr>
-          <p:cNvSpPr>
-            <a:spLocks noGrp="1"/>
-          </p:cNvSpPr>
-          <p:nvPr>
-            <p:ph type="body" sz="quarter" idx="12"/>
-          </p:nvPr>
-        </p:nvSpPr>
-        <p:spPr/>
-        <p:txBody>
-          <a:bodyPr/>
-          <a:lstStyle/>
-          <a:p>
-            <a:endParaRPr lang="en-US" noProof="0" dirty="0"/>
-          </a:p>
-        </p:txBody>
-      </p:sp>
-      <p:sp>
-        <p:nvSpPr>
-          <p:cNvPr id="7" name="Titel 6">
-            <a:extLst>
-              <a:ext uri="{FF2B5EF4-FFF2-40B4-BE49-F238E27FC236}">
-                <a16:creationId xmlns:a16="http://schemas.microsoft.com/office/drawing/2014/main" id="{257B34DA-F6BC-04E0-7981-3F7D556C0B1F}"/>
-              </a:ext>
-            </a:extLst>
-          </p:cNvPr>
-          <p:cNvSpPr>
-            <a:spLocks noGrp="1"/>
-          </p:cNvSpPr>
-          <p:nvPr>
-            <p:ph type="title"/>
-          </p:nvPr>
-        </p:nvSpPr>
-        <p:spPr/>
-        <p:txBody>
-          <a:bodyPr/>
-          <a:lstStyle/>
-          <a:p>
-            <a:endParaRPr lang="en-US" noProof="0" dirty="0"/>
-          </a:p>
-        </p:txBody>
-      </p:sp>
-      <p:sp>
-        <p:nvSpPr>
-          <p:cNvPr id="10" name="Inhaltsplatzhalter 9">
-            <a:extLst>
-              <a:ext uri="{FF2B5EF4-FFF2-40B4-BE49-F238E27FC236}">
-                <a16:creationId xmlns:a16="http://schemas.microsoft.com/office/drawing/2014/main" id="{1DA1CC60-ABE8-FA5B-30CF-E47720B805DA}"/>
-              </a:ext>
-            </a:extLst>
-          </p:cNvPr>
-          <p:cNvSpPr>
-            <a:spLocks noGrp="1"/>
-          </p:cNvSpPr>
-          <p:nvPr>
-            <p:ph sz="quarter" idx="20"/>
-          </p:nvPr>
-        </p:nvSpPr>
-        <p:spPr>
-          <a:xfrm>
-            <a:off x="359533" y="1203598"/>
-            <a:ext cx="8424467" cy="3332402"/>
-          </a:xfrm>
-        </p:spPr>
-        <p:txBody>
-          <a:bodyPr anchor="t"/>
-          <a:lstStyle/>
-          <a:p>
-            <a:pPr>
-              <a:lnSpc>
-                <a:spcPct val="150000"/>
-              </a:lnSpc>
-            </a:pPr>
-            <a:endParaRPr lang="en-US" noProof="0" dirty="0"/>
-          </a:p>
-        </p:txBody>
-      </p:sp>
-      <p:sp>
-        <p:nvSpPr>
-          <p:cNvPr id="9" name="Textplatzhalter 8">
-            <a:extLst>
-              <a:ext uri="{FF2B5EF4-FFF2-40B4-BE49-F238E27FC236}">
-                <a16:creationId xmlns:a16="http://schemas.microsoft.com/office/drawing/2014/main" id="{3CF5D1FE-ADE6-CCE1-EE0E-EF9EF886F6F9}"/>
-              </a:ext>
-            </a:extLst>
-          </p:cNvPr>
-          <p:cNvSpPr>
-            <a:spLocks noGrp="1"/>
-          </p:cNvSpPr>
-          <p:nvPr>
-            <p:ph type="body" sz="quarter" idx="19"/>
-          </p:nvPr>
-        </p:nvSpPr>
-        <p:spPr/>
-        <p:txBody>
-          <a:bodyPr/>
-          <a:lstStyle/>
-          <a:p>
-            <a:endParaRPr lang="en-US" noProof="0" dirty="0"/>
-          </a:p>
-        </p:txBody>
-      </p:sp>
-      <p:sp>
-        <p:nvSpPr>
-          <p:cNvPr id="11" name="Fußzeilenplatzhalter 10">
-            <a:extLst>
-              <a:ext uri="{FF2B5EF4-FFF2-40B4-BE49-F238E27FC236}">
-                <a16:creationId xmlns:a16="http://schemas.microsoft.com/office/drawing/2014/main" id="{BD3BC772-1808-72C0-840C-4671D66F866E}"/>
-              </a:ext>
-            </a:extLst>
-          </p:cNvPr>
-          <p:cNvSpPr>
-            <a:spLocks noGrp="1"/>
-          </p:cNvSpPr>
-          <p:nvPr>
-            <p:ph type="ftr" sz="quarter" idx="17"/>
-          </p:nvPr>
-        </p:nvSpPr>
-        <p:spPr/>
-        <p:txBody>
-          <a:bodyPr/>
-          <a:lstStyle/>
-          <a:p>
-            <a:endParaRPr lang="en-US" noProof="0" dirty="0"/>
-          </a:p>
-        </p:txBody>
-      </p:sp>
-      <p:sp>
-        <p:nvSpPr>
-          <p:cNvPr id="12" name="Foliennummernplatzhalter 11">
-            <a:extLst>
-              <a:ext uri="{FF2B5EF4-FFF2-40B4-BE49-F238E27FC236}">
-                <a16:creationId xmlns:a16="http://schemas.microsoft.com/office/drawing/2014/main" id="{EAB3C26B-0B46-9A09-B6C8-9B7226ECB059}"/>
-              </a:ext>
-            </a:extLst>
-          </p:cNvPr>
-          <p:cNvSpPr>
-            <a:spLocks noGrp="1"/>
-          </p:cNvSpPr>
-          <p:nvPr>
-            <p:ph type="sldNum" sz="quarter" idx="18"/>
-          </p:nvPr>
-        </p:nvSpPr>
-        <p:spPr/>
-        <p:txBody>
-          <a:bodyPr/>
-          <a:lstStyle/>
-          <a:p>
-            <a:fld id="{E6639024-6672-4F87-864B-EA4FA9190A1A}" type="slidenum">
-              <a:rPr lang="en-US" noProof="0" smtClean="0"/>
-              <a:pPr/>
-              <a:t>48</a:t>
-            </a:fld>
-            <a:endParaRPr lang="en-US" noProof="0" dirty="0"/>
-          </a:p>
-        </p:txBody>
-      </p:sp>
-    </p:spTree>
-    <p:extLst>
-      <p:ext uri="{BB962C8B-B14F-4D97-AF65-F5344CB8AC3E}">
-        <p14:creationId xmlns:p14="http://schemas.microsoft.com/office/powerpoint/2010/main" val="2327944303"/>
       </p:ext>
     </p:extLst>
   </p:cSld>
@@ -45244,6 +45902,207 @@
     <p:extLst>
       <p:ext uri="{BB962C8B-B14F-4D97-AF65-F5344CB8AC3E}">
         <p14:creationId xmlns:p14="http://schemas.microsoft.com/office/powerpoint/2010/main" val="248474880"/>
+      </p:ext>
+    </p:extLst>
+  </p:cSld>
+  <p:clrMapOvr>
+    <a:masterClrMapping/>
+  </p:clrMapOvr>
+</p:sld>
+</file>
+
+<file path=ppt/slides/slide50.xml><?xml version="1.0" encoding="utf-8"?>
+<p:sld xmlns:a="http://schemas.openxmlformats.org/drawingml/2006/main" xmlns:r="http://schemas.openxmlformats.org/officeDocument/2006/relationships" xmlns:p="http://schemas.openxmlformats.org/presentationml/2006/main">
+  <p:cSld>
+    <p:spTree>
+      <p:nvGrpSpPr>
+        <p:cNvPr id="1" name="">
+          <a:extLst>
+            <a:ext uri="{FF2B5EF4-FFF2-40B4-BE49-F238E27FC236}">
+              <a16:creationId xmlns:a16="http://schemas.microsoft.com/office/drawing/2014/main" id="{D4900803-E03E-4256-407B-FAE7CDFC165F}"/>
+            </a:ext>
+          </a:extLst>
+        </p:cNvPr>
+        <p:cNvGrpSpPr/>
+        <p:nvPr/>
+      </p:nvGrpSpPr>
+      <p:grpSpPr>
+        <a:xfrm>
+          <a:off x="0" y="0"/>
+          <a:ext cx="0" cy="0"/>
+          <a:chOff x="0" y="0"/>
+          <a:chExt cx="0" cy="0"/>
+        </a:xfrm>
+      </p:grpSpPr>
+      <p:sp>
+        <p:nvSpPr>
+          <p:cNvPr id="8" name="Textplatzhalter 7">
+            <a:extLst>
+              <a:ext uri="{FF2B5EF4-FFF2-40B4-BE49-F238E27FC236}">
+                <a16:creationId xmlns:a16="http://schemas.microsoft.com/office/drawing/2014/main" id="{181ABAB7-4944-26AF-8D85-744ECD9FD451}"/>
+              </a:ext>
+            </a:extLst>
+          </p:cNvPr>
+          <p:cNvSpPr>
+            <a:spLocks noGrp="1"/>
+          </p:cNvSpPr>
+          <p:nvPr>
+            <p:ph type="body" sz="quarter" idx="12"/>
+          </p:nvPr>
+        </p:nvSpPr>
+        <p:spPr/>
+        <p:txBody>
+          <a:bodyPr/>
+          <a:lstStyle/>
+          <a:p>
+            <a:endParaRPr lang="en-US" noProof="0" dirty="0"/>
+          </a:p>
+        </p:txBody>
+      </p:sp>
+      <p:sp>
+        <p:nvSpPr>
+          <p:cNvPr id="7" name="Titel 6">
+            <a:extLst>
+              <a:ext uri="{FF2B5EF4-FFF2-40B4-BE49-F238E27FC236}">
+                <a16:creationId xmlns:a16="http://schemas.microsoft.com/office/drawing/2014/main" id="{257B34DA-F6BC-04E0-7981-3F7D556C0B1F}"/>
+              </a:ext>
+            </a:extLst>
+          </p:cNvPr>
+          <p:cNvSpPr>
+            <a:spLocks noGrp="1"/>
+          </p:cNvSpPr>
+          <p:nvPr>
+            <p:ph type="title"/>
+          </p:nvPr>
+        </p:nvSpPr>
+        <p:spPr/>
+        <p:txBody>
+          <a:bodyPr/>
+          <a:lstStyle/>
+          <a:p>
+            <a:endParaRPr lang="en-US" noProof="0" dirty="0"/>
+          </a:p>
+        </p:txBody>
+      </p:sp>
+      <p:sp>
+        <p:nvSpPr>
+          <p:cNvPr id="10" name="Inhaltsplatzhalter 9">
+            <a:extLst>
+              <a:ext uri="{FF2B5EF4-FFF2-40B4-BE49-F238E27FC236}">
+                <a16:creationId xmlns:a16="http://schemas.microsoft.com/office/drawing/2014/main" id="{1DA1CC60-ABE8-FA5B-30CF-E47720B805DA}"/>
+              </a:ext>
+            </a:extLst>
+          </p:cNvPr>
+          <p:cNvSpPr>
+            <a:spLocks noGrp="1"/>
+          </p:cNvSpPr>
+          <p:nvPr>
+            <p:ph sz="quarter" idx="20"/>
+          </p:nvPr>
+        </p:nvSpPr>
+        <p:spPr>
+          <a:xfrm>
+            <a:off x="359533" y="1203598"/>
+            <a:ext cx="8424467" cy="3332402"/>
+          </a:xfrm>
+        </p:spPr>
+        <p:txBody>
+          <a:bodyPr anchor="t"/>
+          <a:lstStyle/>
+          <a:p>
+            <a:pPr>
+              <a:lnSpc>
+                <a:spcPct val="150000"/>
+              </a:lnSpc>
+            </a:pPr>
+            <a:endParaRPr lang="en-US" noProof="0" dirty="0"/>
+          </a:p>
+        </p:txBody>
+      </p:sp>
+      <p:sp>
+        <p:nvSpPr>
+          <p:cNvPr id="9" name="Textplatzhalter 8">
+            <a:extLst>
+              <a:ext uri="{FF2B5EF4-FFF2-40B4-BE49-F238E27FC236}">
+                <a16:creationId xmlns:a16="http://schemas.microsoft.com/office/drawing/2014/main" id="{3CF5D1FE-ADE6-CCE1-EE0E-EF9EF886F6F9}"/>
+              </a:ext>
+            </a:extLst>
+          </p:cNvPr>
+          <p:cNvSpPr>
+            <a:spLocks noGrp="1"/>
+          </p:cNvSpPr>
+          <p:nvPr>
+            <p:ph type="body" sz="quarter" idx="19"/>
+          </p:nvPr>
+        </p:nvSpPr>
+        <p:spPr/>
+        <p:txBody>
+          <a:bodyPr/>
+          <a:lstStyle/>
+          <a:p>
+            <a:endParaRPr lang="en-US" noProof="0" dirty="0"/>
+          </a:p>
+        </p:txBody>
+      </p:sp>
+      <p:sp>
+        <p:nvSpPr>
+          <p:cNvPr id="11" name="Fußzeilenplatzhalter 10">
+            <a:extLst>
+              <a:ext uri="{FF2B5EF4-FFF2-40B4-BE49-F238E27FC236}">
+                <a16:creationId xmlns:a16="http://schemas.microsoft.com/office/drawing/2014/main" id="{BD3BC772-1808-72C0-840C-4671D66F866E}"/>
+              </a:ext>
+            </a:extLst>
+          </p:cNvPr>
+          <p:cNvSpPr>
+            <a:spLocks noGrp="1"/>
+          </p:cNvSpPr>
+          <p:nvPr>
+            <p:ph type="ftr" sz="quarter" idx="17"/>
+          </p:nvPr>
+        </p:nvSpPr>
+        <p:spPr/>
+        <p:txBody>
+          <a:bodyPr/>
+          <a:lstStyle/>
+          <a:p>
+            <a:endParaRPr lang="en-US" noProof="0" dirty="0"/>
+          </a:p>
+        </p:txBody>
+      </p:sp>
+      <p:sp>
+        <p:nvSpPr>
+          <p:cNvPr id="12" name="Foliennummernplatzhalter 11">
+            <a:extLst>
+              <a:ext uri="{FF2B5EF4-FFF2-40B4-BE49-F238E27FC236}">
+                <a16:creationId xmlns:a16="http://schemas.microsoft.com/office/drawing/2014/main" id="{EAB3C26B-0B46-9A09-B6C8-9B7226ECB059}"/>
+              </a:ext>
+            </a:extLst>
+          </p:cNvPr>
+          <p:cNvSpPr>
+            <a:spLocks noGrp="1"/>
+          </p:cNvSpPr>
+          <p:nvPr>
+            <p:ph type="sldNum" sz="quarter" idx="18"/>
+          </p:nvPr>
+        </p:nvSpPr>
+        <p:spPr/>
+        <p:txBody>
+          <a:bodyPr/>
+          <a:lstStyle/>
+          <a:p>
+            <a:fld id="{E6639024-6672-4F87-864B-EA4FA9190A1A}" type="slidenum">
+              <a:rPr lang="en-US" noProof="0" smtClean="0"/>
+              <a:pPr/>
+              <a:t>50</a:t>
+            </a:fld>
+            <a:endParaRPr lang="en-US" noProof="0" dirty="0"/>
+          </a:p>
+        </p:txBody>
+      </p:sp>
+    </p:spTree>
+    <p:extLst>
+      <p:ext uri="{BB962C8B-B14F-4D97-AF65-F5344CB8AC3E}">
+        <p14:creationId xmlns:p14="http://schemas.microsoft.com/office/powerpoint/2010/main" val="2327944303"/>
       </p:ext>
     </p:extLst>
   </p:cSld>
@@ -46206,29 +47065,31 @@
             </a:pPr>
             <a:r>
               <a:rPr lang="en-US" dirty="0"/>
-              <a:t>What to do?</a:t>
-            </a:r>
-          </a:p>
-          <a:p>
-            <a:pPr>
+              <a:t>What can be done about this?</a:t>
+            </a:r>
+          </a:p>
+          <a:p>
+            <a:pPr marL="0" indent="0">
               <a:lnSpc>
                 <a:spcPct val="150000"/>
               </a:lnSpc>
+              <a:buNone/>
             </a:pPr>
             <a:r>
               <a:rPr lang="en-US" dirty="0"/>
-              <a:t>Find existing vulnerabilities</a:t>
-            </a:r>
-          </a:p>
-          <a:p>
-            <a:pPr>
+              <a:t>☐ Find existing vulnerabilities</a:t>
+            </a:r>
+          </a:p>
+          <a:p>
+            <a:pPr marL="0" indent="0">
               <a:lnSpc>
                 <a:spcPct val="150000"/>
               </a:lnSpc>
+              <a:buNone/>
             </a:pPr>
             <a:r>
               <a:rPr lang="en-US" dirty="0"/>
-              <a:t>Prevent new vulnerabilities</a:t>
+              <a:t>☐ Prevent new vulnerabilities</a:t>
             </a:r>
           </a:p>
         </p:txBody>
@@ -46955,7 +47816,7 @@
             </a:pPr>
             <a:r>
               <a:rPr lang="en-US" dirty="0"/>
-              <a:t>	…benchmark and promote the best </a:t>
+              <a:t>	…promote the best </a:t>
             </a:r>
             <a:r>
               <a:rPr lang="en-US" b="1" dirty="0"/>

</xml_diff>

<commit_message>
Added titles to the plots of my BA thesis presentation, as well as other minor tweaks to the presentation slides
</commit_message>
<xml_diff>
--- a/dev_documents/presentation/ba_thesis_presentation_kronig.pptx
+++ b/dev_documents/presentation/ba_thesis_presentation_kronig.pptx
@@ -7,10 +7,10 @@
     <p:sldMasterId id="2147483793" r:id="rId3"/>
   </p:sldMasterIdLst>
   <p:notesMasterIdLst>
-    <p:notesMasterId r:id="rId54"/>
+    <p:notesMasterId r:id="rId55"/>
   </p:notesMasterIdLst>
   <p:handoutMasterIdLst>
-    <p:handoutMasterId r:id="rId55"/>
+    <p:handoutMasterId r:id="rId56"/>
   </p:handoutMasterIdLst>
   <p:sldIdLst>
     <p:sldId id="256" r:id="rId4"/>
@@ -22,47 +22,48 @@
     <p:sldId id="325" r:id="rId10"/>
     <p:sldId id="313" r:id="rId11"/>
     <p:sldId id="324" r:id="rId12"/>
-    <p:sldId id="330" r:id="rId13"/>
-    <p:sldId id="315" r:id="rId14"/>
-    <p:sldId id="316" r:id="rId15"/>
-    <p:sldId id="317" r:id="rId16"/>
-    <p:sldId id="290" r:id="rId17"/>
-    <p:sldId id="291" r:id="rId18"/>
-    <p:sldId id="274" r:id="rId19"/>
-    <p:sldId id="262" r:id="rId20"/>
-    <p:sldId id="273" r:id="rId21"/>
-    <p:sldId id="275" r:id="rId22"/>
-    <p:sldId id="326" r:id="rId23"/>
-    <p:sldId id="263" r:id="rId24"/>
-    <p:sldId id="277" r:id="rId25"/>
-    <p:sldId id="276" r:id="rId26"/>
-    <p:sldId id="278" r:id="rId27"/>
-    <p:sldId id="292" r:id="rId28"/>
-    <p:sldId id="281" r:id="rId29"/>
-    <p:sldId id="286" r:id="rId30"/>
-    <p:sldId id="287" r:id="rId31"/>
-    <p:sldId id="288" r:id="rId32"/>
-    <p:sldId id="289" r:id="rId33"/>
-    <p:sldId id="264" r:id="rId34"/>
-    <p:sldId id="293" r:id="rId35"/>
-    <p:sldId id="331" r:id="rId36"/>
-    <p:sldId id="294" r:id="rId37"/>
-    <p:sldId id="296" r:id="rId38"/>
-    <p:sldId id="297" r:id="rId39"/>
-    <p:sldId id="298" r:id="rId40"/>
-    <p:sldId id="295" r:id="rId41"/>
-    <p:sldId id="282" r:id="rId42"/>
-    <p:sldId id="301" r:id="rId43"/>
-    <p:sldId id="302" r:id="rId44"/>
-    <p:sldId id="283" r:id="rId45"/>
-    <p:sldId id="304" r:id="rId46"/>
-    <p:sldId id="305" r:id="rId47"/>
-    <p:sldId id="284" r:id="rId48"/>
-    <p:sldId id="285" r:id="rId49"/>
-    <p:sldId id="308" r:id="rId50"/>
-    <p:sldId id="307" r:id="rId51"/>
-    <p:sldId id="327" r:id="rId52"/>
-    <p:sldId id="306" r:id="rId53"/>
+    <p:sldId id="332" r:id="rId13"/>
+    <p:sldId id="330" r:id="rId14"/>
+    <p:sldId id="315" r:id="rId15"/>
+    <p:sldId id="316" r:id="rId16"/>
+    <p:sldId id="317" r:id="rId17"/>
+    <p:sldId id="290" r:id="rId18"/>
+    <p:sldId id="291" r:id="rId19"/>
+    <p:sldId id="274" r:id="rId20"/>
+    <p:sldId id="262" r:id="rId21"/>
+    <p:sldId id="273" r:id="rId22"/>
+    <p:sldId id="275" r:id="rId23"/>
+    <p:sldId id="326" r:id="rId24"/>
+    <p:sldId id="263" r:id="rId25"/>
+    <p:sldId id="277" r:id="rId26"/>
+    <p:sldId id="276" r:id="rId27"/>
+    <p:sldId id="278" r:id="rId28"/>
+    <p:sldId id="292" r:id="rId29"/>
+    <p:sldId id="335" r:id="rId30"/>
+    <p:sldId id="333" r:id="rId31"/>
+    <p:sldId id="334" r:id="rId32"/>
+    <p:sldId id="288" r:id="rId33"/>
+    <p:sldId id="289" r:id="rId34"/>
+    <p:sldId id="264" r:id="rId35"/>
+    <p:sldId id="293" r:id="rId36"/>
+    <p:sldId id="331" r:id="rId37"/>
+    <p:sldId id="294" r:id="rId38"/>
+    <p:sldId id="296" r:id="rId39"/>
+    <p:sldId id="297" r:id="rId40"/>
+    <p:sldId id="298" r:id="rId41"/>
+    <p:sldId id="295" r:id="rId42"/>
+    <p:sldId id="282" r:id="rId43"/>
+    <p:sldId id="301" r:id="rId44"/>
+    <p:sldId id="302" r:id="rId45"/>
+    <p:sldId id="283" r:id="rId46"/>
+    <p:sldId id="304" r:id="rId47"/>
+    <p:sldId id="305" r:id="rId48"/>
+    <p:sldId id="284" r:id="rId49"/>
+    <p:sldId id="285" r:id="rId50"/>
+    <p:sldId id="308" r:id="rId51"/>
+    <p:sldId id="307" r:id="rId52"/>
+    <p:sldId id="327" r:id="rId53"/>
+    <p:sldId id="306" r:id="rId54"/>
   </p:sldIdLst>
   <p:sldSz cx="9144000" cy="5143500" type="screen16x9"/>
   <p:notesSz cx="6858000" cy="9144000"/>
@@ -254,7 +255,7 @@
           <a:p>
             <a:fld id="{442B13D9-EE20-4263-A517-453A6CC03581}" type="datetimeFigureOut">
               <a:rPr lang="en-US" smtClean="0"/>
-              <a:t>2/5/2026</a:t>
+              <a:t>2/7/2026</a:t>
             </a:fld>
             <a:endParaRPr lang="en-US"/>
           </a:p>
@@ -419,7 +420,7 @@
           <a:p>
             <a:fld id="{C4B9E2E8-0589-406D-8FD1-7B0DBC84FBDE}" type="datetimeFigureOut">
               <a:rPr lang="de-CH" smtClean="0"/>
-              <a:t>05.02.2026</a:t>
+              <a:t>07.02.2026</a:t>
             </a:fld>
             <a:endParaRPr lang="de-CH"/>
           </a:p>
@@ -31446,6 +31447,423 @@
         <p:cNvPr id="1" name="">
           <a:extLst>
             <a:ext uri="{FF2B5EF4-FFF2-40B4-BE49-F238E27FC236}">
+              <a16:creationId xmlns:a16="http://schemas.microsoft.com/office/drawing/2014/main" id="{7AD7CCEB-EC9C-81C2-56E5-63FAFE94147D}"/>
+            </a:ext>
+          </a:extLst>
+        </p:cNvPr>
+        <p:cNvGrpSpPr/>
+        <p:nvPr/>
+      </p:nvGrpSpPr>
+      <p:grpSpPr>
+        <a:xfrm>
+          <a:off x="0" y="0"/>
+          <a:ext cx="0" cy="0"/>
+          <a:chOff x="0" y="0"/>
+          <a:chExt cx="0" cy="0"/>
+        </a:xfrm>
+      </p:grpSpPr>
+      <p:sp>
+        <p:nvSpPr>
+          <p:cNvPr id="8" name="Textplatzhalter 7">
+            <a:extLst>
+              <a:ext uri="{FF2B5EF4-FFF2-40B4-BE49-F238E27FC236}">
+                <a16:creationId xmlns:a16="http://schemas.microsoft.com/office/drawing/2014/main" id="{4A4FBC87-F219-6970-8421-413D8B6C8DFA}"/>
+              </a:ext>
+            </a:extLst>
+          </p:cNvPr>
+          <p:cNvSpPr>
+            <a:spLocks noGrp="1"/>
+          </p:cNvSpPr>
+          <p:nvPr>
+            <p:ph type="body" sz="quarter" idx="12"/>
+          </p:nvPr>
+        </p:nvSpPr>
+        <p:spPr/>
+        <p:txBody>
+          <a:bodyPr/>
+          <a:lstStyle/>
+          <a:p>
+            <a:r>
+              <a:rPr lang="en-US" noProof="0" dirty="0">
+                <a:solidFill>
+                  <a:schemeClr val="bg2"/>
+                </a:solidFill>
+              </a:rPr>
+              <a:t>The Causes</a:t>
+            </a:r>
+          </a:p>
+        </p:txBody>
+      </p:sp>
+      <p:sp>
+        <p:nvSpPr>
+          <p:cNvPr id="7" name="Titel 6">
+            <a:extLst>
+              <a:ext uri="{FF2B5EF4-FFF2-40B4-BE49-F238E27FC236}">
+                <a16:creationId xmlns:a16="http://schemas.microsoft.com/office/drawing/2014/main" id="{51372BE3-83D3-6344-0781-FFE9D2AE6669}"/>
+              </a:ext>
+            </a:extLst>
+          </p:cNvPr>
+          <p:cNvSpPr>
+            <a:spLocks noGrp="1"/>
+          </p:cNvSpPr>
+          <p:nvPr>
+            <p:ph type="title"/>
+          </p:nvPr>
+        </p:nvSpPr>
+        <p:spPr/>
+        <p:txBody>
+          <a:bodyPr/>
+          <a:lstStyle/>
+          <a:p>
+            <a:r>
+              <a:rPr lang="en-US" dirty="0">
+                <a:solidFill>
+                  <a:schemeClr val="tx1"/>
+                </a:solidFill>
+              </a:rPr>
+              <a:t>State of Android App Security</a:t>
+            </a:r>
+            <a:endParaRPr lang="en-US" noProof="0" dirty="0">
+              <a:solidFill>
+                <a:schemeClr val="tx1"/>
+              </a:solidFill>
+            </a:endParaRPr>
+          </a:p>
+        </p:txBody>
+      </p:sp>
+      <p:sp>
+        <p:nvSpPr>
+          <p:cNvPr id="9" name="Textplatzhalter 8">
+            <a:extLst>
+              <a:ext uri="{FF2B5EF4-FFF2-40B4-BE49-F238E27FC236}">
+                <a16:creationId xmlns:a16="http://schemas.microsoft.com/office/drawing/2014/main" id="{038E9439-892E-FC8C-7FB2-F5A581592DE8}"/>
+              </a:ext>
+            </a:extLst>
+          </p:cNvPr>
+          <p:cNvSpPr>
+            <a:spLocks noGrp="1"/>
+          </p:cNvSpPr>
+          <p:nvPr>
+            <p:ph type="body" sz="quarter" idx="19"/>
+          </p:nvPr>
+        </p:nvSpPr>
+        <p:spPr/>
+        <p:txBody>
+          <a:bodyPr/>
+          <a:lstStyle/>
+          <a:p>
+            <a:endParaRPr lang="en-US" noProof="0" dirty="0"/>
+          </a:p>
+        </p:txBody>
+      </p:sp>
+      <p:sp>
+        <p:nvSpPr>
+          <p:cNvPr id="11" name="Fußzeilenplatzhalter 10">
+            <a:extLst>
+              <a:ext uri="{FF2B5EF4-FFF2-40B4-BE49-F238E27FC236}">
+                <a16:creationId xmlns:a16="http://schemas.microsoft.com/office/drawing/2014/main" id="{E41A3795-B4C6-CA60-77E9-29E6DC6AD0EA}"/>
+              </a:ext>
+            </a:extLst>
+          </p:cNvPr>
+          <p:cNvSpPr>
+            <a:spLocks noGrp="1"/>
+          </p:cNvSpPr>
+          <p:nvPr>
+            <p:ph type="ftr" sz="quarter" idx="17"/>
+          </p:nvPr>
+        </p:nvSpPr>
+        <p:spPr/>
+        <p:txBody>
+          <a:bodyPr/>
+          <a:lstStyle/>
+          <a:p>
+            <a:endParaRPr lang="en-US" noProof="0" dirty="0"/>
+          </a:p>
+        </p:txBody>
+      </p:sp>
+      <p:sp>
+        <p:nvSpPr>
+          <p:cNvPr id="12" name="Foliennummernplatzhalter 11">
+            <a:extLst>
+              <a:ext uri="{FF2B5EF4-FFF2-40B4-BE49-F238E27FC236}">
+                <a16:creationId xmlns:a16="http://schemas.microsoft.com/office/drawing/2014/main" id="{32415A1A-755C-EDC4-5542-4E2338E787DA}"/>
+              </a:ext>
+            </a:extLst>
+          </p:cNvPr>
+          <p:cNvSpPr>
+            <a:spLocks noGrp="1"/>
+          </p:cNvSpPr>
+          <p:nvPr>
+            <p:ph type="sldNum" sz="quarter" idx="18"/>
+          </p:nvPr>
+        </p:nvSpPr>
+        <p:spPr/>
+        <p:txBody>
+          <a:bodyPr/>
+          <a:lstStyle/>
+          <a:p>
+            <a:fld id="{E6639024-6672-4F87-864B-EA4FA9190A1A}" type="slidenum">
+              <a:rPr lang="en-US" noProof="0" smtClean="0"/>
+              <a:pPr/>
+              <a:t>10</a:t>
+            </a:fld>
+            <a:endParaRPr lang="en-US" noProof="0" dirty="0"/>
+          </a:p>
+        </p:txBody>
+      </p:sp>
+      <p:sp>
+        <p:nvSpPr>
+          <p:cNvPr id="2" name="Inhaltsplatzhalter 9">
+            <a:extLst>
+              <a:ext uri="{FF2B5EF4-FFF2-40B4-BE49-F238E27FC236}">
+                <a16:creationId xmlns:a16="http://schemas.microsoft.com/office/drawing/2014/main" id="{527D5B62-9FAA-F21D-1333-063B246C9974}"/>
+              </a:ext>
+            </a:extLst>
+          </p:cNvPr>
+          <p:cNvSpPr txBox="1">
+            <a:spLocks/>
+          </p:cNvSpPr>
+          <p:nvPr/>
+        </p:nvSpPr>
+        <p:spPr>
+          <a:xfrm>
+            <a:off x="359532" y="1207321"/>
+            <a:ext cx="8424467" cy="3332402"/>
+          </a:xfrm>
+          <a:prstGeom prst="rect">
+            <a:avLst/>
+          </a:prstGeom>
+        </p:spPr>
+        <p:txBody>
+          <a:bodyPr vert="horz" lIns="36000" tIns="36000" rIns="36000" bIns="36000" rtlCol="0" anchor="t">
+            <a:normAutofit/>
+          </a:bodyPr>
+          <a:lstStyle>
+            <a:lvl1pPr marL="216000" indent="-216000" algn="l" defTabSz="685800" rtl="0" eaLnBrk="1" latinLnBrk="0" hangingPunct="1">
+              <a:lnSpc>
+                <a:spcPct val="100000"/>
+              </a:lnSpc>
+              <a:spcBef>
+                <a:spcPts val="200"/>
+              </a:spcBef>
+              <a:buClr>
+                <a:schemeClr val="tx1"/>
+              </a:buClr>
+              <a:buFont typeface="Symbol" panose="05050102010706020507" pitchFamily="18" charset="2"/>
+              <a:buChar char="-"/>
+              <a:defRPr sz="1800" kern="1200">
+                <a:solidFill>
+                  <a:schemeClr val="tx1"/>
+                </a:solidFill>
+                <a:latin typeface="+mn-lt"/>
+                <a:ea typeface="+mn-ea"/>
+                <a:cs typeface="+mn-cs"/>
+              </a:defRPr>
+            </a:lvl1pPr>
+            <a:lvl2pPr marL="432000" indent="-216000" algn="l" defTabSz="685800" rtl="0" eaLnBrk="1" latinLnBrk="0" hangingPunct="1">
+              <a:lnSpc>
+                <a:spcPct val="100000"/>
+              </a:lnSpc>
+              <a:spcBef>
+                <a:spcPts val="200"/>
+              </a:spcBef>
+              <a:buFont typeface="Symbol" panose="05050102010706020507" pitchFamily="18" charset="2"/>
+              <a:buChar char="-"/>
+              <a:defRPr sz="1600" kern="1200">
+                <a:solidFill>
+                  <a:schemeClr val="tx1"/>
+                </a:solidFill>
+                <a:latin typeface="+mn-lt"/>
+                <a:ea typeface="+mn-ea"/>
+                <a:cs typeface="+mn-cs"/>
+              </a:defRPr>
+            </a:lvl2pPr>
+            <a:lvl3pPr marL="648000" indent="-216000" algn="l" defTabSz="685800" rtl="0" eaLnBrk="1" latinLnBrk="0" hangingPunct="1">
+              <a:lnSpc>
+                <a:spcPct val="100000"/>
+              </a:lnSpc>
+              <a:spcBef>
+                <a:spcPts val="200"/>
+              </a:spcBef>
+              <a:buFont typeface="Symbol" panose="05050102010706020507" pitchFamily="18" charset="2"/>
+              <a:buChar char="-"/>
+              <a:defRPr sz="1400" kern="1200">
+                <a:solidFill>
+                  <a:schemeClr val="tx1"/>
+                </a:solidFill>
+                <a:latin typeface="+mn-lt"/>
+                <a:ea typeface="+mn-ea"/>
+                <a:cs typeface="+mn-cs"/>
+              </a:defRPr>
+            </a:lvl3pPr>
+            <a:lvl4pPr marL="864000" indent="-216000" algn="l" defTabSz="685800" rtl="0" eaLnBrk="1" latinLnBrk="0" hangingPunct="1">
+              <a:lnSpc>
+                <a:spcPct val="100000"/>
+              </a:lnSpc>
+              <a:spcBef>
+                <a:spcPts val="200"/>
+              </a:spcBef>
+              <a:buFont typeface="Symbol" panose="05050102010706020507" pitchFamily="18" charset="2"/>
+              <a:buChar char="-"/>
+              <a:defRPr sz="1200" kern="1200">
+                <a:solidFill>
+                  <a:schemeClr val="tx1"/>
+                </a:solidFill>
+                <a:latin typeface="+mn-lt"/>
+                <a:ea typeface="+mn-ea"/>
+                <a:cs typeface="+mn-cs"/>
+              </a:defRPr>
+            </a:lvl4pPr>
+            <a:lvl5pPr marL="1080000" indent="-216000" algn="l" defTabSz="685800" rtl="0" eaLnBrk="1" latinLnBrk="0" hangingPunct="1">
+              <a:lnSpc>
+                <a:spcPct val="100000"/>
+              </a:lnSpc>
+              <a:spcBef>
+                <a:spcPts val="200"/>
+              </a:spcBef>
+              <a:buFont typeface="Symbol" panose="05050102010706020507" pitchFamily="18" charset="2"/>
+              <a:buChar char="-"/>
+              <a:defRPr sz="1100" kern="1200">
+                <a:solidFill>
+                  <a:schemeClr val="tx1"/>
+                </a:solidFill>
+                <a:latin typeface="+mn-lt"/>
+                <a:ea typeface="+mn-ea"/>
+                <a:cs typeface="+mn-cs"/>
+              </a:defRPr>
+            </a:lvl5pPr>
+            <a:lvl6pPr marL="1885950" indent="-171450" algn="l" defTabSz="685800" rtl="0" eaLnBrk="1" latinLnBrk="0" hangingPunct="1">
+              <a:lnSpc>
+                <a:spcPct val="90000"/>
+              </a:lnSpc>
+              <a:spcBef>
+                <a:spcPts val="375"/>
+              </a:spcBef>
+              <a:buFont typeface="Arial" panose="020B0604020202020204" pitchFamily="34" charset="0"/>
+              <a:buChar char="•"/>
+              <a:defRPr sz="1350" kern="1200">
+                <a:solidFill>
+                  <a:schemeClr val="tx1"/>
+                </a:solidFill>
+                <a:latin typeface="+mn-lt"/>
+                <a:ea typeface="+mn-ea"/>
+                <a:cs typeface="+mn-cs"/>
+              </a:defRPr>
+            </a:lvl6pPr>
+            <a:lvl7pPr marL="2228850" indent="-171450" algn="l" defTabSz="685800" rtl="0" eaLnBrk="1" latinLnBrk="0" hangingPunct="1">
+              <a:lnSpc>
+                <a:spcPct val="90000"/>
+              </a:lnSpc>
+              <a:spcBef>
+                <a:spcPts val="375"/>
+              </a:spcBef>
+              <a:buFont typeface="Arial" panose="020B0604020202020204" pitchFamily="34" charset="0"/>
+              <a:buChar char="•"/>
+              <a:defRPr sz="1350" kern="1200">
+                <a:solidFill>
+                  <a:schemeClr val="tx1"/>
+                </a:solidFill>
+                <a:latin typeface="+mn-lt"/>
+                <a:ea typeface="+mn-ea"/>
+                <a:cs typeface="+mn-cs"/>
+              </a:defRPr>
+            </a:lvl7pPr>
+            <a:lvl8pPr marL="2571750" indent="-171450" algn="l" defTabSz="685800" rtl="0" eaLnBrk="1" latinLnBrk="0" hangingPunct="1">
+              <a:lnSpc>
+                <a:spcPct val="90000"/>
+              </a:lnSpc>
+              <a:spcBef>
+                <a:spcPts val="375"/>
+              </a:spcBef>
+              <a:buFont typeface="Arial" panose="020B0604020202020204" pitchFamily="34" charset="0"/>
+              <a:buChar char="•"/>
+              <a:defRPr sz="1350" kern="1200">
+                <a:solidFill>
+                  <a:schemeClr val="tx1"/>
+                </a:solidFill>
+                <a:latin typeface="+mn-lt"/>
+                <a:ea typeface="+mn-ea"/>
+                <a:cs typeface="+mn-cs"/>
+              </a:defRPr>
+            </a:lvl8pPr>
+            <a:lvl9pPr marL="2914650" indent="-171450" algn="l" defTabSz="685800" rtl="0" eaLnBrk="1" latinLnBrk="0" hangingPunct="1">
+              <a:lnSpc>
+                <a:spcPct val="90000"/>
+              </a:lnSpc>
+              <a:spcBef>
+                <a:spcPts val="375"/>
+              </a:spcBef>
+              <a:buFont typeface="Arial" panose="020B0604020202020204" pitchFamily="34" charset="0"/>
+              <a:buChar char="•"/>
+              <a:defRPr sz="1350" kern="1200">
+                <a:solidFill>
+                  <a:schemeClr val="tx1"/>
+                </a:solidFill>
+                <a:latin typeface="+mn-lt"/>
+                <a:ea typeface="+mn-ea"/>
+                <a:cs typeface="+mn-cs"/>
+              </a:defRPr>
+            </a:lvl9pPr>
+          </a:lstStyle>
+          <a:p>
+            <a:pPr marL="0" indent="0">
+              <a:lnSpc>
+                <a:spcPct val="150000"/>
+              </a:lnSpc>
+              <a:buNone/>
+            </a:pPr>
+            <a:r>
+              <a:rPr lang="en-US" dirty="0"/>
+              <a:t>What can be done about this?</a:t>
+            </a:r>
+          </a:p>
+          <a:p>
+            <a:pPr marL="0" indent="0">
+              <a:lnSpc>
+                <a:spcPct val="150000"/>
+              </a:lnSpc>
+              <a:buNone/>
+            </a:pPr>
+            <a:r>
+              <a:rPr lang="en-US" dirty="0"/>
+              <a:t>🗹 Find existing vulnerabilities</a:t>
+            </a:r>
+          </a:p>
+          <a:p>
+            <a:pPr marL="0" indent="0">
+              <a:lnSpc>
+                <a:spcPct val="150000"/>
+              </a:lnSpc>
+              <a:buNone/>
+            </a:pPr>
+            <a:r>
+              <a:rPr lang="en-US" dirty="0"/>
+              <a:t>☐ Prevent new vulnerabilities</a:t>
+            </a:r>
+          </a:p>
+        </p:txBody>
+      </p:sp>
+    </p:spTree>
+    <p:extLst>
+      <p:ext uri="{BB962C8B-B14F-4D97-AF65-F5344CB8AC3E}">
+        <p14:creationId xmlns:p14="http://schemas.microsoft.com/office/powerpoint/2010/main" val="2196692478"/>
+      </p:ext>
+    </p:extLst>
+  </p:cSld>
+  <p:clrMapOvr>
+    <a:masterClrMapping/>
+  </p:clrMapOvr>
+</p:sld>
+</file>
+
+<file path=ppt/slides/slide11.xml><?xml version="1.0" encoding="utf-8"?>
+<p:sld xmlns:a="http://schemas.openxmlformats.org/drawingml/2006/main" xmlns:r="http://schemas.openxmlformats.org/officeDocument/2006/relationships" xmlns:p="http://schemas.openxmlformats.org/presentationml/2006/main">
+  <p:cSld>
+    <p:spTree>
+      <p:nvGrpSpPr>
+        <p:cNvPr id="1" name="">
+          <a:extLst>
+            <a:ext uri="{FF2B5EF4-FFF2-40B4-BE49-F238E27FC236}">
               <a16:creationId xmlns:a16="http://schemas.microsoft.com/office/drawing/2014/main" id="{FCF8C2E8-6FBF-0F6F-0B3B-93E3FEAD7254}"/>
             </a:ext>
           </a:extLst>
@@ -31604,7 +32022,7 @@
             <a:fld id="{E6639024-6672-4F87-864B-EA4FA9190A1A}" type="slidenum">
               <a:rPr lang="en-US" noProof="0" smtClean="0"/>
               <a:pPr/>
-              <a:t>10</a:t>
+              <a:t>11</a:t>
             </a:fld>
             <a:endParaRPr lang="en-US" noProof="0" dirty="0"/>
           </a:p>
@@ -31855,7 +32273,7 @@
 </p:sld>
 </file>
 
-<file path=ppt/slides/slide11.xml><?xml version="1.0" encoding="utf-8"?>
+<file path=ppt/slides/slide12.xml><?xml version="1.0" encoding="utf-8"?>
 <p:sld xmlns:a="http://schemas.openxmlformats.org/drawingml/2006/main" xmlns:r="http://schemas.openxmlformats.org/officeDocument/2006/relationships" xmlns:p="http://schemas.openxmlformats.org/presentationml/2006/main">
   <p:cSld>
     <p:spTree>
@@ -31905,7 +32323,7 @@
                   <a:schemeClr val="bg2"/>
                 </a:solidFill>
               </a:rPr>
-              <a:t>Mobile Security Knowledge</a:t>
+              <a:t>Making Mobile Security More Accessible</a:t>
             </a:r>
             <a:endParaRPr lang="en-US" noProof="0" dirty="0">
               <a:solidFill>
@@ -31980,18 +32398,6 @@
             </a:pPr>
             <a:r>
               <a:rPr lang="en-US" dirty="0"/>
-              <a:t>“Make mobile security knowledge more accessible”</a:t>
-            </a:r>
-            <a:endParaRPr lang="en-US" noProof="0" dirty="0"/>
-          </a:p>
-          <a:p>
-            <a:pPr>
-              <a:lnSpc>
-                <a:spcPct val="150000"/>
-              </a:lnSpc>
-            </a:pPr>
-            <a:r>
-              <a:rPr lang="en-US" dirty="0"/>
               <a:t>OWASP</a:t>
             </a:r>
             <a:r>
@@ -32113,7 +32519,7 @@
             <a:fld id="{E6639024-6672-4F87-864B-EA4FA9190A1A}" type="slidenum">
               <a:rPr lang="en-US" noProof="0" smtClean="0"/>
               <a:pPr/>
-              <a:t>11</a:t>
+              <a:t>12</a:t>
             </a:fld>
             <a:endParaRPr lang="en-US" noProof="0" dirty="0"/>
           </a:p>
@@ -32132,7 +32538,7 @@
 </p:sld>
 </file>
 
-<file path=ppt/slides/slide12.xml><?xml version="1.0" encoding="utf-8"?>
+<file path=ppt/slides/slide13.xml><?xml version="1.0" encoding="utf-8"?>
 <p:sld xmlns:a="http://schemas.openxmlformats.org/drawingml/2006/main" xmlns:r="http://schemas.openxmlformats.org/officeDocument/2006/relationships" xmlns:p="http://schemas.openxmlformats.org/presentationml/2006/main">
   <p:cSld>
     <p:spTree>
@@ -32220,17 +32626,6 @@
             </a:pPr>
             <a:r>
               <a:rPr lang="en-US" dirty="0"/>
-              <a:t>“Promote the best security testing tools”</a:t>
-            </a:r>
-          </a:p>
-          <a:p>
-            <a:pPr>
-              <a:lnSpc>
-                <a:spcPct val="150000"/>
-              </a:lnSpc>
-            </a:pPr>
-            <a:r>
-              <a:rPr lang="en-US" dirty="0"/>
               <a:t>Tools for vulnerability detection</a:t>
             </a:r>
             <a:endParaRPr lang="en-US" b="1" dirty="0"/>
@@ -32272,14 +32667,6 @@
             <a:r>
               <a:rPr lang="en-US" dirty="0"/>
               <a:t>ecurity </a:t>
-            </a:r>
-            <a:r>
-              <a:rPr lang="en-US" b="1" dirty="0"/>
-              <a:t>A</a:t>
-            </a:r>
-            <a:r>
-              <a:rPr lang="en-US" dirty="0"/>
-              <a:t>nalysis </a:t>
             </a:r>
             <a:r>
               <a:rPr lang="en-US" b="1" dirty="0"/>
@@ -32412,7 +32799,7 @@
             <a:fld id="{E6639024-6672-4F87-864B-EA4FA9190A1A}" type="slidenum">
               <a:rPr lang="en-US" noProof="0" smtClean="0"/>
               <a:pPr/>
-              <a:t>12</a:t>
+              <a:t>13</a:t>
             </a:fld>
             <a:endParaRPr lang="en-US" noProof="0" dirty="0"/>
           </a:p>
@@ -32445,7 +32832,7 @@
                   <a:schemeClr val="bg2"/>
                 </a:solidFill>
               </a:rPr>
-              <a:t>Security Testing Tools</a:t>
+              <a:t>Promoting the Best Security Testing Tools</a:t>
             </a:r>
             <a:endParaRPr lang="en-US" noProof="0" dirty="0">
               <a:solidFill>
@@ -32468,7 +32855,7 @@
 </p:sld>
 </file>
 
-<file path=ppt/slides/slide13.xml><?xml version="1.0" encoding="utf-8"?>
+<file path=ppt/slides/slide14.xml><?xml version="1.0" encoding="utf-8"?>
 <p:sld xmlns:a="http://schemas.openxmlformats.org/drawingml/2006/main" xmlns:r="http://schemas.openxmlformats.org/officeDocument/2006/relationships" xmlns:p="http://schemas.openxmlformats.org/presentationml/2006/main">
   <p:cSld>
     <p:spTree>
@@ -32684,7 +33071,7 @@
             <a:fld id="{E6639024-6672-4F87-864B-EA4FA9190A1A}" type="slidenum">
               <a:rPr lang="en-US" noProof="0" smtClean="0"/>
               <a:pPr/>
-              <a:t>13</a:t>
+              <a:t>14</a:t>
             </a:fld>
             <a:endParaRPr lang="en-US" noProof="0" dirty="0"/>
           </a:p>
@@ -32740,7 +33127,7 @@
 </p:sld>
 </file>
 
-<file path=ppt/slides/slide14.xml><?xml version="1.0" encoding="utf-8"?>
+<file path=ppt/slides/slide15.xml><?xml version="1.0" encoding="utf-8"?>
 <p:sld xmlns:a="http://schemas.openxmlformats.org/drawingml/2006/main" xmlns:r="http://schemas.openxmlformats.org/officeDocument/2006/relationships" xmlns:p="http://schemas.openxmlformats.org/presentationml/2006/main">
   <p:cSld>
     <p:spTree>
@@ -33016,7 +33403,7 @@
             <a:fld id="{E6639024-6672-4F87-864B-EA4FA9190A1A}" type="slidenum">
               <a:rPr lang="en-US" noProof="0" smtClean="0"/>
               <a:pPr/>
-              <a:t>14</a:t>
+              <a:t>15</a:t>
             </a:fld>
             <a:endParaRPr lang="en-US" noProof="0" dirty="0"/>
           </a:p>
@@ -33035,7 +33422,7 @@
 </p:sld>
 </file>
 
-<file path=ppt/slides/slide15.xml><?xml version="1.0" encoding="utf-8"?>
+<file path=ppt/slides/slide16.xml><?xml version="1.0" encoding="utf-8"?>
 <p:sld xmlns:a="http://schemas.openxmlformats.org/drawingml/2006/main" xmlns:r="http://schemas.openxmlformats.org/officeDocument/2006/relationships" xmlns:p="http://schemas.openxmlformats.org/presentationml/2006/main">
   <p:cSld>
     <p:spTree>
@@ -33243,7 +33630,7 @@
             <a:fld id="{E6639024-6672-4F87-864B-EA4FA9190A1A}" type="slidenum">
               <a:rPr lang="en-US" noProof="0" smtClean="0"/>
               <a:pPr/>
-              <a:t>15</a:t>
+              <a:t>16</a:t>
             </a:fld>
             <a:endParaRPr lang="en-US" noProof="0" dirty="0"/>
           </a:p>
@@ -33593,7 +33980,7 @@
 </p:sld>
 </file>
 
-<file path=ppt/slides/slide16.xml><?xml version="1.0" encoding="utf-8"?>
+<file path=ppt/slides/slide17.xml><?xml version="1.0" encoding="utf-8"?>
 <p:sld xmlns:a="http://schemas.openxmlformats.org/drawingml/2006/main" xmlns:r="http://schemas.openxmlformats.org/officeDocument/2006/relationships" xmlns:p="http://schemas.openxmlformats.org/presentationml/2006/main">
   <p:cSld>
     <p:spTree>
@@ -33786,7 +34173,7 @@
             <a:fld id="{E6639024-6672-4F87-864B-EA4FA9190A1A}" type="slidenum">
               <a:rPr lang="en-US" noProof="0" smtClean="0"/>
               <a:pPr/>
-              <a:t>16</a:t>
+              <a:t>17</a:t>
             </a:fld>
             <a:endParaRPr lang="en-US" noProof="0" dirty="0"/>
           </a:p>
@@ -33805,7 +34192,7 @@
 </p:sld>
 </file>
 
-<file path=ppt/slides/slide17.xml><?xml version="1.0" encoding="utf-8"?>
+<file path=ppt/slides/slide18.xml><?xml version="1.0" encoding="utf-8"?>
 <p:sld xmlns:a="http://schemas.openxmlformats.org/drawingml/2006/main" xmlns:r="http://schemas.openxmlformats.org/officeDocument/2006/relationships" xmlns:p="http://schemas.openxmlformats.org/presentationml/2006/main">
   <p:cSld>
     <p:spTree>
@@ -34053,7 +34440,7 @@
             <a:fld id="{E6639024-6672-4F87-864B-EA4FA9190A1A}" type="slidenum">
               <a:rPr lang="en-US" noProof="0" smtClean="0"/>
               <a:pPr/>
-              <a:t>17</a:t>
+              <a:t>18</a:t>
             </a:fld>
             <a:endParaRPr lang="en-US" noProof="0" dirty="0"/>
           </a:p>
@@ -34072,7 +34459,7 @@
 </p:sld>
 </file>
 
-<file path=ppt/slides/slide18.xml><?xml version="1.0" encoding="utf-8"?>
+<file path=ppt/slides/slide19.xml><?xml version="1.0" encoding="utf-8"?>
 <p:sld xmlns:a="http://schemas.openxmlformats.org/drawingml/2006/main" xmlns:r="http://schemas.openxmlformats.org/officeDocument/2006/relationships" xmlns:p="http://schemas.openxmlformats.org/presentationml/2006/main">
   <p:cSld>
     <p:spTree>
@@ -34298,7 +34685,7 @@
             <a:fld id="{E6639024-6672-4F87-864B-EA4FA9190A1A}" type="slidenum">
               <a:rPr lang="en-US" noProof="0" smtClean="0"/>
               <a:pPr/>
-              <a:t>18</a:t>
+              <a:t>19</a:t>
             </a:fld>
             <a:endParaRPr lang="en-US" noProof="0" dirty="0"/>
           </a:p>
@@ -34308,249 +34695,6 @@
     <p:extLst>
       <p:ext uri="{BB962C8B-B14F-4D97-AF65-F5344CB8AC3E}">
         <p14:creationId xmlns:p14="http://schemas.microsoft.com/office/powerpoint/2010/main" val="2199029289"/>
-      </p:ext>
-    </p:extLst>
-  </p:cSld>
-  <p:clrMapOvr>
-    <a:masterClrMapping/>
-  </p:clrMapOvr>
-</p:sld>
-</file>
-
-<file path=ppt/slides/slide19.xml><?xml version="1.0" encoding="utf-8"?>
-<p:sld xmlns:a="http://schemas.openxmlformats.org/drawingml/2006/main" xmlns:r="http://schemas.openxmlformats.org/officeDocument/2006/relationships" xmlns:p="http://schemas.openxmlformats.org/presentationml/2006/main">
-  <p:cSld>
-    <p:spTree>
-      <p:nvGrpSpPr>
-        <p:cNvPr id="1" name="">
-          <a:extLst>
-            <a:ext uri="{FF2B5EF4-FFF2-40B4-BE49-F238E27FC236}">
-              <a16:creationId xmlns:a16="http://schemas.microsoft.com/office/drawing/2014/main" id="{5F733B7E-72D3-1709-B65C-B3D8DC6981C8}"/>
-            </a:ext>
-          </a:extLst>
-        </p:cNvPr>
-        <p:cNvGrpSpPr/>
-        <p:nvPr/>
-      </p:nvGrpSpPr>
-      <p:grpSpPr>
-        <a:xfrm>
-          <a:off x="0" y="0"/>
-          <a:ext cx="0" cy="0"/>
-          <a:chOff x="0" y="0"/>
-          <a:chExt cx="0" cy="0"/>
-        </a:xfrm>
-      </p:grpSpPr>
-      <p:sp>
-        <p:nvSpPr>
-          <p:cNvPr id="8" name="Textplatzhalter 7">
-            <a:extLst>
-              <a:ext uri="{FF2B5EF4-FFF2-40B4-BE49-F238E27FC236}">
-                <a16:creationId xmlns:a16="http://schemas.microsoft.com/office/drawing/2014/main" id="{DD381B2E-4AFF-D4C0-6343-A568834FB8D9}"/>
-              </a:ext>
-            </a:extLst>
-          </p:cNvPr>
-          <p:cNvSpPr>
-            <a:spLocks noGrp="1"/>
-          </p:cNvSpPr>
-          <p:nvPr>
-            <p:ph type="body" sz="quarter" idx="12"/>
-          </p:nvPr>
-        </p:nvSpPr>
-        <p:spPr/>
-        <p:txBody>
-          <a:bodyPr/>
-          <a:lstStyle/>
-          <a:p>
-            <a:r>
-              <a:rPr lang="en-US" dirty="0">
-                <a:solidFill>
-                  <a:schemeClr val="bg2"/>
-                </a:solidFill>
-              </a:rPr>
-              <a:t>Findings</a:t>
-            </a:r>
-            <a:endParaRPr lang="en-US" noProof="0" dirty="0">
-              <a:solidFill>
-                <a:schemeClr val="bg2"/>
-              </a:solidFill>
-            </a:endParaRPr>
-          </a:p>
-        </p:txBody>
-      </p:sp>
-      <p:sp>
-        <p:nvSpPr>
-          <p:cNvPr id="7" name="Titel 6">
-            <a:extLst>
-              <a:ext uri="{FF2B5EF4-FFF2-40B4-BE49-F238E27FC236}">
-                <a16:creationId xmlns:a16="http://schemas.microsoft.com/office/drawing/2014/main" id="{1ED5E6CC-8E9C-6CB3-1CF2-68F978E8BC6C}"/>
-              </a:ext>
-            </a:extLst>
-          </p:cNvPr>
-          <p:cNvSpPr>
-            <a:spLocks noGrp="1"/>
-          </p:cNvSpPr>
-          <p:nvPr>
-            <p:ph type="title"/>
-          </p:nvPr>
-        </p:nvSpPr>
-        <p:spPr/>
-        <p:txBody>
-          <a:bodyPr/>
-          <a:lstStyle/>
-          <a:p>
-            <a:r>
-              <a:rPr lang="en-US" dirty="0">
-                <a:solidFill>
-                  <a:schemeClr val="tx1"/>
-                </a:solidFill>
-              </a:rPr>
-              <a:t>Connection to Academia</a:t>
-            </a:r>
-          </a:p>
-        </p:txBody>
-      </p:sp>
-      <p:sp>
-        <p:nvSpPr>
-          <p:cNvPr id="10" name="Inhaltsplatzhalter 9">
-            <a:extLst>
-              <a:ext uri="{FF2B5EF4-FFF2-40B4-BE49-F238E27FC236}">
-                <a16:creationId xmlns:a16="http://schemas.microsoft.com/office/drawing/2014/main" id="{79C9BA29-3B39-660E-ABE9-719786955148}"/>
-              </a:ext>
-            </a:extLst>
-          </p:cNvPr>
-          <p:cNvSpPr>
-            <a:spLocks noGrp="1"/>
-          </p:cNvSpPr>
-          <p:nvPr>
-            <p:ph sz="quarter" idx="20"/>
-          </p:nvPr>
-        </p:nvSpPr>
-        <p:spPr>
-          <a:xfrm>
-            <a:off x="359533" y="1203598"/>
-            <a:ext cx="8424467" cy="3332402"/>
-          </a:xfrm>
-        </p:spPr>
-        <p:txBody>
-          <a:bodyPr anchor="t"/>
-          <a:lstStyle/>
-          <a:p>
-            <a:pPr marL="0" indent="0">
-              <a:lnSpc>
-                <a:spcPct val="150000"/>
-              </a:lnSpc>
-              <a:buNone/>
-            </a:pPr>
-            <a:r>
-              <a:rPr lang="en-US" noProof="0" dirty="0"/>
-              <a:t>MASTG reference apps used for:</a:t>
-            </a:r>
-          </a:p>
-          <a:p>
-            <a:pPr>
-              <a:lnSpc>
-                <a:spcPct val="150000"/>
-              </a:lnSpc>
-            </a:pPr>
-            <a:r>
-              <a:rPr lang="en-US" dirty="0"/>
-              <a:t>Developing &amp; t</a:t>
-            </a:r>
-            <a:r>
-              <a:rPr lang="en-US" noProof="0" dirty="0" err="1"/>
-              <a:t>esting</a:t>
-            </a:r>
-            <a:r>
-              <a:rPr lang="en-US" noProof="0" dirty="0"/>
-              <a:t> tools</a:t>
-            </a:r>
-          </a:p>
-        </p:txBody>
-      </p:sp>
-      <p:sp>
-        <p:nvSpPr>
-          <p:cNvPr id="9" name="Textplatzhalter 8">
-            <a:extLst>
-              <a:ext uri="{FF2B5EF4-FFF2-40B4-BE49-F238E27FC236}">
-                <a16:creationId xmlns:a16="http://schemas.microsoft.com/office/drawing/2014/main" id="{948CA5CC-A51D-381C-6849-0D90C9D653FA}"/>
-              </a:ext>
-            </a:extLst>
-          </p:cNvPr>
-          <p:cNvSpPr>
-            <a:spLocks noGrp="1"/>
-          </p:cNvSpPr>
-          <p:nvPr>
-            <p:ph type="body" sz="quarter" idx="19"/>
-          </p:nvPr>
-        </p:nvSpPr>
-        <p:spPr/>
-        <p:txBody>
-          <a:bodyPr/>
-          <a:lstStyle/>
-          <a:p>
-            <a:endParaRPr lang="en-US" noProof="0" dirty="0"/>
-          </a:p>
-        </p:txBody>
-      </p:sp>
-      <p:sp>
-        <p:nvSpPr>
-          <p:cNvPr id="11" name="Fußzeilenplatzhalter 10">
-            <a:extLst>
-              <a:ext uri="{FF2B5EF4-FFF2-40B4-BE49-F238E27FC236}">
-                <a16:creationId xmlns:a16="http://schemas.microsoft.com/office/drawing/2014/main" id="{0BBC15E4-EE0A-3CA4-5E66-8A0625B0233A}"/>
-              </a:ext>
-            </a:extLst>
-          </p:cNvPr>
-          <p:cNvSpPr>
-            <a:spLocks noGrp="1"/>
-          </p:cNvSpPr>
-          <p:nvPr>
-            <p:ph type="ftr" sz="quarter" idx="17"/>
-          </p:nvPr>
-        </p:nvSpPr>
-        <p:spPr/>
-        <p:txBody>
-          <a:bodyPr/>
-          <a:lstStyle/>
-          <a:p>
-            <a:endParaRPr lang="en-US" noProof="0" dirty="0"/>
-          </a:p>
-        </p:txBody>
-      </p:sp>
-      <p:sp>
-        <p:nvSpPr>
-          <p:cNvPr id="12" name="Foliennummernplatzhalter 11">
-            <a:extLst>
-              <a:ext uri="{FF2B5EF4-FFF2-40B4-BE49-F238E27FC236}">
-                <a16:creationId xmlns:a16="http://schemas.microsoft.com/office/drawing/2014/main" id="{09BAEEFB-D1F0-912C-1FBB-43BC11BF7729}"/>
-              </a:ext>
-            </a:extLst>
-          </p:cNvPr>
-          <p:cNvSpPr>
-            <a:spLocks noGrp="1"/>
-          </p:cNvSpPr>
-          <p:nvPr>
-            <p:ph type="sldNum" sz="quarter" idx="18"/>
-          </p:nvPr>
-        </p:nvSpPr>
-        <p:spPr/>
-        <p:txBody>
-          <a:bodyPr/>
-          <a:lstStyle/>
-          <a:p>
-            <a:fld id="{E6639024-6672-4F87-864B-EA4FA9190A1A}" type="slidenum">
-              <a:rPr lang="en-US" noProof="0" smtClean="0"/>
-              <a:pPr/>
-              <a:t>19</a:t>
-            </a:fld>
-            <a:endParaRPr lang="en-US" noProof="0" dirty="0"/>
-          </a:p>
-        </p:txBody>
-      </p:sp>
-    </p:spTree>
-    <p:extLst>
-      <p:ext uri="{BB962C8B-B14F-4D97-AF65-F5344CB8AC3E}">
-        <p14:creationId xmlns:p14="http://schemas.microsoft.com/office/powerpoint/2010/main" val="1307421813"/>
       </p:ext>
     </p:extLst>
   </p:cSld>
@@ -34724,8 +34868,17 @@
             </a:pPr>
             <a:r>
               <a:rPr lang="en-US" i="1" noProof="0" dirty="0"/>
-              <a:t>Vulnerabilities</a:t>
-            </a:r>
+              <a:t>Prone </a:t>
+            </a:r>
+            <a:r>
+              <a:rPr lang="en-US" i="1" dirty="0"/>
+              <a:t>to v</a:t>
+            </a:r>
+            <a:r>
+              <a:rPr lang="en-US" i="1" noProof="0" dirty="0" err="1"/>
+              <a:t>ulnerabilities</a:t>
+            </a:r>
+            <a:endParaRPr lang="en-US" i="1" noProof="0" dirty="0"/>
           </a:p>
           <a:p>
             <a:pPr>
@@ -34886,6 +35039,249 @@
         <p:cNvPr id="1" name="">
           <a:extLst>
             <a:ext uri="{FF2B5EF4-FFF2-40B4-BE49-F238E27FC236}">
+              <a16:creationId xmlns:a16="http://schemas.microsoft.com/office/drawing/2014/main" id="{5F733B7E-72D3-1709-B65C-B3D8DC6981C8}"/>
+            </a:ext>
+          </a:extLst>
+        </p:cNvPr>
+        <p:cNvGrpSpPr/>
+        <p:nvPr/>
+      </p:nvGrpSpPr>
+      <p:grpSpPr>
+        <a:xfrm>
+          <a:off x="0" y="0"/>
+          <a:ext cx="0" cy="0"/>
+          <a:chOff x="0" y="0"/>
+          <a:chExt cx="0" cy="0"/>
+        </a:xfrm>
+      </p:grpSpPr>
+      <p:sp>
+        <p:nvSpPr>
+          <p:cNvPr id="8" name="Textplatzhalter 7">
+            <a:extLst>
+              <a:ext uri="{FF2B5EF4-FFF2-40B4-BE49-F238E27FC236}">
+                <a16:creationId xmlns:a16="http://schemas.microsoft.com/office/drawing/2014/main" id="{DD381B2E-4AFF-D4C0-6343-A568834FB8D9}"/>
+              </a:ext>
+            </a:extLst>
+          </p:cNvPr>
+          <p:cNvSpPr>
+            <a:spLocks noGrp="1"/>
+          </p:cNvSpPr>
+          <p:nvPr>
+            <p:ph type="body" sz="quarter" idx="12"/>
+          </p:nvPr>
+        </p:nvSpPr>
+        <p:spPr/>
+        <p:txBody>
+          <a:bodyPr/>
+          <a:lstStyle/>
+          <a:p>
+            <a:r>
+              <a:rPr lang="en-US" dirty="0">
+                <a:solidFill>
+                  <a:schemeClr val="bg2"/>
+                </a:solidFill>
+              </a:rPr>
+              <a:t>Findings</a:t>
+            </a:r>
+            <a:endParaRPr lang="en-US" noProof="0" dirty="0">
+              <a:solidFill>
+                <a:schemeClr val="bg2"/>
+              </a:solidFill>
+            </a:endParaRPr>
+          </a:p>
+        </p:txBody>
+      </p:sp>
+      <p:sp>
+        <p:nvSpPr>
+          <p:cNvPr id="7" name="Titel 6">
+            <a:extLst>
+              <a:ext uri="{FF2B5EF4-FFF2-40B4-BE49-F238E27FC236}">
+                <a16:creationId xmlns:a16="http://schemas.microsoft.com/office/drawing/2014/main" id="{1ED5E6CC-8E9C-6CB3-1CF2-68F978E8BC6C}"/>
+              </a:ext>
+            </a:extLst>
+          </p:cNvPr>
+          <p:cNvSpPr>
+            <a:spLocks noGrp="1"/>
+          </p:cNvSpPr>
+          <p:nvPr>
+            <p:ph type="title"/>
+          </p:nvPr>
+        </p:nvSpPr>
+        <p:spPr/>
+        <p:txBody>
+          <a:bodyPr/>
+          <a:lstStyle/>
+          <a:p>
+            <a:r>
+              <a:rPr lang="en-US" dirty="0">
+                <a:solidFill>
+                  <a:schemeClr val="tx1"/>
+                </a:solidFill>
+              </a:rPr>
+              <a:t>Connection to Academia</a:t>
+            </a:r>
+          </a:p>
+        </p:txBody>
+      </p:sp>
+      <p:sp>
+        <p:nvSpPr>
+          <p:cNvPr id="10" name="Inhaltsplatzhalter 9">
+            <a:extLst>
+              <a:ext uri="{FF2B5EF4-FFF2-40B4-BE49-F238E27FC236}">
+                <a16:creationId xmlns:a16="http://schemas.microsoft.com/office/drawing/2014/main" id="{79C9BA29-3B39-660E-ABE9-719786955148}"/>
+              </a:ext>
+            </a:extLst>
+          </p:cNvPr>
+          <p:cNvSpPr>
+            <a:spLocks noGrp="1"/>
+          </p:cNvSpPr>
+          <p:nvPr>
+            <p:ph sz="quarter" idx="20"/>
+          </p:nvPr>
+        </p:nvSpPr>
+        <p:spPr>
+          <a:xfrm>
+            <a:off x="359533" y="1203598"/>
+            <a:ext cx="8424467" cy="3332402"/>
+          </a:xfrm>
+        </p:spPr>
+        <p:txBody>
+          <a:bodyPr anchor="t"/>
+          <a:lstStyle/>
+          <a:p>
+            <a:pPr marL="0" indent="0">
+              <a:lnSpc>
+                <a:spcPct val="150000"/>
+              </a:lnSpc>
+              <a:buNone/>
+            </a:pPr>
+            <a:r>
+              <a:rPr lang="en-US" noProof="0" dirty="0"/>
+              <a:t>MASTG reference apps used for:</a:t>
+            </a:r>
+          </a:p>
+          <a:p>
+            <a:pPr>
+              <a:lnSpc>
+                <a:spcPct val="150000"/>
+              </a:lnSpc>
+            </a:pPr>
+            <a:r>
+              <a:rPr lang="en-US" dirty="0"/>
+              <a:t>Developing &amp; t</a:t>
+            </a:r>
+            <a:r>
+              <a:rPr lang="en-US" noProof="0" dirty="0" err="1"/>
+              <a:t>esting</a:t>
+            </a:r>
+            <a:r>
+              <a:rPr lang="en-US" noProof="0" dirty="0"/>
+              <a:t> tools</a:t>
+            </a:r>
+          </a:p>
+        </p:txBody>
+      </p:sp>
+      <p:sp>
+        <p:nvSpPr>
+          <p:cNvPr id="9" name="Textplatzhalter 8">
+            <a:extLst>
+              <a:ext uri="{FF2B5EF4-FFF2-40B4-BE49-F238E27FC236}">
+                <a16:creationId xmlns:a16="http://schemas.microsoft.com/office/drawing/2014/main" id="{948CA5CC-A51D-381C-6849-0D90C9D653FA}"/>
+              </a:ext>
+            </a:extLst>
+          </p:cNvPr>
+          <p:cNvSpPr>
+            <a:spLocks noGrp="1"/>
+          </p:cNvSpPr>
+          <p:nvPr>
+            <p:ph type="body" sz="quarter" idx="19"/>
+          </p:nvPr>
+        </p:nvSpPr>
+        <p:spPr/>
+        <p:txBody>
+          <a:bodyPr/>
+          <a:lstStyle/>
+          <a:p>
+            <a:endParaRPr lang="en-US" noProof="0" dirty="0"/>
+          </a:p>
+        </p:txBody>
+      </p:sp>
+      <p:sp>
+        <p:nvSpPr>
+          <p:cNvPr id="11" name="Fußzeilenplatzhalter 10">
+            <a:extLst>
+              <a:ext uri="{FF2B5EF4-FFF2-40B4-BE49-F238E27FC236}">
+                <a16:creationId xmlns:a16="http://schemas.microsoft.com/office/drawing/2014/main" id="{0BBC15E4-EE0A-3CA4-5E66-8A0625B0233A}"/>
+              </a:ext>
+            </a:extLst>
+          </p:cNvPr>
+          <p:cNvSpPr>
+            <a:spLocks noGrp="1"/>
+          </p:cNvSpPr>
+          <p:nvPr>
+            <p:ph type="ftr" sz="quarter" idx="17"/>
+          </p:nvPr>
+        </p:nvSpPr>
+        <p:spPr/>
+        <p:txBody>
+          <a:bodyPr/>
+          <a:lstStyle/>
+          <a:p>
+            <a:endParaRPr lang="en-US" noProof="0" dirty="0"/>
+          </a:p>
+        </p:txBody>
+      </p:sp>
+      <p:sp>
+        <p:nvSpPr>
+          <p:cNvPr id="12" name="Foliennummernplatzhalter 11">
+            <a:extLst>
+              <a:ext uri="{FF2B5EF4-FFF2-40B4-BE49-F238E27FC236}">
+                <a16:creationId xmlns:a16="http://schemas.microsoft.com/office/drawing/2014/main" id="{09BAEEFB-D1F0-912C-1FBB-43BC11BF7729}"/>
+              </a:ext>
+            </a:extLst>
+          </p:cNvPr>
+          <p:cNvSpPr>
+            <a:spLocks noGrp="1"/>
+          </p:cNvSpPr>
+          <p:nvPr>
+            <p:ph type="sldNum" sz="quarter" idx="18"/>
+          </p:nvPr>
+        </p:nvSpPr>
+        <p:spPr/>
+        <p:txBody>
+          <a:bodyPr/>
+          <a:lstStyle/>
+          <a:p>
+            <a:fld id="{E6639024-6672-4F87-864B-EA4FA9190A1A}" type="slidenum">
+              <a:rPr lang="en-US" noProof="0" smtClean="0"/>
+              <a:pPr/>
+              <a:t>20</a:t>
+            </a:fld>
+            <a:endParaRPr lang="en-US" noProof="0" dirty="0"/>
+          </a:p>
+        </p:txBody>
+      </p:sp>
+    </p:spTree>
+    <p:extLst>
+      <p:ext uri="{BB962C8B-B14F-4D97-AF65-F5344CB8AC3E}">
+        <p14:creationId xmlns:p14="http://schemas.microsoft.com/office/powerpoint/2010/main" val="1307421813"/>
+      </p:ext>
+    </p:extLst>
+  </p:cSld>
+  <p:clrMapOvr>
+    <a:masterClrMapping/>
+  </p:clrMapOvr>
+</p:sld>
+</file>
+
+<file path=ppt/slides/slide21.xml><?xml version="1.0" encoding="utf-8"?>
+<p:sld xmlns:a="http://schemas.openxmlformats.org/drawingml/2006/main" xmlns:r="http://schemas.openxmlformats.org/officeDocument/2006/relationships" xmlns:p="http://schemas.openxmlformats.org/presentationml/2006/main">
+  <p:cSld>
+    <p:spTree>
+      <p:nvGrpSpPr>
+        <p:cNvPr id="1" name="">
+          <a:extLst>
+            <a:ext uri="{FF2B5EF4-FFF2-40B4-BE49-F238E27FC236}">
               <a16:creationId xmlns:a16="http://schemas.microsoft.com/office/drawing/2014/main" id="{8604C0DE-1380-91C2-0F3C-7B21E37677AE}"/>
             </a:ext>
           </a:extLst>
@@ -35117,7 +35513,7 @@
             <a:fld id="{E6639024-6672-4F87-864B-EA4FA9190A1A}" type="slidenum">
               <a:rPr lang="en-US" noProof="0" smtClean="0"/>
               <a:pPr/>
-              <a:t>20</a:t>
+              <a:t>21</a:t>
             </a:fld>
             <a:endParaRPr lang="en-US" noProof="0" dirty="0"/>
           </a:p>
@@ -35136,7 +35532,7 @@
 </p:sld>
 </file>
 
-<file path=ppt/slides/slide21.xml><?xml version="1.0" encoding="utf-8"?>
+<file path=ppt/slides/slide22.xml><?xml version="1.0" encoding="utf-8"?>
 <p:sld xmlns:a="http://schemas.openxmlformats.org/drawingml/2006/main" xmlns:r="http://schemas.openxmlformats.org/officeDocument/2006/relationships" xmlns:p="http://schemas.openxmlformats.org/presentationml/2006/main">
   <p:cSld>
     <p:spTree>
@@ -35351,7 +35747,7 @@
             <a:fld id="{E6639024-6672-4F87-864B-EA4FA9190A1A}" type="slidenum">
               <a:rPr lang="en-US" noProof="0" smtClean="0"/>
               <a:pPr/>
-              <a:t>21</a:t>
+              <a:t>22</a:t>
             </a:fld>
             <a:endParaRPr lang="en-US" noProof="0" dirty="0"/>
           </a:p>
@@ -35370,7 +35766,7 @@
 </p:sld>
 </file>
 
-<file path=ppt/slides/slide22.xml><?xml version="1.0" encoding="utf-8"?>
+<file path=ppt/slides/slide23.xml><?xml version="1.0" encoding="utf-8"?>
 <p:sld xmlns:a="http://schemas.openxmlformats.org/drawingml/2006/main" xmlns:r="http://schemas.openxmlformats.org/officeDocument/2006/relationships" xmlns:p="http://schemas.openxmlformats.org/presentationml/2006/main">
   <p:cSld>
     <p:spTree>
@@ -35607,7 +36003,7 @@
             <a:fld id="{E6639024-6672-4F87-864B-EA4FA9190A1A}" type="slidenum">
               <a:rPr lang="en-US" noProof="0" smtClean="0"/>
               <a:pPr/>
-              <a:t>22</a:t>
+              <a:t>23</a:t>
             </a:fld>
             <a:endParaRPr lang="en-US" noProof="0" dirty="0"/>
           </a:p>
@@ -35626,7 +36022,7 @@
 </p:sld>
 </file>
 
-<file path=ppt/slides/slide23.xml><?xml version="1.0" encoding="utf-8"?>
+<file path=ppt/slides/slide24.xml><?xml version="1.0" encoding="utf-8"?>
 <p:sld xmlns:a="http://schemas.openxmlformats.org/drawingml/2006/main" xmlns:r="http://schemas.openxmlformats.org/officeDocument/2006/relationships" xmlns:p="http://schemas.openxmlformats.org/presentationml/2006/main">
   <p:cSld>
     <p:spTree>
@@ -35945,7 +36341,7 @@
             <a:fld id="{E6639024-6672-4F87-864B-EA4FA9190A1A}" type="slidenum">
               <a:rPr lang="en-US" noProof="0" smtClean="0"/>
               <a:pPr/>
-              <a:t>23</a:t>
+              <a:t>24</a:t>
             </a:fld>
             <a:endParaRPr lang="en-US" noProof="0" dirty="0"/>
           </a:p>
@@ -35964,7 +36360,7 @@
 </p:sld>
 </file>
 
-<file path=ppt/slides/slide24.xml><?xml version="1.0" encoding="utf-8"?>
+<file path=ppt/slides/slide25.xml><?xml version="1.0" encoding="utf-8"?>
 <p:sld xmlns:a="http://schemas.openxmlformats.org/drawingml/2006/main" xmlns:r="http://schemas.openxmlformats.org/officeDocument/2006/relationships" xmlns:p="http://schemas.openxmlformats.org/presentationml/2006/main">
   <p:cSld>
     <p:spTree>
@@ -36213,7 +36609,7 @@
             <a:fld id="{E6639024-6672-4F87-864B-EA4FA9190A1A}" type="slidenum">
               <a:rPr lang="en-US" noProof="0" smtClean="0"/>
               <a:pPr/>
-              <a:t>24</a:t>
+              <a:t>25</a:t>
             </a:fld>
             <a:endParaRPr lang="en-US" noProof="0" dirty="0"/>
           </a:p>
@@ -36232,7 +36628,7 @@
 </p:sld>
 </file>
 
-<file path=ppt/slides/slide25.xml><?xml version="1.0" encoding="utf-8"?>
+<file path=ppt/slides/slide26.xml><?xml version="1.0" encoding="utf-8"?>
 <p:sld xmlns:a="http://schemas.openxmlformats.org/drawingml/2006/main" xmlns:r="http://schemas.openxmlformats.org/officeDocument/2006/relationships" xmlns:p="http://schemas.openxmlformats.org/presentationml/2006/main">
   <p:cSld>
     <p:spTree>
@@ -36458,7 +36854,7 @@
             <a:fld id="{E6639024-6672-4F87-864B-EA4FA9190A1A}" type="slidenum">
               <a:rPr lang="en-US" noProof="0" smtClean="0"/>
               <a:pPr/>
-              <a:t>25</a:t>
+              <a:t>26</a:t>
             </a:fld>
             <a:endParaRPr lang="en-US" noProof="0" dirty="0"/>
           </a:p>
@@ -36468,304 +36864,6 @@
     <p:extLst>
       <p:ext uri="{BB962C8B-B14F-4D97-AF65-F5344CB8AC3E}">
         <p14:creationId xmlns:p14="http://schemas.microsoft.com/office/powerpoint/2010/main" val="4215819408"/>
-      </p:ext>
-    </p:extLst>
-  </p:cSld>
-  <p:clrMapOvr>
-    <a:masterClrMapping/>
-  </p:clrMapOvr>
-</p:sld>
-</file>
-
-<file path=ppt/slides/slide26.xml><?xml version="1.0" encoding="utf-8"?>
-<p:sld xmlns:a="http://schemas.openxmlformats.org/drawingml/2006/main" xmlns:r="http://schemas.openxmlformats.org/officeDocument/2006/relationships" xmlns:p="http://schemas.openxmlformats.org/presentationml/2006/main">
-  <p:cSld>
-    <p:spTree>
-      <p:nvGrpSpPr>
-        <p:cNvPr id="1" name="">
-          <a:extLst>
-            <a:ext uri="{FF2B5EF4-FFF2-40B4-BE49-F238E27FC236}">
-              <a16:creationId xmlns:a16="http://schemas.microsoft.com/office/drawing/2014/main" id="{7D59C200-C32E-0A2F-B9F6-73EF7AFBEFF8}"/>
-            </a:ext>
-          </a:extLst>
-        </p:cNvPr>
-        <p:cNvGrpSpPr/>
-        <p:nvPr/>
-      </p:nvGrpSpPr>
-      <p:grpSpPr>
-        <a:xfrm>
-          <a:off x="0" y="0"/>
-          <a:ext cx="0" cy="0"/>
-          <a:chOff x="0" y="0"/>
-          <a:chExt cx="0" cy="0"/>
-        </a:xfrm>
-      </p:grpSpPr>
-      <p:sp>
-        <p:nvSpPr>
-          <p:cNvPr id="8" name="Textplatzhalter 7">
-            <a:extLst>
-              <a:ext uri="{FF2B5EF4-FFF2-40B4-BE49-F238E27FC236}">
-                <a16:creationId xmlns:a16="http://schemas.microsoft.com/office/drawing/2014/main" id="{81EA6906-DE83-D868-78EC-96D02556B0F1}"/>
-              </a:ext>
-            </a:extLst>
-          </p:cNvPr>
-          <p:cNvSpPr>
-            <a:spLocks noGrp="1"/>
-          </p:cNvSpPr>
-          <p:nvPr>
-            <p:ph type="body" sz="quarter" idx="12"/>
-          </p:nvPr>
-        </p:nvSpPr>
-        <p:spPr/>
-        <p:txBody>
-          <a:bodyPr/>
-          <a:lstStyle/>
-          <a:p>
-            <a:r>
-              <a:rPr lang="en-US" dirty="0">
-                <a:solidFill>
-                  <a:schemeClr val="bg2"/>
-                </a:solidFill>
-              </a:rPr>
-              <a:t>Skewered Coverage of Vulnerability Types</a:t>
-            </a:r>
-            <a:endParaRPr lang="en-US" noProof="0" dirty="0">
-              <a:solidFill>
-                <a:schemeClr val="bg2"/>
-              </a:solidFill>
-            </a:endParaRPr>
-          </a:p>
-        </p:txBody>
-      </p:sp>
-      <p:sp>
-        <p:nvSpPr>
-          <p:cNvPr id="7" name="Titel 6">
-            <a:extLst>
-              <a:ext uri="{FF2B5EF4-FFF2-40B4-BE49-F238E27FC236}">
-                <a16:creationId xmlns:a16="http://schemas.microsoft.com/office/drawing/2014/main" id="{0B665C04-AF5B-5616-9DFA-738B89A7611D}"/>
-              </a:ext>
-            </a:extLst>
-          </p:cNvPr>
-          <p:cNvSpPr>
-            <a:spLocks noGrp="1"/>
-          </p:cNvSpPr>
-          <p:nvPr>
-            <p:ph type="title"/>
-          </p:nvPr>
-        </p:nvSpPr>
-        <p:spPr/>
-        <p:txBody>
-          <a:bodyPr/>
-          <a:lstStyle/>
-          <a:p>
-            <a:r>
-              <a:rPr lang="en-US" dirty="0">
-                <a:solidFill>
-                  <a:schemeClr val="tx1"/>
-                </a:solidFill>
-              </a:rPr>
-              <a:t>State of the Art in MASTG Reference Apps</a:t>
-            </a:r>
-            <a:endParaRPr lang="en-US" noProof="0" dirty="0">
-              <a:solidFill>
-                <a:schemeClr val="tx1"/>
-              </a:solidFill>
-            </a:endParaRPr>
-          </a:p>
-        </p:txBody>
-      </p:sp>
-      <p:sp>
-        <p:nvSpPr>
-          <p:cNvPr id="10" name="Inhaltsplatzhalter 9">
-            <a:extLst>
-              <a:ext uri="{FF2B5EF4-FFF2-40B4-BE49-F238E27FC236}">
-                <a16:creationId xmlns:a16="http://schemas.microsoft.com/office/drawing/2014/main" id="{B61C4AA6-DE64-4849-5979-342EB940CD85}"/>
-              </a:ext>
-            </a:extLst>
-          </p:cNvPr>
-          <p:cNvSpPr>
-            <a:spLocks noGrp="1"/>
-          </p:cNvSpPr>
-          <p:nvPr>
-            <p:ph sz="quarter" idx="20"/>
-          </p:nvPr>
-        </p:nvSpPr>
-        <p:spPr>
-          <a:xfrm>
-            <a:off x="359533" y="1203598"/>
-            <a:ext cx="8424467" cy="3332402"/>
-          </a:xfrm>
-        </p:spPr>
-        <p:txBody>
-          <a:bodyPr anchor="t"/>
-          <a:lstStyle/>
-          <a:p>
-            <a:pPr>
-              <a:lnSpc>
-                <a:spcPct val="150000"/>
-              </a:lnSpc>
-            </a:pPr>
-            <a:r>
-              <a:rPr lang="en-US" noProof="0" dirty="0"/>
-              <a:t>Top 10 vulnerability types account for 53.4% of all implementations</a:t>
-            </a:r>
-          </a:p>
-          <a:p>
-            <a:pPr>
-              <a:lnSpc>
-                <a:spcPct val="150000"/>
-              </a:lnSpc>
-            </a:pPr>
-            <a:r>
-              <a:rPr lang="en-US" noProof="0" dirty="0"/>
-              <a:t>5 of category Platform</a:t>
-            </a:r>
-          </a:p>
-          <a:p>
-            <a:pPr>
-              <a:lnSpc>
-                <a:spcPct val="150000"/>
-              </a:lnSpc>
-            </a:pPr>
-            <a:r>
-              <a:rPr lang="en-US" noProof="0" dirty="0"/>
-              <a:t>3 of category Storage</a:t>
-            </a:r>
-          </a:p>
-          <a:p>
-            <a:pPr>
-              <a:lnSpc>
-                <a:spcPct val="150000"/>
-              </a:lnSpc>
-            </a:pPr>
-            <a:r>
-              <a:rPr lang="en-US" dirty="0"/>
-              <a:t>Reflects study results</a:t>
-            </a:r>
-            <a:endParaRPr lang="en-US" noProof="0" dirty="0"/>
-          </a:p>
-        </p:txBody>
-      </p:sp>
-      <p:sp>
-        <p:nvSpPr>
-          <p:cNvPr id="9" name="Textplatzhalter 8">
-            <a:extLst>
-              <a:ext uri="{FF2B5EF4-FFF2-40B4-BE49-F238E27FC236}">
-                <a16:creationId xmlns:a16="http://schemas.microsoft.com/office/drawing/2014/main" id="{EC02DE1F-34AD-90C9-EDBE-24BFEBAA77E2}"/>
-              </a:ext>
-            </a:extLst>
-          </p:cNvPr>
-          <p:cNvSpPr>
-            <a:spLocks noGrp="1"/>
-          </p:cNvSpPr>
-          <p:nvPr>
-            <p:ph type="body" sz="quarter" idx="19"/>
-          </p:nvPr>
-        </p:nvSpPr>
-        <p:spPr/>
-        <p:txBody>
-          <a:bodyPr/>
-          <a:lstStyle/>
-          <a:p>
-            <a:endParaRPr lang="en-US" noProof="0" dirty="0"/>
-          </a:p>
-        </p:txBody>
-      </p:sp>
-      <p:sp>
-        <p:nvSpPr>
-          <p:cNvPr id="11" name="Fußzeilenplatzhalter 10">
-            <a:extLst>
-              <a:ext uri="{FF2B5EF4-FFF2-40B4-BE49-F238E27FC236}">
-                <a16:creationId xmlns:a16="http://schemas.microsoft.com/office/drawing/2014/main" id="{4F7B802E-2DA0-812A-146C-74E3AABDBD1D}"/>
-              </a:ext>
-            </a:extLst>
-          </p:cNvPr>
-          <p:cNvSpPr>
-            <a:spLocks noGrp="1"/>
-          </p:cNvSpPr>
-          <p:nvPr>
-            <p:ph type="ftr" sz="quarter" idx="17"/>
-          </p:nvPr>
-        </p:nvSpPr>
-        <p:spPr/>
-        <p:txBody>
-          <a:bodyPr/>
-          <a:lstStyle/>
-          <a:p>
-            <a:endParaRPr lang="en-US" noProof="0" dirty="0"/>
-          </a:p>
-        </p:txBody>
-      </p:sp>
-      <p:sp>
-        <p:nvSpPr>
-          <p:cNvPr id="12" name="Foliennummernplatzhalter 11">
-            <a:extLst>
-              <a:ext uri="{FF2B5EF4-FFF2-40B4-BE49-F238E27FC236}">
-                <a16:creationId xmlns:a16="http://schemas.microsoft.com/office/drawing/2014/main" id="{19115836-5613-879F-A790-692FD7D1A23F}"/>
-              </a:ext>
-            </a:extLst>
-          </p:cNvPr>
-          <p:cNvSpPr>
-            <a:spLocks noGrp="1"/>
-          </p:cNvSpPr>
-          <p:nvPr>
-            <p:ph type="sldNum" sz="quarter" idx="18"/>
-          </p:nvPr>
-        </p:nvSpPr>
-        <p:spPr/>
-        <p:txBody>
-          <a:bodyPr/>
-          <a:lstStyle/>
-          <a:p>
-            <a:fld id="{E6639024-6672-4F87-864B-EA4FA9190A1A}" type="slidenum">
-              <a:rPr lang="en-US" noProof="0" smtClean="0"/>
-              <a:pPr/>
-              <a:t>26</a:t>
-            </a:fld>
-            <a:endParaRPr lang="en-US" noProof="0" dirty="0"/>
-          </a:p>
-        </p:txBody>
-      </p:sp>
-      <p:pic>
-        <p:nvPicPr>
-          <p:cNvPr id="2" name="Inhaltsplatzhalter 2" descr="Ein Bild, das Text, Screenshot, parallel, Reihe enthält.&#10;&#10;KI-generierte Inhalte können fehlerhaft sein.">
-            <a:extLst>
-              <a:ext uri="{FF2B5EF4-FFF2-40B4-BE49-F238E27FC236}">
-                <a16:creationId xmlns:a16="http://schemas.microsoft.com/office/drawing/2014/main" id="{7FBD92A1-B005-D63C-5EF0-A01D236A99F6}"/>
-              </a:ext>
-            </a:extLst>
-          </p:cNvPr>
-          <p:cNvPicPr>
-            <a:picLocks noChangeAspect="1"/>
-          </p:cNvPicPr>
-          <p:nvPr/>
-        </p:nvPicPr>
-        <p:blipFill>
-          <a:blip r:embed="rId2">
-            <a:extLst>
-              <a:ext uri="{28A0092B-C50C-407E-A947-70E740481C1C}">
-                <a14:useLocalDpi xmlns:a14="http://schemas.microsoft.com/office/drawing/2010/main" val="0"/>
-              </a:ext>
-            </a:extLst>
-          </a:blip>
-          <a:stretch>
-            <a:fillRect/>
-          </a:stretch>
-        </p:blipFill>
-        <p:spPr>
-          <a:xfrm>
-            <a:off x="3284519" y="1774106"/>
-            <a:ext cx="5501682" cy="2726961"/>
-          </a:xfrm>
-          <a:prstGeom prst="rect">
-            <a:avLst/>
-          </a:prstGeom>
-        </p:spPr>
-      </p:pic>
-    </p:spTree>
-    <p:extLst>
-      <p:ext uri="{BB962C8B-B14F-4D97-AF65-F5344CB8AC3E}">
-        <p14:creationId xmlns:p14="http://schemas.microsoft.com/office/powerpoint/2010/main" val="2753036520"/>
       </p:ext>
     </p:extLst>
   </p:cSld>
@@ -36783,7 +36881,7 @@
         <p:cNvPr id="1" name="">
           <a:extLst>
             <a:ext uri="{FF2B5EF4-FFF2-40B4-BE49-F238E27FC236}">
-              <a16:creationId xmlns:a16="http://schemas.microsoft.com/office/drawing/2014/main" id="{06F1BC5B-78CB-C24B-853C-6E8A26D67917}"/>
+              <a16:creationId xmlns:a16="http://schemas.microsoft.com/office/drawing/2014/main" id="{452AEED3-820A-E3C0-A771-BDF00D104EA7}"/>
             </a:ext>
           </a:extLst>
         </p:cNvPr>
@@ -36803,7 +36901,7 @@
           <p:cNvPr id="8" name="Textplatzhalter 7">
             <a:extLst>
               <a:ext uri="{FF2B5EF4-FFF2-40B4-BE49-F238E27FC236}">
-                <a16:creationId xmlns:a16="http://schemas.microsoft.com/office/drawing/2014/main" id="{252E3904-4812-C9B7-5775-5D734B039787}"/>
+                <a16:creationId xmlns:a16="http://schemas.microsoft.com/office/drawing/2014/main" id="{3ACB5757-5A6B-434F-FD0D-35EA5A630A18}"/>
               </a:ext>
             </a:extLst>
           </p:cNvPr>
@@ -36825,13 +36923,8 @@
                   <a:schemeClr val="bg2"/>
                 </a:solidFill>
               </a:rPr>
-              <a:t>Skewered Coverage of Vulnerability Categories</a:t>
-            </a:r>
-            <a:endParaRPr lang="en-US" noProof="0" dirty="0">
-              <a:solidFill>
-                <a:schemeClr val="bg2"/>
-              </a:solidFill>
-            </a:endParaRPr>
+              <a:t>Skewered Coverage of Vulnerability Types</a:t>
+            </a:r>
           </a:p>
         </p:txBody>
       </p:sp>
@@ -36840,7 +36933,7 @@
           <p:cNvPr id="7" name="Titel 6">
             <a:extLst>
               <a:ext uri="{FF2B5EF4-FFF2-40B4-BE49-F238E27FC236}">
-                <a16:creationId xmlns:a16="http://schemas.microsoft.com/office/drawing/2014/main" id="{44B1AE32-53CC-B7F1-2010-D2EB1A2AC2AE}"/>
+                <a16:creationId xmlns:a16="http://schemas.microsoft.com/office/drawing/2014/main" id="{E6108429-5608-01F5-35B0-6D8B5A8079DE}"/>
               </a:ext>
             </a:extLst>
           </p:cNvPr>
@@ -36877,7 +36970,7 @@
           <p:cNvPr id="10" name="Inhaltsplatzhalter 9">
             <a:extLst>
               <a:ext uri="{FF2B5EF4-FFF2-40B4-BE49-F238E27FC236}">
-                <a16:creationId xmlns:a16="http://schemas.microsoft.com/office/drawing/2014/main" id="{0E833CFD-4B51-B7FF-A14E-DE8807F4F35B}"/>
+                <a16:creationId xmlns:a16="http://schemas.microsoft.com/office/drawing/2014/main" id="{F4D0EF72-6BF5-DB4D-7995-3A56034A88FC}"/>
               </a:ext>
             </a:extLst>
           </p:cNvPr>
@@ -36904,8 +36997,8 @@
               </a:lnSpc>
             </a:pPr>
             <a:r>
-              <a:rPr lang="en-US" noProof="0" dirty="0"/>
-              <a:t>Favoring of Storage and Platform vulnerability types</a:t>
+              <a:rPr lang="en-US" dirty="0"/>
+              <a:t>Top 10 vulnerability types account for 53.4% of all implementations</a:t>
             </a:r>
           </a:p>
           <a:p>
@@ -36915,8 +37008,30 @@
               </a:lnSpc>
             </a:pPr>
             <a:r>
-              <a:rPr lang="en-US" noProof="0" dirty="0"/>
-              <a:t>Lack of Privacy</a:t>
+              <a:rPr lang="en-US" dirty="0"/>
+              <a:t>5 of category Platform</a:t>
+            </a:r>
+          </a:p>
+          <a:p>
+            <a:pPr>
+              <a:lnSpc>
+                <a:spcPct val="150000"/>
+              </a:lnSpc>
+            </a:pPr>
+            <a:r>
+              <a:rPr lang="en-US" dirty="0"/>
+              <a:t>3 of category Storage</a:t>
+            </a:r>
+          </a:p>
+          <a:p>
+            <a:pPr>
+              <a:lnSpc>
+                <a:spcPct val="150000"/>
+              </a:lnSpc>
+            </a:pPr>
+            <a:r>
+              <a:rPr lang="en-US" dirty="0"/>
+              <a:t>Reflects study results</a:t>
             </a:r>
           </a:p>
         </p:txBody>
@@ -36926,7 +37041,7 @@
           <p:cNvPr id="9" name="Textplatzhalter 8">
             <a:extLst>
               <a:ext uri="{FF2B5EF4-FFF2-40B4-BE49-F238E27FC236}">
-                <a16:creationId xmlns:a16="http://schemas.microsoft.com/office/drawing/2014/main" id="{8D9BFD35-040A-29FC-8694-DBAA2AF676FD}"/>
+                <a16:creationId xmlns:a16="http://schemas.microsoft.com/office/drawing/2014/main" id="{3AD5E2D0-756E-F45F-53E8-F20F3D731254}"/>
               </a:ext>
             </a:extLst>
           </p:cNvPr>
@@ -36951,7 +37066,7 @@
           <p:cNvPr id="11" name="Fußzeilenplatzhalter 10">
             <a:extLst>
               <a:ext uri="{FF2B5EF4-FFF2-40B4-BE49-F238E27FC236}">
-                <a16:creationId xmlns:a16="http://schemas.microsoft.com/office/drawing/2014/main" id="{E9691BB3-45EB-BDE3-3471-265F3F81407E}"/>
+                <a16:creationId xmlns:a16="http://schemas.microsoft.com/office/drawing/2014/main" id="{BAC9D7E3-BDC7-0D56-BD55-60295A005FE0}"/>
               </a:ext>
             </a:extLst>
           </p:cNvPr>
@@ -36976,7 +37091,7 @@
           <p:cNvPr id="12" name="Foliennummernplatzhalter 11">
             <a:extLst>
               <a:ext uri="{FF2B5EF4-FFF2-40B4-BE49-F238E27FC236}">
-                <a16:creationId xmlns:a16="http://schemas.microsoft.com/office/drawing/2014/main" id="{6B8D5B11-6F07-5EAE-0F89-3022D9100E0F}"/>
+                <a16:creationId xmlns:a16="http://schemas.microsoft.com/office/drawing/2014/main" id="{8A55B551-593B-558D-0CB7-D36647F7C9D8}"/>
               </a:ext>
             </a:extLst>
           </p:cNvPr>
@@ -37003,10 +37118,10 @@
       </p:sp>
       <p:pic>
         <p:nvPicPr>
-          <p:cNvPr id="5" name="Grafik 4" descr="Ein Bild, das Text, Screenshot, Diagramm, Reihe enthält.&#10;&#10;KI-generierte Inhalte können fehlerhaft sein.">
+          <p:cNvPr id="5" name="Grafik 4" descr="Ein Bild, das Text, Screenshot, Reihe, Diagramm enthält.&#10;&#10;KI-generierte Inhalte können fehlerhaft sein.">
             <a:extLst>
               <a:ext uri="{FF2B5EF4-FFF2-40B4-BE49-F238E27FC236}">
-                <a16:creationId xmlns:a16="http://schemas.microsoft.com/office/drawing/2014/main" id="{256FF658-159D-EA96-4349-1EE40FE88FF7}"/>
+                <a16:creationId xmlns:a16="http://schemas.microsoft.com/office/drawing/2014/main" id="{221CF007-E999-38C4-B860-53368421C26B}"/>
               </a:ext>
             </a:extLst>
           </p:cNvPr>
@@ -37016,21 +37131,15 @@
           <p:nvPr/>
         </p:nvPicPr>
         <p:blipFill>
-          <a:blip r:embed="rId2">
-            <a:extLst>
-              <a:ext uri="{28A0092B-C50C-407E-A947-70E740481C1C}">
-                <a14:useLocalDpi xmlns:a14="http://schemas.microsoft.com/office/drawing/2010/main" val="0"/>
-              </a:ext>
-            </a:extLst>
-          </a:blip>
+          <a:blip r:embed="rId2"/>
           <a:stretch>
             <a:fillRect/>
           </a:stretch>
         </p:blipFill>
         <p:spPr>
           <a:xfrm>
-            <a:off x="3282318" y="1771509"/>
-            <a:ext cx="5501682" cy="2721511"/>
+            <a:off x="3281955" y="1866244"/>
+            <a:ext cx="5501682" cy="2730019"/>
           </a:xfrm>
           <a:prstGeom prst="rect">
             <a:avLst/>
@@ -37040,7 +37149,7 @@
     </p:spTree>
     <p:extLst>
       <p:ext uri="{BB962C8B-B14F-4D97-AF65-F5344CB8AC3E}">
-        <p14:creationId xmlns:p14="http://schemas.microsoft.com/office/powerpoint/2010/main" val="429615744"/>
+        <p14:creationId xmlns:p14="http://schemas.microsoft.com/office/powerpoint/2010/main" val="187275627"/>
       </p:ext>
     </p:extLst>
   </p:cSld>
@@ -37058,7 +37167,7 @@
         <p:cNvPr id="1" name="">
           <a:extLst>
             <a:ext uri="{FF2B5EF4-FFF2-40B4-BE49-F238E27FC236}">
-              <a16:creationId xmlns:a16="http://schemas.microsoft.com/office/drawing/2014/main" id="{BC0BB663-935E-D418-D37F-9CDC31D29716}"/>
+              <a16:creationId xmlns:a16="http://schemas.microsoft.com/office/drawing/2014/main" id="{CE943637-D2FD-AD52-68A8-B943BAB89F4F}"/>
             </a:ext>
           </a:extLst>
         </p:cNvPr>
@@ -37078,7 +37187,7 @@
           <p:cNvPr id="8" name="Textplatzhalter 7">
             <a:extLst>
               <a:ext uri="{FF2B5EF4-FFF2-40B4-BE49-F238E27FC236}">
-                <a16:creationId xmlns:a16="http://schemas.microsoft.com/office/drawing/2014/main" id="{F7955161-BBF5-1C75-18DC-F62AEE7CA967}"/>
+                <a16:creationId xmlns:a16="http://schemas.microsoft.com/office/drawing/2014/main" id="{A103AA15-7B23-42DD-E449-1E825014CCDF}"/>
               </a:ext>
             </a:extLst>
           </p:cNvPr>
@@ -37102,6 +37211,11 @@
               </a:rPr>
               <a:t>Skewered Coverage of Vulnerability Categories</a:t>
             </a:r>
+            <a:endParaRPr lang="en-US" noProof="0" dirty="0">
+              <a:solidFill>
+                <a:schemeClr val="bg2"/>
+              </a:solidFill>
+            </a:endParaRPr>
           </a:p>
         </p:txBody>
       </p:sp>
@@ -37110,7 +37224,7 @@
           <p:cNvPr id="7" name="Titel 6">
             <a:extLst>
               <a:ext uri="{FF2B5EF4-FFF2-40B4-BE49-F238E27FC236}">
-                <a16:creationId xmlns:a16="http://schemas.microsoft.com/office/drawing/2014/main" id="{489DEFCC-3F7D-AEC9-6D4C-44D424BE5163}"/>
+                <a16:creationId xmlns:a16="http://schemas.microsoft.com/office/drawing/2014/main" id="{00D112F5-102E-31D9-552D-8463A244CDBE}"/>
               </a:ext>
             </a:extLst>
           </p:cNvPr>
@@ -37147,7 +37261,7 @@
           <p:cNvPr id="10" name="Inhaltsplatzhalter 9">
             <a:extLst>
               <a:ext uri="{FF2B5EF4-FFF2-40B4-BE49-F238E27FC236}">
-                <a16:creationId xmlns:a16="http://schemas.microsoft.com/office/drawing/2014/main" id="{01397524-03B4-9187-61DF-04916F51399F}"/>
+                <a16:creationId xmlns:a16="http://schemas.microsoft.com/office/drawing/2014/main" id="{DE7FA4BA-6EA4-8C8E-580A-F457510AEA6E}"/>
               </a:ext>
             </a:extLst>
           </p:cNvPr>
@@ -37175,7 +37289,7 @@
             </a:pPr>
             <a:r>
               <a:rPr lang="en-US" noProof="0" dirty="0"/>
-              <a:t>Auth and Crypto have most unrepresented vulnerabilities</a:t>
+              <a:t>Favoring of Storage and Platform vulnerability types</a:t>
             </a:r>
           </a:p>
           <a:p>
@@ -37186,7 +37300,7 @@
             </a:pPr>
             <a:r>
               <a:rPr lang="en-US" noProof="0" dirty="0"/>
-              <a:t>Dominance of Platform</a:t>
+              <a:t>Lack of Privacy</a:t>
             </a:r>
           </a:p>
         </p:txBody>
@@ -37196,7 +37310,7 @@
           <p:cNvPr id="9" name="Textplatzhalter 8">
             <a:extLst>
               <a:ext uri="{FF2B5EF4-FFF2-40B4-BE49-F238E27FC236}">
-                <a16:creationId xmlns:a16="http://schemas.microsoft.com/office/drawing/2014/main" id="{3501A1E7-91B5-78F3-E471-1171396A4686}"/>
+                <a16:creationId xmlns:a16="http://schemas.microsoft.com/office/drawing/2014/main" id="{C62D1908-2EEC-EE71-8828-97D450819168}"/>
               </a:ext>
             </a:extLst>
           </p:cNvPr>
@@ -37221,7 +37335,7 @@
           <p:cNvPr id="11" name="Fußzeilenplatzhalter 10">
             <a:extLst>
               <a:ext uri="{FF2B5EF4-FFF2-40B4-BE49-F238E27FC236}">
-                <a16:creationId xmlns:a16="http://schemas.microsoft.com/office/drawing/2014/main" id="{453AFAC2-0924-DEA4-61BA-D0FA1ECA1F65}"/>
+                <a16:creationId xmlns:a16="http://schemas.microsoft.com/office/drawing/2014/main" id="{C5746516-6295-A892-43AB-3F26098AC000}"/>
               </a:ext>
             </a:extLst>
           </p:cNvPr>
@@ -37246,7 +37360,7 @@
           <p:cNvPr id="12" name="Foliennummernplatzhalter 11">
             <a:extLst>
               <a:ext uri="{FF2B5EF4-FFF2-40B4-BE49-F238E27FC236}">
-                <a16:creationId xmlns:a16="http://schemas.microsoft.com/office/drawing/2014/main" id="{44B5349E-2C96-5882-F0EE-66BFBA34B92D}"/>
+                <a16:creationId xmlns:a16="http://schemas.microsoft.com/office/drawing/2014/main" id="{06997794-13A3-EEF9-765C-ED6A3CBDC5D9}"/>
               </a:ext>
             </a:extLst>
           </p:cNvPr>
@@ -37273,10 +37387,10 @@
       </p:sp>
       <p:pic>
         <p:nvPicPr>
-          <p:cNvPr id="6" name="Grafik 5" descr="Ein Bild, das Text, Screenshot, Diagramm, Reihe enthält.&#10;&#10;KI-generierte Inhalte können fehlerhaft sein.">
+          <p:cNvPr id="16" name="Grafik 15" descr="Ein Bild, das Text, Screenshot, Diagramm, Schrift enthält.&#10;&#10;KI-generierte Inhalte können fehlerhaft sein.">
             <a:extLst>
               <a:ext uri="{FF2B5EF4-FFF2-40B4-BE49-F238E27FC236}">
-                <a16:creationId xmlns:a16="http://schemas.microsoft.com/office/drawing/2014/main" id="{DDA69A8B-801C-26B7-1943-F53F23240E14}"/>
+                <a16:creationId xmlns:a16="http://schemas.microsoft.com/office/drawing/2014/main" id="{FBFF6CC8-0115-B442-5264-3D3BD210FA01}"/>
               </a:ext>
             </a:extLst>
           </p:cNvPr>
@@ -37286,21 +37400,15 @@
           <p:nvPr/>
         </p:nvPicPr>
         <p:blipFill>
-          <a:blip r:embed="rId2">
-            <a:extLst>
-              <a:ext uri="{28A0092B-C50C-407E-A947-70E740481C1C}">
-                <a14:useLocalDpi xmlns:a14="http://schemas.microsoft.com/office/drawing/2010/main" val="0"/>
-              </a:ext>
-            </a:extLst>
-          </a:blip>
+          <a:blip r:embed="rId2"/>
           <a:stretch>
             <a:fillRect/>
           </a:stretch>
         </p:blipFill>
         <p:spPr>
           <a:xfrm>
-            <a:off x="3282318" y="1817118"/>
-            <a:ext cx="5500800" cy="2708726"/>
+            <a:off x="3282137" y="1915610"/>
+            <a:ext cx="5501682" cy="2727725"/>
           </a:xfrm>
           <a:prstGeom prst="rect">
             <a:avLst/>
@@ -37310,7 +37418,7 @@
     </p:spTree>
     <p:extLst>
       <p:ext uri="{BB962C8B-B14F-4D97-AF65-F5344CB8AC3E}">
-        <p14:creationId xmlns:p14="http://schemas.microsoft.com/office/powerpoint/2010/main" val="770529016"/>
+        <p14:creationId xmlns:p14="http://schemas.microsoft.com/office/powerpoint/2010/main" val="2050261490"/>
       </p:ext>
     </p:extLst>
   </p:cSld>
@@ -37328,7 +37436,7 @@
         <p:cNvPr id="1" name="">
           <a:extLst>
             <a:ext uri="{FF2B5EF4-FFF2-40B4-BE49-F238E27FC236}">
-              <a16:creationId xmlns:a16="http://schemas.microsoft.com/office/drawing/2014/main" id="{EB01ACF5-18A0-EAE5-A8C8-475B7867DEF0}"/>
+              <a16:creationId xmlns:a16="http://schemas.microsoft.com/office/drawing/2014/main" id="{EA510894-AC59-53B0-65F1-F4E144D57481}"/>
             </a:ext>
           </a:extLst>
         </p:cNvPr>
@@ -37348,7 +37456,7 @@
           <p:cNvPr id="8" name="Textplatzhalter 7">
             <a:extLst>
               <a:ext uri="{FF2B5EF4-FFF2-40B4-BE49-F238E27FC236}">
-                <a16:creationId xmlns:a16="http://schemas.microsoft.com/office/drawing/2014/main" id="{ABFE2FA0-3875-E63F-A13E-92265A1C2104}"/>
+                <a16:creationId xmlns:a16="http://schemas.microsoft.com/office/drawing/2014/main" id="{9C35A3DD-A023-A702-60C9-E83151780AF2}"/>
               </a:ext>
             </a:extLst>
           </p:cNvPr>
@@ -37370,7 +37478,7 @@
                   <a:schemeClr val="bg2"/>
                 </a:solidFill>
               </a:rPr>
-              <a:t>Take-Away Points</a:t>
+              <a:t>Skewered Coverage of Vulnerability Categories</a:t>
             </a:r>
             <a:endParaRPr lang="en-US" noProof="0" dirty="0">
               <a:solidFill>
@@ -37385,7 +37493,7 @@
           <p:cNvPr id="7" name="Titel 6">
             <a:extLst>
               <a:ext uri="{FF2B5EF4-FFF2-40B4-BE49-F238E27FC236}">
-                <a16:creationId xmlns:a16="http://schemas.microsoft.com/office/drawing/2014/main" id="{8FB65092-B6F7-EA63-2473-E42A23A13511}"/>
+                <a16:creationId xmlns:a16="http://schemas.microsoft.com/office/drawing/2014/main" id="{A025C0AB-962A-282A-0043-6E6B2ED1FDF3}"/>
               </a:ext>
             </a:extLst>
           </p:cNvPr>
@@ -37422,7 +37530,7 @@
           <p:cNvPr id="10" name="Inhaltsplatzhalter 9">
             <a:extLst>
               <a:ext uri="{FF2B5EF4-FFF2-40B4-BE49-F238E27FC236}">
-                <a16:creationId xmlns:a16="http://schemas.microsoft.com/office/drawing/2014/main" id="{D196EB32-07BB-9EDA-EA78-295AE111AB68}"/>
+                <a16:creationId xmlns:a16="http://schemas.microsoft.com/office/drawing/2014/main" id="{6E718A96-AEA2-E265-63FA-9D833CE83633}"/>
               </a:ext>
             </a:extLst>
           </p:cNvPr>
@@ -37449,8 +37557,8 @@
               </a:lnSpc>
             </a:pPr>
             <a:r>
-              <a:rPr lang="en-US" noProof="0" dirty="0"/>
-              <a:t>Uneven coverage</a:t>
+              <a:rPr lang="en-US" dirty="0"/>
+              <a:t>Auth and Crypto have most unrepresented vulnerabilities</a:t>
             </a:r>
           </a:p>
           <a:p>
@@ -37460,30 +37568,8 @@
               </a:lnSpc>
             </a:pPr>
             <a:r>
-              <a:rPr lang="en-US" noProof="0" dirty="0"/>
-              <a:t>Many without any implementation</a:t>
-            </a:r>
-          </a:p>
-          <a:p>
-            <a:pPr>
-              <a:lnSpc>
-                <a:spcPct val="150000"/>
-              </a:lnSpc>
-            </a:pPr>
-            <a:r>
-              <a:rPr lang="en-US" noProof="0" dirty="0"/>
-              <a:t>Most implementations cover the same types</a:t>
-            </a:r>
-          </a:p>
-          <a:p>
-            <a:pPr>
-              <a:lnSpc>
-                <a:spcPct val="150000"/>
-              </a:lnSpc>
-            </a:pPr>
-            <a:r>
-              <a:rPr lang="en-US" noProof="0" dirty="0"/>
-              <a:t>All vulnerabilities should have a reference implementation</a:t>
+              <a:rPr lang="en-US" dirty="0"/>
+              <a:t>Dominance of Platform</a:t>
             </a:r>
           </a:p>
         </p:txBody>
@@ -37493,7 +37579,7 @@
           <p:cNvPr id="9" name="Textplatzhalter 8">
             <a:extLst>
               <a:ext uri="{FF2B5EF4-FFF2-40B4-BE49-F238E27FC236}">
-                <a16:creationId xmlns:a16="http://schemas.microsoft.com/office/drawing/2014/main" id="{2307A860-3827-6F06-296E-00585923ABC7}"/>
+                <a16:creationId xmlns:a16="http://schemas.microsoft.com/office/drawing/2014/main" id="{6C703E3A-EEB3-817D-093E-340F730748A1}"/>
               </a:ext>
             </a:extLst>
           </p:cNvPr>
@@ -37518,7 +37604,7 @@
           <p:cNvPr id="11" name="Fußzeilenplatzhalter 10">
             <a:extLst>
               <a:ext uri="{FF2B5EF4-FFF2-40B4-BE49-F238E27FC236}">
-                <a16:creationId xmlns:a16="http://schemas.microsoft.com/office/drawing/2014/main" id="{7D4F15AF-8828-B4E0-C81F-00B70DDD2BC3}"/>
+                <a16:creationId xmlns:a16="http://schemas.microsoft.com/office/drawing/2014/main" id="{50269AB1-5424-62E0-533F-19D03018E148}"/>
               </a:ext>
             </a:extLst>
           </p:cNvPr>
@@ -37543,7 +37629,7 @@
           <p:cNvPr id="12" name="Foliennummernplatzhalter 11">
             <a:extLst>
               <a:ext uri="{FF2B5EF4-FFF2-40B4-BE49-F238E27FC236}">
-                <a16:creationId xmlns:a16="http://schemas.microsoft.com/office/drawing/2014/main" id="{6B43B162-B6F0-67F0-A483-1AE252154D1E}"/>
+                <a16:creationId xmlns:a16="http://schemas.microsoft.com/office/drawing/2014/main" id="{3EE1F040-0B41-97AD-DABE-DD28D59F10A8}"/>
               </a:ext>
             </a:extLst>
           </p:cNvPr>
@@ -37568,10 +37654,40 @@
           </a:p>
         </p:txBody>
       </p:sp>
+      <p:pic>
+        <p:nvPicPr>
+          <p:cNvPr id="5" name="Grafik 4" descr="Ein Bild, das Text, Screenshot, Diagramm, Reihe enthält.&#10;&#10;KI-generierte Inhalte können fehlerhaft sein.">
+            <a:extLst>
+              <a:ext uri="{FF2B5EF4-FFF2-40B4-BE49-F238E27FC236}">
+                <a16:creationId xmlns:a16="http://schemas.microsoft.com/office/drawing/2014/main" id="{AB65EF75-83F2-1D4D-13F6-152B4248380B}"/>
+              </a:ext>
+            </a:extLst>
+          </p:cNvPr>
+          <p:cNvPicPr>
+            <a:picLocks noChangeAspect="1"/>
+          </p:cNvPicPr>
+          <p:nvPr/>
+        </p:nvPicPr>
+        <p:blipFill>
+          <a:blip r:embed="rId2"/>
+          <a:stretch>
+            <a:fillRect/>
+          </a:stretch>
+        </p:blipFill>
+        <p:spPr>
+          <a:xfrm>
+            <a:off x="3265979" y="1919624"/>
+            <a:ext cx="5517840" cy="2733396"/>
+          </a:xfrm>
+          <a:prstGeom prst="rect">
+            <a:avLst/>
+          </a:prstGeom>
+        </p:spPr>
+      </p:pic>
     </p:spTree>
     <p:extLst>
       <p:ext uri="{BB962C8B-B14F-4D97-AF65-F5344CB8AC3E}">
-        <p14:creationId xmlns:p14="http://schemas.microsoft.com/office/powerpoint/2010/main" val="121004567"/>
+        <p14:creationId xmlns:p14="http://schemas.microsoft.com/office/powerpoint/2010/main" val="3721211798"/>
       </p:ext>
     </p:extLst>
   </p:cSld>
@@ -37879,6 +37995,267 @@
         <p:cNvPr id="1" name="">
           <a:extLst>
             <a:ext uri="{FF2B5EF4-FFF2-40B4-BE49-F238E27FC236}">
+              <a16:creationId xmlns:a16="http://schemas.microsoft.com/office/drawing/2014/main" id="{EB01ACF5-18A0-EAE5-A8C8-475B7867DEF0}"/>
+            </a:ext>
+          </a:extLst>
+        </p:cNvPr>
+        <p:cNvGrpSpPr/>
+        <p:nvPr/>
+      </p:nvGrpSpPr>
+      <p:grpSpPr>
+        <a:xfrm>
+          <a:off x="0" y="0"/>
+          <a:ext cx="0" cy="0"/>
+          <a:chOff x="0" y="0"/>
+          <a:chExt cx="0" cy="0"/>
+        </a:xfrm>
+      </p:grpSpPr>
+      <p:sp>
+        <p:nvSpPr>
+          <p:cNvPr id="8" name="Textplatzhalter 7">
+            <a:extLst>
+              <a:ext uri="{FF2B5EF4-FFF2-40B4-BE49-F238E27FC236}">
+                <a16:creationId xmlns:a16="http://schemas.microsoft.com/office/drawing/2014/main" id="{ABFE2FA0-3875-E63F-A13E-92265A1C2104}"/>
+              </a:ext>
+            </a:extLst>
+          </p:cNvPr>
+          <p:cNvSpPr>
+            <a:spLocks noGrp="1"/>
+          </p:cNvSpPr>
+          <p:nvPr>
+            <p:ph type="body" sz="quarter" idx="12"/>
+          </p:nvPr>
+        </p:nvSpPr>
+        <p:spPr/>
+        <p:txBody>
+          <a:bodyPr/>
+          <a:lstStyle/>
+          <a:p>
+            <a:r>
+              <a:rPr lang="en-US" dirty="0">
+                <a:solidFill>
+                  <a:schemeClr val="bg2"/>
+                </a:solidFill>
+              </a:rPr>
+              <a:t>Take-Away Points</a:t>
+            </a:r>
+            <a:endParaRPr lang="en-US" noProof="0" dirty="0">
+              <a:solidFill>
+                <a:schemeClr val="bg2"/>
+              </a:solidFill>
+            </a:endParaRPr>
+          </a:p>
+        </p:txBody>
+      </p:sp>
+      <p:sp>
+        <p:nvSpPr>
+          <p:cNvPr id="7" name="Titel 6">
+            <a:extLst>
+              <a:ext uri="{FF2B5EF4-FFF2-40B4-BE49-F238E27FC236}">
+                <a16:creationId xmlns:a16="http://schemas.microsoft.com/office/drawing/2014/main" id="{8FB65092-B6F7-EA63-2473-E42A23A13511}"/>
+              </a:ext>
+            </a:extLst>
+          </p:cNvPr>
+          <p:cNvSpPr>
+            <a:spLocks noGrp="1"/>
+          </p:cNvSpPr>
+          <p:nvPr>
+            <p:ph type="title"/>
+          </p:nvPr>
+        </p:nvSpPr>
+        <p:spPr/>
+        <p:txBody>
+          <a:bodyPr/>
+          <a:lstStyle/>
+          <a:p>
+            <a:r>
+              <a:rPr lang="en-US" dirty="0">
+                <a:solidFill>
+                  <a:schemeClr val="tx1"/>
+                </a:solidFill>
+              </a:rPr>
+              <a:t>State of the Art in MASTG Reference Apps</a:t>
+            </a:r>
+            <a:endParaRPr lang="en-US" noProof="0" dirty="0">
+              <a:solidFill>
+                <a:schemeClr val="tx1"/>
+              </a:solidFill>
+            </a:endParaRPr>
+          </a:p>
+        </p:txBody>
+      </p:sp>
+      <p:sp>
+        <p:nvSpPr>
+          <p:cNvPr id="10" name="Inhaltsplatzhalter 9">
+            <a:extLst>
+              <a:ext uri="{FF2B5EF4-FFF2-40B4-BE49-F238E27FC236}">
+                <a16:creationId xmlns:a16="http://schemas.microsoft.com/office/drawing/2014/main" id="{D196EB32-07BB-9EDA-EA78-295AE111AB68}"/>
+              </a:ext>
+            </a:extLst>
+          </p:cNvPr>
+          <p:cNvSpPr>
+            <a:spLocks noGrp="1"/>
+          </p:cNvSpPr>
+          <p:nvPr>
+            <p:ph sz="quarter" idx="20"/>
+          </p:nvPr>
+        </p:nvSpPr>
+        <p:spPr>
+          <a:xfrm>
+            <a:off x="359533" y="1203598"/>
+            <a:ext cx="8424467" cy="3332402"/>
+          </a:xfrm>
+        </p:spPr>
+        <p:txBody>
+          <a:bodyPr anchor="t"/>
+          <a:lstStyle/>
+          <a:p>
+            <a:pPr>
+              <a:lnSpc>
+                <a:spcPct val="150000"/>
+              </a:lnSpc>
+            </a:pPr>
+            <a:r>
+              <a:rPr lang="en-US" noProof="0" dirty="0"/>
+              <a:t>Uneven coverage</a:t>
+            </a:r>
+          </a:p>
+          <a:p>
+            <a:pPr>
+              <a:lnSpc>
+                <a:spcPct val="150000"/>
+              </a:lnSpc>
+            </a:pPr>
+            <a:r>
+              <a:rPr lang="en-US" noProof="0" dirty="0"/>
+              <a:t>Many without any implementation</a:t>
+            </a:r>
+          </a:p>
+          <a:p>
+            <a:pPr>
+              <a:lnSpc>
+                <a:spcPct val="150000"/>
+              </a:lnSpc>
+            </a:pPr>
+            <a:r>
+              <a:rPr lang="en-US" noProof="0" dirty="0"/>
+              <a:t>Most implementations cover the same types</a:t>
+            </a:r>
+          </a:p>
+          <a:p>
+            <a:pPr>
+              <a:lnSpc>
+                <a:spcPct val="150000"/>
+              </a:lnSpc>
+            </a:pPr>
+            <a:r>
+              <a:rPr lang="en-US" noProof="0" dirty="0"/>
+              <a:t>All vulnerabilities should have a reference implementation</a:t>
+            </a:r>
+          </a:p>
+        </p:txBody>
+      </p:sp>
+      <p:sp>
+        <p:nvSpPr>
+          <p:cNvPr id="9" name="Textplatzhalter 8">
+            <a:extLst>
+              <a:ext uri="{FF2B5EF4-FFF2-40B4-BE49-F238E27FC236}">
+                <a16:creationId xmlns:a16="http://schemas.microsoft.com/office/drawing/2014/main" id="{2307A860-3827-6F06-296E-00585923ABC7}"/>
+              </a:ext>
+            </a:extLst>
+          </p:cNvPr>
+          <p:cNvSpPr>
+            <a:spLocks noGrp="1"/>
+          </p:cNvSpPr>
+          <p:nvPr>
+            <p:ph type="body" sz="quarter" idx="19"/>
+          </p:nvPr>
+        </p:nvSpPr>
+        <p:spPr/>
+        <p:txBody>
+          <a:bodyPr/>
+          <a:lstStyle/>
+          <a:p>
+            <a:endParaRPr lang="en-US" noProof="0" dirty="0"/>
+          </a:p>
+        </p:txBody>
+      </p:sp>
+      <p:sp>
+        <p:nvSpPr>
+          <p:cNvPr id="11" name="Fußzeilenplatzhalter 10">
+            <a:extLst>
+              <a:ext uri="{FF2B5EF4-FFF2-40B4-BE49-F238E27FC236}">
+                <a16:creationId xmlns:a16="http://schemas.microsoft.com/office/drawing/2014/main" id="{7D4F15AF-8828-B4E0-C81F-00B70DDD2BC3}"/>
+              </a:ext>
+            </a:extLst>
+          </p:cNvPr>
+          <p:cNvSpPr>
+            <a:spLocks noGrp="1"/>
+          </p:cNvSpPr>
+          <p:nvPr>
+            <p:ph type="ftr" sz="quarter" idx="17"/>
+          </p:nvPr>
+        </p:nvSpPr>
+        <p:spPr/>
+        <p:txBody>
+          <a:bodyPr/>
+          <a:lstStyle/>
+          <a:p>
+            <a:endParaRPr lang="en-US" noProof="0" dirty="0"/>
+          </a:p>
+        </p:txBody>
+      </p:sp>
+      <p:sp>
+        <p:nvSpPr>
+          <p:cNvPr id="12" name="Foliennummernplatzhalter 11">
+            <a:extLst>
+              <a:ext uri="{FF2B5EF4-FFF2-40B4-BE49-F238E27FC236}">
+                <a16:creationId xmlns:a16="http://schemas.microsoft.com/office/drawing/2014/main" id="{6B43B162-B6F0-67F0-A483-1AE252154D1E}"/>
+              </a:ext>
+            </a:extLst>
+          </p:cNvPr>
+          <p:cNvSpPr>
+            <a:spLocks noGrp="1"/>
+          </p:cNvSpPr>
+          <p:nvPr>
+            <p:ph type="sldNum" sz="quarter" idx="18"/>
+          </p:nvPr>
+        </p:nvSpPr>
+        <p:spPr/>
+        <p:txBody>
+          <a:bodyPr/>
+          <a:lstStyle/>
+          <a:p>
+            <a:fld id="{E6639024-6672-4F87-864B-EA4FA9190A1A}" type="slidenum">
+              <a:rPr lang="en-US" noProof="0" smtClean="0"/>
+              <a:pPr/>
+              <a:t>30</a:t>
+            </a:fld>
+            <a:endParaRPr lang="en-US" noProof="0" dirty="0"/>
+          </a:p>
+        </p:txBody>
+      </p:sp>
+    </p:spTree>
+    <p:extLst>
+      <p:ext uri="{BB962C8B-B14F-4D97-AF65-F5344CB8AC3E}">
+        <p14:creationId xmlns:p14="http://schemas.microsoft.com/office/powerpoint/2010/main" val="121004567"/>
+      </p:ext>
+    </p:extLst>
+  </p:cSld>
+  <p:clrMapOvr>
+    <a:masterClrMapping/>
+  </p:clrMapOvr>
+</p:sld>
+</file>
+
+<file path=ppt/slides/slide31.xml><?xml version="1.0" encoding="utf-8"?>
+<p:sld xmlns:a="http://schemas.openxmlformats.org/drawingml/2006/main" xmlns:r="http://schemas.openxmlformats.org/officeDocument/2006/relationships" xmlns:p="http://schemas.openxmlformats.org/presentationml/2006/main">
+  <p:cSld>
+    <p:spTree>
+      <p:nvGrpSpPr>
+        <p:cNvPr id="1" name="">
+          <a:extLst>
+            <a:ext uri="{FF2B5EF4-FFF2-40B4-BE49-F238E27FC236}">
               <a16:creationId xmlns:a16="http://schemas.microsoft.com/office/drawing/2014/main" id="{DA8C4075-1FC6-D5EE-574B-05F6521F064B}"/>
             </a:ext>
           </a:extLst>
@@ -38125,7 +38502,7 @@
             <a:fld id="{E6639024-6672-4F87-864B-EA4FA9190A1A}" type="slidenum">
               <a:rPr lang="en-US" noProof="0" smtClean="0"/>
               <a:pPr/>
-              <a:t>30</a:t>
+              <a:t>31</a:t>
             </a:fld>
             <a:endParaRPr lang="en-US" noProof="0" dirty="0"/>
           </a:p>
@@ -38144,7 +38521,7 @@
 </p:sld>
 </file>
 
-<file path=ppt/slides/slide31.xml><?xml version="1.0" encoding="utf-8"?>
+<file path=ppt/slides/slide32.xml><?xml version="1.0" encoding="utf-8"?>
 <p:sld xmlns:a="http://schemas.openxmlformats.org/drawingml/2006/main" xmlns:r="http://schemas.openxmlformats.org/officeDocument/2006/relationships" xmlns:p="http://schemas.openxmlformats.org/presentationml/2006/main">
   <p:cSld>
     <p:spTree>
@@ -38345,7 +38722,7 @@
             <a:fld id="{E6639024-6672-4F87-864B-EA4FA9190A1A}" type="slidenum">
               <a:rPr lang="en-US" noProof="0" smtClean="0"/>
               <a:pPr/>
-              <a:t>31</a:t>
+              <a:t>32</a:t>
             </a:fld>
             <a:endParaRPr lang="en-US" noProof="0" dirty="0"/>
           </a:p>
@@ -38597,7 +38974,7 @@
 </p:sld>
 </file>
 
-<file path=ppt/slides/slide32.xml><?xml version="1.0" encoding="utf-8"?>
+<file path=ppt/slides/slide33.xml><?xml version="1.0" encoding="utf-8"?>
 <p:sld xmlns:a="http://schemas.openxmlformats.org/drawingml/2006/main" xmlns:r="http://schemas.openxmlformats.org/officeDocument/2006/relationships" xmlns:p="http://schemas.openxmlformats.org/presentationml/2006/main">
   <p:cSld>
     <p:spTree>
@@ -38803,7 +39180,7 @@
             <a:fld id="{E6639024-6672-4F87-864B-EA4FA9190A1A}" type="slidenum">
               <a:rPr lang="en-US" noProof="0" smtClean="0"/>
               <a:pPr/>
-              <a:t>32</a:t>
+              <a:t>33</a:t>
             </a:fld>
             <a:endParaRPr lang="en-US" noProof="0" dirty="0"/>
           </a:p>
@@ -39064,7 +39441,7 @@
 </p:sld>
 </file>
 
-<file path=ppt/slides/slide33.xml><?xml version="1.0" encoding="utf-8"?>
+<file path=ppt/slides/slide34.xml><?xml version="1.0" encoding="utf-8"?>
 <p:sld xmlns:a="http://schemas.openxmlformats.org/drawingml/2006/main" xmlns:r="http://schemas.openxmlformats.org/officeDocument/2006/relationships" xmlns:p="http://schemas.openxmlformats.org/presentationml/2006/main">
   <p:cSld>
     <p:spTree>
@@ -39270,7 +39647,7 @@
             <a:fld id="{E6639024-6672-4F87-864B-EA4FA9190A1A}" type="slidenum">
               <a:rPr lang="en-US" noProof="0" smtClean="0"/>
               <a:pPr/>
-              <a:t>33</a:t>
+              <a:t>34</a:t>
             </a:fld>
             <a:endParaRPr lang="en-US" noProof="0" dirty="0"/>
           </a:p>
@@ -39531,7 +39908,7 @@
 </p:sld>
 </file>
 
-<file path=ppt/slides/slide34.xml><?xml version="1.0" encoding="utf-8"?>
+<file path=ppt/slides/slide35.xml><?xml version="1.0" encoding="utf-8"?>
 <p:sld xmlns:a="http://schemas.openxmlformats.org/drawingml/2006/main" xmlns:r="http://schemas.openxmlformats.org/officeDocument/2006/relationships" xmlns:p="http://schemas.openxmlformats.org/presentationml/2006/main">
   <p:cSld>
     <p:spTree>
@@ -39702,7 +40079,7 @@
             <a:fld id="{E6639024-6672-4F87-864B-EA4FA9190A1A}" type="slidenum">
               <a:rPr lang="en-US" noProof="0" smtClean="0"/>
               <a:pPr/>
-              <a:t>34</a:t>
+              <a:t>35</a:t>
             </a:fld>
             <a:endParaRPr lang="en-US" noProof="0" dirty="0"/>
           </a:p>
@@ -39998,7 +40375,7 @@
 </p:sld>
 </file>
 
-<file path=ppt/slides/slide35.xml><?xml version="1.0" encoding="utf-8"?>
+<file path=ppt/slides/slide36.xml><?xml version="1.0" encoding="utf-8"?>
 <p:sld xmlns:a="http://schemas.openxmlformats.org/drawingml/2006/main" xmlns:r="http://schemas.openxmlformats.org/officeDocument/2006/relationships" xmlns:p="http://schemas.openxmlformats.org/presentationml/2006/main">
   <p:cSld>
     <p:spTree>
@@ -40169,7 +40546,7 @@
             <a:fld id="{E6639024-6672-4F87-864B-EA4FA9190A1A}" type="slidenum">
               <a:rPr lang="en-US" noProof="0" smtClean="0"/>
               <a:pPr/>
-              <a:t>35</a:t>
+              <a:t>36</a:t>
             </a:fld>
             <a:endParaRPr lang="en-US" noProof="0" dirty="0"/>
           </a:p>
@@ -40476,7 +40853,7 @@
 </p:sld>
 </file>
 
-<file path=ppt/slides/slide36.xml><?xml version="1.0" encoding="utf-8"?>
+<file path=ppt/slides/slide37.xml><?xml version="1.0" encoding="utf-8"?>
 <p:sld xmlns:a="http://schemas.openxmlformats.org/drawingml/2006/main" xmlns:r="http://schemas.openxmlformats.org/officeDocument/2006/relationships" xmlns:p="http://schemas.openxmlformats.org/presentationml/2006/main">
   <p:cSld>
     <p:spTree>
@@ -40647,7 +41024,7 @@
             <a:fld id="{E6639024-6672-4F87-864B-EA4FA9190A1A}" type="slidenum">
               <a:rPr lang="en-US" noProof="0" smtClean="0"/>
               <a:pPr/>
-              <a:t>36</a:t>
+              <a:t>37</a:t>
             </a:fld>
             <a:endParaRPr lang="en-US" noProof="0" dirty="0"/>
           </a:p>
@@ -40905,44 +41282,33 @@
               <a:t>Mostly differ in encryption and storage</a:t>
             </a:r>
           </a:p>
-        </p:txBody>
-      </p:sp>
-      <p:pic>
-        <p:nvPicPr>
-          <p:cNvPr id="3" name="Grafik 2" descr="Ein Bild, das Text, Diagramm, Reihe, Screenshot enthält.&#10;&#10;KI-generierte Inhalte können fehlerhaft sein.">
-            <a:extLst>
-              <a:ext uri="{FF2B5EF4-FFF2-40B4-BE49-F238E27FC236}">
-                <a16:creationId xmlns:a16="http://schemas.microsoft.com/office/drawing/2014/main" id="{CE32860B-E065-EEDB-4657-C65095ACD456}"/>
-              </a:ext>
-            </a:extLst>
-          </p:cNvPr>
-          <p:cNvPicPr>
-            <a:picLocks noChangeAspect="1"/>
-          </p:cNvPicPr>
-          <p:nvPr/>
-        </p:nvPicPr>
-        <p:blipFill>
-          <a:blip r:embed="rId2">
-            <a:extLst>
-              <a:ext uri="{28A0092B-C50C-407E-A947-70E740481C1C}">
-                <a14:useLocalDpi xmlns:a14="http://schemas.microsoft.com/office/drawing/2010/main" val="0"/>
-              </a:ext>
-            </a:extLst>
-          </a:blip>
-          <a:stretch>
-            <a:fillRect/>
-          </a:stretch>
-        </p:blipFill>
-        <p:spPr>
-          <a:xfrm>
-            <a:off x="4572000" y="1314268"/>
-            <a:ext cx="4212000" cy="3181232"/>
-          </a:xfrm>
-          <a:prstGeom prst="rect">
-            <a:avLst/>
-          </a:prstGeom>
-        </p:spPr>
-      </p:pic>
+          <a:p>
+            <a:pPr marL="0" indent="0">
+              <a:lnSpc>
+                <a:spcPct val="150000"/>
+              </a:lnSpc>
+              <a:buNone/>
+            </a:pPr>
+            <a:r>
+              <a:rPr lang="en-US" i="1" noProof="0" dirty="0"/>
+              <a:t>-&gt; </a:t>
+            </a:r>
+            <a:r>
+              <a:rPr lang="en-US" i="1" noProof="0" dirty="0" err="1"/>
+              <a:t>Abstra</a:t>
+            </a:r>
+            <a:r>
+              <a:rPr lang="en-US" i="1" dirty="0" err="1"/>
+              <a:t>ct</a:t>
+            </a:r>
+            <a:r>
+              <a:rPr lang="en-US" i="1" dirty="0"/>
+              <a:t> classes for login &amp; registration</a:t>
+            </a:r>
+            <a:endParaRPr lang="en-US" i="1" noProof="0" dirty="0"/>
+          </a:p>
+        </p:txBody>
+      </p:sp>
     </p:spTree>
     <p:extLst>
       <p:ext uri="{BB962C8B-B14F-4D97-AF65-F5344CB8AC3E}">
@@ -40956,7 +41322,7 @@
 </p:sld>
 </file>
 
-<file path=ppt/slides/slide37.xml><?xml version="1.0" encoding="utf-8"?>
+<file path=ppt/slides/slide38.xml><?xml version="1.0" encoding="utf-8"?>
 <p:sld xmlns:a="http://schemas.openxmlformats.org/drawingml/2006/main" xmlns:r="http://schemas.openxmlformats.org/officeDocument/2006/relationships" xmlns:p="http://schemas.openxmlformats.org/presentationml/2006/main">
   <p:cSld>
     <p:spTree>
@@ -41127,7 +41493,7 @@
             <a:fld id="{E6639024-6672-4F87-864B-EA4FA9190A1A}" type="slidenum">
               <a:rPr lang="en-US" noProof="0" smtClean="0"/>
               <a:pPr/>
-              <a:t>37</a:t>
+              <a:t>38</a:t>
             </a:fld>
             <a:endParaRPr lang="en-US" noProof="0" dirty="0"/>
           </a:p>
@@ -41363,42 +41729,6 @@
           </a:p>
         </p:txBody>
       </p:sp>
-      <p:pic>
-        <p:nvPicPr>
-          <p:cNvPr id="3" name="Grafik 2" descr="Ein Bild, das Text, Diagramm, Reihe, Screenshot enthält.&#10;&#10;KI-generierte Inhalte können fehlerhaft sein.">
-            <a:extLst>
-              <a:ext uri="{FF2B5EF4-FFF2-40B4-BE49-F238E27FC236}">
-                <a16:creationId xmlns:a16="http://schemas.microsoft.com/office/drawing/2014/main" id="{0DDE39E9-0DF5-98C6-5D82-F120D0BB1E29}"/>
-              </a:ext>
-            </a:extLst>
-          </p:cNvPr>
-          <p:cNvPicPr>
-            <a:picLocks noChangeAspect="1"/>
-          </p:cNvPicPr>
-          <p:nvPr/>
-        </p:nvPicPr>
-        <p:blipFill>
-          <a:blip r:embed="rId2">
-            <a:extLst>
-              <a:ext uri="{28A0092B-C50C-407E-A947-70E740481C1C}">
-                <a14:useLocalDpi xmlns:a14="http://schemas.microsoft.com/office/drawing/2010/main" val="0"/>
-              </a:ext>
-            </a:extLst>
-          </a:blip>
-          <a:stretch>
-            <a:fillRect/>
-          </a:stretch>
-        </p:blipFill>
-        <p:spPr>
-          <a:xfrm>
-            <a:off x="4572000" y="1314268"/>
-            <a:ext cx="4212000" cy="3181232"/>
-          </a:xfrm>
-          <a:prstGeom prst="rect">
-            <a:avLst/>
-          </a:prstGeom>
-        </p:spPr>
-      </p:pic>
     </p:spTree>
     <p:extLst>
       <p:ext uri="{BB962C8B-B14F-4D97-AF65-F5344CB8AC3E}">
@@ -41412,7 +41742,7 @@
 </p:sld>
 </file>
 
-<file path=ppt/slides/slide38.xml><?xml version="1.0" encoding="utf-8"?>
+<file path=ppt/slides/slide39.xml><?xml version="1.0" encoding="utf-8"?>
 <p:sld xmlns:a="http://schemas.openxmlformats.org/drawingml/2006/main" xmlns:r="http://schemas.openxmlformats.org/officeDocument/2006/relationships" xmlns:p="http://schemas.openxmlformats.org/presentationml/2006/main">
   <p:cSld>
     <p:spTree>
@@ -41583,7 +41913,7 @@
             <a:fld id="{E6639024-6672-4F87-864B-EA4FA9190A1A}" type="slidenum">
               <a:rPr lang="en-US" noProof="0" smtClean="0"/>
               <a:pPr/>
-              <a:t>38</a:t>
+              <a:t>39</a:t>
             </a:fld>
             <a:endParaRPr lang="en-US" noProof="0" dirty="0"/>
           </a:p>
@@ -41857,259 +42187,6 @@
     <p:extLst>
       <p:ext uri="{BB962C8B-B14F-4D97-AF65-F5344CB8AC3E}">
         <p14:creationId xmlns:p14="http://schemas.microsoft.com/office/powerpoint/2010/main" val="105921891"/>
-      </p:ext>
-    </p:extLst>
-  </p:cSld>
-  <p:clrMapOvr>
-    <a:masterClrMapping/>
-  </p:clrMapOvr>
-</p:sld>
-</file>
-
-<file path=ppt/slides/slide39.xml><?xml version="1.0" encoding="utf-8"?>
-<p:sld xmlns:a="http://schemas.openxmlformats.org/drawingml/2006/main" xmlns:r="http://schemas.openxmlformats.org/officeDocument/2006/relationships" xmlns:p="http://schemas.openxmlformats.org/presentationml/2006/main">
-  <p:cSld>
-    <p:spTree>
-      <p:nvGrpSpPr>
-        <p:cNvPr id="1" name="">
-          <a:extLst>
-            <a:ext uri="{FF2B5EF4-FFF2-40B4-BE49-F238E27FC236}">
-              <a16:creationId xmlns:a16="http://schemas.microsoft.com/office/drawing/2014/main" id="{85EBC30F-C25B-7073-3A1B-1660465740B3}"/>
-            </a:ext>
-          </a:extLst>
-        </p:cNvPr>
-        <p:cNvGrpSpPr/>
-        <p:nvPr/>
-      </p:nvGrpSpPr>
-      <p:grpSpPr>
-        <a:xfrm>
-          <a:off x="0" y="0"/>
-          <a:ext cx="0" cy="0"/>
-          <a:chOff x="0" y="0"/>
-          <a:chExt cx="0" cy="0"/>
-        </a:xfrm>
-      </p:grpSpPr>
-      <p:sp>
-        <p:nvSpPr>
-          <p:cNvPr id="8" name="Textplatzhalter 7">
-            <a:extLst>
-              <a:ext uri="{FF2B5EF4-FFF2-40B4-BE49-F238E27FC236}">
-                <a16:creationId xmlns:a16="http://schemas.microsoft.com/office/drawing/2014/main" id="{8D60D8A2-CAC1-F1D4-4407-CDABBAF2AD26}"/>
-              </a:ext>
-            </a:extLst>
-          </p:cNvPr>
-          <p:cNvSpPr>
-            <a:spLocks noGrp="1"/>
-          </p:cNvSpPr>
-          <p:nvPr>
-            <p:ph type="body" sz="quarter" idx="12"/>
-          </p:nvPr>
-        </p:nvSpPr>
-        <p:spPr/>
-        <p:txBody>
-          <a:bodyPr/>
-          <a:lstStyle/>
-          <a:p>
-            <a:r>
-              <a:rPr lang="en-US" dirty="0">
-                <a:solidFill>
-                  <a:schemeClr val="bg2"/>
-                </a:solidFill>
-              </a:rPr>
-              <a:t>Overview of Our Apps</a:t>
-            </a:r>
-            <a:endParaRPr lang="en-US" noProof="0" dirty="0">
-              <a:solidFill>
-                <a:schemeClr val="bg2"/>
-              </a:solidFill>
-            </a:endParaRPr>
-          </a:p>
-        </p:txBody>
-      </p:sp>
-      <p:sp>
-        <p:nvSpPr>
-          <p:cNvPr id="7" name="Titel 6">
-            <a:extLst>
-              <a:ext uri="{FF2B5EF4-FFF2-40B4-BE49-F238E27FC236}">
-                <a16:creationId xmlns:a16="http://schemas.microsoft.com/office/drawing/2014/main" id="{0F7445F2-BA2E-405F-D428-A101D5485C24}"/>
-              </a:ext>
-            </a:extLst>
-          </p:cNvPr>
-          <p:cNvSpPr>
-            <a:spLocks noGrp="1"/>
-          </p:cNvSpPr>
-          <p:nvPr>
-            <p:ph type="title"/>
-          </p:nvPr>
-        </p:nvSpPr>
-        <p:spPr/>
-        <p:txBody>
-          <a:bodyPr/>
-          <a:lstStyle/>
-          <a:p>
-            <a:r>
-              <a:rPr lang="en-US" dirty="0">
-                <a:solidFill>
-                  <a:schemeClr val="tx1"/>
-                </a:solidFill>
-              </a:rPr>
-              <a:t>Results</a:t>
-            </a:r>
-          </a:p>
-        </p:txBody>
-      </p:sp>
-      <p:sp>
-        <p:nvSpPr>
-          <p:cNvPr id="10" name="Inhaltsplatzhalter 9">
-            <a:extLst>
-              <a:ext uri="{FF2B5EF4-FFF2-40B4-BE49-F238E27FC236}">
-                <a16:creationId xmlns:a16="http://schemas.microsoft.com/office/drawing/2014/main" id="{6A8EAE79-55D3-0EEA-7F7A-4174686DBDDA}"/>
-              </a:ext>
-            </a:extLst>
-          </p:cNvPr>
-          <p:cNvSpPr>
-            <a:spLocks noGrp="1"/>
-          </p:cNvSpPr>
-          <p:nvPr>
-            <p:ph sz="quarter" idx="20"/>
-          </p:nvPr>
-        </p:nvSpPr>
-        <p:spPr>
-          <a:xfrm>
-            <a:off x="359533" y="1203598"/>
-            <a:ext cx="8424467" cy="3332402"/>
-          </a:xfrm>
-        </p:spPr>
-        <p:txBody>
-          <a:bodyPr anchor="t"/>
-          <a:lstStyle/>
-          <a:p>
-            <a:pPr>
-              <a:lnSpc>
-                <a:spcPct val="150000"/>
-              </a:lnSpc>
-            </a:pPr>
-            <a:r>
-              <a:rPr lang="en-US" noProof="0" dirty="0"/>
-              <a:t>Three apps</a:t>
-            </a:r>
-          </a:p>
-          <a:p>
-            <a:pPr>
-              <a:lnSpc>
-                <a:spcPct val="150000"/>
-              </a:lnSpc>
-            </a:pPr>
-            <a:r>
-              <a:rPr lang="en-US" noProof="0" dirty="0"/>
-              <a:t>28 vulnerabilities</a:t>
-            </a:r>
-          </a:p>
-          <a:p>
-            <a:pPr>
-              <a:lnSpc>
-                <a:spcPct val="150000"/>
-              </a:lnSpc>
-            </a:pPr>
-            <a:r>
-              <a:rPr lang="en-US" noProof="0" dirty="0"/>
-              <a:t>Complete coverage of MASVS-STORAGE and CRYPTO</a:t>
-            </a:r>
-          </a:p>
-          <a:p>
-            <a:pPr>
-              <a:lnSpc>
-                <a:spcPct val="150000"/>
-              </a:lnSpc>
-            </a:pPr>
-            <a:endParaRPr lang="en-US" noProof="0" dirty="0"/>
-          </a:p>
-        </p:txBody>
-      </p:sp>
-      <p:sp>
-        <p:nvSpPr>
-          <p:cNvPr id="9" name="Textplatzhalter 8">
-            <a:extLst>
-              <a:ext uri="{FF2B5EF4-FFF2-40B4-BE49-F238E27FC236}">
-                <a16:creationId xmlns:a16="http://schemas.microsoft.com/office/drawing/2014/main" id="{21972BDC-A039-337C-C4D1-1A08C3B37ECE}"/>
-              </a:ext>
-            </a:extLst>
-          </p:cNvPr>
-          <p:cNvSpPr>
-            <a:spLocks noGrp="1"/>
-          </p:cNvSpPr>
-          <p:nvPr>
-            <p:ph type="body" sz="quarter" idx="19"/>
-          </p:nvPr>
-        </p:nvSpPr>
-        <p:spPr/>
-        <p:txBody>
-          <a:bodyPr/>
-          <a:lstStyle/>
-          <a:p>
-            <a:endParaRPr lang="en-US" noProof="0" dirty="0"/>
-          </a:p>
-        </p:txBody>
-      </p:sp>
-      <p:sp>
-        <p:nvSpPr>
-          <p:cNvPr id="11" name="Fußzeilenplatzhalter 10">
-            <a:extLst>
-              <a:ext uri="{FF2B5EF4-FFF2-40B4-BE49-F238E27FC236}">
-                <a16:creationId xmlns:a16="http://schemas.microsoft.com/office/drawing/2014/main" id="{E0ABAD69-43AC-D932-B15F-D0E672663AF0}"/>
-              </a:ext>
-            </a:extLst>
-          </p:cNvPr>
-          <p:cNvSpPr>
-            <a:spLocks noGrp="1"/>
-          </p:cNvSpPr>
-          <p:nvPr>
-            <p:ph type="ftr" sz="quarter" idx="17"/>
-          </p:nvPr>
-        </p:nvSpPr>
-        <p:spPr/>
-        <p:txBody>
-          <a:bodyPr/>
-          <a:lstStyle/>
-          <a:p>
-            <a:endParaRPr lang="en-US" noProof="0" dirty="0"/>
-          </a:p>
-        </p:txBody>
-      </p:sp>
-      <p:sp>
-        <p:nvSpPr>
-          <p:cNvPr id="12" name="Foliennummernplatzhalter 11">
-            <a:extLst>
-              <a:ext uri="{FF2B5EF4-FFF2-40B4-BE49-F238E27FC236}">
-                <a16:creationId xmlns:a16="http://schemas.microsoft.com/office/drawing/2014/main" id="{08D30E9D-0965-D08C-B126-2AD14507A205}"/>
-              </a:ext>
-            </a:extLst>
-          </p:cNvPr>
-          <p:cNvSpPr>
-            <a:spLocks noGrp="1"/>
-          </p:cNvSpPr>
-          <p:nvPr>
-            <p:ph type="sldNum" sz="quarter" idx="18"/>
-          </p:nvPr>
-        </p:nvSpPr>
-        <p:spPr/>
-        <p:txBody>
-          <a:bodyPr/>
-          <a:lstStyle/>
-          <a:p>
-            <a:fld id="{E6639024-6672-4F87-864B-EA4FA9190A1A}" type="slidenum">
-              <a:rPr lang="en-US" noProof="0" smtClean="0"/>
-              <a:pPr/>
-              <a:t>39</a:t>
-            </a:fld>
-            <a:endParaRPr lang="en-US" noProof="0" dirty="0"/>
-          </a:p>
-        </p:txBody>
-      </p:sp>
-    </p:spTree>
-    <p:extLst>
-      <p:ext uri="{BB962C8B-B14F-4D97-AF65-F5344CB8AC3E}">
-        <p14:creationId xmlns:p14="http://schemas.microsoft.com/office/powerpoint/2010/main" val="2743562481"/>
       </p:ext>
     </p:extLst>
   </p:cSld>
@@ -42653,6 +42730,259 @@
         <p:cNvPr id="1" name="">
           <a:extLst>
             <a:ext uri="{FF2B5EF4-FFF2-40B4-BE49-F238E27FC236}">
+              <a16:creationId xmlns:a16="http://schemas.microsoft.com/office/drawing/2014/main" id="{85EBC30F-C25B-7073-3A1B-1660465740B3}"/>
+            </a:ext>
+          </a:extLst>
+        </p:cNvPr>
+        <p:cNvGrpSpPr/>
+        <p:nvPr/>
+      </p:nvGrpSpPr>
+      <p:grpSpPr>
+        <a:xfrm>
+          <a:off x="0" y="0"/>
+          <a:ext cx="0" cy="0"/>
+          <a:chOff x="0" y="0"/>
+          <a:chExt cx="0" cy="0"/>
+        </a:xfrm>
+      </p:grpSpPr>
+      <p:sp>
+        <p:nvSpPr>
+          <p:cNvPr id="8" name="Textplatzhalter 7">
+            <a:extLst>
+              <a:ext uri="{FF2B5EF4-FFF2-40B4-BE49-F238E27FC236}">
+                <a16:creationId xmlns:a16="http://schemas.microsoft.com/office/drawing/2014/main" id="{8D60D8A2-CAC1-F1D4-4407-CDABBAF2AD26}"/>
+              </a:ext>
+            </a:extLst>
+          </p:cNvPr>
+          <p:cNvSpPr>
+            <a:spLocks noGrp="1"/>
+          </p:cNvSpPr>
+          <p:nvPr>
+            <p:ph type="body" sz="quarter" idx="12"/>
+          </p:nvPr>
+        </p:nvSpPr>
+        <p:spPr/>
+        <p:txBody>
+          <a:bodyPr/>
+          <a:lstStyle/>
+          <a:p>
+            <a:r>
+              <a:rPr lang="en-US" dirty="0">
+                <a:solidFill>
+                  <a:schemeClr val="bg2"/>
+                </a:solidFill>
+              </a:rPr>
+              <a:t>Overview of Our Apps</a:t>
+            </a:r>
+            <a:endParaRPr lang="en-US" noProof="0" dirty="0">
+              <a:solidFill>
+                <a:schemeClr val="bg2"/>
+              </a:solidFill>
+            </a:endParaRPr>
+          </a:p>
+        </p:txBody>
+      </p:sp>
+      <p:sp>
+        <p:nvSpPr>
+          <p:cNvPr id="7" name="Titel 6">
+            <a:extLst>
+              <a:ext uri="{FF2B5EF4-FFF2-40B4-BE49-F238E27FC236}">
+                <a16:creationId xmlns:a16="http://schemas.microsoft.com/office/drawing/2014/main" id="{0F7445F2-BA2E-405F-D428-A101D5485C24}"/>
+              </a:ext>
+            </a:extLst>
+          </p:cNvPr>
+          <p:cNvSpPr>
+            <a:spLocks noGrp="1"/>
+          </p:cNvSpPr>
+          <p:nvPr>
+            <p:ph type="title"/>
+          </p:nvPr>
+        </p:nvSpPr>
+        <p:spPr/>
+        <p:txBody>
+          <a:bodyPr/>
+          <a:lstStyle/>
+          <a:p>
+            <a:r>
+              <a:rPr lang="en-US" dirty="0">
+                <a:solidFill>
+                  <a:schemeClr val="tx1"/>
+                </a:solidFill>
+              </a:rPr>
+              <a:t>Results</a:t>
+            </a:r>
+          </a:p>
+        </p:txBody>
+      </p:sp>
+      <p:sp>
+        <p:nvSpPr>
+          <p:cNvPr id="10" name="Inhaltsplatzhalter 9">
+            <a:extLst>
+              <a:ext uri="{FF2B5EF4-FFF2-40B4-BE49-F238E27FC236}">
+                <a16:creationId xmlns:a16="http://schemas.microsoft.com/office/drawing/2014/main" id="{6A8EAE79-55D3-0EEA-7F7A-4174686DBDDA}"/>
+              </a:ext>
+            </a:extLst>
+          </p:cNvPr>
+          <p:cNvSpPr>
+            <a:spLocks noGrp="1"/>
+          </p:cNvSpPr>
+          <p:nvPr>
+            <p:ph sz="quarter" idx="20"/>
+          </p:nvPr>
+        </p:nvSpPr>
+        <p:spPr>
+          <a:xfrm>
+            <a:off x="359533" y="1203598"/>
+            <a:ext cx="8424467" cy="3332402"/>
+          </a:xfrm>
+        </p:spPr>
+        <p:txBody>
+          <a:bodyPr anchor="t"/>
+          <a:lstStyle/>
+          <a:p>
+            <a:pPr>
+              <a:lnSpc>
+                <a:spcPct val="150000"/>
+              </a:lnSpc>
+            </a:pPr>
+            <a:r>
+              <a:rPr lang="en-US" noProof="0" dirty="0"/>
+              <a:t>Three apps</a:t>
+            </a:r>
+          </a:p>
+          <a:p>
+            <a:pPr>
+              <a:lnSpc>
+                <a:spcPct val="150000"/>
+              </a:lnSpc>
+            </a:pPr>
+            <a:r>
+              <a:rPr lang="en-US" noProof="0" dirty="0"/>
+              <a:t>28 vulnerabilities</a:t>
+            </a:r>
+          </a:p>
+          <a:p>
+            <a:pPr>
+              <a:lnSpc>
+                <a:spcPct val="150000"/>
+              </a:lnSpc>
+            </a:pPr>
+            <a:r>
+              <a:rPr lang="en-US" noProof="0" dirty="0"/>
+              <a:t>Complete coverage of MASVS-STORAGE and CRYPTO</a:t>
+            </a:r>
+          </a:p>
+          <a:p>
+            <a:pPr>
+              <a:lnSpc>
+                <a:spcPct val="150000"/>
+              </a:lnSpc>
+            </a:pPr>
+            <a:endParaRPr lang="en-US" noProof="0" dirty="0"/>
+          </a:p>
+        </p:txBody>
+      </p:sp>
+      <p:sp>
+        <p:nvSpPr>
+          <p:cNvPr id="9" name="Textplatzhalter 8">
+            <a:extLst>
+              <a:ext uri="{FF2B5EF4-FFF2-40B4-BE49-F238E27FC236}">
+                <a16:creationId xmlns:a16="http://schemas.microsoft.com/office/drawing/2014/main" id="{21972BDC-A039-337C-C4D1-1A08C3B37ECE}"/>
+              </a:ext>
+            </a:extLst>
+          </p:cNvPr>
+          <p:cNvSpPr>
+            <a:spLocks noGrp="1"/>
+          </p:cNvSpPr>
+          <p:nvPr>
+            <p:ph type="body" sz="quarter" idx="19"/>
+          </p:nvPr>
+        </p:nvSpPr>
+        <p:spPr/>
+        <p:txBody>
+          <a:bodyPr/>
+          <a:lstStyle/>
+          <a:p>
+            <a:endParaRPr lang="en-US" noProof="0" dirty="0"/>
+          </a:p>
+        </p:txBody>
+      </p:sp>
+      <p:sp>
+        <p:nvSpPr>
+          <p:cNvPr id="11" name="Fußzeilenplatzhalter 10">
+            <a:extLst>
+              <a:ext uri="{FF2B5EF4-FFF2-40B4-BE49-F238E27FC236}">
+                <a16:creationId xmlns:a16="http://schemas.microsoft.com/office/drawing/2014/main" id="{E0ABAD69-43AC-D932-B15F-D0E672663AF0}"/>
+              </a:ext>
+            </a:extLst>
+          </p:cNvPr>
+          <p:cNvSpPr>
+            <a:spLocks noGrp="1"/>
+          </p:cNvSpPr>
+          <p:nvPr>
+            <p:ph type="ftr" sz="quarter" idx="17"/>
+          </p:nvPr>
+        </p:nvSpPr>
+        <p:spPr/>
+        <p:txBody>
+          <a:bodyPr/>
+          <a:lstStyle/>
+          <a:p>
+            <a:endParaRPr lang="en-US" noProof="0" dirty="0"/>
+          </a:p>
+        </p:txBody>
+      </p:sp>
+      <p:sp>
+        <p:nvSpPr>
+          <p:cNvPr id="12" name="Foliennummernplatzhalter 11">
+            <a:extLst>
+              <a:ext uri="{FF2B5EF4-FFF2-40B4-BE49-F238E27FC236}">
+                <a16:creationId xmlns:a16="http://schemas.microsoft.com/office/drawing/2014/main" id="{08D30E9D-0965-D08C-B126-2AD14507A205}"/>
+              </a:ext>
+            </a:extLst>
+          </p:cNvPr>
+          <p:cNvSpPr>
+            <a:spLocks noGrp="1"/>
+          </p:cNvSpPr>
+          <p:nvPr>
+            <p:ph type="sldNum" sz="quarter" idx="18"/>
+          </p:nvPr>
+        </p:nvSpPr>
+        <p:spPr/>
+        <p:txBody>
+          <a:bodyPr/>
+          <a:lstStyle/>
+          <a:p>
+            <a:fld id="{E6639024-6672-4F87-864B-EA4FA9190A1A}" type="slidenum">
+              <a:rPr lang="en-US" noProof="0" smtClean="0"/>
+              <a:pPr/>
+              <a:t>40</a:t>
+            </a:fld>
+            <a:endParaRPr lang="en-US" noProof="0" dirty="0"/>
+          </a:p>
+        </p:txBody>
+      </p:sp>
+    </p:spTree>
+    <p:extLst>
+      <p:ext uri="{BB962C8B-B14F-4D97-AF65-F5344CB8AC3E}">
+        <p14:creationId xmlns:p14="http://schemas.microsoft.com/office/powerpoint/2010/main" val="2743562481"/>
+      </p:ext>
+    </p:extLst>
+  </p:cSld>
+  <p:clrMapOvr>
+    <a:masterClrMapping/>
+  </p:clrMapOvr>
+</p:sld>
+</file>
+
+<file path=ppt/slides/slide41.xml><?xml version="1.0" encoding="utf-8"?>
+<p:sld xmlns:a="http://schemas.openxmlformats.org/drawingml/2006/main" xmlns:r="http://schemas.openxmlformats.org/officeDocument/2006/relationships" xmlns:p="http://schemas.openxmlformats.org/presentationml/2006/main">
+  <p:cSld>
+    <p:spTree>
+      <p:nvGrpSpPr>
+        <p:cNvPr id="1" name="">
+          <a:extLst>
+            <a:ext uri="{FF2B5EF4-FFF2-40B4-BE49-F238E27FC236}">
               <a16:creationId xmlns:a16="http://schemas.microsoft.com/office/drawing/2014/main" id="{51F29159-1E84-C261-434B-0CC9EBBFC7FA}"/>
             </a:ext>
           </a:extLst>
@@ -42887,7 +43217,7 @@
             <a:fld id="{E6639024-6672-4F87-864B-EA4FA9190A1A}" type="slidenum">
               <a:rPr lang="en-US" noProof="0" smtClean="0"/>
               <a:pPr/>
-              <a:t>40</a:t>
+              <a:t>41</a:t>
             </a:fld>
             <a:endParaRPr lang="en-US" noProof="0" dirty="0"/>
           </a:p>
@@ -42906,7 +43236,7 @@
 </p:sld>
 </file>
 
-<file path=ppt/slides/slide41.xml><?xml version="1.0" encoding="utf-8"?>
+<file path=ppt/slides/slide42.xml><?xml version="1.0" encoding="utf-8"?>
 <p:sld xmlns:a="http://schemas.openxmlformats.org/drawingml/2006/main" xmlns:r="http://schemas.openxmlformats.org/officeDocument/2006/relationships" xmlns:p="http://schemas.openxmlformats.org/presentationml/2006/main">
   <p:cSld>
     <p:spTree>
@@ -43121,7 +43451,7 @@
             <a:fld id="{E6639024-6672-4F87-864B-EA4FA9190A1A}" type="slidenum">
               <a:rPr lang="en-US" noProof="0" smtClean="0"/>
               <a:pPr/>
-              <a:t>41</a:t>
+              <a:t>42</a:t>
             </a:fld>
             <a:endParaRPr lang="en-US" noProof="0" dirty="0"/>
           </a:p>
@@ -43129,10 +43459,10 @@
       </p:sp>
       <p:pic>
         <p:nvPicPr>
-          <p:cNvPr id="3" name="Grafik 2" descr="Ein Bild, das Text, Screenshot, Diagramm, Reihe enthält.&#10;&#10;KI-generierte Inhalte können fehlerhaft sein.">
+          <p:cNvPr id="14" name="Grafik 13" descr="Ein Bild, das Text, Screenshot, Diagramm, Reihe enthält.&#10;&#10;KI-generierte Inhalte können fehlerhaft sein.">
             <a:extLst>
               <a:ext uri="{FF2B5EF4-FFF2-40B4-BE49-F238E27FC236}">
-                <a16:creationId xmlns:a16="http://schemas.microsoft.com/office/drawing/2014/main" id="{C248F9D5-5A82-83F9-3F7E-8FCF1E3CBF3E}"/>
+                <a16:creationId xmlns:a16="http://schemas.microsoft.com/office/drawing/2014/main" id="{D1077B73-6AD1-11DE-AB4E-213FB00C9F9B}"/>
               </a:ext>
             </a:extLst>
           </p:cNvPr>
@@ -43142,21 +43472,15 @@
           <p:nvPr/>
         </p:nvPicPr>
         <p:blipFill>
-          <a:blip r:embed="rId2">
-            <a:extLst>
-              <a:ext uri="{28A0092B-C50C-407E-A947-70E740481C1C}">
-                <a14:useLocalDpi xmlns:a14="http://schemas.microsoft.com/office/drawing/2010/main" val="0"/>
-              </a:ext>
-            </a:extLst>
-          </a:blip>
+          <a:blip r:embed="rId2"/>
           <a:stretch>
             <a:fillRect/>
           </a:stretch>
         </p:blipFill>
         <p:spPr>
           <a:xfrm>
-            <a:off x="3484161" y="1914334"/>
-            <a:ext cx="5299839" cy="2621666"/>
+            <a:off x="3286161" y="1958013"/>
+            <a:ext cx="5299839" cy="2629862"/>
           </a:xfrm>
           <a:prstGeom prst="rect">
             <a:avLst/>
@@ -43176,7 +43500,7 @@
 </p:sld>
 </file>
 
-<file path=ppt/slides/slide42.xml><?xml version="1.0" encoding="utf-8"?>
+<file path=ppt/slides/slide43.xml><?xml version="1.0" encoding="utf-8"?>
 <p:sld xmlns:a="http://schemas.openxmlformats.org/drawingml/2006/main" xmlns:r="http://schemas.openxmlformats.org/officeDocument/2006/relationships" xmlns:p="http://schemas.openxmlformats.org/presentationml/2006/main">
   <p:cSld>
     <p:spTree>
@@ -43413,7 +43737,7 @@
             <a:fld id="{E6639024-6672-4F87-864B-EA4FA9190A1A}" type="slidenum">
               <a:rPr lang="en-US" noProof="0" smtClean="0"/>
               <a:pPr/>
-              <a:t>42</a:t>
+              <a:t>43</a:t>
             </a:fld>
             <a:endParaRPr lang="en-US" noProof="0" dirty="0"/>
           </a:p>
@@ -43432,7 +43756,7 @@
 </p:sld>
 </file>
 
-<file path=ppt/slides/slide43.xml><?xml version="1.0" encoding="utf-8"?>
+<file path=ppt/slides/slide44.xml><?xml version="1.0" encoding="utf-8"?>
 <p:sld xmlns:a="http://schemas.openxmlformats.org/drawingml/2006/main" xmlns:r="http://schemas.openxmlformats.org/officeDocument/2006/relationships" xmlns:p="http://schemas.openxmlformats.org/presentationml/2006/main">
   <p:cSld>
     <p:spTree>
@@ -43653,7 +43977,7 @@
             <a:fld id="{E6639024-6672-4F87-864B-EA4FA9190A1A}" type="slidenum">
               <a:rPr lang="en-US" noProof="0" smtClean="0"/>
               <a:pPr/>
-              <a:t>43</a:t>
+              <a:t>44</a:t>
             </a:fld>
             <a:endParaRPr lang="en-US" noProof="0" dirty="0"/>
           </a:p>
@@ -43672,7 +43996,7 @@
 </p:sld>
 </file>
 
-<file path=ppt/slides/slide44.xml><?xml version="1.0" encoding="utf-8"?>
+<file path=ppt/slides/slide45.xml><?xml version="1.0" encoding="utf-8"?>
 <p:sld xmlns:a="http://schemas.openxmlformats.org/drawingml/2006/main" xmlns:r="http://schemas.openxmlformats.org/officeDocument/2006/relationships" xmlns:p="http://schemas.openxmlformats.org/presentationml/2006/main">
   <p:cSld>
     <p:spTree>
@@ -43893,7 +44217,7 @@
             <a:fld id="{E6639024-6672-4F87-864B-EA4FA9190A1A}" type="slidenum">
               <a:rPr lang="en-US" noProof="0" smtClean="0"/>
               <a:pPr/>
-              <a:t>44</a:t>
+              <a:t>45</a:t>
             </a:fld>
             <a:endParaRPr lang="en-US" noProof="0" dirty="0"/>
           </a:p>
@@ -43912,7 +44236,7 @@
 </p:sld>
 </file>
 
-<file path=ppt/slides/slide45.xml><?xml version="1.0" encoding="utf-8"?>
+<file path=ppt/slides/slide46.xml><?xml version="1.0" encoding="utf-8"?>
 <p:sld xmlns:a="http://schemas.openxmlformats.org/drawingml/2006/main" xmlns:r="http://schemas.openxmlformats.org/officeDocument/2006/relationships" xmlns:p="http://schemas.openxmlformats.org/presentationml/2006/main">
   <p:cSld>
     <p:spTree>
@@ -44133,7 +44457,7 @@
             <a:fld id="{E6639024-6672-4F87-864B-EA4FA9190A1A}" type="slidenum">
               <a:rPr lang="en-US" noProof="0" smtClean="0"/>
               <a:pPr/>
-              <a:t>45</a:t>
+              <a:t>46</a:t>
             </a:fld>
             <a:endParaRPr lang="en-US" noProof="0" dirty="0"/>
           </a:p>
@@ -44152,7 +44476,7 @@
 </p:sld>
 </file>
 
-<file path=ppt/slides/slide46.xml><?xml version="1.0" encoding="utf-8"?>
+<file path=ppt/slides/slide47.xml><?xml version="1.0" encoding="utf-8"?>
 <p:sld xmlns:a="http://schemas.openxmlformats.org/drawingml/2006/main" xmlns:r="http://schemas.openxmlformats.org/officeDocument/2006/relationships" xmlns:p="http://schemas.openxmlformats.org/presentationml/2006/main">
   <p:cSld>
     <p:spTree>
@@ -44409,7 +44733,7 @@
             <a:fld id="{E6639024-6672-4F87-864B-EA4FA9190A1A}" type="slidenum">
               <a:rPr lang="en-US" noProof="0" smtClean="0"/>
               <a:pPr/>
-              <a:t>46</a:t>
+              <a:t>47</a:t>
             </a:fld>
             <a:endParaRPr lang="en-US" noProof="0" dirty="0"/>
           </a:p>
@@ -44428,7 +44752,7 @@
 </p:sld>
 </file>
 
-<file path=ppt/slides/slide47.xml><?xml version="1.0" encoding="utf-8"?>
+<file path=ppt/slides/slide48.xml><?xml version="1.0" encoding="utf-8"?>
 <p:sld xmlns:a="http://schemas.openxmlformats.org/drawingml/2006/main" xmlns:r="http://schemas.openxmlformats.org/officeDocument/2006/relationships" xmlns:p="http://schemas.openxmlformats.org/presentationml/2006/main">
   <p:cSld>
     <p:spTree>
@@ -44617,7 +44941,7 @@
             <a:fld id="{E6639024-6672-4F87-864B-EA4FA9190A1A}" type="slidenum">
               <a:rPr lang="en-US" noProof="0" smtClean="0"/>
               <a:pPr/>
-              <a:t>47</a:t>
+              <a:t>48</a:t>
             </a:fld>
             <a:endParaRPr lang="en-US" noProof="0" dirty="0"/>
           </a:p>
@@ -44636,7 +44960,7 @@
 </p:sld>
 </file>
 
-<file path=ppt/slides/slide48.xml><?xml version="1.0" encoding="utf-8"?>
+<file path=ppt/slides/slide49.xml><?xml version="1.0" encoding="utf-8"?>
 <p:sld xmlns:a="http://schemas.openxmlformats.org/drawingml/2006/main" xmlns:r="http://schemas.openxmlformats.org/officeDocument/2006/relationships" xmlns:p="http://schemas.openxmlformats.org/presentationml/2006/main">
   <p:cSld>
     <p:spTree>
@@ -44905,7 +45229,7 @@
             <a:fld id="{E6639024-6672-4F87-864B-EA4FA9190A1A}" type="slidenum">
               <a:rPr lang="en-US" noProof="0" smtClean="0"/>
               <a:pPr/>
-              <a:t>48</a:t>
+              <a:t>49</a:t>
             </a:fld>
             <a:endParaRPr lang="en-US" noProof="0" dirty="0"/>
           </a:p>
@@ -44915,406 +45239,6 @@
     <p:extLst>
       <p:ext uri="{BB962C8B-B14F-4D97-AF65-F5344CB8AC3E}">
         <p14:creationId xmlns:p14="http://schemas.microsoft.com/office/powerpoint/2010/main" val="2128757960"/>
-      </p:ext>
-    </p:extLst>
-  </p:cSld>
-  <p:clrMapOvr>
-    <a:masterClrMapping/>
-  </p:clrMapOvr>
-</p:sld>
-</file>
-
-<file path=ppt/slides/slide49.xml><?xml version="1.0" encoding="utf-8"?>
-<p:sld xmlns:a="http://schemas.openxmlformats.org/drawingml/2006/main" xmlns:r="http://schemas.openxmlformats.org/officeDocument/2006/relationships" xmlns:p="http://schemas.openxmlformats.org/presentationml/2006/main">
-  <p:cSld>
-    <p:spTree>
-      <p:nvGrpSpPr>
-        <p:cNvPr id="1" name="">
-          <a:extLst>
-            <a:ext uri="{FF2B5EF4-FFF2-40B4-BE49-F238E27FC236}">
-              <a16:creationId xmlns:a16="http://schemas.microsoft.com/office/drawing/2014/main" id="{BB40AE52-FC4D-C8EB-2D9D-4D6B89AF5260}"/>
-            </a:ext>
-          </a:extLst>
-        </p:cNvPr>
-        <p:cNvGrpSpPr/>
-        <p:nvPr/>
-      </p:nvGrpSpPr>
-      <p:grpSpPr>
-        <a:xfrm>
-          <a:off x="0" y="0"/>
-          <a:ext cx="0" cy="0"/>
-          <a:chOff x="0" y="0"/>
-          <a:chExt cx="0" cy="0"/>
-        </a:xfrm>
-      </p:grpSpPr>
-      <p:sp>
-        <p:nvSpPr>
-          <p:cNvPr id="8" name="Textplatzhalter 7">
-            <a:extLst>
-              <a:ext uri="{FF2B5EF4-FFF2-40B4-BE49-F238E27FC236}">
-                <a16:creationId xmlns:a16="http://schemas.microsoft.com/office/drawing/2014/main" id="{CDED4ACE-6196-C8D7-8A33-7F52874BCD9F}"/>
-              </a:ext>
-            </a:extLst>
-          </p:cNvPr>
-          <p:cNvSpPr>
-            <a:spLocks noGrp="1"/>
-          </p:cNvSpPr>
-          <p:nvPr>
-            <p:ph type="body" sz="quarter" idx="12"/>
-          </p:nvPr>
-        </p:nvSpPr>
-        <p:spPr/>
-        <p:txBody>
-          <a:bodyPr/>
-          <a:lstStyle/>
-          <a:p>
-            <a:endParaRPr lang="en-US" noProof="0" dirty="0"/>
-          </a:p>
-        </p:txBody>
-      </p:sp>
-      <p:sp>
-        <p:nvSpPr>
-          <p:cNvPr id="7" name="Titel 6">
-            <a:extLst>
-              <a:ext uri="{FF2B5EF4-FFF2-40B4-BE49-F238E27FC236}">
-                <a16:creationId xmlns:a16="http://schemas.microsoft.com/office/drawing/2014/main" id="{CFA00ED5-48B8-9DCD-233D-6BEB2B0C8011}"/>
-              </a:ext>
-            </a:extLst>
-          </p:cNvPr>
-          <p:cNvSpPr>
-            <a:spLocks noGrp="1"/>
-          </p:cNvSpPr>
-          <p:nvPr>
-            <p:ph type="title"/>
-          </p:nvPr>
-        </p:nvSpPr>
-        <p:spPr/>
-        <p:txBody>
-          <a:bodyPr/>
-          <a:lstStyle/>
-          <a:p>
-            <a:r>
-              <a:rPr lang="en-US" noProof="0" dirty="0">
-                <a:solidFill>
-                  <a:schemeClr val="tx1"/>
-                </a:solidFill>
-              </a:rPr>
-              <a:t>References</a:t>
-            </a:r>
-          </a:p>
-        </p:txBody>
-      </p:sp>
-      <p:sp>
-        <p:nvSpPr>
-          <p:cNvPr id="10" name="Inhaltsplatzhalter 9">
-            <a:extLst>
-              <a:ext uri="{FF2B5EF4-FFF2-40B4-BE49-F238E27FC236}">
-                <a16:creationId xmlns:a16="http://schemas.microsoft.com/office/drawing/2014/main" id="{09A9A1BE-072D-3160-0CDF-6BEE52C1A57A}"/>
-              </a:ext>
-            </a:extLst>
-          </p:cNvPr>
-          <p:cNvSpPr>
-            <a:spLocks noGrp="1"/>
-          </p:cNvSpPr>
-          <p:nvPr>
-            <p:ph sz="quarter" idx="20"/>
-          </p:nvPr>
-        </p:nvSpPr>
-        <p:spPr>
-          <a:xfrm>
-            <a:off x="359533" y="1203598"/>
-            <a:ext cx="8424467" cy="3332402"/>
-          </a:xfrm>
-        </p:spPr>
-        <p:txBody>
-          <a:bodyPr anchor="t">
-            <a:normAutofit/>
-          </a:bodyPr>
-          <a:lstStyle/>
-          <a:p>
-            <a:pPr>
-              <a:lnSpc>
-                <a:spcPct val="150000"/>
-              </a:lnSpc>
-            </a:pPr>
-            <a:r>
-              <a:rPr lang="de-CH" sz="1400" dirty="0"/>
-              <a:t>Chiboora, T. H., </a:t>
-            </a:r>
-            <a:r>
-              <a:rPr lang="de-CH" sz="1400" dirty="0" err="1"/>
-              <a:t>Chacha</a:t>
-            </a:r>
-            <a:r>
-              <a:rPr lang="de-CH" sz="1400" dirty="0"/>
-              <a:t>, L., </a:t>
-            </a:r>
-            <a:r>
-              <a:rPr lang="de-CH" sz="1400" dirty="0" err="1"/>
-              <a:t>Byagutangaza</a:t>
-            </a:r>
-            <a:r>
-              <a:rPr lang="de-CH" sz="1400" dirty="0"/>
-              <a:t>, T., &amp; </a:t>
-            </a:r>
-            <a:r>
-              <a:rPr lang="de-CH" sz="1400" dirty="0" err="1"/>
-              <a:t>Gueye</a:t>
-            </a:r>
-            <a:r>
-              <a:rPr lang="de-CH" sz="1400" dirty="0"/>
-              <a:t>, A. (2023). </a:t>
-            </a:r>
-            <a:r>
-              <a:rPr lang="de-CH" sz="1400" i="1" dirty="0" err="1"/>
-              <a:t>Evaluating</a:t>
-            </a:r>
-            <a:r>
-              <a:rPr lang="de-CH" sz="1400" i="1" dirty="0"/>
-              <a:t> mobile </a:t>
-            </a:r>
-            <a:r>
-              <a:rPr lang="de-CH" sz="1400" i="1" dirty="0" err="1"/>
-              <a:t>banking</a:t>
-            </a:r>
-            <a:r>
-              <a:rPr lang="de-CH" sz="1400" i="1" dirty="0"/>
-              <a:t> </a:t>
-            </a:r>
-            <a:r>
-              <a:rPr lang="de-CH" sz="1400" i="1" dirty="0" err="1"/>
-              <a:t>application</a:t>
-            </a:r>
-            <a:r>
-              <a:rPr lang="de-CH" sz="1400" i="1" dirty="0"/>
-              <a:t> </a:t>
-            </a:r>
-            <a:r>
-              <a:rPr lang="de-CH" sz="1400" i="1" dirty="0" err="1"/>
-              <a:t>security</a:t>
-            </a:r>
-            <a:r>
-              <a:rPr lang="de-CH" sz="1400" i="1" dirty="0"/>
-              <a:t> </a:t>
-            </a:r>
-            <a:r>
-              <a:rPr lang="de-CH" sz="1400" i="1" dirty="0" err="1"/>
-              <a:t>posture</a:t>
-            </a:r>
-            <a:r>
-              <a:rPr lang="de-CH" sz="1400" i="1" dirty="0"/>
-              <a:t> </a:t>
-            </a:r>
-            <a:r>
-              <a:rPr lang="de-CH" sz="1400" i="1" dirty="0" err="1"/>
-              <a:t>using</a:t>
-            </a:r>
-            <a:r>
-              <a:rPr lang="de-CH" sz="1400" i="1" dirty="0"/>
-              <a:t> </a:t>
-            </a:r>
-            <a:r>
-              <a:rPr lang="de-CH" sz="1400" i="1" dirty="0" err="1"/>
-              <a:t>the</a:t>
-            </a:r>
-            <a:r>
-              <a:rPr lang="de-CH" sz="1400" i="1" dirty="0"/>
-              <a:t> </a:t>
-            </a:r>
-            <a:r>
-              <a:rPr lang="de-CH" sz="1400" i="1" dirty="0" err="1"/>
-              <a:t>OWASP’s</a:t>
-            </a:r>
-            <a:r>
-              <a:rPr lang="de-CH" sz="1400" i="1" dirty="0"/>
-              <a:t> MASVS </a:t>
-            </a:r>
-            <a:r>
-              <a:rPr lang="de-CH" sz="1400" i="1" dirty="0" err="1"/>
-              <a:t>framework</a:t>
-            </a:r>
-            <a:r>
-              <a:rPr lang="de-CH" sz="1400" dirty="0"/>
-              <a:t>. In </a:t>
-            </a:r>
-            <a:r>
-              <a:rPr lang="de-CH" sz="1400" i="1" dirty="0"/>
-              <a:t>Proceedings </a:t>
-            </a:r>
-            <a:r>
-              <a:rPr lang="de-CH" sz="1400" i="1" dirty="0" err="1"/>
-              <a:t>of</a:t>
-            </a:r>
-            <a:r>
-              <a:rPr lang="de-CH" sz="1400" i="1" dirty="0"/>
-              <a:t> </a:t>
-            </a:r>
-            <a:r>
-              <a:rPr lang="de-CH" sz="1400" i="1" dirty="0" err="1"/>
-              <a:t>the</a:t>
-            </a:r>
-            <a:r>
-              <a:rPr lang="de-CH" sz="1400" i="1" dirty="0"/>
-              <a:t> 6th ACM SIGCAS/SIGCHI Conference on Computing and </a:t>
-            </a:r>
-            <a:r>
-              <a:rPr lang="de-CH" sz="1400" i="1" dirty="0" err="1"/>
-              <a:t>Sustainable</a:t>
-            </a:r>
-            <a:r>
-              <a:rPr lang="de-CH" sz="1400" i="1" dirty="0"/>
-              <a:t> Societies (COMPASS 2023)</a:t>
-            </a:r>
-            <a:r>
-              <a:rPr lang="de-CH" sz="1400" dirty="0"/>
-              <a:t> (pp. 99–106). ACM. </a:t>
-            </a:r>
-            <a:r>
-              <a:rPr lang="de-CH" sz="1400" dirty="0">
-                <a:hlinkClick r:id="rId2"/>
-              </a:rPr>
-              <a:t>https://doi.org/10.1145/3588001.3609367</a:t>
-            </a:r>
-            <a:endParaRPr lang="de-CH" sz="1400" dirty="0"/>
-          </a:p>
-          <a:p>
-            <a:pPr>
-              <a:lnSpc>
-                <a:spcPct val="150000"/>
-              </a:lnSpc>
-            </a:pPr>
-            <a:r>
-              <a:rPr lang="en-US" sz="1400" dirty="0"/>
-              <a:t>OWASP Mobile Application Security. (2025). </a:t>
-            </a:r>
-            <a:r>
-              <a:rPr lang="en-US" sz="1400" i="1" dirty="0"/>
-              <a:t>Home page</a:t>
-            </a:r>
-            <a:r>
-              <a:rPr lang="en-US" sz="1400" dirty="0"/>
-              <a:t>. The OWASP Foundation. </a:t>
-            </a:r>
-            <a:r>
-              <a:rPr lang="en-US" sz="1400" dirty="0">
-                <a:hlinkClick r:id="rId3"/>
-              </a:rPr>
-              <a:t>https://mas.owasp.org/</a:t>
-            </a:r>
-            <a:endParaRPr lang="en-US" sz="1400" dirty="0"/>
-          </a:p>
-          <a:p>
-            <a:pPr>
-              <a:lnSpc>
-                <a:spcPct val="150000"/>
-              </a:lnSpc>
-            </a:pPr>
-            <a:r>
-              <a:rPr lang="en-US" sz="1400" dirty="0"/>
-              <a:t>OWASP Mobile Application Security Testing Guide (MASTG). (2025). </a:t>
-            </a:r>
-            <a:r>
-              <a:rPr lang="en-US" sz="1400" i="1" dirty="0"/>
-              <a:t>Android reference apps section</a:t>
-            </a:r>
-            <a:r>
-              <a:rPr lang="en-US" sz="1400" dirty="0"/>
-              <a:t>. The OWASP Foundation. </a:t>
-            </a:r>
-            <a:r>
-              <a:rPr lang="en-US" sz="1400" dirty="0">
-                <a:hlinkClick r:id="rId4"/>
-              </a:rPr>
-              <a:t>https://github.com/OWASP/mastg/tree/ffde0bdd9bdfd375d93ddb433bd3134e3977c64d/apps/android</a:t>
-            </a:r>
-            <a:endParaRPr lang="en-US" sz="1400" noProof="0" dirty="0"/>
-          </a:p>
-        </p:txBody>
-      </p:sp>
-      <p:sp>
-        <p:nvSpPr>
-          <p:cNvPr id="9" name="Textplatzhalter 8">
-            <a:extLst>
-              <a:ext uri="{FF2B5EF4-FFF2-40B4-BE49-F238E27FC236}">
-                <a16:creationId xmlns:a16="http://schemas.microsoft.com/office/drawing/2014/main" id="{0FD75FB1-E467-F2FE-BC4D-F49775063E4C}"/>
-              </a:ext>
-            </a:extLst>
-          </p:cNvPr>
-          <p:cNvSpPr>
-            <a:spLocks noGrp="1"/>
-          </p:cNvSpPr>
-          <p:nvPr>
-            <p:ph type="body" sz="quarter" idx="19"/>
-          </p:nvPr>
-        </p:nvSpPr>
-        <p:spPr/>
-        <p:txBody>
-          <a:bodyPr/>
-          <a:lstStyle/>
-          <a:p>
-            <a:endParaRPr lang="en-US" noProof="0" dirty="0"/>
-          </a:p>
-        </p:txBody>
-      </p:sp>
-      <p:sp>
-        <p:nvSpPr>
-          <p:cNvPr id="11" name="Fußzeilenplatzhalter 10">
-            <a:extLst>
-              <a:ext uri="{FF2B5EF4-FFF2-40B4-BE49-F238E27FC236}">
-                <a16:creationId xmlns:a16="http://schemas.microsoft.com/office/drawing/2014/main" id="{A907E6BB-8850-8DA0-6092-87B50923B4F2}"/>
-              </a:ext>
-            </a:extLst>
-          </p:cNvPr>
-          <p:cNvSpPr>
-            <a:spLocks noGrp="1"/>
-          </p:cNvSpPr>
-          <p:nvPr>
-            <p:ph type="ftr" sz="quarter" idx="17"/>
-          </p:nvPr>
-        </p:nvSpPr>
-        <p:spPr/>
-        <p:txBody>
-          <a:bodyPr/>
-          <a:lstStyle/>
-          <a:p>
-            <a:endParaRPr lang="en-US" noProof="0" dirty="0"/>
-          </a:p>
-        </p:txBody>
-      </p:sp>
-      <p:sp>
-        <p:nvSpPr>
-          <p:cNvPr id="12" name="Foliennummernplatzhalter 11">
-            <a:extLst>
-              <a:ext uri="{FF2B5EF4-FFF2-40B4-BE49-F238E27FC236}">
-                <a16:creationId xmlns:a16="http://schemas.microsoft.com/office/drawing/2014/main" id="{32296EAA-DCB2-B193-D4AA-9D3B42002ACE}"/>
-              </a:ext>
-            </a:extLst>
-          </p:cNvPr>
-          <p:cNvSpPr>
-            <a:spLocks noGrp="1"/>
-          </p:cNvSpPr>
-          <p:nvPr>
-            <p:ph type="sldNum" sz="quarter" idx="18"/>
-          </p:nvPr>
-        </p:nvSpPr>
-        <p:spPr/>
-        <p:txBody>
-          <a:bodyPr/>
-          <a:lstStyle/>
-          <a:p>
-            <a:fld id="{E6639024-6672-4F87-864B-EA4FA9190A1A}" type="slidenum">
-              <a:rPr lang="en-US" noProof="0" smtClean="0"/>
-              <a:pPr/>
-              <a:t>49</a:t>
-            </a:fld>
-            <a:endParaRPr lang="en-US" noProof="0" dirty="0"/>
-          </a:p>
-        </p:txBody>
-      </p:sp>
-    </p:spTree>
-    <p:extLst>
-      <p:ext uri="{BB962C8B-B14F-4D97-AF65-F5344CB8AC3E}">
-        <p14:creationId xmlns:p14="http://schemas.microsoft.com/office/powerpoint/2010/main" val="1316929055"/>
       </p:ext>
     </p:extLst>
   </p:cSld>
@@ -45919,6 +45843,406 @@
         <p:cNvPr id="1" name="">
           <a:extLst>
             <a:ext uri="{FF2B5EF4-FFF2-40B4-BE49-F238E27FC236}">
+              <a16:creationId xmlns:a16="http://schemas.microsoft.com/office/drawing/2014/main" id="{BB40AE52-FC4D-C8EB-2D9D-4D6B89AF5260}"/>
+            </a:ext>
+          </a:extLst>
+        </p:cNvPr>
+        <p:cNvGrpSpPr/>
+        <p:nvPr/>
+      </p:nvGrpSpPr>
+      <p:grpSpPr>
+        <a:xfrm>
+          <a:off x="0" y="0"/>
+          <a:ext cx="0" cy="0"/>
+          <a:chOff x="0" y="0"/>
+          <a:chExt cx="0" cy="0"/>
+        </a:xfrm>
+      </p:grpSpPr>
+      <p:sp>
+        <p:nvSpPr>
+          <p:cNvPr id="8" name="Textplatzhalter 7">
+            <a:extLst>
+              <a:ext uri="{FF2B5EF4-FFF2-40B4-BE49-F238E27FC236}">
+                <a16:creationId xmlns:a16="http://schemas.microsoft.com/office/drawing/2014/main" id="{CDED4ACE-6196-C8D7-8A33-7F52874BCD9F}"/>
+              </a:ext>
+            </a:extLst>
+          </p:cNvPr>
+          <p:cNvSpPr>
+            <a:spLocks noGrp="1"/>
+          </p:cNvSpPr>
+          <p:nvPr>
+            <p:ph type="body" sz="quarter" idx="12"/>
+          </p:nvPr>
+        </p:nvSpPr>
+        <p:spPr/>
+        <p:txBody>
+          <a:bodyPr/>
+          <a:lstStyle/>
+          <a:p>
+            <a:endParaRPr lang="en-US" noProof="0" dirty="0"/>
+          </a:p>
+        </p:txBody>
+      </p:sp>
+      <p:sp>
+        <p:nvSpPr>
+          <p:cNvPr id="7" name="Titel 6">
+            <a:extLst>
+              <a:ext uri="{FF2B5EF4-FFF2-40B4-BE49-F238E27FC236}">
+                <a16:creationId xmlns:a16="http://schemas.microsoft.com/office/drawing/2014/main" id="{CFA00ED5-48B8-9DCD-233D-6BEB2B0C8011}"/>
+              </a:ext>
+            </a:extLst>
+          </p:cNvPr>
+          <p:cNvSpPr>
+            <a:spLocks noGrp="1"/>
+          </p:cNvSpPr>
+          <p:nvPr>
+            <p:ph type="title"/>
+          </p:nvPr>
+        </p:nvSpPr>
+        <p:spPr/>
+        <p:txBody>
+          <a:bodyPr/>
+          <a:lstStyle/>
+          <a:p>
+            <a:r>
+              <a:rPr lang="en-US" noProof="0" dirty="0">
+                <a:solidFill>
+                  <a:schemeClr val="tx1"/>
+                </a:solidFill>
+              </a:rPr>
+              <a:t>References</a:t>
+            </a:r>
+          </a:p>
+        </p:txBody>
+      </p:sp>
+      <p:sp>
+        <p:nvSpPr>
+          <p:cNvPr id="10" name="Inhaltsplatzhalter 9">
+            <a:extLst>
+              <a:ext uri="{FF2B5EF4-FFF2-40B4-BE49-F238E27FC236}">
+                <a16:creationId xmlns:a16="http://schemas.microsoft.com/office/drawing/2014/main" id="{09A9A1BE-072D-3160-0CDF-6BEE52C1A57A}"/>
+              </a:ext>
+            </a:extLst>
+          </p:cNvPr>
+          <p:cNvSpPr>
+            <a:spLocks noGrp="1"/>
+          </p:cNvSpPr>
+          <p:nvPr>
+            <p:ph sz="quarter" idx="20"/>
+          </p:nvPr>
+        </p:nvSpPr>
+        <p:spPr>
+          <a:xfrm>
+            <a:off x="359533" y="1203598"/>
+            <a:ext cx="8424467" cy="3332402"/>
+          </a:xfrm>
+        </p:spPr>
+        <p:txBody>
+          <a:bodyPr anchor="t">
+            <a:normAutofit/>
+          </a:bodyPr>
+          <a:lstStyle/>
+          <a:p>
+            <a:pPr>
+              <a:lnSpc>
+                <a:spcPct val="150000"/>
+              </a:lnSpc>
+            </a:pPr>
+            <a:r>
+              <a:rPr lang="de-CH" sz="1400" dirty="0"/>
+              <a:t>Chiboora, T. H., </a:t>
+            </a:r>
+            <a:r>
+              <a:rPr lang="de-CH" sz="1400" dirty="0" err="1"/>
+              <a:t>Chacha</a:t>
+            </a:r>
+            <a:r>
+              <a:rPr lang="de-CH" sz="1400" dirty="0"/>
+              <a:t>, L., </a:t>
+            </a:r>
+            <a:r>
+              <a:rPr lang="de-CH" sz="1400" dirty="0" err="1"/>
+              <a:t>Byagutangaza</a:t>
+            </a:r>
+            <a:r>
+              <a:rPr lang="de-CH" sz="1400" dirty="0"/>
+              <a:t>, T., &amp; </a:t>
+            </a:r>
+            <a:r>
+              <a:rPr lang="de-CH" sz="1400" dirty="0" err="1"/>
+              <a:t>Gueye</a:t>
+            </a:r>
+            <a:r>
+              <a:rPr lang="de-CH" sz="1400" dirty="0"/>
+              <a:t>, A. (2023). </a:t>
+            </a:r>
+            <a:r>
+              <a:rPr lang="de-CH" sz="1400" i="1" dirty="0" err="1"/>
+              <a:t>Evaluating</a:t>
+            </a:r>
+            <a:r>
+              <a:rPr lang="de-CH" sz="1400" i="1" dirty="0"/>
+              <a:t> mobile </a:t>
+            </a:r>
+            <a:r>
+              <a:rPr lang="de-CH" sz="1400" i="1" dirty="0" err="1"/>
+              <a:t>banking</a:t>
+            </a:r>
+            <a:r>
+              <a:rPr lang="de-CH" sz="1400" i="1" dirty="0"/>
+              <a:t> </a:t>
+            </a:r>
+            <a:r>
+              <a:rPr lang="de-CH" sz="1400" i="1" dirty="0" err="1"/>
+              <a:t>application</a:t>
+            </a:r>
+            <a:r>
+              <a:rPr lang="de-CH" sz="1400" i="1" dirty="0"/>
+              <a:t> </a:t>
+            </a:r>
+            <a:r>
+              <a:rPr lang="de-CH" sz="1400" i="1" dirty="0" err="1"/>
+              <a:t>security</a:t>
+            </a:r>
+            <a:r>
+              <a:rPr lang="de-CH" sz="1400" i="1" dirty="0"/>
+              <a:t> </a:t>
+            </a:r>
+            <a:r>
+              <a:rPr lang="de-CH" sz="1400" i="1" dirty="0" err="1"/>
+              <a:t>posture</a:t>
+            </a:r>
+            <a:r>
+              <a:rPr lang="de-CH" sz="1400" i="1" dirty="0"/>
+              <a:t> </a:t>
+            </a:r>
+            <a:r>
+              <a:rPr lang="de-CH" sz="1400" i="1" dirty="0" err="1"/>
+              <a:t>using</a:t>
+            </a:r>
+            <a:r>
+              <a:rPr lang="de-CH" sz="1400" i="1" dirty="0"/>
+              <a:t> </a:t>
+            </a:r>
+            <a:r>
+              <a:rPr lang="de-CH" sz="1400" i="1" dirty="0" err="1"/>
+              <a:t>the</a:t>
+            </a:r>
+            <a:r>
+              <a:rPr lang="de-CH" sz="1400" i="1" dirty="0"/>
+              <a:t> </a:t>
+            </a:r>
+            <a:r>
+              <a:rPr lang="de-CH" sz="1400" i="1" dirty="0" err="1"/>
+              <a:t>OWASP’s</a:t>
+            </a:r>
+            <a:r>
+              <a:rPr lang="de-CH" sz="1400" i="1" dirty="0"/>
+              <a:t> MASVS </a:t>
+            </a:r>
+            <a:r>
+              <a:rPr lang="de-CH" sz="1400" i="1" dirty="0" err="1"/>
+              <a:t>framework</a:t>
+            </a:r>
+            <a:r>
+              <a:rPr lang="de-CH" sz="1400" dirty="0"/>
+              <a:t>. In </a:t>
+            </a:r>
+            <a:r>
+              <a:rPr lang="de-CH" sz="1400" i="1" dirty="0"/>
+              <a:t>Proceedings </a:t>
+            </a:r>
+            <a:r>
+              <a:rPr lang="de-CH" sz="1400" i="1" dirty="0" err="1"/>
+              <a:t>of</a:t>
+            </a:r>
+            <a:r>
+              <a:rPr lang="de-CH" sz="1400" i="1" dirty="0"/>
+              <a:t> </a:t>
+            </a:r>
+            <a:r>
+              <a:rPr lang="de-CH" sz="1400" i="1" dirty="0" err="1"/>
+              <a:t>the</a:t>
+            </a:r>
+            <a:r>
+              <a:rPr lang="de-CH" sz="1400" i="1" dirty="0"/>
+              <a:t> 6th ACM SIGCAS/SIGCHI Conference on Computing and </a:t>
+            </a:r>
+            <a:r>
+              <a:rPr lang="de-CH" sz="1400" i="1" dirty="0" err="1"/>
+              <a:t>Sustainable</a:t>
+            </a:r>
+            <a:r>
+              <a:rPr lang="de-CH" sz="1400" i="1" dirty="0"/>
+              <a:t> Societies (COMPASS 2023)</a:t>
+            </a:r>
+            <a:r>
+              <a:rPr lang="de-CH" sz="1400" dirty="0"/>
+              <a:t> (pp. 99–106). ACM. </a:t>
+            </a:r>
+            <a:r>
+              <a:rPr lang="de-CH" sz="1400" dirty="0">
+                <a:hlinkClick r:id="rId2"/>
+              </a:rPr>
+              <a:t>https://doi.org/10.1145/3588001.3609367</a:t>
+            </a:r>
+            <a:endParaRPr lang="de-CH" sz="1400" dirty="0"/>
+          </a:p>
+          <a:p>
+            <a:pPr>
+              <a:lnSpc>
+                <a:spcPct val="150000"/>
+              </a:lnSpc>
+            </a:pPr>
+            <a:r>
+              <a:rPr lang="en-US" sz="1400" dirty="0"/>
+              <a:t>OWASP Mobile Application Security. (2025). </a:t>
+            </a:r>
+            <a:r>
+              <a:rPr lang="en-US" sz="1400" i="1" dirty="0"/>
+              <a:t>Home page</a:t>
+            </a:r>
+            <a:r>
+              <a:rPr lang="en-US" sz="1400" dirty="0"/>
+              <a:t>. The OWASP Foundation. </a:t>
+            </a:r>
+            <a:r>
+              <a:rPr lang="en-US" sz="1400" dirty="0">
+                <a:hlinkClick r:id="rId3"/>
+              </a:rPr>
+              <a:t>https://mas.owasp.org/</a:t>
+            </a:r>
+            <a:endParaRPr lang="en-US" sz="1400" dirty="0"/>
+          </a:p>
+          <a:p>
+            <a:pPr>
+              <a:lnSpc>
+                <a:spcPct val="150000"/>
+              </a:lnSpc>
+            </a:pPr>
+            <a:r>
+              <a:rPr lang="en-US" sz="1400" dirty="0"/>
+              <a:t>OWASP Mobile Application Security Testing Guide (MASTG). (2025). </a:t>
+            </a:r>
+            <a:r>
+              <a:rPr lang="en-US" sz="1400" i="1" dirty="0"/>
+              <a:t>Android reference apps section</a:t>
+            </a:r>
+            <a:r>
+              <a:rPr lang="en-US" sz="1400" dirty="0"/>
+              <a:t>. The OWASP Foundation. </a:t>
+            </a:r>
+            <a:r>
+              <a:rPr lang="en-US" sz="1400" dirty="0">
+                <a:hlinkClick r:id="rId4"/>
+              </a:rPr>
+              <a:t>https://github.com/OWASP/mastg/tree/ffde0bdd9bdfd375d93ddb433bd3134e3977c64d/apps/android</a:t>
+            </a:r>
+            <a:endParaRPr lang="en-US" sz="1400" noProof="0" dirty="0"/>
+          </a:p>
+        </p:txBody>
+      </p:sp>
+      <p:sp>
+        <p:nvSpPr>
+          <p:cNvPr id="9" name="Textplatzhalter 8">
+            <a:extLst>
+              <a:ext uri="{FF2B5EF4-FFF2-40B4-BE49-F238E27FC236}">
+                <a16:creationId xmlns:a16="http://schemas.microsoft.com/office/drawing/2014/main" id="{0FD75FB1-E467-F2FE-BC4D-F49775063E4C}"/>
+              </a:ext>
+            </a:extLst>
+          </p:cNvPr>
+          <p:cNvSpPr>
+            <a:spLocks noGrp="1"/>
+          </p:cNvSpPr>
+          <p:nvPr>
+            <p:ph type="body" sz="quarter" idx="19"/>
+          </p:nvPr>
+        </p:nvSpPr>
+        <p:spPr/>
+        <p:txBody>
+          <a:bodyPr/>
+          <a:lstStyle/>
+          <a:p>
+            <a:endParaRPr lang="en-US" noProof="0" dirty="0"/>
+          </a:p>
+        </p:txBody>
+      </p:sp>
+      <p:sp>
+        <p:nvSpPr>
+          <p:cNvPr id="11" name="Fußzeilenplatzhalter 10">
+            <a:extLst>
+              <a:ext uri="{FF2B5EF4-FFF2-40B4-BE49-F238E27FC236}">
+                <a16:creationId xmlns:a16="http://schemas.microsoft.com/office/drawing/2014/main" id="{A907E6BB-8850-8DA0-6092-87B50923B4F2}"/>
+              </a:ext>
+            </a:extLst>
+          </p:cNvPr>
+          <p:cNvSpPr>
+            <a:spLocks noGrp="1"/>
+          </p:cNvSpPr>
+          <p:nvPr>
+            <p:ph type="ftr" sz="quarter" idx="17"/>
+          </p:nvPr>
+        </p:nvSpPr>
+        <p:spPr/>
+        <p:txBody>
+          <a:bodyPr/>
+          <a:lstStyle/>
+          <a:p>
+            <a:endParaRPr lang="en-US" noProof="0" dirty="0"/>
+          </a:p>
+        </p:txBody>
+      </p:sp>
+      <p:sp>
+        <p:nvSpPr>
+          <p:cNvPr id="12" name="Foliennummernplatzhalter 11">
+            <a:extLst>
+              <a:ext uri="{FF2B5EF4-FFF2-40B4-BE49-F238E27FC236}">
+                <a16:creationId xmlns:a16="http://schemas.microsoft.com/office/drawing/2014/main" id="{32296EAA-DCB2-B193-D4AA-9D3B42002ACE}"/>
+              </a:ext>
+            </a:extLst>
+          </p:cNvPr>
+          <p:cNvSpPr>
+            <a:spLocks noGrp="1"/>
+          </p:cNvSpPr>
+          <p:nvPr>
+            <p:ph type="sldNum" sz="quarter" idx="18"/>
+          </p:nvPr>
+        </p:nvSpPr>
+        <p:spPr/>
+        <p:txBody>
+          <a:bodyPr/>
+          <a:lstStyle/>
+          <a:p>
+            <a:fld id="{E6639024-6672-4F87-864B-EA4FA9190A1A}" type="slidenum">
+              <a:rPr lang="en-US" noProof="0" smtClean="0"/>
+              <a:pPr/>
+              <a:t>50</a:t>
+            </a:fld>
+            <a:endParaRPr lang="en-US" noProof="0" dirty="0"/>
+          </a:p>
+        </p:txBody>
+      </p:sp>
+    </p:spTree>
+    <p:extLst>
+      <p:ext uri="{BB962C8B-B14F-4D97-AF65-F5344CB8AC3E}">
+        <p14:creationId xmlns:p14="http://schemas.microsoft.com/office/powerpoint/2010/main" val="1316929055"/>
+      </p:ext>
+    </p:extLst>
+  </p:cSld>
+  <p:clrMapOvr>
+    <a:masterClrMapping/>
+  </p:clrMapOvr>
+</p:sld>
+</file>
+
+<file path=ppt/slides/slide51.xml><?xml version="1.0" encoding="utf-8"?>
+<p:sld xmlns:a="http://schemas.openxmlformats.org/drawingml/2006/main" xmlns:r="http://schemas.openxmlformats.org/officeDocument/2006/relationships" xmlns:p="http://schemas.openxmlformats.org/presentationml/2006/main">
+  <p:cSld>
+    <p:spTree>
+      <p:nvGrpSpPr>
+        <p:cNvPr id="1" name="">
+          <a:extLst>
+            <a:ext uri="{FF2B5EF4-FFF2-40B4-BE49-F238E27FC236}">
               <a16:creationId xmlns:a16="http://schemas.microsoft.com/office/drawing/2014/main" id="{D4900803-E03E-4256-407B-FAE7CDFC165F}"/>
             </a:ext>
           </a:extLst>
@@ -46093,7 +46417,7 @@
             <a:fld id="{E6639024-6672-4F87-864B-EA4FA9190A1A}" type="slidenum">
               <a:rPr lang="en-US" noProof="0" smtClean="0"/>
               <a:pPr/>
-              <a:t>50</a:t>
+              <a:t>51</a:t>
             </a:fld>
             <a:endParaRPr lang="en-US" noProof="0" dirty="0"/>
           </a:p>

</xml_diff>

<commit_message>
Adjusted readbility of graph axes and applied finishing touches to my presentation slides for the BA thesis presentation
</commit_message>
<xml_diff>
--- a/dev_documents/presentation/ba_thesis_presentation_kronig.pptx
+++ b/dev_documents/presentation/ba_thesis_presentation_kronig.pptx
@@ -44,17 +44,17 @@
     <p:sldId id="334" r:id="rId32"/>
     <p:sldId id="288" r:id="rId33"/>
     <p:sldId id="289" r:id="rId34"/>
-    <p:sldId id="264" r:id="rId35"/>
-    <p:sldId id="293" r:id="rId36"/>
-    <p:sldId id="331" r:id="rId37"/>
-    <p:sldId id="294" r:id="rId38"/>
-    <p:sldId id="296" r:id="rId39"/>
-    <p:sldId id="297" r:id="rId40"/>
-    <p:sldId id="298" r:id="rId41"/>
-    <p:sldId id="295" r:id="rId42"/>
-    <p:sldId id="282" r:id="rId43"/>
-    <p:sldId id="301" r:id="rId44"/>
-    <p:sldId id="302" r:id="rId45"/>
+    <p:sldId id="336" r:id="rId35"/>
+    <p:sldId id="264" r:id="rId36"/>
+    <p:sldId id="293" r:id="rId37"/>
+    <p:sldId id="331" r:id="rId38"/>
+    <p:sldId id="294" r:id="rId39"/>
+    <p:sldId id="296" r:id="rId40"/>
+    <p:sldId id="297" r:id="rId41"/>
+    <p:sldId id="298" r:id="rId42"/>
+    <p:sldId id="295" r:id="rId43"/>
+    <p:sldId id="282" r:id="rId44"/>
+    <p:sldId id="301" r:id="rId45"/>
     <p:sldId id="283" r:id="rId46"/>
     <p:sldId id="304" r:id="rId47"/>
     <p:sldId id="305" r:id="rId48"/>
@@ -255,7 +255,7 @@
           <a:p>
             <a:fld id="{442B13D9-EE20-4263-A517-453A6CC03581}" type="datetimeFigureOut">
               <a:rPr lang="en-US" smtClean="0"/>
-              <a:t>2/7/2026</a:t>
+              <a:t>2/8/2026</a:t>
             </a:fld>
             <a:endParaRPr lang="en-US"/>
           </a:p>
@@ -420,7 +420,7 @@
           <a:p>
             <a:fld id="{C4B9E2E8-0589-406D-8FD1-7B0DBC84FBDE}" type="datetimeFigureOut">
               <a:rPr lang="de-CH" smtClean="0"/>
-              <a:t>07.02.2026</a:t>
+              <a:t>08.02.2026</a:t>
             </a:fld>
             <a:endParaRPr lang="de-CH"/>
           </a:p>
@@ -37118,10 +37118,10 @@
       </p:sp>
       <p:pic>
         <p:nvPicPr>
-          <p:cNvPr id="5" name="Grafik 4" descr="Ein Bild, das Text, Screenshot, Reihe, Diagramm enthält.&#10;&#10;KI-generierte Inhalte können fehlerhaft sein.">
+          <p:cNvPr id="4" name="Grafik 3" descr="Ein Bild, das Text, Screenshot, Diagramm, Reihe enthält.&#10;&#10;KI-generierte Inhalte können fehlerhaft sein.">
             <a:extLst>
               <a:ext uri="{FF2B5EF4-FFF2-40B4-BE49-F238E27FC236}">
-                <a16:creationId xmlns:a16="http://schemas.microsoft.com/office/drawing/2014/main" id="{221CF007-E999-38C4-B860-53368421C26B}"/>
+                <a16:creationId xmlns:a16="http://schemas.microsoft.com/office/drawing/2014/main" id="{8BA1C4DB-FA78-CC79-254A-F04BC5514D14}"/>
               </a:ext>
             </a:extLst>
           </p:cNvPr>
@@ -37138,7 +37138,7 @@
         </p:blipFill>
         <p:spPr>
           <a:xfrm>
-            <a:off x="3281955" y="1866244"/>
+            <a:off x="3281955" y="1852044"/>
             <a:ext cx="5501682" cy="2730019"/>
           </a:xfrm>
           <a:prstGeom prst="rect">
@@ -38142,17 +38142,6 @@
               <a:t>Most implementations cover the same types</a:t>
             </a:r>
           </a:p>
-          <a:p>
-            <a:pPr>
-              <a:lnSpc>
-                <a:spcPct val="150000"/>
-              </a:lnSpc>
-            </a:pPr>
-            <a:r>
-              <a:rPr lang="en-US" noProof="0" dirty="0"/>
-              <a:t>All vulnerabilities should have a reference implementation</a:t>
-            </a:r>
-          </a:p>
         </p:txBody>
       </p:sp>
       <p:sp>
@@ -38404,28 +38393,6 @@
             </a:r>
             <a:endParaRPr lang="en-US" noProof="0" dirty="0"/>
           </a:p>
-          <a:p>
-            <a:pPr>
-              <a:lnSpc>
-                <a:spcPct val="150000"/>
-              </a:lnSpc>
-            </a:pPr>
-            <a:r>
-              <a:rPr lang="en-US" noProof="0" dirty="0"/>
-              <a:t>Focus on MASVS-CRYPTO</a:t>
-            </a:r>
-          </a:p>
-          <a:p>
-            <a:pPr>
-              <a:lnSpc>
-                <a:spcPct val="150000"/>
-              </a:lnSpc>
-            </a:pPr>
-            <a:r>
-              <a:rPr lang="en-US" noProof="0" dirty="0"/>
-              <a:t>Start with MASVS-STORAGE</a:t>
-            </a:r>
-          </a:p>
         </p:txBody>
       </p:sp>
       <p:sp>
@@ -38522,6 +38489,256 @@
 </file>
 
 <file path=ppt/slides/slide32.xml><?xml version="1.0" encoding="utf-8"?>
+<p:sld xmlns:a="http://schemas.openxmlformats.org/drawingml/2006/main" xmlns:r="http://schemas.openxmlformats.org/officeDocument/2006/relationships" xmlns:p="http://schemas.openxmlformats.org/presentationml/2006/main">
+  <p:cSld>
+    <p:spTree>
+      <p:nvGrpSpPr>
+        <p:cNvPr id="1" name="">
+          <a:extLst>
+            <a:ext uri="{FF2B5EF4-FFF2-40B4-BE49-F238E27FC236}">
+              <a16:creationId xmlns:a16="http://schemas.microsoft.com/office/drawing/2014/main" id="{A40A3952-823F-8219-7E6A-8D8FC0756857}"/>
+            </a:ext>
+          </a:extLst>
+        </p:cNvPr>
+        <p:cNvGrpSpPr/>
+        <p:nvPr/>
+      </p:nvGrpSpPr>
+      <p:grpSpPr>
+        <a:xfrm>
+          <a:off x="0" y="0"/>
+          <a:ext cx="0" cy="0"/>
+          <a:chOff x="0" y="0"/>
+          <a:chExt cx="0" cy="0"/>
+        </a:xfrm>
+      </p:grpSpPr>
+      <p:sp>
+        <p:nvSpPr>
+          <p:cNvPr id="8" name="Textplatzhalter 7">
+            <a:extLst>
+              <a:ext uri="{FF2B5EF4-FFF2-40B4-BE49-F238E27FC236}">
+                <a16:creationId xmlns:a16="http://schemas.microsoft.com/office/drawing/2014/main" id="{4BD67313-B2D8-1380-031F-011B643D7550}"/>
+              </a:ext>
+            </a:extLst>
+          </p:cNvPr>
+          <p:cNvSpPr>
+            <a:spLocks noGrp="1"/>
+          </p:cNvSpPr>
+          <p:nvPr>
+            <p:ph type="body" sz="quarter" idx="12"/>
+          </p:nvPr>
+        </p:nvSpPr>
+        <p:spPr/>
+        <p:txBody>
+          <a:bodyPr/>
+          <a:lstStyle/>
+          <a:p>
+            <a:r>
+              <a:rPr lang="en-US" dirty="0">
+                <a:solidFill>
+                  <a:schemeClr val="bg2"/>
+                </a:solidFill>
+              </a:rPr>
+              <a:t>Significance for Our Apps</a:t>
+            </a:r>
+            <a:endParaRPr lang="en-US" noProof="0" dirty="0">
+              <a:solidFill>
+                <a:schemeClr val="bg2"/>
+              </a:solidFill>
+            </a:endParaRPr>
+          </a:p>
+        </p:txBody>
+      </p:sp>
+      <p:sp>
+        <p:nvSpPr>
+          <p:cNvPr id="7" name="Titel 6">
+            <a:extLst>
+              <a:ext uri="{FF2B5EF4-FFF2-40B4-BE49-F238E27FC236}">
+                <a16:creationId xmlns:a16="http://schemas.microsoft.com/office/drawing/2014/main" id="{722999AC-490B-298B-56E1-A8B3438BDE52}"/>
+              </a:ext>
+            </a:extLst>
+          </p:cNvPr>
+          <p:cNvSpPr>
+            <a:spLocks noGrp="1"/>
+          </p:cNvSpPr>
+          <p:nvPr>
+            <p:ph type="title"/>
+          </p:nvPr>
+        </p:nvSpPr>
+        <p:spPr/>
+        <p:txBody>
+          <a:bodyPr/>
+          <a:lstStyle/>
+          <a:p>
+            <a:r>
+              <a:rPr lang="en-US" dirty="0">
+                <a:solidFill>
+                  <a:schemeClr val="tx1"/>
+                </a:solidFill>
+              </a:rPr>
+              <a:t>State of the Art in MASTG Reference Apps</a:t>
+            </a:r>
+            <a:endParaRPr lang="en-US" noProof="0" dirty="0">
+              <a:solidFill>
+                <a:schemeClr val="tx1"/>
+              </a:solidFill>
+            </a:endParaRPr>
+          </a:p>
+        </p:txBody>
+      </p:sp>
+      <p:sp>
+        <p:nvSpPr>
+          <p:cNvPr id="10" name="Inhaltsplatzhalter 9">
+            <a:extLst>
+              <a:ext uri="{FF2B5EF4-FFF2-40B4-BE49-F238E27FC236}">
+                <a16:creationId xmlns:a16="http://schemas.microsoft.com/office/drawing/2014/main" id="{93D12BA4-0790-FBF1-683E-0A2BB0F0B99D}"/>
+              </a:ext>
+            </a:extLst>
+          </p:cNvPr>
+          <p:cNvSpPr>
+            <a:spLocks noGrp="1"/>
+          </p:cNvSpPr>
+          <p:nvPr>
+            <p:ph sz="quarter" idx="20"/>
+          </p:nvPr>
+        </p:nvSpPr>
+        <p:spPr>
+          <a:xfrm>
+            <a:off x="359533" y="1203598"/>
+            <a:ext cx="8424467" cy="3332402"/>
+          </a:xfrm>
+        </p:spPr>
+        <p:txBody>
+          <a:bodyPr anchor="t"/>
+          <a:lstStyle/>
+          <a:p>
+            <a:pPr>
+              <a:lnSpc>
+                <a:spcPct val="150000"/>
+              </a:lnSpc>
+            </a:pPr>
+            <a:r>
+              <a:rPr lang="en-US" noProof="0" dirty="0"/>
+              <a:t>One category at a time</a:t>
+            </a:r>
+          </a:p>
+          <a:p>
+            <a:pPr>
+              <a:lnSpc>
+                <a:spcPct val="150000"/>
+              </a:lnSpc>
+            </a:pPr>
+            <a:r>
+              <a:rPr lang="en-US" noProof="0" dirty="0"/>
+              <a:t>Focus on MASVS-CRYPTO</a:t>
+            </a:r>
+          </a:p>
+          <a:p>
+            <a:pPr>
+              <a:lnSpc>
+                <a:spcPct val="150000"/>
+              </a:lnSpc>
+            </a:pPr>
+            <a:r>
+              <a:rPr lang="en-US" noProof="0" dirty="0"/>
+              <a:t>Start with MASVS-STORAGE</a:t>
+            </a:r>
+          </a:p>
+        </p:txBody>
+      </p:sp>
+      <p:sp>
+        <p:nvSpPr>
+          <p:cNvPr id="9" name="Textplatzhalter 8">
+            <a:extLst>
+              <a:ext uri="{FF2B5EF4-FFF2-40B4-BE49-F238E27FC236}">
+                <a16:creationId xmlns:a16="http://schemas.microsoft.com/office/drawing/2014/main" id="{340E70E9-4E14-C78A-35F9-9776B9C431E8}"/>
+              </a:ext>
+            </a:extLst>
+          </p:cNvPr>
+          <p:cNvSpPr>
+            <a:spLocks noGrp="1"/>
+          </p:cNvSpPr>
+          <p:nvPr>
+            <p:ph type="body" sz="quarter" idx="19"/>
+          </p:nvPr>
+        </p:nvSpPr>
+        <p:spPr/>
+        <p:txBody>
+          <a:bodyPr/>
+          <a:lstStyle/>
+          <a:p>
+            <a:endParaRPr lang="en-US" noProof="0" dirty="0"/>
+          </a:p>
+        </p:txBody>
+      </p:sp>
+      <p:sp>
+        <p:nvSpPr>
+          <p:cNvPr id="11" name="Fußzeilenplatzhalter 10">
+            <a:extLst>
+              <a:ext uri="{FF2B5EF4-FFF2-40B4-BE49-F238E27FC236}">
+                <a16:creationId xmlns:a16="http://schemas.microsoft.com/office/drawing/2014/main" id="{60C9F215-4ADC-3AC7-E5DE-B9819A9EDBE7}"/>
+              </a:ext>
+            </a:extLst>
+          </p:cNvPr>
+          <p:cNvSpPr>
+            <a:spLocks noGrp="1"/>
+          </p:cNvSpPr>
+          <p:nvPr>
+            <p:ph type="ftr" sz="quarter" idx="17"/>
+          </p:nvPr>
+        </p:nvSpPr>
+        <p:spPr/>
+        <p:txBody>
+          <a:bodyPr/>
+          <a:lstStyle/>
+          <a:p>
+            <a:endParaRPr lang="en-US" noProof="0" dirty="0"/>
+          </a:p>
+        </p:txBody>
+      </p:sp>
+      <p:sp>
+        <p:nvSpPr>
+          <p:cNvPr id="12" name="Foliennummernplatzhalter 11">
+            <a:extLst>
+              <a:ext uri="{FF2B5EF4-FFF2-40B4-BE49-F238E27FC236}">
+                <a16:creationId xmlns:a16="http://schemas.microsoft.com/office/drawing/2014/main" id="{905A06EB-2963-FEAA-FBFF-9344A5D613A7}"/>
+              </a:ext>
+            </a:extLst>
+          </p:cNvPr>
+          <p:cNvSpPr>
+            <a:spLocks noGrp="1"/>
+          </p:cNvSpPr>
+          <p:nvPr>
+            <p:ph type="sldNum" sz="quarter" idx="18"/>
+          </p:nvPr>
+        </p:nvSpPr>
+        <p:spPr/>
+        <p:txBody>
+          <a:bodyPr/>
+          <a:lstStyle/>
+          <a:p>
+            <a:fld id="{E6639024-6672-4F87-864B-EA4FA9190A1A}" type="slidenum">
+              <a:rPr lang="en-US" noProof="0" smtClean="0"/>
+              <a:pPr/>
+              <a:t>32</a:t>
+            </a:fld>
+            <a:endParaRPr lang="en-US" noProof="0" dirty="0"/>
+          </a:p>
+        </p:txBody>
+      </p:sp>
+    </p:spTree>
+    <p:extLst>
+      <p:ext uri="{BB962C8B-B14F-4D97-AF65-F5344CB8AC3E}">
+        <p14:creationId xmlns:p14="http://schemas.microsoft.com/office/powerpoint/2010/main" val="3936751353"/>
+      </p:ext>
+    </p:extLst>
+  </p:cSld>
+  <p:clrMapOvr>
+    <a:masterClrMapping/>
+  </p:clrMapOvr>
+</p:sld>
+</file>
+
+<file path=ppt/slides/slide33.xml><?xml version="1.0" encoding="utf-8"?>
 <p:sld xmlns:a="http://schemas.openxmlformats.org/drawingml/2006/main" xmlns:r="http://schemas.openxmlformats.org/officeDocument/2006/relationships" xmlns:p="http://schemas.openxmlformats.org/presentationml/2006/main">
   <p:cSld>
     <p:spTree>
@@ -38722,7 +38939,7 @@
             <a:fld id="{E6639024-6672-4F87-864B-EA4FA9190A1A}" type="slidenum">
               <a:rPr lang="en-US" noProof="0" smtClean="0"/>
               <a:pPr/>
-              <a:t>32</a:t>
+              <a:t>33</a:t>
             </a:fld>
             <a:endParaRPr lang="en-US" noProof="0" dirty="0"/>
           </a:p>
@@ -38974,7 +39191,7 @@
 </p:sld>
 </file>
 
-<file path=ppt/slides/slide33.xml><?xml version="1.0" encoding="utf-8"?>
+<file path=ppt/slides/slide34.xml><?xml version="1.0" encoding="utf-8"?>
 <p:sld xmlns:a="http://schemas.openxmlformats.org/drawingml/2006/main" xmlns:r="http://schemas.openxmlformats.org/officeDocument/2006/relationships" xmlns:p="http://schemas.openxmlformats.org/presentationml/2006/main">
   <p:cSld>
     <p:spTree>
@@ -39180,7 +39397,7 @@
             <a:fld id="{E6639024-6672-4F87-864B-EA4FA9190A1A}" type="slidenum">
               <a:rPr lang="en-US" noProof="0" smtClean="0"/>
               <a:pPr/>
-              <a:t>33</a:t>
+              <a:t>34</a:t>
             </a:fld>
             <a:endParaRPr lang="en-US" noProof="0" dirty="0"/>
           </a:p>
@@ -39441,7 +39658,7 @@
 </p:sld>
 </file>
 
-<file path=ppt/slides/slide34.xml><?xml version="1.0" encoding="utf-8"?>
+<file path=ppt/slides/slide35.xml><?xml version="1.0" encoding="utf-8"?>
 <p:sld xmlns:a="http://schemas.openxmlformats.org/drawingml/2006/main" xmlns:r="http://schemas.openxmlformats.org/officeDocument/2006/relationships" xmlns:p="http://schemas.openxmlformats.org/presentationml/2006/main">
   <p:cSld>
     <p:spTree>
@@ -39647,7 +39864,7 @@
             <a:fld id="{E6639024-6672-4F87-864B-EA4FA9190A1A}" type="slidenum">
               <a:rPr lang="en-US" noProof="0" smtClean="0"/>
               <a:pPr/>
-              <a:t>34</a:t>
+              <a:t>35</a:t>
             </a:fld>
             <a:endParaRPr lang="en-US" noProof="0" dirty="0"/>
           </a:p>
@@ -39908,7 +40125,7 @@
 </p:sld>
 </file>
 
-<file path=ppt/slides/slide35.xml><?xml version="1.0" encoding="utf-8"?>
+<file path=ppt/slides/slide36.xml><?xml version="1.0" encoding="utf-8"?>
 <p:sld xmlns:a="http://schemas.openxmlformats.org/drawingml/2006/main" xmlns:r="http://schemas.openxmlformats.org/officeDocument/2006/relationships" xmlns:p="http://schemas.openxmlformats.org/presentationml/2006/main">
   <p:cSld>
     <p:spTree>
@@ -40079,7 +40296,7 @@
             <a:fld id="{E6639024-6672-4F87-864B-EA4FA9190A1A}" type="slidenum">
               <a:rPr lang="en-US" noProof="0" smtClean="0"/>
               <a:pPr/>
-              <a:t>35</a:t>
+              <a:t>36</a:t>
             </a:fld>
             <a:endParaRPr lang="en-US" noProof="0" dirty="0"/>
           </a:p>
@@ -40375,7 +40592,7 @@
 </p:sld>
 </file>
 
-<file path=ppt/slides/slide36.xml><?xml version="1.0" encoding="utf-8"?>
+<file path=ppt/slides/slide37.xml><?xml version="1.0" encoding="utf-8"?>
 <p:sld xmlns:a="http://schemas.openxmlformats.org/drawingml/2006/main" xmlns:r="http://schemas.openxmlformats.org/officeDocument/2006/relationships" xmlns:p="http://schemas.openxmlformats.org/presentationml/2006/main">
   <p:cSld>
     <p:spTree>
@@ -40546,7 +40763,7 @@
             <a:fld id="{E6639024-6672-4F87-864B-EA4FA9190A1A}" type="slidenum">
               <a:rPr lang="en-US" noProof="0" smtClean="0"/>
               <a:pPr/>
-              <a:t>36</a:t>
+              <a:t>37</a:t>
             </a:fld>
             <a:endParaRPr lang="en-US" noProof="0" dirty="0"/>
           </a:p>
@@ -40853,7 +41070,7 @@
 </p:sld>
 </file>
 
-<file path=ppt/slides/slide37.xml><?xml version="1.0" encoding="utf-8"?>
+<file path=ppt/slides/slide38.xml><?xml version="1.0" encoding="utf-8"?>
 <p:sld xmlns:a="http://schemas.openxmlformats.org/drawingml/2006/main" xmlns:r="http://schemas.openxmlformats.org/officeDocument/2006/relationships" xmlns:p="http://schemas.openxmlformats.org/presentationml/2006/main">
   <p:cSld>
     <p:spTree>
@@ -41024,7 +41241,7 @@
             <a:fld id="{E6639024-6672-4F87-864B-EA4FA9190A1A}" type="slidenum">
               <a:rPr lang="en-US" noProof="0" smtClean="0"/>
               <a:pPr/>
-              <a:t>37</a:t>
+              <a:t>38</a:t>
             </a:fld>
             <a:endParaRPr lang="en-US" noProof="0" dirty="0"/>
           </a:p>
@@ -41232,7 +41449,7 @@
               <a:buNone/>
             </a:pPr>
             <a:r>
-              <a:rPr lang="en-US" b="1" noProof="0" dirty="0"/>
+              <a:rPr lang="en-US" u="sng" noProof="0" dirty="0"/>
               <a:t>All</a:t>
             </a:r>
             <a:r>
@@ -41256,7 +41473,11 @@
             </a:pPr>
             <a:r>
               <a:rPr lang="en-US" noProof="0" dirty="0"/>
-              <a:t>Login &amp; registration logic</a:t>
+              <a:t>Login </a:t>
+            </a:r>
+            <a:r>
+              <a:rPr lang="en-US" dirty="0"/>
+              <a:t>logic</a:t>
             </a:r>
           </a:p>
           <a:p>
@@ -41267,7 +41488,7 @@
             </a:pPr>
             <a:r>
               <a:rPr lang="en-US" noProof="0" dirty="0"/>
-              <a:t>Layouts</a:t>
+              <a:t>Registration logic</a:t>
             </a:r>
           </a:p>
           <a:p>
@@ -41322,7 +41543,7 @@
 </p:sld>
 </file>
 
-<file path=ppt/slides/slide38.xml><?xml version="1.0" encoding="utf-8"?>
+<file path=ppt/slides/slide39.xml><?xml version="1.0" encoding="utf-8"?>
 <p:sld xmlns:a="http://schemas.openxmlformats.org/drawingml/2006/main" xmlns:r="http://schemas.openxmlformats.org/officeDocument/2006/relationships" xmlns:p="http://schemas.openxmlformats.org/presentationml/2006/main">
   <p:cSld>
     <p:spTree>
@@ -41493,7 +41714,7 @@
             <a:fld id="{E6639024-6672-4F87-864B-EA4FA9190A1A}" type="slidenum">
               <a:rPr lang="en-US" noProof="0" smtClean="0"/>
               <a:pPr/>
-              <a:t>38</a:t>
+              <a:t>39</a:t>
             </a:fld>
             <a:endParaRPr lang="en-US" noProof="0" dirty="0"/>
           </a:p>
@@ -41733,460 +41954,6 @@
     <p:extLst>
       <p:ext uri="{BB962C8B-B14F-4D97-AF65-F5344CB8AC3E}">
         <p14:creationId xmlns:p14="http://schemas.microsoft.com/office/powerpoint/2010/main" val="1834614368"/>
-      </p:ext>
-    </p:extLst>
-  </p:cSld>
-  <p:clrMapOvr>
-    <a:masterClrMapping/>
-  </p:clrMapOvr>
-</p:sld>
-</file>
-
-<file path=ppt/slides/slide39.xml><?xml version="1.0" encoding="utf-8"?>
-<p:sld xmlns:a="http://schemas.openxmlformats.org/drawingml/2006/main" xmlns:r="http://schemas.openxmlformats.org/officeDocument/2006/relationships" xmlns:p="http://schemas.openxmlformats.org/presentationml/2006/main">
-  <p:cSld>
-    <p:spTree>
-      <p:nvGrpSpPr>
-        <p:cNvPr id="1" name="">
-          <a:extLst>
-            <a:ext uri="{FF2B5EF4-FFF2-40B4-BE49-F238E27FC236}">
-              <a16:creationId xmlns:a16="http://schemas.microsoft.com/office/drawing/2014/main" id="{ACD6E733-7832-5804-7FC1-5A31B1EB6365}"/>
-            </a:ext>
-          </a:extLst>
-        </p:cNvPr>
-        <p:cNvGrpSpPr/>
-        <p:nvPr/>
-      </p:nvGrpSpPr>
-      <p:grpSpPr>
-        <a:xfrm>
-          <a:off x="0" y="0"/>
-          <a:ext cx="0" cy="0"/>
-          <a:chOff x="0" y="0"/>
-          <a:chExt cx="0" cy="0"/>
-        </a:xfrm>
-      </p:grpSpPr>
-      <p:sp>
-        <p:nvSpPr>
-          <p:cNvPr id="8" name="Textplatzhalter 7">
-            <a:extLst>
-              <a:ext uri="{FF2B5EF4-FFF2-40B4-BE49-F238E27FC236}">
-                <a16:creationId xmlns:a16="http://schemas.microsoft.com/office/drawing/2014/main" id="{B2102DA2-5FC0-19DA-8369-12AC04B6C90F}"/>
-              </a:ext>
-            </a:extLst>
-          </p:cNvPr>
-          <p:cNvSpPr>
-            <a:spLocks noGrp="1"/>
-          </p:cNvSpPr>
-          <p:nvPr>
-            <p:ph type="body" sz="quarter" idx="12"/>
-          </p:nvPr>
-        </p:nvSpPr>
-        <p:spPr/>
-        <p:txBody>
-          <a:bodyPr/>
-          <a:lstStyle/>
-          <a:p>
-            <a:r>
-              <a:rPr lang="en-US" dirty="0">
-                <a:solidFill>
-                  <a:schemeClr val="bg2"/>
-                </a:solidFill>
-              </a:rPr>
-              <a:t>Architecture Summary</a:t>
-            </a:r>
-            <a:endParaRPr lang="en-US" noProof="0" dirty="0">
-              <a:solidFill>
-                <a:schemeClr val="bg2"/>
-              </a:solidFill>
-            </a:endParaRPr>
-          </a:p>
-        </p:txBody>
-      </p:sp>
-      <p:sp>
-        <p:nvSpPr>
-          <p:cNvPr id="7" name="Titel 6">
-            <a:extLst>
-              <a:ext uri="{FF2B5EF4-FFF2-40B4-BE49-F238E27FC236}">
-                <a16:creationId xmlns:a16="http://schemas.microsoft.com/office/drawing/2014/main" id="{845227B0-7E12-E105-2EC8-FD9270EE5520}"/>
-              </a:ext>
-            </a:extLst>
-          </p:cNvPr>
-          <p:cNvSpPr>
-            <a:spLocks noGrp="1"/>
-          </p:cNvSpPr>
-          <p:nvPr>
-            <p:ph type="title"/>
-          </p:nvPr>
-        </p:nvSpPr>
-        <p:spPr/>
-        <p:txBody>
-          <a:bodyPr/>
-          <a:lstStyle/>
-          <a:p>
-            <a:r>
-              <a:rPr lang="en-US" dirty="0">
-                <a:solidFill>
-                  <a:schemeClr val="tx1"/>
-                </a:solidFill>
-              </a:rPr>
-              <a:t>Designing Our Apps</a:t>
-            </a:r>
-            <a:endParaRPr lang="en-US" noProof="0" dirty="0">
-              <a:solidFill>
-                <a:schemeClr val="tx1"/>
-              </a:solidFill>
-            </a:endParaRPr>
-          </a:p>
-        </p:txBody>
-      </p:sp>
-      <p:sp>
-        <p:nvSpPr>
-          <p:cNvPr id="9" name="Textplatzhalter 8">
-            <a:extLst>
-              <a:ext uri="{FF2B5EF4-FFF2-40B4-BE49-F238E27FC236}">
-                <a16:creationId xmlns:a16="http://schemas.microsoft.com/office/drawing/2014/main" id="{FAD81F6D-E53C-382A-ADB7-5DF0712CE77A}"/>
-              </a:ext>
-            </a:extLst>
-          </p:cNvPr>
-          <p:cNvSpPr>
-            <a:spLocks noGrp="1"/>
-          </p:cNvSpPr>
-          <p:nvPr>
-            <p:ph type="body" sz="quarter" idx="19"/>
-          </p:nvPr>
-        </p:nvSpPr>
-        <p:spPr/>
-        <p:txBody>
-          <a:bodyPr/>
-          <a:lstStyle/>
-          <a:p>
-            <a:endParaRPr lang="en-US" noProof="0" dirty="0"/>
-          </a:p>
-        </p:txBody>
-      </p:sp>
-      <p:sp>
-        <p:nvSpPr>
-          <p:cNvPr id="11" name="Fußzeilenplatzhalter 10">
-            <a:extLst>
-              <a:ext uri="{FF2B5EF4-FFF2-40B4-BE49-F238E27FC236}">
-                <a16:creationId xmlns:a16="http://schemas.microsoft.com/office/drawing/2014/main" id="{C5D983D1-D00D-9A57-DDF6-46687BEB33F2}"/>
-              </a:ext>
-            </a:extLst>
-          </p:cNvPr>
-          <p:cNvSpPr>
-            <a:spLocks noGrp="1"/>
-          </p:cNvSpPr>
-          <p:nvPr>
-            <p:ph type="ftr" sz="quarter" idx="17"/>
-          </p:nvPr>
-        </p:nvSpPr>
-        <p:spPr/>
-        <p:txBody>
-          <a:bodyPr/>
-          <a:lstStyle/>
-          <a:p>
-            <a:endParaRPr lang="en-US" noProof="0" dirty="0"/>
-          </a:p>
-        </p:txBody>
-      </p:sp>
-      <p:sp>
-        <p:nvSpPr>
-          <p:cNvPr id="12" name="Foliennummernplatzhalter 11">
-            <a:extLst>
-              <a:ext uri="{FF2B5EF4-FFF2-40B4-BE49-F238E27FC236}">
-                <a16:creationId xmlns:a16="http://schemas.microsoft.com/office/drawing/2014/main" id="{4CB90E0B-E2F5-5F9D-9ACA-840520605786}"/>
-              </a:ext>
-            </a:extLst>
-          </p:cNvPr>
-          <p:cNvSpPr>
-            <a:spLocks noGrp="1"/>
-          </p:cNvSpPr>
-          <p:nvPr>
-            <p:ph type="sldNum" sz="quarter" idx="18"/>
-          </p:nvPr>
-        </p:nvSpPr>
-        <p:spPr/>
-        <p:txBody>
-          <a:bodyPr/>
-          <a:lstStyle/>
-          <a:p>
-            <a:fld id="{E6639024-6672-4F87-864B-EA4FA9190A1A}" type="slidenum">
-              <a:rPr lang="en-US" noProof="0" smtClean="0"/>
-              <a:pPr/>
-              <a:t>39</a:t>
-            </a:fld>
-            <a:endParaRPr lang="en-US" noProof="0" dirty="0"/>
-          </a:p>
-        </p:txBody>
-      </p:sp>
-      <p:sp>
-        <p:nvSpPr>
-          <p:cNvPr id="4" name="Inhaltsplatzhalter 9">
-            <a:extLst>
-              <a:ext uri="{FF2B5EF4-FFF2-40B4-BE49-F238E27FC236}">
-                <a16:creationId xmlns:a16="http://schemas.microsoft.com/office/drawing/2014/main" id="{E4591698-D6E5-4652-8666-21E829868FD0}"/>
-              </a:ext>
-            </a:extLst>
-          </p:cNvPr>
-          <p:cNvSpPr txBox="1">
-            <a:spLocks/>
-          </p:cNvSpPr>
-          <p:nvPr/>
-        </p:nvSpPr>
-        <p:spPr>
-          <a:xfrm>
-            <a:off x="359533" y="1203598"/>
-            <a:ext cx="8424467" cy="3332402"/>
-          </a:xfrm>
-          <a:prstGeom prst="rect">
-            <a:avLst/>
-          </a:prstGeom>
-        </p:spPr>
-        <p:txBody>
-          <a:bodyPr vert="horz" lIns="36000" tIns="36000" rIns="36000" bIns="36000" rtlCol="0" anchor="t">
-            <a:normAutofit/>
-          </a:bodyPr>
-          <a:lstStyle>
-            <a:lvl1pPr marL="216000" indent="-216000" algn="l" defTabSz="685800" rtl="0" eaLnBrk="1" latinLnBrk="0" hangingPunct="1">
-              <a:lnSpc>
-                <a:spcPct val="100000"/>
-              </a:lnSpc>
-              <a:spcBef>
-                <a:spcPts val="200"/>
-              </a:spcBef>
-              <a:buClr>
-                <a:schemeClr val="tx1"/>
-              </a:buClr>
-              <a:buFont typeface="Symbol" panose="05050102010706020507" pitchFamily="18" charset="2"/>
-              <a:buChar char="-"/>
-              <a:defRPr sz="1800" kern="1200">
-                <a:solidFill>
-                  <a:schemeClr val="tx1"/>
-                </a:solidFill>
-                <a:latin typeface="+mn-lt"/>
-                <a:ea typeface="+mn-ea"/>
-                <a:cs typeface="+mn-cs"/>
-              </a:defRPr>
-            </a:lvl1pPr>
-            <a:lvl2pPr marL="432000" indent="-216000" algn="l" defTabSz="685800" rtl="0" eaLnBrk="1" latinLnBrk="0" hangingPunct="1">
-              <a:lnSpc>
-                <a:spcPct val="100000"/>
-              </a:lnSpc>
-              <a:spcBef>
-                <a:spcPts val="200"/>
-              </a:spcBef>
-              <a:buFont typeface="Symbol" panose="05050102010706020507" pitchFamily="18" charset="2"/>
-              <a:buChar char="-"/>
-              <a:defRPr sz="1600" kern="1200">
-                <a:solidFill>
-                  <a:schemeClr val="tx1"/>
-                </a:solidFill>
-                <a:latin typeface="+mn-lt"/>
-                <a:ea typeface="+mn-ea"/>
-                <a:cs typeface="+mn-cs"/>
-              </a:defRPr>
-            </a:lvl2pPr>
-            <a:lvl3pPr marL="648000" indent="-216000" algn="l" defTabSz="685800" rtl="0" eaLnBrk="1" latinLnBrk="0" hangingPunct="1">
-              <a:lnSpc>
-                <a:spcPct val="100000"/>
-              </a:lnSpc>
-              <a:spcBef>
-                <a:spcPts val="200"/>
-              </a:spcBef>
-              <a:buFont typeface="Symbol" panose="05050102010706020507" pitchFamily="18" charset="2"/>
-              <a:buChar char="-"/>
-              <a:defRPr sz="1400" kern="1200">
-                <a:solidFill>
-                  <a:schemeClr val="tx1"/>
-                </a:solidFill>
-                <a:latin typeface="+mn-lt"/>
-                <a:ea typeface="+mn-ea"/>
-                <a:cs typeface="+mn-cs"/>
-              </a:defRPr>
-            </a:lvl3pPr>
-            <a:lvl4pPr marL="864000" indent="-216000" algn="l" defTabSz="685800" rtl="0" eaLnBrk="1" latinLnBrk="0" hangingPunct="1">
-              <a:lnSpc>
-                <a:spcPct val="100000"/>
-              </a:lnSpc>
-              <a:spcBef>
-                <a:spcPts val="200"/>
-              </a:spcBef>
-              <a:buFont typeface="Symbol" panose="05050102010706020507" pitchFamily="18" charset="2"/>
-              <a:buChar char="-"/>
-              <a:defRPr sz="1200" kern="1200">
-                <a:solidFill>
-                  <a:schemeClr val="tx1"/>
-                </a:solidFill>
-                <a:latin typeface="+mn-lt"/>
-                <a:ea typeface="+mn-ea"/>
-                <a:cs typeface="+mn-cs"/>
-              </a:defRPr>
-            </a:lvl4pPr>
-            <a:lvl5pPr marL="1080000" indent="-216000" algn="l" defTabSz="685800" rtl="0" eaLnBrk="1" latinLnBrk="0" hangingPunct="1">
-              <a:lnSpc>
-                <a:spcPct val="100000"/>
-              </a:lnSpc>
-              <a:spcBef>
-                <a:spcPts val="200"/>
-              </a:spcBef>
-              <a:buFont typeface="Symbol" panose="05050102010706020507" pitchFamily="18" charset="2"/>
-              <a:buChar char="-"/>
-              <a:defRPr sz="1100" kern="1200">
-                <a:solidFill>
-                  <a:schemeClr val="tx1"/>
-                </a:solidFill>
-                <a:latin typeface="+mn-lt"/>
-                <a:ea typeface="+mn-ea"/>
-                <a:cs typeface="+mn-cs"/>
-              </a:defRPr>
-            </a:lvl5pPr>
-            <a:lvl6pPr marL="1885950" indent="-171450" algn="l" defTabSz="685800" rtl="0" eaLnBrk="1" latinLnBrk="0" hangingPunct="1">
-              <a:lnSpc>
-                <a:spcPct val="90000"/>
-              </a:lnSpc>
-              <a:spcBef>
-                <a:spcPts val="375"/>
-              </a:spcBef>
-              <a:buFont typeface="Arial" panose="020B0604020202020204" pitchFamily="34" charset="0"/>
-              <a:buChar char="•"/>
-              <a:defRPr sz="1350" kern="1200">
-                <a:solidFill>
-                  <a:schemeClr val="tx1"/>
-                </a:solidFill>
-                <a:latin typeface="+mn-lt"/>
-                <a:ea typeface="+mn-ea"/>
-                <a:cs typeface="+mn-cs"/>
-              </a:defRPr>
-            </a:lvl6pPr>
-            <a:lvl7pPr marL="2228850" indent="-171450" algn="l" defTabSz="685800" rtl="0" eaLnBrk="1" latinLnBrk="0" hangingPunct="1">
-              <a:lnSpc>
-                <a:spcPct val="90000"/>
-              </a:lnSpc>
-              <a:spcBef>
-                <a:spcPts val="375"/>
-              </a:spcBef>
-              <a:buFont typeface="Arial" panose="020B0604020202020204" pitchFamily="34" charset="0"/>
-              <a:buChar char="•"/>
-              <a:defRPr sz="1350" kern="1200">
-                <a:solidFill>
-                  <a:schemeClr val="tx1"/>
-                </a:solidFill>
-                <a:latin typeface="+mn-lt"/>
-                <a:ea typeface="+mn-ea"/>
-                <a:cs typeface="+mn-cs"/>
-              </a:defRPr>
-            </a:lvl7pPr>
-            <a:lvl8pPr marL="2571750" indent="-171450" algn="l" defTabSz="685800" rtl="0" eaLnBrk="1" latinLnBrk="0" hangingPunct="1">
-              <a:lnSpc>
-                <a:spcPct val="90000"/>
-              </a:lnSpc>
-              <a:spcBef>
-                <a:spcPts val="375"/>
-              </a:spcBef>
-              <a:buFont typeface="Arial" panose="020B0604020202020204" pitchFamily="34" charset="0"/>
-              <a:buChar char="•"/>
-              <a:defRPr sz="1350" kern="1200">
-                <a:solidFill>
-                  <a:schemeClr val="tx1"/>
-                </a:solidFill>
-                <a:latin typeface="+mn-lt"/>
-                <a:ea typeface="+mn-ea"/>
-                <a:cs typeface="+mn-cs"/>
-              </a:defRPr>
-            </a:lvl8pPr>
-            <a:lvl9pPr marL="2914650" indent="-171450" algn="l" defTabSz="685800" rtl="0" eaLnBrk="1" latinLnBrk="0" hangingPunct="1">
-              <a:lnSpc>
-                <a:spcPct val="90000"/>
-              </a:lnSpc>
-              <a:spcBef>
-                <a:spcPts val="375"/>
-              </a:spcBef>
-              <a:buFont typeface="Arial" panose="020B0604020202020204" pitchFamily="34" charset="0"/>
-              <a:buChar char="•"/>
-              <a:defRPr sz="1350" kern="1200">
-                <a:solidFill>
-                  <a:schemeClr val="tx1"/>
-                </a:solidFill>
-                <a:latin typeface="+mn-lt"/>
-                <a:ea typeface="+mn-ea"/>
-                <a:cs typeface="+mn-cs"/>
-              </a:defRPr>
-            </a:lvl9pPr>
-          </a:lstStyle>
-          <a:p>
-            <a:pPr>
-              <a:lnSpc>
-                <a:spcPct val="150000"/>
-              </a:lnSpc>
-            </a:pPr>
-            <a:r>
-              <a:rPr lang="en-US" dirty="0"/>
-              <a:t>One app per vulnerability category</a:t>
-            </a:r>
-            <a:endParaRPr lang="en-US" noProof="0" dirty="0"/>
-          </a:p>
-          <a:p>
-            <a:pPr>
-              <a:lnSpc>
-                <a:spcPct val="150000"/>
-              </a:lnSpc>
-            </a:pPr>
-            <a:r>
-              <a:rPr lang="en-US" noProof="0" dirty="0"/>
-              <a:t>One app package per vulnerability type</a:t>
-            </a:r>
-          </a:p>
-          <a:p>
-            <a:pPr>
-              <a:lnSpc>
-                <a:spcPct val="150000"/>
-              </a:lnSpc>
-            </a:pPr>
-            <a:r>
-              <a:rPr lang="en-US" noProof="0" dirty="0"/>
-              <a:t>Shared resources in </a:t>
-            </a:r>
-            <a:r>
-              <a:rPr lang="en-US" i="1" noProof="0" dirty="0"/>
-              <a:t>“common”</a:t>
-            </a:r>
-          </a:p>
-          <a:p>
-            <a:pPr>
-              <a:lnSpc>
-                <a:spcPct val="150000"/>
-              </a:lnSpc>
-            </a:pPr>
-            <a:r>
-              <a:rPr lang="en-US" noProof="0" dirty="0"/>
-              <a:t>All apps are independent modules of the project</a:t>
-            </a:r>
-          </a:p>
-          <a:p>
-            <a:pPr>
-              <a:lnSpc>
-                <a:spcPct val="150000"/>
-              </a:lnSpc>
-            </a:pPr>
-            <a:r>
-              <a:rPr lang="en-US" noProof="0" dirty="0"/>
-              <a:t>Custom templates reduce boiler plate code</a:t>
-            </a:r>
-          </a:p>
-          <a:p>
-            <a:pPr>
-              <a:lnSpc>
-                <a:spcPct val="150000"/>
-              </a:lnSpc>
-            </a:pPr>
-            <a:endParaRPr lang="en-US" noProof="0" dirty="0"/>
-          </a:p>
-        </p:txBody>
-      </p:sp>
-    </p:spTree>
-    <p:extLst>
-      <p:ext uri="{BB962C8B-B14F-4D97-AF65-F5344CB8AC3E}">
-        <p14:creationId xmlns:p14="http://schemas.microsoft.com/office/powerpoint/2010/main" val="105921891"/>
       </p:ext>
     </p:extLst>
   </p:cSld>
@@ -42730,6 +42497,460 @@
         <p:cNvPr id="1" name="">
           <a:extLst>
             <a:ext uri="{FF2B5EF4-FFF2-40B4-BE49-F238E27FC236}">
+              <a16:creationId xmlns:a16="http://schemas.microsoft.com/office/drawing/2014/main" id="{ACD6E733-7832-5804-7FC1-5A31B1EB6365}"/>
+            </a:ext>
+          </a:extLst>
+        </p:cNvPr>
+        <p:cNvGrpSpPr/>
+        <p:nvPr/>
+      </p:nvGrpSpPr>
+      <p:grpSpPr>
+        <a:xfrm>
+          <a:off x="0" y="0"/>
+          <a:ext cx="0" cy="0"/>
+          <a:chOff x="0" y="0"/>
+          <a:chExt cx="0" cy="0"/>
+        </a:xfrm>
+      </p:grpSpPr>
+      <p:sp>
+        <p:nvSpPr>
+          <p:cNvPr id="8" name="Textplatzhalter 7">
+            <a:extLst>
+              <a:ext uri="{FF2B5EF4-FFF2-40B4-BE49-F238E27FC236}">
+                <a16:creationId xmlns:a16="http://schemas.microsoft.com/office/drawing/2014/main" id="{B2102DA2-5FC0-19DA-8369-12AC04B6C90F}"/>
+              </a:ext>
+            </a:extLst>
+          </p:cNvPr>
+          <p:cNvSpPr>
+            <a:spLocks noGrp="1"/>
+          </p:cNvSpPr>
+          <p:nvPr>
+            <p:ph type="body" sz="quarter" idx="12"/>
+          </p:nvPr>
+        </p:nvSpPr>
+        <p:spPr/>
+        <p:txBody>
+          <a:bodyPr/>
+          <a:lstStyle/>
+          <a:p>
+            <a:r>
+              <a:rPr lang="en-US" dirty="0">
+                <a:solidFill>
+                  <a:schemeClr val="bg2"/>
+                </a:solidFill>
+              </a:rPr>
+              <a:t>Architecture Summary</a:t>
+            </a:r>
+            <a:endParaRPr lang="en-US" noProof="0" dirty="0">
+              <a:solidFill>
+                <a:schemeClr val="bg2"/>
+              </a:solidFill>
+            </a:endParaRPr>
+          </a:p>
+        </p:txBody>
+      </p:sp>
+      <p:sp>
+        <p:nvSpPr>
+          <p:cNvPr id="7" name="Titel 6">
+            <a:extLst>
+              <a:ext uri="{FF2B5EF4-FFF2-40B4-BE49-F238E27FC236}">
+                <a16:creationId xmlns:a16="http://schemas.microsoft.com/office/drawing/2014/main" id="{845227B0-7E12-E105-2EC8-FD9270EE5520}"/>
+              </a:ext>
+            </a:extLst>
+          </p:cNvPr>
+          <p:cNvSpPr>
+            <a:spLocks noGrp="1"/>
+          </p:cNvSpPr>
+          <p:nvPr>
+            <p:ph type="title"/>
+          </p:nvPr>
+        </p:nvSpPr>
+        <p:spPr/>
+        <p:txBody>
+          <a:bodyPr/>
+          <a:lstStyle/>
+          <a:p>
+            <a:r>
+              <a:rPr lang="en-US" dirty="0">
+                <a:solidFill>
+                  <a:schemeClr val="tx1"/>
+                </a:solidFill>
+              </a:rPr>
+              <a:t>Designing Our Apps</a:t>
+            </a:r>
+            <a:endParaRPr lang="en-US" noProof="0" dirty="0">
+              <a:solidFill>
+                <a:schemeClr val="tx1"/>
+              </a:solidFill>
+            </a:endParaRPr>
+          </a:p>
+        </p:txBody>
+      </p:sp>
+      <p:sp>
+        <p:nvSpPr>
+          <p:cNvPr id="9" name="Textplatzhalter 8">
+            <a:extLst>
+              <a:ext uri="{FF2B5EF4-FFF2-40B4-BE49-F238E27FC236}">
+                <a16:creationId xmlns:a16="http://schemas.microsoft.com/office/drawing/2014/main" id="{FAD81F6D-E53C-382A-ADB7-5DF0712CE77A}"/>
+              </a:ext>
+            </a:extLst>
+          </p:cNvPr>
+          <p:cNvSpPr>
+            <a:spLocks noGrp="1"/>
+          </p:cNvSpPr>
+          <p:nvPr>
+            <p:ph type="body" sz="quarter" idx="19"/>
+          </p:nvPr>
+        </p:nvSpPr>
+        <p:spPr/>
+        <p:txBody>
+          <a:bodyPr/>
+          <a:lstStyle/>
+          <a:p>
+            <a:endParaRPr lang="en-US" noProof="0" dirty="0"/>
+          </a:p>
+        </p:txBody>
+      </p:sp>
+      <p:sp>
+        <p:nvSpPr>
+          <p:cNvPr id="11" name="Fußzeilenplatzhalter 10">
+            <a:extLst>
+              <a:ext uri="{FF2B5EF4-FFF2-40B4-BE49-F238E27FC236}">
+                <a16:creationId xmlns:a16="http://schemas.microsoft.com/office/drawing/2014/main" id="{C5D983D1-D00D-9A57-DDF6-46687BEB33F2}"/>
+              </a:ext>
+            </a:extLst>
+          </p:cNvPr>
+          <p:cNvSpPr>
+            <a:spLocks noGrp="1"/>
+          </p:cNvSpPr>
+          <p:nvPr>
+            <p:ph type="ftr" sz="quarter" idx="17"/>
+          </p:nvPr>
+        </p:nvSpPr>
+        <p:spPr/>
+        <p:txBody>
+          <a:bodyPr/>
+          <a:lstStyle/>
+          <a:p>
+            <a:endParaRPr lang="en-US" noProof="0" dirty="0"/>
+          </a:p>
+        </p:txBody>
+      </p:sp>
+      <p:sp>
+        <p:nvSpPr>
+          <p:cNvPr id="12" name="Foliennummernplatzhalter 11">
+            <a:extLst>
+              <a:ext uri="{FF2B5EF4-FFF2-40B4-BE49-F238E27FC236}">
+                <a16:creationId xmlns:a16="http://schemas.microsoft.com/office/drawing/2014/main" id="{4CB90E0B-E2F5-5F9D-9ACA-840520605786}"/>
+              </a:ext>
+            </a:extLst>
+          </p:cNvPr>
+          <p:cNvSpPr>
+            <a:spLocks noGrp="1"/>
+          </p:cNvSpPr>
+          <p:nvPr>
+            <p:ph type="sldNum" sz="quarter" idx="18"/>
+          </p:nvPr>
+        </p:nvSpPr>
+        <p:spPr/>
+        <p:txBody>
+          <a:bodyPr/>
+          <a:lstStyle/>
+          <a:p>
+            <a:fld id="{E6639024-6672-4F87-864B-EA4FA9190A1A}" type="slidenum">
+              <a:rPr lang="en-US" noProof="0" smtClean="0"/>
+              <a:pPr/>
+              <a:t>40</a:t>
+            </a:fld>
+            <a:endParaRPr lang="en-US" noProof="0" dirty="0"/>
+          </a:p>
+        </p:txBody>
+      </p:sp>
+      <p:sp>
+        <p:nvSpPr>
+          <p:cNvPr id="4" name="Inhaltsplatzhalter 9">
+            <a:extLst>
+              <a:ext uri="{FF2B5EF4-FFF2-40B4-BE49-F238E27FC236}">
+                <a16:creationId xmlns:a16="http://schemas.microsoft.com/office/drawing/2014/main" id="{E4591698-D6E5-4652-8666-21E829868FD0}"/>
+              </a:ext>
+            </a:extLst>
+          </p:cNvPr>
+          <p:cNvSpPr txBox="1">
+            <a:spLocks/>
+          </p:cNvSpPr>
+          <p:nvPr/>
+        </p:nvSpPr>
+        <p:spPr>
+          <a:xfrm>
+            <a:off x="359533" y="1203598"/>
+            <a:ext cx="8424467" cy="3332402"/>
+          </a:xfrm>
+          <a:prstGeom prst="rect">
+            <a:avLst/>
+          </a:prstGeom>
+        </p:spPr>
+        <p:txBody>
+          <a:bodyPr vert="horz" lIns="36000" tIns="36000" rIns="36000" bIns="36000" rtlCol="0" anchor="t">
+            <a:normAutofit/>
+          </a:bodyPr>
+          <a:lstStyle>
+            <a:lvl1pPr marL="216000" indent="-216000" algn="l" defTabSz="685800" rtl="0" eaLnBrk="1" latinLnBrk="0" hangingPunct="1">
+              <a:lnSpc>
+                <a:spcPct val="100000"/>
+              </a:lnSpc>
+              <a:spcBef>
+                <a:spcPts val="200"/>
+              </a:spcBef>
+              <a:buClr>
+                <a:schemeClr val="tx1"/>
+              </a:buClr>
+              <a:buFont typeface="Symbol" panose="05050102010706020507" pitchFamily="18" charset="2"/>
+              <a:buChar char="-"/>
+              <a:defRPr sz="1800" kern="1200">
+                <a:solidFill>
+                  <a:schemeClr val="tx1"/>
+                </a:solidFill>
+                <a:latin typeface="+mn-lt"/>
+                <a:ea typeface="+mn-ea"/>
+                <a:cs typeface="+mn-cs"/>
+              </a:defRPr>
+            </a:lvl1pPr>
+            <a:lvl2pPr marL="432000" indent="-216000" algn="l" defTabSz="685800" rtl="0" eaLnBrk="1" latinLnBrk="0" hangingPunct="1">
+              <a:lnSpc>
+                <a:spcPct val="100000"/>
+              </a:lnSpc>
+              <a:spcBef>
+                <a:spcPts val="200"/>
+              </a:spcBef>
+              <a:buFont typeface="Symbol" panose="05050102010706020507" pitchFamily="18" charset="2"/>
+              <a:buChar char="-"/>
+              <a:defRPr sz="1600" kern="1200">
+                <a:solidFill>
+                  <a:schemeClr val="tx1"/>
+                </a:solidFill>
+                <a:latin typeface="+mn-lt"/>
+                <a:ea typeface="+mn-ea"/>
+                <a:cs typeface="+mn-cs"/>
+              </a:defRPr>
+            </a:lvl2pPr>
+            <a:lvl3pPr marL="648000" indent="-216000" algn="l" defTabSz="685800" rtl="0" eaLnBrk="1" latinLnBrk="0" hangingPunct="1">
+              <a:lnSpc>
+                <a:spcPct val="100000"/>
+              </a:lnSpc>
+              <a:spcBef>
+                <a:spcPts val="200"/>
+              </a:spcBef>
+              <a:buFont typeface="Symbol" panose="05050102010706020507" pitchFamily="18" charset="2"/>
+              <a:buChar char="-"/>
+              <a:defRPr sz="1400" kern="1200">
+                <a:solidFill>
+                  <a:schemeClr val="tx1"/>
+                </a:solidFill>
+                <a:latin typeface="+mn-lt"/>
+                <a:ea typeface="+mn-ea"/>
+                <a:cs typeface="+mn-cs"/>
+              </a:defRPr>
+            </a:lvl3pPr>
+            <a:lvl4pPr marL="864000" indent="-216000" algn="l" defTabSz="685800" rtl="0" eaLnBrk="1" latinLnBrk="0" hangingPunct="1">
+              <a:lnSpc>
+                <a:spcPct val="100000"/>
+              </a:lnSpc>
+              <a:spcBef>
+                <a:spcPts val="200"/>
+              </a:spcBef>
+              <a:buFont typeface="Symbol" panose="05050102010706020507" pitchFamily="18" charset="2"/>
+              <a:buChar char="-"/>
+              <a:defRPr sz="1200" kern="1200">
+                <a:solidFill>
+                  <a:schemeClr val="tx1"/>
+                </a:solidFill>
+                <a:latin typeface="+mn-lt"/>
+                <a:ea typeface="+mn-ea"/>
+                <a:cs typeface="+mn-cs"/>
+              </a:defRPr>
+            </a:lvl4pPr>
+            <a:lvl5pPr marL="1080000" indent="-216000" algn="l" defTabSz="685800" rtl="0" eaLnBrk="1" latinLnBrk="0" hangingPunct="1">
+              <a:lnSpc>
+                <a:spcPct val="100000"/>
+              </a:lnSpc>
+              <a:spcBef>
+                <a:spcPts val="200"/>
+              </a:spcBef>
+              <a:buFont typeface="Symbol" panose="05050102010706020507" pitchFamily="18" charset="2"/>
+              <a:buChar char="-"/>
+              <a:defRPr sz="1100" kern="1200">
+                <a:solidFill>
+                  <a:schemeClr val="tx1"/>
+                </a:solidFill>
+                <a:latin typeface="+mn-lt"/>
+                <a:ea typeface="+mn-ea"/>
+                <a:cs typeface="+mn-cs"/>
+              </a:defRPr>
+            </a:lvl5pPr>
+            <a:lvl6pPr marL="1885950" indent="-171450" algn="l" defTabSz="685800" rtl="0" eaLnBrk="1" latinLnBrk="0" hangingPunct="1">
+              <a:lnSpc>
+                <a:spcPct val="90000"/>
+              </a:lnSpc>
+              <a:spcBef>
+                <a:spcPts val="375"/>
+              </a:spcBef>
+              <a:buFont typeface="Arial" panose="020B0604020202020204" pitchFamily="34" charset="0"/>
+              <a:buChar char="•"/>
+              <a:defRPr sz="1350" kern="1200">
+                <a:solidFill>
+                  <a:schemeClr val="tx1"/>
+                </a:solidFill>
+                <a:latin typeface="+mn-lt"/>
+                <a:ea typeface="+mn-ea"/>
+                <a:cs typeface="+mn-cs"/>
+              </a:defRPr>
+            </a:lvl6pPr>
+            <a:lvl7pPr marL="2228850" indent="-171450" algn="l" defTabSz="685800" rtl="0" eaLnBrk="1" latinLnBrk="0" hangingPunct="1">
+              <a:lnSpc>
+                <a:spcPct val="90000"/>
+              </a:lnSpc>
+              <a:spcBef>
+                <a:spcPts val="375"/>
+              </a:spcBef>
+              <a:buFont typeface="Arial" panose="020B0604020202020204" pitchFamily="34" charset="0"/>
+              <a:buChar char="•"/>
+              <a:defRPr sz="1350" kern="1200">
+                <a:solidFill>
+                  <a:schemeClr val="tx1"/>
+                </a:solidFill>
+                <a:latin typeface="+mn-lt"/>
+                <a:ea typeface="+mn-ea"/>
+                <a:cs typeface="+mn-cs"/>
+              </a:defRPr>
+            </a:lvl7pPr>
+            <a:lvl8pPr marL="2571750" indent="-171450" algn="l" defTabSz="685800" rtl="0" eaLnBrk="1" latinLnBrk="0" hangingPunct="1">
+              <a:lnSpc>
+                <a:spcPct val="90000"/>
+              </a:lnSpc>
+              <a:spcBef>
+                <a:spcPts val="375"/>
+              </a:spcBef>
+              <a:buFont typeface="Arial" panose="020B0604020202020204" pitchFamily="34" charset="0"/>
+              <a:buChar char="•"/>
+              <a:defRPr sz="1350" kern="1200">
+                <a:solidFill>
+                  <a:schemeClr val="tx1"/>
+                </a:solidFill>
+                <a:latin typeface="+mn-lt"/>
+                <a:ea typeface="+mn-ea"/>
+                <a:cs typeface="+mn-cs"/>
+              </a:defRPr>
+            </a:lvl8pPr>
+            <a:lvl9pPr marL="2914650" indent="-171450" algn="l" defTabSz="685800" rtl="0" eaLnBrk="1" latinLnBrk="0" hangingPunct="1">
+              <a:lnSpc>
+                <a:spcPct val="90000"/>
+              </a:lnSpc>
+              <a:spcBef>
+                <a:spcPts val="375"/>
+              </a:spcBef>
+              <a:buFont typeface="Arial" panose="020B0604020202020204" pitchFamily="34" charset="0"/>
+              <a:buChar char="•"/>
+              <a:defRPr sz="1350" kern="1200">
+                <a:solidFill>
+                  <a:schemeClr val="tx1"/>
+                </a:solidFill>
+                <a:latin typeface="+mn-lt"/>
+                <a:ea typeface="+mn-ea"/>
+                <a:cs typeface="+mn-cs"/>
+              </a:defRPr>
+            </a:lvl9pPr>
+          </a:lstStyle>
+          <a:p>
+            <a:pPr>
+              <a:lnSpc>
+                <a:spcPct val="150000"/>
+              </a:lnSpc>
+            </a:pPr>
+            <a:r>
+              <a:rPr lang="en-US" dirty="0"/>
+              <a:t>One app per vulnerability category</a:t>
+            </a:r>
+            <a:endParaRPr lang="en-US" noProof="0" dirty="0"/>
+          </a:p>
+          <a:p>
+            <a:pPr>
+              <a:lnSpc>
+                <a:spcPct val="150000"/>
+              </a:lnSpc>
+            </a:pPr>
+            <a:r>
+              <a:rPr lang="en-US" noProof="0" dirty="0"/>
+              <a:t>One app package per vulnerability type</a:t>
+            </a:r>
+          </a:p>
+          <a:p>
+            <a:pPr>
+              <a:lnSpc>
+                <a:spcPct val="150000"/>
+              </a:lnSpc>
+            </a:pPr>
+            <a:r>
+              <a:rPr lang="en-US" noProof="0" dirty="0"/>
+              <a:t>Shared resources in </a:t>
+            </a:r>
+            <a:r>
+              <a:rPr lang="en-US" i="1" noProof="0" dirty="0"/>
+              <a:t>“common”</a:t>
+            </a:r>
+          </a:p>
+          <a:p>
+            <a:pPr>
+              <a:lnSpc>
+                <a:spcPct val="150000"/>
+              </a:lnSpc>
+            </a:pPr>
+            <a:r>
+              <a:rPr lang="en-US" noProof="0" dirty="0"/>
+              <a:t>All apps are independent modules of the project</a:t>
+            </a:r>
+          </a:p>
+          <a:p>
+            <a:pPr>
+              <a:lnSpc>
+                <a:spcPct val="150000"/>
+              </a:lnSpc>
+            </a:pPr>
+            <a:r>
+              <a:rPr lang="en-US" noProof="0" dirty="0"/>
+              <a:t>Custom templates reduce boiler plate code</a:t>
+            </a:r>
+          </a:p>
+          <a:p>
+            <a:pPr>
+              <a:lnSpc>
+                <a:spcPct val="150000"/>
+              </a:lnSpc>
+            </a:pPr>
+            <a:endParaRPr lang="en-US" noProof="0" dirty="0"/>
+          </a:p>
+        </p:txBody>
+      </p:sp>
+    </p:spTree>
+    <p:extLst>
+      <p:ext uri="{BB962C8B-B14F-4D97-AF65-F5344CB8AC3E}">
+        <p14:creationId xmlns:p14="http://schemas.microsoft.com/office/powerpoint/2010/main" val="105921891"/>
+      </p:ext>
+    </p:extLst>
+  </p:cSld>
+  <p:clrMapOvr>
+    <a:masterClrMapping/>
+  </p:clrMapOvr>
+</p:sld>
+</file>
+
+<file path=ppt/slides/slide41.xml><?xml version="1.0" encoding="utf-8"?>
+<p:sld xmlns:a="http://schemas.openxmlformats.org/drawingml/2006/main" xmlns:r="http://schemas.openxmlformats.org/officeDocument/2006/relationships" xmlns:p="http://schemas.openxmlformats.org/presentationml/2006/main">
+  <p:cSld>
+    <p:spTree>
+      <p:nvGrpSpPr>
+        <p:cNvPr id="1" name="">
+          <a:extLst>
+            <a:ext uri="{FF2B5EF4-FFF2-40B4-BE49-F238E27FC236}">
               <a16:creationId xmlns:a16="http://schemas.microsoft.com/office/drawing/2014/main" id="{85EBC30F-C25B-7073-3A1B-1660465740B3}"/>
             </a:ext>
           </a:extLst>
@@ -42956,7 +43177,7 @@
             <a:fld id="{E6639024-6672-4F87-864B-EA4FA9190A1A}" type="slidenum">
               <a:rPr lang="en-US" noProof="0" smtClean="0"/>
               <a:pPr/>
-              <a:t>40</a:t>
+              <a:t>41</a:t>
             </a:fld>
             <a:endParaRPr lang="en-US" noProof="0" dirty="0"/>
           </a:p>
@@ -42975,7 +43196,7 @@
 </p:sld>
 </file>
 
-<file path=ppt/slides/slide41.xml><?xml version="1.0" encoding="utf-8"?>
+<file path=ppt/slides/slide42.xml><?xml version="1.0" encoding="utf-8"?>
 <p:sld xmlns:a="http://schemas.openxmlformats.org/drawingml/2006/main" xmlns:r="http://schemas.openxmlformats.org/officeDocument/2006/relationships" xmlns:p="http://schemas.openxmlformats.org/presentationml/2006/main">
   <p:cSld>
     <p:spTree>
@@ -43025,7 +43246,7 @@
                   <a:schemeClr val="bg2"/>
                 </a:solidFill>
               </a:rPr>
-              <a:t>Overview of Our Apps</a:t>
+              <a:t>Contribution to Vulnerability Coverage</a:t>
             </a:r>
             <a:endParaRPr lang="en-US" noProof="0" dirty="0">
               <a:solidFill>
@@ -43131,6 +43352,18 @@
                 <a:spcPct val="150000"/>
               </a:lnSpc>
             </a:pPr>
+            <a:r>
+              <a:rPr lang="en-US" dirty="0"/>
+              <a:t>Largest contribution to Crypto</a:t>
+            </a:r>
+            <a:endParaRPr lang="en-US" noProof="0" dirty="0"/>
+          </a:p>
+          <a:p>
+            <a:pPr>
+              <a:lnSpc>
+                <a:spcPct val="150000"/>
+              </a:lnSpc>
+            </a:pPr>
             <a:endParaRPr lang="en-US" noProof="0" dirty="0"/>
           </a:p>
           <a:p>
@@ -43217,240 +43450,6 @@
             <a:fld id="{E6639024-6672-4F87-864B-EA4FA9190A1A}" type="slidenum">
               <a:rPr lang="en-US" noProof="0" smtClean="0"/>
               <a:pPr/>
-              <a:t>41</a:t>
-            </a:fld>
-            <a:endParaRPr lang="en-US" noProof="0" dirty="0"/>
-          </a:p>
-        </p:txBody>
-      </p:sp>
-    </p:spTree>
-    <p:extLst>
-      <p:ext uri="{BB962C8B-B14F-4D97-AF65-F5344CB8AC3E}">
-        <p14:creationId xmlns:p14="http://schemas.microsoft.com/office/powerpoint/2010/main" val="991241013"/>
-      </p:ext>
-    </p:extLst>
-  </p:cSld>
-  <p:clrMapOvr>
-    <a:masterClrMapping/>
-  </p:clrMapOvr>
-</p:sld>
-</file>
-
-<file path=ppt/slides/slide42.xml><?xml version="1.0" encoding="utf-8"?>
-<p:sld xmlns:a="http://schemas.openxmlformats.org/drawingml/2006/main" xmlns:r="http://schemas.openxmlformats.org/officeDocument/2006/relationships" xmlns:p="http://schemas.openxmlformats.org/presentationml/2006/main">
-  <p:cSld>
-    <p:spTree>
-      <p:nvGrpSpPr>
-        <p:cNvPr id="1" name="">
-          <a:extLst>
-            <a:ext uri="{FF2B5EF4-FFF2-40B4-BE49-F238E27FC236}">
-              <a16:creationId xmlns:a16="http://schemas.microsoft.com/office/drawing/2014/main" id="{F214EE8D-A3F9-A17E-026A-E54B75D254FB}"/>
-            </a:ext>
-          </a:extLst>
-        </p:cNvPr>
-        <p:cNvGrpSpPr/>
-        <p:nvPr/>
-      </p:nvGrpSpPr>
-      <p:grpSpPr>
-        <a:xfrm>
-          <a:off x="0" y="0"/>
-          <a:ext cx="0" cy="0"/>
-          <a:chOff x="0" y="0"/>
-          <a:chExt cx="0" cy="0"/>
-        </a:xfrm>
-      </p:grpSpPr>
-      <p:sp>
-        <p:nvSpPr>
-          <p:cNvPr id="8" name="Textplatzhalter 7">
-            <a:extLst>
-              <a:ext uri="{FF2B5EF4-FFF2-40B4-BE49-F238E27FC236}">
-                <a16:creationId xmlns:a16="http://schemas.microsoft.com/office/drawing/2014/main" id="{E3CFD75C-28E3-802B-6BD6-DC1892352669}"/>
-              </a:ext>
-            </a:extLst>
-          </p:cNvPr>
-          <p:cNvSpPr>
-            <a:spLocks noGrp="1"/>
-          </p:cNvSpPr>
-          <p:nvPr>
-            <p:ph type="body" sz="quarter" idx="12"/>
-          </p:nvPr>
-        </p:nvSpPr>
-        <p:spPr/>
-        <p:txBody>
-          <a:bodyPr/>
-          <a:lstStyle/>
-          <a:p>
-            <a:r>
-              <a:rPr lang="en-US" noProof="0" dirty="0">
-                <a:solidFill>
-                  <a:schemeClr val="bg2"/>
-                </a:solidFill>
-              </a:rPr>
-              <a:t>Comparison with other MASTG Apps</a:t>
-            </a:r>
-          </a:p>
-        </p:txBody>
-      </p:sp>
-      <p:sp>
-        <p:nvSpPr>
-          <p:cNvPr id="7" name="Titel 6">
-            <a:extLst>
-              <a:ext uri="{FF2B5EF4-FFF2-40B4-BE49-F238E27FC236}">
-                <a16:creationId xmlns:a16="http://schemas.microsoft.com/office/drawing/2014/main" id="{F5233A53-64FE-CA26-14C6-FEE787318BC9}"/>
-              </a:ext>
-            </a:extLst>
-          </p:cNvPr>
-          <p:cNvSpPr>
-            <a:spLocks noGrp="1"/>
-          </p:cNvSpPr>
-          <p:nvPr>
-            <p:ph type="title"/>
-          </p:nvPr>
-        </p:nvSpPr>
-        <p:spPr/>
-        <p:txBody>
-          <a:bodyPr/>
-          <a:lstStyle/>
-          <a:p>
-            <a:r>
-              <a:rPr lang="en-US" noProof="0" dirty="0">
-                <a:solidFill>
-                  <a:schemeClr val="tx1"/>
-                </a:solidFill>
-              </a:rPr>
-              <a:t>Results</a:t>
-            </a:r>
-          </a:p>
-        </p:txBody>
-      </p:sp>
-      <p:sp>
-        <p:nvSpPr>
-          <p:cNvPr id="10" name="Inhaltsplatzhalter 9">
-            <a:extLst>
-              <a:ext uri="{FF2B5EF4-FFF2-40B4-BE49-F238E27FC236}">
-                <a16:creationId xmlns:a16="http://schemas.microsoft.com/office/drawing/2014/main" id="{B0CCCF5B-3D13-9BA2-D1CF-0A198C4D8018}"/>
-              </a:ext>
-            </a:extLst>
-          </p:cNvPr>
-          <p:cNvSpPr>
-            <a:spLocks noGrp="1"/>
-          </p:cNvSpPr>
-          <p:nvPr>
-            <p:ph sz="quarter" idx="20"/>
-          </p:nvPr>
-        </p:nvSpPr>
-        <p:spPr>
-          <a:xfrm>
-            <a:off x="359533" y="1203598"/>
-            <a:ext cx="8424467" cy="3332402"/>
-          </a:xfrm>
-        </p:spPr>
-        <p:txBody>
-          <a:bodyPr anchor="t"/>
-          <a:lstStyle/>
-          <a:p>
-            <a:pPr>
-              <a:lnSpc>
-                <a:spcPct val="150000"/>
-              </a:lnSpc>
-            </a:pPr>
-            <a:r>
-              <a:rPr lang="en-US" noProof="0" dirty="0"/>
-              <a:t>Largest contribution to Crypto category</a:t>
-            </a:r>
-          </a:p>
-          <a:p>
-            <a:pPr>
-              <a:lnSpc>
-                <a:spcPct val="150000"/>
-              </a:lnSpc>
-            </a:pPr>
-            <a:endParaRPr lang="en-US" noProof="0" dirty="0"/>
-          </a:p>
-          <a:p>
-            <a:pPr>
-              <a:lnSpc>
-                <a:spcPct val="150000"/>
-              </a:lnSpc>
-            </a:pPr>
-            <a:endParaRPr lang="en-US" noProof="0" dirty="0"/>
-          </a:p>
-        </p:txBody>
-      </p:sp>
-      <p:sp>
-        <p:nvSpPr>
-          <p:cNvPr id="9" name="Textplatzhalter 8">
-            <a:extLst>
-              <a:ext uri="{FF2B5EF4-FFF2-40B4-BE49-F238E27FC236}">
-                <a16:creationId xmlns:a16="http://schemas.microsoft.com/office/drawing/2014/main" id="{8A29B60F-0C6A-26D2-D7BB-9FE0D1A767D8}"/>
-              </a:ext>
-            </a:extLst>
-          </p:cNvPr>
-          <p:cNvSpPr>
-            <a:spLocks noGrp="1"/>
-          </p:cNvSpPr>
-          <p:nvPr>
-            <p:ph type="body" sz="quarter" idx="19"/>
-          </p:nvPr>
-        </p:nvSpPr>
-        <p:spPr/>
-        <p:txBody>
-          <a:bodyPr/>
-          <a:lstStyle/>
-          <a:p>
-            <a:endParaRPr lang="en-US" noProof="0" dirty="0"/>
-          </a:p>
-        </p:txBody>
-      </p:sp>
-      <p:sp>
-        <p:nvSpPr>
-          <p:cNvPr id="11" name="Fußzeilenplatzhalter 10">
-            <a:extLst>
-              <a:ext uri="{FF2B5EF4-FFF2-40B4-BE49-F238E27FC236}">
-                <a16:creationId xmlns:a16="http://schemas.microsoft.com/office/drawing/2014/main" id="{89867BC0-A9AD-6CAE-A20C-B360213BE709}"/>
-              </a:ext>
-            </a:extLst>
-          </p:cNvPr>
-          <p:cNvSpPr>
-            <a:spLocks noGrp="1"/>
-          </p:cNvSpPr>
-          <p:nvPr>
-            <p:ph type="ftr" sz="quarter" idx="17"/>
-          </p:nvPr>
-        </p:nvSpPr>
-        <p:spPr/>
-        <p:txBody>
-          <a:bodyPr/>
-          <a:lstStyle/>
-          <a:p>
-            <a:endParaRPr lang="en-US" noProof="0" dirty="0"/>
-          </a:p>
-        </p:txBody>
-      </p:sp>
-      <p:sp>
-        <p:nvSpPr>
-          <p:cNvPr id="12" name="Foliennummernplatzhalter 11">
-            <a:extLst>
-              <a:ext uri="{FF2B5EF4-FFF2-40B4-BE49-F238E27FC236}">
-                <a16:creationId xmlns:a16="http://schemas.microsoft.com/office/drawing/2014/main" id="{FCCCB0FA-F845-B5B9-FB50-83C6DDB4FB9D}"/>
-              </a:ext>
-            </a:extLst>
-          </p:cNvPr>
-          <p:cNvSpPr>
-            <a:spLocks noGrp="1"/>
-          </p:cNvSpPr>
-          <p:nvPr>
-            <p:ph type="sldNum" sz="quarter" idx="18"/>
-          </p:nvPr>
-        </p:nvSpPr>
-        <p:spPr/>
-        <p:txBody>
-          <a:bodyPr/>
-          <a:lstStyle/>
-          <a:p>
-            <a:fld id="{E6639024-6672-4F87-864B-EA4FA9190A1A}" type="slidenum">
-              <a:rPr lang="en-US" noProof="0" smtClean="0"/>
-              <a:pPr/>
               <a:t>42</a:t>
             </a:fld>
             <a:endParaRPr lang="en-US" noProof="0" dirty="0"/>
@@ -43459,10 +43458,10 @@
       </p:sp>
       <p:pic>
         <p:nvPicPr>
-          <p:cNvPr id="14" name="Grafik 13" descr="Ein Bild, das Text, Screenshot, Diagramm, Reihe enthält.&#10;&#10;KI-generierte Inhalte können fehlerhaft sein.">
+          <p:cNvPr id="2" name="Grafik 1" descr="Ein Bild, das Text, Screenshot, Diagramm, Reihe enthält.&#10;&#10;KI-generierte Inhalte können fehlerhaft sein.">
             <a:extLst>
               <a:ext uri="{FF2B5EF4-FFF2-40B4-BE49-F238E27FC236}">
-                <a16:creationId xmlns:a16="http://schemas.microsoft.com/office/drawing/2014/main" id="{D1077B73-6AD1-11DE-AB4E-213FB00C9F9B}"/>
+                <a16:creationId xmlns:a16="http://schemas.microsoft.com/office/drawing/2014/main" id="{3869F84A-9648-A0B4-45DA-CAEDD94BF7D7}"/>
               </a:ext>
             </a:extLst>
           </p:cNvPr>
@@ -43479,8 +43478,8 @@
         </p:blipFill>
         <p:spPr>
           <a:xfrm>
-            <a:off x="3286161" y="1958013"/>
-            <a:ext cx="5299839" cy="2629862"/>
+            <a:off x="4193573" y="2525937"/>
+            <a:ext cx="4590064" cy="2277661"/>
           </a:xfrm>
           <a:prstGeom prst="rect">
             <a:avLst/>
@@ -43490,7 +43489,7 @@
     </p:spTree>
     <p:extLst>
       <p:ext uri="{BB962C8B-B14F-4D97-AF65-F5344CB8AC3E}">
-        <p14:creationId xmlns:p14="http://schemas.microsoft.com/office/powerpoint/2010/main" val="3788952433"/>
+        <p14:creationId xmlns:p14="http://schemas.microsoft.com/office/powerpoint/2010/main" val="991241013"/>
       </p:ext>
     </p:extLst>
   </p:cSld>

</xml_diff>

<commit_message>
Added final version of BA thesis presentation slides to designated <presentation> folder
</commit_message>
<xml_diff>
--- a/dev_documents/presentation/ba_thesis_presentation_kronig.pptx
+++ b/dev_documents/presentation/ba_thesis_presentation_kronig.pptx
@@ -255,7 +255,7 @@
           <a:p>
             <a:fld id="{442B13D9-EE20-4263-A517-453A6CC03581}" type="datetimeFigureOut">
               <a:rPr lang="en-US" smtClean="0"/>
-              <a:t>2/8/2026</a:t>
+              <a:t>2/10/2026</a:t>
             </a:fld>
             <a:endParaRPr lang="en-US"/>
           </a:p>
@@ -420,7 +420,7 @@
           <a:p>
             <a:fld id="{C4B9E2E8-0589-406D-8FD1-7B0DBC84FBDE}" type="datetimeFigureOut">
               <a:rPr lang="de-CH" smtClean="0"/>
-              <a:t>08.02.2026</a:t>
+              <a:t>10.02.2026</a:t>
             </a:fld>
             <a:endParaRPr lang="de-CH"/>
           </a:p>
@@ -32402,7 +32402,7 @@
             </a:r>
             <a:r>
               <a:rPr lang="en-US" noProof="0" dirty="0"/>
-              <a:t> MASTG</a:t>
+              <a:t> MAS(TG)</a:t>
             </a:r>
           </a:p>
           <a:p>

</xml_diff>